<commit_message>
Show lesson 6's decision rule on a slide of its own
The deck went from Bayes' rule to the factorisation without ever showing
the argmax that joins them, although the notes said the denominator could
be dropped. Slide 26 now carries it, with notes on the objection to expect
and why P(x) is recoverable. The rule is set as arg max with a side
subscript: under the image's matplotlib, \arg\max_c with limits collapses
the spacing of the whole expression. The lesson plan's ranges move by one.

Co-Authored-By: Claude Opus 5.5 <noreply@anthropic.com>
</commit_message>
<xml_diff>
--- a/Lessons/06_knn_naive_bayes_svm/Slides/knn_naive_bayes_svm_slides.pptx
+++ b/Lessons/06_knn_naive_bayes_svm/Slides/knn_naive_bayes_svm_slides.pptx
@@ -5,7 +5,7 @@
     <p:sldMasterId id="2147483648" r:id="rId1"/>
   </p:sldMasterIdLst>
   <p:notesMasterIdLst>
-    <p:notesMasterId r:id="rId55"/>
+    <p:notesMasterId r:id="rId56"/>
   </p:notesMasterIdLst>
   <p:sldIdLst>
     <p:sldId id="256" r:id="rId2"/>
@@ -61,6 +61,7 @@
     <p:sldId id="306" r:id="rId52"/>
     <p:sldId id="307" r:id="rId53"/>
     <p:sldId id="308" r:id="rId54"/>
+    <p:sldId id="309" r:id="rId55"/>
   </p:sldIdLst>
   <p:sldSz cx="9144000" cy="5143500" type="screen16x9"/>
   <p:notesSz cx="6858000" cy="9144000"/>
@@ -2646,49 +2647,35 @@
             </a:pPr>
             <a:r>
               <a:rPr/>
-              <a:t>One assumption, stated in one line, and everything follows from it.</a:t>
-            </a:r>
-          </a:p>
-          <a:p>
-            <a:pPr lvl="0" indent="0" marL="0">
-              <a:buNone/>
-            </a:pPr>
-          </a:p>
-          <a:p>
-            <a:pPr lvl="0" indent="0" marL="0">
-              <a:buNone/>
-            </a:pPr>
-            <a:r>
-              <a:rPr/>
-              <a:t>Emphasise the words “given the class”. This is not a claim that the features are independent - it is a claim that whatever dependence they have is entirely explained by which class they belong to. Those are different claims and the distinction matters in about ten minutes, when we measure it.</a:t>
-            </a:r>
-          </a:p>
-          <a:p>
-            <a:pPr lvl="0" indent="0" marL="0">
-              <a:buNone/>
-            </a:pPr>
-          </a:p>
-          <a:p>
-            <a:pPr lvl="0" indent="0" marL="0">
-              <a:buNone/>
-            </a:pPr>
-            <a:r>
-              <a:rPr/>
-              <a:t>What it buys: one n-dimensional estimation problem becomes n one-dimensional ones. A one-dimensional density needs very little data. Training becomes a single pass computing a mean and a variance per feature per class - there is no iteration, no optimisation, nothing to converge.</a:t>
-            </a:r>
-          </a:p>
-          <a:p>
-            <a:pPr lvl="0" indent="0" marL="0">
-              <a:buNone/>
-            </a:pPr>
-          </a:p>
-          <a:p>
-            <a:pPr lvl="0" indent="0" marL="0">
-              <a:buNone/>
-            </a:pPr>
-            <a:r>
-              <a:rPr/>
-              <a:t>Mention that in practice this is computed as a sum of logarithms, for the same underflow reason as lesson 4’s log-likelihood: a product of several hundred small probabilities is exactly zero in floating point. Handout section 4.2 has the log form.</a:t>
+              <a:t>This is the classifier, before any assumption: score each class by the numerator and pick the largest. The denominator has gone because it is the same for every class.</a:t>
+            </a:r>
+          </a:p>
+          <a:p>
+            <a:pPr lvl="0" indent="0" marL="0">
+              <a:buNone/>
+            </a:pPr>
+          </a:p>
+          <a:p>
+            <a:pPr lvl="0" indent="0" marL="0">
+              <a:buNone/>
+            </a:pPr>
+            <a:r>
+              <a:rPr/>
+              <a:t>Expect someone to object that the number is then no longer a probability. The instinct is sound - a term has been thrown away - and the answer is that it is recoverable. The denominator is the sum of the numerators over the classes, so dividing each score by the sum of the scores gives the probability back exactly. That is what predict_proba does, in logarithms. Dropping it costs nothing in calibration; where Naive Bayes does lose calibration is inside the numerator, and we will see that in a few slides.</a:t>
+            </a:r>
+          </a:p>
+          <a:p>
+            <a:pPr lvl="0" indent="0" marL="0">
+              <a:buNone/>
+            </a:pPr>
+          </a:p>
+          <a:p>
+            <a:pPr lvl="0" indent="0" marL="0">
+              <a:buNone/>
+            </a:pPr>
+            <a:r>
+              <a:rPr/>
+              <a:t>Then point at the first factor: this is where all the difficulty now sits, and the next slide is the assumption that makes it estimable. Handout section 4.1 carries a worked example with the pumps’ priors.</a:t>
             </a:r>
           </a:p>
         </p:txBody>
@@ -2770,35 +2757,49 @@
             </a:pPr>
             <a:r>
               <a:rPr/>
-              <a:t>This is the naive assumption, written down. One n-dimensional density on the left; n one-dimensional densities on the right.</a:t>
-            </a:r>
-          </a:p>
-          <a:p>
-            <a:pPr lvl="0" indent="0" marL="0">
-              <a:buNone/>
-            </a:pPr>
-          </a:p>
-          <a:p>
-            <a:pPr lvl="0" indent="0" marL="0">
-              <a:buNone/>
-            </a:pPr>
-            <a:r>
-              <a:rPr/>
-              <a:t>Why that matters is a counting argument, and it is worth making concrete. To estimate the left-hand side directly you would need enough pumps to fill an n-dimensional space - the curse of dimensionality from an hour ago, arriving in a new disguise. To estimate the right-hand side you need enough pumps to fit n separate histograms, which is a completely different demand.</a:t>
-            </a:r>
-          </a:p>
-          <a:p>
-            <a:pPr lvl="0" indent="0" marL="0">
-              <a:buNone/>
-            </a:pPr>
-          </a:p>
-          <a:p>
-            <a:pPr lvl="0" indent="0" marL="0">
-              <a:buNone/>
-            </a:pPr>
-            <a:r>
-              <a:rPr/>
-              <a:t>That is the whole bargain: an assumption that is usually false, traded for an estimation problem that is actually solvable. Notebook 02 measures what the assumption costs when it fails.</a:t>
+              <a:t>One assumption, stated in one line, and everything follows from it.</a:t>
+            </a:r>
+          </a:p>
+          <a:p>
+            <a:pPr lvl="0" indent="0" marL="0">
+              <a:buNone/>
+            </a:pPr>
+          </a:p>
+          <a:p>
+            <a:pPr lvl="0" indent="0" marL="0">
+              <a:buNone/>
+            </a:pPr>
+            <a:r>
+              <a:rPr/>
+              <a:t>Emphasise the words “given the class”. This is not a claim that the features are independent - it is a claim that whatever dependence they have is entirely explained by which class they belong to. Those are different claims and the distinction matters in about ten minutes, when we measure it.</a:t>
+            </a:r>
+          </a:p>
+          <a:p>
+            <a:pPr lvl="0" indent="0" marL="0">
+              <a:buNone/>
+            </a:pPr>
+          </a:p>
+          <a:p>
+            <a:pPr lvl="0" indent="0" marL="0">
+              <a:buNone/>
+            </a:pPr>
+            <a:r>
+              <a:rPr/>
+              <a:t>What it buys: one n-dimensional estimation problem becomes n one-dimensional ones. A one-dimensional density needs very little data. Training becomes a single pass computing a mean and a variance per feature per class - there is no iteration, no optimisation, nothing to converge.</a:t>
+            </a:r>
+          </a:p>
+          <a:p>
+            <a:pPr lvl="0" indent="0" marL="0">
+              <a:buNone/>
+            </a:pPr>
+          </a:p>
+          <a:p>
+            <a:pPr lvl="0" indent="0" marL="0">
+              <a:buNone/>
+            </a:pPr>
+            <a:r>
+              <a:rPr/>
+              <a:t>Mention that in practice this is computed as a sum of logarithms, for the same underflow reason as lesson 4’s log-likelihood: a product of several hundred small probabilities is exactly zero in floating point. Handout section 4.2 has the log form.</a:t>
             </a:r>
           </a:p>
         </p:txBody>
@@ -2880,49 +2881,35 @@
             </a:pPr>
             <a:r>
               <a:rPr/>
-              <a:t>Both halves matter, and students tend to hear only one of them.</a:t>
-            </a:r>
-          </a:p>
-          <a:p>
-            <a:pPr lvl="0" indent="0" marL="0">
-              <a:buNone/>
-            </a:pPr>
-          </a:p>
-          <a:p>
-            <a:pPr lvl="0" indent="0" marL="0">
-              <a:buNone/>
-            </a:pPr>
-            <a:r>
-              <a:rPr/>
-              <a:t>The bargain is real. Nothing else in this course trains in one pass, and nothing else tolerates ten thousand features on a few thousand rows.</a:t>
-            </a:r>
-          </a:p>
-          <a:p>
-            <a:pPr lvl="0" indent="0" marL="0">
-              <a:buNone/>
-            </a:pPr>
-          </a:p>
-          <a:p>
-            <a:pPr lvl="0" indent="0" marL="0">
-              <a:buNone/>
-            </a:pPr>
-            <a:r>
-              <a:rPr/>
-              <a:t>The assumption is false almost everywhere, and give concrete cases rather than a general warning. Two sensors on the same machine are both driven by the operating point, so of course they move together. In text, “New” and “York” co-occur far more than independence would allow. In medicine, symptoms of the same disease arrive in clusters.</a:t>
-            </a:r>
-          </a:p>
-          <a:p>
-            <a:pPr lvl="0" indent="0" marL="0">
-              <a:buNone/>
-            </a:pPr>
-          </a:p>
-          <a:p>
-            <a:pPr lvl="0" indent="0" marL="0">
-              <a:buNone/>
-            </a:pPr>
-            <a:r>
-              <a:rPr/>
-              <a:t>Then the framing that makes the rest of this segment worth doing, and put it as a question to the room: given that the assumption is essentially always false, why does anybody use this? The answer is that the assumption being false and the CLASSIFIER being wrong are different things. Argmax only needs the ordering right, not the probabilities. Handout section 4.2 closes on exactly this.</a:t>
+              <a:t>This is the naive assumption, written down. One n-dimensional density on the left; n one-dimensional densities on the right.</a:t>
+            </a:r>
+          </a:p>
+          <a:p>
+            <a:pPr lvl="0" indent="0" marL="0">
+              <a:buNone/>
+            </a:pPr>
+          </a:p>
+          <a:p>
+            <a:pPr lvl="0" indent="0" marL="0">
+              <a:buNone/>
+            </a:pPr>
+            <a:r>
+              <a:rPr/>
+              <a:t>Why that matters is a counting argument, and it is worth making concrete. To estimate the left-hand side directly you would need enough pumps to fill an n-dimensional space - the curse of dimensionality from an hour ago, arriving in a new disguise. To estimate the right-hand side you need enough pumps to fit n separate histograms, which is a completely different demand.</a:t>
+            </a:r>
+          </a:p>
+          <a:p>
+            <a:pPr lvl="0" indent="0" marL="0">
+              <a:buNone/>
+            </a:pPr>
+          </a:p>
+          <a:p>
+            <a:pPr lvl="0" indent="0" marL="0">
+              <a:buNone/>
+            </a:pPr>
+            <a:r>
+              <a:rPr/>
+              <a:t>That is the whole bargain: an assumption that is usually false, traded for an estimation problem that is actually solvable. Notebook 02 measures what the assumption costs when it fails.</a:t>
             </a:r>
           </a:p>
         </p:txBody>
@@ -3004,49 +2991,49 @@
             </a:pPr>
             <a:r>
               <a:rPr/>
-              <a:t>A point behind k-NN, and an enormous distance ahead of the linear model - from a method that assumes something false and trains in a single pass over the data.</a:t>
-            </a:r>
-          </a:p>
-          <a:p>
-            <a:pPr lvl="0" indent="0" marL="0">
-              <a:buNone/>
-            </a:pPr>
-          </a:p>
-          <a:p>
-            <a:pPr lvl="0" indent="0" marL="0">
-              <a:buNone/>
-            </a:pPr>
-            <a:r>
-              <a:rPr/>
-              <a:t>Resist the temptation to stop here, because a score alone tells you nothing about when it will hold. Ask the room the useful question instead: WHY did that work? If the assumption is false, what happened?</a:t>
-            </a:r>
-          </a:p>
-          <a:p>
-            <a:pPr lvl="0" indent="0" marL="0">
-              <a:buNone/>
-            </a:pPr>
-          </a:p>
-          <a:p>
-            <a:pPr lvl="0" indent="0" marL="0">
-              <a:buNone/>
-            </a:pPr>
-            <a:r>
-              <a:rPr/>
-              <a:t>Then be explicit that we are about to check, rather than speculate. This is the habit worth transferring: when a model does better than you expected, find out which of your assumptions was accidentally satisfied. That tells you whether the result will survive on the next dataset.</a:t>
-            </a:r>
-          </a:p>
-          <a:p>
-            <a:pPr lvl="0" indent="0" marL="0">
-              <a:buNone/>
-            </a:pPr>
-          </a:p>
-          <a:p>
-            <a:pPr lvl="0" indent="0" marL="0">
-              <a:buNone/>
-            </a:pPr>
-            <a:r>
-              <a:rPr/>
-              <a:t>Handout section 4.3.</a:t>
+              <a:t>Both halves matter, and students tend to hear only one of them.</a:t>
+            </a:r>
+          </a:p>
+          <a:p>
+            <a:pPr lvl="0" indent="0" marL="0">
+              <a:buNone/>
+            </a:pPr>
+          </a:p>
+          <a:p>
+            <a:pPr lvl="0" indent="0" marL="0">
+              <a:buNone/>
+            </a:pPr>
+            <a:r>
+              <a:rPr/>
+              <a:t>The bargain is real. Nothing else in this course trains in one pass, and nothing else tolerates ten thousand features on a few thousand rows.</a:t>
+            </a:r>
+          </a:p>
+          <a:p>
+            <a:pPr lvl="0" indent="0" marL="0">
+              <a:buNone/>
+            </a:pPr>
+          </a:p>
+          <a:p>
+            <a:pPr lvl="0" indent="0" marL="0">
+              <a:buNone/>
+            </a:pPr>
+            <a:r>
+              <a:rPr/>
+              <a:t>The assumption is false almost everywhere, and give concrete cases rather than a general warning. Two sensors on the same machine are both driven by the operating point, so of course they move together. In text, “New” and “York” co-occur far more than independence would allow. In medicine, symptoms of the same disease arrive in clusters.</a:t>
+            </a:r>
+          </a:p>
+          <a:p>
+            <a:pPr lvl="0" indent="0" marL="0">
+              <a:buNone/>
+            </a:pPr>
+          </a:p>
+          <a:p>
+            <a:pPr lvl="0" indent="0" marL="0">
+              <a:buNone/>
+            </a:pPr>
+            <a:r>
+              <a:rPr/>
+              <a:t>Then the framing that makes the rest of this segment worth doing, and put it as a question to the room: given that the assumption is essentially always false, why does anybody use this? The answer is that the assumption being false and the CLASSIFIER being wrong are different things. Argmax only needs the ordering right, not the probabilities. Handout section 4.2 closes on exactly this.</a:t>
             </a:r>
           </a:p>
         </p:txBody>
@@ -3128,49 +3115,49 @@
             </a:pPr>
             <a:r>
               <a:rPr/>
-              <a:t>Measured directly, and remember the assumption concerns independence GIVEN THE CLASS - so the second and third rows are the ones that count, not the first.</a:t>
-            </a:r>
-          </a:p>
-          <a:p>
-            <a:pPr lvl="0" indent="0" marL="0">
-              <a:buNone/>
-            </a:pPr>
-          </a:p>
-          <a:p>
-            <a:pPr lvl="0" indent="0" marL="0">
-              <a:buNone/>
-            </a:pPr>
-            <a:r>
-              <a:rPr/>
-              <a:t>Within each class the two readings are essentially uncorrelated: −0.006 among healthy pumps is as close to zero as a sample of this size will ever produce. The assumption is not approximately satisfied here; it is satisfied.</a:t>
-            </a:r>
-          </a:p>
-          <a:p>
-            <a:pPr lvl="0" indent="0" marL="0">
-              <a:buNone/>
-            </a:pPr>
-          </a:p>
-          <a:p>
-            <a:pPr lvl="0" indent="0" marL="0">
-              <a:buNone/>
-            </a:pPr>
-            <a:r>
-              <a:rPr/>
-              <a:t>Say why that is more useful than the 0.933. A score tells you what happened once. Knowing WHY it happened tells you when to expect it again - and it gives them a check they can run in two lines before trusting Naive Bayes on anything.</a:t>
-            </a:r>
-          </a:p>
-          <a:p>
-            <a:pPr lvl="0" indent="0" marL="0">
-              <a:buNone/>
-            </a:pPr>
-          </a:p>
-          <a:p>
-            <a:pPr lvl="0" indent="0" marL="0">
-              <a:buNone/>
-            </a:pPr>
-            <a:r>
-              <a:rPr/>
-              <a:t>The obvious caution, since somebody will raise it: zero correlation is not independence. Correlation only detects linear dependence. For Gaussian Naive Bayes with Gaussian-ish features it is the right check; in general it is necessary and not sufficient.</a:t>
+              <a:t>A point behind k-NN, and an enormous distance ahead of the linear model - from a method that assumes something false and trains in a single pass over the data.</a:t>
+            </a:r>
+          </a:p>
+          <a:p>
+            <a:pPr lvl="0" indent="0" marL="0">
+              <a:buNone/>
+            </a:pPr>
+          </a:p>
+          <a:p>
+            <a:pPr lvl="0" indent="0" marL="0">
+              <a:buNone/>
+            </a:pPr>
+            <a:r>
+              <a:rPr/>
+              <a:t>Resist the temptation to stop here, because a score alone tells you nothing about when it will hold. Ask the room the useful question instead: WHY did that work? If the assumption is false, what happened?</a:t>
+            </a:r>
+          </a:p>
+          <a:p>
+            <a:pPr lvl="0" indent="0" marL="0">
+              <a:buNone/>
+            </a:pPr>
+          </a:p>
+          <a:p>
+            <a:pPr lvl="0" indent="0" marL="0">
+              <a:buNone/>
+            </a:pPr>
+            <a:r>
+              <a:rPr/>
+              <a:t>Then be explicit that we are about to check, rather than speculate. This is the habit worth transferring: when a model does better than you expected, find out which of your assumptions was accidentally satisfied. That tells you whether the result will survive on the next dataset.</a:t>
+            </a:r>
+          </a:p>
+          <a:p>
+            <a:pPr lvl="0" indent="0" marL="0">
+              <a:buNone/>
+            </a:pPr>
+          </a:p>
+          <a:p>
+            <a:pPr lvl="0" indent="0" marL="0">
+              <a:buNone/>
+            </a:pPr>
+            <a:r>
+              <a:rPr/>
+              <a:t>Handout section 4.3.</a:t>
             </a:r>
           </a:p>
         </p:txBody>
@@ -3384,49 +3371,49 @@
             </a:pPr>
             <a:r>
               <a:rPr/>
-              <a:t>Change one thing about the problem and watch the method fall apart. Describe the physics before the geometry, because the rule is completely reasonable engineering.</a:t>
-            </a:r>
-          </a:p>
-          <a:p>
-            <a:pPr lvl="0" indent="0" marL="0">
-              <a:buNone/>
-            </a:pPr>
-          </a:p>
-          <a:p>
-            <a:pPr lvl="0" indent="0" marL="0">
-              <a:buNone/>
-            </a:pPr>
-            <a:r>
-              <a:rPr/>
-              <a:t>High demand and high delivery: fine, that is the machine working hard. Low and low: fine, that is idle. High demand with low delivery, or the reverse: something is wrong between them. Exactly one high means faulty.</a:t>
-            </a:r>
-          </a:p>
-          <a:p>
-            <a:pPr lvl="0" indent="0" marL="0">
-              <a:buNone/>
-            </a:pPr>
-          </a:p>
-          <a:p>
-            <a:pPr lvl="0" indent="0" marL="0">
-              <a:buNone/>
-            </a:pPr>
-            <a:r>
-              <a:rPr/>
-              <a:t>Ask them, before the picture, what each sensor tells you ON ITS OWN under that rule. Give it a moment. The answer is: nothing at all. Every value of sensor A appears in both classes about equally often, because whether it means “faulty” depends entirely on sensor B.</a:t>
-            </a:r>
-          </a:p>
-          <a:p>
-            <a:pPr lvl="0" indent="0" marL="0">
-              <a:buNone/>
-            </a:pPr>
-          </a:p>
-          <a:p>
-            <a:pPr lvl="0" indent="0" marL="0">
-              <a:buNone/>
-            </a:pPr>
-            <a:r>
-              <a:rPr/>
-              <a:t>That is what an interaction is, and it is precisely the structure the independence assumption is unable to represent. Handout section 4.4.</a:t>
+              <a:t>Measured directly, and remember the assumption concerns independence GIVEN THE CLASS - so the second and third rows are the ones that count, not the first.</a:t>
+            </a:r>
+          </a:p>
+          <a:p>
+            <a:pPr lvl="0" indent="0" marL="0">
+              <a:buNone/>
+            </a:pPr>
+          </a:p>
+          <a:p>
+            <a:pPr lvl="0" indent="0" marL="0">
+              <a:buNone/>
+            </a:pPr>
+            <a:r>
+              <a:rPr/>
+              <a:t>Within each class the two readings are essentially uncorrelated: −0.006 among healthy pumps is as close to zero as a sample of this size will ever produce. The assumption is not approximately satisfied here; it is satisfied.</a:t>
+            </a:r>
+          </a:p>
+          <a:p>
+            <a:pPr lvl="0" indent="0" marL="0">
+              <a:buNone/>
+            </a:pPr>
+          </a:p>
+          <a:p>
+            <a:pPr lvl="0" indent="0" marL="0">
+              <a:buNone/>
+            </a:pPr>
+            <a:r>
+              <a:rPr/>
+              <a:t>Say why that is more useful than the 0.933. A score tells you what happened once. Knowing WHY it happened tells you when to expect it again - and it gives them a check they can run in two lines before trusting Naive Bayes on anything.</a:t>
+            </a:r>
+          </a:p>
+          <a:p>
+            <a:pPr lvl="0" indent="0" marL="0">
+              <a:buNone/>
+            </a:pPr>
+          </a:p>
+          <a:p>
+            <a:pPr lvl="0" indent="0" marL="0">
+              <a:buNone/>
+            </a:pPr>
+            <a:r>
+              <a:rPr/>
+              <a:t>The obvious caution, since somebody will raise it: zero correlation is not independence. Correlation only detects linear dependence. For Gaussian Naive Bayes with Gaussian-ish features it is the right check; in general it is necessary and not sufficient.</a:t>
             </a:r>
           </a:p>
         </p:txBody>
@@ -3508,49 +3495,49 @@
             </a:pPr>
             <a:r>
               <a:rPr/>
-              <a:t>Left panel: the two sensors together. Four clean groups, and a perfectly learnable rule - any method that can draw a non-linear boundary will find it.</a:t>
-            </a:r>
-          </a:p>
-          <a:p>
-            <a:pPr lvl="0" indent="0" marL="0">
-              <a:buNone/>
-            </a:pPr>
-          </a:p>
-          <a:p>
-            <a:pPr lvl="0" indent="0" marL="0">
-              <a:buNone/>
-            </a:pPr>
-            <a:r>
-              <a:rPr/>
-              <a:t>Middle and right: each sensor on its own, which is ALL Naive Bayes ever gets. The two class distributions sit almost exactly on top of one another.</a:t>
-            </a:r>
-          </a:p>
-          <a:p>
-            <a:pPr lvl="0" indent="0" marL="0">
-              <a:buNone/>
-            </a:pPr>
-          </a:p>
-          <a:p>
-            <a:pPr lvl="0" indent="0" marL="0">
-              <a:buNone/>
-            </a:pPr>
-            <a:r>
-              <a:rPr/>
-              <a:t>That is the slide in one sentence: the information is real, it is entirely in the relationship between the columns, and factorising the density throws that relationship away before the model ever sees it.</a:t>
-            </a:r>
-          </a:p>
-          <a:p>
-            <a:pPr lvl="0" indent="0" marL="0">
-              <a:buNone/>
-            </a:pPr>
-          </a:p>
-          <a:p>
-            <a:pPr lvl="0" indent="0" marL="0">
-              <a:buNone/>
-            </a:pPr>
-            <a:r>
-              <a:rPr/>
-              <a:t>Worth saying that no amount of data repairs this. It is not an estimation problem - with a million rows the marginals still overlap. The model cannot represent what is being asked of it.</a:t>
+              <a:t>Change one thing about the problem and watch the method fall apart. Describe the physics before the geometry, because the rule is completely reasonable engineering.</a:t>
+            </a:r>
+          </a:p>
+          <a:p>
+            <a:pPr lvl="0" indent="0" marL="0">
+              <a:buNone/>
+            </a:pPr>
+          </a:p>
+          <a:p>
+            <a:pPr lvl="0" indent="0" marL="0">
+              <a:buNone/>
+            </a:pPr>
+            <a:r>
+              <a:rPr/>
+              <a:t>High demand and high delivery: fine, that is the machine working hard. Low and low: fine, that is idle. High demand with low delivery, or the reverse: something is wrong between them. Exactly one high means faulty.</a:t>
+            </a:r>
+          </a:p>
+          <a:p>
+            <a:pPr lvl="0" indent="0" marL="0">
+              <a:buNone/>
+            </a:pPr>
+          </a:p>
+          <a:p>
+            <a:pPr lvl="0" indent="0" marL="0">
+              <a:buNone/>
+            </a:pPr>
+            <a:r>
+              <a:rPr/>
+              <a:t>Ask them, before the picture, what each sensor tells you ON ITS OWN under that rule. Give it a moment. The answer is: nothing at all. Every value of sensor A appears in both classes about equally often, because whether it means “faulty” depends entirely on sensor B.</a:t>
+            </a:r>
+          </a:p>
+          <a:p>
+            <a:pPr lvl="0" indent="0" marL="0">
+              <a:buNone/>
+            </a:pPr>
+          </a:p>
+          <a:p>
+            <a:pPr lvl="0" indent="0" marL="0">
+              <a:buNone/>
+            </a:pPr>
+            <a:r>
+              <a:rPr/>
+              <a:t>That is what an interaction is, and it is precisely the structure the independence assumption is unable to represent. Handout section 4.4.</a:t>
             </a:r>
           </a:p>
         </p:txBody>
@@ -3632,63 +3619,49 @@
             </a:pPr>
             <a:r>
               <a:rPr/>
-              <a:t>Two things to draw out, and the second is the more interesting.</a:t>
-            </a:r>
-          </a:p>
-          <a:p>
-            <a:pPr lvl="0" indent="0" marL="0">
-              <a:buNone/>
-            </a:pPr>
-          </a:p>
-          <a:p>
-            <a:pPr lvl="0" indent="0" marL="0">
-              <a:buNone/>
-            </a:pPr>
-            <a:r>
-              <a:rPr/>
-              <a:t>First: k-NN and the RBF SVM are at 0.967 and 0.972 on this data. The problem is not hard. It is only hard for a model that looks at one feature at a time.</a:t>
-            </a:r>
-          </a:p>
-          <a:p>
-            <a:pPr lvl="0" indent="0" marL="0">
-              <a:buNone/>
-            </a:pPr>
-          </a:p>
-          <a:p>
-            <a:pPr lvl="0" indent="0" marL="0">
-              <a:buNone/>
-            </a:pPr>
-            <a:r>
-              <a:rPr/>
-              <a:t>Second, and take the time: 0.404 is BELOW CHANCE. Below the majority baseline of 0.523, and below what you would get by flipping a coin. Ask how that is even possible - a model with no information should surely sit at 50%.</a:t>
-            </a:r>
-          </a:p>
-          <a:p>
-            <a:pPr lvl="0" indent="0" marL="0">
-              <a:buNone/>
-            </a:pPr>
-          </a:p>
-          <a:p>
-            <a:pPr lvl="0" indent="0" marL="0">
-              <a:buNone/>
-            </a:pPr>
-            <a:r>
-              <a:rPr/>
-              <a:t>The explanation is worth having in full. The class means on each sensor differ by about 0.17, against a spread near 1, purely as an artefact of a finite sample. That accident is the ONLY per-feature evidence available. Naive Bayes has nothing else to multiply, so it follows it - and in this sample it points the wrong way.</a:t>
-            </a:r>
-          </a:p>
-          <a:p>
-            <a:pPr lvl="0" indent="0" marL="0">
-              <a:buNone/>
-            </a:pPr>
-          </a:p>
-          <a:p>
-            <a:pPr lvl="0" indent="0" marL="0">
-              <a:buNone/>
-            </a:pPr>
-            <a:r>
-              <a:rPr/>
-              <a:t>The sentence to land: a model with no signal does not sit politely at 50%. It follows whatever spurious structure it can find, with complete confidence.</a:t>
+              <a:t>Left panel: the two sensors together. Four clean groups, and a perfectly learnable rule - any method that can draw a non-linear boundary will find it.</a:t>
+            </a:r>
+          </a:p>
+          <a:p>
+            <a:pPr lvl="0" indent="0" marL="0">
+              <a:buNone/>
+            </a:pPr>
+          </a:p>
+          <a:p>
+            <a:pPr lvl="0" indent="0" marL="0">
+              <a:buNone/>
+            </a:pPr>
+            <a:r>
+              <a:rPr/>
+              <a:t>Middle and right: each sensor on its own, which is ALL Naive Bayes ever gets. The two class distributions sit almost exactly on top of one another.</a:t>
+            </a:r>
+          </a:p>
+          <a:p>
+            <a:pPr lvl="0" indent="0" marL="0">
+              <a:buNone/>
+            </a:pPr>
+          </a:p>
+          <a:p>
+            <a:pPr lvl="0" indent="0" marL="0">
+              <a:buNone/>
+            </a:pPr>
+            <a:r>
+              <a:rPr/>
+              <a:t>That is the slide in one sentence: the information is real, it is entirely in the relationship between the columns, and factorising the density throws that relationship away before the model ever sees it.</a:t>
+            </a:r>
+          </a:p>
+          <a:p>
+            <a:pPr lvl="0" indent="0" marL="0">
+              <a:buNone/>
+            </a:pPr>
+          </a:p>
+          <a:p>
+            <a:pPr lvl="0" indent="0" marL="0">
+              <a:buNone/>
+            </a:pPr>
+            <a:r>
+              <a:rPr/>
+              <a:t>Worth saying that no amount of data repairs this. It is not an estimation problem - with a million rows the marginals still overlap. The model cannot represent what is being asked of it.</a:t>
             </a:r>
           </a:p>
         </p:txBody>
@@ -3770,59 +3743,63 @@
             </a:pPr>
             <a:r>
               <a:rPr/>
-              <a:t>Two numbers, four thousandths apart. The model is exactly as confident when it is wrong as when it is right, which means </a:t>
-            </a:r>
-            <a:r>
-              <a:rPr>
-                <a:latin typeface="Courier"/>
-              </a:rPr>
-              <a:t>predict_proba</a:t>
-            </a:r>
-            <a:r>
-              <a:rPr/>
-              <a:t> carries no usable information about reliability here.</a:t>
-            </a:r>
-          </a:p>
-          <a:p>
-            <a:pPr lvl="0" indent="0" marL="0">
-              <a:buNone/>
-            </a:pPr>
-          </a:p>
-          <a:p>
-            <a:pPr lvl="0" indent="0" marL="0">
-              <a:buNone/>
-            </a:pPr>
-            <a:r>
-              <a:rPr/>
-              <a:t>The more common complaint runs in the opposite direction, so give it too: when features ARE correlated, multiplying their probabilities counts the same evidence repeatedly. Ten correlated words in a document are treated as ten independent pieces of evidence, and the posterior saturates. Naive Bayes is famous for reporting 0.999 on problems it gets wrong a fifth of the time.</a:t>
-            </a:r>
-          </a:p>
-          <a:p>
-            <a:pPr lvl="0" indent="0" marL="0">
-              <a:buNone/>
-            </a:pPr>
-          </a:p>
-          <a:p>
-            <a:pPr lvl="0" indent="0" marL="0">
-              <a:buNone/>
-            </a:pPr>
-            <a:r>
-              <a:rPr/>
-              <a:t>Then lesson 5’s distinction, which this is the textbook case of: ranking and calibration are different properties. A model can order examples usefully and still report numbers that mean nothing.</a:t>
-            </a:r>
-          </a:p>
-          <a:p>
-            <a:pPr lvl="0" indent="0" marL="0">
-              <a:buNone/>
-            </a:pPr>
-          </a:p>
-          <a:p>
-            <a:pPr lvl="0" indent="0" marL="0">
-              <a:buNone/>
-            </a:pPr>
-            <a:r>
-              <a:rPr/>
-              <a:t>The practical consequence, and it is concrete: do not use Naive Bayes anywhere a calibrated probability enters a decision - including lesson 4’s cost calculation in section 7.2, where the threshold depends on the probability being real.</a:t>
+              <a:t>Two things to draw out, and the second is the more interesting.</a:t>
+            </a:r>
+          </a:p>
+          <a:p>
+            <a:pPr lvl="0" indent="0" marL="0">
+              <a:buNone/>
+            </a:pPr>
+          </a:p>
+          <a:p>
+            <a:pPr lvl="0" indent="0" marL="0">
+              <a:buNone/>
+            </a:pPr>
+            <a:r>
+              <a:rPr/>
+              <a:t>First: k-NN and the RBF SVM are at 0.967 and 0.972 on this data. The problem is not hard. It is only hard for a model that looks at one feature at a time.</a:t>
+            </a:r>
+          </a:p>
+          <a:p>
+            <a:pPr lvl="0" indent="0" marL="0">
+              <a:buNone/>
+            </a:pPr>
+          </a:p>
+          <a:p>
+            <a:pPr lvl="0" indent="0" marL="0">
+              <a:buNone/>
+            </a:pPr>
+            <a:r>
+              <a:rPr/>
+              <a:t>Second, and take the time: 0.404 is BELOW CHANCE. Below the majority baseline of 0.523, and below what you would get by flipping a coin. Ask how that is even possible - a model with no information should surely sit at 50%.</a:t>
+            </a:r>
+          </a:p>
+          <a:p>
+            <a:pPr lvl="0" indent="0" marL="0">
+              <a:buNone/>
+            </a:pPr>
+          </a:p>
+          <a:p>
+            <a:pPr lvl="0" indent="0" marL="0">
+              <a:buNone/>
+            </a:pPr>
+            <a:r>
+              <a:rPr/>
+              <a:t>The explanation is worth having in full. The class means on each sensor differ by about 0.17, against a spread near 1, purely as an artefact of a finite sample. That accident is the ONLY per-feature evidence available. Naive Bayes has nothing else to multiply, so it follows it - and in this sample it points the wrong way.</a:t>
+            </a:r>
+          </a:p>
+          <a:p>
+            <a:pPr lvl="0" indent="0" marL="0">
+              <a:buNone/>
+            </a:pPr>
+          </a:p>
+          <a:p>
+            <a:pPr lvl="0" indent="0" marL="0">
+              <a:buNone/>
+            </a:pPr>
+            <a:r>
+              <a:rPr/>
+              <a:t>The sentence to land: a model with no signal does not sit politely at 50%. It follows whatever spurious structure it can find, with complete confidence.</a:t>
             </a:r>
           </a:p>
         </p:txBody>
@@ -3904,49 +3881,59 @@
             </a:pPr>
             <a:r>
               <a:rPr/>
-              <a:t>Run notebooks/02. Eighteen minutes.</a:t>
-            </a:r>
-          </a:p>
-          <a:p>
-            <a:pPr lvl="0" indent="0" marL="0">
-              <a:buNone/>
-            </a:pPr>
-          </a:p>
-          <a:p>
-            <a:pPr lvl="0" indent="0" marL="0">
-              <a:buNone/>
-            </a:pPr>
-            <a:r>
-              <a:rPr/>
-              <a:t>The cell to protect is the one that prints 0.404 next to the 0.523 baseline. Let them see a below-chance score appear from correct code on solvable data before any explanation arrives.</a:t>
-            </a:r>
-          </a:p>
-          <a:p>
-            <a:pPr lvl="0" indent="0" marL="0">
-              <a:buNone/>
-            </a:pPr>
-          </a:p>
-          <a:p>
-            <a:pPr lvl="0" indent="0" marL="0">
-              <a:buNone/>
-            </a:pPr>
-            <a:r>
-              <a:rPr/>
-              <a:t>Have them compute the within-class correlations themselves on both datasets. Two lines, and it is the diagnostic they should carry: measure the assumption, do not assume it.</a:t>
-            </a:r>
-          </a:p>
-          <a:p>
-            <a:pPr lvl="0" indent="0" marL="0">
-              <a:buNone/>
-            </a:pPr>
-          </a:p>
-          <a:p>
-            <a:pPr lvl="0" indent="0" marL="0">
-              <a:buNone/>
-            </a:pPr>
-            <a:r>
-              <a:rPr/>
-              <a:t>If time allows, the interesting exercise is to hand Naive Bayes the product of the two sensors as a third column and watch it recover. That is the whole story of feature engineering versus model choice in one cell.</a:t>
+              <a:t>Two numbers, four thousandths apart. The model is exactly as confident when it is wrong as when it is right, which means </a:t>
+            </a:r>
+            <a:r>
+              <a:rPr>
+                <a:latin typeface="Courier"/>
+              </a:rPr>
+              <a:t>predict_proba</a:t>
+            </a:r>
+            <a:r>
+              <a:rPr/>
+              <a:t> carries no usable information about reliability here.</a:t>
+            </a:r>
+          </a:p>
+          <a:p>
+            <a:pPr lvl="0" indent="0" marL="0">
+              <a:buNone/>
+            </a:pPr>
+          </a:p>
+          <a:p>
+            <a:pPr lvl="0" indent="0" marL="0">
+              <a:buNone/>
+            </a:pPr>
+            <a:r>
+              <a:rPr/>
+              <a:t>The more common complaint runs in the opposite direction, so give it too: when features ARE correlated, multiplying their probabilities counts the same evidence repeatedly. Ten correlated words in a document are treated as ten independent pieces of evidence, and the posterior saturates. Naive Bayes is famous for reporting 0.999 on problems it gets wrong a fifth of the time.</a:t>
+            </a:r>
+          </a:p>
+          <a:p>
+            <a:pPr lvl="0" indent="0" marL="0">
+              <a:buNone/>
+            </a:pPr>
+          </a:p>
+          <a:p>
+            <a:pPr lvl="0" indent="0" marL="0">
+              <a:buNone/>
+            </a:pPr>
+            <a:r>
+              <a:rPr/>
+              <a:t>Then lesson 5’s distinction, which this is the textbook case of: ranking and calibration are different properties. A model can order examples usefully and still report numbers that mean nothing.</a:t>
+            </a:r>
+          </a:p>
+          <a:p>
+            <a:pPr lvl="0" indent="0" marL="0">
+              <a:buNone/>
+            </a:pPr>
+          </a:p>
+          <a:p>
+            <a:pPr lvl="0" indent="0" marL="0">
+              <a:buNone/>
+            </a:pPr>
+            <a:r>
+              <a:rPr/>
+              <a:t>The practical consequence, and it is concrete: do not use Naive Bayes anywhere a calibrated probability enters a decision - including lesson 4’s cost calculation in section 7.2, where the threshold depends on the probability being real.</a:t>
             </a:r>
           </a:p>
         </p:txBody>
@@ -4028,49 +4015,49 @@
             </a:pPr>
             <a:r>
               <a:rPr/>
-              <a:t>Start with the problem rather than the solution. Draw two well-separated blobs on the board and ask for the boundary. Somebody will draw a line. Ask whether another line would have been equally good, and keep asking until the room sees that there are infinitely many, all with identical training error.</a:t>
-            </a:r>
-          </a:p>
-          <a:p>
-            <a:pPr lvl="0" indent="0" marL="0">
-              <a:buNone/>
-            </a:pPr>
-          </a:p>
-          <a:p>
-            <a:pPr lvl="0" indent="0" marL="0">
-              <a:buNone/>
-            </a:pPr>
-            <a:r>
-              <a:rPr/>
-              <a:t>So the error cannot decide. Something else has to. Logistic regression breaks the tie with log loss - a perfectly respectable answer, and one answer among several. The SVM breaks it differently: take the boundary with the most room around it.</a:t>
-            </a:r>
-          </a:p>
-          <a:p>
-            <a:pPr lvl="0" indent="0" marL="0">
-              <a:buNone/>
-            </a:pPr>
-          </a:p>
-          <a:p>
-            <a:pPr lvl="0" indent="0" marL="0">
-              <a:buNone/>
-            </a:pPr>
-            <a:r>
-              <a:rPr/>
-              <a:t>The intuition, and this is the sentence to say slowly: maximising the distance to the closest points chooses the boundary that tolerates the most movement in the data before it changes its mind. That is a statement about GENERALISATION, not about fit - which is unusual, because almost everything else in this course optimises fit and controls generalisation indirectly.</a:t>
-            </a:r>
-          </a:p>
-          <a:p>
-            <a:pPr lvl="0" indent="0" marL="0">
-              <a:buNone/>
-            </a:pPr>
-          </a:p>
-          <a:p>
-            <a:pPr lvl="0" indent="0" marL="0">
-              <a:buNone/>
-            </a:pPr>
-            <a:r>
-              <a:rPr/>
-              <a:t>Handout section 5.1.</a:t>
+              <a:t>Run notebooks/02. Eighteen minutes.</a:t>
+            </a:r>
+          </a:p>
+          <a:p>
+            <a:pPr lvl="0" indent="0" marL="0">
+              <a:buNone/>
+            </a:pPr>
+          </a:p>
+          <a:p>
+            <a:pPr lvl="0" indent="0" marL="0">
+              <a:buNone/>
+            </a:pPr>
+            <a:r>
+              <a:rPr/>
+              <a:t>The cell to protect is the one that prints 0.404 next to the 0.523 baseline. Let them see a below-chance score appear from correct code on solvable data before any explanation arrives.</a:t>
+            </a:r>
+          </a:p>
+          <a:p>
+            <a:pPr lvl="0" indent="0" marL="0">
+              <a:buNone/>
+            </a:pPr>
+          </a:p>
+          <a:p>
+            <a:pPr lvl="0" indent="0" marL="0">
+              <a:buNone/>
+            </a:pPr>
+            <a:r>
+              <a:rPr/>
+              <a:t>Have them compute the within-class correlations themselves on both datasets. Two lines, and it is the diagnostic they should carry: measure the assumption, do not assume it.</a:t>
+            </a:r>
+          </a:p>
+          <a:p>
+            <a:pPr lvl="0" indent="0" marL="0">
+              <a:buNone/>
+            </a:pPr>
+          </a:p>
+          <a:p>
+            <a:pPr lvl="0" indent="0" marL="0">
+              <a:buNone/>
+            </a:pPr>
+            <a:r>
+              <a:rPr/>
+              <a:t>If time allows, the interesting exercise is to hand Naive Bayes the product of the two sensors as a third column and watch it recover. That is the whole story of feature engineering versus model choice in one cell.</a:t>
             </a:r>
           </a:p>
         </p:txBody>
@@ -4152,49 +4139,49 @@
             </a:pPr>
             <a:r>
               <a:rPr/>
-              <a:t>The solid line is the boundary, the dashed lines are the edges of the slab, and the circled points are the support vectors touching it.</a:t>
-            </a:r>
-          </a:p>
-          <a:p>
-            <a:pPr lvl="0" indent="0" marL="0">
-              <a:buNone/>
-            </a:pPr>
-          </a:p>
-          <a:p>
-            <a:pPr lvl="0" indent="0" marL="0">
-              <a:buNone/>
-            </a:pPr>
-            <a:r>
-              <a:rPr/>
-              <a:t>The number to say out loud: of eighty points, THREE determine the answer. Move any of the other seventy-seven - anywhere, as far as you like, as long as they stay outside the slab - and the boundary does not shift by a millimetre.</a:t>
-            </a:r>
-          </a:p>
-          <a:p>
-            <a:pPr lvl="0" indent="0" marL="0">
-              <a:buNone/>
-            </a:pPr>
-          </a:p>
-          <a:p>
-            <a:pPr lvl="0" indent="0" marL="0">
-              <a:buNone/>
-            </a:pPr>
-            <a:r>
-              <a:rPr/>
-              <a:t>That is where the name comes from, and it is a genuinely different idea from anything so far. Every linear model in lessons 3 and 4 used every row: each one contributed to the gradient in proportion to its error. Here most of the data is irrelevant once the fit is done.</a:t>
-            </a:r>
-          </a:p>
-          <a:p>
-            <a:pPr lvl="0" indent="0" marL="0">
-              <a:buNone/>
-            </a:pPr>
-          </a:p>
-          <a:p>
-            <a:pPr lvl="0" indent="0" marL="0">
-              <a:buNone/>
-            </a:pPr>
-            <a:r>
-              <a:rPr/>
-              <a:t>Two consequences worth naming. The model is small - you store the support vectors, not the dataset, which is the contrast with k-NN. And it is sensitive in a specific way: an outlier near the boundary matters enormously, while an outlier far from it matters not at all.</a:t>
+              <a:t>Start with the problem rather than the solution. Draw two well-separated blobs on the board and ask for the boundary. Somebody will draw a line. Ask whether another line would have been equally good, and keep asking until the room sees that there are infinitely many, all with identical training error.</a:t>
+            </a:r>
+          </a:p>
+          <a:p>
+            <a:pPr lvl="0" indent="0" marL="0">
+              <a:buNone/>
+            </a:pPr>
+          </a:p>
+          <a:p>
+            <a:pPr lvl="0" indent="0" marL="0">
+              <a:buNone/>
+            </a:pPr>
+            <a:r>
+              <a:rPr/>
+              <a:t>So the error cannot decide. Something else has to. Logistic regression breaks the tie with log loss - a perfectly respectable answer, and one answer among several. The SVM breaks it differently: take the boundary with the most room around it.</a:t>
+            </a:r>
+          </a:p>
+          <a:p>
+            <a:pPr lvl="0" indent="0" marL="0">
+              <a:buNone/>
+            </a:pPr>
+          </a:p>
+          <a:p>
+            <a:pPr lvl="0" indent="0" marL="0">
+              <a:buNone/>
+            </a:pPr>
+            <a:r>
+              <a:rPr/>
+              <a:t>The intuition, and this is the sentence to say slowly: maximising the distance to the closest points chooses the boundary that tolerates the most movement in the data before it changes its mind. That is a statement about GENERALISATION, not about fit - which is unusual, because almost everything else in this course optimises fit and controls generalisation indirectly.</a:t>
+            </a:r>
+          </a:p>
+          <a:p>
+            <a:pPr lvl="0" indent="0" marL="0">
+              <a:buNone/>
+            </a:pPr>
+          </a:p>
+          <a:p>
+            <a:pPr lvl="0" indent="0" marL="0">
+              <a:buNone/>
+            </a:pPr>
+            <a:r>
+              <a:rPr/>
+              <a:t>Handout section 5.1.</a:t>
             </a:r>
           </a:p>
         </p:txBody>
@@ -4276,35 +4263,49 @@
             </a:pPr>
             <a:r>
               <a:rPr/>
-              <a:t>The point worth stressing is why the soft margin is not a patch or a convenience. With even one mislabelled point inside the other class, the strict problem is INFEASIBLE - there is no solution, not a bad one. Real data always contains such points. So the soft margin is the only version anyone ever runs; the hard-margin problem is a teaching device.</a:t>
-            </a:r>
-          </a:p>
-          <a:p>
-            <a:pPr lvl="0" indent="0" marL="0">
-              <a:buNone/>
-            </a:pPr>
-          </a:p>
-          <a:p>
-            <a:pPr lvl="0" indent="0" marL="0">
-              <a:buNone/>
-            </a:pPr>
-            <a:r>
-              <a:rPr/>
-              <a:t>Our own labels are flipped at 4%, deliberately, so this is not a hypothetical for this dataset: the hard-margin problem on these pumps has no answer.</a:t>
-            </a:r>
-          </a:p>
-          <a:p>
-            <a:pPr lvl="0" indent="0" marL="0">
-              <a:buNone/>
-            </a:pPr>
-          </a:p>
-          <a:p>
-            <a:pPr lvl="0" indent="0" marL="0">
-              <a:buNone/>
-            </a:pPr>
-            <a:r>
-              <a:rPr/>
-              <a:t>The next slide puts it in symbols. Handout section 5.2 has the derivation.</a:t>
+              <a:t>The solid line is the boundary, the dashed lines are the edges of the slab, and the circled points are the support vectors touching it.</a:t>
+            </a:r>
+          </a:p>
+          <a:p>
+            <a:pPr lvl="0" indent="0" marL="0">
+              <a:buNone/>
+            </a:pPr>
+          </a:p>
+          <a:p>
+            <a:pPr lvl="0" indent="0" marL="0">
+              <a:buNone/>
+            </a:pPr>
+            <a:r>
+              <a:rPr/>
+              <a:t>The number to say out loud: of eighty points, THREE determine the answer. Move any of the other seventy-seven - anywhere, as far as you like, as long as they stay outside the slab - and the boundary does not shift by a millimetre.</a:t>
+            </a:r>
+          </a:p>
+          <a:p>
+            <a:pPr lvl="0" indent="0" marL="0">
+              <a:buNone/>
+            </a:pPr>
+          </a:p>
+          <a:p>
+            <a:pPr lvl="0" indent="0" marL="0">
+              <a:buNone/>
+            </a:pPr>
+            <a:r>
+              <a:rPr/>
+              <a:t>That is where the name comes from, and it is a genuinely different idea from anything so far. Every linear model in lessons 3 and 4 used every row: each one contributed to the gradient in proportion to its error. Here most of the data is irrelevant once the fit is done.</a:t>
+            </a:r>
+          </a:p>
+          <a:p>
+            <a:pPr lvl="0" indent="0" marL="0">
+              <a:buNone/>
+            </a:pPr>
+          </a:p>
+          <a:p>
+            <a:pPr lvl="0" indent="0" marL="0">
+              <a:buNone/>
+            </a:pPr>
+            <a:r>
+              <a:rPr/>
+              <a:t>Two consequences worth naming. The model is small - you store the support vectors, not the dataset, which is the contrast with k-NN. And it is sensitive in a specific way: an outlier near the boundary matters enormously, while an outlier far from it matters not at all.</a:t>
             </a:r>
           </a:p>
         </p:txBody>
@@ -4386,49 +4387,35 @@
             </a:pPr>
             <a:r>
               <a:rPr/>
-              <a:t>The constraint is not on the slide any more - it made the line wide enough to land at 28pt - so state it: subject to y_i(w’x_i + b) &gt;= 1 - xi_i, every point on the right side of the slab by a margin, or paying xi_i for the shortfall. Handout section 5.2 writes it out.</a:t>
-            </a:r>
-          </a:p>
-          <a:p>
-            <a:pPr lvl="0" indent="0" marL="0">
-              <a:buNone/>
-            </a:pPr>
-          </a:p>
-          <a:p>
-            <a:pPr lvl="0" indent="0" marL="0">
-              <a:buNone/>
-            </a:pPr>
-            <a:r>
-              <a:rPr/>
-              <a:t>Do not derive this. State what each piece is doing and move on - handout section 5.2 has the derivation, including why maximising the margin is the same as minimising the norm of w.</a:t>
-            </a:r>
-          </a:p>
-          <a:p>
-            <a:pPr lvl="0" indent="0" marL="0">
-              <a:buNone/>
-            </a:pPr>
-          </a:p>
-          <a:p>
-            <a:pPr lvl="0" indent="0" marL="0">
-              <a:buNone/>
-            </a:pPr>
-            <a:r>
-              <a:rPr/>
-              <a:t>The first term wants a wide slab. The second term wants few violations. C sets the exchange rate between them, and that is the entire content of the expression. Read it out in those words rather than reading the symbols.</a:t>
-            </a:r>
-          </a:p>
-          <a:p>
-            <a:pPr lvl="0" indent="0" marL="0">
-              <a:buNone/>
-            </a:pPr>
-          </a:p>
-          <a:p>
-            <a:pPr lvl="0" indent="0" marL="0">
-              <a:buNone/>
-            </a:pPr>
-            <a:r>
-              <a:rPr/>
-              <a:t>If someone asks about the half in front of the norm: it is there to make the derivative tidy, exactly as in lesson 3’s cost function.</a:t>
+              <a:t>The point worth stressing is why the soft margin is not a patch or a convenience. With even one mislabelled point inside the other class, the strict problem is INFEASIBLE - there is no solution, not a bad one. Real data always contains such points. So the soft margin is the only version anyone ever runs; the hard-margin problem is a teaching device.</a:t>
+            </a:r>
+          </a:p>
+          <a:p>
+            <a:pPr lvl="0" indent="0" marL="0">
+              <a:buNone/>
+            </a:pPr>
+          </a:p>
+          <a:p>
+            <a:pPr lvl="0" indent="0" marL="0">
+              <a:buNone/>
+            </a:pPr>
+            <a:r>
+              <a:rPr/>
+              <a:t>Our own labels are flipped at 4%, deliberately, so this is not a hypothetical for this dataset: the hard-margin problem on these pumps has no answer.</a:t>
+            </a:r>
+          </a:p>
+          <a:p>
+            <a:pPr lvl="0" indent="0" marL="0">
+              <a:buNone/>
+            </a:pPr>
+          </a:p>
+          <a:p>
+            <a:pPr lvl="0" indent="0" marL="0">
+              <a:buNone/>
+            </a:pPr>
+            <a:r>
+              <a:rPr/>
+              <a:t>The next slide puts it in symbols. Handout section 5.2 has the derivation.</a:t>
             </a:r>
           </a:p>
         </p:txBody>
@@ -4510,55 +4497,49 @@
             </a:pPr>
             <a:r>
               <a:rPr/>
-              <a:t>Third appearance of the same idea, and say so - that repetition is the point. Lesson 3 had λ, this morning had k, now C. Every model has one knob that trades fitting this data against surviving the next, and recognising it in an unfamiliar model is worth more than memorising three names.</a:t>
-            </a:r>
-          </a:p>
-          <a:p>
-            <a:pPr lvl="0" indent="0" marL="0">
-              <a:buNone/>
-            </a:pPr>
-          </a:p>
-          <a:p>
-            <a:pPr lvl="0" indent="0" marL="0">
-              <a:buNone/>
-            </a:pPr>
-            <a:r>
-              <a:rPr/>
-              <a:t>Then the direction, which catches people out constantly and is worth writing on the board. Large λ means MORE regularisation. Large C means LESS. They run opposite ways, and scikit-learn’s </a:t>
-            </a:r>
-            <a:r>
-              <a:rPr>
-                <a:latin typeface="Courier"/>
-              </a:rPr>
-              <a:t>C</a:t>
-            </a:r>
-            <a:r>
-              <a:rPr/>
-              <a:t> parameter in </a:t>
-            </a:r>
-            <a:r>
-              <a:rPr>
-                <a:latin typeface="Courier"/>
-              </a:rPr>
-              <a:t>LogisticRegression</a:t>
-            </a:r>
-            <a:r>
-              <a:rPr/>
-              <a:t> has the same inverted convention - it is the reciprocal of the penalty there too.</a:t>
-            </a:r>
-          </a:p>
-          <a:p>
-            <a:pPr lvl="0" indent="0" marL="0">
-              <a:buNone/>
-            </a:pPr>
-          </a:p>
-          <a:p>
-            <a:pPr lvl="0" indent="0" marL="0">
-              <a:buNone/>
-            </a:pPr>
-            <a:r>
-              <a:rPr/>
-              <a:t>Ask them which way they would expect C to run before you tell them. Most guess wrong, and having guessed wrong once is what makes it stick.</a:t>
+              <a:t>The constraint is not on the slide any more - it made the line wide enough to land at 28pt - so state it: subject to y_i(w’x_i + b) &gt;= 1 - xi_i, every point on the right side of the slab by a margin, or paying xi_i for the shortfall. Handout section 5.2 writes it out.</a:t>
+            </a:r>
+          </a:p>
+          <a:p>
+            <a:pPr lvl="0" indent="0" marL="0">
+              <a:buNone/>
+            </a:pPr>
+          </a:p>
+          <a:p>
+            <a:pPr lvl="0" indent="0" marL="0">
+              <a:buNone/>
+            </a:pPr>
+            <a:r>
+              <a:rPr/>
+              <a:t>Do not derive this. State what each piece is doing and move on - handout section 5.2 has the derivation, including why maximising the margin is the same as minimising the norm of w.</a:t>
+            </a:r>
+          </a:p>
+          <a:p>
+            <a:pPr lvl="0" indent="0" marL="0">
+              <a:buNone/>
+            </a:pPr>
+          </a:p>
+          <a:p>
+            <a:pPr lvl="0" indent="0" marL="0">
+              <a:buNone/>
+            </a:pPr>
+            <a:r>
+              <a:rPr/>
+              <a:t>The first term wants a wide slab. The second term wants few violations. C sets the exchange rate between them, and that is the entire content of the expression. Read it out in those words rather than reading the symbols.</a:t>
+            </a:r>
+          </a:p>
+          <a:p>
+            <a:pPr lvl="0" indent="0" marL="0">
+              <a:buNone/>
+            </a:pPr>
+          </a:p>
+          <a:p>
+            <a:pPr lvl="0" indent="0" marL="0">
+              <a:buNone/>
+            </a:pPr>
+            <a:r>
+              <a:rPr/>
+              <a:t>If someone asks about the half in front of the norm: it is there to make the derivative tidy, exactly as in lesson 3’s cost function.</a:t>
             </a:r>
           </a:p>
         </p:txBody>
@@ -4764,49 +4745,55 @@
             </a:pPr>
             <a:r>
               <a:rPr/>
-              <a:t>The linear kernel scores 0.613 - the base rate, exactly as logistic regression did this morning, with the same zero variance across folds.</a:t>
-            </a:r>
-          </a:p>
-          <a:p>
-            <a:pPr lvl="0" indent="0" marL="0">
-              <a:buNone/>
-            </a:pPr>
-          </a:p>
-          <a:p>
-            <a:pPr lvl="0" indent="0" marL="0">
-              <a:buNone/>
-            </a:pPr>
-            <a:r>
-              <a:rPr/>
-              <a:t>Make the point explicitly, because it is the one students most often get backwards: the margin criterion is a better way of CHOOSING among straight lines. It does not give you anything other than a straight line. When no straight line works, choosing the best one optimally still gets you nothing. A better criterion cannot rescue an inadequate hypothesis class.</a:t>
-            </a:r>
-          </a:p>
-          <a:p>
-            <a:pPr lvl="0" indent="0" marL="0">
-              <a:buNone/>
-            </a:pPr>
-          </a:p>
-          <a:p>
-            <a:pPr lvl="0" indent="0" marL="0">
-              <a:buNone/>
-            </a:pPr>
-            <a:r>
-              <a:rPr/>
-              <a:t>Then the RBF row, which is the same algorithm with one argument changed, at 0.947 - the best number in the whole lesson, and within a hair of the 0.96 ceiling.</a:t>
-            </a:r>
-          </a:p>
-          <a:p>
-            <a:pPr lvl="0" indent="0" marL="0">
-              <a:buNone/>
-            </a:pPr>
-          </a:p>
-          <a:p>
-            <a:pPr lvl="0" indent="0" marL="0">
-              <a:buNone/>
-            </a:pPr>
-            <a:r>
-              <a:rPr/>
-              <a:t>The support-vector column says the same thing in a second language, and that is the next slide.</a:t>
+              <a:t>Third appearance of the same idea, and say so - that repetition is the point. Lesson 3 had λ, this morning had k, now C. Every model has one knob that trades fitting this data against surviving the next, and recognising it in an unfamiliar model is worth more than memorising three names.</a:t>
+            </a:r>
+          </a:p>
+          <a:p>
+            <a:pPr lvl="0" indent="0" marL="0">
+              <a:buNone/>
+            </a:pPr>
+          </a:p>
+          <a:p>
+            <a:pPr lvl="0" indent="0" marL="0">
+              <a:buNone/>
+            </a:pPr>
+            <a:r>
+              <a:rPr/>
+              <a:t>Then the direction, which catches people out constantly and is worth writing on the board. Large λ means MORE regularisation. Large C means LESS. They run opposite ways, and scikit-learn’s </a:t>
+            </a:r>
+            <a:r>
+              <a:rPr>
+                <a:latin typeface="Courier"/>
+              </a:rPr>
+              <a:t>C</a:t>
+            </a:r>
+            <a:r>
+              <a:rPr/>
+              <a:t> parameter in </a:t>
+            </a:r>
+            <a:r>
+              <a:rPr>
+                <a:latin typeface="Courier"/>
+              </a:rPr>
+              <a:t>LogisticRegression</a:t>
+            </a:r>
+            <a:r>
+              <a:rPr/>
+              <a:t> has the same inverted convention - it is the reciprocal of the penalty there too.</a:t>
+            </a:r>
+          </a:p>
+          <a:p>
+            <a:pPr lvl="0" indent="0" marL="0">
+              <a:buNone/>
+            </a:pPr>
+          </a:p>
+          <a:p>
+            <a:pPr lvl="0" indent="0" marL="0">
+              <a:buNone/>
+            </a:pPr>
+            <a:r>
+              <a:rPr/>
+              <a:t>Ask them which way they would expect C to run before you tell them. Most guess wrong, and having guessed wrong once is what makes it stick.</a:t>
             </a:r>
           </a:p>
         </p:txBody>
@@ -4888,59 +4875,49 @@
             </a:pPr>
             <a:r>
               <a:rPr/>
-              <a:t>Explain what 79% actually means geometrically. A support vector is a point on the margin or inside it. If 79% of your data is in that position, there is no region of empty space between the classes at all - the model has been forced to place a boundary through a crowd.</a:t>
-            </a:r>
-          </a:p>
-          <a:p>
-            <a:pPr lvl="0" indent="0" marL="0">
-              <a:buNone/>
-            </a:pPr>
-          </a:p>
-          <a:p>
-            <a:pPr lvl="0" indent="0" marL="0">
-              <a:buNone/>
-            </a:pPr>
-            <a:r>
-              <a:rPr/>
-              <a:t>Contrast with 23%, where the model found genuine room and only the points near the edge matter.</a:t>
-            </a:r>
-          </a:p>
-          <a:p>
-            <a:pPr lvl="0" indent="0" marL="0">
-              <a:buNone/>
-            </a:pPr>
-          </a:p>
-          <a:p>
-            <a:pPr lvl="0" indent="0" marL="0">
-              <a:buNone/>
-            </a:pPr>
-            <a:r>
-              <a:rPr/>
-              <a:t>Give them the diagnostic to keep, since it costs nothing: after fitting an SVM, look at </a:t>
-            </a:r>
-            <a:r>
-              <a:rPr>
-                <a:latin typeface="Courier"/>
-              </a:rPr>
-              <a:t>len(model.support_)</a:t>
-            </a:r>
-            <a:r>
-              <a:rPr/>
-              <a:t> over the number of training rows. High means the model is struggling to find room, which usually means the kernel is wrong for the geometry. It is a warning available BEFORE you cross-validate anything.</a:t>
-            </a:r>
-          </a:p>
-          <a:p>
-            <a:pPr lvl="0" indent="0" marL="0">
-              <a:buNone/>
-            </a:pPr>
-          </a:p>
-          <a:p>
-            <a:pPr lvl="0" indent="0" marL="0">
-              <a:buNone/>
-            </a:pPr>
-            <a:r>
-              <a:rPr/>
-              <a:t>Worth adding that it also predicts prediction cost - every support vector is one kernel evaluation per query, so a model needing 79% of the data has thrown away most of the speed advantage over k-NN.</a:t>
+              <a:t>The linear kernel scores 0.613 - the base rate, exactly as logistic regression did this morning, with the same zero variance across folds.</a:t>
+            </a:r>
+          </a:p>
+          <a:p>
+            <a:pPr lvl="0" indent="0" marL="0">
+              <a:buNone/>
+            </a:pPr>
+          </a:p>
+          <a:p>
+            <a:pPr lvl="0" indent="0" marL="0">
+              <a:buNone/>
+            </a:pPr>
+            <a:r>
+              <a:rPr/>
+              <a:t>Make the point explicitly, because it is the one students most often get backwards: the margin criterion is a better way of CHOOSING among straight lines. It does not give you anything other than a straight line. When no straight line works, choosing the best one optimally still gets you nothing. A better criterion cannot rescue an inadequate hypothesis class.</a:t>
+            </a:r>
+          </a:p>
+          <a:p>
+            <a:pPr lvl="0" indent="0" marL="0">
+              <a:buNone/>
+            </a:pPr>
+          </a:p>
+          <a:p>
+            <a:pPr lvl="0" indent="0" marL="0">
+              <a:buNone/>
+            </a:pPr>
+            <a:r>
+              <a:rPr/>
+              <a:t>Then the RBF row, which is the same algorithm with one argument changed, at 0.947 - the best number in the whole lesson, and within a hair of the 0.96 ceiling.</a:t>
+            </a:r>
+          </a:p>
+          <a:p>
+            <a:pPr lvl="0" indent="0" marL="0">
+              <a:buNone/>
+            </a:pPr>
+          </a:p>
+          <a:p>
+            <a:pPr lvl="0" indent="0" marL="0">
+              <a:buNone/>
+            </a:pPr>
+            <a:r>
+              <a:rPr/>
+              <a:t>The support-vector column says the same thing in a second language, and that is the next slide.</a:t>
             </a:r>
           </a:p>
         </p:txBody>
@@ -5022,49 +4999,59 @@
             </a:pPr>
             <a:r>
               <a:rPr/>
-              <a:t>Build the picture in words first and let them see it before the figure appears. Take the scatter plot from the start of the lesson, lift each point off the page by its distance from the centre, and look from the side.</a:t>
-            </a:r>
-          </a:p>
-          <a:p>
-            <a:pPr lvl="0" indent="0" marL="0">
-              <a:buNone/>
-            </a:pPr>
-          </a:p>
-          <a:p>
-            <a:pPr lvl="0" indent="0" marL="0">
-              <a:buNone/>
-            </a:pPr>
-            <a:r>
-              <a:rPr/>
-              <a:t>Then the sentence that reframes the whole afternoon: the classes were never inseparable. Separability is not a property of the data - it is a property of the data AND the coordinates you happen to have measured it in.</a:t>
-            </a:r>
-          </a:p>
-          <a:p>
-            <a:pPr lvl="0" indent="0" marL="0">
-              <a:buNone/>
-            </a:pPr>
-          </a:p>
-          <a:p>
-            <a:pPr lvl="0" indent="0" marL="0">
-              <a:buNone/>
-            </a:pPr>
-            <a:r>
-              <a:rPr/>
-              <a:t>Ask what is unsatisfying about what we just did, and wait for it. We chose that lift by already knowing the answer. We knew the fault mode was radial. In any real problem you do not, and inventing the right coordinate is the hard part - which is exactly the difficulty the kernel trick removes.</a:t>
-            </a:r>
-          </a:p>
-          <a:p>
-            <a:pPr lvl="0" indent="0" marL="0">
-              <a:buNone/>
-            </a:pPr>
-          </a:p>
-          <a:p>
-            <a:pPr lvl="0" indent="0" marL="0">
-              <a:buNone/>
-            </a:pPr>
-            <a:r>
-              <a:rPr/>
-              <a:t>Handout section 5.4.</a:t>
+              <a:t>Explain what 79% actually means geometrically. A support vector is a point on the margin or inside it. If 79% of your data is in that position, there is no region of empty space between the classes at all - the model has been forced to place a boundary through a crowd.</a:t>
+            </a:r>
+          </a:p>
+          <a:p>
+            <a:pPr lvl="0" indent="0" marL="0">
+              <a:buNone/>
+            </a:pPr>
+          </a:p>
+          <a:p>
+            <a:pPr lvl="0" indent="0" marL="0">
+              <a:buNone/>
+            </a:pPr>
+            <a:r>
+              <a:rPr/>
+              <a:t>Contrast with 23%, where the model found genuine room and only the points near the edge matter.</a:t>
+            </a:r>
+          </a:p>
+          <a:p>
+            <a:pPr lvl="0" indent="0" marL="0">
+              <a:buNone/>
+            </a:pPr>
+          </a:p>
+          <a:p>
+            <a:pPr lvl="0" indent="0" marL="0">
+              <a:buNone/>
+            </a:pPr>
+            <a:r>
+              <a:rPr/>
+              <a:t>Give them the diagnostic to keep, since it costs nothing: after fitting an SVM, look at </a:t>
+            </a:r>
+            <a:r>
+              <a:rPr>
+                <a:latin typeface="Courier"/>
+              </a:rPr>
+              <a:t>len(model.support_)</a:t>
+            </a:r>
+            <a:r>
+              <a:rPr/>
+              <a:t> over the number of training rows. High means the model is struggling to find room, which usually means the kernel is wrong for the geometry. It is a warning available BEFORE you cross-validate anything.</a:t>
+            </a:r>
+          </a:p>
+          <a:p>
+            <a:pPr lvl="0" indent="0" marL="0">
+              <a:buNone/>
+            </a:pPr>
+          </a:p>
+          <a:p>
+            <a:pPr lvl="0" indent="0" marL="0">
+              <a:buNone/>
+            </a:pPr>
+            <a:r>
+              <a:rPr/>
+              <a:t>Worth adding that it also predicts prediction cost - every support vector is one kernel evaluation per query, so a model needing 79% of the data has thrown away most of the speed advantage over k-NN.</a:t>
             </a:r>
           </a:p>
         </p:txBody>
@@ -5146,35 +5133,49 @@
             </a:pPr>
             <a:r>
               <a:rPr/>
-              <a:t>The same 1,200 pumps twice: on the left in the plane where they were measured, on the right lifted by their distance from the design point. The gold plane does what no line could.</a:t>
-            </a:r>
-          </a:p>
-          <a:p>
-            <a:pPr lvl="0" indent="0" marL="0">
-              <a:buNone/>
-            </a:pPr>
-          </a:p>
-          <a:p>
-            <a:pPr lvl="0" indent="0" marL="0">
-              <a:buNone/>
-            </a:pPr>
-            <a:r>
-              <a:rPr/>
-              <a:t>Have them look at the right panel and confirm for themselves that a flat horizontal cut separates the colours cleanly. Nothing was added - no new measurement, no extra sensor. The third coordinate is computed from the two they already had.</a:t>
-            </a:r>
-          </a:p>
-          <a:p>
-            <a:pPr lvl="0" indent="0" marL="0">
-              <a:buNone/>
-            </a:pPr>
-          </a:p>
-          <a:p>
-            <a:pPr lvl="0" indent="0" marL="0">
-              <a:buNone/>
-            </a:pPr>
-            <a:r>
-              <a:rPr/>
-              <a:t>Then set up the objection that the next slide answers. This worked because the lift was three-dimensional and we could guess it. The spaces that work in general are enormous - the useful ones are sometimes infinite-dimensional - and computing the coordinates of every point in such a space is impossible.</a:t>
+              <a:t>Build the picture in words first and let them see it before the figure appears. Take the scatter plot from the start of the lesson, lift each point off the page by its distance from the centre, and look from the side.</a:t>
+            </a:r>
+          </a:p>
+          <a:p>
+            <a:pPr lvl="0" indent="0" marL="0">
+              <a:buNone/>
+            </a:pPr>
+          </a:p>
+          <a:p>
+            <a:pPr lvl="0" indent="0" marL="0">
+              <a:buNone/>
+            </a:pPr>
+            <a:r>
+              <a:rPr/>
+              <a:t>Then the sentence that reframes the whole afternoon: the classes were never inseparable. Separability is not a property of the data - it is a property of the data AND the coordinates you happen to have measured it in.</a:t>
+            </a:r>
+          </a:p>
+          <a:p>
+            <a:pPr lvl="0" indent="0" marL="0">
+              <a:buNone/>
+            </a:pPr>
+          </a:p>
+          <a:p>
+            <a:pPr lvl="0" indent="0" marL="0">
+              <a:buNone/>
+            </a:pPr>
+            <a:r>
+              <a:rPr/>
+              <a:t>Ask what is unsatisfying about what we just did, and wait for it. We chose that lift by already knowing the answer. We knew the fault mode was radial. In any real problem you do not, and inventing the right coordinate is the hard part - which is exactly the difficulty the kernel trick removes.</a:t>
+            </a:r>
+          </a:p>
+          <a:p>
+            <a:pPr lvl="0" indent="0" marL="0">
+              <a:buNone/>
+            </a:pPr>
+          </a:p>
+          <a:p>
+            <a:pPr lvl="0" indent="0" marL="0">
+              <a:buNone/>
+            </a:pPr>
+            <a:r>
+              <a:rPr/>
+              <a:t>Handout section 5.4.</a:t>
             </a:r>
           </a:p>
         </p:txBody>
@@ -5256,35 +5257,35 @@
             </a:pPr>
             <a:r>
               <a:rPr/>
-              <a:t>The trick in one sentence: the SVM never needs the coordinates, only the angles and lengths between points, and those can be obtained without ever going there.</a:t>
-            </a:r>
-          </a:p>
-          <a:p>
-            <a:pPr lvl="0" indent="0" marL="0">
-              <a:buNone/>
-            </a:pPr>
-          </a:p>
-          <a:p>
-            <a:pPr lvl="0" indent="0" marL="0">
-              <a:buNone/>
-            </a:pPr>
-            <a:r>
-              <a:rPr/>
-              <a:t>Do not prove it - handout section 5.4 shows where the inner products come from in the dual formulation. The claim to state and let land is that a function of two ordinary two-dimensional vectors returns their inner product in a space of infinite dimension, at the cost of one exponential.</a:t>
-            </a:r>
-          </a:p>
-          <a:p>
-            <a:pPr lvl="0" indent="0" marL="0">
-              <a:buNone/>
-            </a:pPr>
-          </a:p>
-          <a:p>
-            <a:pPr lvl="0" indent="0" marL="0">
-              <a:buNone/>
-            </a:pPr>
-            <a:r>
-              <a:rPr/>
-              <a:t>And close the loop from the previous slide: we chose the lift in the picture by knowing the answer. The RBF kernel does something equivalent without being told, which is exactly why it works on problems where nobody could guess the right coordinates.</a:t>
+              <a:t>The same 1,200 pumps twice: on the left in the plane where they were measured, on the right lifted by their distance from the design point. The gold plane does what no line could.</a:t>
+            </a:r>
+          </a:p>
+          <a:p>
+            <a:pPr lvl="0" indent="0" marL="0">
+              <a:buNone/>
+            </a:pPr>
+          </a:p>
+          <a:p>
+            <a:pPr lvl="0" indent="0" marL="0">
+              <a:buNone/>
+            </a:pPr>
+            <a:r>
+              <a:rPr/>
+              <a:t>Have them look at the right panel and confirm for themselves that a flat horizontal cut separates the colours cleanly. Nothing was added - no new measurement, no extra sensor. The third coordinate is computed from the two they already had.</a:t>
+            </a:r>
+          </a:p>
+          <a:p>
+            <a:pPr lvl="0" indent="0" marL="0">
+              <a:buNone/>
+            </a:pPr>
+          </a:p>
+          <a:p>
+            <a:pPr lvl="0" indent="0" marL="0">
+              <a:buNone/>
+            </a:pPr>
+            <a:r>
+              <a:rPr/>
+              <a:t>Then set up the objection that the next slide answers. This worked because the lift was three-dimensional and we could guess it. The spaces that work in general are enormous - the useful ones are sometimes infinite-dimensional - and computing the coordinates of every point in such a space is impossible.</a:t>
             </a:r>
           </a:p>
         </p:txBody>
@@ -5366,59 +5367,35 @@
             </a:pPr>
             <a:r>
               <a:rPr/>
-              <a:t>One line, and it is the whole of what scikit-learn does when you leave </a:t>
-            </a:r>
-            <a:r>
-              <a:rPr>
-                <a:latin typeface="Courier"/>
-              </a:rPr>
-              <a:t>kernel</a:t>
-            </a:r>
-            <a:r>
-              <a:rPr/>
-              <a:t> at its default.</a:t>
-            </a:r>
-          </a:p>
-          <a:p>
-            <a:pPr lvl="0" indent="0" marL="0">
-              <a:buNone/>
-            </a:pPr>
-          </a:p>
-          <a:p>
-            <a:pPr lvl="0" indent="0" marL="0">
-              <a:buNone/>
-            </a:pPr>
-            <a:r>
-              <a:rPr/>
-              <a:t>Read it aloud as a similarity rather than as a formula: the closer two points are, the nearer the exponent is to zero and the nearer the kernel is to one; far apart, it falls away to nothing. That is all an RBF kernel says - how much does this point look like that one.</a:t>
-            </a:r>
-          </a:p>
-          <a:p>
-            <a:pPr lvl="0" indent="0" marL="0">
-              <a:buNone/>
-            </a:pPr>
-          </a:p>
-          <a:p>
-            <a:pPr lvl="0" indent="0" marL="0">
-              <a:buNone/>
-            </a:pPr>
-            <a:r>
-              <a:rPr/>
-              <a:t>Now say what γ means, because the next two slides turn on it: it sets how far a single training point’s influence reaches. Small γ, wide reach, smooth boundary. Large γ, each point influences only its immediate neighbourhood - and a boundary that can afford an island around every mislabelled pump.</a:t>
-            </a:r>
-          </a:p>
-          <a:p>
-            <a:pPr lvl="0" indent="0" marL="0">
-              <a:buNone/>
-            </a:pPr>
-          </a:p>
-          <a:p>
-            <a:pPr lvl="0" indent="0" marL="0">
-              <a:buNone/>
-            </a:pPr>
-            <a:r>
-              <a:rPr/>
-              <a:t>Worth naming the cost, since this is an engineering course: one exponential per pair of points, so the kernel matrix is m × m. That is why support vector machines are a poor fit above a hundred thousand rows, and it is a property of the method rather than of the implementation.</a:t>
+              <a:t>The trick in one sentence: the SVM never needs the coordinates, only the angles and lengths between points, and those can be obtained without ever going there.</a:t>
+            </a:r>
+          </a:p>
+          <a:p>
+            <a:pPr lvl="0" indent="0" marL="0">
+              <a:buNone/>
+            </a:pPr>
+          </a:p>
+          <a:p>
+            <a:pPr lvl="0" indent="0" marL="0">
+              <a:buNone/>
+            </a:pPr>
+            <a:r>
+              <a:rPr/>
+              <a:t>Do not prove it - handout section 5.4 shows where the inner products come from in the dual formulation. The claim to state and let land is that a function of two ordinary two-dimensional vectors returns their inner product in a space of infinite dimension, at the cost of one exponential.</a:t>
+            </a:r>
+          </a:p>
+          <a:p>
+            <a:pPr lvl="0" indent="0" marL="0">
+              <a:buNone/>
+            </a:pPr>
+          </a:p>
+          <a:p>
+            <a:pPr lvl="0" indent="0" marL="0">
+              <a:buNone/>
+            </a:pPr>
+            <a:r>
+              <a:rPr/>
+              <a:t>And close the loop from the previous slide: we chose the lift in the picture by knowing the answer. The RBF kernel does something equivalent without being told, which is exactly why it works on problems where nobody could guess the right coordinates.</a:t>
             </a:r>
           </a:p>
         </p:txBody>
@@ -5500,53 +5477,59 @@
             </a:pPr>
             <a:r>
               <a:rPr/>
-              <a:t>Read the two columns against each other, exactly as lesson 5 taught, and let the last row do the work.</a:t>
-            </a:r>
-          </a:p>
-          <a:p>
-            <a:pPr lvl="0" indent="0" marL="0">
-              <a:buNone/>
-            </a:pPr>
-          </a:p>
-          <a:p>
-            <a:pPr lvl="0" indent="0" marL="0">
-              <a:buNone/>
-            </a:pPr>
-            <a:r>
-              <a:rPr/>
-              <a:t>The bottom row has the best training score on the slide - 0.995, nearly perfect - and the worst honest one. That is the signature of overfitting, and here it is not inferred from theory but measured on the same data by two different procedures.</a:t>
-            </a:r>
-          </a:p>
-          <a:p>
-            <a:pPr lvl="0" indent="0" marL="0">
-              <a:buNone/>
-            </a:pPr>
-          </a:p>
-          <a:p>
-            <a:pPr lvl="0" indent="0" marL="0">
-              <a:buNone/>
-            </a:pPr>
-            <a:r>
-              <a:rPr b="1"/>
-              <a:t>Now the second predictable mistake, and defend the instinct.</a:t>
-            </a:r>
-            <a:r>
-              <a:rPr/>
-              <a:t> Choosing between these three on the training score selects the WORST model, with complete confidence and a very impressive number to report. And the instinct behind it is not stupid: a higher score on the data you have is, in every other part of engineering, evidence of a better system. Fitting the data well is what we spent lessons 3 and 4 doing. What breaks the analogy is that a flexible model can fit data it has already been shown without learning anything transferable.</a:t>
-            </a:r>
-          </a:p>
-          <a:p>
-            <a:pPr lvl="0" indent="0" marL="0">
-              <a:buNone/>
-            </a:pPr>
-          </a:p>
-          <a:p>
-            <a:pPr lvl="0" indent="0" marL="0">
-              <a:buNone/>
-            </a:pPr>
-            <a:r>
-              <a:rPr/>
-              <a:t>The reason this table is on the slide rather than in the handout is that the next slide shows the same three settings as pictures - so the failure is visible as well as measurable, which is rare.</a:t>
+              <a:t>One line, and it is the whole of what scikit-learn does when you leave </a:t>
+            </a:r>
+            <a:r>
+              <a:rPr>
+                <a:latin typeface="Courier"/>
+              </a:rPr>
+              <a:t>kernel</a:t>
+            </a:r>
+            <a:r>
+              <a:rPr/>
+              <a:t> at its default.</a:t>
+            </a:r>
+          </a:p>
+          <a:p>
+            <a:pPr lvl="0" indent="0" marL="0">
+              <a:buNone/>
+            </a:pPr>
+          </a:p>
+          <a:p>
+            <a:pPr lvl="0" indent="0" marL="0">
+              <a:buNone/>
+            </a:pPr>
+            <a:r>
+              <a:rPr/>
+              <a:t>Read it aloud as a similarity rather than as a formula: the closer two points are, the nearer the exponent is to zero and the nearer the kernel is to one; far apart, it falls away to nothing. That is all an RBF kernel says - how much does this point look like that one.</a:t>
+            </a:r>
+          </a:p>
+          <a:p>
+            <a:pPr lvl="0" indent="0" marL="0">
+              <a:buNone/>
+            </a:pPr>
+          </a:p>
+          <a:p>
+            <a:pPr lvl="0" indent="0" marL="0">
+              <a:buNone/>
+            </a:pPr>
+            <a:r>
+              <a:rPr/>
+              <a:t>Now say what γ means, because the next two slides turn on it: it sets how far a single training point’s influence reaches. Small γ, wide reach, smooth boundary. Large γ, each point influences only its immediate neighbourhood - and a boundary that can afford an island around every mislabelled pump.</a:t>
+            </a:r>
+          </a:p>
+          <a:p>
+            <a:pPr lvl="0" indent="0" marL="0">
+              <a:buNone/>
+            </a:pPr>
+          </a:p>
+          <a:p>
+            <a:pPr lvl="0" indent="0" marL="0">
+              <a:buNone/>
+            </a:pPr>
+            <a:r>
+              <a:rPr/>
+              <a:t>Worth naming the cost, since this is an engineering course: one exponential per pair of points, so the kernel matrix is m × m. That is why support vector machines are a poor fit above a hundred thousand rows, and it is a property of the method rather than of the implementation.</a:t>
             </a:r>
           </a:p>
         </p:txBody>
@@ -5628,63 +5611,53 @@
             </a:pPr>
             <a:r>
               <a:rPr/>
-              <a:t>Three settings, with training and cross-validated scores in each title. Read them together.</a:t>
-            </a:r>
-          </a:p>
-          <a:p>
-            <a:pPr lvl="0" indent="0" marL="0">
-              <a:buNone/>
-            </a:pPr>
-          </a:p>
-          <a:p>
-            <a:pPr lvl="0" indent="0" marL="0">
-              <a:buNone/>
-            </a:pPr>
-            <a:r>
-              <a:rPr/>
-              <a:t>Left, γ = 0.1: a smooth boundary, slightly too smooth, and the two scores agree. Middle, γ = 1: close to the true envelope, and the best honest score.</a:t>
-            </a:r>
-          </a:p>
-          <a:p>
-            <a:pPr lvl="0" indent="0" marL="0">
-              <a:buNone/>
-            </a:pPr>
-          </a:p>
-          <a:p>
-            <a:pPr lvl="0" indent="0" marL="0">
-              <a:buNone/>
-            </a:pPr>
-            <a:r>
-              <a:rPr/>
-              <a:t>Right is the one to sit on. The boundary has broken into bubbles - small islands around individual points, including the mislabelled ones. That is what a 0.995 training score looks like from the outside: the model has drawn a private territory around each flipped label so that it can get it right.</a:t>
-            </a:r>
-          </a:p>
-          <a:p>
-            <a:pPr lvl="0" indent="0" marL="0">
-              <a:buNone/>
-            </a:pPr>
-          </a:p>
-          <a:p>
-            <a:pPr lvl="0" indent="0" marL="0">
-              <a:buNone/>
-            </a:pPr>
-            <a:r>
-              <a:rPr/>
-              <a:t>Ask them what happens to a new pump landing in the gap between two bubbles. That is the 0.902.</a:t>
-            </a:r>
-          </a:p>
-          <a:p>
-            <a:pPr lvl="0" indent="0" marL="0">
-              <a:buNone/>
-            </a:pPr>
-          </a:p>
-          <a:p>
-            <a:pPr lvl="0" indent="0" marL="0">
-              <a:buNone/>
-            </a:pPr>
-            <a:r>
-              <a:rPr/>
-              <a:t>The reason this slide matters more than the table: they have seen overfitting as a curve on a plot since lesson 5. Here it is a shape in the input space, and the shape is obviously wrong in a way no number is. When you can plot the boundary, plot it.</a:t>
+              <a:t>Read the two columns against each other, exactly as lesson 5 taught, and let the last row do the work.</a:t>
+            </a:r>
+          </a:p>
+          <a:p>
+            <a:pPr lvl="0" indent="0" marL="0">
+              <a:buNone/>
+            </a:pPr>
+          </a:p>
+          <a:p>
+            <a:pPr lvl="0" indent="0" marL="0">
+              <a:buNone/>
+            </a:pPr>
+            <a:r>
+              <a:rPr/>
+              <a:t>The bottom row has the best training score on the slide - 0.995, nearly perfect - and the worst honest one. That is the signature of overfitting, and here it is not inferred from theory but measured on the same data by two different procedures.</a:t>
+            </a:r>
+          </a:p>
+          <a:p>
+            <a:pPr lvl="0" indent="0" marL="0">
+              <a:buNone/>
+            </a:pPr>
+          </a:p>
+          <a:p>
+            <a:pPr lvl="0" indent="0" marL="0">
+              <a:buNone/>
+            </a:pPr>
+            <a:r>
+              <a:rPr b="1"/>
+              <a:t>Now the second predictable mistake, and defend the instinct.</a:t>
+            </a:r>
+            <a:r>
+              <a:rPr/>
+              <a:t> Choosing between these three on the training score selects the WORST model, with complete confidence and a very impressive number to report. And the instinct behind it is not stupid: a higher score on the data you have is, in every other part of engineering, evidence of a better system. Fitting the data well is what we spent lessons 3 and 4 doing. What breaks the analogy is that a flexible model can fit data it has already been shown without learning anything transferable.</a:t>
+            </a:r>
+          </a:p>
+          <a:p>
+            <a:pPr lvl="0" indent="0" marL="0">
+              <a:buNone/>
+            </a:pPr>
+          </a:p>
+          <a:p>
+            <a:pPr lvl="0" indent="0" marL="0">
+              <a:buNone/>
+            </a:pPr>
+            <a:r>
+              <a:rPr/>
+              <a:t>The reason this table is on the slide rather than in the handout is that the next slide shows the same three settings as pictures - so the failure is visible as well as measurable, which is rare.</a:t>
             </a:r>
           </a:p>
         </p:txBody>
@@ -5766,49 +5739,63 @@
             </a:pPr>
             <a:r>
               <a:rPr/>
-              <a:t>Run notebooks/03. Eighteen minutes.</a:t>
-            </a:r>
-          </a:p>
-          <a:p>
-            <a:pPr lvl="0" indent="0" marL="0">
-              <a:buNone/>
-            </a:pPr>
-          </a:p>
-          <a:p>
-            <a:pPr lvl="0" indent="0" marL="0">
-              <a:buNone/>
-            </a:pPr>
-            <a:r>
-              <a:rPr/>
-              <a:t>The cell to protect is the γ sweep with the boundary drawn at each setting. Let them turn γ up themselves and watch the bubbles form - it is the most direct experience of overfitting available in this course.</a:t>
-            </a:r>
-          </a:p>
-          <a:p>
-            <a:pPr lvl="0" indent="0" marL="0">
-              <a:buNone/>
-            </a:pPr>
-          </a:p>
-          <a:p>
-            <a:pPr lvl="0" indent="0" marL="0">
-              <a:buNone/>
-            </a:pPr>
-            <a:r>
-              <a:rPr/>
-              <a:t>Have them print the support-vector fraction for the linear and RBF kernels side by side. Two numbers, and it makes the diagnostic real rather than a claim on a slide.</a:t>
-            </a:r>
-          </a:p>
-          <a:p>
-            <a:pPr lvl="0" indent="0" marL="0">
-              <a:buNone/>
-            </a:pPr>
-          </a:p>
-          <a:p>
-            <a:pPr lvl="0" indent="0" marL="0">
-              <a:buNone/>
-            </a:pPr>
-            <a:r>
-              <a:rPr/>
-              <a:t>If time runs short, skip the C sweep and set it as reading: the table is in handout section 5.5.</a:t>
+              <a:t>Three settings, with training and cross-validated scores in each title. Read them together.</a:t>
+            </a:r>
+          </a:p>
+          <a:p>
+            <a:pPr lvl="0" indent="0" marL="0">
+              <a:buNone/>
+            </a:pPr>
+          </a:p>
+          <a:p>
+            <a:pPr lvl="0" indent="0" marL="0">
+              <a:buNone/>
+            </a:pPr>
+            <a:r>
+              <a:rPr/>
+              <a:t>Left, γ = 0.1: a smooth boundary, slightly too smooth, and the two scores agree. Middle, γ = 1: close to the true envelope, and the best honest score.</a:t>
+            </a:r>
+          </a:p>
+          <a:p>
+            <a:pPr lvl="0" indent="0" marL="0">
+              <a:buNone/>
+            </a:pPr>
+          </a:p>
+          <a:p>
+            <a:pPr lvl="0" indent="0" marL="0">
+              <a:buNone/>
+            </a:pPr>
+            <a:r>
+              <a:rPr/>
+              <a:t>Right is the one to sit on. The boundary has broken into bubbles - small islands around individual points, including the mislabelled ones. That is what a 0.995 training score looks like from the outside: the model has drawn a private territory around each flipped label so that it can get it right.</a:t>
+            </a:r>
+          </a:p>
+          <a:p>
+            <a:pPr lvl="0" indent="0" marL="0">
+              <a:buNone/>
+            </a:pPr>
+          </a:p>
+          <a:p>
+            <a:pPr lvl="0" indent="0" marL="0">
+              <a:buNone/>
+            </a:pPr>
+            <a:r>
+              <a:rPr/>
+              <a:t>Ask them what happens to a new pump landing in the gap between two bubbles. That is the 0.902.</a:t>
+            </a:r>
+          </a:p>
+          <a:p>
+            <a:pPr lvl="0" indent="0" marL="0">
+              <a:buNone/>
+            </a:pPr>
+          </a:p>
+          <a:p>
+            <a:pPr lvl="0" indent="0" marL="0">
+              <a:buNone/>
+            </a:pPr>
+            <a:r>
+              <a:rPr/>
+              <a:t>The reason this slide matters more than the table: they have seen overfitting as a curve on a plot since lesson 5. Here it is a shape in the input space, and the shape is obviously wrong in a way no number is. When you can plot the boundary, plot it.</a:t>
             </a:r>
           </a:p>
         </p:txBody>
@@ -5890,57 +5877,49 @@
             </a:pPr>
             <a:r>
               <a:rPr/>
-              <a:t>Everything in the lesson on the same 1,200 pumps, cross-validated the same way.</a:t>
-            </a:r>
-          </a:p>
-          <a:p>
-            <a:pPr lvl="0" indent="0" marL="0">
-              <a:buNone/>
-            </a:pPr>
-          </a:p>
-          <a:p>
-            <a:pPr lvl="0" indent="0" marL="0">
-              <a:buNone/>
-            </a:pPr>
-            <a:r>
-              <a:rPr/>
-              <a:t>Read the top three rows together: all exactly 0.613, and all three are linear. Then the bottom three, all near the ceiling, reached by three completely unrelated routes - remembering the neighbourhood, assuming independence, bending the space. There is no single idea shared between them.</a:t>
-            </a:r>
-          </a:p>
-          <a:p>
-            <a:pPr lvl="0" indent="0" marL="0">
-              <a:buNone/>
-            </a:pPr>
-          </a:p>
-          <a:p>
-            <a:pPr lvl="0" indent="0" marL="0">
-              <a:buNone/>
-            </a:pPr>
-            <a:r>
-              <a:rPr/>
-              <a:t>Then the number that is the lesson: the gap between best and worst is </a:t>
-            </a:r>
-            <a:r>
-              <a:rPr b="1"/>
-              <a:t>0.334</a:t>
-            </a:r>
-            <a:r>
-              <a:rPr/>
-              <a:t>. Larger than any difference this course has shown between a good model and a carefully tuned one - lesson 5’s entire hyperparameter search moved things by a few hundredths.</a:t>
-            </a:r>
-          </a:p>
-          <a:p>
-            <a:pPr lvl="0" indent="0" marL="0">
-              <a:buNone/>
-            </a:pPr>
-          </a:p>
-          <a:p>
-            <a:pPr lvl="0" indent="0" marL="0">
-              <a:buNone/>
-            </a:pPr>
-            <a:r>
-              <a:rPr/>
-              <a:t>Say the conclusion plainly, and it is the practical takeaway of the whole lesson: choosing the right family matters far more than tuning the wrong one. Nobody in the top three rows could have tuned their way out. And the way to tell which family you need is to look at the data first, which is what lesson 2 was for.</a:t>
+              <a:t>Run notebooks/03. Eighteen minutes.</a:t>
+            </a:r>
+          </a:p>
+          <a:p>
+            <a:pPr lvl="0" indent="0" marL="0">
+              <a:buNone/>
+            </a:pPr>
+          </a:p>
+          <a:p>
+            <a:pPr lvl="0" indent="0" marL="0">
+              <a:buNone/>
+            </a:pPr>
+            <a:r>
+              <a:rPr/>
+              <a:t>The cell to protect is the γ sweep with the boundary drawn at each setting. Let them turn γ up themselves and watch the bubbles form - it is the most direct experience of overfitting available in this course.</a:t>
+            </a:r>
+          </a:p>
+          <a:p>
+            <a:pPr lvl="0" indent="0" marL="0">
+              <a:buNone/>
+            </a:pPr>
+          </a:p>
+          <a:p>
+            <a:pPr lvl="0" indent="0" marL="0">
+              <a:buNone/>
+            </a:pPr>
+            <a:r>
+              <a:rPr/>
+              <a:t>Have them print the support-vector fraction for the linear and RBF kernels side by side. Two numbers, and it makes the diagnostic real rather than a claim on a slide.</a:t>
+            </a:r>
+          </a:p>
+          <a:p>
+            <a:pPr lvl="0" indent="0" marL="0">
+              <a:buNone/>
+            </a:pPr>
+          </a:p>
+          <a:p>
+            <a:pPr lvl="0" indent="0" marL="0">
+              <a:buNone/>
+            </a:pPr>
+            <a:r>
+              <a:rPr/>
+              <a:t>If time runs short, skip the C sweep and set it as reading: the table is in handout section 5.5.</a:t>
             </a:r>
           </a:p>
         </p:txBody>
@@ -6154,35 +6133,57 @@
             </a:pPr>
             <a:r>
               <a:rPr/>
-              <a:t>A table to photograph. Work down it and attach today’s evidence to each row, so it is remembered as a set of conclusions rather than as advice.</a:t>
-            </a:r>
-          </a:p>
-          <a:p>
-            <a:pPr lvl="0" indent="0" marL="0">
-              <a:buNone/>
-            </a:pPr>
-          </a:p>
-          <a:p>
-            <a:pPr lvl="0" indent="0" marL="0">
-              <a:buNone/>
-            </a:pPr>
-            <a:r>
-              <a:rPr/>
-              <a:t>Row two deserves a sentence on its own, because it is the one that sounds wrong after the last hour. Text classification is the canonical case: tens of thousands of word-count features, an assumption that is transparently false, and a method that works anyway - because being roughly right in ten thousand dimensions beats being unable to estimate anything at all. Also mention Naive Bayes as a baseline: it trains in one pass, so if your tuned model does not beat it you have learned something quickly and cheaply.</a:t>
-            </a:r>
-          </a:p>
-          <a:p>
-            <a:pPr lvl="0" indent="0" marL="0">
-              <a:buNone/>
-            </a:pPr>
-          </a:p>
-          <a:p>
-            <a:pPr lvl="0" indent="0" marL="0">
-              <a:buNone/>
-            </a:pPr>
-            <a:r>
-              <a:rPr/>
-              <a:t>One row that did not fit and should be said out loud: when you need to explain the decision to the person affected, none of today’s three will do it. A support vector machine in a lifted space has no explanation a customer would accept. Lesson 3’s Resources document covers why that is sometimes a legal requirement rather than a preference.</a:t>
+              <a:t>Everything in the lesson on the same 1,200 pumps, cross-validated the same way.</a:t>
+            </a:r>
+          </a:p>
+          <a:p>
+            <a:pPr lvl="0" indent="0" marL="0">
+              <a:buNone/>
+            </a:pPr>
+          </a:p>
+          <a:p>
+            <a:pPr lvl="0" indent="0" marL="0">
+              <a:buNone/>
+            </a:pPr>
+            <a:r>
+              <a:rPr/>
+              <a:t>Read the top three rows together: all exactly 0.613, and all three are linear. Then the bottom three, all near the ceiling, reached by three completely unrelated routes - remembering the neighbourhood, assuming independence, bending the space. There is no single idea shared between them.</a:t>
+            </a:r>
+          </a:p>
+          <a:p>
+            <a:pPr lvl="0" indent="0" marL="0">
+              <a:buNone/>
+            </a:pPr>
+          </a:p>
+          <a:p>
+            <a:pPr lvl="0" indent="0" marL="0">
+              <a:buNone/>
+            </a:pPr>
+            <a:r>
+              <a:rPr/>
+              <a:t>Then the number that is the lesson: the gap between best and worst is </a:t>
+            </a:r>
+            <a:r>
+              <a:rPr b="1"/>
+              <a:t>0.334</a:t>
+            </a:r>
+            <a:r>
+              <a:rPr/>
+              <a:t>. Larger than any difference this course has shown between a good model and a carefully tuned one - lesson 5’s entire hyperparameter search moved things by a few hundredths.</a:t>
+            </a:r>
+          </a:p>
+          <a:p>
+            <a:pPr lvl="0" indent="0" marL="0">
+              <a:buNone/>
+            </a:pPr>
+          </a:p>
+          <a:p>
+            <a:pPr lvl="0" indent="0" marL="0">
+              <a:buNone/>
+            </a:pPr>
+            <a:r>
+              <a:rPr/>
+              <a:t>Say the conclusion plainly, and it is the practical takeaway of the whole lesson: choosing the right family matters far more than tuning the wrong one. Nobody in the top three rows could have tuned their way out. And the way to tell which family you need is to look at the data first, which is what lesson 2 was for.</a:t>
             </a:r>
           </a:p>
         </p:txBody>
@@ -6264,49 +6265,35 @@
             </a:pPr>
             <a:r>
               <a:rPr/>
-              <a:t>Close on the number they opened the second segment with, and say it one more time: seventy per cent. In a hundred dimensions the nearest point in the entire dataset is seven tenths of the way to the farthest, and every method built on distance is operating on a quantity that has stopped varying.</a:t>
-            </a:r>
-          </a:p>
-          <a:p>
-            <a:pPr lvl="0" indent="0" marL="0">
-              <a:buNone/>
-            </a:pPr>
-          </a:p>
-          <a:p>
-            <a:pPr lvl="0" indent="0" marL="0">
-              <a:buNone/>
-            </a:pPr>
-            <a:r>
-              <a:rPr/>
-              <a:t>If they remember one habit from today, make it the diagnostic pair: before reaching for a model, look at the shape of the data; after fitting one, check whether the assumption it depends on is actually satisfied on your data. Two lines of code gave us the −0.006 that explained the 0.933.</a:t>
-            </a:r>
-          </a:p>
-          <a:p>
-            <a:pPr lvl="0" indent="0" marL="0">
-              <a:buNone/>
-            </a:pPr>
-          </a:p>
-          <a:p>
-            <a:pPr lvl="0" indent="0" marL="0">
-              <a:buNone/>
-            </a:pPr>
-            <a:r>
-              <a:rPr/>
-              <a:t>And the correction to the instinct that this lesson exists to install: more features is not free. It is nearly free for a linear model and it is expensive for anything built on a distance.</a:t>
-            </a:r>
-          </a:p>
-          <a:p>
-            <a:pPr lvl="0" indent="0" marL="0">
-              <a:buNone/>
-            </a:pPr>
-          </a:p>
-          <a:p>
-            <a:pPr lvl="0" indent="0" marL="0">
-              <a:buNone/>
-            </a:pPr>
-            <a:r>
-              <a:rPr/>
-              <a:t>Handout section 7 lists all of this with the section numbers.</a:t>
+              <a:t>A table to photograph. Work down it and attach today’s evidence to each row, so it is remembered as a set of conclusions rather than as advice.</a:t>
+            </a:r>
+          </a:p>
+          <a:p>
+            <a:pPr lvl="0" indent="0" marL="0">
+              <a:buNone/>
+            </a:pPr>
+          </a:p>
+          <a:p>
+            <a:pPr lvl="0" indent="0" marL="0">
+              <a:buNone/>
+            </a:pPr>
+            <a:r>
+              <a:rPr/>
+              <a:t>Row two deserves a sentence on its own, because it is the one that sounds wrong after the last hour. Text classification is the canonical case: tens of thousands of word-count features, an assumption that is transparently false, and a method that works anyway - because being roughly right in ten thousand dimensions beats being unable to estimate anything at all. Also mention Naive Bayes as a baseline: it trains in one pass, so if your tuned model does not beat it you have learned something quickly and cheaply.</a:t>
+            </a:r>
+          </a:p>
+          <a:p>
+            <a:pPr lvl="0" indent="0" marL="0">
+              <a:buNone/>
+            </a:pPr>
+          </a:p>
+          <a:p>
+            <a:pPr lvl="0" indent="0" marL="0">
+              <a:buNone/>
+            </a:pPr>
+            <a:r>
+              <a:rPr/>
+              <a:t>One row that did not fit and should be said out loud: when you need to explain the decision to the person affected, none of today’s three will do it. A support vector machine in a lifted space has no explanation a customer would accept. Lesson 3’s Resources document covers why that is sometimes a legal requirement rather than a preference.</a:t>
             </a:r>
           </a:p>
         </p:txBody>
@@ -6388,49 +6375,49 @@
             </a:pPr>
             <a:r>
               <a:rPr/>
-              <a:t>Set it explicitly and say out loud when it comes back: the first ten minutes of next Friday, 13 November.</a:t>
-            </a:r>
-          </a:p>
-          <a:p>
-            <a:pPr lvl="0" indent="0" marL="0">
-              <a:buNone/>
-            </a:pPr>
-          </a:p>
-          <a:p>
-            <a:pPr lvl="0" indent="0" marL="0">
-              <a:buNone/>
-            </a:pPr>
-            <a:r>
-              <a:rPr/>
-              <a:t>The marks are for the reasoning, not for the accuracy. A well-argued choice that scores slightly worse beats a lucky winner with no justification - and the argument has to reference the data, in the way that the −0.006 justified Naive Bayes on the pumps this afternoon.</a:t>
-            </a:r>
-          </a:p>
-          <a:p>
-            <a:pPr lvl="0" indent="0" marL="0">
-              <a:buNone/>
-            </a:pPr>
-          </a:p>
-          <a:p>
-            <a:pPr lvl="0" indent="0" marL="0">
-              <a:buNone/>
-            </a:pPr>
-            <a:r>
-              <a:rPr/>
-              <a:t>Remind them that everything must be cross-validated and reported with a spread, in the format lesson 5 set. Scaling goes inside the pipeline; that will be checked.</a:t>
-            </a:r>
-          </a:p>
-          <a:p>
-            <a:pPr lvl="0" indent="0" marL="0">
-              <a:buNone/>
-            </a:pPr>
-          </a:p>
-          <a:p>
-            <a:pPr lvl="0" indent="0" marL="0">
-              <a:buNone/>
-            </a:pPr>
-            <a:r>
-              <a:rPr/>
-              <a:t>Next week: decision trees and ensembles. A fourth family, with a different answer again to the same question - how do you draw a boundary that is not a line.</a:t>
+              <a:t>Close on the number they opened the second segment with, and say it one more time: seventy per cent. In a hundred dimensions the nearest point in the entire dataset is seven tenths of the way to the farthest, and every method built on distance is operating on a quantity that has stopped varying.</a:t>
+            </a:r>
+          </a:p>
+          <a:p>
+            <a:pPr lvl="0" indent="0" marL="0">
+              <a:buNone/>
+            </a:pPr>
+          </a:p>
+          <a:p>
+            <a:pPr lvl="0" indent="0" marL="0">
+              <a:buNone/>
+            </a:pPr>
+            <a:r>
+              <a:rPr/>
+              <a:t>If they remember one habit from today, make it the diagnostic pair: before reaching for a model, look at the shape of the data; after fitting one, check whether the assumption it depends on is actually satisfied on your data. Two lines of code gave us the −0.006 that explained the 0.933.</a:t>
+            </a:r>
+          </a:p>
+          <a:p>
+            <a:pPr lvl="0" indent="0" marL="0">
+              <a:buNone/>
+            </a:pPr>
+          </a:p>
+          <a:p>
+            <a:pPr lvl="0" indent="0" marL="0">
+              <a:buNone/>
+            </a:pPr>
+            <a:r>
+              <a:rPr/>
+              <a:t>And the correction to the instinct that this lesson exists to install: more features is not free. It is nearly free for a linear model and it is expensive for anything built on a distance.</a:t>
+            </a:r>
+          </a:p>
+          <a:p>
+            <a:pPr lvl="0" indent="0" marL="0">
+              <a:buNone/>
+            </a:pPr>
+          </a:p>
+          <a:p>
+            <a:pPr lvl="0" indent="0" marL="0">
+              <a:buNone/>
+            </a:pPr>
+            <a:r>
+              <a:rPr/>
+              <a:t>Handout section 7 lists all of this with the section numbers.</a:t>
             </a:r>
           </a:p>
         </p:txBody>
@@ -6453,6 +6440,130 @@
             <a:fld id="{18BDFEC3-8487-43E8-A154-7C12CBC1FFF2}" type="slidenum">
               <a:rPr lang="en-US"/>
               <a:t>53</a:t>
+            </a:fld>
+            <a:endParaRPr lang="en-US"/>
+          </a:p>
+        </p:txBody>
+      </p:sp>
+    </p:spTree>
+  </p:cSld>
+</p:notes>
+</file>
+
+<file path=ppt/notesSlides/notesSlide53.xml><?xml version="1.0" encoding="utf-8"?>
+<p:notes xmlns:a="http://schemas.openxmlformats.org/drawingml/2006/main" xmlns:r="http://schemas.openxmlformats.org/officeDocument/2006/relationships" xmlns:p="http://schemas.openxmlformats.org/presentationml/2006/main">
+  <p:cSld>
+    <p:spTree>
+      <p:nvGrpSpPr>
+        <p:cNvPr id="1" name=""/>
+        <p:cNvGrpSpPr/>
+        <p:nvPr/>
+      </p:nvGrpSpPr>
+      <p:grpSpPr>
+        <a:xfrm>
+          <a:off x="0" y="0"/>
+          <a:ext cx="0" cy="0"/>
+          <a:chOff x="0" y="0"/>
+          <a:chExt cx="0" cy="0"/>
+        </a:xfrm>
+      </p:grpSpPr>
+      <p:sp>
+        <p:nvSpPr>
+          <p:cNvPr id="2" name="Slide Image Placeholder 1"/>
+          <p:cNvSpPr>
+            <a:spLocks noGrp="1" noRot="1" noChangeAspect="1"/>
+          </p:cNvSpPr>
+          <p:nvPr>
+            <p:ph type="sldImg"/>
+          </p:nvPr>
+        </p:nvSpPr>
+        <p:spPr/>
+      </p:sp>
+      <p:sp>
+        <p:nvSpPr>
+          <p:cNvPr id="3" name="Notes Placeholder 2"/>
+          <p:cNvSpPr>
+            <a:spLocks noGrp="1"/>
+          </p:cNvSpPr>
+          <p:nvPr>
+            <p:ph type="body" idx="1"/>
+          </p:nvPr>
+        </p:nvSpPr>
+        <p:spPr/>
+        <p:txBody>
+          <a:bodyPr/>
+          <a:lstStyle/>
+          <a:p>
+            <a:pPr lvl="0" indent="0" marL="0">
+              <a:buNone/>
+            </a:pPr>
+            <a:r>
+              <a:rPr/>
+              <a:t>Set it explicitly and say out loud when it comes back: the first ten minutes of next Friday, 13 November.</a:t>
+            </a:r>
+          </a:p>
+          <a:p>
+            <a:pPr lvl="0" indent="0" marL="0">
+              <a:buNone/>
+            </a:pPr>
+          </a:p>
+          <a:p>
+            <a:pPr lvl="0" indent="0" marL="0">
+              <a:buNone/>
+            </a:pPr>
+            <a:r>
+              <a:rPr/>
+              <a:t>The marks are for the reasoning, not for the accuracy. A well-argued choice that scores slightly worse beats a lucky winner with no justification - and the argument has to reference the data, in the way that the −0.006 justified Naive Bayes on the pumps this afternoon.</a:t>
+            </a:r>
+          </a:p>
+          <a:p>
+            <a:pPr lvl="0" indent="0" marL="0">
+              <a:buNone/>
+            </a:pPr>
+          </a:p>
+          <a:p>
+            <a:pPr lvl="0" indent="0" marL="0">
+              <a:buNone/>
+            </a:pPr>
+            <a:r>
+              <a:rPr/>
+              <a:t>Remind them that everything must be cross-validated and reported with a spread, in the format lesson 5 set. Scaling goes inside the pipeline; that will be checked.</a:t>
+            </a:r>
+          </a:p>
+          <a:p>
+            <a:pPr lvl="0" indent="0" marL="0">
+              <a:buNone/>
+            </a:pPr>
+          </a:p>
+          <a:p>
+            <a:pPr lvl="0" indent="0" marL="0">
+              <a:buNone/>
+            </a:pPr>
+            <a:r>
+              <a:rPr/>
+              <a:t>Next week: decision trees and ensembles. A fourth family, with a different answer again to the same question - how do you draw a boundary that is not a line.</a:t>
+            </a:r>
+          </a:p>
+        </p:txBody>
+      </p:sp>
+      <p:sp>
+        <p:nvSpPr>
+          <p:cNvPr id="4" name="Slide Number Placeholder 3"/>
+          <p:cNvSpPr>
+            <a:spLocks noGrp="1"/>
+          </p:cNvSpPr>
+          <p:nvPr>
+            <p:ph type="sldNum" sz="quarter" idx="10"/>
+          </p:nvPr>
+        </p:nvSpPr>
+        <p:spPr/>
+        <p:txBody>
+          <a:bodyPr/>
+          <a:lstStyle/>
+          <a:p>
+            <a:fld id="{18BDFEC3-8487-43E8-A154-7C12CBC1FFF2}" type="slidenum">
+              <a:rPr lang="en-US"/>
+              <a:t>54</a:t>
             </a:fld>
             <a:endParaRPr lang="en-US"/>
           </a:p>
@@ -12498,6 +12609,88 @@
             </a:pPr>
             <a:r>
               <a:rPr/>
+              <a:t>The decision drops the denominator</a:t>
+            </a:r>
+          </a:p>
+        </p:txBody>
+      </p:sp>
+      <p:pic>
+        <p:nvPicPr>
+          <p:cNvPr descr="eq_1286136c78.png" id="0" name="Picture 1"/>
+          <p:cNvPicPr>
+            <a:picLocks noGrp="1" noChangeAspect="1"/>
+          </p:cNvPicPr>
+          <p:nvPr/>
+        </p:nvPicPr>
+        <p:blipFill>
+          <a:blip r:embed="rId3"/>
+          <a:stretch>
+            <a:fillRect/>
+          </a:stretch>
+        </p:blipFill>
+        <p:spPr bwMode="auto">
+          <a:xfrm>
+            <a:off x="457200" y="2509639"/>
+            <a:ext cx="8229600" cy="673100"/>
+          </a:xfrm>
+          <a:prstGeom prst="rect">
+            <a:avLst/>
+          </a:prstGeom>
+          <a:noFill/>
+          <a:ln w="9525">
+            <a:noFill/>
+            <a:headEnd/>
+            <a:tailEnd/>
+          </a:ln>
+        </p:spPr>
+      </p:pic>
+    </p:spTree>
+  </p:cSld>
+</p:sld>
+</file>
+
+<file path=ppt/slides/slide27.xml><?xml version="1.0" encoding="utf-8"?>
+<p:sld xmlns:a="http://schemas.openxmlformats.org/drawingml/2006/main" xmlns:r="http://schemas.openxmlformats.org/officeDocument/2006/relationships" xmlns:p="http://schemas.openxmlformats.org/presentationml/2006/main">
+  <p:cSld>
+    <p:spTree>
+      <p:nvGrpSpPr>
+        <p:cNvPr id="1" name=""/>
+        <p:cNvGrpSpPr/>
+        <p:nvPr/>
+      </p:nvGrpSpPr>
+      <p:grpSpPr>
+        <a:xfrm>
+          <a:off x="0" y="0"/>
+          <a:ext cx="0" cy="0"/>
+          <a:chOff x="0" y="0"/>
+          <a:chExt cx="0" cy="0"/>
+        </a:xfrm>
+      </p:grpSpPr>
+      <p:sp>
+        <p:nvSpPr>
+          <p:cNvPr id="2" name="Title 1"/>
+          <p:cNvSpPr>
+            <a:spLocks noGrp="1"/>
+          </p:cNvSpPr>
+          <p:nvPr>
+            <p:ph type="title"/>
+          </p:nvPr>
+        </p:nvSpPr>
+        <p:spPr>
+          <a:xfrm>
+            <a:off x="457200" y="205979"/>
+            <a:ext cx="8229600" cy="857250"/>
+          </a:xfrm>
+        </p:spPr>
+        <p:txBody>
+          <a:bodyPr/>
+          <a:lstStyle/>
+          <a:p>
+            <a:pPr lvl="0" indent="0" marL="0">
+              <a:buNone/>
+            </a:pPr>
+            <a:r>
+              <a:rPr/>
               <a:t>The assumption: independent, given the class</a:t>
             </a:r>
           </a:p>
@@ -12550,7 +12743,7 @@
 </p:sld>
 </file>
 
-<file path=ppt/slides/slide27.xml><?xml version="1.0" encoding="utf-8"?>
+<file path=ppt/slides/slide28.xml><?xml version="1.0" encoding="utf-8"?>
 <p:sld xmlns:a="http://schemas.openxmlformats.org/drawingml/2006/main" xmlns:r="http://schemas.openxmlformats.org/officeDocument/2006/relationships" xmlns:p="http://schemas.openxmlformats.org/presentationml/2006/main">
   <p:cSld>
     <p:spTree>
@@ -12632,7 +12825,7 @@
 </p:sld>
 </file>
 
-<file path=ppt/slides/slide28.xml><?xml version="1.0" encoding="utf-8"?>
+<file path=ppt/slides/slide29.xml><?xml version="1.0" encoding="utf-8"?>
 <p:sld xmlns:a="http://schemas.openxmlformats.org/drawingml/2006/main" xmlns:r="http://schemas.openxmlformats.org/officeDocument/2006/relationships" xmlns:p="http://schemas.openxmlformats.org/presentationml/2006/main">
   <p:cSld>
     <p:spTree>
@@ -12745,7 +12938,135 @@
 </p:sld>
 </file>
 
-<file path=ppt/slides/slide29.xml><?xml version="1.0" encoding="utf-8"?>
+<file path=ppt/slides/slide3.xml><?xml version="1.0" encoding="utf-8"?>
+<p:sld xmlns:a="http://schemas.openxmlformats.org/drawingml/2006/main" xmlns:r="http://schemas.openxmlformats.org/officeDocument/2006/relationships" xmlns:p="http://schemas.openxmlformats.org/presentationml/2006/main">
+  <p:cSld>
+    <p:spTree>
+      <p:nvGrpSpPr>
+        <p:cNvPr id="1" name=""/>
+        <p:cNvGrpSpPr/>
+        <p:nvPr/>
+      </p:nvGrpSpPr>
+      <p:grpSpPr>
+        <a:xfrm>
+          <a:off x="0" y="0"/>
+          <a:ext cx="0" cy="0"/>
+          <a:chOff x="0" y="0"/>
+          <a:chExt cx="0" cy="0"/>
+        </a:xfrm>
+      </p:grpSpPr>
+      <p:sp>
+        <p:nvSpPr>
+          <p:cNvPr id="2" name="Title 1"/>
+          <p:cNvSpPr>
+            <a:spLocks noGrp="1"/>
+          </p:cNvSpPr>
+          <p:nvPr>
+            <p:ph type="title"/>
+          </p:nvPr>
+        </p:nvSpPr>
+        <p:spPr>
+          <a:xfrm>
+            <a:off x="457200" y="205979"/>
+            <a:ext cx="8229600" cy="857250"/>
+          </a:xfrm>
+        </p:spPr>
+        <p:txBody>
+          <a:bodyPr/>
+          <a:lstStyle/>
+          <a:p>
+            <a:pPr lvl="0" indent="0" marL="0">
+              <a:buNone/>
+            </a:pPr>
+            <a:r>
+              <a:rPr/>
+              <a:t>Today: the first lesson that offers a choice</a:t>
+            </a:r>
+          </a:p>
+        </p:txBody>
+      </p:sp>
+      <p:sp>
+        <p:nvSpPr>
+          <p:cNvPr id="3" name="Content Placeholder 2"/>
+          <p:cNvSpPr>
+            <a:spLocks noGrp="1"/>
+          </p:cNvSpPr>
+          <p:nvPr>
+            <p:ph idx="1"/>
+          </p:nvPr>
+        </p:nvSpPr>
+        <p:spPr>
+          <a:xfrm>
+            <a:off x="457200" y="1200151"/>
+            <a:ext cx="8229600" cy="3394472"/>
+          </a:xfrm>
+        </p:spPr>
+        <p:txBody>
+          <a:bodyPr/>
+          <a:lstStyle/>
+          <a:p>
+            <a:pPr lvl="0"/>
+            <a:r>
+              <a:rPr b="1"/>
+              <a:t>k-nearest neighbours (k-NN)</a:t>
+            </a:r>
+            <a:r>
+              <a:rPr/>
+              <a:t>: remember, and vote</a:t>
+            </a:r>
+          </a:p>
+          <a:p>
+            <a:pPr lvl="0"/>
+            <a:r>
+              <a:rPr/>
+              <a:t>The </a:t>
+            </a:r>
+            <a:r>
+              <a:rPr b="1"/>
+              <a:t>curse of dimensionality</a:t>
+            </a:r>
+            <a:r>
+              <a:rPr/>
+              <a:t>: the bill for that</a:t>
+            </a:r>
+          </a:p>
+          <a:p>
+            <a:pPr lvl="0"/>
+            <a:r>
+              <a:rPr b="1"/>
+              <a:t>Naive Bayes</a:t>
+            </a:r>
+            <a:r>
+              <a:rPr/>
+              <a:t>: one strong assumption, bought cheap</a:t>
+            </a:r>
+          </a:p>
+          <a:p>
+            <a:pPr lvl="0"/>
+            <a:r>
+              <a:rPr b="1"/>
+              <a:t>Support vector machines (SVM)</a:t>
+            </a:r>
+            <a:r>
+              <a:rPr/>
+              <a:t>: margins, and kernels</a:t>
+            </a:r>
+          </a:p>
+          <a:p>
+            <a:pPr lvl="0"/>
+            <a:r>
+              <a:rPr/>
+              <a:t>Which family to reach for, and why that beats tuning</a:t>
+            </a:r>
+          </a:p>
+        </p:txBody>
+      </p:sp>
+    </p:spTree>
+  </p:cSld>
+</p:sld>
+</file>
+
+<file path=ppt/slides/slide30.xml><?xml version="1.0" encoding="utf-8"?>
 <p:sld xmlns:a="http://schemas.openxmlformats.org/drawingml/2006/main" xmlns:r="http://schemas.openxmlformats.org/officeDocument/2006/relationships" xmlns:p="http://schemas.openxmlformats.org/presentationml/2006/main">
   <p:cSld>
     <p:spTree>
@@ -12987,135 +13308,7 @@
 </p:sld>
 </file>
 
-<file path=ppt/slides/slide3.xml><?xml version="1.0" encoding="utf-8"?>
-<p:sld xmlns:a="http://schemas.openxmlformats.org/drawingml/2006/main" xmlns:r="http://schemas.openxmlformats.org/officeDocument/2006/relationships" xmlns:p="http://schemas.openxmlformats.org/presentationml/2006/main">
-  <p:cSld>
-    <p:spTree>
-      <p:nvGrpSpPr>
-        <p:cNvPr id="1" name=""/>
-        <p:cNvGrpSpPr/>
-        <p:nvPr/>
-      </p:nvGrpSpPr>
-      <p:grpSpPr>
-        <a:xfrm>
-          <a:off x="0" y="0"/>
-          <a:ext cx="0" cy="0"/>
-          <a:chOff x="0" y="0"/>
-          <a:chExt cx="0" cy="0"/>
-        </a:xfrm>
-      </p:grpSpPr>
-      <p:sp>
-        <p:nvSpPr>
-          <p:cNvPr id="2" name="Title 1"/>
-          <p:cNvSpPr>
-            <a:spLocks noGrp="1"/>
-          </p:cNvSpPr>
-          <p:nvPr>
-            <p:ph type="title"/>
-          </p:nvPr>
-        </p:nvSpPr>
-        <p:spPr>
-          <a:xfrm>
-            <a:off x="457200" y="205979"/>
-            <a:ext cx="8229600" cy="857250"/>
-          </a:xfrm>
-        </p:spPr>
-        <p:txBody>
-          <a:bodyPr/>
-          <a:lstStyle/>
-          <a:p>
-            <a:pPr lvl="0" indent="0" marL="0">
-              <a:buNone/>
-            </a:pPr>
-            <a:r>
-              <a:rPr/>
-              <a:t>Today: the first lesson that offers a choice</a:t>
-            </a:r>
-          </a:p>
-        </p:txBody>
-      </p:sp>
-      <p:sp>
-        <p:nvSpPr>
-          <p:cNvPr id="3" name="Content Placeholder 2"/>
-          <p:cNvSpPr>
-            <a:spLocks noGrp="1"/>
-          </p:cNvSpPr>
-          <p:nvPr>
-            <p:ph idx="1"/>
-          </p:nvPr>
-        </p:nvSpPr>
-        <p:spPr>
-          <a:xfrm>
-            <a:off x="457200" y="1200151"/>
-            <a:ext cx="8229600" cy="3394472"/>
-          </a:xfrm>
-        </p:spPr>
-        <p:txBody>
-          <a:bodyPr/>
-          <a:lstStyle/>
-          <a:p>
-            <a:pPr lvl="0"/>
-            <a:r>
-              <a:rPr b="1"/>
-              <a:t>k-nearest neighbours (k-NN)</a:t>
-            </a:r>
-            <a:r>
-              <a:rPr/>
-              <a:t>: remember, and vote</a:t>
-            </a:r>
-          </a:p>
-          <a:p>
-            <a:pPr lvl="0"/>
-            <a:r>
-              <a:rPr/>
-              <a:t>The </a:t>
-            </a:r>
-            <a:r>
-              <a:rPr b="1"/>
-              <a:t>curse of dimensionality</a:t>
-            </a:r>
-            <a:r>
-              <a:rPr/>
-              <a:t>: the bill for that</a:t>
-            </a:r>
-          </a:p>
-          <a:p>
-            <a:pPr lvl="0"/>
-            <a:r>
-              <a:rPr b="1"/>
-              <a:t>Naive Bayes</a:t>
-            </a:r>
-            <a:r>
-              <a:rPr/>
-              <a:t>: one strong assumption, bought cheap</a:t>
-            </a:r>
-          </a:p>
-          <a:p>
-            <a:pPr lvl="0"/>
-            <a:r>
-              <a:rPr b="1"/>
-              <a:t>Support vector machines (SVM)</a:t>
-            </a:r>
-            <a:r>
-              <a:rPr/>
-              <a:t>: margins, and kernels</a:t>
-            </a:r>
-          </a:p>
-          <a:p>
-            <a:pPr lvl="0"/>
-            <a:r>
-              <a:rPr/>
-              <a:t>Which family to reach for, and why that beats tuning</a:t>
-            </a:r>
-          </a:p>
-        </p:txBody>
-      </p:sp>
-    </p:spTree>
-  </p:cSld>
-</p:sld>
-</file>
-
-<file path=ppt/slides/slide30.xml><?xml version="1.0" encoding="utf-8"?>
+<file path=ppt/slides/slide31.xml><?xml version="1.0" encoding="utf-8"?>
 <p:sld xmlns:a="http://schemas.openxmlformats.org/drawingml/2006/main" xmlns:r="http://schemas.openxmlformats.org/officeDocument/2006/relationships" xmlns:p="http://schemas.openxmlformats.org/presentationml/2006/main">
   <p:cSld>
     <p:spTree>
@@ -13325,7 +13518,7 @@
 </p:sld>
 </file>
 
-<file path=ppt/slides/slide31.xml><?xml version="1.0" encoding="utf-8"?>
+<file path=ppt/slides/slide32.xml><?xml version="1.0" encoding="utf-8"?>
 <p:sld xmlns:a="http://schemas.openxmlformats.org/drawingml/2006/main" xmlns:r="http://schemas.openxmlformats.org/officeDocument/2006/relationships" xmlns:p="http://schemas.openxmlformats.org/presentationml/2006/main">
   <p:cSld>
     <p:spTree>
@@ -13427,7 +13620,7 @@
 </p:sld>
 </file>
 
-<file path=ppt/slides/slide32.xml><?xml version="1.0" encoding="utf-8"?>
+<file path=ppt/slides/slide33.xml><?xml version="1.0" encoding="utf-8"?>
 <p:sld xmlns:a="http://schemas.openxmlformats.org/drawingml/2006/main" xmlns:r="http://schemas.openxmlformats.org/officeDocument/2006/relationships" xmlns:p="http://schemas.openxmlformats.org/presentationml/2006/main">
   <p:cSld>
     <p:spTree>
@@ -13509,7 +13702,7 @@
 </p:sld>
 </file>
 
-<file path=ppt/slides/slide33.xml><?xml version="1.0" encoding="utf-8"?>
+<file path=ppt/slides/slide34.xml><?xml version="1.0" encoding="utf-8"?>
 <p:sld xmlns:a="http://schemas.openxmlformats.org/drawingml/2006/main" xmlns:r="http://schemas.openxmlformats.org/officeDocument/2006/relationships" xmlns:p="http://schemas.openxmlformats.org/presentationml/2006/main">
   <p:cSld>
     <p:spTree>
@@ -13815,119 +14008,6 @@
 </p:sld>
 </file>
 
-<file path=ppt/slides/slide34.xml><?xml version="1.0" encoding="utf-8"?>
-<p:sld xmlns:a="http://schemas.openxmlformats.org/drawingml/2006/main" xmlns:r="http://schemas.openxmlformats.org/officeDocument/2006/relationships" xmlns:p="http://schemas.openxmlformats.org/presentationml/2006/main">
-  <p:cSld>
-    <p:spTree>
-      <p:nvGrpSpPr>
-        <p:cNvPr id="1" name=""/>
-        <p:cNvGrpSpPr/>
-        <p:nvPr/>
-      </p:nvGrpSpPr>
-      <p:grpSpPr>
-        <a:xfrm>
-          <a:off x="0" y="0"/>
-          <a:ext cx="0" cy="0"/>
-          <a:chOff x="0" y="0"/>
-          <a:chExt cx="0" cy="0"/>
-        </a:xfrm>
-      </p:grpSpPr>
-      <p:sp>
-        <p:nvSpPr>
-          <p:cNvPr id="2" name="Title 1"/>
-          <p:cNvSpPr>
-            <a:spLocks noGrp="1"/>
-          </p:cNvSpPr>
-          <p:nvPr>
-            <p:ph type="title"/>
-          </p:nvPr>
-        </p:nvSpPr>
-        <p:spPr>
-          <a:xfrm>
-            <a:off x="457200" y="205979"/>
-            <a:ext cx="8229600" cy="857250"/>
-          </a:xfrm>
-        </p:spPr>
-        <p:txBody>
-          <a:bodyPr/>
-          <a:lstStyle/>
-          <a:p>
-            <a:pPr lvl="0" indent="0" marL="0">
-              <a:buNone/>
-            </a:pPr>
-            <a:r>
-              <a:rPr/>
-              <a:t>Its probabilities are not probabilities</a:t>
-            </a:r>
-          </a:p>
-        </p:txBody>
-      </p:sp>
-      <p:sp>
-        <p:nvSpPr>
-          <p:cNvPr id="3" name="Content Placeholder 2"/>
-          <p:cNvSpPr>
-            <a:spLocks noGrp="1"/>
-          </p:cNvSpPr>
-          <p:nvPr>
-            <p:ph idx="1"/>
-          </p:nvPr>
-        </p:nvSpPr>
-        <p:spPr>
-          <a:xfrm>
-            <a:off x="457200" y="1200151"/>
-            <a:ext cx="8229600" cy="3394472"/>
-          </a:xfrm>
-        </p:spPr>
-        <p:txBody>
-          <a:bodyPr/>
-          <a:lstStyle/>
-          <a:p>
-            <a:pPr lvl="0"/>
-            <a:r>
-              <a:rPr/>
-              <a:t>Mean confidence when </a:t>
-            </a:r>
-            <a:r>
-              <a:rPr b="1"/>
-              <a:t>correct: 0.567</a:t>
-            </a:r>
-            <a:r>
-              <a:rPr/>
-              <a:t>. When </a:t>
-            </a:r>
-            <a:r>
-              <a:rPr b="1"/>
-              <a:t>wrong: 0.555</a:t>
-            </a:r>
-          </a:p>
-          <a:p>
-            <a:pPr lvl="0"/>
-            <a:r>
-              <a:rPr/>
-              <a:t>It cannot tell the difference between the two situations</a:t>
-            </a:r>
-          </a:p>
-          <a:p>
-            <a:pPr lvl="0"/>
-            <a:r>
-              <a:rPr/>
-              <a:t>With correlated features it fails the other way: 0.999 reported, with an accuracy nothing like that</a:t>
-            </a:r>
-          </a:p>
-          <a:p>
-            <a:pPr lvl="0"/>
-            <a:r>
-              <a:rPr b="1"/>
-              <a:t>The ranking may be useful while the probabilities are not</a:t>
-            </a:r>
-          </a:p>
-        </p:txBody>
-      </p:sp>
-    </p:spTree>
-  </p:cSld>
-</p:sld>
-</file>
-
 <file path=ppt/slides/slide35.xml><?xml version="1.0" encoding="utf-8"?>
 <p:sld xmlns:a="http://schemas.openxmlformats.org/drawingml/2006/main" xmlns:r="http://schemas.openxmlformats.org/officeDocument/2006/relationships" xmlns:p="http://schemas.openxmlformats.org/presentationml/2006/main">
   <p:cSld>
@@ -13970,7 +14050,7 @@
             </a:pPr>
             <a:r>
               <a:rPr/>
-              <a:t>Notebook 2, live</a:t>
+              <a:t>Its probabilities are not probabilities</a:t>
             </a:r>
           </a:p>
         </p:txBody>
@@ -13998,7 +14078,40 @@
             <a:pPr lvl="0"/>
             <a:r>
               <a:rPr/>
-              <a:t>Where the assumption holds, and one step away where it does not</a:t>
+              <a:t>Mean confidence when </a:t>
+            </a:r>
+            <a:r>
+              <a:rPr b="1"/>
+              <a:t>correct: 0.567</a:t>
+            </a:r>
+            <a:r>
+              <a:rPr/>
+              <a:t>. When </a:t>
+            </a:r>
+            <a:r>
+              <a:rPr b="1"/>
+              <a:t>wrong: 0.555</a:t>
+            </a:r>
+          </a:p>
+          <a:p>
+            <a:pPr lvl="0"/>
+            <a:r>
+              <a:rPr/>
+              <a:t>It cannot tell the difference between the two situations</a:t>
+            </a:r>
+          </a:p>
+          <a:p>
+            <a:pPr lvl="0"/>
+            <a:r>
+              <a:rPr/>
+              <a:t>With correlated features it fails the other way: 0.999 reported, with an accuracy nothing like that</a:t>
+            </a:r>
+          </a:p>
+          <a:p>
+            <a:pPr lvl="0"/>
+            <a:r>
+              <a:rPr b="1"/>
+              <a:t>The ranking may be useful while the probabilities are not</a:t>
             </a:r>
           </a:p>
         </p:txBody>
@@ -14050,7 +14163,7 @@
             </a:pPr>
             <a:r>
               <a:rPr/>
-              <a:t>The margin: a criterion that is not the error</a:t>
+              <a:t>Notebook 2, live</a:t>
             </a:r>
           </a:p>
         </p:txBody>
@@ -14078,48 +14191,7 @@
             <a:pPr lvl="0"/>
             <a:r>
               <a:rPr/>
-              <a:t>On separable data there are </a:t>
-            </a:r>
-            <a:r>
-              <a:rPr b="1"/>
-              <a:t>infinitely many</a:t>
-            </a:r>
-            <a:r>
-              <a:rPr/>
-              <a:t> separating lines, and every one has </a:t>
-            </a:r>
-            <a:r>
-              <a:rPr b="1"/>
-              <a:t>zero training error</a:t>
-            </a:r>
-          </a:p>
-          <a:p>
-            <a:pPr lvl="0"/>
-            <a:r>
-              <a:rPr/>
-              <a:t>Minimising the error therefore cannot choose between them</a:t>
-            </a:r>
-          </a:p>
-          <a:p>
-            <a:pPr lvl="0"/>
-            <a:r>
-              <a:rPr/>
-              <a:t>The SVM picks the widest </a:t>
-            </a:r>
-            <a:r>
-              <a:rPr b="1"/>
-              <a:t>slab</a:t>
-            </a:r>
-            <a:r>
-              <a:rPr/>
-              <a:t>: push it out until it touches the nearest point of each class</a:t>
-            </a:r>
-          </a:p>
-          <a:p>
-            <a:pPr lvl="0"/>
-            <a:r>
-              <a:rPr/>
-              <a:t>A boundary passing close to a point is one small perturbation from getting it wrong</a:t>
+              <a:t>Where the assumption holds, and one step away where it does not</a:t>
             </a:r>
           </a:p>
         </p:txBody>
@@ -14130,6 +14202,127 @@
 </file>
 
 <file path=ppt/slides/slide37.xml><?xml version="1.0" encoding="utf-8"?>
+<p:sld xmlns:a="http://schemas.openxmlformats.org/drawingml/2006/main" xmlns:r="http://schemas.openxmlformats.org/officeDocument/2006/relationships" xmlns:p="http://schemas.openxmlformats.org/presentationml/2006/main">
+  <p:cSld>
+    <p:spTree>
+      <p:nvGrpSpPr>
+        <p:cNvPr id="1" name=""/>
+        <p:cNvGrpSpPr/>
+        <p:nvPr/>
+      </p:nvGrpSpPr>
+      <p:grpSpPr>
+        <a:xfrm>
+          <a:off x="0" y="0"/>
+          <a:ext cx="0" cy="0"/>
+          <a:chOff x="0" y="0"/>
+          <a:chExt cx="0" cy="0"/>
+        </a:xfrm>
+      </p:grpSpPr>
+      <p:sp>
+        <p:nvSpPr>
+          <p:cNvPr id="2" name="Title 1"/>
+          <p:cNvSpPr>
+            <a:spLocks noGrp="1"/>
+          </p:cNvSpPr>
+          <p:nvPr>
+            <p:ph type="title"/>
+          </p:nvPr>
+        </p:nvSpPr>
+        <p:spPr>
+          <a:xfrm>
+            <a:off x="457200" y="205979"/>
+            <a:ext cx="8229600" cy="857250"/>
+          </a:xfrm>
+        </p:spPr>
+        <p:txBody>
+          <a:bodyPr/>
+          <a:lstStyle/>
+          <a:p>
+            <a:pPr lvl="0" indent="0" marL="0">
+              <a:buNone/>
+            </a:pPr>
+            <a:r>
+              <a:rPr/>
+              <a:t>The margin: a criterion that is not the error</a:t>
+            </a:r>
+          </a:p>
+        </p:txBody>
+      </p:sp>
+      <p:sp>
+        <p:nvSpPr>
+          <p:cNvPr id="3" name="Content Placeholder 2"/>
+          <p:cNvSpPr>
+            <a:spLocks noGrp="1"/>
+          </p:cNvSpPr>
+          <p:nvPr>
+            <p:ph idx="1"/>
+          </p:nvPr>
+        </p:nvSpPr>
+        <p:spPr>
+          <a:xfrm>
+            <a:off x="457200" y="1200151"/>
+            <a:ext cx="8229600" cy="3394472"/>
+          </a:xfrm>
+        </p:spPr>
+        <p:txBody>
+          <a:bodyPr/>
+          <a:lstStyle/>
+          <a:p>
+            <a:pPr lvl="0"/>
+            <a:r>
+              <a:rPr/>
+              <a:t>On separable data there are </a:t>
+            </a:r>
+            <a:r>
+              <a:rPr b="1"/>
+              <a:t>infinitely many</a:t>
+            </a:r>
+            <a:r>
+              <a:rPr/>
+              <a:t> separating lines, and every one has </a:t>
+            </a:r>
+            <a:r>
+              <a:rPr b="1"/>
+              <a:t>zero training error</a:t>
+            </a:r>
+          </a:p>
+          <a:p>
+            <a:pPr lvl="0"/>
+            <a:r>
+              <a:rPr/>
+              <a:t>Minimising the error therefore cannot choose between them</a:t>
+            </a:r>
+          </a:p>
+          <a:p>
+            <a:pPr lvl="0"/>
+            <a:r>
+              <a:rPr/>
+              <a:t>The SVM picks the widest </a:t>
+            </a:r>
+            <a:r>
+              <a:rPr b="1"/>
+              <a:t>slab</a:t>
+            </a:r>
+            <a:r>
+              <a:rPr/>
+              <a:t>: push it out until it touches the nearest point of each class</a:t>
+            </a:r>
+          </a:p>
+          <a:p>
+            <a:pPr lvl="0"/>
+            <a:r>
+              <a:rPr/>
+              <a:t>A boundary passing close to a point is one small perturbation from getting it wrong</a:t>
+            </a:r>
+          </a:p>
+        </p:txBody>
+      </p:sp>
+    </p:spTree>
+  </p:cSld>
+</p:sld>
+</file>
+
+<file path=ppt/slides/slide38.xml><?xml version="1.0" encoding="utf-8"?>
 <p:sld xmlns:a="http://schemas.openxmlformats.org/drawingml/2006/main" xmlns:r="http://schemas.openxmlformats.org/officeDocument/2006/relationships" xmlns:p="http://schemas.openxmlformats.org/presentationml/2006/main">
   <p:cSld>
     <p:spTree>
@@ -14211,7 +14404,7 @@
 </p:sld>
 </file>
 
-<file path=ppt/slides/slide38.xml><?xml version="1.0" encoding="utf-8"?>
+<file path=ppt/slides/slide39.xml><?xml version="1.0" encoding="utf-8"?>
 <p:sld xmlns:a="http://schemas.openxmlformats.org/drawingml/2006/main" xmlns:r="http://schemas.openxmlformats.org/officeDocument/2006/relationships" xmlns:p="http://schemas.openxmlformats.org/presentationml/2006/main">
   <p:cSld>
     <p:spTree>
@@ -14309,7 +14502,113 @@
 </p:sld>
 </file>
 
-<file path=ppt/slides/slide39.xml><?xml version="1.0" encoding="utf-8"?>
+<file path=ppt/slides/slide4.xml><?xml version="1.0" encoding="utf-8"?>
+<p:sld xmlns:a="http://schemas.openxmlformats.org/drawingml/2006/main" xmlns:r="http://schemas.openxmlformats.org/officeDocument/2006/relationships" xmlns:p="http://schemas.openxmlformats.org/presentationml/2006/main">
+  <p:cSld>
+    <p:spTree>
+      <p:nvGrpSpPr>
+        <p:cNvPr id="1" name=""/>
+        <p:cNvGrpSpPr/>
+        <p:nvPr/>
+      </p:nvGrpSpPr>
+      <p:grpSpPr>
+        <a:xfrm>
+          <a:off x="0" y="0"/>
+          <a:ext cx="0" cy="0"/>
+          <a:chOff x="0" y="0"/>
+          <a:chExt cx="0" cy="0"/>
+        </a:xfrm>
+      </p:grpSpPr>
+      <p:sp>
+        <p:nvSpPr>
+          <p:cNvPr id="2" name="Title 1"/>
+          <p:cNvSpPr>
+            <a:spLocks noGrp="1"/>
+          </p:cNvSpPr>
+          <p:nvPr>
+            <p:ph type="title"/>
+          </p:nvPr>
+        </p:nvSpPr>
+        <p:spPr>
+          <a:xfrm>
+            <a:off x="457200" y="205979"/>
+            <a:ext cx="8229600" cy="857250"/>
+          </a:xfrm>
+        </p:spPr>
+        <p:txBody>
+          <a:bodyPr/>
+          <a:lstStyle/>
+          <a:p>
+            <a:pPr lvl="0" indent="0" marL="0">
+              <a:buNone/>
+            </a:pPr>
+            <a:r>
+              <a:rPr/>
+              <a:t>1,200 pumps, two readings each</a:t>
+            </a:r>
+          </a:p>
+        </p:txBody>
+      </p:sp>
+      <p:sp>
+        <p:nvSpPr>
+          <p:cNvPr id="3" name="Content Placeholder 2"/>
+          <p:cNvSpPr>
+            <a:spLocks noGrp="1"/>
+          </p:cNvSpPr>
+          <p:nvPr>
+            <p:ph idx="1"/>
+          </p:nvPr>
+        </p:nvSpPr>
+        <p:spPr>
+          <a:xfrm>
+            <a:off x="457200" y="1200151"/>
+            <a:ext cx="8229600" cy="3394472"/>
+          </a:xfrm>
+        </p:spPr>
+        <p:txBody>
+          <a:bodyPr/>
+          <a:lstStyle/>
+          <a:p>
+            <a:pPr lvl="0"/>
+            <a:r>
+              <a:rPr/>
+              <a:t>Vibration in Hz, pressure in bar</a:t>
+            </a:r>
+          </a:p>
+          <a:p>
+            <a:pPr lvl="0"/>
+            <a:r>
+              <a:rPr/>
+              <a:t>A pump is faulty when its readings fall </a:t>
+            </a:r>
+            <a:r>
+              <a:rPr b="1"/>
+              <a:t>outside the design envelope</a:t>
+            </a:r>
+            <a:r>
+              <a:rPr/>
+              <a:t>, too low as readily as too high</a:t>
+            </a:r>
+          </a:p>
+          <a:p>
+            <a:pPr lvl="0"/>
+            <a:r>
+              <a:rPr b="1"/>
+              <a:t>61.3%</a:t>
+            </a:r>
+            <a:r>
+              <a:rPr/>
+              <a:t> faulty; 4% of the labels are deliberately flipped</a:t>
+            </a:r>
+          </a:p>
+        </p:txBody>
+      </p:sp>
+    </p:spTree>
+  </p:cSld>
+</p:sld>
+</file>
+
+<file path=ppt/slides/slide40.xml><?xml version="1.0" encoding="utf-8"?>
 <p:sld xmlns:a="http://schemas.openxmlformats.org/drawingml/2006/main" xmlns:r="http://schemas.openxmlformats.org/officeDocument/2006/relationships" xmlns:p="http://schemas.openxmlformats.org/presentationml/2006/main">
   <p:cSld>
     <p:spTree>
@@ -14391,7 +14690,7 @@
 </p:sld>
 </file>
 
-<file path=ppt/slides/slide4.xml><?xml version="1.0" encoding="utf-8"?>
+<file path=ppt/slides/slide41.xml><?xml version="1.0" encoding="utf-8"?>
 <p:sld xmlns:a="http://schemas.openxmlformats.org/drawingml/2006/main" xmlns:r="http://schemas.openxmlformats.org/officeDocument/2006/relationships" xmlns:p="http://schemas.openxmlformats.org/presentationml/2006/main">
   <p:cSld>
     <p:spTree>
@@ -14433,7 +14732,7 @@
             </a:pPr>
             <a:r>
               <a:rPr/>
-              <a:t>1,200 pumps, two readings each</a:t>
+              <a:t>C is the price of a training error</a:t>
             </a:r>
           </a:p>
         </p:txBody>
@@ -14460,34 +14759,41 @@
           <a:p>
             <a:pPr lvl="0"/>
             <a:r>
-              <a:rPr/>
-              <a:t>Vibration in Hz, pressure in bar</a:t>
+              <a:rPr b="1"/>
+              <a:t>Large C</a:t>
+            </a:r>
+            <a:r>
+              <a:rPr/>
+              <a:t>: violations are expensive, so the model contorts to classify everything. Narrow margin, low bias, high variance</a:t>
             </a:r>
           </a:p>
           <a:p>
             <a:pPr lvl="0"/>
             <a:r>
-              <a:rPr/>
-              <a:t>A pump is faulty when its readings fall </a:t>
-            </a:r>
-            <a:r>
               <a:rPr b="1"/>
-              <a:t>outside the design envelope</a:t>
-            </a:r>
-            <a:r>
-              <a:rPr/>
-              <a:t>, too low as readily as too high</a:t>
+              <a:t>Small C</a:t>
+            </a:r>
+            <a:r>
+              <a:rPr/>
+              <a:t>: a wider, calmer boundary, at the cost of some errors</a:t>
             </a:r>
           </a:p>
           <a:p>
             <a:pPr lvl="0"/>
             <a:r>
+              <a:rPr/>
+              <a:t>The same dial as k in k-NN and λ in lesson 3, in a third costume</a:t>
+            </a:r>
+          </a:p>
+          <a:p>
+            <a:pPr lvl="0"/>
+            <a:r>
+              <a:rPr/>
+              <a:t>Note the direction: </a:t>
+            </a:r>
+            <a:r>
               <a:rPr b="1"/>
-              <a:t>61.3%</a:t>
-            </a:r>
-            <a:r>
-              <a:rPr/>
-              <a:t> faulty; 4% of the labels are deliberately flipped</a:t>
+              <a:t>large C means less regularisation</a:t>
             </a:r>
           </a:p>
         </p:txBody>
@@ -14497,120 +14803,7 @@
 </p:sld>
 </file>
 
-<file path=ppt/slides/slide40.xml><?xml version="1.0" encoding="utf-8"?>
-<p:sld xmlns:a="http://schemas.openxmlformats.org/drawingml/2006/main" xmlns:r="http://schemas.openxmlformats.org/officeDocument/2006/relationships" xmlns:p="http://schemas.openxmlformats.org/presentationml/2006/main">
-  <p:cSld>
-    <p:spTree>
-      <p:nvGrpSpPr>
-        <p:cNvPr id="1" name=""/>
-        <p:cNvGrpSpPr/>
-        <p:nvPr/>
-      </p:nvGrpSpPr>
-      <p:grpSpPr>
-        <a:xfrm>
-          <a:off x="0" y="0"/>
-          <a:ext cx="0" cy="0"/>
-          <a:chOff x="0" y="0"/>
-          <a:chExt cx="0" cy="0"/>
-        </a:xfrm>
-      </p:grpSpPr>
-      <p:sp>
-        <p:nvSpPr>
-          <p:cNvPr id="2" name="Title 1"/>
-          <p:cNvSpPr>
-            <a:spLocks noGrp="1"/>
-          </p:cNvSpPr>
-          <p:nvPr>
-            <p:ph type="title"/>
-          </p:nvPr>
-        </p:nvSpPr>
-        <p:spPr>
-          <a:xfrm>
-            <a:off x="457200" y="205979"/>
-            <a:ext cx="8229600" cy="857250"/>
-          </a:xfrm>
-        </p:spPr>
-        <p:txBody>
-          <a:bodyPr/>
-          <a:lstStyle/>
-          <a:p>
-            <a:pPr lvl="0" indent="0" marL="0">
-              <a:buNone/>
-            </a:pPr>
-            <a:r>
-              <a:rPr/>
-              <a:t>C is the price of a training error</a:t>
-            </a:r>
-          </a:p>
-        </p:txBody>
-      </p:sp>
-      <p:sp>
-        <p:nvSpPr>
-          <p:cNvPr id="3" name="Content Placeholder 2"/>
-          <p:cNvSpPr>
-            <a:spLocks noGrp="1"/>
-          </p:cNvSpPr>
-          <p:nvPr>
-            <p:ph idx="1"/>
-          </p:nvPr>
-        </p:nvSpPr>
-        <p:spPr>
-          <a:xfrm>
-            <a:off x="457200" y="1200151"/>
-            <a:ext cx="8229600" cy="3394472"/>
-          </a:xfrm>
-        </p:spPr>
-        <p:txBody>
-          <a:bodyPr/>
-          <a:lstStyle/>
-          <a:p>
-            <a:pPr lvl="0"/>
-            <a:r>
-              <a:rPr b="1"/>
-              <a:t>Large C</a:t>
-            </a:r>
-            <a:r>
-              <a:rPr/>
-              <a:t>: violations are expensive, so the model contorts to classify everything. Narrow margin, low bias, high variance</a:t>
-            </a:r>
-          </a:p>
-          <a:p>
-            <a:pPr lvl="0"/>
-            <a:r>
-              <a:rPr b="1"/>
-              <a:t>Small C</a:t>
-            </a:r>
-            <a:r>
-              <a:rPr/>
-              <a:t>: a wider, calmer boundary, at the cost of some errors</a:t>
-            </a:r>
-          </a:p>
-          <a:p>
-            <a:pPr lvl="0"/>
-            <a:r>
-              <a:rPr/>
-              <a:t>The same dial as k in k-NN and λ in lesson 3, in a third costume</a:t>
-            </a:r>
-          </a:p>
-          <a:p>
-            <a:pPr lvl="0"/>
-            <a:r>
-              <a:rPr/>
-              <a:t>Note the direction: </a:t>
-            </a:r>
-            <a:r>
-              <a:rPr b="1"/>
-              <a:t>large C means less regularisation</a:t>
-            </a:r>
-          </a:p>
-        </p:txBody>
-      </p:sp>
-    </p:spTree>
-  </p:cSld>
-</p:sld>
-</file>
-
-<file path=ppt/slides/slide41.xml><?xml version="1.0" encoding="utf-8"?>
+<file path=ppt/slides/slide42.xml><?xml version="1.0" encoding="utf-8"?>
 <p:sld xmlns:a="http://schemas.openxmlformats.org/drawingml/2006/main" xmlns:r="http://schemas.openxmlformats.org/officeDocument/2006/relationships" xmlns:p="http://schemas.openxmlformats.org/presentationml/2006/main">
   <p:cSld>
     <p:spTree>
@@ -14843,129 +15036,6 @@
 </p:sld>
 </file>
 
-<file path=ppt/slides/slide42.xml><?xml version="1.0" encoding="utf-8"?>
-<p:sld xmlns:a="http://schemas.openxmlformats.org/drawingml/2006/main" xmlns:r="http://schemas.openxmlformats.org/officeDocument/2006/relationships" xmlns:p="http://schemas.openxmlformats.org/presentationml/2006/main">
-  <p:cSld>
-    <p:spTree>
-      <p:nvGrpSpPr>
-        <p:cNvPr id="1" name=""/>
-        <p:cNvGrpSpPr/>
-        <p:nvPr/>
-      </p:nvGrpSpPr>
-      <p:grpSpPr>
-        <a:xfrm>
-          <a:off x="0" y="0"/>
-          <a:ext cx="0" cy="0"/>
-          <a:chOff x="0" y="0"/>
-          <a:chExt cx="0" cy="0"/>
-        </a:xfrm>
-      </p:grpSpPr>
-      <p:sp>
-        <p:nvSpPr>
-          <p:cNvPr id="2" name="Title 1"/>
-          <p:cNvSpPr>
-            <a:spLocks noGrp="1"/>
-          </p:cNvSpPr>
-          <p:nvPr>
-            <p:ph type="title"/>
-          </p:nvPr>
-        </p:nvSpPr>
-        <p:spPr>
-          <a:xfrm>
-            <a:off x="457200" y="205979"/>
-            <a:ext cx="8229600" cy="857250"/>
-          </a:xfrm>
-        </p:spPr>
-        <p:txBody>
-          <a:bodyPr/>
-          <a:lstStyle/>
-          <a:p>
-            <a:pPr lvl="0" indent="0" marL="0">
-              <a:buNone/>
-            </a:pPr>
-            <a:r>
-              <a:rPr/>
-              <a:t>A high support-vector fraction is a free warning</a:t>
-            </a:r>
-          </a:p>
-        </p:txBody>
-      </p:sp>
-      <p:sp>
-        <p:nvSpPr>
-          <p:cNvPr id="3" name="Content Placeholder 2"/>
-          <p:cNvSpPr>
-            <a:spLocks noGrp="1"/>
-          </p:cNvSpPr>
-          <p:nvPr>
-            <p:ph idx="1"/>
-          </p:nvPr>
-        </p:nvSpPr>
-        <p:spPr>
-          <a:xfrm>
-            <a:off x="457200" y="1200151"/>
-            <a:ext cx="8229600" cy="3394472"/>
-          </a:xfrm>
-        </p:spPr>
-        <p:txBody>
-          <a:bodyPr/>
-          <a:lstStyle/>
-          <a:p>
-            <a:pPr lvl="0"/>
-            <a:r>
-              <a:rPr/>
-              <a:t>The linear model needs </a:t>
-            </a:r>
-            <a:r>
-              <a:rPr b="1"/>
-              <a:t>79%</a:t>
-            </a:r>
-            <a:r>
-              <a:rPr/>
-              <a:t> of the training set to define its boundary</a:t>
-            </a:r>
-          </a:p>
-          <a:p>
-            <a:pPr lvl="0"/>
-            <a:r>
-              <a:rPr/>
-              <a:t>The RBF model needs </a:t>
-            </a:r>
-            <a:r>
-              <a:rPr b="1"/>
-              <a:t>23%</a:t>
-            </a:r>
-          </a:p>
-          <a:p>
-            <a:pPr lvl="0"/>
-            <a:r>
-              <a:rPr/>
-              <a:t>Almost every point sits on or inside the margin: there is no slab that separates anything</a:t>
-            </a:r>
-          </a:p>
-          <a:p>
-            <a:pPr lvl="0"/>
-            <a:r>
-              <a:rPr/>
-              <a:t>The count falls out of </a:t>
-            </a:r>
-            <a:r>
-              <a:rPr>
-                <a:latin typeface="Courier"/>
-              </a:rPr>
-              <a:t>fit</a:t>
-            </a:r>
-            <a:r>
-              <a:rPr/>
-              <a:t> at no cost, and you should look at it</a:t>
-            </a:r>
-          </a:p>
-        </p:txBody>
-      </p:sp>
-    </p:spTree>
-  </p:cSld>
-</p:sld>
-</file>
-
 <file path=ppt/slides/slide43.xml><?xml version="1.0" encoding="utf-8"?>
 <p:sld xmlns:a="http://schemas.openxmlformats.org/drawingml/2006/main" xmlns:r="http://schemas.openxmlformats.org/officeDocument/2006/relationships" xmlns:p="http://schemas.openxmlformats.org/presentationml/2006/main">
   <p:cSld>
@@ -15008,7 +15078,7 @@
             </a:pPr>
             <a:r>
               <a:rPr/>
-              <a:t>The kernel trick: they needed different coordinates</a:t>
+              <a:t>A high support-vector fraction is a free warning</a:t>
             </a:r>
           </a:p>
         </p:txBody>
@@ -15036,36 +15106,50 @@
             <a:pPr lvl="0"/>
             <a:r>
               <a:rPr/>
-              <a:t>Healthy pumps in a disc, faulty ones around it: no line works </a:t>
+              <a:t>The linear model needs </a:t>
             </a:r>
             <a:r>
               <a:rPr b="1"/>
-              <a:t>in the plane</a:t>
+              <a:t>79%</a:t>
+            </a:r>
+            <a:r>
+              <a:rPr/>
+              <a:t> of the training set to define its boundary</a:t>
             </a:r>
           </a:p>
           <a:p>
             <a:pPr lvl="0"/>
             <a:r>
               <a:rPr/>
-              <a:t>Add a third coordinate: the </a:t>
+              <a:t>The RBF model needs </a:t>
             </a:r>
             <a:r>
               <a:rPr b="1"/>
-              <a:t>distance from the design point</a:t>
+              <a:t>23%</a:t>
             </a:r>
           </a:p>
           <a:p>
             <a:pPr lvl="0"/>
             <a:r>
               <a:rPr/>
-              <a:t>Healthy pumps rise a little, faulty ones a lot, and a flat plane separates them perfectly</a:t>
+              <a:t>Almost every point sits on or inside the margin: there is no slab that separates anything</a:t>
             </a:r>
           </a:p>
           <a:p>
             <a:pPr lvl="0"/>
             <a:r>
               <a:rPr/>
-              <a:t>The classes were always separable. They were measured in the wrong coordinates</a:t>
+              <a:t>The count falls out of </a:t>
+            </a:r>
+            <a:r>
+              <a:rPr>
+                <a:latin typeface="Courier"/>
+              </a:rPr>
+              <a:t>fit</a:t>
+            </a:r>
+            <a:r>
+              <a:rPr/>
+              <a:t> at no cost, and you should look at it</a:t>
             </a:r>
           </a:p>
         </p:txBody>
@@ -15076,6 +15160,115 @@
 </file>
 
 <file path=ppt/slides/slide44.xml><?xml version="1.0" encoding="utf-8"?>
+<p:sld xmlns:a="http://schemas.openxmlformats.org/drawingml/2006/main" xmlns:r="http://schemas.openxmlformats.org/officeDocument/2006/relationships" xmlns:p="http://schemas.openxmlformats.org/presentationml/2006/main">
+  <p:cSld>
+    <p:spTree>
+      <p:nvGrpSpPr>
+        <p:cNvPr id="1" name=""/>
+        <p:cNvGrpSpPr/>
+        <p:nvPr/>
+      </p:nvGrpSpPr>
+      <p:grpSpPr>
+        <a:xfrm>
+          <a:off x="0" y="0"/>
+          <a:ext cx="0" cy="0"/>
+          <a:chOff x="0" y="0"/>
+          <a:chExt cx="0" cy="0"/>
+        </a:xfrm>
+      </p:grpSpPr>
+      <p:sp>
+        <p:nvSpPr>
+          <p:cNvPr id="2" name="Title 1"/>
+          <p:cNvSpPr>
+            <a:spLocks noGrp="1"/>
+          </p:cNvSpPr>
+          <p:nvPr>
+            <p:ph type="title"/>
+          </p:nvPr>
+        </p:nvSpPr>
+        <p:spPr>
+          <a:xfrm>
+            <a:off x="457200" y="205979"/>
+            <a:ext cx="8229600" cy="857250"/>
+          </a:xfrm>
+        </p:spPr>
+        <p:txBody>
+          <a:bodyPr/>
+          <a:lstStyle/>
+          <a:p>
+            <a:pPr lvl="0" indent="0" marL="0">
+              <a:buNone/>
+            </a:pPr>
+            <a:r>
+              <a:rPr/>
+              <a:t>The kernel trick: they needed different coordinates</a:t>
+            </a:r>
+          </a:p>
+        </p:txBody>
+      </p:sp>
+      <p:sp>
+        <p:nvSpPr>
+          <p:cNvPr id="3" name="Content Placeholder 2"/>
+          <p:cNvSpPr>
+            <a:spLocks noGrp="1"/>
+          </p:cNvSpPr>
+          <p:nvPr>
+            <p:ph idx="1"/>
+          </p:nvPr>
+        </p:nvSpPr>
+        <p:spPr>
+          <a:xfrm>
+            <a:off x="457200" y="1200151"/>
+            <a:ext cx="8229600" cy="3394472"/>
+          </a:xfrm>
+        </p:spPr>
+        <p:txBody>
+          <a:bodyPr/>
+          <a:lstStyle/>
+          <a:p>
+            <a:pPr lvl="0"/>
+            <a:r>
+              <a:rPr/>
+              <a:t>Healthy pumps in a disc, faulty ones around it: no line works </a:t>
+            </a:r>
+            <a:r>
+              <a:rPr b="1"/>
+              <a:t>in the plane</a:t>
+            </a:r>
+          </a:p>
+          <a:p>
+            <a:pPr lvl="0"/>
+            <a:r>
+              <a:rPr/>
+              <a:t>Add a third coordinate: the </a:t>
+            </a:r>
+            <a:r>
+              <a:rPr b="1"/>
+              <a:t>distance from the design point</a:t>
+            </a:r>
+          </a:p>
+          <a:p>
+            <a:pPr lvl="0"/>
+            <a:r>
+              <a:rPr/>
+              <a:t>Healthy pumps rise a little, faulty ones a lot, and a flat plane separates them perfectly</a:t>
+            </a:r>
+          </a:p>
+          <a:p>
+            <a:pPr lvl="0"/>
+            <a:r>
+              <a:rPr/>
+              <a:t>The classes were always separable. They were measured in the wrong coordinates</a:t>
+            </a:r>
+          </a:p>
+        </p:txBody>
+      </p:sp>
+    </p:spTree>
+  </p:cSld>
+</p:sld>
+</file>
+
+<file path=ppt/slides/slide45.xml><?xml version="1.0" encoding="utf-8"?>
 <p:sld xmlns:a="http://schemas.openxmlformats.org/drawingml/2006/main" xmlns:r="http://schemas.openxmlformats.org/officeDocument/2006/relationships" xmlns:p="http://schemas.openxmlformats.org/presentationml/2006/main">
   <p:cSld>
     <p:spTree>
@@ -15157,7 +15350,7 @@
 </p:sld>
 </file>
 
-<file path=ppt/slides/slide45.xml><?xml version="1.0" encoding="utf-8"?>
+<file path=ppt/slides/slide46.xml><?xml version="1.0" encoding="utf-8"?>
 <p:sld xmlns:a="http://schemas.openxmlformats.org/drawingml/2006/main" xmlns:r="http://schemas.openxmlformats.org/officeDocument/2006/relationships" xmlns:p="http://schemas.openxmlformats.org/presentationml/2006/main">
   <p:cSld>
     <p:spTree>
@@ -15275,7 +15468,7 @@
 </p:sld>
 </file>
 
-<file path=ppt/slides/slide46.xml><?xml version="1.0" encoding="utf-8"?>
+<file path=ppt/slides/slide47.xml><?xml version="1.0" encoding="utf-8"?>
 <p:sld xmlns:a="http://schemas.openxmlformats.org/drawingml/2006/main" xmlns:r="http://schemas.openxmlformats.org/officeDocument/2006/relationships" xmlns:p="http://schemas.openxmlformats.org/presentationml/2006/main">
   <p:cSld>
     <p:spTree>
@@ -15357,7 +15550,7 @@
 </p:sld>
 </file>
 
-<file path=ppt/slides/slide47.xml><?xml version="1.0" encoding="utf-8"?>
+<file path=ppt/slides/slide48.xml><?xml version="1.0" encoding="utf-8"?>
 <p:sld xmlns:a="http://schemas.openxmlformats.org/drawingml/2006/main" xmlns:r="http://schemas.openxmlformats.org/officeDocument/2006/relationships" xmlns:p="http://schemas.openxmlformats.org/presentationml/2006/main">
   <p:cSld>
     <p:spTree>
@@ -15629,7 +15822,7 @@
 </p:sld>
 </file>
 
-<file path=ppt/slides/slide48.xml><?xml version="1.0" encoding="utf-8"?>
+<file path=ppt/slides/slide49.xml><?xml version="1.0" encoding="utf-8"?>
 <p:sld xmlns:a="http://schemas.openxmlformats.org/drawingml/2006/main" xmlns:r="http://schemas.openxmlformats.org/officeDocument/2006/relationships" xmlns:p="http://schemas.openxmlformats.org/presentationml/2006/main">
   <p:cSld>
     <p:spTree>
@@ -15706,86 +15899,6 @@
           </a:ln>
         </p:spPr>
       </p:pic>
-    </p:spTree>
-  </p:cSld>
-</p:sld>
-</file>
-
-<file path=ppt/slides/slide49.xml><?xml version="1.0" encoding="utf-8"?>
-<p:sld xmlns:a="http://schemas.openxmlformats.org/drawingml/2006/main" xmlns:r="http://schemas.openxmlformats.org/officeDocument/2006/relationships" xmlns:p="http://schemas.openxmlformats.org/presentationml/2006/main">
-  <p:cSld>
-    <p:spTree>
-      <p:nvGrpSpPr>
-        <p:cNvPr id="1" name=""/>
-        <p:cNvGrpSpPr/>
-        <p:nvPr/>
-      </p:nvGrpSpPr>
-      <p:grpSpPr>
-        <a:xfrm>
-          <a:off x="0" y="0"/>
-          <a:ext cx="0" cy="0"/>
-          <a:chOff x="0" y="0"/>
-          <a:chExt cx="0" cy="0"/>
-        </a:xfrm>
-      </p:grpSpPr>
-      <p:sp>
-        <p:nvSpPr>
-          <p:cNvPr id="2" name="Title 1"/>
-          <p:cNvSpPr>
-            <a:spLocks noGrp="1"/>
-          </p:cNvSpPr>
-          <p:nvPr>
-            <p:ph type="title"/>
-          </p:nvPr>
-        </p:nvSpPr>
-        <p:spPr>
-          <a:xfrm>
-            <a:off x="457200" y="205979"/>
-            <a:ext cx="8229600" cy="857250"/>
-          </a:xfrm>
-        </p:spPr>
-        <p:txBody>
-          <a:bodyPr/>
-          <a:lstStyle/>
-          <a:p>
-            <a:pPr lvl="0" indent="0" marL="0">
-              <a:buNone/>
-            </a:pPr>
-            <a:r>
-              <a:rPr/>
-              <a:t>Notebook 3, live</a:t>
-            </a:r>
-          </a:p>
-        </p:txBody>
-      </p:sp>
-      <p:sp>
-        <p:nvSpPr>
-          <p:cNvPr id="3" name="Content Placeholder 2"/>
-          <p:cNvSpPr>
-            <a:spLocks noGrp="1"/>
-          </p:cNvSpPr>
-          <p:nvPr>
-            <p:ph idx="1"/>
-          </p:nvPr>
-        </p:nvSpPr>
-        <p:spPr>
-          <a:xfrm>
-            <a:off x="457200" y="1200151"/>
-            <a:ext cx="8229600" cy="3394472"/>
-          </a:xfrm>
-        </p:spPr>
-        <p:txBody>
-          <a:bodyPr/>
-          <a:lstStyle/>
-          <a:p>
-            <a:pPr lvl="0"/>
-            <a:r>
-              <a:rPr/>
-              <a:t>Margins, support vectors, and what γ does to the boundary</a:t>
-            </a:r>
-          </a:p>
-        </p:txBody>
-      </p:sp>
     </p:spTree>
   </p:cSld>
 </p:sld>
@@ -15874,6 +15987,86 @@
 </file>
 
 <file path=ppt/slides/slide50.xml><?xml version="1.0" encoding="utf-8"?>
+<p:sld xmlns:a="http://schemas.openxmlformats.org/drawingml/2006/main" xmlns:r="http://schemas.openxmlformats.org/officeDocument/2006/relationships" xmlns:p="http://schemas.openxmlformats.org/presentationml/2006/main">
+  <p:cSld>
+    <p:spTree>
+      <p:nvGrpSpPr>
+        <p:cNvPr id="1" name=""/>
+        <p:cNvGrpSpPr/>
+        <p:nvPr/>
+      </p:nvGrpSpPr>
+      <p:grpSpPr>
+        <a:xfrm>
+          <a:off x="0" y="0"/>
+          <a:ext cx="0" cy="0"/>
+          <a:chOff x="0" y="0"/>
+          <a:chExt cx="0" cy="0"/>
+        </a:xfrm>
+      </p:grpSpPr>
+      <p:sp>
+        <p:nvSpPr>
+          <p:cNvPr id="2" name="Title 1"/>
+          <p:cNvSpPr>
+            <a:spLocks noGrp="1"/>
+          </p:cNvSpPr>
+          <p:nvPr>
+            <p:ph type="title"/>
+          </p:nvPr>
+        </p:nvSpPr>
+        <p:spPr>
+          <a:xfrm>
+            <a:off x="457200" y="205979"/>
+            <a:ext cx="8229600" cy="857250"/>
+          </a:xfrm>
+        </p:spPr>
+        <p:txBody>
+          <a:bodyPr/>
+          <a:lstStyle/>
+          <a:p>
+            <a:pPr lvl="0" indent="0" marL="0">
+              <a:buNone/>
+            </a:pPr>
+            <a:r>
+              <a:rPr/>
+              <a:t>Notebook 3, live</a:t>
+            </a:r>
+          </a:p>
+        </p:txBody>
+      </p:sp>
+      <p:sp>
+        <p:nvSpPr>
+          <p:cNvPr id="3" name="Content Placeholder 2"/>
+          <p:cNvSpPr>
+            <a:spLocks noGrp="1"/>
+          </p:cNvSpPr>
+          <p:nvPr>
+            <p:ph idx="1"/>
+          </p:nvPr>
+        </p:nvSpPr>
+        <p:spPr>
+          <a:xfrm>
+            <a:off x="457200" y="1200151"/>
+            <a:ext cx="8229600" cy="3394472"/>
+          </a:xfrm>
+        </p:spPr>
+        <p:txBody>
+          <a:bodyPr/>
+          <a:lstStyle/>
+          <a:p>
+            <a:pPr lvl="0"/>
+            <a:r>
+              <a:rPr/>
+              <a:t>Margins, support vectors, and what γ does to the boundary</a:t>
+            </a:r>
+          </a:p>
+        </p:txBody>
+      </p:sp>
+    </p:spTree>
+  </p:cSld>
+</p:sld>
+</file>
+
+<file path=ppt/slides/slide51.xml><?xml version="1.0" encoding="utf-8"?>
 <p:sld xmlns:a="http://schemas.openxmlformats.org/drawingml/2006/main" xmlns:r="http://schemas.openxmlformats.org/officeDocument/2006/relationships" xmlns:p="http://schemas.openxmlformats.org/presentationml/2006/main">
   <p:cSld>
     <p:spTree>
@@ -16211,7 +16404,7 @@
 </p:sld>
 </file>
 
-<file path=ppt/slides/slide51.xml><?xml version="1.0" encoding="utf-8"?>
+<file path=ppt/slides/slide52.xml><?xml version="1.0" encoding="utf-8"?>
 <p:sld xmlns:a="http://schemas.openxmlformats.org/drawingml/2006/main" xmlns:r="http://schemas.openxmlformats.org/officeDocument/2006/relationships" xmlns:p="http://schemas.openxmlformats.org/presentationml/2006/main">
   <p:cSld>
     <p:spTree>
@@ -16489,7 +16682,7 @@
 </p:sld>
 </file>
 
-<file path=ppt/slides/slide52.xml><?xml version="1.0" encoding="utf-8"?>
+<file path=ppt/slides/slide53.xml><?xml version="1.0" encoding="utf-8"?>
 <p:sld xmlns:a="http://schemas.openxmlformats.org/drawingml/2006/main" xmlns:r="http://schemas.openxmlformats.org/officeDocument/2006/relationships" xmlns:p="http://schemas.openxmlformats.org/presentationml/2006/main">
   <p:cSld>
     <p:spTree>
@@ -16621,7 +16814,7 @@
 </p:sld>
 </file>
 
-<file path=ppt/slides/slide53.xml><?xml version="1.0" encoding="utf-8"?>
+<file path=ppt/slides/slide54.xml><?xml version="1.0" encoding="utf-8"?>
 <p:sld xmlns:a="http://schemas.openxmlformats.org/drawingml/2006/main" xmlns:r="http://schemas.openxmlformats.org/officeDocument/2006/relationships" xmlns:p="http://schemas.openxmlformats.org/presentationml/2006/main">
   <p:cSld>
     <p:spTree>

</xml_diff>

<commit_message>
Say what Gaussian Naive Bayes trains, and why it beats a line on the pumps
Lesson 6 used Gaussian Naive Bayes without ever saying what the Gaussian
is or what training computes. Section 4.2 now gives the density, states
training as priors plus a mean and a variance per feature per class - ten
numbers on the pumps, no optimisation - and shows the fitted table: the two
classes share a centre and differ only in width, which is why a linear
model sits at the baseline. One pump is worked term by term to 0.981.

Notebook 02 prints every one of those numbers, two slides carry the density
and the table, the Naive Bayes segment takes 24 minutes and notebook 02 16,
and the concepts index gains the evidence, the Gaussian model, what training
is, and why a density can exceed 1.

Co-Authored-By: Claude Opus 5.5 <noreply@anthropic.com>
</commit_message>
<xml_diff>
--- a/Lessons/06_knn_naive_bayes_svm/Slides/knn_naive_bayes_svm_slides.pptx
+++ b/Lessons/06_knn_naive_bayes_svm/Slides/knn_naive_bayes_svm_slides.pptx
@@ -5,7 +5,7 @@
     <p:sldMasterId id="2147483648" r:id="rId1"/>
   </p:sldMasterIdLst>
   <p:notesMasterIdLst>
-    <p:notesMasterId r:id="rId56"/>
+    <p:notesMasterId r:id="rId58"/>
   </p:notesMasterIdLst>
   <p:sldIdLst>
     <p:sldId id="256" r:id="rId2"/>
@@ -62,6 +62,8 @@
     <p:sldId id="307" r:id="rId53"/>
     <p:sldId id="308" r:id="rId54"/>
     <p:sldId id="309" r:id="rId55"/>
+    <p:sldId id="310" r:id="rId56"/>
+    <p:sldId id="311" r:id="rId57"/>
   </p:sldIdLst>
   <p:sldSz cx="9144000" cy="5143500" type="screen16x9"/>
   <p:notesSz cx="6858000" cy="9144000"/>
@@ -2991,49 +2993,35 @@
             </a:pPr>
             <a:r>
               <a:rPr/>
-              <a:t>Both halves matter, and students tend to hear only one of them.</a:t>
-            </a:r>
-          </a:p>
-          <a:p>
-            <a:pPr lvl="0" indent="0" marL="0">
-              <a:buNone/>
-            </a:pPr>
-          </a:p>
-          <a:p>
-            <a:pPr lvl="0" indent="0" marL="0">
-              <a:buNone/>
-            </a:pPr>
-            <a:r>
-              <a:rPr/>
-              <a:t>The bargain is real. Nothing else in this course trains in one pass, and nothing else tolerates ten thousand features on a few thousand rows.</a:t>
-            </a:r>
-          </a:p>
-          <a:p>
-            <a:pPr lvl="0" indent="0" marL="0">
-              <a:buNone/>
-            </a:pPr>
-          </a:p>
-          <a:p>
-            <a:pPr lvl="0" indent="0" marL="0">
-              <a:buNone/>
-            </a:pPr>
-            <a:r>
-              <a:rPr/>
-              <a:t>The assumption is false almost everywhere, and give concrete cases rather than a general warning. Two sensors on the same machine are both driven by the operating point, so of course they move together. In text, “New” and “York” co-occur far more than independence would allow. In medicine, symptoms of the same disease arrive in clusters.</a:t>
-            </a:r>
-          </a:p>
-          <a:p>
-            <a:pPr lvl="0" indent="0" marL="0">
-              <a:buNone/>
-            </a:pPr>
-          </a:p>
-          <a:p>
-            <a:pPr lvl="0" indent="0" marL="0">
-              <a:buNone/>
-            </a:pPr>
-            <a:r>
-              <a:rPr/>
-              <a:t>Then the framing that makes the rest of this segment worth doing, and put it as a question to the room: given that the assumption is essentially always false, why does anybody use this? The answer is that the assumption being false and the CLASSIFIER being wrong are different things. Argmax only needs the ordering right, not the probabilities. Handout section 4.2 closes on exactly this.</a:t>
+              <a:t>The factorisation leaves one choice open: what shape each one-dimensional density has. “Gaussian” answers it. Every feature, in every class, gets its own bell curve with its own centre mu and its own width sigma.</a:t>
+            </a:r>
+          </a:p>
+          <a:p>
+            <a:pPr lvl="0" indent="0" marL="0">
+              <a:buNone/>
+            </a:pPr>
+          </a:p>
+          <a:p>
+            <a:pPr lvl="0" indent="0" marL="0">
+              <a:buNone/>
+            </a:pPr>
+            <a:r>
+              <a:rPr/>
+              <a:t>So say plainly what training is, because students expect an optimisation and there is none. Training computes three kinds of average: the class priors, and a mean and a variance per feature per class. One pass over the data. No gradient descent, no learning rate, no iterations, nothing to converge.</a:t>
+            </a:r>
+          </a:p>
+          <a:p>
+            <a:pPr lvl="0" indent="0" marL="0">
+              <a:buNone/>
+            </a:pPr>
+          </a:p>
+          <a:p>
+            <a:pPr lvl="0" indent="0" marL="0">
+              <a:buNone/>
+            </a:pPr>
+            <a:r>
+              <a:rPr/>
+              <a:t>Ask the room how many numbers that is for the pumps - two features, two classes. Let them count: two priors, four means, four variances. Ten. The next slide shows all ten. Handout section 4.2.</a:t>
             </a:r>
           </a:p>
         </p:txBody>
@@ -3115,49 +3103,49 @@
             </a:pPr>
             <a:r>
               <a:rPr/>
-              <a:t>A point behind k-NN, and an enormous distance ahead of the linear model - from a method that assumes something false and trains in a single pass over the data.</a:t>
-            </a:r>
-          </a:p>
-          <a:p>
-            <a:pPr lvl="0" indent="0" marL="0">
-              <a:buNone/>
-            </a:pPr>
-          </a:p>
-          <a:p>
-            <a:pPr lvl="0" indent="0" marL="0">
-              <a:buNone/>
-            </a:pPr>
-            <a:r>
-              <a:rPr/>
-              <a:t>Resist the temptation to stop here, because a score alone tells you nothing about when it will hold. Ask the room the useful question instead: WHY did that work? If the assumption is false, what happened?</a:t>
-            </a:r>
-          </a:p>
-          <a:p>
-            <a:pPr lvl="0" indent="0" marL="0">
-              <a:buNone/>
-            </a:pPr>
-          </a:p>
-          <a:p>
-            <a:pPr lvl="0" indent="0" marL="0">
-              <a:buNone/>
-            </a:pPr>
-            <a:r>
-              <a:rPr/>
-              <a:t>Then be explicit that we are about to check, rather than speculate. This is the habit worth transferring: when a model does better than you expected, find out which of your assumptions was accidentally satisfied. That tells you whether the result will survive on the next dataset.</a:t>
-            </a:r>
-          </a:p>
-          <a:p>
-            <a:pPr lvl="0" indent="0" marL="0">
-              <a:buNone/>
-            </a:pPr>
-          </a:p>
-          <a:p>
-            <a:pPr lvl="0" indent="0" marL="0">
-              <a:buNone/>
-            </a:pPr>
-            <a:r>
-              <a:rPr/>
-              <a:t>Handout section 4.3.</a:t>
+              <a:t>Let them read the means first and find the surprise themselves: the two classes have the same centre, to a few hundredths of a hertz. What differs is the width. Healthy pumps are a narrow bell around the design point, faulty ones a wide bell - the disc and the ring, one feature at a time.</a:t>
+            </a:r>
+          </a:p>
+          <a:p>
+            <a:pPr lvl="0" indent="0" marL="0">
+              <a:buNone/>
+            </a:pPr>
+          </a:p>
+          <a:p>
+            <a:pPr lvl="0" indent="0" marL="0">
+              <a:buNone/>
+            </a:pPr>
+            <a:r>
+              <a:rPr/>
+              <a:t>This explains the result they are about to see. A linear model separates classes by putting a boundary between their means, and here there is nothing between the means to find, so logistic regression will sit at the baseline. Naive Bayes compares widths.</a:t>
+            </a:r>
+          </a:p>
+          <a:p>
+            <a:pPr lvl="0" indent="0" marL="0">
+              <a:buNone/>
+            </a:pPr>
+          </a:p>
+          <a:p>
+            <a:pPr lvl="0" indent="0" marL="0">
+              <a:buNone/>
+            </a:pPr>
+            <a:r>
+              <a:rPr/>
+              <a:t>One pump makes it concrete. At 48 Hz and 5.6 bar, 6 Hz off the design point, that is three and a half healthy standard deviations but barely more than one faulty one. The vibration term decides it: P(faulty) = 0.981. At the design point itself, 42 Hz and 5.6 bar, P(healthy) = 0.820.</a:t>
+            </a:r>
+          </a:p>
+          <a:p>
+            <a:pPr lvl="0" indent="0" marL="0">
+              <a:buNone/>
+            </a:pPr>
+          </a:p>
+          <a:p>
+            <a:pPr lvl="0" indent="0" marL="0">
+              <a:buNone/>
+            </a:pPr>
+            <a:r>
+              <a:rPr/>
+              <a:t>If someone spots in the handout that one log-density is positive, that is the moment to say a density is not a probability: a bell 0.22 bar wide peaks above 1. Handout section 4.2 works the pump through term by term.</a:t>
             </a:r>
           </a:p>
         </p:txBody>
@@ -3371,49 +3359,49 @@
             </a:pPr>
             <a:r>
               <a:rPr/>
-              <a:t>Measured directly, and remember the assumption concerns independence GIVEN THE CLASS - so the second and third rows are the ones that count, not the first.</a:t>
-            </a:r>
-          </a:p>
-          <a:p>
-            <a:pPr lvl="0" indent="0" marL="0">
-              <a:buNone/>
-            </a:pPr>
-          </a:p>
-          <a:p>
-            <a:pPr lvl="0" indent="0" marL="0">
-              <a:buNone/>
-            </a:pPr>
-            <a:r>
-              <a:rPr/>
-              <a:t>Within each class the two readings are essentially uncorrelated: −0.006 among healthy pumps is as close to zero as a sample of this size will ever produce. The assumption is not approximately satisfied here; it is satisfied.</a:t>
-            </a:r>
-          </a:p>
-          <a:p>
-            <a:pPr lvl="0" indent="0" marL="0">
-              <a:buNone/>
-            </a:pPr>
-          </a:p>
-          <a:p>
-            <a:pPr lvl="0" indent="0" marL="0">
-              <a:buNone/>
-            </a:pPr>
-            <a:r>
-              <a:rPr/>
-              <a:t>Say why that is more useful than the 0.933. A score tells you what happened once. Knowing WHY it happened tells you when to expect it again - and it gives them a check they can run in two lines before trusting Naive Bayes on anything.</a:t>
-            </a:r>
-          </a:p>
-          <a:p>
-            <a:pPr lvl="0" indent="0" marL="0">
-              <a:buNone/>
-            </a:pPr>
-          </a:p>
-          <a:p>
-            <a:pPr lvl="0" indent="0" marL="0">
-              <a:buNone/>
-            </a:pPr>
-            <a:r>
-              <a:rPr/>
-              <a:t>The obvious caution, since somebody will raise it: zero correlation is not independence. Correlation only detects linear dependence. For Gaussian Naive Bayes with Gaussian-ish features it is the right check; in general it is necessary and not sufficient.</a:t>
+              <a:t>Both halves matter, and students tend to hear only one of them.</a:t>
+            </a:r>
+          </a:p>
+          <a:p>
+            <a:pPr lvl="0" indent="0" marL="0">
+              <a:buNone/>
+            </a:pPr>
+          </a:p>
+          <a:p>
+            <a:pPr lvl="0" indent="0" marL="0">
+              <a:buNone/>
+            </a:pPr>
+            <a:r>
+              <a:rPr/>
+              <a:t>The bargain is real. Nothing else in this course trains in one pass, and nothing else tolerates ten thousand features on a few thousand rows.</a:t>
+            </a:r>
+          </a:p>
+          <a:p>
+            <a:pPr lvl="0" indent="0" marL="0">
+              <a:buNone/>
+            </a:pPr>
+          </a:p>
+          <a:p>
+            <a:pPr lvl="0" indent="0" marL="0">
+              <a:buNone/>
+            </a:pPr>
+            <a:r>
+              <a:rPr/>
+              <a:t>The assumption is false almost everywhere, and give concrete cases rather than a general warning. Two sensors on the same machine are both driven by the operating point, so of course they move together. In text, “New” and “York” co-occur far more than independence would allow. In medicine, symptoms of the same disease arrive in clusters.</a:t>
+            </a:r>
+          </a:p>
+          <a:p>
+            <a:pPr lvl="0" indent="0" marL="0">
+              <a:buNone/>
+            </a:pPr>
+          </a:p>
+          <a:p>
+            <a:pPr lvl="0" indent="0" marL="0">
+              <a:buNone/>
+            </a:pPr>
+            <a:r>
+              <a:rPr/>
+              <a:t>Then the framing that makes the rest of this segment worth doing, and put it as a question to the room: given that the assumption is essentially always false, why does anybody use this? The answer is that the assumption being false and the CLASSIFIER being wrong are different things. Argmax only needs the ordering right, not the probabilities. Handout section 4.2 closes on exactly this.</a:t>
             </a:r>
           </a:p>
         </p:txBody>
@@ -3495,49 +3483,49 @@
             </a:pPr>
             <a:r>
               <a:rPr/>
-              <a:t>Change one thing about the problem and watch the method fall apart. Describe the physics before the geometry, because the rule is completely reasonable engineering.</a:t>
-            </a:r>
-          </a:p>
-          <a:p>
-            <a:pPr lvl="0" indent="0" marL="0">
-              <a:buNone/>
-            </a:pPr>
-          </a:p>
-          <a:p>
-            <a:pPr lvl="0" indent="0" marL="0">
-              <a:buNone/>
-            </a:pPr>
-            <a:r>
-              <a:rPr/>
-              <a:t>High demand and high delivery: fine, that is the machine working hard. Low and low: fine, that is idle. High demand with low delivery, or the reverse: something is wrong between them. Exactly one high means faulty.</a:t>
-            </a:r>
-          </a:p>
-          <a:p>
-            <a:pPr lvl="0" indent="0" marL="0">
-              <a:buNone/>
-            </a:pPr>
-          </a:p>
-          <a:p>
-            <a:pPr lvl="0" indent="0" marL="0">
-              <a:buNone/>
-            </a:pPr>
-            <a:r>
-              <a:rPr/>
-              <a:t>Ask them, before the picture, what each sensor tells you ON ITS OWN under that rule. Give it a moment. The answer is: nothing at all. Every value of sensor A appears in both classes about equally often, because whether it means “faulty” depends entirely on sensor B.</a:t>
-            </a:r>
-          </a:p>
-          <a:p>
-            <a:pPr lvl="0" indent="0" marL="0">
-              <a:buNone/>
-            </a:pPr>
-          </a:p>
-          <a:p>
-            <a:pPr lvl="0" indent="0" marL="0">
-              <a:buNone/>
-            </a:pPr>
-            <a:r>
-              <a:rPr/>
-              <a:t>That is what an interaction is, and it is precisely the structure the independence assumption is unable to represent. Handout section 4.4.</a:t>
+              <a:t>A point behind k-NN, and an enormous distance ahead of the linear model - from a method that assumes something false and trains in a single pass over the data.</a:t>
+            </a:r>
+          </a:p>
+          <a:p>
+            <a:pPr lvl="0" indent="0" marL="0">
+              <a:buNone/>
+            </a:pPr>
+          </a:p>
+          <a:p>
+            <a:pPr lvl="0" indent="0" marL="0">
+              <a:buNone/>
+            </a:pPr>
+            <a:r>
+              <a:rPr/>
+              <a:t>Resist the temptation to stop here, because a score alone tells you nothing about when it will hold. Ask the room the useful question instead: WHY did that work? If the assumption is false, what happened?</a:t>
+            </a:r>
+          </a:p>
+          <a:p>
+            <a:pPr lvl="0" indent="0" marL="0">
+              <a:buNone/>
+            </a:pPr>
+          </a:p>
+          <a:p>
+            <a:pPr lvl="0" indent="0" marL="0">
+              <a:buNone/>
+            </a:pPr>
+            <a:r>
+              <a:rPr/>
+              <a:t>Then be explicit that we are about to check, rather than speculate. This is the habit worth transferring: when a model does better than you expected, find out which of your assumptions was accidentally satisfied. That tells you whether the result will survive on the next dataset.</a:t>
+            </a:r>
+          </a:p>
+          <a:p>
+            <a:pPr lvl="0" indent="0" marL="0">
+              <a:buNone/>
+            </a:pPr>
+          </a:p>
+          <a:p>
+            <a:pPr lvl="0" indent="0" marL="0">
+              <a:buNone/>
+            </a:pPr>
+            <a:r>
+              <a:rPr/>
+              <a:t>Handout section 4.3.</a:t>
             </a:r>
           </a:p>
         </p:txBody>
@@ -3619,49 +3607,49 @@
             </a:pPr>
             <a:r>
               <a:rPr/>
-              <a:t>Left panel: the two sensors together. Four clean groups, and a perfectly learnable rule - any method that can draw a non-linear boundary will find it.</a:t>
-            </a:r>
-          </a:p>
-          <a:p>
-            <a:pPr lvl="0" indent="0" marL="0">
-              <a:buNone/>
-            </a:pPr>
-          </a:p>
-          <a:p>
-            <a:pPr lvl="0" indent="0" marL="0">
-              <a:buNone/>
-            </a:pPr>
-            <a:r>
-              <a:rPr/>
-              <a:t>Middle and right: each sensor on its own, which is ALL Naive Bayes ever gets. The two class distributions sit almost exactly on top of one another.</a:t>
-            </a:r>
-          </a:p>
-          <a:p>
-            <a:pPr lvl="0" indent="0" marL="0">
-              <a:buNone/>
-            </a:pPr>
-          </a:p>
-          <a:p>
-            <a:pPr lvl="0" indent="0" marL="0">
-              <a:buNone/>
-            </a:pPr>
-            <a:r>
-              <a:rPr/>
-              <a:t>That is the slide in one sentence: the information is real, it is entirely in the relationship between the columns, and factorising the density throws that relationship away before the model ever sees it.</a:t>
-            </a:r>
-          </a:p>
-          <a:p>
-            <a:pPr lvl="0" indent="0" marL="0">
-              <a:buNone/>
-            </a:pPr>
-          </a:p>
-          <a:p>
-            <a:pPr lvl="0" indent="0" marL="0">
-              <a:buNone/>
-            </a:pPr>
-            <a:r>
-              <a:rPr/>
-              <a:t>Worth saying that no amount of data repairs this. It is not an estimation problem - with a million rows the marginals still overlap. The model cannot represent what is being asked of it.</a:t>
+              <a:t>Measured directly, and remember the assumption concerns independence GIVEN THE CLASS - so the second and third rows are the ones that count, not the first.</a:t>
+            </a:r>
+          </a:p>
+          <a:p>
+            <a:pPr lvl="0" indent="0" marL="0">
+              <a:buNone/>
+            </a:pPr>
+          </a:p>
+          <a:p>
+            <a:pPr lvl="0" indent="0" marL="0">
+              <a:buNone/>
+            </a:pPr>
+            <a:r>
+              <a:rPr/>
+              <a:t>Within each class the two readings are essentially uncorrelated: −0.006 among healthy pumps is as close to zero as a sample of this size will ever produce. The assumption is not approximately satisfied here; it is satisfied.</a:t>
+            </a:r>
+          </a:p>
+          <a:p>
+            <a:pPr lvl="0" indent="0" marL="0">
+              <a:buNone/>
+            </a:pPr>
+          </a:p>
+          <a:p>
+            <a:pPr lvl="0" indent="0" marL="0">
+              <a:buNone/>
+            </a:pPr>
+            <a:r>
+              <a:rPr/>
+              <a:t>Say why that is more useful than the 0.933. A score tells you what happened once. Knowing WHY it happened tells you when to expect it again - and it gives them a check they can run in two lines before trusting Naive Bayes on anything.</a:t>
+            </a:r>
+          </a:p>
+          <a:p>
+            <a:pPr lvl="0" indent="0" marL="0">
+              <a:buNone/>
+            </a:pPr>
+          </a:p>
+          <a:p>
+            <a:pPr lvl="0" indent="0" marL="0">
+              <a:buNone/>
+            </a:pPr>
+            <a:r>
+              <a:rPr/>
+              <a:t>The obvious caution, since somebody will raise it: zero correlation is not independence. Correlation only detects linear dependence. For Gaussian Naive Bayes with Gaussian-ish features it is the right check; in general it is necessary and not sufficient.</a:t>
             </a:r>
           </a:p>
         </p:txBody>
@@ -3743,63 +3731,49 @@
             </a:pPr>
             <a:r>
               <a:rPr/>
-              <a:t>Two things to draw out, and the second is the more interesting.</a:t>
-            </a:r>
-          </a:p>
-          <a:p>
-            <a:pPr lvl="0" indent="0" marL="0">
-              <a:buNone/>
-            </a:pPr>
-          </a:p>
-          <a:p>
-            <a:pPr lvl="0" indent="0" marL="0">
-              <a:buNone/>
-            </a:pPr>
-            <a:r>
-              <a:rPr/>
-              <a:t>First: k-NN and the RBF SVM are at 0.967 and 0.972 on this data. The problem is not hard. It is only hard for a model that looks at one feature at a time.</a:t>
-            </a:r>
-          </a:p>
-          <a:p>
-            <a:pPr lvl="0" indent="0" marL="0">
-              <a:buNone/>
-            </a:pPr>
-          </a:p>
-          <a:p>
-            <a:pPr lvl="0" indent="0" marL="0">
-              <a:buNone/>
-            </a:pPr>
-            <a:r>
-              <a:rPr/>
-              <a:t>Second, and take the time: 0.404 is BELOW CHANCE. Below the majority baseline of 0.523, and below what you would get by flipping a coin. Ask how that is even possible - a model with no information should surely sit at 50%.</a:t>
-            </a:r>
-          </a:p>
-          <a:p>
-            <a:pPr lvl="0" indent="0" marL="0">
-              <a:buNone/>
-            </a:pPr>
-          </a:p>
-          <a:p>
-            <a:pPr lvl="0" indent="0" marL="0">
-              <a:buNone/>
-            </a:pPr>
-            <a:r>
-              <a:rPr/>
-              <a:t>The explanation is worth having in full. The class means on each sensor differ by about 0.17, against a spread near 1, purely as an artefact of a finite sample. That accident is the ONLY per-feature evidence available. Naive Bayes has nothing else to multiply, so it follows it - and in this sample it points the wrong way.</a:t>
-            </a:r>
-          </a:p>
-          <a:p>
-            <a:pPr lvl="0" indent="0" marL="0">
-              <a:buNone/>
-            </a:pPr>
-          </a:p>
-          <a:p>
-            <a:pPr lvl="0" indent="0" marL="0">
-              <a:buNone/>
-            </a:pPr>
-            <a:r>
-              <a:rPr/>
-              <a:t>The sentence to land: a model with no signal does not sit politely at 50%. It follows whatever spurious structure it can find, with complete confidence.</a:t>
+              <a:t>Change one thing about the problem and watch the method fall apart. Describe the physics before the geometry, because the rule is completely reasonable engineering.</a:t>
+            </a:r>
+          </a:p>
+          <a:p>
+            <a:pPr lvl="0" indent="0" marL="0">
+              <a:buNone/>
+            </a:pPr>
+          </a:p>
+          <a:p>
+            <a:pPr lvl="0" indent="0" marL="0">
+              <a:buNone/>
+            </a:pPr>
+            <a:r>
+              <a:rPr/>
+              <a:t>High demand and high delivery: fine, that is the machine working hard. Low and low: fine, that is idle. High demand with low delivery, or the reverse: something is wrong between them. Exactly one high means faulty.</a:t>
+            </a:r>
+          </a:p>
+          <a:p>
+            <a:pPr lvl="0" indent="0" marL="0">
+              <a:buNone/>
+            </a:pPr>
+          </a:p>
+          <a:p>
+            <a:pPr lvl="0" indent="0" marL="0">
+              <a:buNone/>
+            </a:pPr>
+            <a:r>
+              <a:rPr/>
+              <a:t>Ask them, before the picture, what each sensor tells you ON ITS OWN under that rule. Give it a moment. The answer is: nothing at all. Every value of sensor A appears in both classes about equally often, because whether it means “faulty” depends entirely on sensor B.</a:t>
+            </a:r>
+          </a:p>
+          <a:p>
+            <a:pPr lvl="0" indent="0" marL="0">
+              <a:buNone/>
+            </a:pPr>
+          </a:p>
+          <a:p>
+            <a:pPr lvl="0" indent="0" marL="0">
+              <a:buNone/>
+            </a:pPr>
+            <a:r>
+              <a:rPr/>
+              <a:t>That is what an interaction is, and it is precisely the structure the independence assumption is unable to represent. Handout section 4.4.</a:t>
             </a:r>
           </a:p>
         </p:txBody>
@@ -3881,59 +3855,49 @@
             </a:pPr>
             <a:r>
               <a:rPr/>
-              <a:t>Two numbers, four thousandths apart. The model is exactly as confident when it is wrong as when it is right, which means </a:t>
-            </a:r>
-            <a:r>
-              <a:rPr>
-                <a:latin typeface="Courier"/>
-              </a:rPr>
-              <a:t>predict_proba</a:t>
-            </a:r>
-            <a:r>
-              <a:rPr/>
-              <a:t> carries no usable information about reliability here.</a:t>
-            </a:r>
-          </a:p>
-          <a:p>
-            <a:pPr lvl="0" indent="0" marL="0">
-              <a:buNone/>
-            </a:pPr>
-          </a:p>
-          <a:p>
-            <a:pPr lvl="0" indent="0" marL="0">
-              <a:buNone/>
-            </a:pPr>
-            <a:r>
-              <a:rPr/>
-              <a:t>The more common complaint runs in the opposite direction, so give it too: when features ARE correlated, multiplying their probabilities counts the same evidence repeatedly. Ten correlated words in a document are treated as ten independent pieces of evidence, and the posterior saturates. Naive Bayes is famous for reporting 0.999 on problems it gets wrong a fifth of the time.</a:t>
-            </a:r>
-          </a:p>
-          <a:p>
-            <a:pPr lvl="0" indent="0" marL="0">
-              <a:buNone/>
-            </a:pPr>
-          </a:p>
-          <a:p>
-            <a:pPr lvl="0" indent="0" marL="0">
-              <a:buNone/>
-            </a:pPr>
-            <a:r>
-              <a:rPr/>
-              <a:t>Then lesson 5’s distinction, which this is the textbook case of: ranking and calibration are different properties. A model can order examples usefully and still report numbers that mean nothing.</a:t>
-            </a:r>
-          </a:p>
-          <a:p>
-            <a:pPr lvl="0" indent="0" marL="0">
-              <a:buNone/>
-            </a:pPr>
-          </a:p>
-          <a:p>
-            <a:pPr lvl="0" indent="0" marL="0">
-              <a:buNone/>
-            </a:pPr>
-            <a:r>
-              <a:rPr/>
-              <a:t>The practical consequence, and it is concrete: do not use Naive Bayes anywhere a calibrated probability enters a decision - including lesson 4’s cost calculation in section 7.2, where the threshold depends on the probability being real.</a:t>
+              <a:t>Left panel: the two sensors together. Four clean groups, and a perfectly learnable rule - any method that can draw a non-linear boundary will find it.</a:t>
+            </a:r>
+          </a:p>
+          <a:p>
+            <a:pPr lvl="0" indent="0" marL="0">
+              <a:buNone/>
+            </a:pPr>
+          </a:p>
+          <a:p>
+            <a:pPr lvl="0" indent="0" marL="0">
+              <a:buNone/>
+            </a:pPr>
+            <a:r>
+              <a:rPr/>
+              <a:t>Middle and right: each sensor on its own, which is ALL Naive Bayes ever gets. The two class distributions sit almost exactly on top of one another.</a:t>
+            </a:r>
+          </a:p>
+          <a:p>
+            <a:pPr lvl="0" indent="0" marL="0">
+              <a:buNone/>
+            </a:pPr>
+          </a:p>
+          <a:p>
+            <a:pPr lvl="0" indent="0" marL="0">
+              <a:buNone/>
+            </a:pPr>
+            <a:r>
+              <a:rPr/>
+              <a:t>That is the slide in one sentence: the information is real, it is entirely in the relationship between the columns, and factorising the density throws that relationship away before the model ever sees it.</a:t>
+            </a:r>
+          </a:p>
+          <a:p>
+            <a:pPr lvl="0" indent="0" marL="0">
+              <a:buNone/>
+            </a:pPr>
+          </a:p>
+          <a:p>
+            <a:pPr lvl="0" indent="0" marL="0">
+              <a:buNone/>
+            </a:pPr>
+            <a:r>
+              <a:rPr/>
+              <a:t>Worth saying that no amount of data repairs this. It is not an estimation problem - with a million rows the marginals still overlap. The model cannot represent what is being asked of it.</a:t>
             </a:r>
           </a:p>
         </p:txBody>
@@ -4015,49 +3979,63 @@
             </a:pPr>
             <a:r>
               <a:rPr/>
-              <a:t>Run notebooks/02. Eighteen minutes.</a:t>
-            </a:r>
-          </a:p>
-          <a:p>
-            <a:pPr lvl="0" indent="0" marL="0">
-              <a:buNone/>
-            </a:pPr>
-          </a:p>
-          <a:p>
-            <a:pPr lvl="0" indent="0" marL="0">
-              <a:buNone/>
-            </a:pPr>
-            <a:r>
-              <a:rPr/>
-              <a:t>The cell to protect is the one that prints 0.404 next to the 0.523 baseline. Let them see a below-chance score appear from correct code on solvable data before any explanation arrives.</a:t>
-            </a:r>
-          </a:p>
-          <a:p>
-            <a:pPr lvl="0" indent="0" marL="0">
-              <a:buNone/>
-            </a:pPr>
-          </a:p>
-          <a:p>
-            <a:pPr lvl="0" indent="0" marL="0">
-              <a:buNone/>
-            </a:pPr>
-            <a:r>
-              <a:rPr/>
-              <a:t>Have them compute the within-class correlations themselves on both datasets. Two lines, and it is the diagnostic they should carry: measure the assumption, do not assume it.</a:t>
-            </a:r>
-          </a:p>
-          <a:p>
-            <a:pPr lvl="0" indent="0" marL="0">
-              <a:buNone/>
-            </a:pPr>
-          </a:p>
-          <a:p>
-            <a:pPr lvl="0" indent="0" marL="0">
-              <a:buNone/>
-            </a:pPr>
-            <a:r>
-              <a:rPr/>
-              <a:t>If time allows, the interesting exercise is to hand Naive Bayes the product of the two sensors as a third column and watch it recover. That is the whole story of feature engineering versus model choice in one cell.</a:t>
+              <a:t>Two things to draw out, and the second is the more interesting.</a:t>
+            </a:r>
+          </a:p>
+          <a:p>
+            <a:pPr lvl="0" indent="0" marL="0">
+              <a:buNone/>
+            </a:pPr>
+          </a:p>
+          <a:p>
+            <a:pPr lvl="0" indent="0" marL="0">
+              <a:buNone/>
+            </a:pPr>
+            <a:r>
+              <a:rPr/>
+              <a:t>First: k-NN and the RBF SVM are at 0.967 and 0.972 on this data. The problem is not hard. It is only hard for a model that looks at one feature at a time.</a:t>
+            </a:r>
+          </a:p>
+          <a:p>
+            <a:pPr lvl="0" indent="0" marL="0">
+              <a:buNone/>
+            </a:pPr>
+          </a:p>
+          <a:p>
+            <a:pPr lvl="0" indent="0" marL="0">
+              <a:buNone/>
+            </a:pPr>
+            <a:r>
+              <a:rPr/>
+              <a:t>Second, and take the time: 0.404 is BELOW CHANCE. Below the majority baseline of 0.523, and below what you would get by flipping a coin. Ask how that is even possible - a model with no information should surely sit at 50%.</a:t>
+            </a:r>
+          </a:p>
+          <a:p>
+            <a:pPr lvl="0" indent="0" marL="0">
+              <a:buNone/>
+            </a:pPr>
+          </a:p>
+          <a:p>
+            <a:pPr lvl="0" indent="0" marL="0">
+              <a:buNone/>
+            </a:pPr>
+            <a:r>
+              <a:rPr/>
+              <a:t>The explanation is worth having in full. The class means on each sensor differ by about 0.17, against a spread near 1, purely as an artefact of a finite sample. That accident is the ONLY per-feature evidence available. Naive Bayes has nothing else to multiply, so it follows it - and in this sample it points the wrong way.</a:t>
+            </a:r>
+          </a:p>
+          <a:p>
+            <a:pPr lvl="0" indent="0" marL="0">
+              <a:buNone/>
+            </a:pPr>
+          </a:p>
+          <a:p>
+            <a:pPr lvl="0" indent="0" marL="0">
+              <a:buNone/>
+            </a:pPr>
+            <a:r>
+              <a:rPr/>
+              <a:t>The sentence to land: a model with no signal does not sit politely at 50%. It follows whatever spurious structure it can find, with complete confidence.</a:t>
             </a:r>
           </a:p>
         </p:txBody>
@@ -4139,49 +4117,59 @@
             </a:pPr>
             <a:r>
               <a:rPr/>
-              <a:t>Start with the problem rather than the solution. Draw two well-separated blobs on the board and ask for the boundary. Somebody will draw a line. Ask whether another line would have been equally good, and keep asking until the room sees that there are infinitely many, all with identical training error.</a:t>
-            </a:r>
-          </a:p>
-          <a:p>
-            <a:pPr lvl="0" indent="0" marL="0">
-              <a:buNone/>
-            </a:pPr>
-          </a:p>
-          <a:p>
-            <a:pPr lvl="0" indent="0" marL="0">
-              <a:buNone/>
-            </a:pPr>
-            <a:r>
-              <a:rPr/>
-              <a:t>So the error cannot decide. Something else has to. Logistic regression breaks the tie with log loss - a perfectly respectable answer, and one answer among several. The SVM breaks it differently: take the boundary with the most room around it.</a:t>
-            </a:r>
-          </a:p>
-          <a:p>
-            <a:pPr lvl="0" indent="0" marL="0">
-              <a:buNone/>
-            </a:pPr>
-          </a:p>
-          <a:p>
-            <a:pPr lvl="0" indent="0" marL="0">
-              <a:buNone/>
-            </a:pPr>
-            <a:r>
-              <a:rPr/>
-              <a:t>The intuition, and this is the sentence to say slowly: maximising the distance to the closest points chooses the boundary that tolerates the most movement in the data before it changes its mind. That is a statement about GENERALISATION, not about fit - which is unusual, because almost everything else in this course optimises fit and controls generalisation indirectly.</a:t>
-            </a:r>
-          </a:p>
-          <a:p>
-            <a:pPr lvl="0" indent="0" marL="0">
-              <a:buNone/>
-            </a:pPr>
-          </a:p>
-          <a:p>
-            <a:pPr lvl="0" indent="0" marL="0">
-              <a:buNone/>
-            </a:pPr>
-            <a:r>
-              <a:rPr/>
-              <a:t>Handout section 5.1.</a:t>
+              <a:t>Two numbers, four thousandths apart. The model is exactly as confident when it is wrong as when it is right, which means </a:t>
+            </a:r>
+            <a:r>
+              <a:rPr>
+                <a:latin typeface="Courier"/>
+              </a:rPr>
+              <a:t>predict_proba</a:t>
+            </a:r>
+            <a:r>
+              <a:rPr/>
+              <a:t> carries no usable information about reliability here.</a:t>
+            </a:r>
+          </a:p>
+          <a:p>
+            <a:pPr lvl="0" indent="0" marL="0">
+              <a:buNone/>
+            </a:pPr>
+          </a:p>
+          <a:p>
+            <a:pPr lvl="0" indent="0" marL="0">
+              <a:buNone/>
+            </a:pPr>
+            <a:r>
+              <a:rPr/>
+              <a:t>The more common complaint runs in the opposite direction, so give it too: when features ARE correlated, multiplying their probabilities counts the same evidence repeatedly. Ten correlated words in a document are treated as ten independent pieces of evidence, and the posterior saturates. Naive Bayes is famous for reporting 0.999 on problems it gets wrong a fifth of the time.</a:t>
+            </a:r>
+          </a:p>
+          <a:p>
+            <a:pPr lvl="0" indent="0" marL="0">
+              <a:buNone/>
+            </a:pPr>
+          </a:p>
+          <a:p>
+            <a:pPr lvl="0" indent="0" marL="0">
+              <a:buNone/>
+            </a:pPr>
+            <a:r>
+              <a:rPr/>
+              <a:t>Then lesson 5’s distinction, which this is the textbook case of: ranking and calibration are different properties. A model can order examples usefully and still report numbers that mean nothing.</a:t>
+            </a:r>
+          </a:p>
+          <a:p>
+            <a:pPr lvl="0" indent="0" marL="0">
+              <a:buNone/>
+            </a:pPr>
+          </a:p>
+          <a:p>
+            <a:pPr lvl="0" indent="0" marL="0">
+              <a:buNone/>
+            </a:pPr>
+            <a:r>
+              <a:rPr/>
+              <a:t>The practical consequence, and it is concrete: do not use Naive Bayes anywhere a calibrated probability enters a decision - including lesson 4’s cost calculation in section 7.2, where the threshold depends on the probability being real.</a:t>
             </a:r>
           </a:p>
         </p:txBody>
@@ -4263,49 +4251,49 @@
             </a:pPr>
             <a:r>
               <a:rPr/>
-              <a:t>The solid line is the boundary, the dashed lines are the edges of the slab, and the circled points are the support vectors touching it.</a:t>
-            </a:r>
-          </a:p>
-          <a:p>
-            <a:pPr lvl="0" indent="0" marL="0">
-              <a:buNone/>
-            </a:pPr>
-          </a:p>
-          <a:p>
-            <a:pPr lvl="0" indent="0" marL="0">
-              <a:buNone/>
-            </a:pPr>
-            <a:r>
-              <a:rPr/>
-              <a:t>The number to say out loud: of eighty points, THREE determine the answer. Move any of the other seventy-seven - anywhere, as far as you like, as long as they stay outside the slab - and the boundary does not shift by a millimetre.</a:t>
-            </a:r>
-          </a:p>
-          <a:p>
-            <a:pPr lvl="0" indent="0" marL="0">
-              <a:buNone/>
-            </a:pPr>
-          </a:p>
-          <a:p>
-            <a:pPr lvl="0" indent="0" marL="0">
-              <a:buNone/>
-            </a:pPr>
-            <a:r>
-              <a:rPr/>
-              <a:t>That is where the name comes from, and it is a genuinely different idea from anything so far. Every linear model in lessons 3 and 4 used every row: each one contributed to the gradient in proportion to its error. Here most of the data is irrelevant once the fit is done.</a:t>
-            </a:r>
-          </a:p>
-          <a:p>
-            <a:pPr lvl="0" indent="0" marL="0">
-              <a:buNone/>
-            </a:pPr>
-          </a:p>
-          <a:p>
-            <a:pPr lvl="0" indent="0" marL="0">
-              <a:buNone/>
-            </a:pPr>
-            <a:r>
-              <a:rPr/>
-              <a:t>Two consequences worth naming. The model is small - you store the support vectors, not the dataset, which is the contrast with k-NN. And it is sensitive in a specific way: an outlier near the boundary matters enormously, while an outlier far from it matters not at all.</a:t>
+              <a:t>Run notebooks/02. Sixteen minutes.</a:t>
+            </a:r>
+          </a:p>
+          <a:p>
+            <a:pPr lvl="0" indent="0" marL="0">
+              <a:buNone/>
+            </a:pPr>
+          </a:p>
+          <a:p>
+            <a:pPr lvl="0" indent="0" marL="0">
+              <a:buNone/>
+            </a:pPr>
+            <a:r>
+              <a:rPr/>
+              <a:t>The cell to protect is the one that prints 0.404 next to the 0.523 baseline. Let them see a below-chance score appear from correct code on solvable data before any explanation arrives.</a:t>
+            </a:r>
+          </a:p>
+          <a:p>
+            <a:pPr lvl="0" indent="0" marL="0">
+              <a:buNone/>
+            </a:pPr>
+          </a:p>
+          <a:p>
+            <a:pPr lvl="0" indent="0" marL="0">
+              <a:buNone/>
+            </a:pPr>
+            <a:r>
+              <a:rPr/>
+              <a:t>The notebook prints the within-class correlations on both datasets. Before that cell runs, ask them to predict the signs for the interacting sensors: it is the diagnostic they should carry - measure the assumption, do not assume it.</a:t>
+            </a:r>
+          </a:p>
+          <a:p>
+            <a:pPr lvl="0" indent="0" marL="0">
+              <a:buNone/>
+            </a:pPr>
+          </a:p>
+          <a:p>
+            <a:pPr lvl="0" indent="0" marL="0">
+              <a:buNone/>
+            </a:pPr>
+            <a:r>
+              <a:rPr/>
+              <a:t>If time allows, the interesting exercise is to hand Naive Bayes the product of the two sensors as a third column and watch it recover. That is the whole story of feature engineering versus model choice in one cell.</a:t>
             </a:r>
           </a:p>
         </p:txBody>
@@ -4387,35 +4375,49 @@
             </a:pPr>
             <a:r>
               <a:rPr/>
-              <a:t>The point worth stressing is why the soft margin is not a patch or a convenience. With even one mislabelled point inside the other class, the strict problem is INFEASIBLE - there is no solution, not a bad one. Real data always contains such points. So the soft margin is the only version anyone ever runs; the hard-margin problem is a teaching device.</a:t>
-            </a:r>
-          </a:p>
-          <a:p>
-            <a:pPr lvl="0" indent="0" marL="0">
-              <a:buNone/>
-            </a:pPr>
-          </a:p>
-          <a:p>
-            <a:pPr lvl="0" indent="0" marL="0">
-              <a:buNone/>
-            </a:pPr>
-            <a:r>
-              <a:rPr/>
-              <a:t>Our own labels are flipped at 4%, deliberately, so this is not a hypothetical for this dataset: the hard-margin problem on these pumps has no answer.</a:t>
-            </a:r>
-          </a:p>
-          <a:p>
-            <a:pPr lvl="0" indent="0" marL="0">
-              <a:buNone/>
-            </a:pPr>
-          </a:p>
-          <a:p>
-            <a:pPr lvl="0" indent="0" marL="0">
-              <a:buNone/>
-            </a:pPr>
-            <a:r>
-              <a:rPr/>
-              <a:t>The next slide puts it in symbols. Handout section 5.2 has the derivation.</a:t>
+              <a:t>Start with the problem rather than the solution. Draw two well-separated blobs on the board and ask for the boundary. Somebody will draw a line. Ask whether another line would have been equally good, and keep asking until the room sees that there are infinitely many, all with identical training error.</a:t>
+            </a:r>
+          </a:p>
+          <a:p>
+            <a:pPr lvl="0" indent="0" marL="0">
+              <a:buNone/>
+            </a:pPr>
+          </a:p>
+          <a:p>
+            <a:pPr lvl="0" indent="0" marL="0">
+              <a:buNone/>
+            </a:pPr>
+            <a:r>
+              <a:rPr/>
+              <a:t>So the error cannot decide. Something else has to. Logistic regression breaks the tie with log loss - a perfectly respectable answer, and one answer among several. The SVM breaks it differently: take the boundary with the most room around it.</a:t>
+            </a:r>
+          </a:p>
+          <a:p>
+            <a:pPr lvl="0" indent="0" marL="0">
+              <a:buNone/>
+            </a:pPr>
+          </a:p>
+          <a:p>
+            <a:pPr lvl="0" indent="0" marL="0">
+              <a:buNone/>
+            </a:pPr>
+            <a:r>
+              <a:rPr/>
+              <a:t>The intuition, and this is the sentence to say slowly: maximising the distance to the closest points chooses the boundary that tolerates the most movement in the data before it changes its mind. That is a statement about GENERALISATION, not about fit - which is unusual, because almost everything else in this course optimises fit and controls generalisation indirectly.</a:t>
+            </a:r>
+          </a:p>
+          <a:p>
+            <a:pPr lvl="0" indent="0" marL="0">
+              <a:buNone/>
+            </a:pPr>
+          </a:p>
+          <a:p>
+            <a:pPr lvl="0" indent="0" marL="0">
+              <a:buNone/>
+            </a:pPr>
+            <a:r>
+              <a:rPr/>
+              <a:t>Handout section 5.1.</a:t>
             </a:r>
           </a:p>
         </p:txBody>
@@ -4497,49 +4499,49 @@
             </a:pPr>
             <a:r>
               <a:rPr/>
-              <a:t>The constraint is not on the slide any more - it made the line wide enough to land at 28pt - so state it: subject to y_i(w’x_i + b) &gt;= 1 - xi_i, every point on the right side of the slab by a margin, or paying xi_i for the shortfall. Handout section 5.2 writes it out.</a:t>
-            </a:r>
-          </a:p>
-          <a:p>
-            <a:pPr lvl="0" indent="0" marL="0">
-              <a:buNone/>
-            </a:pPr>
-          </a:p>
-          <a:p>
-            <a:pPr lvl="0" indent="0" marL="0">
-              <a:buNone/>
-            </a:pPr>
-            <a:r>
-              <a:rPr/>
-              <a:t>Do not derive this. State what each piece is doing and move on - handout section 5.2 has the derivation, including why maximising the margin is the same as minimising the norm of w.</a:t>
-            </a:r>
-          </a:p>
-          <a:p>
-            <a:pPr lvl="0" indent="0" marL="0">
-              <a:buNone/>
-            </a:pPr>
-          </a:p>
-          <a:p>
-            <a:pPr lvl="0" indent="0" marL="0">
-              <a:buNone/>
-            </a:pPr>
-            <a:r>
-              <a:rPr/>
-              <a:t>The first term wants a wide slab. The second term wants few violations. C sets the exchange rate between them, and that is the entire content of the expression. Read it out in those words rather than reading the symbols.</a:t>
-            </a:r>
-          </a:p>
-          <a:p>
-            <a:pPr lvl="0" indent="0" marL="0">
-              <a:buNone/>
-            </a:pPr>
-          </a:p>
-          <a:p>
-            <a:pPr lvl="0" indent="0" marL="0">
-              <a:buNone/>
-            </a:pPr>
-            <a:r>
-              <a:rPr/>
-              <a:t>If someone asks about the half in front of the norm: it is there to make the derivative tidy, exactly as in lesson 3’s cost function.</a:t>
+              <a:t>The solid line is the boundary, the dashed lines are the edges of the slab, and the circled points are the support vectors touching it.</a:t>
+            </a:r>
+          </a:p>
+          <a:p>
+            <a:pPr lvl="0" indent="0" marL="0">
+              <a:buNone/>
+            </a:pPr>
+          </a:p>
+          <a:p>
+            <a:pPr lvl="0" indent="0" marL="0">
+              <a:buNone/>
+            </a:pPr>
+            <a:r>
+              <a:rPr/>
+              <a:t>The number to say out loud: of eighty points, THREE determine the answer. Move any of the other seventy-seven - anywhere, as far as you like, as long as they stay outside the slab - and the boundary does not shift by a millimetre.</a:t>
+            </a:r>
+          </a:p>
+          <a:p>
+            <a:pPr lvl="0" indent="0" marL="0">
+              <a:buNone/>
+            </a:pPr>
+          </a:p>
+          <a:p>
+            <a:pPr lvl="0" indent="0" marL="0">
+              <a:buNone/>
+            </a:pPr>
+            <a:r>
+              <a:rPr/>
+              <a:t>That is where the name comes from, and it is a genuinely different idea from anything so far. Every linear model in lessons 3 and 4 used every row: each one contributed to the gradient in proportion to its error. Here most of the data is irrelevant once the fit is done.</a:t>
+            </a:r>
+          </a:p>
+          <a:p>
+            <a:pPr lvl="0" indent="0" marL="0">
+              <a:buNone/>
+            </a:pPr>
+          </a:p>
+          <a:p>
+            <a:pPr lvl="0" indent="0" marL="0">
+              <a:buNone/>
+            </a:pPr>
+            <a:r>
+              <a:rPr/>
+              <a:t>Two consequences worth naming. The model is small - you store the support vectors, not the dataset, which is the contrast with k-NN. And it is sensitive in a specific way: an outlier near the boundary matters enormously, while an outlier far from it matters not at all.</a:t>
             </a:r>
           </a:p>
         </p:txBody>
@@ -4745,55 +4747,35 @@
             </a:pPr>
             <a:r>
               <a:rPr/>
-              <a:t>Third appearance of the same idea, and say so - that repetition is the point. Lesson 3 had λ, this morning had k, now C. Every model has one knob that trades fitting this data against surviving the next, and recognising it in an unfamiliar model is worth more than memorising three names.</a:t>
-            </a:r>
-          </a:p>
-          <a:p>
-            <a:pPr lvl="0" indent="0" marL="0">
-              <a:buNone/>
-            </a:pPr>
-          </a:p>
-          <a:p>
-            <a:pPr lvl="0" indent="0" marL="0">
-              <a:buNone/>
-            </a:pPr>
-            <a:r>
-              <a:rPr/>
-              <a:t>Then the direction, which catches people out constantly and is worth writing on the board. Large λ means MORE regularisation. Large C means LESS. They run opposite ways, and scikit-learn’s </a:t>
-            </a:r>
-            <a:r>
-              <a:rPr>
-                <a:latin typeface="Courier"/>
-              </a:rPr>
-              <a:t>C</a:t>
-            </a:r>
-            <a:r>
-              <a:rPr/>
-              <a:t> parameter in </a:t>
-            </a:r>
-            <a:r>
-              <a:rPr>
-                <a:latin typeface="Courier"/>
-              </a:rPr>
-              <a:t>LogisticRegression</a:t>
-            </a:r>
-            <a:r>
-              <a:rPr/>
-              <a:t> has the same inverted convention - it is the reciprocal of the penalty there too.</a:t>
-            </a:r>
-          </a:p>
-          <a:p>
-            <a:pPr lvl="0" indent="0" marL="0">
-              <a:buNone/>
-            </a:pPr>
-          </a:p>
-          <a:p>
-            <a:pPr lvl="0" indent="0" marL="0">
-              <a:buNone/>
-            </a:pPr>
-            <a:r>
-              <a:rPr/>
-              <a:t>Ask them which way they would expect C to run before you tell them. Most guess wrong, and having guessed wrong once is what makes it stick.</a:t>
+              <a:t>The point worth stressing is why the soft margin is not a patch or a convenience. With even one mislabelled point inside the other class, the strict problem is INFEASIBLE - there is no solution, not a bad one. Real data always contains such points. So the soft margin is the only version anyone ever runs; the hard-margin problem is a teaching device.</a:t>
+            </a:r>
+          </a:p>
+          <a:p>
+            <a:pPr lvl="0" indent="0" marL="0">
+              <a:buNone/>
+            </a:pPr>
+          </a:p>
+          <a:p>
+            <a:pPr lvl="0" indent="0" marL="0">
+              <a:buNone/>
+            </a:pPr>
+            <a:r>
+              <a:rPr/>
+              <a:t>Our own labels are flipped at 4%, deliberately, so this is not a hypothetical for this dataset: the hard-margin problem on these pumps has no answer.</a:t>
+            </a:r>
+          </a:p>
+          <a:p>
+            <a:pPr lvl="0" indent="0" marL="0">
+              <a:buNone/>
+            </a:pPr>
+          </a:p>
+          <a:p>
+            <a:pPr lvl="0" indent="0" marL="0">
+              <a:buNone/>
+            </a:pPr>
+            <a:r>
+              <a:rPr/>
+              <a:t>The next slide puts it in symbols. Handout section 5.2 has the derivation.</a:t>
             </a:r>
           </a:p>
         </p:txBody>
@@ -4875,49 +4857,49 @@
             </a:pPr>
             <a:r>
               <a:rPr/>
-              <a:t>The linear kernel scores 0.613 - the base rate, exactly as logistic regression did this morning, with the same zero variance across folds.</a:t>
-            </a:r>
-          </a:p>
-          <a:p>
-            <a:pPr lvl="0" indent="0" marL="0">
-              <a:buNone/>
-            </a:pPr>
-          </a:p>
-          <a:p>
-            <a:pPr lvl="0" indent="0" marL="0">
-              <a:buNone/>
-            </a:pPr>
-            <a:r>
-              <a:rPr/>
-              <a:t>Make the point explicitly, because it is the one students most often get backwards: the margin criterion is a better way of CHOOSING among straight lines. It does not give you anything other than a straight line. When no straight line works, choosing the best one optimally still gets you nothing. A better criterion cannot rescue an inadequate hypothesis class.</a:t>
-            </a:r>
-          </a:p>
-          <a:p>
-            <a:pPr lvl="0" indent="0" marL="0">
-              <a:buNone/>
-            </a:pPr>
-          </a:p>
-          <a:p>
-            <a:pPr lvl="0" indent="0" marL="0">
-              <a:buNone/>
-            </a:pPr>
-            <a:r>
-              <a:rPr/>
-              <a:t>Then the RBF row, which is the same algorithm with one argument changed, at 0.947 - the best number in the whole lesson, and within a hair of the 0.96 ceiling.</a:t>
-            </a:r>
-          </a:p>
-          <a:p>
-            <a:pPr lvl="0" indent="0" marL="0">
-              <a:buNone/>
-            </a:pPr>
-          </a:p>
-          <a:p>
-            <a:pPr lvl="0" indent="0" marL="0">
-              <a:buNone/>
-            </a:pPr>
-            <a:r>
-              <a:rPr/>
-              <a:t>The support-vector column says the same thing in a second language, and that is the next slide.</a:t>
+              <a:t>The constraint is not on the slide any more - it made the line wide enough to land at 28pt - so state it: subject to y_i(w’x_i + b) &gt;= 1 - xi_i, every point on the right side of the slab by a margin, or paying xi_i for the shortfall. Handout section 5.2 writes it out.</a:t>
+            </a:r>
+          </a:p>
+          <a:p>
+            <a:pPr lvl="0" indent="0" marL="0">
+              <a:buNone/>
+            </a:pPr>
+          </a:p>
+          <a:p>
+            <a:pPr lvl="0" indent="0" marL="0">
+              <a:buNone/>
+            </a:pPr>
+            <a:r>
+              <a:rPr/>
+              <a:t>Do not derive this. State what each piece is doing and move on - handout section 5.2 has the derivation, including why maximising the margin is the same as minimising the norm of w.</a:t>
+            </a:r>
+          </a:p>
+          <a:p>
+            <a:pPr lvl="0" indent="0" marL="0">
+              <a:buNone/>
+            </a:pPr>
+          </a:p>
+          <a:p>
+            <a:pPr lvl="0" indent="0" marL="0">
+              <a:buNone/>
+            </a:pPr>
+            <a:r>
+              <a:rPr/>
+              <a:t>The first term wants a wide slab. The second term wants few violations. C sets the exchange rate between them, and that is the entire content of the expression. Read it out in those words rather than reading the symbols.</a:t>
+            </a:r>
+          </a:p>
+          <a:p>
+            <a:pPr lvl="0" indent="0" marL="0">
+              <a:buNone/>
+            </a:pPr>
+          </a:p>
+          <a:p>
+            <a:pPr lvl="0" indent="0" marL="0">
+              <a:buNone/>
+            </a:pPr>
+            <a:r>
+              <a:rPr/>
+              <a:t>If someone asks about the half in front of the norm: it is there to make the derivative tidy, exactly as in lesson 3’s cost function.</a:t>
             </a:r>
           </a:p>
         </p:txBody>
@@ -4999,59 +4981,55 @@
             </a:pPr>
             <a:r>
               <a:rPr/>
-              <a:t>Explain what 79% actually means geometrically. A support vector is a point on the margin or inside it. If 79% of your data is in that position, there is no region of empty space between the classes at all - the model has been forced to place a boundary through a crowd.</a:t>
-            </a:r>
-          </a:p>
-          <a:p>
-            <a:pPr lvl="0" indent="0" marL="0">
-              <a:buNone/>
-            </a:pPr>
-          </a:p>
-          <a:p>
-            <a:pPr lvl="0" indent="0" marL="0">
-              <a:buNone/>
-            </a:pPr>
-            <a:r>
-              <a:rPr/>
-              <a:t>Contrast with 23%, where the model found genuine room and only the points near the edge matter.</a:t>
-            </a:r>
-          </a:p>
-          <a:p>
-            <a:pPr lvl="0" indent="0" marL="0">
-              <a:buNone/>
-            </a:pPr>
-          </a:p>
-          <a:p>
-            <a:pPr lvl="0" indent="0" marL="0">
-              <a:buNone/>
-            </a:pPr>
-            <a:r>
-              <a:rPr/>
-              <a:t>Give them the diagnostic to keep, since it costs nothing: after fitting an SVM, look at </a:t>
+              <a:t>Third appearance of the same idea, and say so - that repetition is the point. Lesson 3 had λ, this morning had k, now C. Every model has one knob that trades fitting this data against surviving the next, and recognising it in an unfamiliar model is worth more than memorising three names.</a:t>
+            </a:r>
+          </a:p>
+          <a:p>
+            <a:pPr lvl="0" indent="0" marL="0">
+              <a:buNone/>
+            </a:pPr>
+          </a:p>
+          <a:p>
+            <a:pPr lvl="0" indent="0" marL="0">
+              <a:buNone/>
+            </a:pPr>
+            <a:r>
+              <a:rPr/>
+              <a:t>Then the direction, which catches people out constantly and is worth writing on the board. Large λ means MORE regularisation. Large C means LESS. They run opposite ways, and scikit-learn’s </a:t>
             </a:r>
             <a:r>
               <a:rPr>
                 <a:latin typeface="Courier"/>
               </a:rPr>
-              <a:t>len(model.support_)</a:t>
-            </a:r>
-            <a:r>
-              <a:rPr/>
-              <a:t> over the number of training rows. High means the model is struggling to find room, which usually means the kernel is wrong for the geometry. It is a warning available BEFORE you cross-validate anything.</a:t>
-            </a:r>
-          </a:p>
-          <a:p>
-            <a:pPr lvl="0" indent="0" marL="0">
-              <a:buNone/>
-            </a:pPr>
-          </a:p>
-          <a:p>
-            <a:pPr lvl="0" indent="0" marL="0">
-              <a:buNone/>
-            </a:pPr>
-            <a:r>
-              <a:rPr/>
-              <a:t>Worth adding that it also predicts prediction cost - every support vector is one kernel evaluation per query, so a model needing 79% of the data has thrown away most of the speed advantage over k-NN.</a:t>
+              <a:t>C</a:t>
+            </a:r>
+            <a:r>
+              <a:rPr/>
+              <a:t> parameter in </a:t>
+            </a:r>
+            <a:r>
+              <a:rPr>
+                <a:latin typeface="Courier"/>
+              </a:rPr>
+              <a:t>LogisticRegression</a:t>
+            </a:r>
+            <a:r>
+              <a:rPr/>
+              <a:t> has the same inverted convention - it is the reciprocal of the penalty there too.</a:t>
+            </a:r>
+          </a:p>
+          <a:p>
+            <a:pPr lvl="0" indent="0" marL="0">
+              <a:buNone/>
+            </a:pPr>
+          </a:p>
+          <a:p>
+            <a:pPr lvl="0" indent="0" marL="0">
+              <a:buNone/>
+            </a:pPr>
+            <a:r>
+              <a:rPr/>
+              <a:t>Ask them which way they would expect C to run before you tell them. Most guess wrong, and having guessed wrong once is what makes it stick.</a:t>
             </a:r>
           </a:p>
         </p:txBody>
@@ -5133,49 +5111,49 @@
             </a:pPr>
             <a:r>
               <a:rPr/>
-              <a:t>Build the picture in words first and let them see it before the figure appears. Take the scatter plot from the start of the lesson, lift each point off the page by its distance from the centre, and look from the side.</a:t>
-            </a:r>
-          </a:p>
-          <a:p>
-            <a:pPr lvl="0" indent="0" marL="0">
-              <a:buNone/>
-            </a:pPr>
-          </a:p>
-          <a:p>
-            <a:pPr lvl="0" indent="0" marL="0">
-              <a:buNone/>
-            </a:pPr>
-            <a:r>
-              <a:rPr/>
-              <a:t>Then the sentence that reframes the whole afternoon: the classes were never inseparable. Separability is not a property of the data - it is a property of the data AND the coordinates you happen to have measured it in.</a:t>
-            </a:r>
-          </a:p>
-          <a:p>
-            <a:pPr lvl="0" indent="0" marL="0">
-              <a:buNone/>
-            </a:pPr>
-          </a:p>
-          <a:p>
-            <a:pPr lvl="0" indent="0" marL="0">
-              <a:buNone/>
-            </a:pPr>
-            <a:r>
-              <a:rPr/>
-              <a:t>Ask what is unsatisfying about what we just did, and wait for it. We chose that lift by already knowing the answer. We knew the fault mode was radial. In any real problem you do not, and inventing the right coordinate is the hard part - which is exactly the difficulty the kernel trick removes.</a:t>
-            </a:r>
-          </a:p>
-          <a:p>
-            <a:pPr lvl="0" indent="0" marL="0">
-              <a:buNone/>
-            </a:pPr>
-          </a:p>
-          <a:p>
-            <a:pPr lvl="0" indent="0" marL="0">
-              <a:buNone/>
-            </a:pPr>
-            <a:r>
-              <a:rPr/>
-              <a:t>Handout section 5.4.</a:t>
+              <a:t>The linear kernel scores 0.613 - the base rate, exactly as logistic regression did this morning, with the same zero variance across folds.</a:t>
+            </a:r>
+          </a:p>
+          <a:p>
+            <a:pPr lvl="0" indent="0" marL="0">
+              <a:buNone/>
+            </a:pPr>
+          </a:p>
+          <a:p>
+            <a:pPr lvl="0" indent="0" marL="0">
+              <a:buNone/>
+            </a:pPr>
+            <a:r>
+              <a:rPr/>
+              <a:t>Make the point explicitly, because it is the one students most often get backwards: the margin criterion is a better way of CHOOSING among straight lines. It does not give you anything other than a straight line. When no straight line works, choosing the best one optimally still gets you nothing. A better criterion cannot rescue an inadequate hypothesis class.</a:t>
+            </a:r>
+          </a:p>
+          <a:p>
+            <a:pPr lvl="0" indent="0" marL="0">
+              <a:buNone/>
+            </a:pPr>
+          </a:p>
+          <a:p>
+            <a:pPr lvl="0" indent="0" marL="0">
+              <a:buNone/>
+            </a:pPr>
+            <a:r>
+              <a:rPr/>
+              <a:t>Then the RBF row, which is the same algorithm with one argument changed, at 0.947 - the best number in the whole lesson, and within a hair of the 0.96 ceiling.</a:t>
+            </a:r>
+          </a:p>
+          <a:p>
+            <a:pPr lvl="0" indent="0" marL="0">
+              <a:buNone/>
+            </a:pPr>
+          </a:p>
+          <a:p>
+            <a:pPr lvl="0" indent="0" marL="0">
+              <a:buNone/>
+            </a:pPr>
+            <a:r>
+              <a:rPr/>
+              <a:t>The support-vector column says the same thing in a second language, and that is the next slide.</a:t>
             </a:r>
           </a:p>
         </p:txBody>
@@ -5257,35 +5235,59 @@
             </a:pPr>
             <a:r>
               <a:rPr/>
-              <a:t>The same 1,200 pumps twice: on the left in the plane where they were measured, on the right lifted by their distance from the design point. The gold plane does what no line could.</a:t>
-            </a:r>
-          </a:p>
-          <a:p>
-            <a:pPr lvl="0" indent="0" marL="0">
-              <a:buNone/>
-            </a:pPr>
-          </a:p>
-          <a:p>
-            <a:pPr lvl="0" indent="0" marL="0">
-              <a:buNone/>
-            </a:pPr>
-            <a:r>
-              <a:rPr/>
-              <a:t>Have them look at the right panel and confirm for themselves that a flat horizontal cut separates the colours cleanly. Nothing was added - no new measurement, no extra sensor. The third coordinate is computed from the two they already had.</a:t>
-            </a:r>
-          </a:p>
-          <a:p>
-            <a:pPr lvl="0" indent="0" marL="0">
-              <a:buNone/>
-            </a:pPr>
-          </a:p>
-          <a:p>
-            <a:pPr lvl="0" indent="0" marL="0">
-              <a:buNone/>
-            </a:pPr>
-            <a:r>
-              <a:rPr/>
-              <a:t>Then set up the objection that the next slide answers. This worked because the lift was three-dimensional and we could guess it. The spaces that work in general are enormous - the useful ones are sometimes infinite-dimensional - and computing the coordinates of every point in such a space is impossible.</a:t>
+              <a:t>Explain what 79% actually means geometrically. A support vector is a point on the margin or inside it. If 79% of your data is in that position, there is no region of empty space between the classes at all - the model has been forced to place a boundary through a crowd.</a:t>
+            </a:r>
+          </a:p>
+          <a:p>
+            <a:pPr lvl="0" indent="0" marL="0">
+              <a:buNone/>
+            </a:pPr>
+          </a:p>
+          <a:p>
+            <a:pPr lvl="0" indent="0" marL="0">
+              <a:buNone/>
+            </a:pPr>
+            <a:r>
+              <a:rPr/>
+              <a:t>Contrast with 23%, where the model found genuine room and only the points near the edge matter.</a:t>
+            </a:r>
+          </a:p>
+          <a:p>
+            <a:pPr lvl="0" indent="0" marL="0">
+              <a:buNone/>
+            </a:pPr>
+          </a:p>
+          <a:p>
+            <a:pPr lvl="0" indent="0" marL="0">
+              <a:buNone/>
+            </a:pPr>
+            <a:r>
+              <a:rPr/>
+              <a:t>Give them the diagnostic to keep, since it costs nothing: after fitting an SVM, look at </a:t>
+            </a:r>
+            <a:r>
+              <a:rPr>
+                <a:latin typeface="Courier"/>
+              </a:rPr>
+              <a:t>len(model.support_)</a:t>
+            </a:r>
+            <a:r>
+              <a:rPr/>
+              <a:t> over the number of training rows. High means the model is struggling to find room, which usually means the kernel is wrong for the geometry. It is a warning available BEFORE you cross-validate anything.</a:t>
+            </a:r>
+          </a:p>
+          <a:p>
+            <a:pPr lvl="0" indent="0" marL="0">
+              <a:buNone/>
+            </a:pPr>
+          </a:p>
+          <a:p>
+            <a:pPr lvl="0" indent="0" marL="0">
+              <a:buNone/>
+            </a:pPr>
+            <a:r>
+              <a:rPr/>
+              <a:t>Worth adding that it also predicts prediction cost - every support vector is one kernel evaluation per query, so a model needing 79% of the data has thrown away most of the speed advantage over k-NN.</a:t>
             </a:r>
           </a:p>
         </p:txBody>
@@ -5367,35 +5369,49 @@
             </a:pPr>
             <a:r>
               <a:rPr/>
-              <a:t>The trick in one sentence: the SVM never needs the coordinates, only the angles and lengths between points, and those can be obtained without ever going there.</a:t>
-            </a:r>
-          </a:p>
-          <a:p>
-            <a:pPr lvl="0" indent="0" marL="0">
-              <a:buNone/>
-            </a:pPr>
-          </a:p>
-          <a:p>
-            <a:pPr lvl="0" indent="0" marL="0">
-              <a:buNone/>
-            </a:pPr>
-            <a:r>
-              <a:rPr/>
-              <a:t>Do not prove it - handout section 5.4 shows where the inner products come from in the dual formulation. The claim to state and let land is that a function of two ordinary two-dimensional vectors returns their inner product in a space of infinite dimension, at the cost of one exponential.</a:t>
-            </a:r>
-          </a:p>
-          <a:p>
-            <a:pPr lvl="0" indent="0" marL="0">
-              <a:buNone/>
-            </a:pPr>
-          </a:p>
-          <a:p>
-            <a:pPr lvl="0" indent="0" marL="0">
-              <a:buNone/>
-            </a:pPr>
-            <a:r>
-              <a:rPr/>
-              <a:t>And close the loop from the previous slide: we chose the lift in the picture by knowing the answer. The RBF kernel does something equivalent without being told, which is exactly why it works on problems where nobody could guess the right coordinates.</a:t>
+              <a:t>Build the picture in words first and let them see it before the figure appears. Take the scatter plot from the start of the lesson, lift each point off the page by its distance from the centre, and look from the side.</a:t>
+            </a:r>
+          </a:p>
+          <a:p>
+            <a:pPr lvl="0" indent="0" marL="0">
+              <a:buNone/>
+            </a:pPr>
+          </a:p>
+          <a:p>
+            <a:pPr lvl="0" indent="0" marL="0">
+              <a:buNone/>
+            </a:pPr>
+            <a:r>
+              <a:rPr/>
+              <a:t>Then the sentence that reframes the whole afternoon: the classes were never inseparable. Separability is not a property of the data - it is a property of the data AND the coordinates you happen to have measured it in.</a:t>
+            </a:r>
+          </a:p>
+          <a:p>
+            <a:pPr lvl="0" indent="0" marL="0">
+              <a:buNone/>
+            </a:pPr>
+          </a:p>
+          <a:p>
+            <a:pPr lvl="0" indent="0" marL="0">
+              <a:buNone/>
+            </a:pPr>
+            <a:r>
+              <a:rPr/>
+              <a:t>Ask what is unsatisfying about what we just did, and wait for it. We chose that lift by already knowing the answer. We knew the fault mode was radial. In any real problem you do not, and inventing the right coordinate is the hard part - which is exactly the difficulty the kernel trick removes.</a:t>
+            </a:r>
+          </a:p>
+          <a:p>
+            <a:pPr lvl="0" indent="0" marL="0">
+              <a:buNone/>
+            </a:pPr>
+          </a:p>
+          <a:p>
+            <a:pPr lvl="0" indent="0" marL="0">
+              <a:buNone/>
+            </a:pPr>
+            <a:r>
+              <a:rPr/>
+              <a:t>Handout section 5.4.</a:t>
             </a:r>
           </a:p>
         </p:txBody>
@@ -5477,59 +5493,35 @@
             </a:pPr>
             <a:r>
               <a:rPr/>
-              <a:t>One line, and it is the whole of what scikit-learn does when you leave </a:t>
-            </a:r>
-            <a:r>
-              <a:rPr>
-                <a:latin typeface="Courier"/>
-              </a:rPr>
-              <a:t>kernel</a:t>
-            </a:r>
-            <a:r>
-              <a:rPr/>
-              <a:t> at its default.</a:t>
-            </a:r>
-          </a:p>
-          <a:p>
-            <a:pPr lvl="0" indent="0" marL="0">
-              <a:buNone/>
-            </a:pPr>
-          </a:p>
-          <a:p>
-            <a:pPr lvl="0" indent="0" marL="0">
-              <a:buNone/>
-            </a:pPr>
-            <a:r>
-              <a:rPr/>
-              <a:t>Read it aloud as a similarity rather than as a formula: the closer two points are, the nearer the exponent is to zero and the nearer the kernel is to one; far apart, it falls away to nothing. That is all an RBF kernel says - how much does this point look like that one.</a:t>
-            </a:r>
-          </a:p>
-          <a:p>
-            <a:pPr lvl="0" indent="0" marL="0">
-              <a:buNone/>
-            </a:pPr>
-          </a:p>
-          <a:p>
-            <a:pPr lvl="0" indent="0" marL="0">
-              <a:buNone/>
-            </a:pPr>
-            <a:r>
-              <a:rPr/>
-              <a:t>Now say what γ means, because the next two slides turn on it: it sets how far a single training point’s influence reaches. Small γ, wide reach, smooth boundary. Large γ, each point influences only its immediate neighbourhood - and a boundary that can afford an island around every mislabelled pump.</a:t>
-            </a:r>
-          </a:p>
-          <a:p>
-            <a:pPr lvl="0" indent="0" marL="0">
-              <a:buNone/>
-            </a:pPr>
-          </a:p>
-          <a:p>
-            <a:pPr lvl="0" indent="0" marL="0">
-              <a:buNone/>
-            </a:pPr>
-            <a:r>
-              <a:rPr/>
-              <a:t>Worth naming the cost, since this is an engineering course: one exponential per pair of points, so the kernel matrix is m × m. That is why support vector machines are a poor fit above a hundred thousand rows, and it is a property of the method rather than of the implementation.</a:t>
+              <a:t>The same 1,200 pumps twice: on the left in the plane where they were measured, on the right lifted by their distance from the design point. The gold plane does what no line could.</a:t>
+            </a:r>
+          </a:p>
+          <a:p>
+            <a:pPr lvl="0" indent="0" marL="0">
+              <a:buNone/>
+            </a:pPr>
+          </a:p>
+          <a:p>
+            <a:pPr lvl="0" indent="0" marL="0">
+              <a:buNone/>
+            </a:pPr>
+            <a:r>
+              <a:rPr/>
+              <a:t>Have them look at the right panel and confirm for themselves that a flat horizontal cut separates the colours cleanly. Nothing was added - no new measurement, no extra sensor. The third coordinate is computed from the two they already had.</a:t>
+            </a:r>
+          </a:p>
+          <a:p>
+            <a:pPr lvl="0" indent="0" marL="0">
+              <a:buNone/>
+            </a:pPr>
+          </a:p>
+          <a:p>
+            <a:pPr lvl="0" indent="0" marL="0">
+              <a:buNone/>
+            </a:pPr>
+            <a:r>
+              <a:rPr/>
+              <a:t>Then set up the objection that the next slide answers. This worked because the lift was three-dimensional and we could guess it. The spaces that work in general are enormous - the useful ones are sometimes infinite-dimensional - and computing the coordinates of every point in such a space is impossible.</a:t>
             </a:r>
           </a:p>
         </p:txBody>
@@ -5611,53 +5603,35 @@
             </a:pPr>
             <a:r>
               <a:rPr/>
-              <a:t>Read the two columns against each other, exactly as lesson 5 taught, and let the last row do the work.</a:t>
-            </a:r>
-          </a:p>
-          <a:p>
-            <a:pPr lvl="0" indent="0" marL="0">
-              <a:buNone/>
-            </a:pPr>
-          </a:p>
-          <a:p>
-            <a:pPr lvl="0" indent="0" marL="0">
-              <a:buNone/>
-            </a:pPr>
-            <a:r>
-              <a:rPr/>
-              <a:t>The bottom row has the best training score on the slide - 0.995, nearly perfect - and the worst honest one. That is the signature of overfitting, and here it is not inferred from theory but measured on the same data by two different procedures.</a:t>
-            </a:r>
-          </a:p>
-          <a:p>
-            <a:pPr lvl="0" indent="0" marL="0">
-              <a:buNone/>
-            </a:pPr>
-          </a:p>
-          <a:p>
-            <a:pPr lvl="0" indent="0" marL="0">
-              <a:buNone/>
-            </a:pPr>
-            <a:r>
-              <a:rPr b="1"/>
-              <a:t>Now the second predictable mistake, and defend the instinct.</a:t>
-            </a:r>
-            <a:r>
-              <a:rPr/>
-              <a:t> Choosing between these three on the training score selects the WORST model, with complete confidence and a very impressive number to report. And the instinct behind it is not stupid: a higher score on the data you have is, in every other part of engineering, evidence of a better system. Fitting the data well is what we spent lessons 3 and 4 doing. What breaks the analogy is that a flexible model can fit data it has already been shown without learning anything transferable.</a:t>
-            </a:r>
-          </a:p>
-          <a:p>
-            <a:pPr lvl="0" indent="0" marL="0">
-              <a:buNone/>
-            </a:pPr>
-          </a:p>
-          <a:p>
-            <a:pPr lvl="0" indent="0" marL="0">
-              <a:buNone/>
-            </a:pPr>
-            <a:r>
-              <a:rPr/>
-              <a:t>The reason this table is on the slide rather than in the handout is that the next slide shows the same three settings as pictures - so the failure is visible as well as measurable, which is rare.</a:t>
+              <a:t>The trick in one sentence: the SVM never needs the coordinates, only the angles and lengths between points, and those can be obtained without ever going there.</a:t>
+            </a:r>
+          </a:p>
+          <a:p>
+            <a:pPr lvl="0" indent="0" marL="0">
+              <a:buNone/>
+            </a:pPr>
+          </a:p>
+          <a:p>
+            <a:pPr lvl="0" indent="0" marL="0">
+              <a:buNone/>
+            </a:pPr>
+            <a:r>
+              <a:rPr/>
+              <a:t>Do not prove it - handout section 5.4 shows where the inner products come from in the dual formulation. The claim to state and let land is that a function of two ordinary two-dimensional vectors returns their inner product in a space of infinite dimension, at the cost of one exponential.</a:t>
+            </a:r>
+          </a:p>
+          <a:p>
+            <a:pPr lvl="0" indent="0" marL="0">
+              <a:buNone/>
+            </a:pPr>
+          </a:p>
+          <a:p>
+            <a:pPr lvl="0" indent="0" marL="0">
+              <a:buNone/>
+            </a:pPr>
+            <a:r>
+              <a:rPr/>
+              <a:t>And close the loop from the previous slide: we chose the lift in the picture by knowing the answer. The RBF kernel does something equivalent without being told, which is exactly why it works on problems where nobody could guess the right coordinates.</a:t>
             </a:r>
           </a:p>
         </p:txBody>
@@ -5739,63 +5713,59 @@
             </a:pPr>
             <a:r>
               <a:rPr/>
-              <a:t>Three settings, with training and cross-validated scores in each title. Read them together.</a:t>
-            </a:r>
-          </a:p>
-          <a:p>
-            <a:pPr lvl="0" indent="0" marL="0">
-              <a:buNone/>
-            </a:pPr>
-          </a:p>
-          <a:p>
-            <a:pPr lvl="0" indent="0" marL="0">
-              <a:buNone/>
-            </a:pPr>
-            <a:r>
-              <a:rPr/>
-              <a:t>Left, γ = 0.1: a smooth boundary, slightly too smooth, and the two scores agree. Middle, γ = 1: close to the true envelope, and the best honest score.</a:t>
-            </a:r>
-          </a:p>
-          <a:p>
-            <a:pPr lvl="0" indent="0" marL="0">
-              <a:buNone/>
-            </a:pPr>
-          </a:p>
-          <a:p>
-            <a:pPr lvl="0" indent="0" marL="0">
-              <a:buNone/>
-            </a:pPr>
-            <a:r>
-              <a:rPr/>
-              <a:t>Right is the one to sit on. The boundary has broken into bubbles - small islands around individual points, including the mislabelled ones. That is what a 0.995 training score looks like from the outside: the model has drawn a private territory around each flipped label so that it can get it right.</a:t>
-            </a:r>
-          </a:p>
-          <a:p>
-            <a:pPr lvl="0" indent="0" marL="0">
-              <a:buNone/>
-            </a:pPr>
-          </a:p>
-          <a:p>
-            <a:pPr lvl="0" indent="0" marL="0">
-              <a:buNone/>
-            </a:pPr>
-            <a:r>
-              <a:rPr/>
-              <a:t>Ask them what happens to a new pump landing in the gap between two bubbles. That is the 0.902.</a:t>
-            </a:r>
-          </a:p>
-          <a:p>
-            <a:pPr lvl="0" indent="0" marL="0">
-              <a:buNone/>
-            </a:pPr>
-          </a:p>
-          <a:p>
-            <a:pPr lvl="0" indent="0" marL="0">
-              <a:buNone/>
-            </a:pPr>
-            <a:r>
-              <a:rPr/>
-              <a:t>The reason this slide matters more than the table: they have seen overfitting as a curve on a plot since lesson 5. Here it is a shape in the input space, and the shape is obviously wrong in a way no number is. When you can plot the boundary, plot it.</a:t>
+              <a:t>One line, and it is the whole of what scikit-learn does when you leave </a:t>
+            </a:r>
+            <a:r>
+              <a:rPr>
+                <a:latin typeface="Courier"/>
+              </a:rPr>
+              <a:t>kernel</a:t>
+            </a:r>
+            <a:r>
+              <a:rPr/>
+              <a:t> at its default.</a:t>
+            </a:r>
+          </a:p>
+          <a:p>
+            <a:pPr lvl="0" indent="0" marL="0">
+              <a:buNone/>
+            </a:pPr>
+          </a:p>
+          <a:p>
+            <a:pPr lvl="0" indent="0" marL="0">
+              <a:buNone/>
+            </a:pPr>
+            <a:r>
+              <a:rPr/>
+              <a:t>Read it aloud as a similarity rather than as a formula: the closer two points are, the nearer the exponent is to zero and the nearer the kernel is to one; far apart, it falls away to nothing. That is all an RBF kernel says - how much does this point look like that one.</a:t>
+            </a:r>
+          </a:p>
+          <a:p>
+            <a:pPr lvl="0" indent="0" marL="0">
+              <a:buNone/>
+            </a:pPr>
+          </a:p>
+          <a:p>
+            <a:pPr lvl="0" indent="0" marL="0">
+              <a:buNone/>
+            </a:pPr>
+            <a:r>
+              <a:rPr/>
+              <a:t>Now say what γ means, because the next two slides turn on it: it sets how far a single training point’s influence reaches. Small γ, wide reach, smooth boundary. Large γ, each point influences only its immediate neighbourhood - and a boundary that can afford an island around every mislabelled pump.</a:t>
+            </a:r>
+          </a:p>
+          <a:p>
+            <a:pPr lvl="0" indent="0" marL="0">
+              <a:buNone/>
+            </a:pPr>
+          </a:p>
+          <a:p>
+            <a:pPr lvl="0" indent="0" marL="0">
+              <a:buNone/>
+            </a:pPr>
+            <a:r>
+              <a:rPr/>
+              <a:t>Worth naming the cost, since this is an engineering course: one exponential per pair of points, so the kernel matrix is m × m. That is why support vector machines are a poor fit above a hundred thousand rows, and it is a property of the method rather than of the implementation.</a:t>
             </a:r>
           </a:p>
         </p:txBody>
@@ -5877,49 +5847,53 @@
             </a:pPr>
             <a:r>
               <a:rPr/>
-              <a:t>Run notebooks/03. Eighteen minutes.</a:t>
-            </a:r>
-          </a:p>
-          <a:p>
-            <a:pPr lvl="0" indent="0" marL="0">
-              <a:buNone/>
-            </a:pPr>
-          </a:p>
-          <a:p>
-            <a:pPr lvl="0" indent="0" marL="0">
-              <a:buNone/>
-            </a:pPr>
-            <a:r>
-              <a:rPr/>
-              <a:t>The cell to protect is the γ sweep with the boundary drawn at each setting. Let them turn γ up themselves and watch the bubbles form - it is the most direct experience of overfitting available in this course.</a:t>
-            </a:r>
-          </a:p>
-          <a:p>
-            <a:pPr lvl="0" indent="0" marL="0">
-              <a:buNone/>
-            </a:pPr>
-          </a:p>
-          <a:p>
-            <a:pPr lvl="0" indent="0" marL="0">
-              <a:buNone/>
-            </a:pPr>
-            <a:r>
-              <a:rPr/>
-              <a:t>Have them print the support-vector fraction for the linear and RBF kernels side by side. Two numbers, and it makes the diagnostic real rather than a claim on a slide.</a:t>
-            </a:r>
-          </a:p>
-          <a:p>
-            <a:pPr lvl="0" indent="0" marL="0">
-              <a:buNone/>
-            </a:pPr>
-          </a:p>
-          <a:p>
-            <a:pPr lvl="0" indent="0" marL="0">
-              <a:buNone/>
-            </a:pPr>
-            <a:r>
-              <a:rPr/>
-              <a:t>If time runs short, skip the C sweep and set it as reading: the table is in handout section 5.5.</a:t>
+              <a:t>Read the two columns against each other, exactly as lesson 5 taught, and let the last row do the work.</a:t>
+            </a:r>
+          </a:p>
+          <a:p>
+            <a:pPr lvl="0" indent="0" marL="0">
+              <a:buNone/>
+            </a:pPr>
+          </a:p>
+          <a:p>
+            <a:pPr lvl="0" indent="0" marL="0">
+              <a:buNone/>
+            </a:pPr>
+            <a:r>
+              <a:rPr/>
+              <a:t>The bottom row has the best training score on the slide - 0.995, nearly perfect - and the worst honest one. That is the signature of overfitting, and here it is not inferred from theory but measured on the same data by two different procedures.</a:t>
+            </a:r>
+          </a:p>
+          <a:p>
+            <a:pPr lvl="0" indent="0" marL="0">
+              <a:buNone/>
+            </a:pPr>
+          </a:p>
+          <a:p>
+            <a:pPr lvl="0" indent="0" marL="0">
+              <a:buNone/>
+            </a:pPr>
+            <a:r>
+              <a:rPr b="1"/>
+              <a:t>Now the second predictable mistake, and defend the instinct.</a:t>
+            </a:r>
+            <a:r>
+              <a:rPr/>
+              <a:t> Choosing between these three on the training score selects the WORST model, with complete confidence and a very impressive number to report. And the instinct behind it is not stupid: a higher score on the data you have is, in every other part of engineering, evidence of a better system. Fitting the data well is what we spent lessons 3 and 4 doing. What breaks the analogy is that a flexible model can fit data it has already been shown without learning anything transferable.</a:t>
+            </a:r>
+          </a:p>
+          <a:p>
+            <a:pPr lvl="0" indent="0" marL="0">
+              <a:buNone/>
+            </a:pPr>
+          </a:p>
+          <a:p>
+            <a:pPr lvl="0" indent="0" marL="0">
+              <a:buNone/>
+            </a:pPr>
+            <a:r>
+              <a:rPr/>
+              <a:t>The reason this table is on the slide rather than in the handout is that the next slide shows the same three settings as pictures - so the failure is visible as well as measurable, which is rare.</a:t>
             </a:r>
           </a:p>
         </p:txBody>
@@ -6133,57 +6107,63 @@
             </a:pPr>
             <a:r>
               <a:rPr/>
-              <a:t>Everything in the lesson on the same 1,200 pumps, cross-validated the same way.</a:t>
-            </a:r>
-          </a:p>
-          <a:p>
-            <a:pPr lvl="0" indent="0" marL="0">
-              <a:buNone/>
-            </a:pPr>
-          </a:p>
-          <a:p>
-            <a:pPr lvl="0" indent="0" marL="0">
-              <a:buNone/>
-            </a:pPr>
-            <a:r>
-              <a:rPr/>
-              <a:t>Read the top three rows together: all exactly 0.613, and all three are linear. Then the bottom three, all near the ceiling, reached by three completely unrelated routes - remembering the neighbourhood, assuming independence, bending the space. There is no single idea shared between them.</a:t>
-            </a:r>
-          </a:p>
-          <a:p>
-            <a:pPr lvl="0" indent="0" marL="0">
-              <a:buNone/>
-            </a:pPr>
-          </a:p>
-          <a:p>
-            <a:pPr lvl="0" indent="0" marL="0">
-              <a:buNone/>
-            </a:pPr>
-            <a:r>
-              <a:rPr/>
-              <a:t>Then the number that is the lesson: the gap between best and worst is </a:t>
-            </a:r>
-            <a:r>
-              <a:rPr b="1"/>
-              <a:t>0.334</a:t>
-            </a:r>
-            <a:r>
-              <a:rPr/>
-              <a:t>. Larger than any difference this course has shown between a good model and a carefully tuned one - lesson 5’s entire hyperparameter search moved things by a few hundredths.</a:t>
-            </a:r>
-          </a:p>
-          <a:p>
-            <a:pPr lvl="0" indent="0" marL="0">
-              <a:buNone/>
-            </a:pPr>
-          </a:p>
-          <a:p>
-            <a:pPr lvl="0" indent="0" marL="0">
-              <a:buNone/>
-            </a:pPr>
-            <a:r>
-              <a:rPr/>
-              <a:t>Say the conclusion plainly, and it is the practical takeaway of the whole lesson: choosing the right family matters far more than tuning the wrong one. Nobody in the top three rows could have tuned their way out. And the way to tell which family you need is to look at the data first, which is what lesson 2 was for.</a:t>
+              <a:t>Three settings, with training and cross-validated scores in each title. Read them together.</a:t>
+            </a:r>
+          </a:p>
+          <a:p>
+            <a:pPr lvl="0" indent="0" marL="0">
+              <a:buNone/>
+            </a:pPr>
+          </a:p>
+          <a:p>
+            <a:pPr lvl="0" indent="0" marL="0">
+              <a:buNone/>
+            </a:pPr>
+            <a:r>
+              <a:rPr/>
+              <a:t>Left, γ = 0.1: a smooth boundary, slightly too smooth, and the two scores agree. Middle, γ = 1: close to the true envelope, and the best honest score.</a:t>
+            </a:r>
+          </a:p>
+          <a:p>
+            <a:pPr lvl="0" indent="0" marL="0">
+              <a:buNone/>
+            </a:pPr>
+          </a:p>
+          <a:p>
+            <a:pPr lvl="0" indent="0" marL="0">
+              <a:buNone/>
+            </a:pPr>
+            <a:r>
+              <a:rPr/>
+              <a:t>Right is the one to sit on. The boundary has broken into bubbles - small islands around individual points, including the mislabelled ones. That is what a 0.995 training score looks like from the outside: the model has drawn a private territory around each flipped label so that it can get it right.</a:t>
+            </a:r>
+          </a:p>
+          <a:p>
+            <a:pPr lvl="0" indent="0" marL="0">
+              <a:buNone/>
+            </a:pPr>
+          </a:p>
+          <a:p>
+            <a:pPr lvl="0" indent="0" marL="0">
+              <a:buNone/>
+            </a:pPr>
+            <a:r>
+              <a:rPr/>
+              <a:t>Ask them what happens to a new pump landing in the gap between two bubbles. That is the 0.902.</a:t>
+            </a:r>
+          </a:p>
+          <a:p>
+            <a:pPr lvl="0" indent="0" marL="0">
+              <a:buNone/>
+            </a:pPr>
+          </a:p>
+          <a:p>
+            <a:pPr lvl="0" indent="0" marL="0">
+              <a:buNone/>
+            </a:pPr>
+            <a:r>
+              <a:rPr/>
+              <a:t>The reason this slide matters more than the table: they have seen overfitting as a curve on a plot since lesson 5. Here it is a shape in the input space, and the shape is obviously wrong in a way no number is. When you can plot the boundary, plot it.</a:t>
             </a:r>
           </a:p>
         </p:txBody>
@@ -6265,35 +6245,49 @@
             </a:pPr>
             <a:r>
               <a:rPr/>
-              <a:t>A table to photograph. Work down it and attach today’s evidence to each row, so it is remembered as a set of conclusions rather than as advice.</a:t>
-            </a:r>
-          </a:p>
-          <a:p>
-            <a:pPr lvl="0" indent="0" marL="0">
-              <a:buNone/>
-            </a:pPr>
-          </a:p>
-          <a:p>
-            <a:pPr lvl="0" indent="0" marL="0">
-              <a:buNone/>
-            </a:pPr>
-            <a:r>
-              <a:rPr/>
-              <a:t>Row two deserves a sentence on its own, because it is the one that sounds wrong after the last hour. Text classification is the canonical case: tens of thousands of word-count features, an assumption that is transparently false, and a method that works anyway - because being roughly right in ten thousand dimensions beats being unable to estimate anything at all. Also mention Naive Bayes as a baseline: it trains in one pass, so if your tuned model does not beat it you have learned something quickly and cheaply.</a:t>
-            </a:r>
-          </a:p>
-          <a:p>
-            <a:pPr lvl="0" indent="0" marL="0">
-              <a:buNone/>
-            </a:pPr>
-          </a:p>
-          <a:p>
-            <a:pPr lvl="0" indent="0" marL="0">
-              <a:buNone/>
-            </a:pPr>
-            <a:r>
-              <a:rPr/>
-              <a:t>One row that did not fit and should be said out loud: when you need to explain the decision to the person affected, none of today’s three will do it. A support vector machine in a lifted space has no explanation a customer would accept. Lesson 3’s Resources document covers why that is sometimes a legal requirement rather than a preference.</a:t>
+              <a:t>Run notebooks/03. Eighteen minutes.</a:t>
+            </a:r>
+          </a:p>
+          <a:p>
+            <a:pPr lvl="0" indent="0" marL="0">
+              <a:buNone/>
+            </a:pPr>
+          </a:p>
+          <a:p>
+            <a:pPr lvl="0" indent="0" marL="0">
+              <a:buNone/>
+            </a:pPr>
+            <a:r>
+              <a:rPr/>
+              <a:t>The cell to protect is the γ sweep with the boundary drawn at each setting. Let them turn γ up themselves and watch the bubbles form - it is the most direct experience of overfitting available in this course.</a:t>
+            </a:r>
+          </a:p>
+          <a:p>
+            <a:pPr lvl="0" indent="0" marL="0">
+              <a:buNone/>
+            </a:pPr>
+          </a:p>
+          <a:p>
+            <a:pPr lvl="0" indent="0" marL="0">
+              <a:buNone/>
+            </a:pPr>
+            <a:r>
+              <a:rPr/>
+              <a:t>Have them print the support-vector fraction for the linear and RBF kernels side by side. Two numbers, and it makes the diagnostic real rather than a claim on a slide.</a:t>
+            </a:r>
+          </a:p>
+          <a:p>
+            <a:pPr lvl="0" indent="0" marL="0">
+              <a:buNone/>
+            </a:pPr>
+          </a:p>
+          <a:p>
+            <a:pPr lvl="0" indent="0" marL="0">
+              <a:buNone/>
+            </a:pPr>
+            <a:r>
+              <a:rPr/>
+              <a:t>If time runs short, skip the C sweep and set it as reading: the table is in handout section 5.5.</a:t>
             </a:r>
           </a:p>
         </p:txBody>
@@ -6375,49 +6369,57 @@
             </a:pPr>
             <a:r>
               <a:rPr/>
-              <a:t>Close on the number they opened the second segment with, and say it one more time: seventy per cent. In a hundred dimensions the nearest point in the entire dataset is seven tenths of the way to the farthest, and every method built on distance is operating on a quantity that has stopped varying.</a:t>
-            </a:r>
-          </a:p>
-          <a:p>
-            <a:pPr lvl="0" indent="0" marL="0">
-              <a:buNone/>
-            </a:pPr>
-          </a:p>
-          <a:p>
-            <a:pPr lvl="0" indent="0" marL="0">
-              <a:buNone/>
-            </a:pPr>
-            <a:r>
-              <a:rPr/>
-              <a:t>If they remember one habit from today, make it the diagnostic pair: before reaching for a model, look at the shape of the data; after fitting one, check whether the assumption it depends on is actually satisfied on your data. Two lines of code gave us the −0.006 that explained the 0.933.</a:t>
-            </a:r>
-          </a:p>
-          <a:p>
-            <a:pPr lvl="0" indent="0" marL="0">
-              <a:buNone/>
-            </a:pPr>
-          </a:p>
-          <a:p>
-            <a:pPr lvl="0" indent="0" marL="0">
-              <a:buNone/>
-            </a:pPr>
-            <a:r>
-              <a:rPr/>
-              <a:t>And the correction to the instinct that this lesson exists to install: more features is not free. It is nearly free for a linear model and it is expensive for anything built on a distance.</a:t>
-            </a:r>
-          </a:p>
-          <a:p>
-            <a:pPr lvl="0" indent="0" marL="0">
-              <a:buNone/>
-            </a:pPr>
-          </a:p>
-          <a:p>
-            <a:pPr lvl="0" indent="0" marL="0">
-              <a:buNone/>
-            </a:pPr>
-            <a:r>
-              <a:rPr/>
-              <a:t>Handout section 7 lists all of this with the section numbers.</a:t>
+              <a:t>Everything in the lesson on the same 1,200 pumps, cross-validated the same way.</a:t>
+            </a:r>
+          </a:p>
+          <a:p>
+            <a:pPr lvl="0" indent="0" marL="0">
+              <a:buNone/>
+            </a:pPr>
+          </a:p>
+          <a:p>
+            <a:pPr lvl="0" indent="0" marL="0">
+              <a:buNone/>
+            </a:pPr>
+            <a:r>
+              <a:rPr/>
+              <a:t>Read the top three rows together: all exactly 0.613, and all three are linear. Then the bottom three, all near the ceiling, reached by three completely unrelated routes - remembering the neighbourhood, assuming independence, bending the space. There is no single idea shared between them.</a:t>
+            </a:r>
+          </a:p>
+          <a:p>
+            <a:pPr lvl="0" indent="0" marL="0">
+              <a:buNone/>
+            </a:pPr>
+          </a:p>
+          <a:p>
+            <a:pPr lvl="0" indent="0" marL="0">
+              <a:buNone/>
+            </a:pPr>
+            <a:r>
+              <a:rPr/>
+              <a:t>Then the number that is the lesson: the gap between best and worst is </a:t>
+            </a:r>
+            <a:r>
+              <a:rPr b="1"/>
+              <a:t>0.334</a:t>
+            </a:r>
+            <a:r>
+              <a:rPr/>
+              <a:t>. Larger than any difference this course has shown between a good model and a carefully tuned one - lesson 5’s entire hyperparameter search moved things by a few hundredths.</a:t>
+            </a:r>
+          </a:p>
+          <a:p>
+            <a:pPr lvl="0" indent="0" marL="0">
+              <a:buNone/>
+            </a:pPr>
+          </a:p>
+          <a:p>
+            <a:pPr lvl="0" indent="0" marL="0">
+              <a:buNone/>
+            </a:pPr>
+            <a:r>
+              <a:rPr/>
+              <a:t>Say the conclusion plainly, and it is the practical takeaway of the whole lesson: choosing the right family matters far more than tuning the wrong one. Nobody in the top three rows could have tuned their way out. And the way to tell which family you need is to look at the data first, which is what lesson 2 was for.</a:t>
             </a:r>
           </a:p>
         </p:txBody>
@@ -6499,49 +6501,35 @@
             </a:pPr>
             <a:r>
               <a:rPr/>
-              <a:t>Set it explicitly and say out loud when it comes back: the first ten minutes of next Friday, 13 November.</a:t>
-            </a:r>
-          </a:p>
-          <a:p>
-            <a:pPr lvl="0" indent="0" marL="0">
-              <a:buNone/>
-            </a:pPr>
-          </a:p>
-          <a:p>
-            <a:pPr lvl="0" indent="0" marL="0">
-              <a:buNone/>
-            </a:pPr>
-            <a:r>
-              <a:rPr/>
-              <a:t>The marks are for the reasoning, not for the accuracy. A well-argued choice that scores slightly worse beats a lucky winner with no justification - and the argument has to reference the data, in the way that the −0.006 justified Naive Bayes on the pumps this afternoon.</a:t>
-            </a:r>
-          </a:p>
-          <a:p>
-            <a:pPr lvl="0" indent="0" marL="0">
-              <a:buNone/>
-            </a:pPr>
-          </a:p>
-          <a:p>
-            <a:pPr lvl="0" indent="0" marL="0">
-              <a:buNone/>
-            </a:pPr>
-            <a:r>
-              <a:rPr/>
-              <a:t>Remind them that everything must be cross-validated and reported with a spread, in the format lesson 5 set. Scaling goes inside the pipeline; that will be checked.</a:t>
-            </a:r>
-          </a:p>
-          <a:p>
-            <a:pPr lvl="0" indent="0" marL="0">
-              <a:buNone/>
-            </a:pPr>
-          </a:p>
-          <a:p>
-            <a:pPr lvl="0" indent="0" marL="0">
-              <a:buNone/>
-            </a:pPr>
-            <a:r>
-              <a:rPr/>
-              <a:t>Next week: decision trees and ensembles. A fourth family, with a different answer again to the same question - how do you draw a boundary that is not a line.</a:t>
+              <a:t>A table to photograph. Work down it and attach today’s evidence to each row, so it is remembered as a set of conclusions rather than as advice.</a:t>
+            </a:r>
+          </a:p>
+          <a:p>
+            <a:pPr lvl="0" indent="0" marL="0">
+              <a:buNone/>
+            </a:pPr>
+          </a:p>
+          <a:p>
+            <a:pPr lvl="0" indent="0" marL="0">
+              <a:buNone/>
+            </a:pPr>
+            <a:r>
+              <a:rPr/>
+              <a:t>Row two deserves a sentence on its own, because it is the one that sounds wrong after the last hour. Text classification is the canonical case: tens of thousands of word-count features, an assumption that is transparently false, and a method that works anyway - because being roughly right in ten thousand dimensions beats being unable to estimate anything at all. Also mention Naive Bayes as a baseline: it trains in one pass, so if your tuned model does not beat it you have learned something quickly and cheaply.</a:t>
+            </a:r>
+          </a:p>
+          <a:p>
+            <a:pPr lvl="0" indent="0" marL="0">
+              <a:buNone/>
+            </a:pPr>
+          </a:p>
+          <a:p>
+            <a:pPr lvl="0" indent="0" marL="0">
+              <a:buNone/>
+            </a:pPr>
+            <a:r>
+              <a:rPr/>
+              <a:t>One row that did not fit and should be said out loud: when you need to explain the decision to the person affected, none of today’s three will do it. A support vector machine in a lifted space has no explanation a customer would accept. Lesson 3’s Resources document covers why that is sometimes a legal requirement rather than a preference.</a:t>
             </a:r>
           </a:p>
         </p:txBody>
@@ -6564,6 +6552,254 @@
             <a:fld id="{18BDFEC3-8487-43E8-A154-7C12CBC1FFF2}" type="slidenum">
               <a:rPr lang="en-US"/>
               <a:t>54</a:t>
+            </a:fld>
+            <a:endParaRPr lang="en-US"/>
+          </a:p>
+        </p:txBody>
+      </p:sp>
+    </p:spTree>
+  </p:cSld>
+</p:notes>
+</file>
+
+<file path=ppt/notesSlides/notesSlide54.xml><?xml version="1.0" encoding="utf-8"?>
+<p:notes xmlns:a="http://schemas.openxmlformats.org/drawingml/2006/main" xmlns:r="http://schemas.openxmlformats.org/officeDocument/2006/relationships" xmlns:p="http://schemas.openxmlformats.org/presentationml/2006/main">
+  <p:cSld>
+    <p:spTree>
+      <p:nvGrpSpPr>
+        <p:cNvPr id="1" name=""/>
+        <p:cNvGrpSpPr/>
+        <p:nvPr/>
+      </p:nvGrpSpPr>
+      <p:grpSpPr>
+        <a:xfrm>
+          <a:off x="0" y="0"/>
+          <a:ext cx="0" cy="0"/>
+          <a:chOff x="0" y="0"/>
+          <a:chExt cx="0" cy="0"/>
+        </a:xfrm>
+      </p:grpSpPr>
+      <p:sp>
+        <p:nvSpPr>
+          <p:cNvPr id="2" name="Slide Image Placeholder 1"/>
+          <p:cNvSpPr>
+            <a:spLocks noGrp="1" noRot="1" noChangeAspect="1"/>
+          </p:cNvSpPr>
+          <p:nvPr>
+            <p:ph type="sldImg"/>
+          </p:nvPr>
+        </p:nvSpPr>
+        <p:spPr/>
+      </p:sp>
+      <p:sp>
+        <p:nvSpPr>
+          <p:cNvPr id="3" name="Notes Placeholder 2"/>
+          <p:cNvSpPr>
+            <a:spLocks noGrp="1"/>
+          </p:cNvSpPr>
+          <p:nvPr>
+            <p:ph type="body" idx="1"/>
+          </p:nvPr>
+        </p:nvSpPr>
+        <p:spPr/>
+        <p:txBody>
+          <a:bodyPr/>
+          <a:lstStyle/>
+          <a:p>
+            <a:pPr lvl="0" indent="0" marL="0">
+              <a:buNone/>
+            </a:pPr>
+            <a:r>
+              <a:rPr/>
+              <a:t>Close on the number they opened the second segment with, and say it one more time: seventy per cent. In a hundred dimensions the nearest point in the entire dataset is seven tenths of the way to the farthest, and every method built on distance is operating on a quantity that has stopped varying.</a:t>
+            </a:r>
+          </a:p>
+          <a:p>
+            <a:pPr lvl="0" indent="0" marL="0">
+              <a:buNone/>
+            </a:pPr>
+          </a:p>
+          <a:p>
+            <a:pPr lvl="0" indent="0" marL="0">
+              <a:buNone/>
+            </a:pPr>
+            <a:r>
+              <a:rPr/>
+              <a:t>If they remember one habit from today, make it the diagnostic pair: before reaching for a model, look at the shape of the data; after fitting one, check whether the assumption it depends on is actually satisfied on your data. Two lines of code gave us the −0.006 that explained the 0.933.</a:t>
+            </a:r>
+          </a:p>
+          <a:p>
+            <a:pPr lvl="0" indent="0" marL="0">
+              <a:buNone/>
+            </a:pPr>
+          </a:p>
+          <a:p>
+            <a:pPr lvl="0" indent="0" marL="0">
+              <a:buNone/>
+            </a:pPr>
+            <a:r>
+              <a:rPr/>
+              <a:t>And the correction to the instinct that this lesson exists to install: more features is not free. It is nearly free for a linear model and it is expensive for anything built on a distance.</a:t>
+            </a:r>
+          </a:p>
+          <a:p>
+            <a:pPr lvl="0" indent="0" marL="0">
+              <a:buNone/>
+            </a:pPr>
+          </a:p>
+          <a:p>
+            <a:pPr lvl="0" indent="0" marL="0">
+              <a:buNone/>
+            </a:pPr>
+            <a:r>
+              <a:rPr/>
+              <a:t>Handout section 7 lists all of this with the section numbers.</a:t>
+            </a:r>
+          </a:p>
+        </p:txBody>
+      </p:sp>
+      <p:sp>
+        <p:nvSpPr>
+          <p:cNvPr id="4" name="Slide Number Placeholder 3"/>
+          <p:cNvSpPr>
+            <a:spLocks noGrp="1"/>
+          </p:cNvSpPr>
+          <p:nvPr>
+            <p:ph type="sldNum" sz="quarter" idx="10"/>
+          </p:nvPr>
+        </p:nvSpPr>
+        <p:spPr/>
+        <p:txBody>
+          <a:bodyPr/>
+          <a:lstStyle/>
+          <a:p>
+            <a:fld id="{18BDFEC3-8487-43E8-A154-7C12CBC1FFF2}" type="slidenum">
+              <a:rPr lang="en-US"/>
+              <a:t>55</a:t>
+            </a:fld>
+            <a:endParaRPr lang="en-US"/>
+          </a:p>
+        </p:txBody>
+      </p:sp>
+    </p:spTree>
+  </p:cSld>
+</p:notes>
+</file>
+
+<file path=ppt/notesSlides/notesSlide55.xml><?xml version="1.0" encoding="utf-8"?>
+<p:notes xmlns:a="http://schemas.openxmlformats.org/drawingml/2006/main" xmlns:r="http://schemas.openxmlformats.org/officeDocument/2006/relationships" xmlns:p="http://schemas.openxmlformats.org/presentationml/2006/main">
+  <p:cSld>
+    <p:spTree>
+      <p:nvGrpSpPr>
+        <p:cNvPr id="1" name=""/>
+        <p:cNvGrpSpPr/>
+        <p:nvPr/>
+      </p:nvGrpSpPr>
+      <p:grpSpPr>
+        <a:xfrm>
+          <a:off x="0" y="0"/>
+          <a:ext cx="0" cy="0"/>
+          <a:chOff x="0" y="0"/>
+          <a:chExt cx="0" cy="0"/>
+        </a:xfrm>
+      </p:grpSpPr>
+      <p:sp>
+        <p:nvSpPr>
+          <p:cNvPr id="2" name="Slide Image Placeholder 1"/>
+          <p:cNvSpPr>
+            <a:spLocks noGrp="1" noRot="1" noChangeAspect="1"/>
+          </p:cNvSpPr>
+          <p:nvPr>
+            <p:ph type="sldImg"/>
+          </p:nvPr>
+        </p:nvSpPr>
+        <p:spPr/>
+      </p:sp>
+      <p:sp>
+        <p:nvSpPr>
+          <p:cNvPr id="3" name="Notes Placeholder 2"/>
+          <p:cNvSpPr>
+            <a:spLocks noGrp="1"/>
+          </p:cNvSpPr>
+          <p:nvPr>
+            <p:ph type="body" idx="1"/>
+          </p:nvPr>
+        </p:nvSpPr>
+        <p:spPr/>
+        <p:txBody>
+          <a:bodyPr/>
+          <a:lstStyle/>
+          <a:p>
+            <a:pPr lvl="0" indent="0" marL="0">
+              <a:buNone/>
+            </a:pPr>
+            <a:r>
+              <a:rPr/>
+              <a:t>Set it explicitly and say out loud when it comes back: the first ten minutes of next Friday, 13 November.</a:t>
+            </a:r>
+          </a:p>
+          <a:p>
+            <a:pPr lvl="0" indent="0" marL="0">
+              <a:buNone/>
+            </a:pPr>
+          </a:p>
+          <a:p>
+            <a:pPr lvl="0" indent="0" marL="0">
+              <a:buNone/>
+            </a:pPr>
+            <a:r>
+              <a:rPr/>
+              <a:t>The marks are for the reasoning, not for the accuracy. A well-argued choice that scores slightly worse beats a lucky winner with no justification - and the argument has to reference the data, in the way that the −0.006 justified Naive Bayes on the pumps this afternoon.</a:t>
+            </a:r>
+          </a:p>
+          <a:p>
+            <a:pPr lvl="0" indent="0" marL="0">
+              <a:buNone/>
+            </a:pPr>
+          </a:p>
+          <a:p>
+            <a:pPr lvl="0" indent="0" marL="0">
+              <a:buNone/>
+            </a:pPr>
+            <a:r>
+              <a:rPr/>
+              <a:t>Remind them that everything must be cross-validated and reported with a spread, in the format lesson 5 set. Scaling goes inside the pipeline; that will be checked.</a:t>
+            </a:r>
+          </a:p>
+          <a:p>
+            <a:pPr lvl="0" indent="0" marL="0">
+              <a:buNone/>
+            </a:pPr>
+          </a:p>
+          <a:p>
+            <a:pPr lvl="0" indent="0" marL="0">
+              <a:buNone/>
+            </a:pPr>
+            <a:r>
+              <a:rPr/>
+              <a:t>Next week: decision trees and ensembles. A fourth family, with a different answer again to the same question - how do you draw a boundary that is not a line.</a:t>
+            </a:r>
+          </a:p>
+        </p:txBody>
+      </p:sp>
+      <p:sp>
+        <p:nvSpPr>
+          <p:cNvPr id="4" name="Slide Number Placeholder 3"/>
+          <p:cNvSpPr>
+            <a:spLocks noGrp="1"/>
+          </p:cNvSpPr>
+          <p:nvPr>
+            <p:ph type="sldNum" sz="quarter" idx="10"/>
+          </p:nvPr>
+        </p:nvSpPr>
+        <p:spPr/>
+        <p:txBody>
+          <a:bodyPr/>
+          <a:lstStyle/>
+          <a:p>
+            <a:fld id="{18BDFEC3-8487-43E8-A154-7C12CBC1FFF2}" type="slidenum">
+              <a:rPr lang="en-US"/>
+              <a:t>56</a:t>
             </a:fld>
             <a:endParaRPr lang="en-US"/>
           </a:p>
@@ -12867,72 +13103,41 @@
             </a:pPr>
             <a:r>
               <a:rPr/>
-              <a:t>A wonderful bargain, and almost never true</a:t>
-            </a:r>
-          </a:p>
-        </p:txBody>
-      </p:sp>
-      <p:sp>
-        <p:nvSpPr>
-          <p:cNvPr id="3" name="Content Placeholder 2"/>
-          <p:cNvSpPr>
-            <a:spLocks noGrp="1"/>
-          </p:cNvSpPr>
-          <p:nvPr>
-            <p:ph idx="1"/>
-          </p:nvPr>
-        </p:nvSpPr>
-        <p:spPr>
+              <a:t>Gaussian: each factor is a bell curve</a:t>
+            </a:r>
+          </a:p>
+        </p:txBody>
+      </p:sp>
+      <p:pic>
+        <p:nvPicPr>
+          <p:cNvPr descr="eq_13eb83da37.png" id="0" name="Picture 1"/>
+          <p:cNvPicPr>
+            <a:picLocks noGrp="1" noChangeAspect="1"/>
+          </p:cNvPicPr>
+          <p:nvPr/>
+        </p:nvPicPr>
+        <p:blipFill>
+          <a:blip r:embed="rId3"/>
+          <a:stretch>
+            <a:fillRect/>
+          </a:stretch>
+        </p:blipFill>
+        <p:spPr bwMode="auto">
           <a:xfrm>
-            <a:off x="457200" y="1200151"/>
-            <a:ext cx="8229600" cy="3394472"/>
+            <a:off x="457200" y="2211189"/>
+            <a:ext cx="8229600" cy="1270000"/>
           </a:xfrm>
+          <a:prstGeom prst="rect">
+            <a:avLst/>
+          </a:prstGeom>
+          <a:noFill/>
+          <a:ln w="9525">
+            <a:noFill/>
+            <a:headEnd/>
+            <a:tailEnd/>
+          </a:ln>
         </p:spPr>
-        <p:txBody>
-          <a:bodyPr/>
-          <a:lstStyle/>
-          <a:p>
-            <a:pPr lvl="0"/>
-            <a:r>
-              <a:rPr/>
-              <a:t>Training is </a:t>
-            </a:r>
-            <a:r>
-              <a:rPr b="1"/>
-              <a:t>a single pass</a:t>
-            </a:r>
-            <a:r>
-              <a:rPr/>
-              <a:t>; adding features costs almost nothing</a:t>
-            </a:r>
-          </a:p>
-          <a:p>
-            <a:pPr lvl="0"/>
-            <a:r>
-              <a:rPr/>
-              <a:t>But vibration and pressure are both driven by the operating point</a:t>
-            </a:r>
-          </a:p>
-          <a:p>
-            <a:pPr lvl="0"/>
-            <a:r>
-              <a:rPr/>
-              <a:t>“New” is not independent of “York” given the topic. Symptoms co-occur</a:t>
-            </a:r>
-          </a:p>
-          <a:p>
-            <a:pPr lvl="0"/>
-            <a:r>
-              <a:rPr/>
-              <a:t>So the question is not whether it holds: it is </a:t>
-            </a:r>
-            <a:r>
-              <a:rPr b="1"/>
-              <a:t>when being wrong about it costs you nothing</a:t>
-            </a:r>
-          </a:p>
-        </p:txBody>
-      </p:sp>
+      </p:pic>
     </p:spTree>
   </p:cSld>
 </p:sld>
@@ -13067,6 +13272,485 @@
 </file>
 
 <file path=ppt/slides/slide30.xml><?xml version="1.0" encoding="utf-8"?>
+<p:sld xmlns:a="http://schemas.openxmlformats.org/drawingml/2006/main" xmlns:r="http://schemas.openxmlformats.org/officeDocument/2006/relationships" xmlns:p="http://schemas.openxmlformats.org/presentationml/2006/main">
+  <p:cSld>
+    <p:spTree>
+      <p:nvGrpSpPr>
+        <p:cNvPr id="1" name=""/>
+        <p:cNvGrpSpPr/>
+        <p:nvPr/>
+      </p:nvGrpSpPr>
+      <p:grpSpPr>
+        <a:xfrm>
+          <a:off x="0" y="0"/>
+          <a:ext cx="0" cy="0"/>
+          <a:chOff x="0" y="0"/>
+          <a:chExt cx="0" cy="0"/>
+        </a:xfrm>
+      </p:grpSpPr>
+      <p:sp>
+        <p:nvSpPr>
+          <p:cNvPr id="2" name="Title 1"/>
+          <p:cNvSpPr>
+            <a:spLocks noGrp="1"/>
+          </p:cNvSpPr>
+          <p:nvPr>
+            <p:ph type="title"/>
+          </p:nvPr>
+        </p:nvSpPr>
+        <p:spPr>
+          <a:xfrm>
+            <a:off x="457200" y="205979"/>
+            <a:ext cx="8229600" cy="857250"/>
+          </a:xfrm>
+        </p:spPr>
+        <p:txBody>
+          <a:bodyPr/>
+          <a:lstStyle/>
+          <a:p>
+            <a:pPr lvl="0" indent="0" marL="0">
+              <a:buNone/>
+            </a:pPr>
+            <a:r>
+              <a:rPr/>
+              <a:t>Ten numbers, and the widths decide</a:t>
+            </a:r>
+          </a:p>
+        </p:txBody>
+      </p:sp>
+      <p:graphicFrame>
+        <p:nvGraphicFramePr>
+          <p:cNvPr id="6" name="Content Placeholder 5"/>
+          <p:cNvGraphicFramePr>
+            <a:graphicFrameLocks noGrp="1"/>
+          </p:cNvGraphicFramePr>
+          <p:nvPr>
+            <p:ph idx="1"/>
+          </p:nvPr>
+        </p:nvGraphicFramePr>
+        <p:xfrm>
+          <a:off x="457200" y="1166099"/>
+          <a:ext cx="8229600" cy="3390900"/>
+        </p:xfrm>
+        <a:graphic>
+          <a:graphicData uri="http://schemas.openxmlformats.org/drawingml/2006/table">
+            <a:tbl>
+              <a:tblPr firstRow="1" bandRow="1">
+                <a:tableStyleId>{5C22544A-7EE6-4342-B048-85BDC9FD1C3A}</a:tableStyleId>
+              </a:tblPr>
+              <a:tblGrid>
+                <a:gridCol w="1371600"/>
+                <a:gridCol w="1371600"/>
+                <a:gridCol w="1371600"/>
+                <a:gridCol w="1371600"/>
+                <a:gridCol w="1371600"/>
+                <a:gridCol w="1371600"/>
+              </a:tblGrid>
+              <a:tr h="0">
+                <a:tc>
+                  <a:txBody>
+                    <a:bodyPr/>
+                    <a:lstStyle/>
+                    <a:p>
+                      <a:pPr lvl="0" indent="0" marL="0">
+                        <a:buNone/>
+                      </a:pPr>
+                      <a:r>
+                        <a:rPr/>
+                        <a:t>Class</a:t>
+                      </a:r>
+                    </a:p>
+                  </a:txBody>
+                  <a:tcPr/>
+                </a:tc>
+                <a:tc>
+                  <a:txBody>
+                    <a:bodyPr/>
+                    <a:lstStyle/>
+                    <a:p>
+                      <a:pPr lvl="0" indent="0" marL="0">
+                        <a:buNone/>
+                      </a:pPr>
+                      <a:r>
+                        <a:rPr/>
+                        <a:t>Prior</a:t>
+                      </a:r>
+                    </a:p>
+                  </a:txBody>
+                  <a:tcPr/>
+                </a:tc>
+                <a:tc>
+                  <a:txBody>
+                    <a:bodyPr/>
+                    <a:lstStyle/>
+                    <a:p>
+                      <a:pPr lvl="0" indent="0" marL="0">
+                        <a:buNone/>
+                      </a:pPr>
+                      <a:r>
+                        <a:rPr/>
+                        <a:t>Vibration mean</a:t>
+                      </a:r>
+                    </a:p>
+                  </a:txBody>
+                  <a:tcPr/>
+                </a:tc>
+                <a:tc>
+                  <a:txBody>
+                    <a:bodyPr/>
+                    <a:lstStyle/>
+                    <a:p>
+                      <a:pPr lvl="0" indent="0" marL="0">
+                        <a:buNone/>
+                      </a:pPr>
+                      <a:r>
+                        <a:rPr/>
+                        <a:t>Vibration sd</a:t>
+                      </a:r>
+                    </a:p>
+                  </a:txBody>
+                  <a:tcPr/>
+                </a:tc>
+                <a:tc>
+                  <a:txBody>
+                    <a:bodyPr/>
+                    <a:lstStyle/>
+                    <a:p>
+                      <a:pPr lvl="0" indent="0" marL="0">
+                        <a:buNone/>
+                      </a:pPr>
+                      <a:r>
+                        <a:rPr/>
+                        <a:t>Pressure mean</a:t>
+                      </a:r>
+                    </a:p>
+                  </a:txBody>
+                  <a:tcPr/>
+                </a:tc>
+                <a:tc>
+                  <a:txBody>
+                    <a:bodyPr/>
+                    <a:lstStyle/>
+                    <a:p>
+                      <a:pPr lvl="0" indent="0" marL="0">
+                        <a:buNone/>
+                      </a:pPr>
+                      <a:r>
+                        <a:rPr/>
+                        <a:t>Pressure sd</a:t>
+                      </a:r>
+                    </a:p>
+                  </a:txBody>
+                  <a:tcPr/>
+                </a:tc>
+              </a:tr>
+              <a:tr h="0">
+                <a:tc>
+                  <a:txBody>
+                    <a:bodyPr/>
+                    <a:lstStyle/>
+                    <a:p>
+                      <a:pPr lvl="0" indent="0" marL="0">
+                        <a:buNone/>
+                      </a:pPr>
+                      <a:r>
+                        <a:rPr/>
+                        <a:t>Healthy</a:t>
+                      </a:r>
+                    </a:p>
+                  </a:txBody>
+                </a:tc>
+                <a:tc>
+                  <a:txBody>
+                    <a:bodyPr/>
+                    <a:lstStyle/>
+                    <a:p>
+                      <a:pPr lvl="0" indent="0" marL="0">
+                        <a:buNone/>
+                      </a:pPr>
+                      <a:r>
+                        <a:rPr/>
+                        <a:t>0.3875</a:t>
+                      </a:r>
+                    </a:p>
+                  </a:txBody>
+                </a:tc>
+                <a:tc>
+                  <a:txBody>
+                    <a:bodyPr/>
+                    <a:lstStyle/>
+                    <a:p>
+                      <a:pPr lvl="0" indent="0" marL="0">
+                        <a:buNone/>
+                      </a:pPr>
+                      <a:r>
+                        <a:rPr/>
+                        <a:t>41.986 Hz</a:t>
+                      </a:r>
+                    </a:p>
+                  </a:txBody>
+                </a:tc>
+                <a:tc>
+                  <a:txBody>
+                    <a:bodyPr/>
+                    <a:lstStyle/>
+                    <a:p>
+                      <a:pPr lvl="0" indent="0" marL="0">
+                        <a:buNone/>
+                      </a:pPr>
+                      <a:r>
+                        <a:rPr b="1"/>
+                        <a:t>1.695</a:t>
+                      </a:r>
+                    </a:p>
+                  </a:txBody>
+                </a:tc>
+                <a:tc>
+                  <a:txBody>
+                    <a:bodyPr/>
+                    <a:lstStyle/>
+                    <a:p>
+                      <a:pPr lvl="0" indent="0" marL="0">
+                        <a:buNone/>
+                      </a:pPr>
+                      <a:r>
+                        <a:rPr/>
+                        <a:t>5.617 bar</a:t>
+                      </a:r>
+                    </a:p>
+                  </a:txBody>
+                </a:tc>
+                <a:tc>
+                  <a:txBody>
+                    <a:bodyPr/>
+                    <a:lstStyle/>
+                    <a:p>
+                      <a:pPr lvl="0" indent="0" marL="0">
+                        <a:buNone/>
+                      </a:pPr>
+                      <a:r>
+                        <a:rPr b="1"/>
+                        <a:t>0.219</a:t>
+                      </a:r>
+                    </a:p>
+                  </a:txBody>
+                </a:tc>
+              </a:tr>
+              <a:tr h="0">
+                <a:tc>
+                  <a:txBody>
+                    <a:bodyPr/>
+                    <a:lstStyle/>
+                    <a:p>
+                      <a:pPr lvl="0" indent="0" marL="0">
+                        <a:buNone/>
+                      </a:pPr>
+                      <a:r>
+                        <a:rPr/>
+                        <a:t>Faulty</a:t>
+                      </a:r>
+                    </a:p>
+                  </a:txBody>
+                </a:tc>
+                <a:tc>
+                  <a:txBody>
+                    <a:bodyPr/>
+                    <a:lstStyle/>
+                    <a:p>
+                      <a:pPr lvl="0" indent="0" marL="0">
+                        <a:buNone/>
+                      </a:pPr>
+                      <a:r>
+                        <a:rPr/>
+                        <a:t>0.6125</a:t>
+                      </a:r>
+                    </a:p>
+                  </a:txBody>
+                </a:tc>
+                <a:tc>
+                  <a:txBody>
+                    <a:bodyPr/>
+                    <a:lstStyle/>
+                    <a:p>
+                      <a:pPr lvl="0" indent="0" marL="0">
+                        <a:buNone/>
+                      </a:pPr>
+                      <a:r>
+                        <a:rPr/>
+                        <a:t>42.015 Hz</a:t>
+                      </a:r>
+                    </a:p>
+                  </a:txBody>
+                </a:tc>
+                <a:tc>
+                  <a:txBody>
+                    <a:bodyPr/>
+                    <a:lstStyle/>
+                    <a:p>
+                      <a:pPr lvl="0" indent="0" marL="0">
+                        <a:buNone/>
+                      </a:pPr>
+                      <a:r>
+                        <a:rPr b="1"/>
+                        <a:t>4.636</a:t>
+                      </a:r>
+                    </a:p>
+                  </a:txBody>
+                </a:tc>
+                <a:tc>
+                  <a:txBody>
+                    <a:bodyPr/>
+                    <a:lstStyle/>
+                    <a:p>
+                      <a:pPr lvl="0" indent="0" marL="0">
+                        <a:buNone/>
+                      </a:pPr>
+                      <a:r>
+                        <a:rPr/>
+                        <a:t>5.616 bar</a:t>
+                      </a:r>
+                    </a:p>
+                  </a:txBody>
+                </a:tc>
+                <a:tc>
+                  <a:txBody>
+                    <a:bodyPr/>
+                    <a:lstStyle/>
+                    <a:p>
+                      <a:pPr lvl="0" indent="0" marL="0">
+                        <a:buNone/>
+                      </a:pPr>
+                      <a:r>
+                        <a:rPr b="1"/>
+                        <a:t>0.576</a:t>
+                      </a:r>
+                    </a:p>
+                  </a:txBody>
+                </a:tc>
+              </a:tr>
+            </a:tbl>
+          </a:graphicData>
+        </a:graphic>
+      </p:graphicFrame>
+    </p:spTree>
+  </p:cSld>
+</p:sld>
+</file>
+
+<file path=ppt/slides/slide31.xml><?xml version="1.0" encoding="utf-8"?>
+<p:sld xmlns:a="http://schemas.openxmlformats.org/drawingml/2006/main" xmlns:r="http://schemas.openxmlformats.org/officeDocument/2006/relationships" xmlns:p="http://schemas.openxmlformats.org/presentationml/2006/main">
+  <p:cSld>
+    <p:spTree>
+      <p:nvGrpSpPr>
+        <p:cNvPr id="1" name=""/>
+        <p:cNvGrpSpPr/>
+        <p:nvPr/>
+      </p:nvGrpSpPr>
+      <p:grpSpPr>
+        <a:xfrm>
+          <a:off x="0" y="0"/>
+          <a:ext cx="0" cy="0"/>
+          <a:chOff x="0" y="0"/>
+          <a:chExt cx="0" cy="0"/>
+        </a:xfrm>
+      </p:grpSpPr>
+      <p:sp>
+        <p:nvSpPr>
+          <p:cNvPr id="2" name="Title 1"/>
+          <p:cNvSpPr>
+            <a:spLocks noGrp="1"/>
+          </p:cNvSpPr>
+          <p:nvPr>
+            <p:ph type="title"/>
+          </p:nvPr>
+        </p:nvSpPr>
+        <p:spPr>
+          <a:xfrm>
+            <a:off x="457200" y="205979"/>
+            <a:ext cx="8229600" cy="857250"/>
+          </a:xfrm>
+        </p:spPr>
+        <p:txBody>
+          <a:bodyPr/>
+          <a:lstStyle/>
+          <a:p>
+            <a:pPr lvl="0" indent="0" marL="0">
+              <a:buNone/>
+            </a:pPr>
+            <a:r>
+              <a:rPr/>
+              <a:t>A wonderful bargain, and almost never true</a:t>
+            </a:r>
+          </a:p>
+        </p:txBody>
+      </p:sp>
+      <p:sp>
+        <p:nvSpPr>
+          <p:cNvPr id="3" name="Content Placeholder 2"/>
+          <p:cNvSpPr>
+            <a:spLocks noGrp="1"/>
+          </p:cNvSpPr>
+          <p:nvPr>
+            <p:ph idx="1"/>
+          </p:nvPr>
+        </p:nvSpPr>
+        <p:spPr>
+          <a:xfrm>
+            <a:off x="457200" y="1200151"/>
+            <a:ext cx="8229600" cy="3394472"/>
+          </a:xfrm>
+        </p:spPr>
+        <p:txBody>
+          <a:bodyPr/>
+          <a:lstStyle/>
+          <a:p>
+            <a:pPr lvl="0"/>
+            <a:r>
+              <a:rPr/>
+              <a:t>Training is </a:t>
+            </a:r>
+            <a:r>
+              <a:rPr b="1"/>
+              <a:t>a single pass</a:t>
+            </a:r>
+            <a:r>
+              <a:rPr/>
+              <a:t>; adding features costs almost nothing</a:t>
+            </a:r>
+          </a:p>
+          <a:p>
+            <a:pPr lvl="0"/>
+            <a:r>
+              <a:rPr/>
+              <a:t>But vibration and pressure are both driven by the operating point</a:t>
+            </a:r>
+          </a:p>
+          <a:p>
+            <a:pPr lvl="0"/>
+            <a:r>
+              <a:rPr/>
+              <a:t>“New” is not independent of “York” given the topic. Symptoms co-occur</a:t>
+            </a:r>
+          </a:p>
+          <a:p>
+            <a:pPr lvl="0"/>
+            <a:r>
+              <a:rPr/>
+              <a:t>So the question is not whether it holds: it is </a:t>
+            </a:r>
+            <a:r>
+              <a:rPr b="1"/>
+              <a:t>when being wrong about it costs you nothing</a:t>
+            </a:r>
+          </a:p>
+        </p:txBody>
+      </p:sp>
+    </p:spTree>
+  </p:cSld>
+</p:sld>
+</file>
+
+<file path=ppt/slides/slide32.xml><?xml version="1.0" encoding="utf-8"?>
 <p:sld xmlns:a="http://schemas.openxmlformats.org/drawingml/2006/main" xmlns:r="http://schemas.openxmlformats.org/officeDocument/2006/relationships" xmlns:p="http://schemas.openxmlformats.org/presentationml/2006/main">
   <p:cSld>
     <p:spTree>
@@ -13308,7 +13992,7 @@
 </p:sld>
 </file>
 
-<file path=ppt/slides/slide31.xml><?xml version="1.0" encoding="utf-8"?>
+<file path=ppt/slides/slide33.xml><?xml version="1.0" encoding="utf-8"?>
 <p:sld xmlns:a="http://schemas.openxmlformats.org/drawingml/2006/main" xmlns:r="http://schemas.openxmlformats.org/officeDocument/2006/relationships" xmlns:p="http://schemas.openxmlformats.org/presentationml/2006/main">
   <p:cSld>
     <p:spTree>
@@ -13518,7 +14202,7 @@
 </p:sld>
 </file>
 
-<file path=ppt/slides/slide32.xml><?xml version="1.0" encoding="utf-8"?>
+<file path=ppt/slides/slide34.xml><?xml version="1.0" encoding="utf-8"?>
 <p:sld xmlns:a="http://schemas.openxmlformats.org/drawingml/2006/main" xmlns:r="http://schemas.openxmlformats.org/officeDocument/2006/relationships" xmlns:p="http://schemas.openxmlformats.org/presentationml/2006/main">
   <p:cSld>
     <p:spTree>
@@ -13620,7 +14304,7 @@
 </p:sld>
 </file>
 
-<file path=ppt/slides/slide33.xml><?xml version="1.0" encoding="utf-8"?>
+<file path=ppt/slides/slide35.xml><?xml version="1.0" encoding="utf-8"?>
 <p:sld xmlns:a="http://schemas.openxmlformats.org/drawingml/2006/main" xmlns:r="http://schemas.openxmlformats.org/officeDocument/2006/relationships" xmlns:p="http://schemas.openxmlformats.org/presentationml/2006/main">
   <p:cSld>
     <p:spTree>
@@ -13702,7 +14386,7 @@
 </p:sld>
 </file>
 
-<file path=ppt/slides/slide34.xml><?xml version="1.0" encoding="utf-8"?>
+<file path=ppt/slides/slide36.xml><?xml version="1.0" encoding="utf-8"?>
 <p:sld xmlns:a="http://schemas.openxmlformats.org/drawingml/2006/main" xmlns:r="http://schemas.openxmlformats.org/officeDocument/2006/relationships" xmlns:p="http://schemas.openxmlformats.org/presentationml/2006/main">
   <p:cSld>
     <p:spTree>
@@ -14008,199 +14692,6 @@
 </p:sld>
 </file>
 
-<file path=ppt/slides/slide35.xml><?xml version="1.0" encoding="utf-8"?>
-<p:sld xmlns:a="http://schemas.openxmlformats.org/drawingml/2006/main" xmlns:r="http://schemas.openxmlformats.org/officeDocument/2006/relationships" xmlns:p="http://schemas.openxmlformats.org/presentationml/2006/main">
-  <p:cSld>
-    <p:spTree>
-      <p:nvGrpSpPr>
-        <p:cNvPr id="1" name=""/>
-        <p:cNvGrpSpPr/>
-        <p:nvPr/>
-      </p:nvGrpSpPr>
-      <p:grpSpPr>
-        <a:xfrm>
-          <a:off x="0" y="0"/>
-          <a:ext cx="0" cy="0"/>
-          <a:chOff x="0" y="0"/>
-          <a:chExt cx="0" cy="0"/>
-        </a:xfrm>
-      </p:grpSpPr>
-      <p:sp>
-        <p:nvSpPr>
-          <p:cNvPr id="2" name="Title 1"/>
-          <p:cNvSpPr>
-            <a:spLocks noGrp="1"/>
-          </p:cNvSpPr>
-          <p:nvPr>
-            <p:ph type="title"/>
-          </p:nvPr>
-        </p:nvSpPr>
-        <p:spPr>
-          <a:xfrm>
-            <a:off x="457200" y="205979"/>
-            <a:ext cx="8229600" cy="857250"/>
-          </a:xfrm>
-        </p:spPr>
-        <p:txBody>
-          <a:bodyPr/>
-          <a:lstStyle/>
-          <a:p>
-            <a:pPr lvl="0" indent="0" marL="0">
-              <a:buNone/>
-            </a:pPr>
-            <a:r>
-              <a:rPr/>
-              <a:t>Its probabilities are not probabilities</a:t>
-            </a:r>
-          </a:p>
-        </p:txBody>
-      </p:sp>
-      <p:sp>
-        <p:nvSpPr>
-          <p:cNvPr id="3" name="Content Placeholder 2"/>
-          <p:cNvSpPr>
-            <a:spLocks noGrp="1"/>
-          </p:cNvSpPr>
-          <p:nvPr>
-            <p:ph idx="1"/>
-          </p:nvPr>
-        </p:nvSpPr>
-        <p:spPr>
-          <a:xfrm>
-            <a:off x="457200" y="1200151"/>
-            <a:ext cx="8229600" cy="3394472"/>
-          </a:xfrm>
-        </p:spPr>
-        <p:txBody>
-          <a:bodyPr/>
-          <a:lstStyle/>
-          <a:p>
-            <a:pPr lvl="0"/>
-            <a:r>
-              <a:rPr/>
-              <a:t>Mean confidence when </a:t>
-            </a:r>
-            <a:r>
-              <a:rPr b="1"/>
-              <a:t>correct: 0.567</a:t>
-            </a:r>
-            <a:r>
-              <a:rPr/>
-              <a:t>. When </a:t>
-            </a:r>
-            <a:r>
-              <a:rPr b="1"/>
-              <a:t>wrong: 0.555</a:t>
-            </a:r>
-          </a:p>
-          <a:p>
-            <a:pPr lvl="0"/>
-            <a:r>
-              <a:rPr/>
-              <a:t>It cannot tell the difference between the two situations</a:t>
-            </a:r>
-          </a:p>
-          <a:p>
-            <a:pPr lvl="0"/>
-            <a:r>
-              <a:rPr/>
-              <a:t>With correlated features it fails the other way: 0.999 reported, with an accuracy nothing like that</a:t>
-            </a:r>
-          </a:p>
-          <a:p>
-            <a:pPr lvl="0"/>
-            <a:r>
-              <a:rPr b="1"/>
-              <a:t>The ranking may be useful while the probabilities are not</a:t>
-            </a:r>
-          </a:p>
-        </p:txBody>
-      </p:sp>
-    </p:spTree>
-  </p:cSld>
-</p:sld>
-</file>
-
-<file path=ppt/slides/slide36.xml><?xml version="1.0" encoding="utf-8"?>
-<p:sld xmlns:a="http://schemas.openxmlformats.org/drawingml/2006/main" xmlns:r="http://schemas.openxmlformats.org/officeDocument/2006/relationships" xmlns:p="http://schemas.openxmlformats.org/presentationml/2006/main">
-  <p:cSld>
-    <p:spTree>
-      <p:nvGrpSpPr>
-        <p:cNvPr id="1" name=""/>
-        <p:cNvGrpSpPr/>
-        <p:nvPr/>
-      </p:nvGrpSpPr>
-      <p:grpSpPr>
-        <a:xfrm>
-          <a:off x="0" y="0"/>
-          <a:ext cx="0" cy="0"/>
-          <a:chOff x="0" y="0"/>
-          <a:chExt cx="0" cy="0"/>
-        </a:xfrm>
-      </p:grpSpPr>
-      <p:sp>
-        <p:nvSpPr>
-          <p:cNvPr id="2" name="Title 1"/>
-          <p:cNvSpPr>
-            <a:spLocks noGrp="1"/>
-          </p:cNvSpPr>
-          <p:nvPr>
-            <p:ph type="title"/>
-          </p:nvPr>
-        </p:nvSpPr>
-        <p:spPr>
-          <a:xfrm>
-            <a:off x="457200" y="205979"/>
-            <a:ext cx="8229600" cy="857250"/>
-          </a:xfrm>
-        </p:spPr>
-        <p:txBody>
-          <a:bodyPr/>
-          <a:lstStyle/>
-          <a:p>
-            <a:pPr lvl="0" indent="0" marL="0">
-              <a:buNone/>
-            </a:pPr>
-            <a:r>
-              <a:rPr/>
-              <a:t>Notebook 2, live</a:t>
-            </a:r>
-          </a:p>
-        </p:txBody>
-      </p:sp>
-      <p:sp>
-        <p:nvSpPr>
-          <p:cNvPr id="3" name="Content Placeholder 2"/>
-          <p:cNvSpPr>
-            <a:spLocks noGrp="1"/>
-          </p:cNvSpPr>
-          <p:nvPr>
-            <p:ph idx="1"/>
-          </p:nvPr>
-        </p:nvSpPr>
-        <p:spPr>
-          <a:xfrm>
-            <a:off x="457200" y="1200151"/>
-            <a:ext cx="8229600" cy="3394472"/>
-          </a:xfrm>
-        </p:spPr>
-        <p:txBody>
-          <a:bodyPr/>
-          <a:lstStyle/>
-          <a:p>
-            <a:pPr lvl="0"/>
-            <a:r>
-              <a:rPr/>
-              <a:t>Where the assumption holds, and one step away where it does not</a:t>
-            </a:r>
-          </a:p>
-        </p:txBody>
-      </p:sp>
-    </p:spTree>
-  </p:cSld>
-</p:sld>
-</file>
-
 <file path=ppt/slides/slide37.xml><?xml version="1.0" encoding="utf-8"?>
 <p:sld xmlns:a="http://schemas.openxmlformats.org/drawingml/2006/main" xmlns:r="http://schemas.openxmlformats.org/officeDocument/2006/relationships" xmlns:p="http://schemas.openxmlformats.org/presentationml/2006/main">
   <p:cSld>
@@ -14243,7 +14734,7 @@
             </a:pPr>
             <a:r>
               <a:rPr/>
-              <a:t>The margin: a criterion that is not the error</a:t>
+              <a:t>Its probabilities are not probabilities</a:t>
             </a:r>
           </a:p>
         </p:txBody>
@@ -14271,48 +14762,40 @@
             <a:pPr lvl="0"/>
             <a:r>
               <a:rPr/>
-              <a:t>On separable data there are </a:t>
+              <a:t>Mean confidence when </a:t>
             </a:r>
             <a:r>
               <a:rPr b="1"/>
-              <a:t>infinitely many</a:t>
-            </a:r>
-            <a:r>
-              <a:rPr/>
-              <a:t> separating lines, and every one has </a:t>
+              <a:t>correct: 0.567</a:t>
+            </a:r>
+            <a:r>
+              <a:rPr/>
+              <a:t>. When </a:t>
             </a:r>
             <a:r>
               <a:rPr b="1"/>
-              <a:t>zero training error</a:t>
+              <a:t>wrong: 0.555</a:t>
             </a:r>
           </a:p>
           <a:p>
             <a:pPr lvl="0"/>
             <a:r>
               <a:rPr/>
-              <a:t>Minimising the error therefore cannot choose between them</a:t>
+              <a:t>It cannot tell the difference between the two situations</a:t>
             </a:r>
           </a:p>
           <a:p>
             <a:pPr lvl="0"/>
             <a:r>
               <a:rPr/>
-              <a:t>The SVM picks the widest </a:t>
-            </a:r>
+              <a:t>With correlated features it fails the other way: 0.999 reported, with an accuracy nothing like that</a:t>
+            </a:r>
+          </a:p>
+          <a:p>
+            <a:pPr lvl="0"/>
             <a:r>
               <a:rPr b="1"/>
-              <a:t>slab</a:t>
-            </a:r>
-            <a:r>
-              <a:rPr/>
-              <a:t>: push it out until it touches the nearest point of each class</a:t>
-            </a:r>
-          </a:p>
-          <a:p>
-            <a:pPr lvl="0"/>
-            <a:r>
-              <a:rPr/>
-              <a:t>A boundary passing close to a point is one small perturbation from getting it wrong</a:t>
+              <a:t>The ranking may be useful while the probabilities are not</a:t>
             </a:r>
           </a:p>
         </p:txBody>
@@ -14323,6 +14806,313 @@
 </file>
 
 <file path=ppt/slides/slide38.xml><?xml version="1.0" encoding="utf-8"?>
+<p:sld xmlns:a="http://schemas.openxmlformats.org/drawingml/2006/main" xmlns:r="http://schemas.openxmlformats.org/officeDocument/2006/relationships" xmlns:p="http://schemas.openxmlformats.org/presentationml/2006/main">
+  <p:cSld>
+    <p:spTree>
+      <p:nvGrpSpPr>
+        <p:cNvPr id="1" name=""/>
+        <p:cNvGrpSpPr/>
+        <p:nvPr/>
+      </p:nvGrpSpPr>
+      <p:grpSpPr>
+        <a:xfrm>
+          <a:off x="0" y="0"/>
+          <a:ext cx="0" cy="0"/>
+          <a:chOff x="0" y="0"/>
+          <a:chExt cx="0" cy="0"/>
+        </a:xfrm>
+      </p:grpSpPr>
+      <p:sp>
+        <p:nvSpPr>
+          <p:cNvPr id="2" name="Title 1"/>
+          <p:cNvSpPr>
+            <a:spLocks noGrp="1"/>
+          </p:cNvSpPr>
+          <p:nvPr>
+            <p:ph type="title"/>
+          </p:nvPr>
+        </p:nvSpPr>
+        <p:spPr>
+          <a:xfrm>
+            <a:off x="457200" y="205979"/>
+            <a:ext cx="8229600" cy="857250"/>
+          </a:xfrm>
+        </p:spPr>
+        <p:txBody>
+          <a:bodyPr/>
+          <a:lstStyle/>
+          <a:p>
+            <a:pPr lvl="0" indent="0" marL="0">
+              <a:buNone/>
+            </a:pPr>
+            <a:r>
+              <a:rPr/>
+              <a:t>Notebook 2, live</a:t>
+            </a:r>
+          </a:p>
+        </p:txBody>
+      </p:sp>
+      <p:sp>
+        <p:nvSpPr>
+          <p:cNvPr id="3" name="Content Placeholder 2"/>
+          <p:cNvSpPr>
+            <a:spLocks noGrp="1"/>
+          </p:cNvSpPr>
+          <p:nvPr>
+            <p:ph idx="1"/>
+          </p:nvPr>
+        </p:nvSpPr>
+        <p:spPr>
+          <a:xfrm>
+            <a:off x="457200" y="1200151"/>
+            <a:ext cx="8229600" cy="3394472"/>
+          </a:xfrm>
+        </p:spPr>
+        <p:txBody>
+          <a:bodyPr/>
+          <a:lstStyle/>
+          <a:p>
+            <a:pPr lvl="0"/>
+            <a:r>
+              <a:rPr/>
+              <a:t>Where the assumption holds, and one step away where it does not</a:t>
+            </a:r>
+          </a:p>
+        </p:txBody>
+      </p:sp>
+    </p:spTree>
+  </p:cSld>
+</p:sld>
+</file>
+
+<file path=ppt/slides/slide39.xml><?xml version="1.0" encoding="utf-8"?>
+<p:sld xmlns:a="http://schemas.openxmlformats.org/drawingml/2006/main" xmlns:r="http://schemas.openxmlformats.org/officeDocument/2006/relationships" xmlns:p="http://schemas.openxmlformats.org/presentationml/2006/main">
+  <p:cSld>
+    <p:spTree>
+      <p:nvGrpSpPr>
+        <p:cNvPr id="1" name=""/>
+        <p:cNvGrpSpPr/>
+        <p:nvPr/>
+      </p:nvGrpSpPr>
+      <p:grpSpPr>
+        <a:xfrm>
+          <a:off x="0" y="0"/>
+          <a:ext cx="0" cy="0"/>
+          <a:chOff x="0" y="0"/>
+          <a:chExt cx="0" cy="0"/>
+        </a:xfrm>
+      </p:grpSpPr>
+      <p:sp>
+        <p:nvSpPr>
+          <p:cNvPr id="2" name="Title 1"/>
+          <p:cNvSpPr>
+            <a:spLocks noGrp="1"/>
+          </p:cNvSpPr>
+          <p:nvPr>
+            <p:ph type="title"/>
+          </p:nvPr>
+        </p:nvSpPr>
+        <p:spPr>
+          <a:xfrm>
+            <a:off x="457200" y="205979"/>
+            <a:ext cx="8229600" cy="857250"/>
+          </a:xfrm>
+        </p:spPr>
+        <p:txBody>
+          <a:bodyPr/>
+          <a:lstStyle/>
+          <a:p>
+            <a:pPr lvl="0" indent="0" marL="0">
+              <a:buNone/>
+            </a:pPr>
+            <a:r>
+              <a:rPr/>
+              <a:t>The margin: a criterion that is not the error</a:t>
+            </a:r>
+          </a:p>
+        </p:txBody>
+      </p:sp>
+      <p:sp>
+        <p:nvSpPr>
+          <p:cNvPr id="3" name="Content Placeholder 2"/>
+          <p:cNvSpPr>
+            <a:spLocks noGrp="1"/>
+          </p:cNvSpPr>
+          <p:nvPr>
+            <p:ph idx="1"/>
+          </p:nvPr>
+        </p:nvSpPr>
+        <p:spPr>
+          <a:xfrm>
+            <a:off x="457200" y="1200151"/>
+            <a:ext cx="8229600" cy="3394472"/>
+          </a:xfrm>
+        </p:spPr>
+        <p:txBody>
+          <a:bodyPr/>
+          <a:lstStyle/>
+          <a:p>
+            <a:pPr lvl="0"/>
+            <a:r>
+              <a:rPr/>
+              <a:t>On separable data there are </a:t>
+            </a:r>
+            <a:r>
+              <a:rPr b="1"/>
+              <a:t>infinitely many</a:t>
+            </a:r>
+            <a:r>
+              <a:rPr/>
+              <a:t> separating lines, and every one has </a:t>
+            </a:r>
+            <a:r>
+              <a:rPr b="1"/>
+              <a:t>zero training error</a:t>
+            </a:r>
+          </a:p>
+          <a:p>
+            <a:pPr lvl="0"/>
+            <a:r>
+              <a:rPr/>
+              <a:t>Minimising the error therefore cannot choose between them</a:t>
+            </a:r>
+          </a:p>
+          <a:p>
+            <a:pPr lvl="0"/>
+            <a:r>
+              <a:rPr/>
+              <a:t>The SVM picks the widest </a:t>
+            </a:r>
+            <a:r>
+              <a:rPr b="1"/>
+              <a:t>slab</a:t>
+            </a:r>
+            <a:r>
+              <a:rPr/>
+              <a:t>: push it out until it touches the nearest point of each class</a:t>
+            </a:r>
+          </a:p>
+          <a:p>
+            <a:pPr lvl="0"/>
+            <a:r>
+              <a:rPr/>
+              <a:t>A boundary passing close to a point is one small perturbation from getting it wrong</a:t>
+            </a:r>
+          </a:p>
+        </p:txBody>
+      </p:sp>
+    </p:spTree>
+  </p:cSld>
+</p:sld>
+</file>
+
+<file path=ppt/slides/slide4.xml><?xml version="1.0" encoding="utf-8"?>
+<p:sld xmlns:a="http://schemas.openxmlformats.org/drawingml/2006/main" xmlns:r="http://schemas.openxmlformats.org/officeDocument/2006/relationships" xmlns:p="http://schemas.openxmlformats.org/presentationml/2006/main">
+  <p:cSld>
+    <p:spTree>
+      <p:nvGrpSpPr>
+        <p:cNvPr id="1" name=""/>
+        <p:cNvGrpSpPr/>
+        <p:nvPr/>
+      </p:nvGrpSpPr>
+      <p:grpSpPr>
+        <a:xfrm>
+          <a:off x="0" y="0"/>
+          <a:ext cx="0" cy="0"/>
+          <a:chOff x="0" y="0"/>
+          <a:chExt cx="0" cy="0"/>
+        </a:xfrm>
+      </p:grpSpPr>
+      <p:sp>
+        <p:nvSpPr>
+          <p:cNvPr id="2" name="Title 1"/>
+          <p:cNvSpPr>
+            <a:spLocks noGrp="1"/>
+          </p:cNvSpPr>
+          <p:nvPr>
+            <p:ph type="title"/>
+          </p:nvPr>
+        </p:nvSpPr>
+        <p:spPr>
+          <a:xfrm>
+            <a:off x="457200" y="205979"/>
+            <a:ext cx="8229600" cy="857250"/>
+          </a:xfrm>
+        </p:spPr>
+        <p:txBody>
+          <a:bodyPr/>
+          <a:lstStyle/>
+          <a:p>
+            <a:pPr lvl="0" indent="0" marL="0">
+              <a:buNone/>
+            </a:pPr>
+            <a:r>
+              <a:rPr/>
+              <a:t>1,200 pumps, two readings each</a:t>
+            </a:r>
+          </a:p>
+        </p:txBody>
+      </p:sp>
+      <p:sp>
+        <p:nvSpPr>
+          <p:cNvPr id="3" name="Content Placeholder 2"/>
+          <p:cNvSpPr>
+            <a:spLocks noGrp="1"/>
+          </p:cNvSpPr>
+          <p:nvPr>
+            <p:ph idx="1"/>
+          </p:nvPr>
+        </p:nvSpPr>
+        <p:spPr>
+          <a:xfrm>
+            <a:off x="457200" y="1200151"/>
+            <a:ext cx="8229600" cy="3394472"/>
+          </a:xfrm>
+        </p:spPr>
+        <p:txBody>
+          <a:bodyPr/>
+          <a:lstStyle/>
+          <a:p>
+            <a:pPr lvl="0"/>
+            <a:r>
+              <a:rPr/>
+              <a:t>Vibration in Hz, pressure in bar</a:t>
+            </a:r>
+          </a:p>
+          <a:p>
+            <a:pPr lvl="0"/>
+            <a:r>
+              <a:rPr/>
+              <a:t>A pump is faulty when its readings fall </a:t>
+            </a:r>
+            <a:r>
+              <a:rPr b="1"/>
+              <a:t>outside the design envelope</a:t>
+            </a:r>
+            <a:r>
+              <a:rPr/>
+              <a:t>, too low as readily as too high</a:t>
+            </a:r>
+          </a:p>
+          <a:p>
+            <a:pPr lvl="0"/>
+            <a:r>
+              <a:rPr b="1"/>
+              <a:t>61.3%</a:t>
+            </a:r>
+            <a:r>
+              <a:rPr/>
+              <a:t> faulty; 4% of the labels are deliberately flipped</a:t>
+            </a:r>
+          </a:p>
+        </p:txBody>
+      </p:sp>
+    </p:spTree>
+  </p:cSld>
+</p:sld>
+</file>
+
+<file path=ppt/slides/slide40.xml><?xml version="1.0" encoding="utf-8"?>
 <p:sld xmlns:a="http://schemas.openxmlformats.org/drawingml/2006/main" xmlns:r="http://schemas.openxmlformats.org/officeDocument/2006/relationships" xmlns:p="http://schemas.openxmlformats.org/presentationml/2006/main">
   <p:cSld>
     <p:spTree>
@@ -14404,7 +15194,7 @@
 </p:sld>
 </file>
 
-<file path=ppt/slides/slide39.xml><?xml version="1.0" encoding="utf-8"?>
+<file path=ppt/slides/slide41.xml><?xml version="1.0" encoding="utf-8"?>
 <p:sld xmlns:a="http://schemas.openxmlformats.org/drawingml/2006/main" xmlns:r="http://schemas.openxmlformats.org/officeDocument/2006/relationships" xmlns:p="http://schemas.openxmlformats.org/presentationml/2006/main">
   <p:cSld>
     <p:spTree>
@@ -14502,113 +15292,7 @@
 </p:sld>
 </file>
 
-<file path=ppt/slides/slide4.xml><?xml version="1.0" encoding="utf-8"?>
-<p:sld xmlns:a="http://schemas.openxmlformats.org/drawingml/2006/main" xmlns:r="http://schemas.openxmlformats.org/officeDocument/2006/relationships" xmlns:p="http://schemas.openxmlformats.org/presentationml/2006/main">
-  <p:cSld>
-    <p:spTree>
-      <p:nvGrpSpPr>
-        <p:cNvPr id="1" name=""/>
-        <p:cNvGrpSpPr/>
-        <p:nvPr/>
-      </p:nvGrpSpPr>
-      <p:grpSpPr>
-        <a:xfrm>
-          <a:off x="0" y="0"/>
-          <a:ext cx="0" cy="0"/>
-          <a:chOff x="0" y="0"/>
-          <a:chExt cx="0" cy="0"/>
-        </a:xfrm>
-      </p:grpSpPr>
-      <p:sp>
-        <p:nvSpPr>
-          <p:cNvPr id="2" name="Title 1"/>
-          <p:cNvSpPr>
-            <a:spLocks noGrp="1"/>
-          </p:cNvSpPr>
-          <p:nvPr>
-            <p:ph type="title"/>
-          </p:nvPr>
-        </p:nvSpPr>
-        <p:spPr>
-          <a:xfrm>
-            <a:off x="457200" y="205979"/>
-            <a:ext cx="8229600" cy="857250"/>
-          </a:xfrm>
-        </p:spPr>
-        <p:txBody>
-          <a:bodyPr/>
-          <a:lstStyle/>
-          <a:p>
-            <a:pPr lvl="0" indent="0" marL="0">
-              <a:buNone/>
-            </a:pPr>
-            <a:r>
-              <a:rPr/>
-              <a:t>1,200 pumps, two readings each</a:t>
-            </a:r>
-          </a:p>
-        </p:txBody>
-      </p:sp>
-      <p:sp>
-        <p:nvSpPr>
-          <p:cNvPr id="3" name="Content Placeholder 2"/>
-          <p:cNvSpPr>
-            <a:spLocks noGrp="1"/>
-          </p:cNvSpPr>
-          <p:nvPr>
-            <p:ph idx="1"/>
-          </p:nvPr>
-        </p:nvSpPr>
-        <p:spPr>
-          <a:xfrm>
-            <a:off x="457200" y="1200151"/>
-            <a:ext cx="8229600" cy="3394472"/>
-          </a:xfrm>
-        </p:spPr>
-        <p:txBody>
-          <a:bodyPr/>
-          <a:lstStyle/>
-          <a:p>
-            <a:pPr lvl="0"/>
-            <a:r>
-              <a:rPr/>
-              <a:t>Vibration in Hz, pressure in bar</a:t>
-            </a:r>
-          </a:p>
-          <a:p>
-            <a:pPr lvl="0"/>
-            <a:r>
-              <a:rPr/>
-              <a:t>A pump is faulty when its readings fall </a:t>
-            </a:r>
-            <a:r>
-              <a:rPr b="1"/>
-              <a:t>outside the design envelope</a:t>
-            </a:r>
-            <a:r>
-              <a:rPr/>
-              <a:t>, too low as readily as too high</a:t>
-            </a:r>
-          </a:p>
-          <a:p>
-            <a:pPr lvl="0"/>
-            <a:r>
-              <a:rPr b="1"/>
-              <a:t>61.3%</a:t>
-            </a:r>
-            <a:r>
-              <a:rPr/>
-              <a:t> faulty; 4% of the labels are deliberately flipped</a:t>
-            </a:r>
-          </a:p>
-        </p:txBody>
-      </p:sp>
-    </p:spTree>
-  </p:cSld>
-</p:sld>
-</file>
-
-<file path=ppt/slides/slide40.xml><?xml version="1.0" encoding="utf-8"?>
+<file path=ppt/slides/slide42.xml><?xml version="1.0" encoding="utf-8"?>
 <p:sld xmlns:a="http://schemas.openxmlformats.org/drawingml/2006/main" xmlns:r="http://schemas.openxmlformats.org/officeDocument/2006/relationships" xmlns:p="http://schemas.openxmlformats.org/presentationml/2006/main">
   <p:cSld>
     <p:spTree>
@@ -14690,7 +15374,7 @@
 </p:sld>
 </file>
 
-<file path=ppt/slides/slide41.xml><?xml version="1.0" encoding="utf-8"?>
+<file path=ppt/slides/slide43.xml><?xml version="1.0" encoding="utf-8"?>
 <p:sld xmlns:a="http://schemas.openxmlformats.org/drawingml/2006/main" xmlns:r="http://schemas.openxmlformats.org/officeDocument/2006/relationships" xmlns:p="http://schemas.openxmlformats.org/presentationml/2006/main">
   <p:cSld>
     <p:spTree>
@@ -14803,7 +15487,7 @@
 </p:sld>
 </file>
 
-<file path=ppt/slides/slide42.xml><?xml version="1.0" encoding="utf-8"?>
+<file path=ppt/slides/slide44.xml><?xml version="1.0" encoding="utf-8"?>
 <p:sld xmlns:a="http://schemas.openxmlformats.org/drawingml/2006/main" xmlns:r="http://schemas.openxmlformats.org/officeDocument/2006/relationships" xmlns:p="http://schemas.openxmlformats.org/presentationml/2006/main">
   <p:cSld>
     <p:spTree>
@@ -15036,7 +15720,7 @@
 </p:sld>
 </file>
 
-<file path=ppt/slides/slide43.xml><?xml version="1.0" encoding="utf-8"?>
+<file path=ppt/slides/slide45.xml><?xml version="1.0" encoding="utf-8"?>
 <p:sld xmlns:a="http://schemas.openxmlformats.org/drawingml/2006/main" xmlns:r="http://schemas.openxmlformats.org/officeDocument/2006/relationships" xmlns:p="http://schemas.openxmlformats.org/presentationml/2006/main">
   <p:cSld>
     <p:spTree>
@@ -15159,7 +15843,7 @@
 </p:sld>
 </file>
 
-<file path=ppt/slides/slide44.xml><?xml version="1.0" encoding="utf-8"?>
+<file path=ppt/slides/slide46.xml><?xml version="1.0" encoding="utf-8"?>
 <p:sld xmlns:a="http://schemas.openxmlformats.org/drawingml/2006/main" xmlns:r="http://schemas.openxmlformats.org/officeDocument/2006/relationships" xmlns:p="http://schemas.openxmlformats.org/presentationml/2006/main">
   <p:cSld>
     <p:spTree>
@@ -15268,7 +15952,7 @@
 </p:sld>
 </file>
 
-<file path=ppt/slides/slide45.xml><?xml version="1.0" encoding="utf-8"?>
+<file path=ppt/slides/slide47.xml><?xml version="1.0" encoding="utf-8"?>
 <p:sld xmlns:a="http://schemas.openxmlformats.org/drawingml/2006/main" xmlns:r="http://schemas.openxmlformats.org/officeDocument/2006/relationships" xmlns:p="http://schemas.openxmlformats.org/presentationml/2006/main">
   <p:cSld>
     <p:spTree>
@@ -15350,7 +16034,7 @@
 </p:sld>
 </file>
 
-<file path=ppt/slides/slide46.xml><?xml version="1.0" encoding="utf-8"?>
+<file path=ppt/slides/slide48.xml><?xml version="1.0" encoding="utf-8"?>
 <p:sld xmlns:a="http://schemas.openxmlformats.org/drawingml/2006/main" xmlns:r="http://schemas.openxmlformats.org/officeDocument/2006/relationships" xmlns:p="http://schemas.openxmlformats.org/presentationml/2006/main">
   <p:cSld>
     <p:spTree>
@@ -15468,7 +16152,7 @@
 </p:sld>
 </file>
 
-<file path=ppt/slides/slide47.xml><?xml version="1.0" encoding="utf-8"?>
+<file path=ppt/slides/slide49.xml><?xml version="1.0" encoding="utf-8"?>
 <p:sld xmlns:a="http://schemas.openxmlformats.org/drawingml/2006/main" xmlns:r="http://schemas.openxmlformats.org/officeDocument/2006/relationships" xmlns:p="http://schemas.openxmlformats.org/presentationml/2006/main">
   <p:cSld>
     <p:spTree>
@@ -15550,7 +16234,89 @@
 </p:sld>
 </file>
 
-<file path=ppt/slides/slide48.xml><?xml version="1.0" encoding="utf-8"?>
+<file path=ppt/slides/slide5.xml><?xml version="1.0" encoding="utf-8"?>
+<p:sld xmlns:a="http://schemas.openxmlformats.org/drawingml/2006/main" xmlns:r="http://schemas.openxmlformats.org/officeDocument/2006/relationships" xmlns:p="http://schemas.openxmlformats.org/presentationml/2006/main">
+  <p:cSld>
+    <p:spTree>
+      <p:nvGrpSpPr>
+        <p:cNvPr id="1" name=""/>
+        <p:cNvGrpSpPr/>
+        <p:nvPr/>
+      </p:nvGrpSpPr>
+      <p:grpSpPr>
+        <a:xfrm>
+          <a:off x="0" y="0"/>
+          <a:ext cx="0" cy="0"/>
+          <a:chOff x="0" y="0"/>
+          <a:chExt cx="0" cy="0"/>
+        </a:xfrm>
+      </p:grpSpPr>
+      <p:sp>
+        <p:nvSpPr>
+          <p:cNvPr id="2" name="Title 1"/>
+          <p:cNvSpPr>
+            <a:spLocks noGrp="1"/>
+          </p:cNvSpPr>
+          <p:nvPr>
+            <p:ph type="title"/>
+          </p:nvPr>
+        </p:nvSpPr>
+        <p:spPr>
+          <a:xfrm>
+            <a:off x="457200" y="205979"/>
+            <a:ext cx="8229600" cy="857250"/>
+          </a:xfrm>
+        </p:spPr>
+        <p:txBody>
+          <a:bodyPr/>
+          <a:lstStyle/>
+          <a:p>
+            <a:pPr lvl="0" indent="0" marL="0">
+              <a:buNone/>
+            </a:pPr>
+            <a:r>
+              <a:rPr/>
+              <a:t>The shape of the problem</a:t>
+            </a:r>
+          </a:p>
+        </p:txBody>
+      </p:sp>
+      <p:pic>
+        <p:nvPicPr>
+          <p:cNvPr descr="pump_scatter.png" id="0" name="Picture 1"/>
+          <p:cNvPicPr>
+            <a:picLocks noGrp="1" noChangeAspect="1"/>
+          </p:cNvPicPr>
+          <p:nvPr/>
+        </p:nvPicPr>
+        <p:blipFill>
+          <a:blip r:embed="rId3"/>
+          <a:stretch>
+            <a:fillRect/>
+          </a:stretch>
+        </p:blipFill>
+        <p:spPr bwMode="auto">
+          <a:xfrm>
+            <a:off x="2445144" y="1166099"/>
+            <a:ext cx="4253712" cy="3360181"/>
+          </a:xfrm>
+          <a:prstGeom prst="rect">
+            <a:avLst/>
+          </a:prstGeom>
+          <a:noFill/>
+          <a:ln w="9525">
+            <a:noFill/>
+            <a:headEnd/>
+            <a:tailEnd/>
+          </a:ln>
+        </p:spPr>
+      </p:pic>
+    </p:spTree>
+  </p:cSld>
+</p:sld>
+</file>
+
+<file path=ppt/slides/slide50.xml><?xml version="1.0" encoding="utf-8"?>
 <p:sld xmlns:a="http://schemas.openxmlformats.org/drawingml/2006/main" xmlns:r="http://schemas.openxmlformats.org/officeDocument/2006/relationships" xmlns:p="http://schemas.openxmlformats.org/presentationml/2006/main">
   <p:cSld>
     <p:spTree>
@@ -15822,7 +16588,7 @@
 </p:sld>
 </file>
 
-<file path=ppt/slides/slide49.xml><?xml version="1.0" encoding="utf-8"?>
+<file path=ppt/slides/slide51.xml><?xml version="1.0" encoding="utf-8"?>
 <p:sld xmlns:a="http://schemas.openxmlformats.org/drawingml/2006/main" xmlns:r="http://schemas.openxmlformats.org/officeDocument/2006/relationships" xmlns:p="http://schemas.openxmlformats.org/presentationml/2006/main">
   <p:cSld>
     <p:spTree>
@@ -15904,7 +16670,7 @@
 </p:sld>
 </file>
 
-<file path=ppt/slides/slide5.xml><?xml version="1.0" encoding="utf-8"?>
+<file path=ppt/slides/slide52.xml><?xml version="1.0" encoding="utf-8"?>
 <p:sld xmlns:a="http://schemas.openxmlformats.org/drawingml/2006/main" xmlns:r="http://schemas.openxmlformats.org/officeDocument/2006/relationships" xmlns:p="http://schemas.openxmlformats.org/presentationml/2006/main">
   <p:cSld>
     <p:spTree>
@@ -15946,88 +16712,6 @@
             </a:pPr>
             <a:r>
               <a:rPr/>
-              <a:t>The shape of the problem</a:t>
-            </a:r>
-          </a:p>
-        </p:txBody>
-      </p:sp>
-      <p:pic>
-        <p:nvPicPr>
-          <p:cNvPr descr="pump_scatter.png" id="0" name="Picture 1"/>
-          <p:cNvPicPr>
-            <a:picLocks noGrp="1" noChangeAspect="1"/>
-          </p:cNvPicPr>
-          <p:nvPr/>
-        </p:nvPicPr>
-        <p:blipFill>
-          <a:blip r:embed="rId3"/>
-          <a:stretch>
-            <a:fillRect/>
-          </a:stretch>
-        </p:blipFill>
-        <p:spPr bwMode="auto">
-          <a:xfrm>
-            <a:off x="2445144" y="1166099"/>
-            <a:ext cx="4253712" cy="3360181"/>
-          </a:xfrm>
-          <a:prstGeom prst="rect">
-            <a:avLst/>
-          </a:prstGeom>
-          <a:noFill/>
-          <a:ln w="9525">
-            <a:noFill/>
-            <a:headEnd/>
-            <a:tailEnd/>
-          </a:ln>
-        </p:spPr>
-      </p:pic>
-    </p:spTree>
-  </p:cSld>
-</p:sld>
-</file>
-
-<file path=ppt/slides/slide50.xml><?xml version="1.0" encoding="utf-8"?>
-<p:sld xmlns:a="http://schemas.openxmlformats.org/drawingml/2006/main" xmlns:r="http://schemas.openxmlformats.org/officeDocument/2006/relationships" xmlns:p="http://schemas.openxmlformats.org/presentationml/2006/main">
-  <p:cSld>
-    <p:spTree>
-      <p:nvGrpSpPr>
-        <p:cNvPr id="1" name=""/>
-        <p:cNvGrpSpPr/>
-        <p:nvPr/>
-      </p:nvGrpSpPr>
-      <p:grpSpPr>
-        <a:xfrm>
-          <a:off x="0" y="0"/>
-          <a:ext cx="0" cy="0"/>
-          <a:chOff x="0" y="0"/>
-          <a:chExt cx="0" cy="0"/>
-        </a:xfrm>
-      </p:grpSpPr>
-      <p:sp>
-        <p:nvSpPr>
-          <p:cNvPr id="2" name="Title 1"/>
-          <p:cNvSpPr>
-            <a:spLocks noGrp="1"/>
-          </p:cNvSpPr>
-          <p:nvPr>
-            <p:ph type="title"/>
-          </p:nvPr>
-        </p:nvSpPr>
-        <p:spPr>
-          <a:xfrm>
-            <a:off x="457200" y="205979"/>
-            <a:ext cx="8229600" cy="857250"/>
-          </a:xfrm>
-        </p:spPr>
-        <p:txBody>
-          <a:bodyPr/>
-          <a:lstStyle/>
-          <a:p>
-            <a:pPr lvl="0" indent="0" marL="0">
-              <a:buNone/>
-            </a:pPr>
-            <a:r>
-              <a:rPr/>
               <a:t>Notebook 3, live</a:t>
             </a:r>
           </a:p>
@@ -16066,7 +16750,7 @@
 </p:sld>
 </file>
 
-<file path=ppt/slides/slide51.xml><?xml version="1.0" encoding="utf-8"?>
+<file path=ppt/slides/slide53.xml><?xml version="1.0" encoding="utf-8"?>
 <p:sld xmlns:a="http://schemas.openxmlformats.org/drawingml/2006/main" xmlns:r="http://schemas.openxmlformats.org/officeDocument/2006/relationships" xmlns:p="http://schemas.openxmlformats.org/presentationml/2006/main">
   <p:cSld>
     <p:spTree>
@@ -16404,7 +17088,7 @@
 </p:sld>
 </file>
 
-<file path=ppt/slides/slide52.xml><?xml version="1.0" encoding="utf-8"?>
+<file path=ppt/slides/slide54.xml><?xml version="1.0" encoding="utf-8"?>
 <p:sld xmlns:a="http://schemas.openxmlformats.org/drawingml/2006/main" xmlns:r="http://schemas.openxmlformats.org/officeDocument/2006/relationships" xmlns:p="http://schemas.openxmlformats.org/presentationml/2006/main">
   <p:cSld>
     <p:spTree>
@@ -16682,7 +17366,7 @@
 </p:sld>
 </file>
 
-<file path=ppt/slides/slide53.xml><?xml version="1.0" encoding="utf-8"?>
+<file path=ppt/slides/slide55.xml><?xml version="1.0" encoding="utf-8"?>
 <p:sld xmlns:a="http://schemas.openxmlformats.org/drawingml/2006/main" xmlns:r="http://schemas.openxmlformats.org/officeDocument/2006/relationships" xmlns:p="http://schemas.openxmlformats.org/presentationml/2006/main">
   <p:cSld>
     <p:spTree>
@@ -16814,7 +17498,7 @@
 </p:sld>
 </file>
 
-<file path=ppt/slides/slide54.xml><?xml version="1.0" encoding="utf-8"?>
+<file path=ppt/slides/slide56.xml><?xml version="1.0" encoding="utf-8"?>
 <p:sld xmlns:a="http://schemas.openxmlformats.org/drawingml/2006/main" xmlns:r="http://schemas.openxmlformats.org/officeDocument/2006/relationships" xmlns:p="http://schemas.openxmlformats.org/presentationml/2006/main">
   <p:cSld>
     <p:spTree>

</xml_diff>

<commit_message>
Stop claiming lesson 6's pumps satisfy the naive assumption
Section 4.3, a slide, notebook 02, quiz question 17 and the exercise all
read within-class correlations of -0.006 and -0.049 as proof that the
readings are independent given the class. They are not: healthy pumps fill
a disc and faulty ones a ring, and the squared distances from the design
point correlate at -0.420 among the faulty pumps. Uncorrelated is not
independent, and the lesson now says so, names it as the mistake to expect,
and explains the 0.933 instead: with shared centres the boundary implied by
two axis-aligned bells is an axis-aligned ellipse, and the fitted one sits
at about 3.17 Hz by 0.41 bar against a true envelope of 3.5 by 0.45.

Section 4.2 also gains inference for one pump as four steps, carried by a
new slide with the worked 48 Hz pump.

Co-Authored-By: Claude Opus 5.5 <noreply@anthropic.com>
</commit_message>
<xml_diff>
--- a/Lessons/06_knn_naive_bayes_svm/Slides/knn_naive_bayes_svm_slides.pptx
+++ b/Lessons/06_knn_naive_bayes_svm/Slides/knn_naive_bayes_svm_slides.pptx
@@ -5,7 +5,7 @@
     <p:sldMasterId id="2147483648" r:id="rId1"/>
   </p:sldMasterIdLst>
   <p:notesMasterIdLst>
-    <p:notesMasterId r:id="rId58"/>
+    <p:notesMasterId r:id="rId59"/>
   </p:notesMasterIdLst>
   <p:sldIdLst>
     <p:sldId id="256" r:id="rId2"/>
@@ -64,6 +64,7 @@
     <p:sldId id="309" r:id="rId55"/>
     <p:sldId id="310" r:id="rId56"/>
     <p:sldId id="311" r:id="rId57"/>
+    <p:sldId id="312" r:id="rId58"/>
   </p:sldIdLst>
   <p:sldSz cx="9144000" cy="5143500" type="screen16x9"/>
   <p:notesSz cx="6858000" cy="9144000"/>
@@ -3359,49 +3360,35 @@
             </a:pPr>
             <a:r>
               <a:rPr/>
-              <a:t>Both halves matter, and students tend to hear only one of them.</a:t>
-            </a:r>
-          </a:p>
-          <a:p>
-            <a:pPr lvl="0" indent="0" marL="0">
-              <a:buNone/>
-            </a:pPr>
-          </a:p>
-          <a:p>
-            <a:pPr lvl="0" indent="0" marL="0">
-              <a:buNone/>
-            </a:pPr>
-            <a:r>
-              <a:rPr/>
-              <a:t>The bargain is real. Nothing else in this course trains in one pass, and nothing else tolerates ten thousand features on a few thousand rows.</a:t>
-            </a:r>
-          </a:p>
-          <a:p>
-            <a:pPr lvl="0" indent="0" marL="0">
-              <a:buNone/>
-            </a:pPr>
-          </a:p>
-          <a:p>
-            <a:pPr lvl="0" indent="0" marL="0">
-              <a:buNone/>
-            </a:pPr>
-            <a:r>
-              <a:rPr/>
-              <a:t>The assumption is false almost everywhere, and give concrete cases rather than a general warning. Two sensors on the same machine are both driven by the operating point, so of course they move together. In text, “New” and “York” co-occur far more than independence would allow. In medicine, symptoms of the same disease arrive in clusters.</a:t>
-            </a:r>
-          </a:p>
-          <a:p>
-            <a:pPr lvl="0" indent="0" marL="0">
-              <a:buNone/>
-            </a:pPr>
-          </a:p>
-          <a:p>
-            <a:pPr lvl="0" indent="0" marL="0">
-              <a:buNone/>
-            </a:pPr>
-            <a:r>
-              <a:rPr/>
-              <a:t>Then the framing that makes the rest of this segment worth doing, and put it as a question to the room: given that the assumption is essentially always false, why does anybody use this? The answer is that the assumption being false and the CLASSIFIER being wrong are different things. Argmax only needs the ordering right, not the probabilities. Handout section 4.2 closes on exactly this.</a:t>
+              <a:t>This is inference, and it is worth saying how little it is. For each class, take the log prior and add one number per reading: the log of that class’s bell, evaluated at the reading. Compare the totals. That is the prediction. No training row is consulted - only the ten stored numbers - which is the exact opposite of k-NN, where prediction is the whole cost.</a:t>
+            </a:r>
+          </a:p>
+          <a:p>
+            <a:pPr lvl="0" indent="0" marL="0">
+              <a:buNone/>
+            </a:pPr>
+          </a:p>
+          <a:p>
+            <a:pPr lvl="0" indent="0" marL="0">
+              <a:buNone/>
+            </a:pPr>
+            <a:r>
+              <a:rPr/>
+              <a:t>Walk the pump across. Vibration decides it: 48 Hz is 6 Hz from the centre, three and a half standard deviations for the narrow healthy bell, so its log density is −7.745; for the wide faulty bell it is barely more than one, −3.286. Pressure is at the centre, so it favours the narrow bell slightly - and its healthy log density is positive, +0.598, because a density is not a probability and a narrow bell peaks above 1.</a:t>
+            </a:r>
+          </a:p>
+          <a:p>
+            <a:pPr lvl="0" indent="0" marL="0">
+              <a:buNone/>
+            </a:pPr>
+          </a:p>
+          <a:p>
+            <a:pPr lvl="0" indent="0" marL="0">
+              <a:buNone/>
+            </a:pPr>
+            <a:r>
+              <a:rPr/>
+              <a:t>Faulty has the larger total, so faulty is the prediction. The probability in the title is the normalisation from slide 26 in log form: the gap between the totals, 3.951, through the logistic function, 1 / (1 + e^(−3.951)) = 0.981. Handout section 4.2 lists the four steps.</a:t>
             </a:r>
           </a:p>
         </p:txBody>
@@ -3483,49 +3470,49 @@
             </a:pPr>
             <a:r>
               <a:rPr/>
-              <a:t>A point behind k-NN, and an enormous distance ahead of the linear model - from a method that assumes something false and trains in a single pass over the data.</a:t>
-            </a:r>
-          </a:p>
-          <a:p>
-            <a:pPr lvl="0" indent="0" marL="0">
-              <a:buNone/>
-            </a:pPr>
-          </a:p>
-          <a:p>
-            <a:pPr lvl="0" indent="0" marL="0">
-              <a:buNone/>
-            </a:pPr>
-            <a:r>
-              <a:rPr/>
-              <a:t>Resist the temptation to stop here, because a score alone tells you nothing about when it will hold. Ask the room the useful question instead: WHY did that work? If the assumption is false, what happened?</a:t>
-            </a:r>
-          </a:p>
-          <a:p>
-            <a:pPr lvl="0" indent="0" marL="0">
-              <a:buNone/>
-            </a:pPr>
-          </a:p>
-          <a:p>
-            <a:pPr lvl="0" indent="0" marL="0">
-              <a:buNone/>
-            </a:pPr>
-            <a:r>
-              <a:rPr/>
-              <a:t>Then be explicit that we are about to check, rather than speculate. This is the habit worth transferring: when a model does better than you expected, find out which of your assumptions was accidentally satisfied. That tells you whether the result will survive on the next dataset.</a:t>
-            </a:r>
-          </a:p>
-          <a:p>
-            <a:pPr lvl="0" indent="0" marL="0">
-              <a:buNone/>
-            </a:pPr>
-          </a:p>
-          <a:p>
-            <a:pPr lvl="0" indent="0" marL="0">
-              <a:buNone/>
-            </a:pPr>
-            <a:r>
-              <a:rPr/>
-              <a:t>Handout section 4.3.</a:t>
+              <a:t>Both halves matter, and students tend to hear only one of them.</a:t>
+            </a:r>
+          </a:p>
+          <a:p>
+            <a:pPr lvl="0" indent="0" marL="0">
+              <a:buNone/>
+            </a:pPr>
+          </a:p>
+          <a:p>
+            <a:pPr lvl="0" indent="0" marL="0">
+              <a:buNone/>
+            </a:pPr>
+            <a:r>
+              <a:rPr/>
+              <a:t>The bargain is real. Nothing else in this course trains in one pass, and nothing else tolerates ten thousand features on a few thousand rows.</a:t>
+            </a:r>
+          </a:p>
+          <a:p>
+            <a:pPr lvl="0" indent="0" marL="0">
+              <a:buNone/>
+            </a:pPr>
+          </a:p>
+          <a:p>
+            <a:pPr lvl="0" indent="0" marL="0">
+              <a:buNone/>
+            </a:pPr>
+            <a:r>
+              <a:rPr/>
+              <a:t>The assumption is false almost everywhere, and give concrete cases rather than a general warning. Two sensors on the same machine are both driven by the operating point, so of course they move together. In text, “New” and “York” co-occur far more than independence would allow. In medicine, symptoms of the same disease arrive in clusters.</a:t>
+            </a:r>
+          </a:p>
+          <a:p>
+            <a:pPr lvl="0" indent="0" marL="0">
+              <a:buNone/>
+            </a:pPr>
+          </a:p>
+          <a:p>
+            <a:pPr lvl="0" indent="0" marL="0">
+              <a:buNone/>
+            </a:pPr>
+            <a:r>
+              <a:rPr/>
+              <a:t>Then the framing that makes the rest of this segment worth doing, and put it as a question to the room: given that the assumption is essentially always false, why does anybody use this? The answer is that the assumption being false and the CLASSIFIER being wrong are different things. Argmax only needs the ordering right, not the probabilities. Handout section 4.2 closes on exactly this.</a:t>
             </a:r>
           </a:p>
         </p:txBody>
@@ -3607,49 +3594,49 @@
             </a:pPr>
             <a:r>
               <a:rPr/>
-              <a:t>Measured directly, and remember the assumption concerns independence GIVEN THE CLASS - so the second and third rows are the ones that count, not the first.</a:t>
-            </a:r>
-          </a:p>
-          <a:p>
-            <a:pPr lvl="0" indent="0" marL="0">
-              <a:buNone/>
-            </a:pPr>
-          </a:p>
-          <a:p>
-            <a:pPr lvl="0" indent="0" marL="0">
-              <a:buNone/>
-            </a:pPr>
-            <a:r>
-              <a:rPr/>
-              <a:t>Within each class the two readings are essentially uncorrelated: −0.006 among healthy pumps is as close to zero as a sample of this size will ever produce. The assumption is not approximately satisfied here; it is satisfied.</a:t>
-            </a:r>
-          </a:p>
-          <a:p>
-            <a:pPr lvl="0" indent="0" marL="0">
-              <a:buNone/>
-            </a:pPr>
-          </a:p>
-          <a:p>
-            <a:pPr lvl="0" indent="0" marL="0">
-              <a:buNone/>
-            </a:pPr>
-            <a:r>
-              <a:rPr/>
-              <a:t>Say why that is more useful than the 0.933. A score tells you what happened once. Knowing WHY it happened tells you when to expect it again - and it gives them a check they can run in two lines before trusting Naive Bayes on anything.</a:t>
-            </a:r>
-          </a:p>
-          <a:p>
-            <a:pPr lvl="0" indent="0" marL="0">
-              <a:buNone/>
-            </a:pPr>
-          </a:p>
-          <a:p>
-            <a:pPr lvl="0" indent="0" marL="0">
-              <a:buNone/>
-            </a:pPr>
-            <a:r>
-              <a:rPr/>
-              <a:t>The obvious caution, since somebody will raise it: zero correlation is not independence. Correlation only detects linear dependence. For Gaussian Naive Bayes with Gaussian-ish features it is the right check; in general it is necessary and not sufficient.</a:t>
+              <a:t>A point behind k-NN, and an enormous distance ahead of the linear model - from a method that assumes something false and trains in a single pass over the data.</a:t>
+            </a:r>
+          </a:p>
+          <a:p>
+            <a:pPr lvl="0" indent="0" marL="0">
+              <a:buNone/>
+            </a:pPr>
+          </a:p>
+          <a:p>
+            <a:pPr lvl="0" indent="0" marL="0">
+              <a:buNone/>
+            </a:pPr>
+            <a:r>
+              <a:rPr/>
+              <a:t>Resist the temptation to stop here, because a score alone tells you nothing about when it will hold. Ask the room the useful question instead: WHY did that work? If the assumption is false, what happened?</a:t>
+            </a:r>
+          </a:p>
+          <a:p>
+            <a:pPr lvl="0" indent="0" marL="0">
+              <a:buNone/>
+            </a:pPr>
+          </a:p>
+          <a:p>
+            <a:pPr lvl="0" indent="0" marL="0">
+              <a:buNone/>
+            </a:pPr>
+            <a:r>
+              <a:rPr/>
+              <a:t>Then be explicit that we are about to check, rather than speculate. This is the habit worth transferring: when a model does better than you expected, find out whether it worked because its assumption held or despite it failing. That tells you whether the result will survive on the next dataset.</a:t>
+            </a:r>
+          </a:p>
+          <a:p>
+            <a:pPr lvl="0" indent="0" marL="0">
+              <a:buNone/>
+            </a:pPr>
+          </a:p>
+          <a:p>
+            <a:pPr lvl="0" indent="0" marL="0">
+              <a:buNone/>
+            </a:pPr>
+            <a:r>
+              <a:rPr/>
+              <a:t>Handout section 4.3.</a:t>
             </a:r>
           </a:p>
         </p:txBody>
@@ -3731,49 +3718,35 @@
             </a:pPr>
             <a:r>
               <a:rPr/>
-              <a:t>Change one thing about the problem and watch the method fall apart. Describe the physics before the geometry, because the rule is completely reasonable engineering.</a:t>
-            </a:r>
-          </a:p>
-          <a:p>
-            <a:pPr lvl="0" indent="0" marL="0">
-              <a:buNone/>
-            </a:pPr>
-          </a:p>
-          <a:p>
-            <a:pPr lvl="0" indent="0" marL="0">
-              <a:buNone/>
-            </a:pPr>
-            <a:r>
-              <a:rPr/>
-              <a:t>High demand and high delivery: fine, that is the machine working hard. Low and low: fine, that is idle. High demand with low delivery, or the reverse: something is wrong between them. Exactly one high means faulty.</a:t>
-            </a:r>
-          </a:p>
-          <a:p>
-            <a:pPr lvl="0" indent="0" marL="0">
-              <a:buNone/>
-            </a:pPr>
-          </a:p>
-          <a:p>
-            <a:pPr lvl="0" indent="0" marL="0">
-              <a:buNone/>
-            </a:pPr>
-            <a:r>
-              <a:rPr/>
-              <a:t>Ask them, before the picture, what each sensor tells you ON ITS OWN under that rule. Give it a moment. The answer is: nothing at all. Every value of sensor A appears in both classes about equally often, because whether it means “faulty” depends entirely on sensor B.</a:t>
-            </a:r>
-          </a:p>
-          <a:p>
-            <a:pPr lvl="0" indent="0" marL="0">
-              <a:buNone/>
-            </a:pPr>
-          </a:p>
-          <a:p>
-            <a:pPr lvl="0" indent="0" marL="0">
-              <a:buNone/>
-            </a:pPr>
-            <a:r>
-              <a:rPr/>
-              <a:t>That is what an interaction is, and it is precisely the structure the independence assumption is unable to represent. Handout section 4.4.</a:t>
+              <a:t>Show the middle column first and let the room draw the conclusion everyone draws: within each class the readings are uncorrelated, so the assumption holds. It is the natural check, and for bell-shaped data it would settle it.</a:t>
+            </a:r>
+          </a:p>
+          <a:p>
+            <a:pPr lvl="0" indent="0" marL="0">
+              <a:buNone/>
+            </a:pPr>
+          </a:p>
+          <a:p>
+            <a:pPr lvl="0" indent="0" marL="0">
+              <a:buNone/>
+            </a:pPr>
+            <a:r>
+              <a:rPr/>
+              <a:t>Then the trap. Correlation only sees straight-line dependence. Healthy pumps fill a disc and faulty ones a ring; on a ring, a pump far out in vibration must be central in pressure. That dependence is symmetric, so the straight-line summary averages it to zero. Square each reading’s distance from the design point and it appears: −0.420 among the faulty pumps. The assumption is false.</a:t>
+            </a:r>
+          </a:p>
+          <a:p>
+            <a:pPr lvl="0" indent="0" marL="0">
+              <a:buNone/>
+            </a:pPr>
+          </a:p>
+          <a:p>
+            <a:pPr lvl="0" indent="0" marL="0">
+              <a:buNone/>
+            </a:pPr>
+            <a:r>
+              <a:rPr/>
+              <a:t>So why 0.933? Because the densities are wrong but the boundary they imply is right. With both classes centred on the same point, comparing a narrow bell with a wide one gives an axis-aligned ellipse, and the true envelope is an axis-aligned ellipse. The fitted model’s edge sits at about 3.17 Hz by 0.41 bar against a true 3.5 by 0.45 - the same shape, a tenth small. A false assumption is cheap when it leaves the boundary the right shape. The next slide is the case where it does not. Handout section 4.3.</a:t>
             </a:r>
           </a:p>
         </p:txBody>
@@ -3855,49 +3828,49 @@
             </a:pPr>
             <a:r>
               <a:rPr/>
-              <a:t>Left panel: the two sensors together. Four clean groups, and a perfectly learnable rule - any method that can draw a non-linear boundary will find it.</a:t>
-            </a:r>
-          </a:p>
-          <a:p>
-            <a:pPr lvl="0" indent="0" marL="0">
-              <a:buNone/>
-            </a:pPr>
-          </a:p>
-          <a:p>
-            <a:pPr lvl="0" indent="0" marL="0">
-              <a:buNone/>
-            </a:pPr>
-            <a:r>
-              <a:rPr/>
-              <a:t>Middle and right: each sensor on its own, which is ALL Naive Bayes ever gets. The two class distributions sit almost exactly on top of one another.</a:t>
-            </a:r>
-          </a:p>
-          <a:p>
-            <a:pPr lvl="0" indent="0" marL="0">
-              <a:buNone/>
-            </a:pPr>
-          </a:p>
-          <a:p>
-            <a:pPr lvl="0" indent="0" marL="0">
-              <a:buNone/>
-            </a:pPr>
-            <a:r>
-              <a:rPr/>
-              <a:t>That is the slide in one sentence: the information is real, it is entirely in the relationship between the columns, and factorising the density throws that relationship away before the model ever sees it.</a:t>
-            </a:r>
-          </a:p>
-          <a:p>
-            <a:pPr lvl="0" indent="0" marL="0">
-              <a:buNone/>
-            </a:pPr>
-          </a:p>
-          <a:p>
-            <a:pPr lvl="0" indent="0" marL="0">
-              <a:buNone/>
-            </a:pPr>
-            <a:r>
-              <a:rPr/>
-              <a:t>Worth saying that no amount of data repairs this. It is not an estimation problem - with a million rows the marginals still overlap. The model cannot represent what is being asked of it.</a:t>
+              <a:t>Change one thing about the problem and watch the method fall apart. Describe the physics before the geometry, because the rule is completely reasonable engineering.</a:t>
+            </a:r>
+          </a:p>
+          <a:p>
+            <a:pPr lvl="0" indent="0" marL="0">
+              <a:buNone/>
+            </a:pPr>
+          </a:p>
+          <a:p>
+            <a:pPr lvl="0" indent="0" marL="0">
+              <a:buNone/>
+            </a:pPr>
+            <a:r>
+              <a:rPr/>
+              <a:t>High demand and high delivery: fine, that is the machine working hard. Low and low: fine, that is idle. High demand with low delivery, or the reverse: something is wrong between them. Exactly one high means faulty.</a:t>
+            </a:r>
+          </a:p>
+          <a:p>
+            <a:pPr lvl="0" indent="0" marL="0">
+              <a:buNone/>
+            </a:pPr>
+          </a:p>
+          <a:p>
+            <a:pPr lvl="0" indent="0" marL="0">
+              <a:buNone/>
+            </a:pPr>
+            <a:r>
+              <a:rPr/>
+              <a:t>Ask them, before the picture, what each sensor tells you ON ITS OWN under that rule. Give it a moment. The answer is: nothing at all. Every value of sensor A appears in both classes about equally often, because whether it means “faulty” depends entirely on sensor B.</a:t>
+            </a:r>
+          </a:p>
+          <a:p>
+            <a:pPr lvl="0" indent="0" marL="0">
+              <a:buNone/>
+            </a:pPr>
+          </a:p>
+          <a:p>
+            <a:pPr lvl="0" indent="0" marL="0">
+              <a:buNone/>
+            </a:pPr>
+            <a:r>
+              <a:rPr/>
+              <a:t>That is what an interaction is, and it is precisely the structure the independence assumption is unable to represent. Handout section 4.4.</a:t>
             </a:r>
           </a:p>
         </p:txBody>
@@ -3979,63 +3952,49 @@
             </a:pPr>
             <a:r>
               <a:rPr/>
-              <a:t>Two things to draw out, and the second is the more interesting.</a:t>
-            </a:r>
-          </a:p>
-          <a:p>
-            <a:pPr lvl="0" indent="0" marL="0">
-              <a:buNone/>
-            </a:pPr>
-          </a:p>
-          <a:p>
-            <a:pPr lvl="0" indent="0" marL="0">
-              <a:buNone/>
-            </a:pPr>
-            <a:r>
-              <a:rPr/>
-              <a:t>First: k-NN and the RBF SVM are at 0.967 and 0.972 on this data. The problem is not hard. It is only hard for a model that looks at one feature at a time.</a:t>
-            </a:r>
-          </a:p>
-          <a:p>
-            <a:pPr lvl="0" indent="0" marL="0">
-              <a:buNone/>
-            </a:pPr>
-          </a:p>
-          <a:p>
-            <a:pPr lvl="0" indent="0" marL="0">
-              <a:buNone/>
-            </a:pPr>
-            <a:r>
-              <a:rPr/>
-              <a:t>Second, and take the time: 0.404 is BELOW CHANCE. Below the majority baseline of 0.523, and below what you would get by flipping a coin. Ask how that is even possible - a model with no information should surely sit at 50%.</a:t>
-            </a:r>
-          </a:p>
-          <a:p>
-            <a:pPr lvl="0" indent="0" marL="0">
-              <a:buNone/>
-            </a:pPr>
-          </a:p>
-          <a:p>
-            <a:pPr lvl="0" indent="0" marL="0">
-              <a:buNone/>
-            </a:pPr>
-            <a:r>
-              <a:rPr/>
-              <a:t>The explanation is worth having in full. The class means on each sensor differ by about 0.17, against a spread near 1, purely as an artefact of a finite sample. That accident is the ONLY per-feature evidence available. Naive Bayes has nothing else to multiply, so it follows it - and in this sample it points the wrong way.</a:t>
-            </a:r>
-          </a:p>
-          <a:p>
-            <a:pPr lvl="0" indent="0" marL="0">
-              <a:buNone/>
-            </a:pPr>
-          </a:p>
-          <a:p>
-            <a:pPr lvl="0" indent="0" marL="0">
-              <a:buNone/>
-            </a:pPr>
-            <a:r>
-              <a:rPr/>
-              <a:t>The sentence to land: a model with no signal does not sit politely at 50%. It follows whatever spurious structure it can find, with complete confidence.</a:t>
+              <a:t>Left panel: the two sensors together. Four clean groups, and a perfectly learnable rule - any method that can draw a non-linear boundary will find it.</a:t>
+            </a:r>
+          </a:p>
+          <a:p>
+            <a:pPr lvl="0" indent="0" marL="0">
+              <a:buNone/>
+            </a:pPr>
+          </a:p>
+          <a:p>
+            <a:pPr lvl="0" indent="0" marL="0">
+              <a:buNone/>
+            </a:pPr>
+            <a:r>
+              <a:rPr/>
+              <a:t>Middle and right: each sensor on its own, which is ALL Naive Bayes ever gets. The two class distributions sit almost exactly on top of one another.</a:t>
+            </a:r>
+          </a:p>
+          <a:p>
+            <a:pPr lvl="0" indent="0" marL="0">
+              <a:buNone/>
+            </a:pPr>
+          </a:p>
+          <a:p>
+            <a:pPr lvl="0" indent="0" marL="0">
+              <a:buNone/>
+            </a:pPr>
+            <a:r>
+              <a:rPr/>
+              <a:t>That is the slide in one sentence: the information is real, it is entirely in the relationship between the columns, and factorising the density throws that relationship away before the model ever sees it.</a:t>
+            </a:r>
+          </a:p>
+          <a:p>
+            <a:pPr lvl="0" indent="0" marL="0">
+              <a:buNone/>
+            </a:pPr>
+          </a:p>
+          <a:p>
+            <a:pPr lvl="0" indent="0" marL="0">
+              <a:buNone/>
+            </a:pPr>
+            <a:r>
+              <a:rPr/>
+              <a:t>Worth saying that no amount of data repairs this. It is not an estimation problem - with a million rows the marginals still overlap. The model cannot represent what is being asked of it.</a:t>
             </a:r>
           </a:p>
         </p:txBody>
@@ -4117,59 +4076,63 @@
             </a:pPr>
             <a:r>
               <a:rPr/>
-              <a:t>Two numbers, four thousandths apart. The model is exactly as confident when it is wrong as when it is right, which means </a:t>
-            </a:r>
-            <a:r>
-              <a:rPr>
-                <a:latin typeface="Courier"/>
-              </a:rPr>
-              <a:t>predict_proba</a:t>
-            </a:r>
-            <a:r>
-              <a:rPr/>
-              <a:t> carries no usable information about reliability here.</a:t>
-            </a:r>
-          </a:p>
-          <a:p>
-            <a:pPr lvl="0" indent="0" marL="0">
-              <a:buNone/>
-            </a:pPr>
-          </a:p>
-          <a:p>
-            <a:pPr lvl="0" indent="0" marL="0">
-              <a:buNone/>
-            </a:pPr>
-            <a:r>
-              <a:rPr/>
-              <a:t>The more common complaint runs in the opposite direction, so give it too: when features ARE correlated, multiplying their probabilities counts the same evidence repeatedly. Ten correlated words in a document are treated as ten independent pieces of evidence, and the posterior saturates. Naive Bayes is famous for reporting 0.999 on problems it gets wrong a fifth of the time.</a:t>
-            </a:r>
-          </a:p>
-          <a:p>
-            <a:pPr lvl="0" indent="0" marL="0">
-              <a:buNone/>
-            </a:pPr>
-          </a:p>
-          <a:p>
-            <a:pPr lvl="0" indent="0" marL="0">
-              <a:buNone/>
-            </a:pPr>
-            <a:r>
-              <a:rPr/>
-              <a:t>Then lesson 5’s distinction, which this is the textbook case of: ranking and calibration are different properties. A model can order examples usefully and still report numbers that mean nothing.</a:t>
-            </a:r>
-          </a:p>
-          <a:p>
-            <a:pPr lvl="0" indent="0" marL="0">
-              <a:buNone/>
-            </a:pPr>
-          </a:p>
-          <a:p>
-            <a:pPr lvl="0" indent="0" marL="0">
-              <a:buNone/>
-            </a:pPr>
-            <a:r>
-              <a:rPr/>
-              <a:t>The practical consequence, and it is concrete: do not use Naive Bayes anywhere a calibrated probability enters a decision - including lesson 4’s cost calculation in section 7.2, where the threshold depends on the probability being real.</a:t>
+              <a:t>Two things to draw out, and the second is the more interesting.</a:t>
+            </a:r>
+          </a:p>
+          <a:p>
+            <a:pPr lvl="0" indent="0" marL="0">
+              <a:buNone/>
+            </a:pPr>
+          </a:p>
+          <a:p>
+            <a:pPr lvl="0" indent="0" marL="0">
+              <a:buNone/>
+            </a:pPr>
+            <a:r>
+              <a:rPr/>
+              <a:t>First: k-NN and the RBF SVM are at 0.967 and 0.972 on this data. The problem is not hard. It is only hard for a model that looks at one feature at a time.</a:t>
+            </a:r>
+          </a:p>
+          <a:p>
+            <a:pPr lvl="0" indent="0" marL="0">
+              <a:buNone/>
+            </a:pPr>
+          </a:p>
+          <a:p>
+            <a:pPr lvl="0" indent="0" marL="0">
+              <a:buNone/>
+            </a:pPr>
+            <a:r>
+              <a:rPr/>
+              <a:t>Second, and take the time: 0.404 is BELOW CHANCE. Below the majority baseline of 0.523, and below what you would get by flipping a coin. Ask how that is even possible - a model with no information should surely sit at 50%.</a:t>
+            </a:r>
+          </a:p>
+          <a:p>
+            <a:pPr lvl="0" indent="0" marL="0">
+              <a:buNone/>
+            </a:pPr>
+          </a:p>
+          <a:p>
+            <a:pPr lvl="0" indent="0" marL="0">
+              <a:buNone/>
+            </a:pPr>
+            <a:r>
+              <a:rPr/>
+              <a:t>The explanation is worth having in full. The class means on each sensor differ by about 0.17, against a spread near 1, purely as an artefact of a finite sample. That accident is the ONLY per-feature evidence available. Naive Bayes has nothing else to multiply, so it follows it - and in this sample it points the wrong way.</a:t>
+            </a:r>
+          </a:p>
+          <a:p>
+            <a:pPr lvl="0" indent="0" marL="0">
+              <a:buNone/>
+            </a:pPr>
+          </a:p>
+          <a:p>
+            <a:pPr lvl="0" indent="0" marL="0">
+              <a:buNone/>
+            </a:pPr>
+            <a:r>
+              <a:rPr/>
+              <a:t>The sentence to land: a model with no signal does not sit politely at 50%. It follows whatever spurious structure it can find, with complete confidence.</a:t>
             </a:r>
           </a:p>
         </p:txBody>
@@ -4251,49 +4214,59 @@
             </a:pPr>
             <a:r>
               <a:rPr/>
-              <a:t>Run notebooks/02. Sixteen minutes.</a:t>
-            </a:r>
-          </a:p>
-          <a:p>
-            <a:pPr lvl="0" indent="0" marL="0">
-              <a:buNone/>
-            </a:pPr>
-          </a:p>
-          <a:p>
-            <a:pPr lvl="0" indent="0" marL="0">
-              <a:buNone/>
-            </a:pPr>
-            <a:r>
-              <a:rPr/>
-              <a:t>The cell to protect is the one that prints 0.404 next to the 0.523 baseline. Let them see a below-chance score appear from correct code on solvable data before any explanation arrives.</a:t>
-            </a:r>
-          </a:p>
-          <a:p>
-            <a:pPr lvl="0" indent="0" marL="0">
-              <a:buNone/>
-            </a:pPr>
-          </a:p>
-          <a:p>
-            <a:pPr lvl="0" indent="0" marL="0">
-              <a:buNone/>
-            </a:pPr>
-            <a:r>
-              <a:rPr/>
-              <a:t>The notebook prints the within-class correlations on both datasets. Before that cell runs, ask them to predict the signs for the interacting sensors: it is the diagnostic they should carry - measure the assumption, do not assume it.</a:t>
-            </a:r>
-          </a:p>
-          <a:p>
-            <a:pPr lvl="0" indent="0" marL="0">
-              <a:buNone/>
-            </a:pPr>
-          </a:p>
-          <a:p>
-            <a:pPr lvl="0" indent="0" marL="0">
-              <a:buNone/>
-            </a:pPr>
-            <a:r>
-              <a:rPr/>
-              <a:t>If time allows, the interesting exercise is to hand Naive Bayes the product of the two sensors as a third column and watch it recover. That is the whole story of feature engineering versus model choice in one cell.</a:t>
+              <a:t>Two numbers, four thousandths apart. The model is exactly as confident when it is wrong as when it is right, which means </a:t>
+            </a:r>
+            <a:r>
+              <a:rPr>
+                <a:latin typeface="Courier"/>
+              </a:rPr>
+              <a:t>predict_proba</a:t>
+            </a:r>
+            <a:r>
+              <a:rPr/>
+              <a:t> carries no usable information about reliability here.</a:t>
+            </a:r>
+          </a:p>
+          <a:p>
+            <a:pPr lvl="0" indent="0" marL="0">
+              <a:buNone/>
+            </a:pPr>
+          </a:p>
+          <a:p>
+            <a:pPr lvl="0" indent="0" marL="0">
+              <a:buNone/>
+            </a:pPr>
+            <a:r>
+              <a:rPr/>
+              <a:t>The more common complaint runs in the opposite direction, so give it too: when features ARE correlated, multiplying their probabilities counts the same evidence repeatedly. Ten correlated words in a document are treated as ten independent pieces of evidence, and the posterior saturates. Naive Bayes is famous for reporting 0.999 on problems it gets wrong a fifth of the time.</a:t>
+            </a:r>
+          </a:p>
+          <a:p>
+            <a:pPr lvl="0" indent="0" marL="0">
+              <a:buNone/>
+            </a:pPr>
+          </a:p>
+          <a:p>
+            <a:pPr lvl="0" indent="0" marL="0">
+              <a:buNone/>
+            </a:pPr>
+            <a:r>
+              <a:rPr/>
+              <a:t>Then lesson 5’s distinction, which this is the textbook case of: ranking and calibration are different properties. A model can order examples usefully and still report numbers that mean nothing.</a:t>
+            </a:r>
+          </a:p>
+          <a:p>
+            <a:pPr lvl="0" indent="0" marL="0">
+              <a:buNone/>
+            </a:pPr>
+          </a:p>
+          <a:p>
+            <a:pPr lvl="0" indent="0" marL="0">
+              <a:buNone/>
+            </a:pPr>
+            <a:r>
+              <a:rPr/>
+              <a:t>The practical consequence, and it is concrete: do not use Naive Bayes anywhere a calibrated probability enters a decision - including lesson 4’s cost calculation in section 7.2, where the threshold depends on the probability being real.</a:t>
             </a:r>
           </a:p>
         </p:txBody>
@@ -4375,49 +4348,49 @@
             </a:pPr>
             <a:r>
               <a:rPr/>
-              <a:t>Start with the problem rather than the solution. Draw two well-separated blobs on the board and ask for the boundary. Somebody will draw a line. Ask whether another line would have been equally good, and keep asking until the room sees that there are infinitely many, all with identical training error.</a:t>
-            </a:r>
-          </a:p>
-          <a:p>
-            <a:pPr lvl="0" indent="0" marL="0">
-              <a:buNone/>
-            </a:pPr>
-          </a:p>
-          <a:p>
-            <a:pPr lvl="0" indent="0" marL="0">
-              <a:buNone/>
-            </a:pPr>
-            <a:r>
-              <a:rPr/>
-              <a:t>So the error cannot decide. Something else has to. Logistic regression breaks the tie with log loss - a perfectly respectable answer, and one answer among several. The SVM breaks it differently: take the boundary with the most room around it.</a:t>
-            </a:r>
-          </a:p>
-          <a:p>
-            <a:pPr lvl="0" indent="0" marL="0">
-              <a:buNone/>
-            </a:pPr>
-          </a:p>
-          <a:p>
-            <a:pPr lvl="0" indent="0" marL="0">
-              <a:buNone/>
-            </a:pPr>
-            <a:r>
-              <a:rPr/>
-              <a:t>The intuition, and this is the sentence to say slowly: maximising the distance to the closest points chooses the boundary that tolerates the most movement in the data before it changes its mind. That is a statement about GENERALISATION, not about fit - which is unusual, because almost everything else in this course optimises fit and controls generalisation indirectly.</a:t>
-            </a:r>
-          </a:p>
-          <a:p>
-            <a:pPr lvl="0" indent="0" marL="0">
-              <a:buNone/>
-            </a:pPr>
-          </a:p>
-          <a:p>
-            <a:pPr lvl="0" indent="0" marL="0">
-              <a:buNone/>
-            </a:pPr>
-            <a:r>
-              <a:rPr/>
-              <a:t>Handout section 5.1.</a:t>
+              <a:t>Run notebooks/02. Sixteen minutes.</a:t>
+            </a:r>
+          </a:p>
+          <a:p>
+            <a:pPr lvl="0" indent="0" marL="0">
+              <a:buNone/>
+            </a:pPr>
+          </a:p>
+          <a:p>
+            <a:pPr lvl="0" indent="0" marL="0">
+              <a:buNone/>
+            </a:pPr>
+            <a:r>
+              <a:rPr/>
+              <a:t>The cell to protect is the one that prints 0.404 next to the 0.523 baseline. Let them see a below-chance score appear from correct code on solvable data before any explanation arrives.</a:t>
+            </a:r>
+          </a:p>
+          <a:p>
+            <a:pPr lvl="0" indent="0" marL="0">
+              <a:buNone/>
+            </a:pPr>
+          </a:p>
+          <a:p>
+            <a:pPr lvl="0" indent="0" marL="0">
+              <a:buNone/>
+            </a:pPr>
+            <a:r>
+              <a:rPr/>
+              <a:t>The notebook prints the within-class correlations on both datasets. Before that cell runs, ask them to predict the signs for the interacting sensors: it is the diagnostic they should carry - measure the assumption, do not assume it.</a:t>
+            </a:r>
+          </a:p>
+          <a:p>
+            <a:pPr lvl="0" indent="0" marL="0">
+              <a:buNone/>
+            </a:pPr>
+          </a:p>
+          <a:p>
+            <a:pPr lvl="0" indent="0" marL="0">
+              <a:buNone/>
+            </a:pPr>
+            <a:r>
+              <a:rPr/>
+              <a:t>If time allows, the interesting exercise is to hand Naive Bayes the product of the two sensors as a third column and watch it recover. That is the whole story of feature engineering versus model choice in one cell.</a:t>
             </a:r>
           </a:p>
         </p:txBody>
@@ -4499,49 +4472,49 @@
             </a:pPr>
             <a:r>
               <a:rPr/>
-              <a:t>The solid line is the boundary, the dashed lines are the edges of the slab, and the circled points are the support vectors touching it.</a:t>
-            </a:r>
-          </a:p>
-          <a:p>
-            <a:pPr lvl="0" indent="0" marL="0">
-              <a:buNone/>
-            </a:pPr>
-          </a:p>
-          <a:p>
-            <a:pPr lvl="0" indent="0" marL="0">
-              <a:buNone/>
-            </a:pPr>
-            <a:r>
-              <a:rPr/>
-              <a:t>The number to say out loud: of eighty points, THREE determine the answer. Move any of the other seventy-seven - anywhere, as far as you like, as long as they stay outside the slab - and the boundary does not shift by a millimetre.</a:t>
-            </a:r>
-          </a:p>
-          <a:p>
-            <a:pPr lvl="0" indent="0" marL="0">
-              <a:buNone/>
-            </a:pPr>
-          </a:p>
-          <a:p>
-            <a:pPr lvl="0" indent="0" marL="0">
-              <a:buNone/>
-            </a:pPr>
-            <a:r>
-              <a:rPr/>
-              <a:t>That is where the name comes from, and it is a genuinely different idea from anything so far. Every linear model in lessons 3 and 4 used every row: each one contributed to the gradient in proportion to its error. Here most of the data is irrelevant once the fit is done.</a:t>
-            </a:r>
-          </a:p>
-          <a:p>
-            <a:pPr lvl="0" indent="0" marL="0">
-              <a:buNone/>
-            </a:pPr>
-          </a:p>
-          <a:p>
-            <a:pPr lvl="0" indent="0" marL="0">
-              <a:buNone/>
-            </a:pPr>
-            <a:r>
-              <a:rPr/>
-              <a:t>Two consequences worth naming. The model is small - you store the support vectors, not the dataset, which is the contrast with k-NN. And it is sensitive in a specific way: an outlier near the boundary matters enormously, while an outlier far from it matters not at all.</a:t>
+              <a:t>Start with the problem rather than the solution. Draw two well-separated blobs on the board and ask for the boundary. Somebody will draw a line. Ask whether another line would have been equally good, and keep asking until the room sees that there are infinitely many, all with identical training error.</a:t>
+            </a:r>
+          </a:p>
+          <a:p>
+            <a:pPr lvl="0" indent="0" marL="0">
+              <a:buNone/>
+            </a:pPr>
+          </a:p>
+          <a:p>
+            <a:pPr lvl="0" indent="0" marL="0">
+              <a:buNone/>
+            </a:pPr>
+            <a:r>
+              <a:rPr/>
+              <a:t>So the error cannot decide. Something else has to. Logistic regression breaks the tie with log loss - a perfectly respectable answer, and one answer among several. The SVM breaks it differently: take the boundary with the most room around it.</a:t>
+            </a:r>
+          </a:p>
+          <a:p>
+            <a:pPr lvl="0" indent="0" marL="0">
+              <a:buNone/>
+            </a:pPr>
+          </a:p>
+          <a:p>
+            <a:pPr lvl="0" indent="0" marL="0">
+              <a:buNone/>
+            </a:pPr>
+            <a:r>
+              <a:rPr/>
+              <a:t>The intuition, and this is the sentence to say slowly: maximising the distance to the closest points chooses the boundary that tolerates the most movement in the data before it changes its mind. That is a statement about GENERALISATION, not about fit - which is unusual, because almost everything else in this course optimises fit and controls generalisation indirectly.</a:t>
+            </a:r>
+          </a:p>
+          <a:p>
+            <a:pPr lvl="0" indent="0" marL="0">
+              <a:buNone/>
+            </a:pPr>
+          </a:p>
+          <a:p>
+            <a:pPr lvl="0" indent="0" marL="0">
+              <a:buNone/>
+            </a:pPr>
+            <a:r>
+              <a:rPr/>
+              <a:t>Handout section 5.1.</a:t>
             </a:r>
           </a:p>
         </p:txBody>
@@ -4747,35 +4720,49 @@
             </a:pPr>
             <a:r>
               <a:rPr/>
-              <a:t>The point worth stressing is why the soft margin is not a patch or a convenience. With even one mislabelled point inside the other class, the strict problem is INFEASIBLE - there is no solution, not a bad one. Real data always contains such points. So the soft margin is the only version anyone ever runs; the hard-margin problem is a teaching device.</a:t>
-            </a:r>
-          </a:p>
-          <a:p>
-            <a:pPr lvl="0" indent="0" marL="0">
-              <a:buNone/>
-            </a:pPr>
-          </a:p>
-          <a:p>
-            <a:pPr lvl="0" indent="0" marL="0">
-              <a:buNone/>
-            </a:pPr>
-            <a:r>
-              <a:rPr/>
-              <a:t>Our own labels are flipped at 4%, deliberately, so this is not a hypothetical for this dataset: the hard-margin problem on these pumps has no answer.</a:t>
-            </a:r>
-          </a:p>
-          <a:p>
-            <a:pPr lvl="0" indent="0" marL="0">
-              <a:buNone/>
-            </a:pPr>
-          </a:p>
-          <a:p>
-            <a:pPr lvl="0" indent="0" marL="0">
-              <a:buNone/>
-            </a:pPr>
-            <a:r>
-              <a:rPr/>
-              <a:t>The next slide puts it in symbols. Handout section 5.2 has the derivation.</a:t>
+              <a:t>The solid line is the boundary, the dashed lines are the edges of the slab, and the circled points are the support vectors touching it.</a:t>
+            </a:r>
+          </a:p>
+          <a:p>
+            <a:pPr lvl="0" indent="0" marL="0">
+              <a:buNone/>
+            </a:pPr>
+          </a:p>
+          <a:p>
+            <a:pPr lvl="0" indent="0" marL="0">
+              <a:buNone/>
+            </a:pPr>
+            <a:r>
+              <a:rPr/>
+              <a:t>The number to say out loud: of eighty points, THREE determine the answer. Move any of the other seventy-seven - anywhere, as far as you like, as long as they stay outside the slab - and the boundary does not shift by a millimetre.</a:t>
+            </a:r>
+          </a:p>
+          <a:p>
+            <a:pPr lvl="0" indent="0" marL="0">
+              <a:buNone/>
+            </a:pPr>
+          </a:p>
+          <a:p>
+            <a:pPr lvl="0" indent="0" marL="0">
+              <a:buNone/>
+            </a:pPr>
+            <a:r>
+              <a:rPr/>
+              <a:t>That is where the name comes from, and it is a genuinely different idea from anything so far. Every linear model in lessons 3 and 4 used every row: each one contributed to the gradient in proportion to its error. Here most of the data is irrelevant once the fit is done.</a:t>
+            </a:r>
+          </a:p>
+          <a:p>
+            <a:pPr lvl="0" indent="0" marL="0">
+              <a:buNone/>
+            </a:pPr>
+          </a:p>
+          <a:p>
+            <a:pPr lvl="0" indent="0" marL="0">
+              <a:buNone/>
+            </a:pPr>
+            <a:r>
+              <a:rPr/>
+              <a:t>Two consequences worth naming. The model is small - you store the support vectors, not the dataset, which is the contrast with k-NN. And it is sensitive in a specific way: an outlier near the boundary matters enormously, while an outlier far from it matters not at all.</a:t>
             </a:r>
           </a:p>
         </p:txBody>
@@ -4857,49 +4844,35 @@
             </a:pPr>
             <a:r>
               <a:rPr/>
-              <a:t>The constraint is not on the slide any more - it made the line wide enough to land at 28pt - so state it: subject to y_i(w’x_i + b) &gt;= 1 - xi_i, every point on the right side of the slab by a margin, or paying xi_i for the shortfall. Handout section 5.2 writes it out.</a:t>
-            </a:r>
-          </a:p>
-          <a:p>
-            <a:pPr lvl="0" indent="0" marL="0">
-              <a:buNone/>
-            </a:pPr>
-          </a:p>
-          <a:p>
-            <a:pPr lvl="0" indent="0" marL="0">
-              <a:buNone/>
-            </a:pPr>
-            <a:r>
-              <a:rPr/>
-              <a:t>Do not derive this. State what each piece is doing and move on - handout section 5.2 has the derivation, including why maximising the margin is the same as minimising the norm of w.</a:t>
-            </a:r>
-          </a:p>
-          <a:p>
-            <a:pPr lvl="0" indent="0" marL="0">
-              <a:buNone/>
-            </a:pPr>
-          </a:p>
-          <a:p>
-            <a:pPr lvl="0" indent="0" marL="0">
-              <a:buNone/>
-            </a:pPr>
-            <a:r>
-              <a:rPr/>
-              <a:t>The first term wants a wide slab. The second term wants few violations. C sets the exchange rate between them, and that is the entire content of the expression. Read it out in those words rather than reading the symbols.</a:t>
-            </a:r>
-          </a:p>
-          <a:p>
-            <a:pPr lvl="0" indent="0" marL="0">
-              <a:buNone/>
-            </a:pPr>
-          </a:p>
-          <a:p>
-            <a:pPr lvl="0" indent="0" marL="0">
-              <a:buNone/>
-            </a:pPr>
-            <a:r>
-              <a:rPr/>
-              <a:t>If someone asks about the half in front of the norm: it is there to make the derivative tidy, exactly as in lesson 3’s cost function.</a:t>
+              <a:t>The point worth stressing is why the soft margin is not a patch or a convenience. With even one mislabelled point inside the other class, the strict problem is INFEASIBLE - there is no solution, not a bad one. Real data always contains such points. So the soft margin is the only version anyone ever runs; the hard-margin problem is a teaching device.</a:t>
+            </a:r>
+          </a:p>
+          <a:p>
+            <a:pPr lvl="0" indent="0" marL="0">
+              <a:buNone/>
+            </a:pPr>
+          </a:p>
+          <a:p>
+            <a:pPr lvl="0" indent="0" marL="0">
+              <a:buNone/>
+            </a:pPr>
+            <a:r>
+              <a:rPr/>
+              <a:t>Our own labels are flipped at 4%, deliberately, so this is not a hypothetical for this dataset: the hard-margin problem on these pumps has no answer.</a:t>
+            </a:r>
+          </a:p>
+          <a:p>
+            <a:pPr lvl="0" indent="0" marL="0">
+              <a:buNone/>
+            </a:pPr>
+          </a:p>
+          <a:p>
+            <a:pPr lvl="0" indent="0" marL="0">
+              <a:buNone/>
+            </a:pPr>
+            <a:r>
+              <a:rPr/>
+              <a:t>The next slide puts it in symbols. Handout section 5.2 has the derivation.</a:t>
             </a:r>
           </a:p>
         </p:txBody>
@@ -4981,55 +4954,49 @@
             </a:pPr>
             <a:r>
               <a:rPr/>
-              <a:t>Third appearance of the same idea, and say so - that repetition is the point. Lesson 3 had λ, this morning had k, now C. Every model has one knob that trades fitting this data against surviving the next, and recognising it in an unfamiliar model is worth more than memorising three names.</a:t>
-            </a:r>
-          </a:p>
-          <a:p>
-            <a:pPr lvl="0" indent="0" marL="0">
-              <a:buNone/>
-            </a:pPr>
-          </a:p>
-          <a:p>
-            <a:pPr lvl="0" indent="0" marL="0">
-              <a:buNone/>
-            </a:pPr>
-            <a:r>
-              <a:rPr/>
-              <a:t>Then the direction, which catches people out constantly and is worth writing on the board. Large λ means MORE regularisation. Large C means LESS. They run opposite ways, and scikit-learn’s </a:t>
-            </a:r>
-            <a:r>
-              <a:rPr>
-                <a:latin typeface="Courier"/>
-              </a:rPr>
-              <a:t>C</a:t>
-            </a:r>
-            <a:r>
-              <a:rPr/>
-              <a:t> parameter in </a:t>
-            </a:r>
-            <a:r>
-              <a:rPr>
-                <a:latin typeface="Courier"/>
-              </a:rPr>
-              <a:t>LogisticRegression</a:t>
-            </a:r>
-            <a:r>
-              <a:rPr/>
-              <a:t> has the same inverted convention - it is the reciprocal of the penalty there too.</a:t>
-            </a:r>
-          </a:p>
-          <a:p>
-            <a:pPr lvl="0" indent="0" marL="0">
-              <a:buNone/>
-            </a:pPr>
-          </a:p>
-          <a:p>
-            <a:pPr lvl="0" indent="0" marL="0">
-              <a:buNone/>
-            </a:pPr>
-            <a:r>
-              <a:rPr/>
-              <a:t>Ask them which way they would expect C to run before you tell them. Most guess wrong, and having guessed wrong once is what makes it stick.</a:t>
+              <a:t>The constraint is not on the slide any more - it made the line wide enough to land at 28pt - so state it: subject to y_i(w’x_i + b) &gt;= 1 - xi_i, every point on the right side of the slab by a margin, or paying xi_i for the shortfall. Handout section 5.2 writes it out.</a:t>
+            </a:r>
+          </a:p>
+          <a:p>
+            <a:pPr lvl="0" indent="0" marL="0">
+              <a:buNone/>
+            </a:pPr>
+          </a:p>
+          <a:p>
+            <a:pPr lvl="0" indent="0" marL="0">
+              <a:buNone/>
+            </a:pPr>
+            <a:r>
+              <a:rPr/>
+              <a:t>Do not derive this. State what each piece is doing and move on - handout section 5.2 has the derivation, including why maximising the margin is the same as minimising the norm of w.</a:t>
+            </a:r>
+          </a:p>
+          <a:p>
+            <a:pPr lvl="0" indent="0" marL="0">
+              <a:buNone/>
+            </a:pPr>
+          </a:p>
+          <a:p>
+            <a:pPr lvl="0" indent="0" marL="0">
+              <a:buNone/>
+            </a:pPr>
+            <a:r>
+              <a:rPr/>
+              <a:t>The first term wants a wide slab. The second term wants few violations. C sets the exchange rate between them, and that is the entire content of the expression. Read it out in those words rather than reading the symbols.</a:t>
+            </a:r>
+          </a:p>
+          <a:p>
+            <a:pPr lvl="0" indent="0" marL="0">
+              <a:buNone/>
+            </a:pPr>
+          </a:p>
+          <a:p>
+            <a:pPr lvl="0" indent="0" marL="0">
+              <a:buNone/>
+            </a:pPr>
+            <a:r>
+              <a:rPr/>
+              <a:t>If someone asks about the half in front of the norm: it is there to make the derivative tidy, exactly as in lesson 3’s cost function.</a:t>
             </a:r>
           </a:p>
         </p:txBody>
@@ -5111,49 +5078,55 @@
             </a:pPr>
             <a:r>
               <a:rPr/>
-              <a:t>The linear kernel scores 0.613 - the base rate, exactly as logistic regression did this morning, with the same zero variance across folds.</a:t>
-            </a:r>
-          </a:p>
-          <a:p>
-            <a:pPr lvl="0" indent="0" marL="0">
-              <a:buNone/>
-            </a:pPr>
-          </a:p>
-          <a:p>
-            <a:pPr lvl="0" indent="0" marL="0">
-              <a:buNone/>
-            </a:pPr>
-            <a:r>
-              <a:rPr/>
-              <a:t>Make the point explicitly, because it is the one students most often get backwards: the margin criterion is a better way of CHOOSING among straight lines. It does not give you anything other than a straight line. When no straight line works, choosing the best one optimally still gets you nothing. A better criterion cannot rescue an inadequate hypothesis class.</a:t>
-            </a:r>
-          </a:p>
-          <a:p>
-            <a:pPr lvl="0" indent="0" marL="0">
-              <a:buNone/>
-            </a:pPr>
-          </a:p>
-          <a:p>
-            <a:pPr lvl="0" indent="0" marL="0">
-              <a:buNone/>
-            </a:pPr>
-            <a:r>
-              <a:rPr/>
-              <a:t>Then the RBF row, which is the same algorithm with one argument changed, at 0.947 - the best number in the whole lesson, and within a hair of the 0.96 ceiling.</a:t>
-            </a:r>
-          </a:p>
-          <a:p>
-            <a:pPr lvl="0" indent="0" marL="0">
-              <a:buNone/>
-            </a:pPr>
-          </a:p>
-          <a:p>
-            <a:pPr lvl="0" indent="0" marL="0">
-              <a:buNone/>
-            </a:pPr>
-            <a:r>
-              <a:rPr/>
-              <a:t>The support-vector column says the same thing in a second language, and that is the next slide.</a:t>
+              <a:t>Third appearance of the same idea, and say so - that repetition is the point. Lesson 3 had λ, this morning had k, now C. Every model has one knob that trades fitting this data against surviving the next, and recognising it in an unfamiliar model is worth more than memorising three names.</a:t>
+            </a:r>
+          </a:p>
+          <a:p>
+            <a:pPr lvl="0" indent="0" marL="0">
+              <a:buNone/>
+            </a:pPr>
+          </a:p>
+          <a:p>
+            <a:pPr lvl="0" indent="0" marL="0">
+              <a:buNone/>
+            </a:pPr>
+            <a:r>
+              <a:rPr/>
+              <a:t>Then the direction, which catches people out constantly and is worth writing on the board. Large λ means MORE regularisation. Large C means LESS. They run opposite ways, and scikit-learn’s </a:t>
+            </a:r>
+            <a:r>
+              <a:rPr>
+                <a:latin typeface="Courier"/>
+              </a:rPr>
+              <a:t>C</a:t>
+            </a:r>
+            <a:r>
+              <a:rPr/>
+              <a:t> parameter in </a:t>
+            </a:r>
+            <a:r>
+              <a:rPr>
+                <a:latin typeface="Courier"/>
+              </a:rPr>
+              <a:t>LogisticRegression</a:t>
+            </a:r>
+            <a:r>
+              <a:rPr/>
+              <a:t> has the same inverted convention - it is the reciprocal of the penalty there too.</a:t>
+            </a:r>
+          </a:p>
+          <a:p>
+            <a:pPr lvl="0" indent="0" marL="0">
+              <a:buNone/>
+            </a:pPr>
+          </a:p>
+          <a:p>
+            <a:pPr lvl="0" indent="0" marL="0">
+              <a:buNone/>
+            </a:pPr>
+            <a:r>
+              <a:rPr/>
+              <a:t>Ask them which way they would expect C to run before you tell them. Most guess wrong, and having guessed wrong once is what makes it stick.</a:t>
             </a:r>
           </a:p>
         </p:txBody>
@@ -5235,59 +5208,49 @@
             </a:pPr>
             <a:r>
               <a:rPr/>
-              <a:t>Explain what 79% actually means geometrically. A support vector is a point on the margin or inside it. If 79% of your data is in that position, there is no region of empty space between the classes at all - the model has been forced to place a boundary through a crowd.</a:t>
-            </a:r>
-          </a:p>
-          <a:p>
-            <a:pPr lvl="0" indent="0" marL="0">
-              <a:buNone/>
-            </a:pPr>
-          </a:p>
-          <a:p>
-            <a:pPr lvl="0" indent="0" marL="0">
-              <a:buNone/>
-            </a:pPr>
-            <a:r>
-              <a:rPr/>
-              <a:t>Contrast with 23%, where the model found genuine room and only the points near the edge matter.</a:t>
-            </a:r>
-          </a:p>
-          <a:p>
-            <a:pPr lvl="0" indent="0" marL="0">
-              <a:buNone/>
-            </a:pPr>
-          </a:p>
-          <a:p>
-            <a:pPr lvl="0" indent="0" marL="0">
-              <a:buNone/>
-            </a:pPr>
-            <a:r>
-              <a:rPr/>
-              <a:t>Give them the diagnostic to keep, since it costs nothing: after fitting an SVM, look at </a:t>
-            </a:r>
-            <a:r>
-              <a:rPr>
-                <a:latin typeface="Courier"/>
-              </a:rPr>
-              <a:t>len(model.support_)</a:t>
-            </a:r>
-            <a:r>
-              <a:rPr/>
-              <a:t> over the number of training rows. High means the model is struggling to find room, which usually means the kernel is wrong for the geometry. It is a warning available BEFORE you cross-validate anything.</a:t>
-            </a:r>
-          </a:p>
-          <a:p>
-            <a:pPr lvl="0" indent="0" marL="0">
-              <a:buNone/>
-            </a:pPr>
-          </a:p>
-          <a:p>
-            <a:pPr lvl="0" indent="0" marL="0">
-              <a:buNone/>
-            </a:pPr>
-            <a:r>
-              <a:rPr/>
-              <a:t>Worth adding that it also predicts prediction cost - every support vector is one kernel evaluation per query, so a model needing 79% of the data has thrown away most of the speed advantage over k-NN.</a:t>
+              <a:t>The linear kernel scores 0.613 - the base rate, exactly as logistic regression did this morning, with the same zero variance across folds.</a:t>
+            </a:r>
+          </a:p>
+          <a:p>
+            <a:pPr lvl="0" indent="0" marL="0">
+              <a:buNone/>
+            </a:pPr>
+          </a:p>
+          <a:p>
+            <a:pPr lvl="0" indent="0" marL="0">
+              <a:buNone/>
+            </a:pPr>
+            <a:r>
+              <a:rPr/>
+              <a:t>Make the point explicitly, because it is the one students most often get backwards: the margin criterion is a better way of CHOOSING among straight lines. It does not give you anything other than a straight line. When no straight line works, choosing the best one optimally still gets you nothing. A better criterion cannot rescue an inadequate hypothesis class.</a:t>
+            </a:r>
+          </a:p>
+          <a:p>
+            <a:pPr lvl="0" indent="0" marL="0">
+              <a:buNone/>
+            </a:pPr>
+          </a:p>
+          <a:p>
+            <a:pPr lvl="0" indent="0" marL="0">
+              <a:buNone/>
+            </a:pPr>
+            <a:r>
+              <a:rPr/>
+              <a:t>Then the RBF row, which is the same algorithm with one argument changed, at 0.947 - the best number in the whole lesson, and within a hair of the 0.96 ceiling.</a:t>
+            </a:r>
+          </a:p>
+          <a:p>
+            <a:pPr lvl="0" indent="0" marL="0">
+              <a:buNone/>
+            </a:pPr>
+          </a:p>
+          <a:p>
+            <a:pPr lvl="0" indent="0" marL="0">
+              <a:buNone/>
+            </a:pPr>
+            <a:r>
+              <a:rPr/>
+              <a:t>The support-vector column says the same thing in a second language, and that is the next slide.</a:t>
             </a:r>
           </a:p>
         </p:txBody>
@@ -5369,49 +5332,59 @@
             </a:pPr>
             <a:r>
               <a:rPr/>
-              <a:t>Build the picture in words first and let them see it before the figure appears. Take the scatter plot from the start of the lesson, lift each point off the page by its distance from the centre, and look from the side.</a:t>
-            </a:r>
-          </a:p>
-          <a:p>
-            <a:pPr lvl="0" indent="0" marL="0">
-              <a:buNone/>
-            </a:pPr>
-          </a:p>
-          <a:p>
-            <a:pPr lvl="0" indent="0" marL="0">
-              <a:buNone/>
-            </a:pPr>
-            <a:r>
-              <a:rPr/>
-              <a:t>Then the sentence that reframes the whole afternoon: the classes were never inseparable. Separability is not a property of the data - it is a property of the data AND the coordinates you happen to have measured it in.</a:t>
-            </a:r>
-          </a:p>
-          <a:p>
-            <a:pPr lvl="0" indent="0" marL="0">
-              <a:buNone/>
-            </a:pPr>
-          </a:p>
-          <a:p>
-            <a:pPr lvl="0" indent="0" marL="0">
-              <a:buNone/>
-            </a:pPr>
-            <a:r>
-              <a:rPr/>
-              <a:t>Ask what is unsatisfying about what we just did, and wait for it. We chose that lift by already knowing the answer. We knew the fault mode was radial. In any real problem you do not, and inventing the right coordinate is the hard part - which is exactly the difficulty the kernel trick removes.</a:t>
-            </a:r>
-          </a:p>
-          <a:p>
-            <a:pPr lvl="0" indent="0" marL="0">
-              <a:buNone/>
-            </a:pPr>
-          </a:p>
-          <a:p>
-            <a:pPr lvl="0" indent="0" marL="0">
-              <a:buNone/>
-            </a:pPr>
-            <a:r>
-              <a:rPr/>
-              <a:t>Handout section 5.4.</a:t>
+              <a:t>Explain what 79% actually means geometrically. A support vector is a point on the margin or inside it. If 79% of your data is in that position, there is no region of empty space between the classes at all - the model has been forced to place a boundary through a crowd.</a:t>
+            </a:r>
+          </a:p>
+          <a:p>
+            <a:pPr lvl="0" indent="0" marL="0">
+              <a:buNone/>
+            </a:pPr>
+          </a:p>
+          <a:p>
+            <a:pPr lvl="0" indent="0" marL="0">
+              <a:buNone/>
+            </a:pPr>
+            <a:r>
+              <a:rPr/>
+              <a:t>Contrast with 23%, where the model found genuine room and only the points near the edge matter.</a:t>
+            </a:r>
+          </a:p>
+          <a:p>
+            <a:pPr lvl="0" indent="0" marL="0">
+              <a:buNone/>
+            </a:pPr>
+          </a:p>
+          <a:p>
+            <a:pPr lvl="0" indent="0" marL="0">
+              <a:buNone/>
+            </a:pPr>
+            <a:r>
+              <a:rPr/>
+              <a:t>Give them the diagnostic to keep, since it costs nothing: after fitting an SVM, look at </a:t>
+            </a:r>
+            <a:r>
+              <a:rPr>
+                <a:latin typeface="Courier"/>
+              </a:rPr>
+              <a:t>len(model.support_)</a:t>
+            </a:r>
+            <a:r>
+              <a:rPr/>
+              <a:t> over the number of training rows. High means the model is struggling to find room, which usually means the kernel is wrong for the geometry. It is a warning available BEFORE you cross-validate anything.</a:t>
+            </a:r>
+          </a:p>
+          <a:p>
+            <a:pPr lvl="0" indent="0" marL="0">
+              <a:buNone/>
+            </a:pPr>
+          </a:p>
+          <a:p>
+            <a:pPr lvl="0" indent="0" marL="0">
+              <a:buNone/>
+            </a:pPr>
+            <a:r>
+              <a:rPr/>
+              <a:t>Worth adding that it also predicts prediction cost - every support vector is one kernel evaluation per query, so a model needing 79% of the data has thrown away most of the speed advantage over k-NN.</a:t>
             </a:r>
           </a:p>
         </p:txBody>
@@ -5493,35 +5466,49 @@
             </a:pPr>
             <a:r>
               <a:rPr/>
-              <a:t>The same 1,200 pumps twice: on the left in the plane where they were measured, on the right lifted by their distance from the design point. The gold plane does what no line could.</a:t>
-            </a:r>
-          </a:p>
-          <a:p>
-            <a:pPr lvl="0" indent="0" marL="0">
-              <a:buNone/>
-            </a:pPr>
-          </a:p>
-          <a:p>
-            <a:pPr lvl="0" indent="0" marL="0">
-              <a:buNone/>
-            </a:pPr>
-            <a:r>
-              <a:rPr/>
-              <a:t>Have them look at the right panel and confirm for themselves that a flat horizontal cut separates the colours cleanly. Nothing was added - no new measurement, no extra sensor. The third coordinate is computed from the two they already had.</a:t>
-            </a:r>
-          </a:p>
-          <a:p>
-            <a:pPr lvl="0" indent="0" marL="0">
-              <a:buNone/>
-            </a:pPr>
-          </a:p>
-          <a:p>
-            <a:pPr lvl="0" indent="0" marL="0">
-              <a:buNone/>
-            </a:pPr>
-            <a:r>
-              <a:rPr/>
-              <a:t>Then set up the objection that the next slide answers. This worked because the lift was three-dimensional and we could guess it. The spaces that work in general are enormous - the useful ones are sometimes infinite-dimensional - and computing the coordinates of every point in such a space is impossible.</a:t>
+              <a:t>Build the picture in words first and let them see it before the figure appears. Take the scatter plot from the start of the lesson, lift each point off the page by its distance from the centre, and look from the side.</a:t>
+            </a:r>
+          </a:p>
+          <a:p>
+            <a:pPr lvl="0" indent="0" marL="0">
+              <a:buNone/>
+            </a:pPr>
+          </a:p>
+          <a:p>
+            <a:pPr lvl="0" indent="0" marL="0">
+              <a:buNone/>
+            </a:pPr>
+            <a:r>
+              <a:rPr/>
+              <a:t>Then the sentence that reframes the whole afternoon: the classes were never inseparable. Separability is not a property of the data - it is a property of the data AND the coordinates you happen to have measured it in.</a:t>
+            </a:r>
+          </a:p>
+          <a:p>
+            <a:pPr lvl="0" indent="0" marL="0">
+              <a:buNone/>
+            </a:pPr>
+          </a:p>
+          <a:p>
+            <a:pPr lvl="0" indent="0" marL="0">
+              <a:buNone/>
+            </a:pPr>
+            <a:r>
+              <a:rPr/>
+              <a:t>Ask what is unsatisfying about what we just did, and wait for it. We chose that lift by already knowing the answer. We knew the fault mode was radial. In any real problem you do not, and inventing the right coordinate is the hard part - which is exactly the difficulty the kernel trick removes.</a:t>
+            </a:r>
+          </a:p>
+          <a:p>
+            <a:pPr lvl="0" indent="0" marL="0">
+              <a:buNone/>
+            </a:pPr>
+          </a:p>
+          <a:p>
+            <a:pPr lvl="0" indent="0" marL="0">
+              <a:buNone/>
+            </a:pPr>
+            <a:r>
+              <a:rPr/>
+              <a:t>Handout section 5.4.</a:t>
             </a:r>
           </a:p>
         </p:txBody>
@@ -5603,35 +5590,35 @@
             </a:pPr>
             <a:r>
               <a:rPr/>
-              <a:t>The trick in one sentence: the SVM never needs the coordinates, only the angles and lengths between points, and those can be obtained without ever going there.</a:t>
-            </a:r>
-          </a:p>
-          <a:p>
-            <a:pPr lvl="0" indent="0" marL="0">
-              <a:buNone/>
-            </a:pPr>
-          </a:p>
-          <a:p>
-            <a:pPr lvl="0" indent="0" marL="0">
-              <a:buNone/>
-            </a:pPr>
-            <a:r>
-              <a:rPr/>
-              <a:t>Do not prove it - handout section 5.4 shows where the inner products come from in the dual formulation. The claim to state and let land is that a function of two ordinary two-dimensional vectors returns their inner product in a space of infinite dimension, at the cost of one exponential.</a:t>
-            </a:r>
-          </a:p>
-          <a:p>
-            <a:pPr lvl="0" indent="0" marL="0">
-              <a:buNone/>
-            </a:pPr>
-          </a:p>
-          <a:p>
-            <a:pPr lvl="0" indent="0" marL="0">
-              <a:buNone/>
-            </a:pPr>
-            <a:r>
-              <a:rPr/>
-              <a:t>And close the loop from the previous slide: we chose the lift in the picture by knowing the answer. The RBF kernel does something equivalent without being told, which is exactly why it works on problems where nobody could guess the right coordinates.</a:t>
+              <a:t>The same 1,200 pumps twice: on the left in the plane where they were measured, on the right lifted by their distance from the design point. The gold plane does what no line could.</a:t>
+            </a:r>
+          </a:p>
+          <a:p>
+            <a:pPr lvl="0" indent="0" marL="0">
+              <a:buNone/>
+            </a:pPr>
+          </a:p>
+          <a:p>
+            <a:pPr lvl="0" indent="0" marL="0">
+              <a:buNone/>
+            </a:pPr>
+            <a:r>
+              <a:rPr/>
+              <a:t>Have them look at the right panel and confirm for themselves that a flat horizontal cut separates the colours cleanly. Nothing was added - no new measurement, no extra sensor. The third coordinate is computed from the two they already had.</a:t>
+            </a:r>
+          </a:p>
+          <a:p>
+            <a:pPr lvl="0" indent="0" marL="0">
+              <a:buNone/>
+            </a:pPr>
+          </a:p>
+          <a:p>
+            <a:pPr lvl="0" indent="0" marL="0">
+              <a:buNone/>
+            </a:pPr>
+            <a:r>
+              <a:rPr/>
+              <a:t>Then set up the objection that the next slide answers. This worked because the lift was three-dimensional and we could guess it. The spaces that work in general are enormous - the useful ones are sometimes infinite-dimensional - and computing the coordinates of every point in such a space is impossible.</a:t>
             </a:r>
           </a:p>
         </p:txBody>
@@ -5713,59 +5700,35 @@
             </a:pPr>
             <a:r>
               <a:rPr/>
-              <a:t>One line, and it is the whole of what scikit-learn does when you leave </a:t>
-            </a:r>
-            <a:r>
-              <a:rPr>
-                <a:latin typeface="Courier"/>
-              </a:rPr>
-              <a:t>kernel</a:t>
-            </a:r>
-            <a:r>
-              <a:rPr/>
-              <a:t> at its default.</a:t>
-            </a:r>
-          </a:p>
-          <a:p>
-            <a:pPr lvl="0" indent="0" marL="0">
-              <a:buNone/>
-            </a:pPr>
-          </a:p>
-          <a:p>
-            <a:pPr lvl="0" indent="0" marL="0">
-              <a:buNone/>
-            </a:pPr>
-            <a:r>
-              <a:rPr/>
-              <a:t>Read it aloud as a similarity rather than as a formula: the closer two points are, the nearer the exponent is to zero and the nearer the kernel is to one; far apart, it falls away to nothing. That is all an RBF kernel says - how much does this point look like that one.</a:t>
-            </a:r>
-          </a:p>
-          <a:p>
-            <a:pPr lvl="0" indent="0" marL="0">
-              <a:buNone/>
-            </a:pPr>
-          </a:p>
-          <a:p>
-            <a:pPr lvl="0" indent="0" marL="0">
-              <a:buNone/>
-            </a:pPr>
-            <a:r>
-              <a:rPr/>
-              <a:t>Now say what γ means, because the next two slides turn on it: it sets how far a single training point’s influence reaches. Small γ, wide reach, smooth boundary. Large γ, each point influences only its immediate neighbourhood - and a boundary that can afford an island around every mislabelled pump.</a:t>
-            </a:r>
-          </a:p>
-          <a:p>
-            <a:pPr lvl="0" indent="0" marL="0">
-              <a:buNone/>
-            </a:pPr>
-          </a:p>
-          <a:p>
-            <a:pPr lvl="0" indent="0" marL="0">
-              <a:buNone/>
-            </a:pPr>
-            <a:r>
-              <a:rPr/>
-              <a:t>Worth naming the cost, since this is an engineering course: one exponential per pair of points, so the kernel matrix is m × m. That is why support vector machines are a poor fit above a hundred thousand rows, and it is a property of the method rather than of the implementation.</a:t>
+              <a:t>The trick in one sentence: the SVM never needs the coordinates, only the angles and lengths between points, and those can be obtained without ever going there.</a:t>
+            </a:r>
+          </a:p>
+          <a:p>
+            <a:pPr lvl="0" indent="0" marL="0">
+              <a:buNone/>
+            </a:pPr>
+          </a:p>
+          <a:p>
+            <a:pPr lvl="0" indent="0" marL="0">
+              <a:buNone/>
+            </a:pPr>
+            <a:r>
+              <a:rPr/>
+              <a:t>Do not prove it - handout section 5.4 shows where the inner products come from in the dual formulation. The claim to state and let land is that a function of two ordinary two-dimensional vectors returns their inner product in a space of infinite dimension, at the cost of one exponential.</a:t>
+            </a:r>
+          </a:p>
+          <a:p>
+            <a:pPr lvl="0" indent="0" marL="0">
+              <a:buNone/>
+            </a:pPr>
+          </a:p>
+          <a:p>
+            <a:pPr lvl="0" indent="0" marL="0">
+              <a:buNone/>
+            </a:pPr>
+            <a:r>
+              <a:rPr/>
+              <a:t>And close the loop from the previous slide: we chose the lift in the picture by knowing the answer. The RBF kernel does something equivalent without being told, which is exactly why it works on problems where nobody could guess the right coordinates.</a:t>
             </a:r>
           </a:p>
         </p:txBody>
@@ -5847,53 +5810,59 @@
             </a:pPr>
             <a:r>
               <a:rPr/>
-              <a:t>Read the two columns against each other, exactly as lesson 5 taught, and let the last row do the work.</a:t>
-            </a:r>
-          </a:p>
-          <a:p>
-            <a:pPr lvl="0" indent="0" marL="0">
-              <a:buNone/>
-            </a:pPr>
-          </a:p>
-          <a:p>
-            <a:pPr lvl="0" indent="0" marL="0">
-              <a:buNone/>
-            </a:pPr>
-            <a:r>
-              <a:rPr/>
-              <a:t>The bottom row has the best training score on the slide - 0.995, nearly perfect - and the worst honest one. That is the signature of overfitting, and here it is not inferred from theory but measured on the same data by two different procedures.</a:t>
-            </a:r>
-          </a:p>
-          <a:p>
-            <a:pPr lvl="0" indent="0" marL="0">
-              <a:buNone/>
-            </a:pPr>
-          </a:p>
-          <a:p>
-            <a:pPr lvl="0" indent="0" marL="0">
-              <a:buNone/>
-            </a:pPr>
-            <a:r>
-              <a:rPr b="1"/>
-              <a:t>Now the second predictable mistake, and defend the instinct.</a:t>
-            </a:r>
-            <a:r>
-              <a:rPr/>
-              <a:t> Choosing between these three on the training score selects the WORST model, with complete confidence and a very impressive number to report. And the instinct behind it is not stupid: a higher score on the data you have is, in every other part of engineering, evidence of a better system. Fitting the data well is what we spent lessons 3 and 4 doing. What breaks the analogy is that a flexible model can fit data it has already been shown without learning anything transferable.</a:t>
-            </a:r>
-          </a:p>
-          <a:p>
-            <a:pPr lvl="0" indent="0" marL="0">
-              <a:buNone/>
-            </a:pPr>
-          </a:p>
-          <a:p>
-            <a:pPr lvl="0" indent="0" marL="0">
-              <a:buNone/>
-            </a:pPr>
-            <a:r>
-              <a:rPr/>
-              <a:t>The reason this table is on the slide rather than in the handout is that the next slide shows the same three settings as pictures - so the failure is visible as well as measurable, which is rare.</a:t>
+              <a:t>One line, and it is the whole of what scikit-learn does when you leave </a:t>
+            </a:r>
+            <a:r>
+              <a:rPr>
+                <a:latin typeface="Courier"/>
+              </a:rPr>
+              <a:t>kernel</a:t>
+            </a:r>
+            <a:r>
+              <a:rPr/>
+              <a:t> at its default.</a:t>
+            </a:r>
+          </a:p>
+          <a:p>
+            <a:pPr lvl="0" indent="0" marL="0">
+              <a:buNone/>
+            </a:pPr>
+          </a:p>
+          <a:p>
+            <a:pPr lvl="0" indent="0" marL="0">
+              <a:buNone/>
+            </a:pPr>
+            <a:r>
+              <a:rPr/>
+              <a:t>Read it aloud as a similarity rather than as a formula: the closer two points are, the nearer the exponent is to zero and the nearer the kernel is to one; far apart, it falls away to nothing. That is all an RBF kernel says - how much does this point look like that one.</a:t>
+            </a:r>
+          </a:p>
+          <a:p>
+            <a:pPr lvl="0" indent="0" marL="0">
+              <a:buNone/>
+            </a:pPr>
+          </a:p>
+          <a:p>
+            <a:pPr lvl="0" indent="0" marL="0">
+              <a:buNone/>
+            </a:pPr>
+            <a:r>
+              <a:rPr/>
+              <a:t>Now say what γ means, because the next two slides turn on it: it sets how far a single training point’s influence reaches. Small γ, wide reach, smooth boundary. Large γ, each point influences only its immediate neighbourhood - and a boundary that can afford an island around every mislabelled pump.</a:t>
+            </a:r>
+          </a:p>
+          <a:p>
+            <a:pPr lvl="0" indent="0" marL="0">
+              <a:buNone/>
+            </a:pPr>
+          </a:p>
+          <a:p>
+            <a:pPr lvl="0" indent="0" marL="0">
+              <a:buNone/>
+            </a:pPr>
+            <a:r>
+              <a:rPr/>
+              <a:t>Worth naming the cost, since this is an engineering course: one exponential per pair of points, so the kernel matrix is m × m. That is why support vector machines are a poor fit above a hundred thousand rows, and it is a property of the method rather than of the implementation.</a:t>
             </a:r>
           </a:p>
         </p:txBody>
@@ -6107,63 +6076,53 @@
             </a:pPr>
             <a:r>
               <a:rPr/>
-              <a:t>Three settings, with training and cross-validated scores in each title. Read them together.</a:t>
-            </a:r>
-          </a:p>
-          <a:p>
-            <a:pPr lvl="0" indent="0" marL="0">
-              <a:buNone/>
-            </a:pPr>
-          </a:p>
-          <a:p>
-            <a:pPr lvl="0" indent="0" marL="0">
-              <a:buNone/>
-            </a:pPr>
-            <a:r>
-              <a:rPr/>
-              <a:t>Left, γ = 0.1: a smooth boundary, slightly too smooth, and the two scores agree. Middle, γ = 1: close to the true envelope, and the best honest score.</a:t>
-            </a:r>
-          </a:p>
-          <a:p>
-            <a:pPr lvl="0" indent="0" marL="0">
-              <a:buNone/>
-            </a:pPr>
-          </a:p>
-          <a:p>
-            <a:pPr lvl="0" indent="0" marL="0">
-              <a:buNone/>
-            </a:pPr>
-            <a:r>
-              <a:rPr/>
-              <a:t>Right is the one to sit on. The boundary has broken into bubbles - small islands around individual points, including the mislabelled ones. That is what a 0.995 training score looks like from the outside: the model has drawn a private territory around each flipped label so that it can get it right.</a:t>
-            </a:r>
-          </a:p>
-          <a:p>
-            <a:pPr lvl="0" indent="0" marL="0">
-              <a:buNone/>
-            </a:pPr>
-          </a:p>
-          <a:p>
-            <a:pPr lvl="0" indent="0" marL="0">
-              <a:buNone/>
-            </a:pPr>
-            <a:r>
-              <a:rPr/>
-              <a:t>Ask them what happens to a new pump landing in the gap between two bubbles. That is the 0.902.</a:t>
-            </a:r>
-          </a:p>
-          <a:p>
-            <a:pPr lvl="0" indent="0" marL="0">
-              <a:buNone/>
-            </a:pPr>
-          </a:p>
-          <a:p>
-            <a:pPr lvl="0" indent="0" marL="0">
-              <a:buNone/>
-            </a:pPr>
-            <a:r>
-              <a:rPr/>
-              <a:t>The reason this slide matters more than the table: they have seen overfitting as a curve on a plot since lesson 5. Here it is a shape in the input space, and the shape is obviously wrong in a way no number is. When you can plot the boundary, plot it.</a:t>
+              <a:t>Read the two columns against each other, exactly as lesson 5 taught, and let the last row do the work.</a:t>
+            </a:r>
+          </a:p>
+          <a:p>
+            <a:pPr lvl="0" indent="0" marL="0">
+              <a:buNone/>
+            </a:pPr>
+          </a:p>
+          <a:p>
+            <a:pPr lvl="0" indent="0" marL="0">
+              <a:buNone/>
+            </a:pPr>
+            <a:r>
+              <a:rPr/>
+              <a:t>The bottom row has the best training score on the slide - 0.995, nearly perfect - and the worst honest one. That is the signature of overfitting, and here it is not inferred from theory but measured on the same data by two different procedures.</a:t>
+            </a:r>
+          </a:p>
+          <a:p>
+            <a:pPr lvl="0" indent="0" marL="0">
+              <a:buNone/>
+            </a:pPr>
+          </a:p>
+          <a:p>
+            <a:pPr lvl="0" indent="0" marL="0">
+              <a:buNone/>
+            </a:pPr>
+            <a:r>
+              <a:rPr b="1"/>
+              <a:t>Now the second predictable mistake, and defend the instinct.</a:t>
+            </a:r>
+            <a:r>
+              <a:rPr/>
+              <a:t> Choosing between these three on the training score selects the WORST model, with complete confidence and a very impressive number to report. And the instinct behind it is not stupid: a higher score on the data you have is, in every other part of engineering, evidence of a better system. Fitting the data well is what we spent lessons 3 and 4 doing. What breaks the analogy is that a flexible model can fit data it has already been shown without learning anything transferable.</a:t>
+            </a:r>
+          </a:p>
+          <a:p>
+            <a:pPr lvl="0" indent="0" marL="0">
+              <a:buNone/>
+            </a:pPr>
+          </a:p>
+          <a:p>
+            <a:pPr lvl="0" indent="0" marL="0">
+              <a:buNone/>
+            </a:pPr>
+            <a:r>
+              <a:rPr/>
+              <a:t>The reason this table is on the slide rather than in the handout is that the next slide shows the same three settings as pictures - so the failure is visible as well as measurable, which is rare.</a:t>
             </a:r>
           </a:p>
         </p:txBody>
@@ -6245,49 +6204,63 @@
             </a:pPr>
             <a:r>
               <a:rPr/>
-              <a:t>Run notebooks/03. Eighteen minutes.</a:t>
-            </a:r>
-          </a:p>
-          <a:p>
-            <a:pPr lvl="0" indent="0" marL="0">
-              <a:buNone/>
-            </a:pPr>
-          </a:p>
-          <a:p>
-            <a:pPr lvl="0" indent="0" marL="0">
-              <a:buNone/>
-            </a:pPr>
-            <a:r>
-              <a:rPr/>
-              <a:t>The cell to protect is the γ sweep with the boundary drawn at each setting. Let them turn γ up themselves and watch the bubbles form - it is the most direct experience of overfitting available in this course.</a:t>
-            </a:r>
-          </a:p>
-          <a:p>
-            <a:pPr lvl="0" indent="0" marL="0">
-              <a:buNone/>
-            </a:pPr>
-          </a:p>
-          <a:p>
-            <a:pPr lvl="0" indent="0" marL="0">
-              <a:buNone/>
-            </a:pPr>
-            <a:r>
-              <a:rPr/>
-              <a:t>Have them print the support-vector fraction for the linear and RBF kernels side by side. Two numbers, and it makes the diagnostic real rather than a claim on a slide.</a:t>
-            </a:r>
-          </a:p>
-          <a:p>
-            <a:pPr lvl="0" indent="0" marL="0">
-              <a:buNone/>
-            </a:pPr>
-          </a:p>
-          <a:p>
-            <a:pPr lvl="0" indent="0" marL="0">
-              <a:buNone/>
-            </a:pPr>
-            <a:r>
-              <a:rPr/>
-              <a:t>If time runs short, skip the C sweep and set it as reading: the table is in handout section 5.5.</a:t>
+              <a:t>Three settings, with training and cross-validated scores in each title. Read them together.</a:t>
+            </a:r>
+          </a:p>
+          <a:p>
+            <a:pPr lvl="0" indent="0" marL="0">
+              <a:buNone/>
+            </a:pPr>
+          </a:p>
+          <a:p>
+            <a:pPr lvl="0" indent="0" marL="0">
+              <a:buNone/>
+            </a:pPr>
+            <a:r>
+              <a:rPr/>
+              <a:t>Left, γ = 0.1: a smooth boundary, slightly too smooth, and the two scores agree. Middle, γ = 1: close to the true envelope, and the best honest score.</a:t>
+            </a:r>
+          </a:p>
+          <a:p>
+            <a:pPr lvl="0" indent="0" marL="0">
+              <a:buNone/>
+            </a:pPr>
+          </a:p>
+          <a:p>
+            <a:pPr lvl="0" indent="0" marL="0">
+              <a:buNone/>
+            </a:pPr>
+            <a:r>
+              <a:rPr/>
+              <a:t>Right is the one to sit on. The boundary has broken into bubbles - small islands around individual points, including the mislabelled ones. That is what a 0.995 training score looks like from the outside: the model has drawn a private territory around each flipped label so that it can get it right.</a:t>
+            </a:r>
+          </a:p>
+          <a:p>
+            <a:pPr lvl="0" indent="0" marL="0">
+              <a:buNone/>
+            </a:pPr>
+          </a:p>
+          <a:p>
+            <a:pPr lvl="0" indent="0" marL="0">
+              <a:buNone/>
+            </a:pPr>
+            <a:r>
+              <a:rPr/>
+              <a:t>Ask them what happens to a new pump landing in the gap between two bubbles. That is the 0.902.</a:t>
+            </a:r>
+          </a:p>
+          <a:p>
+            <a:pPr lvl="0" indent="0" marL="0">
+              <a:buNone/>
+            </a:pPr>
+          </a:p>
+          <a:p>
+            <a:pPr lvl="0" indent="0" marL="0">
+              <a:buNone/>
+            </a:pPr>
+            <a:r>
+              <a:rPr/>
+              <a:t>The reason this slide matters more than the table: they have seen overfitting as a curve on a plot since lesson 5. Here it is a shape in the input space, and the shape is obviously wrong in a way no number is. When you can plot the boundary, plot it.</a:t>
             </a:r>
           </a:p>
         </p:txBody>
@@ -6369,57 +6342,49 @@
             </a:pPr>
             <a:r>
               <a:rPr/>
-              <a:t>Everything in the lesson on the same 1,200 pumps, cross-validated the same way.</a:t>
-            </a:r>
-          </a:p>
-          <a:p>
-            <a:pPr lvl="0" indent="0" marL="0">
-              <a:buNone/>
-            </a:pPr>
-          </a:p>
-          <a:p>
-            <a:pPr lvl="0" indent="0" marL="0">
-              <a:buNone/>
-            </a:pPr>
-            <a:r>
-              <a:rPr/>
-              <a:t>Read the top three rows together: all exactly 0.613, and all three are linear. Then the bottom three, all near the ceiling, reached by three completely unrelated routes - remembering the neighbourhood, assuming independence, bending the space. There is no single idea shared between them.</a:t>
-            </a:r>
-          </a:p>
-          <a:p>
-            <a:pPr lvl="0" indent="0" marL="0">
-              <a:buNone/>
-            </a:pPr>
-          </a:p>
-          <a:p>
-            <a:pPr lvl="0" indent="0" marL="0">
-              <a:buNone/>
-            </a:pPr>
-            <a:r>
-              <a:rPr/>
-              <a:t>Then the number that is the lesson: the gap between best and worst is </a:t>
-            </a:r>
-            <a:r>
-              <a:rPr b="1"/>
-              <a:t>0.334</a:t>
-            </a:r>
-            <a:r>
-              <a:rPr/>
-              <a:t>. Larger than any difference this course has shown between a good model and a carefully tuned one - lesson 5’s entire hyperparameter search moved things by a few hundredths.</a:t>
-            </a:r>
-          </a:p>
-          <a:p>
-            <a:pPr lvl="0" indent="0" marL="0">
-              <a:buNone/>
-            </a:pPr>
-          </a:p>
-          <a:p>
-            <a:pPr lvl="0" indent="0" marL="0">
-              <a:buNone/>
-            </a:pPr>
-            <a:r>
-              <a:rPr/>
-              <a:t>Say the conclusion plainly, and it is the practical takeaway of the whole lesson: choosing the right family matters far more than tuning the wrong one. Nobody in the top three rows could have tuned their way out. And the way to tell which family you need is to look at the data first, which is what lesson 2 was for.</a:t>
+              <a:t>Run notebooks/03. Eighteen minutes.</a:t>
+            </a:r>
+          </a:p>
+          <a:p>
+            <a:pPr lvl="0" indent="0" marL="0">
+              <a:buNone/>
+            </a:pPr>
+          </a:p>
+          <a:p>
+            <a:pPr lvl="0" indent="0" marL="0">
+              <a:buNone/>
+            </a:pPr>
+            <a:r>
+              <a:rPr/>
+              <a:t>The cell to protect is the γ sweep with the boundary drawn at each setting. Let them turn γ up themselves and watch the bubbles form - it is the most direct experience of overfitting available in this course.</a:t>
+            </a:r>
+          </a:p>
+          <a:p>
+            <a:pPr lvl="0" indent="0" marL="0">
+              <a:buNone/>
+            </a:pPr>
+          </a:p>
+          <a:p>
+            <a:pPr lvl="0" indent="0" marL="0">
+              <a:buNone/>
+            </a:pPr>
+            <a:r>
+              <a:rPr/>
+              <a:t>Have them print the support-vector fraction for the linear and RBF kernels side by side. Two numbers, and it makes the diagnostic real rather than a claim on a slide.</a:t>
+            </a:r>
+          </a:p>
+          <a:p>
+            <a:pPr lvl="0" indent="0" marL="0">
+              <a:buNone/>
+            </a:pPr>
+          </a:p>
+          <a:p>
+            <a:pPr lvl="0" indent="0" marL="0">
+              <a:buNone/>
+            </a:pPr>
+            <a:r>
+              <a:rPr/>
+              <a:t>If time runs short, skip the C sweep and set it as reading: the table is in handout section 5.5.</a:t>
             </a:r>
           </a:p>
         </p:txBody>
@@ -6501,35 +6466,57 @@
             </a:pPr>
             <a:r>
               <a:rPr/>
-              <a:t>A table to photograph. Work down it and attach today’s evidence to each row, so it is remembered as a set of conclusions rather than as advice.</a:t>
-            </a:r>
-          </a:p>
-          <a:p>
-            <a:pPr lvl="0" indent="0" marL="0">
-              <a:buNone/>
-            </a:pPr>
-          </a:p>
-          <a:p>
-            <a:pPr lvl="0" indent="0" marL="0">
-              <a:buNone/>
-            </a:pPr>
-            <a:r>
-              <a:rPr/>
-              <a:t>Row two deserves a sentence on its own, because it is the one that sounds wrong after the last hour. Text classification is the canonical case: tens of thousands of word-count features, an assumption that is transparently false, and a method that works anyway - because being roughly right in ten thousand dimensions beats being unable to estimate anything at all. Also mention Naive Bayes as a baseline: it trains in one pass, so if your tuned model does not beat it you have learned something quickly and cheaply.</a:t>
-            </a:r>
-          </a:p>
-          <a:p>
-            <a:pPr lvl="0" indent="0" marL="0">
-              <a:buNone/>
-            </a:pPr>
-          </a:p>
-          <a:p>
-            <a:pPr lvl="0" indent="0" marL="0">
-              <a:buNone/>
-            </a:pPr>
-            <a:r>
-              <a:rPr/>
-              <a:t>One row that did not fit and should be said out loud: when you need to explain the decision to the person affected, none of today’s three will do it. A support vector machine in a lifted space has no explanation a customer would accept. Lesson 3’s Resources document covers why that is sometimes a legal requirement rather than a preference.</a:t>
+              <a:t>Everything in the lesson on the same 1,200 pumps, cross-validated the same way.</a:t>
+            </a:r>
+          </a:p>
+          <a:p>
+            <a:pPr lvl="0" indent="0" marL="0">
+              <a:buNone/>
+            </a:pPr>
+          </a:p>
+          <a:p>
+            <a:pPr lvl="0" indent="0" marL="0">
+              <a:buNone/>
+            </a:pPr>
+            <a:r>
+              <a:rPr/>
+              <a:t>Read the top three rows together: all exactly 0.613, and all three are linear. Then the bottom three, all near the ceiling, reached by three completely unrelated routes - remembering the neighbourhood, assuming independence, bending the space. There is no single idea shared between them.</a:t>
+            </a:r>
+          </a:p>
+          <a:p>
+            <a:pPr lvl="0" indent="0" marL="0">
+              <a:buNone/>
+            </a:pPr>
+          </a:p>
+          <a:p>
+            <a:pPr lvl="0" indent="0" marL="0">
+              <a:buNone/>
+            </a:pPr>
+            <a:r>
+              <a:rPr/>
+              <a:t>Then the number that is the lesson: the gap between best and worst is </a:t>
+            </a:r>
+            <a:r>
+              <a:rPr b="1"/>
+              <a:t>0.334</a:t>
+            </a:r>
+            <a:r>
+              <a:rPr/>
+              <a:t>. Larger than any difference this course has shown between a good model and a carefully tuned one - lesson 5’s entire hyperparameter search moved things by a few hundredths.</a:t>
+            </a:r>
+          </a:p>
+          <a:p>
+            <a:pPr lvl="0" indent="0" marL="0">
+              <a:buNone/>
+            </a:pPr>
+          </a:p>
+          <a:p>
+            <a:pPr lvl="0" indent="0" marL="0">
+              <a:buNone/>
+            </a:pPr>
+            <a:r>
+              <a:rPr/>
+              <a:t>Say the conclusion plainly, and it is the practical takeaway of the whole lesson: choosing the right family matters far more than tuning the wrong one. Nobody in the top three rows could have tuned their way out. And the way to tell which family you need is to look at the data first, which is what lesson 2 was for.</a:t>
             </a:r>
           </a:p>
         </p:txBody>
@@ -6611,49 +6598,35 @@
             </a:pPr>
             <a:r>
               <a:rPr/>
-              <a:t>Close on the number they opened the second segment with, and say it one more time: seventy per cent. In a hundred dimensions the nearest point in the entire dataset is seven tenths of the way to the farthest, and every method built on distance is operating on a quantity that has stopped varying.</a:t>
-            </a:r>
-          </a:p>
-          <a:p>
-            <a:pPr lvl="0" indent="0" marL="0">
-              <a:buNone/>
-            </a:pPr>
-          </a:p>
-          <a:p>
-            <a:pPr lvl="0" indent="0" marL="0">
-              <a:buNone/>
-            </a:pPr>
-            <a:r>
-              <a:rPr/>
-              <a:t>If they remember one habit from today, make it the diagnostic pair: before reaching for a model, look at the shape of the data; after fitting one, check whether the assumption it depends on is actually satisfied on your data. Two lines of code gave us the −0.006 that explained the 0.933.</a:t>
-            </a:r>
-          </a:p>
-          <a:p>
-            <a:pPr lvl="0" indent="0" marL="0">
-              <a:buNone/>
-            </a:pPr>
-          </a:p>
-          <a:p>
-            <a:pPr lvl="0" indent="0" marL="0">
-              <a:buNone/>
-            </a:pPr>
-            <a:r>
-              <a:rPr/>
-              <a:t>And the correction to the instinct that this lesson exists to install: more features is not free. It is nearly free for a linear model and it is expensive for anything built on a distance.</a:t>
-            </a:r>
-          </a:p>
-          <a:p>
-            <a:pPr lvl="0" indent="0" marL="0">
-              <a:buNone/>
-            </a:pPr>
-          </a:p>
-          <a:p>
-            <a:pPr lvl="0" indent="0" marL="0">
-              <a:buNone/>
-            </a:pPr>
-            <a:r>
-              <a:rPr/>
-              <a:t>Handout section 7 lists all of this with the section numbers.</a:t>
+              <a:t>A table to photograph. Work down it and attach today’s evidence to each row, so it is remembered as a set of conclusions rather than as advice.</a:t>
+            </a:r>
+          </a:p>
+          <a:p>
+            <a:pPr lvl="0" indent="0" marL="0">
+              <a:buNone/>
+            </a:pPr>
+          </a:p>
+          <a:p>
+            <a:pPr lvl="0" indent="0" marL="0">
+              <a:buNone/>
+            </a:pPr>
+            <a:r>
+              <a:rPr/>
+              <a:t>Row two deserves a sentence on its own, because it is the one that sounds wrong after the last hour. Text classification is the canonical case: tens of thousands of word-count features, an assumption that is transparently false, and a method that works anyway - because being roughly right in ten thousand dimensions beats being unable to estimate anything at all. Also mention Naive Bayes as a baseline: it trains in one pass, so if your tuned model does not beat it you have learned something quickly and cheaply.</a:t>
+            </a:r>
+          </a:p>
+          <a:p>
+            <a:pPr lvl="0" indent="0" marL="0">
+              <a:buNone/>
+            </a:pPr>
+          </a:p>
+          <a:p>
+            <a:pPr lvl="0" indent="0" marL="0">
+              <a:buNone/>
+            </a:pPr>
+            <a:r>
+              <a:rPr/>
+              <a:t>One row that did not fit and should be said out loud: when you need to explain the decision to the person affected, none of today’s three will do it. A support vector machine in a lifted space has no explanation a customer would accept. Lesson 3’s Resources document covers why that is sometimes a legal requirement rather than a preference.</a:t>
             </a:r>
           </a:p>
         </p:txBody>
@@ -6735,49 +6708,49 @@
             </a:pPr>
             <a:r>
               <a:rPr/>
-              <a:t>Set it explicitly and say out loud when it comes back: the first ten minutes of next Friday, 13 November.</a:t>
-            </a:r>
-          </a:p>
-          <a:p>
-            <a:pPr lvl="0" indent="0" marL="0">
-              <a:buNone/>
-            </a:pPr>
-          </a:p>
-          <a:p>
-            <a:pPr lvl="0" indent="0" marL="0">
-              <a:buNone/>
-            </a:pPr>
-            <a:r>
-              <a:rPr/>
-              <a:t>The marks are for the reasoning, not for the accuracy. A well-argued choice that scores slightly worse beats a lucky winner with no justification - and the argument has to reference the data, in the way that the −0.006 justified Naive Bayes on the pumps this afternoon.</a:t>
-            </a:r>
-          </a:p>
-          <a:p>
-            <a:pPr lvl="0" indent="0" marL="0">
-              <a:buNone/>
-            </a:pPr>
-          </a:p>
-          <a:p>
-            <a:pPr lvl="0" indent="0" marL="0">
-              <a:buNone/>
-            </a:pPr>
-            <a:r>
-              <a:rPr/>
-              <a:t>Remind them that everything must be cross-validated and reported with a spread, in the format lesson 5 set. Scaling goes inside the pipeline; that will be checked.</a:t>
-            </a:r>
-          </a:p>
-          <a:p>
-            <a:pPr lvl="0" indent="0" marL="0">
-              <a:buNone/>
-            </a:pPr>
-          </a:p>
-          <a:p>
-            <a:pPr lvl="0" indent="0" marL="0">
-              <a:buNone/>
-            </a:pPr>
-            <a:r>
-              <a:rPr/>
-              <a:t>Next week: decision trees and ensembles. A fourth family, with a different answer again to the same question - how do you draw a boundary that is not a line.</a:t>
+              <a:t>Close on the number they opened the second segment with, and say it one more time: seventy per cent. In a hundred dimensions the nearest point in the entire dataset is seven tenths of the way to the farthest, and every method built on distance is operating on a quantity that has stopped varying.</a:t>
+            </a:r>
+          </a:p>
+          <a:p>
+            <a:pPr lvl="0" indent="0" marL="0">
+              <a:buNone/>
+            </a:pPr>
+          </a:p>
+          <a:p>
+            <a:pPr lvl="0" indent="0" marL="0">
+              <a:buNone/>
+            </a:pPr>
+            <a:r>
+              <a:rPr/>
+              <a:t>If they remember one habit from today, make it the diagnostic pair: before reaching for a model, look at the shape of the data; after fitting one, check whether the assumption it depends on is actually satisfied on your data - and check it properly. The −0.006 said yes; the squared distances said no; and the ellipse the model drew explained the 0.933.</a:t>
+            </a:r>
+          </a:p>
+          <a:p>
+            <a:pPr lvl="0" indent="0" marL="0">
+              <a:buNone/>
+            </a:pPr>
+          </a:p>
+          <a:p>
+            <a:pPr lvl="0" indent="0" marL="0">
+              <a:buNone/>
+            </a:pPr>
+            <a:r>
+              <a:rPr/>
+              <a:t>And the correction to the instinct that this lesson exists to install: more features is not free. It is nearly free for a linear model and it is expensive for anything built on a distance.</a:t>
+            </a:r>
+          </a:p>
+          <a:p>
+            <a:pPr lvl="0" indent="0" marL="0">
+              <a:buNone/>
+            </a:pPr>
+          </a:p>
+          <a:p>
+            <a:pPr lvl="0" indent="0" marL="0">
+              <a:buNone/>
+            </a:pPr>
+            <a:r>
+              <a:rPr/>
+              <a:t>Handout section 7 lists all of this with the section numbers.</a:t>
             </a:r>
           </a:p>
         </p:txBody>
@@ -6800,6 +6773,130 @@
             <a:fld id="{18BDFEC3-8487-43E8-A154-7C12CBC1FFF2}" type="slidenum">
               <a:rPr lang="en-US"/>
               <a:t>56</a:t>
+            </a:fld>
+            <a:endParaRPr lang="en-US"/>
+          </a:p>
+        </p:txBody>
+      </p:sp>
+    </p:spTree>
+  </p:cSld>
+</p:notes>
+</file>
+
+<file path=ppt/notesSlides/notesSlide56.xml><?xml version="1.0" encoding="utf-8"?>
+<p:notes xmlns:a="http://schemas.openxmlformats.org/drawingml/2006/main" xmlns:r="http://schemas.openxmlformats.org/officeDocument/2006/relationships" xmlns:p="http://schemas.openxmlformats.org/presentationml/2006/main">
+  <p:cSld>
+    <p:spTree>
+      <p:nvGrpSpPr>
+        <p:cNvPr id="1" name=""/>
+        <p:cNvGrpSpPr/>
+        <p:nvPr/>
+      </p:nvGrpSpPr>
+      <p:grpSpPr>
+        <a:xfrm>
+          <a:off x="0" y="0"/>
+          <a:ext cx="0" cy="0"/>
+          <a:chOff x="0" y="0"/>
+          <a:chExt cx="0" cy="0"/>
+        </a:xfrm>
+      </p:grpSpPr>
+      <p:sp>
+        <p:nvSpPr>
+          <p:cNvPr id="2" name="Slide Image Placeholder 1"/>
+          <p:cNvSpPr>
+            <a:spLocks noGrp="1" noRot="1" noChangeAspect="1"/>
+          </p:cNvSpPr>
+          <p:nvPr>
+            <p:ph type="sldImg"/>
+          </p:nvPr>
+        </p:nvSpPr>
+        <p:spPr/>
+      </p:sp>
+      <p:sp>
+        <p:nvSpPr>
+          <p:cNvPr id="3" name="Notes Placeholder 2"/>
+          <p:cNvSpPr>
+            <a:spLocks noGrp="1"/>
+          </p:cNvSpPr>
+          <p:nvPr>
+            <p:ph type="body" idx="1"/>
+          </p:nvPr>
+        </p:nvSpPr>
+        <p:spPr/>
+        <p:txBody>
+          <a:bodyPr/>
+          <a:lstStyle/>
+          <a:p>
+            <a:pPr lvl="0" indent="0" marL="0">
+              <a:buNone/>
+            </a:pPr>
+            <a:r>
+              <a:rPr/>
+              <a:t>Set it explicitly and say out loud when it comes back: the first ten minutes of next Friday, 13 November.</a:t>
+            </a:r>
+          </a:p>
+          <a:p>
+            <a:pPr lvl="0" indent="0" marL="0">
+              <a:buNone/>
+            </a:pPr>
+          </a:p>
+          <a:p>
+            <a:pPr lvl="0" indent="0" marL="0">
+              <a:buNone/>
+            </a:pPr>
+            <a:r>
+              <a:rPr/>
+              <a:t>The marks are for the reasoning, not for the accuracy. A well-argued choice that scores slightly worse beats a lucky winner with no justification - and the argument has to reference the data, in the way that the squared distances and the fitted ellipse explained Naive Bayes on the pumps this afternoon.</a:t>
+            </a:r>
+          </a:p>
+          <a:p>
+            <a:pPr lvl="0" indent="0" marL="0">
+              <a:buNone/>
+            </a:pPr>
+          </a:p>
+          <a:p>
+            <a:pPr lvl="0" indent="0" marL="0">
+              <a:buNone/>
+            </a:pPr>
+            <a:r>
+              <a:rPr/>
+              <a:t>Remind them that everything must be cross-validated and reported with a spread, in the format lesson 5 set. Scaling goes inside the pipeline; that will be checked.</a:t>
+            </a:r>
+          </a:p>
+          <a:p>
+            <a:pPr lvl="0" indent="0" marL="0">
+              <a:buNone/>
+            </a:pPr>
+          </a:p>
+          <a:p>
+            <a:pPr lvl="0" indent="0" marL="0">
+              <a:buNone/>
+            </a:pPr>
+            <a:r>
+              <a:rPr/>
+              <a:t>Next week: decision trees and ensembles. A fourth family, with a different answer again to the same question - how do you draw a boundary that is not a line.</a:t>
+            </a:r>
+          </a:p>
+        </p:txBody>
+      </p:sp>
+      <p:sp>
+        <p:nvSpPr>
+          <p:cNvPr id="4" name="Slide Number Placeholder 3"/>
+          <p:cNvSpPr>
+            <a:spLocks noGrp="1"/>
+          </p:cNvSpPr>
+          <p:nvPr>
+            <p:ph type="sldNum" sz="quarter" idx="10"/>
+          </p:nvPr>
+        </p:nvSpPr>
+        <p:spPr/>
+        <p:txBody>
+          <a:bodyPr/>
+          <a:lstStyle/>
+          <a:p>
+            <a:fld id="{18BDFEC3-8487-43E8-A154-7C12CBC1FFF2}" type="slidenum">
+              <a:rPr lang="en-US"/>
+              <a:t>57</a:t>
             </a:fld>
             <a:endParaRPr lang="en-US"/>
           </a:p>
@@ -13679,6 +13776,325 @@
             </a:pPr>
             <a:r>
               <a:rPr/>
+              <a:t>48 Hz, 5.6 bar: faulty, 0.981</a:t>
+            </a:r>
+          </a:p>
+        </p:txBody>
+      </p:sp>
+      <p:graphicFrame>
+        <p:nvGraphicFramePr>
+          <p:cNvPr id="6" name="Content Placeholder 5"/>
+          <p:cNvGraphicFramePr>
+            <a:graphicFrameLocks noGrp="1"/>
+          </p:cNvGraphicFramePr>
+          <p:nvPr>
+            <p:ph idx="1"/>
+          </p:nvPr>
+        </p:nvGraphicFramePr>
+        <p:xfrm>
+          <a:off x="457200" y="1166099"/>
+          <a:ext cx="8229600" cy="3390900"/>
+        </p:xfrm>
+        <a:graphic>
+          <a:graphicData uri="http://schemas.openxmlformats.org/drawingml/2006/table">
+            <a:tbl>
+              <a:tblPr firstRow="1" bandRow="1">
+                <a:tableStyleId>{5C22544A-7EE6-4342-B048-85BDC9FD1C3A}</a:tableStyleId>
+              </a:tblPr>
+              <a:tblGrid>
+                <a:gridCol w="1645920"/>
+                <a:gridCol w="1645920"/>
+                <a:gridCol w="1645920"/>
+                <a:gridCol w="1645920"/>
+                <a:gridCol w="1645920"/>
+              </a:tblGrid>
+              <a:tr h="0">
+                <a:tc>
+                  <a:txBody>
+                    <a:bodyPr/>
+                    <a:lstStyle/>
+                    <a:p>
+                      <a:pPr lvl="0" indent="0" marL="0">
+                        <a:buNone/>
+                      </a:pPr>
+                      <a:r>
+                        <a:rPr/>
+                        <a:t>Class</a:t>
+                      </a:r>
+                    </a:p>
+                  </a:txBody>
+                  <a:tcPr/>
+                </a:tc>
+                <a:tc>
+                  <a:txBody>
+                    <a:bodyPr/>
+                    <a:lstStyle/>
+                    <a:p>
+                      <a:pPr lvl="0" indent="0" marL="0">
+                        <a:buNone/>
+                      </a:pPr>
+                      <a:r>
+                        <a:rPr/>
+                        <a:t>log prior</a:t>
+                      </a:r>
+                    </a:p>
+                  </a:txBody>
+                  <a:tcPr/>
+                </a:tc>
+                <a:tc>
+                  <a:txBody>
+                    <a:bodyPr/>
+                    <a:lstStyle/>
+                    <a:p>
+                      <a:pPr lvl="0" indent="0" marL="0">
+                        <a:buNone/>
+                      </a:pPr>
+                      <a:r>
+                        <a:rPr/>
+                        <a:t>log P(vibration)</a:t>
+                      </a:r>
+                    </a:p>
+                  </a:txBody>
+                  <a:tcPr/>
+                </a:tc>
+                <a:tc>
+                  <a:txBody>
+                    <a:bodyPr/>
+                    <a:lstStyle/>
+                    <a:p>
+                      <a:pPr lvl="0" indent="0" marL="0">
+                        <a:buNone/>
+                      </a:pPr>
+                      <a:r>
+                        <a:rPr/>
+                        <a:t>log P(pressure)</a:t>
+                      </a:r>
+                    </a:p>
+                  </a:txBody>
+                  <a:tcPr/>
+                </a:tc>
+                <a:tc>
+                  <a:txBody>
+                    <a:bodyPr/>
+                    <a:lstStyle/>
+                    <a:p>
+                      <a:pPr lvl="0" indent="0" marL="0">
+                        <a:buNone/>
+                      </a:pPr>
+                      <a:r>
+                        <a:rPr/>
+                        <a:t>Total</a:t>
+                      </a:r>
+                    </a:p>
+                  </a:txBody>
+                  <a:tcPr/>
+                </a:tc>
+              </a:tr>
+              <a:tr h="0">
+                <a:tc>
+                  <a:txBody>
+                    <a:bodyPr/>
+                    <a:lstStyle/>
+                    <a:p>
+                      <a:pPr lvl="0" indent="0" marL="0">
+                        <a:buNone/>
+                      </a:pPr>
+                      <a:r>
+                        <a:rPr/>
+                        <a:t>Healthy</a:t>
+                      </a:r>
+                    </a:p>
+                  </a:txBody>
+                </a:tc>
+                <a:tc>
+                  <a:txBody>
+                    <a:bodyPr/>
+                    <a:lstStyle/>
+                    <a:p>
+                      <a:pPr lvl="0" indent="0" marL="0">
+                        <a:buNone/>
+                      </a:pPr>
+                      <a:r>
+                        <a:rPr/>
+                        <a:t>−0.948</a:t>
+                      </a:r>
+                    </a:p>
+                  </a:txBody>
+                </a:tc>
+                <a:tc>
+                  <a:txBody>
+                    <a:bodyPr/>
+                    <a:lstStyle/>
+                    <a:p>
+                      <a:pPr lvl="0" indent="0" marL="0">
+                        <a:buNone/>
+                      </a:pPr>
+                      <a:r>
+                        <a:rPr/>
+                        <a:t>−7.745</a:t>
+                      </a:r>
+                    </a:p>
+                  </a:txBody>
+                </a:tc>
+                <a:tc>
+                  <a:txBody>
+                    <a:bodyPr/>
+                    <a:lstStyle/>
+                    <a:p>
+                      <a:pPr lvl="0" indent="0" marL="0">
+                        <a:buNone/>
+                      </a:pPr>
+                      <a:r>
+                        <a:rPr/>
+                        <a:t>+0.598</a:t>
+                      </a:r>
+                    </a:p>
+                  </a:txBody>
+                </a:tc>
+                <a:tc>
+                  <a:txBody>
+                    <a:bodyPr/>
+                    <a:lstStyle/>
+                    <a:p>
+                      <a:pPr lvl="0" indent="0" marL="0">
+                        <a:buNone/>
+                      </a:pPr>
+                      <a:r>
+                        <a:rPr/>
+                        <a:t>−8.095</a:t>
+                      </a:r>
+                    </a:p>
+                  </a:txBody>
+                </a:tc>
+              </a:tr>
+              <a:tr h="0">
+                <a:tc>
+                  <a:txBody>
+                    <a:bodyPr/>
+                    <a:lstStyle/>
+                    <a:p>
+                      <a:pPr lvl="0" indent="0" marL="0">
+                        <a:buNone/>
+                      </a:pPr>
+                      <a:r>
+                        <a:rPr/>
+                        <a:t>Faulty</a:t>
+                      </a:r>
+                    </a:p>
+                  </a:txBody>
+                </a:tc>
+                <a:tc>
+                  <a:txBody>
+                    <a:bodyPr/>
+                    <a:lstStyle/>
+                    <a:p>
+                      <a:pPr lvl="0" indent="0" marL="0">
+                        <a:buNone/>
+                      </a:pPr>
+                      <a:r>
+                        <a:rPr/>
+                        <a:t>−0.490</a:t>
+                      </a:r>
+                    </a:p>
+                  </a:txBody>
+                </a:tc>
+                <a:tc>
+                  <a:txBody>
+                    <a:bodyPr/>
+                    <a:lstStyle/>
+                    <a:p>
+                      <a:pPr lvl="0" indent="0" marL="0">
+                        <a:buNone/>
+                      </a:pPr>
+                      <a:r>
+                        <a:rPr/>
+                        <a:t>−3.286</a:t>
+                      </a:r>
+                    </a:p>
+                  </a:txBody>
+                </a:tc>
+                <a:tc>
+                  <a:txBody>
+                    <a:bodyPr/>
+                    <a:lstStyle/>
+                    <a:p>
+                      <a:pPr lvl="0" indent="0" marL="0">
+                        <a:buNone/>
+                      </a:pPr>
+                      <a:r>
+                        <a:rPr/>
+                        <a:t>−0.368</a:t>
+                      </a:r>
+                    </a:p>
+                  </a:txBody>
+                </a:tc>
+                <a:tc>
+                  <a:txBody>
+                    <a:bodyPr/>
+                    <a:lstStyle/>
+                    <a:p>
+                      <a:pPr lvl="0" indent="0" marL="0">
+                        <a:buNone/>
+                      </a:pPr>
+                      <a:r>
+                        <a:rPr b="1"/>
+                        <a:t>−4.144</a:t>
+                      </a:r>
+                    </a:p>
+                  </a:txBody>
+                </a:tc>
+              </a:tr>
+            </a:tbl>
+          </a:graphicData>
+        </a:graphic>
+      </p:graphicFrame>
+    </p:spTree>
+  </p:cSld>
+</p:sld>
+</file>
+
+<file path=ppt/slides/slide32.xml><?xml version="1.0" encoding="utf-8"?>
+<p:sld xmlns:a="http://schemas.openxmlformats.org/drawingml/2006/main" xmlns:r="http://schemas.openxmlformats.org/officeDocument/2006/relationships" xmlns:p="http://schemas.openxmlformats.org/presentationml/2006/main">
+  <p:cSld>
+    <p:spTree>
+      <p:nvGrpSpPr>
+        <p:cNvPr id="1" name=""/>
+        <p:cNvGrpSpPr/>
+        <p:nvPr/>
+      </p:nvGrpSpPr>
+      <p:grpSpPr>
+        <a:xfrm>
+          <a:off x="0" y="0"/>
+          <a:ext cx="0" cy="0"/>
+          <a:chOff x="0" y="0"/>
+          <a:chExt cx="0" cy="0"/>
+        </a:xfrm>
+      </p:grpSpPr>
+      <p:sp>
+        <p:nvSpPr>
+          <p:cNvPr id="2" name="Title 1"/>
+          <p:cNvSpPr>
+            <a:spLocks noGrp="1"/>
+          </p:cNvSpPr>
+          <p:nvPr>
+            <p:ph type="title"/>
+          </p:nvPr>
+        </p:nvSpPr>
+        <p:spPr>
+          <a:xfrm>
+            <a:off x="457200" y="205979"/>
+            <a:ext cx="8229600" cy="857250"/>
+          </a:xfrm>
+        </p:spPr>
+        <p:txBody>
+          <a:bodyPr/>
+          <a:lstStyle/>
+          <a:p>
+            <a:pPr lvl="0" indent="0" marL="0">
+              <a:buNone/>
+            </a:pPr>
+            <a:r>
+              <a:rPr/>
               <a:t>A wonderful bargain, and almost never true</a:t>
             </a:r>
           </a:p>
@@ -13750,7 +14166,7 @@
 </p:sld>
 </file>
 
-<file path=ppt/slides/slide32.xml><?xml version="1.0" encoding="utf-8"?>
+<file path=ppt/slides/slide33.xml><?xml version="1.0" encoding="utf-8"?>
 <p:sld xmlns:a="http://schemas.openxmlformats.org/drawingml/2006/main" xmlns:r="http://schemas.openxmlformats.org/officeDocument/2006/relationships" xmlns:p="http://schemas.openxmlformats.org/presentationml/2006/main">
   <p:cSld>
     <p:spTree>
@@ -13992,7 +14408,7 @@
 </p:sld>
 </file>
 
-<file path=ppt/slides/slide33.xml><?xml version="1.0" encoding="utf-8"?>
+<file path=ppt/slides/slide34.xml><?xml version="1.0" encoding="utf-8"?>
 <p:sld xmlns:a="http://schemas.openxmlformats.org/drawingml/2006/main" xmlns:r="http://schemas.openxmlformats.org/officeDocument/2006/relationships" xmlns:p="http://schemas.openxmlformats.org/presentationml/2006/main">
   <p:cSld>
     <p:spTree>
@@ -14034,7 +14450,7 @@
             </a:pPr>
             <a:r>
               <a:rPr/>
-              <a:t>Because here the assumption is true</a:t>
+              <a:t>Uncorrelated, but not independent</a:t>
             </a:r>
           </a:p>
         </p:txBody>
@@ -14060,8 +14476,9 @@
                 <a:tableStyleId>{5C22544A-7EE6-4342-B048-85BDC9FD1C3A}</a:tableStyleId>
               </a:tblPr>
               <a:tblGrid>
-                <a:gridCol w="4114800"/>
-                <a:gridCol w="4114800"/>
+                <a:gridCol w="2743200"/>
+                <a:gridCol w="2743200"/>
+                <a:gridCol w="2743200"/>
               </a:tblGrid>
               <a:tr h="0">
                 <a:tc>
@@ -14074,7 +14491,7 @@
                       </a:pPr>
                       <a:r>
                         <a:rPr/>
-                        <a:t>Correlation between the two readings</a:t>
+                        <a:t>Within class</a:t>
                       </a:r>
                     </a:p>
                   </a:txBody>
@@ -14090,7 +14507,23 @@
                       </a:pPr>
                       <a:r>
                         <a:rPr/>
-                        <a:t>Value</a:t>
+                        <a:t>Readings</a:t>
+                      </a:r>
+                    </a:p>
+                  </a:txBody>
+                  <a:tcPr/>
+                </a:tc>
+                <a:tc>
+                  <a:txBody>
+                    <a:bodyPr/>
+                    <a:lstStyle/>
+                    <a:p>
+                      <a:pPr lvl="0" indent="0" marL="0">
+                        <a:buNone/>
+                      </a:pPr>
+                      <a:r>
+                        <a:rPr/>
+                        <a:t>Squared distances</a:t>
                       </a:r>
                     </a:p>
                   </a:txBody>
@@ -14108,7 +14541,7 @@
                       </a:pPr>
                       <a:r>
                         <a:rPr/>
-                        <a:t>overall</a:t>
+                        <a:t>healthy pumps</a:t>
                       </a:r>
                     </a:p>
                   </a:txBody>
@@ -14123,7 +14556,22 @@
                       </a:pPr>
                       <a:r>
                         <a:rPr/>
-                        <a:t>−0.046</a:t>
+                        <a:t>−0.006</a:t>
+                      </a:r>
+                    </a:p>
+                  </a:txBody>
+                </a:tc>
+                <a:tc>
+                  <a:txBody>
+                    <a:bodyPr/>
+                    <a:lstStyle/>
+                    <a:p>
+                      <a:pPr lvl="0" indent="0" marL="0">
+                        <a:buNone/>
+                      </a:pPr>
+                      <a:r>
+                        <a:rPr/>
+                        <a:t>+0.168</a:t>
                       </a:r>
                     </a:p>
                   </a:txBody>
@@ -14140,7 +14588,22 @@
                       </a:pPr>
                       <a:r>
                         <a:rPr/>
-                        <a:t>within healthy pumps</a:t>
+                        <a:t>faulty pumps</a:t>
+                      </a:r>
+                    </a:p>
+                  </a:txBody>
+                </a:tc>
+                <a:tc>
+                  <a:txBody>
+                    <a:bodyPr/>
+                    <a:lstStyle/>
+                    <a:p>
+                      <a:pPr lvl="0" indent="0" marL="0">
+                        <a:buNone/>
+                      </a:pPr>
+                      <a:r>
+                        <a:rPr/>
+                        <a:t>−0.049</a:t>
                       </a:r>
                     </a:p>
                   </a:txBody>
@@ -14155,39 +14618,7 @@
                       </a:pPr>
                       <a:r>
                         <a:rPr b="1"/>
-                        <a:t>−0.006</a:t>
-                      </a:r>
-                    </a:p>
-                  </a:txBody>
-                </a:tc>
-              </a:tr>
-              <a:tr h="0">
-                <a:tc>
-                  <a:txBody>
-                    <a:bodyPr/>
-                    <a:lstStyle/>
-                    <a:p>
-                      <a:pPr lvl="0" indent="0" marL="0">
-                        <a:buNone/>
-                      </a:pPr>
-                      <a:r>
-                        <a:rPr/>
-                        <a:t>within faulty pumps</a:t>
-                      </a:r>
-                    </a:p>
-                  </a:txBody>
-                </a:tc>
-                <a:tc>
-                  <a:txBody>
-                    <a:bodyPr/>
-                    <a:lstStyle/>
-                    <a:p>
-                      <a:pPr lvl="0" indent="0" marL="0">
-                        <a:buNone/>
-                      </a:pPr>
-                      <a:r>
-                        <a:rPr b="1"/>
-                        <a:t>−0.049</a:t>
+                        <a:t>−0.420</a:t>
                       </a:r>
                     </a:p>
                   </a:txBody>
@@ -14202,7 +14633,7 @@
 </p:sld>
 </file>
 
-<file path=ppt/slides/slide34.xml><?xml version="1.0" encoding="utf-8"?>
+<file path=ppt/slides/slide35.xml><?xml version="1.0" encoding="utf-8"?>
 <p:sld xmlns:a="http://schemas.openxmlformats.org/drawingml/2006/main" xmlns:r="http://schemas.openxmlformats.org/officeDocument/2006/relationships" xmlns:p="http://schemas.openxmlformats.org/presentationml/2006/main">
   <p:cSld>
     <p:spTree>
@@ -14304,7 +14735,7 @@
 </p:sld>
 </file>
 
-<file path=ppt/slides/slide35.xml><?xml version="1.0" encoding="utf-8"?>
+<file path=ppt/slides/slide36.xml><?xml version="1.0" encoding="utf-8"?>
 <p:sld xmlns:a="http://schemas.openxmlformats.org/drawingml/2006/main" xmlns:r="http://schemas.openxmlformats.org/officeDocument/2006/relationships" xmlns:p="http://schemas.openxmlformats.org/presentationml/2006/main">
   <p:cSld>
     <p:spTree>
@@ -14386,7 +14817,7 @@
 </p:sld>
 </file>
 
-<file path=ppt/slides/slide36.xml><?xml version="1.0" encoding="utf-8"?>
+<file path=ppt/slides/slide37.xml><?xml version="1.0" encoding="utf-8"?>
 <p:sld xmlns:a="http://schemas.openxmlformats.org/drawingml/2006/main" xmlns:r="http://schemas.openxmlformats.org/officeDocument/2006/relationships" xmlns:p="http://schemas.openxmlformats.org/presentationml/2006/main">
   <p:cSld>
     <p:spTree>
@@ -14692,119 +15123,6 @@
 </p:sld>
 </file>
 
-<file path=ppt/slides/slide37.xml><?xml version="1.0" encoding="utf-8"?>
-<p:sld xmlns:a="http://schemas.openxmlformats.org/drawingml/2006/main" xmlns:r="http://schemas.openxmlformats.org/officeDocument/2006/relationships" xmlns:p="http://schemas.openxmlformats.org/presentationml/2006/main">
-  <p:cSld>
-    <p:spTree>
-      <p:nvGrpSpPr>
-        <p:cNvPr id="1" name=""/>
-        <p:cNvGrpSpPr/>
-        <p:nvPr/>
-      </p:nvGrpSpPr>
-      <p:grpSpPr>
-        <a:xfrm>
-          <a:off x="0" y="0"/>
-          <a:ext cx="0" cy="0"/>
-          <a:chOff x="0" y="0"/>
-          <a:chExt cx="0" cy="0"/>
-        </a:xfrm>
-      </p:grpSpPr>
-      <p:sp>
-        <p:nvSpPr>
-          <p:cNvPr id="2" name="Title 1"/>
-          <p:cNvSpPr>
-            <a:spLocks noGrp="1"/>
-          </p:cNvSpPr>
-          <p:nvPr>
-            <p:ph type="title"/>
-          </p:nvPr>
-        </p:nvSpPr>
-        <p:spPr>
-          <a:xfrm>
-            <a:off x="457200" y="205979"/>
-            <a:ext cx="8229600" cy="857250"/>
-          </a:xfrm>
-        </p:spPr>
-        <p:txBody>
-          <a:bodyPr/>
-          <a:lstStyle/>
-          <a:p>
-            <a:pPr lvl="0" indent="0" marL="0">
-              <a:buNone/>
-            </a:pPr>
-            <a:r>
-              <a:rPr/>
-              <a:t>Its probabilities are not probabilities</a:t>
-            </a:r>
-          </a:p>
-        </p:txBody>
-      </p:sp>
-      <p:sp>
-        <p:nvSpPr>
-          <p:cNvPr id="3" name="Content Placeholder 2"/>
-          <p:cNvSpPr>
-            <a:spLocks noGrp="1"/>
-          </p:cNvSpPr>
-          <p:nvPr>
-            <p:ph idx="1"/>
-          </p:nvPr>
-        </p:nvSpPr>
-        <p:spPr>
-          <a:xfrm>
-            <a:off x="457200" y="1200151"/>
-            <a:ext cx="8229600" cy="3394472"/>
-          </a:xfrm>
-        </p:spPr>
-        <p:txBody>
-          <a:bodyPr/>
-          <a:lstStyle/>
-          <a:p>
-            <a:pPr lvl="0"/>
-            <a:r>
-              <a:rPr/>
-              <a:t>Mean confidence when </a:t>
-            </a:r>
-            <a:r>
-              <a:rPr b="1"/>
-              <a:t>correct: 0.567</a:t>
-            </a:r>
-            <a:r>
-              <a:rPr/>
-              <a:t>. When </a:t>
-            </a:r>
-            <a:r>
-              <a:rPr b="1"/>
-              <a:t>wrong: 0.555</a:t>
-            </a:r>
-          </a:p>
-          <a:p>
-            <a:pPr lvl="0"/>
-            <a:r>
-              <a:rPr/>
-              <a:t>It cannot tell the difference between the two situations</a:t>
-            </a:r>
-          </a:p>
-          <a:p>
-            <a:pPr lvl="0"/>
-            <a:r>
-              <a:rPr/>
-              <a:t>With correlated features it fails the other way: 0.999 reported, with an accuracy nothing like that</a:t>
-            </a:r>
-          </a:p>
-          <a:p>
-            <a:pPr lvl="0"/>
-            <a:r>
-              <a:rPr b="1"/>
-              <a:t>The ranking may be useful while the probabilities are not</a:t>
-            </a:r>
-          </a:p>
-        </p:txBody>
-      </p:sp>
-    </p:spTree>
-  </p:cSld>
-</p:sld>
-</file>
-
 <file path=ppt/slides/slide38.xml><?xml version="1.0" encoding="utf-8"?>
 <p:sld xmlns:a="http://schemas.openxmlformats.org/drawingml/2006/main" xmlns:r="http://schemas.openxmlformats.org/officeDocument/2006/relationships" xmlns:p="http://schemas.openxmlformats.org/presentationml/2006/main">
   <p:cSld>
@@ -14847,7 +15165,7 @@
             </a:pPr>
             <a:r>
               <a:rPr/>
-              <a:t>Notebook 2, live</a:t>
+              <a:t>Its probabilities are not probabilities</a:t>
             </a:r>
           </a:p>
         </p:txBody>
@@ -14875,7 +15193,40 @@
             <a:pPr lvl="0"/>
             <a:r>
               <a:rPr/>
-              <a:t>Where the assumption holds, and one step away where it does not</a:t>
+              <a:t>Mean confidence when </a:t>
+            </a:r>
+            <a:r>
+              <a:rPr b="1"/>
+              <a:t>correct: 0.567</a:t>
+            </a:r>
+            <a:r>
+              <a:rPr/>
+              <a:t>. When </a:t>
+            </a:r>
+            <a:r>
+              <a:rPr b="1"/>
+              <a:t>wrong: 0.555</a:t>
+            </a:r>
+          </a:p>
+          <a:p>
+            <a:pPr lvl="0"/>
+            <a:r>
+              <a:rPr/>
+              <a:t>It cannot tell the difference between the two situations</a:t>
+            </a:r>
+          </a:p>
+          <a:p>
+            <a:pPr lvl="0"/>
+            <a:r>
+              <a:rPr/>
+              <a:t>With correlated features it fails the other way: 0.999 reported, with an accuracy nothing like that</a:t>
+            </a:r>
+          </a:p>
+          <a:p>
+            <a:pPr lvl="0"/>
+            <a:r>
+              <a:rPr b="1"/>
+              <a:t>The ranking may be useful while the probabilities are not</a:t>
             </a:r>
           </a:p>
         </p:txBody>
@@ -14927,7 +15278,7 @@
             </a:pPr>
             <a:r>
               <a:rPr/>
-              <a:t>The margin: a criterion that is not the error</a:t>
+              <a:t>Notebook 2, live</a:t>
             </a:r>
           </a:p>
         </p:txBody>
@@ -14955,48 +15306,7 @@
             <a:pPr lvl="0"/>
             <a:r>
               <a:rPr/>
-              <a:t>On separable data there are </a:t>
-            </a:r>
-            <a:r>
-              <a:rPr b="1"/>
-              <a:t>infinitely many</a:t>
-            </a:r>
-            <a:r>
-              <a:rPr/>
-              <a:t> separating lines, and every one has </a:t>
-            </a:r>
-            <a:r>
-              <a:rPr b="1"/>
-              <a:t>zero training error</a:t>
-            </a:r>
-          </a:p>
-          <a:p>
-            <a:pPr lvl="0"/>
-            <a:r>
-              <a:rPr/>
-              <a:t>Minimising the error therefore cannot choose between them</a:t>
-            </a:r>
-          </a:p>
-          <a:p>
-            <a:pPr lvl="0"/>
-            <a:r>
-              <a:rPr/>
-              <a:t>The SVM picks the widest </a:t>
-            </a:r>
-            <a:r>
-              <a:rPr b="1"/>
-              <a:t>slab</a:t>
-            </a:r>
-            <a:r>
-              <a:rPr/>
-              <a:t>: push it out until it touches the nearest point of each class</a:t>
-            </a:r>
-          </a:p>
-          <a:p>
-            <a:pPr lvl="0"/>
-            <a:r>
-              <a:rPr/>
-              <a:t>A boundary passing close to a point is one small perturbation from getting it wrong</a:t>
+              <a:t>Where breaking the assumption is cheap, and one step away where it is fatal</a:t>
             </a:r>
           </a:p>
         </p:txBody>
@@ -15113,6 +15423,127 @@
 </file>
 
 <file path=ppt/slides/slide40.xml><?xml version="1.0" encoding="utf-8"?>
+<p:sld xmlns:a="http://schemas.openxmlformats.org/drawingml/2006/main" xmlns:r="http://schemas.openxmlformats.org/officeDocument/2006/relationships" xmlns:p="http://schemas.openxmlformats.org/presentationml/2006/main">
+  <p:cSld>
+    <p:spTree>
+      <p:nvGrpSpPr>
+        <p:cNvPr id="1" name=""/>
+        <p:cNvGrpSpPr/>
+        <p:nvPr/>
+      </p:nvGrpSpPr>
+      <p:grpSpPr>
+        <a:xfrm>
+          <a:off x="0" y="0"/>
+          <a:ext cx="0" cy="0"/>
+          <a:chOff x="0" y="0"/>
+          <a:chExt cx="0" cy="0"/>
+        </a:xfrm>
+      </p:grpSpPr>
+      <p:sp>
+        <p:nvSpPr>
+          <p:cNvPr id="2" name="Title 1"/>
+          <p:cNvSpPr>
+            <a:spLocks noGrp="1"/>
+          </p:cNvSpPr>
+          <p:nvPr>
+            <p:ph type="title"/>
+          </p:nvPr>
+        </p:nvSpPr>
+        <p:spPr>
+          <a:xfrm>
+            <a:off x="457200" y="205979"/>
+            <a:ext cx="8229600" cy="857250"/>
+          </a:xfrm>
+        </p:spPr>
+        <p:txBody>
+          <a:bodyPr/>
+          <a:lstStyle/>
+          <a:p>
+            <a:pPr lvl="0" indent="0" marL="0">
+              <a:buNone/>
+            </a:pPr>
+            <a:r>
+              <a:rPr/>
+              <a:t>The margin: a criterion that is not the error</a:t>
+            </a:r>
+          </a:p>
+        </p:txBody>
+      </p:sp>
+      <p:sp>
+        <p:nvSpPr>
+          <p:cNvPr id="3" name="Content Placeholder 2"/>
+          <p:cNvSpPr>
+            <a:spLocks noGrp="1"/>
+          </p:cNvSpPr>
+          <p:nvPr>
+            <p:ph idx="1"/>
+          </p:nvPr>
+        </p:nvSpPr>
+        <p:spPr>
+          <a:xfrm>
+            <a:off x="457200" y="1200151"/>
+            <a:ext cx="8229600" cy="3394472"/>
+          </a:xfrm>
+        </p:spPr>
+        <p:txBody>
+          <a:bodyPr/>
+          <a:lstStyle/>
+          <a:p>
+            <a:pPr lvl="0"/>
+            <a:r>
+              <a:rPr/>
+              <a:t>On separable data there are </a:t>
+            </a:r>
+            <a:r>
+              <a:rPr b="1"/>
+              <a:t>infinitely many</a:t>
+            </a:r>
+            <a:r>
+              <a:rPr/>
+              <a:t> separating lines, and every one has </a:t>
+            </a:r>
+            <a:r>
+              <a:rPr b="1"/>
+              <a:t>zero training error</a:t>
+            </a:r>
+          </a:p>
+          <a:p>
+            <a:pPr lvl="0"/>
+            <a:r>
+              <a:rPr/>
+              <a:t>Minimising the error therefore cannot choose between them</a:t>
+            </a:r>
+          </a:p>
+          <a:p>
+            <a:pPr lvl="0"/>
+            <a:r>
+              <a:rPr/>
+              <a:t>The SVM picks the widest </a:t>
+            </a:r>
+            <a:r>
+              <a:rPr b="1"/>
+              <a:t>slab</a:t>
+            </a:r>
+            <a:r>
+              <a:rPr/>
+              <a:t>: push it out until it touches the nearest point of each class</a:t>
+            </a:r>
+          </a:p>
+          <a:p>
+            <a:pPr lvl="0"/>
+            <a:r>
+              <a:rPr/>
+              <a:t>A boundary passing close to a point is one small perturbation from getting it wrong</a:t>
+            </a:r>
+          </a:p>
+        </p:txBody>
+      </p:sp>
+    </p:spTree>
+  </p:cSld>
+</p:sld>
+</file>
+
+<file path=ppt/slides/slide41.xml><?xml version="1.0" encoding="utf-8"?>
 <p:sld xmlns:a="http://schemas.openxmlformats.org/drawingml/2006/main" xmlns:r="http://schemas.openxmlformats.org/officeDocument/2006/relationships" xmlns:p="http://schemas.openxmlformats.org/presentationml/2006/main">
   <p:cSld>
     <p:spTree>
@@ -15194,7 +15625,7 @@
 </p:sld>
 </file>
 
-<file path=ppt/slides/slide41.xml><?xml version="1.0" encoding="utf-8"?>
+<file path=ppt/slides/slide42.xml><?xml version="1.0" encoding="utf-8"?>
 <p:sld xmlns:a="http://schemas.openxmlformats.org/drawingml/2006/main" xmlns:r="http://schemas.openxmlformats.org/officeDocument/2006/relationships" xmlns:p="http://schemas.openxmlformats.org/presentationml/2006/main">
   <p:cSld>
     <p:spTree>
@@ -15292,7 +15723,7 @@
 </p:sld>
 </file>
 
-<file path=ppt/slides/slide42.xml><?xml version="1.0" encoding="utf-8"?>
+<file path=ppt/slides/slide43.xml><?xml version="1.0" encoding="utf-8"?>
 <p:sld xmlns:a="http://schemas.openxmlformats.org/drawingml/2006/main" xmlns:r="http://schemas.openxmlformats.org/officeDocument/2006/relationships" xmlns:p="http://schemas.openxmlformats.org/presentationml/2006/main">
   <p:cSld>
     <p:spTree>
@@ -15374,7 +15805,7 @@
 </p:sld>
 </file>
 
-<file path=ppt/slides/slide43.xml><?xml version="1.0" encoding="utf-8"?>
+<file path=ppt/slides/slide44.xml><?xml version="1.0" encoding="utf-8"?>
 <p:sld xmlns:a="http://schemas.openxmlformats.org/drawingml/2006/main" xmlns:r="http://schemas.openxmlformats.org/officeDocument/2006/relationships" xmlns:p="http://schemas.openxmlformats.org/presentationml/2006/main">
   <p:cSld>
     <p:spTree>
@@ -15487,7 +15918,7 @@
 </p:sld>
 </file>
 
-<file path=ppt/slides/slide44.xml><?xml version="1.0" encoding="utf-8"?>
+<file path=ppt/slides/slide45.xml><?xml version="1.0" encoding="utf-8"?>
 <p:sld xmlns:a="http://schemas.openxmlformats.org/drawingml/2006/main" xmlns:r="http://schemas.openxmlformats.org/officeDocument/2006/relationships" xmlns:p="http://schemas.openxmlformats.org/presentationml/2006/main">
   <p:cSld>
     <p:spTree>
@@ -15720,129 +16151,6 @@
 </p:sld>
 </file>
 
-<file path=ppt/slides/slide45.xml><?xml version="1.0" encoding="utf-8"?>
-<p:sld xmlns:a="http://schemas.openxmlformats.org/drawingml/2006/main" xmlns:r="http://schemas.openxmlformats.org/officeDocument/2006/relationships" xmlns:p="http://schemas.openxmlformats.org/presentationml/2006/main">
-  <p:cSld>
-    <p:spTree>
-      <p:nvGrpSpPr>
-        <p:cNvPr id="1" name=""/>
-        <p:cNvGrpSpPr/>
-        <p:nvPr/>
-      </p:nvGrpSpPr>
-      <p:grpSpPr>
-        <a:xfrm>
-          <a:off x="0" y="0"/>
-          <a:ext cx="0" cy="0"/>
-          <a:chOff x="0" y="0"/>
-          <a:chExt cx="0" cy="0"/>
-        </a:xfrm>
-      </p:grpSpPr>
-      <p:sp>
-        <p:nvSpPr>
-          <p:cNvPr id="2" name="Title 1"/>
-          <p:cNvSpPr>
-            <a:spLocks noGrp="1"/>
-          </p:cNvSpPr>
-          <p:nvPr>
-            <p:ph type="title"/>
-          </p:nvPr>
-        </p:nvSpPr>
-        <p:spPr>
-          <a:xfrm>
-            <a:off x="457200" y="205979"/>
-            <a:ext cx="8229600" cy="857250"/>
-          </a:xfrm>
-        </p:spPr>
-        <p:txBody>
-          <a:bodyPr/>
-          <a:lstStyle/>
-          <a:p>
-            <a:pPr lvl="0" indent="0" marL="0">
-              <a:buNone/>
-            </a:pPr>
-            <a:r>
-              <a:rPr/>
-              <a:t>A high support-vector fraction is a free warning</a:t>
-            </a:r>
-          </a:p>
-        </p:txBody>
-      </p:sp>
-      <p:sp>
-        <p:nvSpPr>
-          <p:cNvPr id="3" name="Content Placeholder 2"/>
-          <p:cNvSpPr>
-            <a:spLocks noGrp="1"/>
-          </p:cNvSpPr>
-          <p:nvPr>
-            <p:ph idx="1"/>
-          </p:nvPr>
-        </p:nvSpPr>
-        <p:spPr>
-          <a:xfrm>
-            <a:off x="457200" y="1200151"/>
-            <a:ext cx="8229600" cy="3394472"/>
-          </a:xfrm>
-        </p:spPr>
-        <p:txBody>
-          <a:bodyPr/>
-          <a:lstStyle/>
-          <a:p>
-            <a:pPr lvl="0"/>
-            <a:r>
-              <a:rPr/>
-              <a:t>The linear model needs </a:t>
-            </a:r>
-            <a:r>
-              <a:rPr b="1"/>
-              <a:t>79%</a:t>
-            </a:r>
-            <a:r>
-              <a:rPr/>
-              <a:t> of the training set to define its boundary</a:t>
-            </a:r>
-          </a:p>
-          <a:p>
-            <a:pPr lvl="0"/>
-            <a:r>
-              <a:rPr/>
-              <a:t>The RBF model needs </a:t>
-            </a:r>
-            <a:r>
-              <a:rPr b="1"/>
-              <a:t>23%</a:t>
-            </a:r>
-          </a:p>
-          <a:p>
-            <a:pPr lvl="0"/>
-            <a:r>
-              <a:rPr/>
-              <a:t>Almost every point sits on or inside the margin: there is no slab that separates anything</a:t>
-            </a:r>
-          </a:p>
-          <a:p>
-            <a:pPr lvl="0"/>
-            <a:r>
-              <a:rPr/>
-              <a:t>The count falls out of </a:t>
-            </a:r>
-            <a:r>
-              <a:rPr>
-                <a:latin typeface="Courier"/>
-              </a:rPr>
-              <a:t>fit</a:t>
-            </a:r>
-            <a:r>
-              <a:rPr/>
-              <a:t> at no cost, and you should look at it</a:t>
-            </a:r>
-          </a:p>
-        </p:txBody>
-      </p:sp>
-    </p:spTree>
-  </p:cSld>
-</p:sld>
-</file>
-
 <file path=ppt/slides/slide46.xml><?xml version="1.0" encoding="utf-8"?>
 <p:sld xmlns:a="http://schemas.openxmlformats.org/drawingml/2006/main" xmlns:r="http://schemas.openxmlformats.org/officeDocument/2006/relationships" xmlns:p="http://schemas.openxmlformats.org/presentationml/2006/main">
   <p:cSld>
@@ -15885,7 +16193,7 @@
             </a:pPr>
             <a:r>
               <a:rPr/>
-              <a:t>The kernel trick: they needed different coordinates</a:t>
+              <a:t>A high support-vector fraction is a free warning</a:t>
             </a:r>
           </a:p>
         </p:txBody>
@@ -15913,36 +16221,50 @@
             <a:pPr lvl="0"/>
             <a:r>
               <a:rPr/>
-              <a:t>Healthy pumps in a disc, faulty ones around it: no line works </a:t>
+              <a:t>The linear model needs </a:t>
             </a:r>
             <a:r>
               <a:rPr b="1"/>
-              <a:t>in the plane</a:t>
+              <a:t>79%</a:t>
+            </a:r>
+            <a:r>
+              <a:rPr/>
+              <a:t> of the training set to define its boundary</a:t>
             </a:r>
           </a:p>
           <a:p>
             <a:pPr lvl="0"/>
             <a:r>
               <a:rPr/>
-              <a:t>Add a third coordinate: the </a:t>
+              <a:t>The RBF model needs </a:t>
             </a:r>
             <a:r>
               <a:rPr b="1"/>
-              <a:t>distance from the design point</a:t>
+              <a:t>23%</a:t>
             </a:r>
           </a:p>
           <a:p>
             <a:pPr lvl="0"/>
             <a:r>
               <a:rPr/>
-              <a:t>Healthy pumps rise a little, faulty ones a lot, and a flat plane separates them perfectly</a:t>
+              <a:t>Almost every point sits on or inside the margin: there is no slab that separates anything</a:t>
             </a:r>
           </a:p>
           <a:p>
             <a:pPr lvl="0"/>
             <a:r>
               <a:rPr/>
-              <a:t>The classes were always separable. They were measured in the wrong coordinates</a:t>
+              <a:t>The count falls out of </a:t>
+            </a:r>
+            <a:r>
+              <a:rPr>
+                <a:latin typeface="Courier"/>
+              </a:rPr>
+              <a:t>fit</a:t>
+            </a:r>
+            <a:r>
+              <a:rPr/>
+              <a:t> at no cost, and you should look at it</a:t>
             </a:r>
           </a:p>
         </p:txBody>
@@ -15953,6 +16275,115 @@
 </file>
 
 <file path=ppt/slides/slide47.xml><?xml version="1.0" encoding="utf-8"?>
+<p:sld xmlns:a="http://schemas.openxmlformats.org/drawingml/2006/main" xmlns:r="http://schemas.openxmlformats.org/officeDocument/2006/relationships" xmlns:p="http://schemas.openxmlformats.org/presentationml/2006/main">
+  <p:cSld>
+    <p:spTree>
+      <p:nvGrpSpPr>
+        <p:cNvPr id="1" name=""/>
+        <p:cNvGrpSpPr/>
+        <p:nvPr/>
+      </p:nvGrpSpPr>
+      <p:grpSpPr>
+        <a:xfrm>
+          <a:off x="0" y="0"/>
+          <a:ext cx="0" cy="0"/>
+          <a:chOff x="0" y="0"/>
+          <a:chExt cx="0" cy="0"/>
+        </a:xfrm>
+      </p:grpSpPr>
+      <p:sp>
+        <p:nvSpPr>
+          <p:cNvPr id="2" name="Title 1"/>
+          <p:cNvSpPr>
+            <a:spLocks noGrp="1"/>
+          </p:cNvSpPr>
+          <p:nvPr>
+            <p:ph type="title"/>
+          </p:nvPr>
+        </p:nvSpPr>
+        <p:spPr>
+          <a:xfrm>
+            <a:off x="457200" y="205979"/>
+            <a:ext cx="8229600" cy="857250"/>
+          </a:xfrm>
+        </p:spPr>
+        <p:txBody>
+          <a:bodyPr/>
+          <a:lstStyle/>
+          <a:p>
+            <a:pPr lvl="0" indent="0" marL="0">
+              <a:buNone/>
+            </a:pPr>
+            <a:r>
+              <a:rPr/>
+              <a:t>The kernel trick: they needed different coordinates</a:t>
+            </a:r>
+          </a:p>
+        </p:txBody>
+      </p:sp>
+      <p:sp>
+        <p:nvSpPr>
+          <p:cNvPr id="3" name="Content Placeholder 2"/>
+          <p:cNvSpPr>
+            <a:spLocks noGrp="1"/>
+          </p:cNvSpPr>
+          <p:nvPr>
+            <p:ph idx="1"/>
+          </p:nvPr>
+        </p:nvSpPr>
+        <p:spPr>
+          <a:xfrm>
+            <a:off x="457200" y="1200151"/>
+            <a:ext cx="8229600" cy="3394472"/>
+          </a:xfrm>
+        </p:spPr>
+        <p:txBody>
+          <a:bodyPr/>
+          <a:lstStyle/>
+          <a:p>
+            <a:pPr lvl="0"/>
+            <a:r>
+              <a:rPr/>
+              <a:t>Healthy pumps in a disc, faulty ones around it: no line works </a:t>
+            </a:r>
+            <a:r>
+              <a:rPr b="1"/>
+              <a:t>in the plane</a:t>
+            </a:r>
+          </a:p>
+          <a:p>
+            <a:pPr lvl="0"/>
+            <a:r>
+              <a:rPr/>
+              <a:t>Add a third coordinate: the </a:t>
+            </a:r>
+            <a:r>
+              <a:rPr b="1"/>
+              <a:t>distance from the design point</a:t>
+            </a:r>
+          </a:p>
+          <a:p>
+            <a:pPr lvl="0"/>
+            <a:r>
+              <a:rPr/>
+              <a:t>Healthy pumps rise a little, faulty ones a lot, and a flat plane separates them perfectly</a:t>
+            </a:r>
+          </a:p>
+          <a:p>
+            <a:pPr lvl="0"/>
+            <a:r>
+              <a:rPr/>
+              <a:t>The classes were always separable. They were measured in the wrong coordinates</a:t>
+            </a:r>
+          </a:p>
+        </p:txBody>
+      </p:sp>
+    </p:spTree>
+  </p:cSld>
+</p:sld>
+</file>
+
+<file path=ppt/slides/slide48.xml><?xml version="1.0" encoding="utf-8"?>
 <p:sld xmlns:a="http://schemas.openxmlformats.org/drawingml/2006/main" xmlns:r="http://schemas.openxmlformats.org/officeDocument/2006/relationships" xmlns:p="http://schemas.openxmlformats.org/presentationml/2006/main">
   <p:cSld>
     <p:spTree>
@@ -16034,124 +16465,6 @@
 </p:sld>
 </file>
 
-<file path=ppt/slides/slide48.xml><?xml version="1.0" encoding="utf-8"?>
-<p:sld xmlns:a="http://schemas.openxmlformats.org/drawingml/2006/main" xmlns:r="http://schemas.openxmlformats.org/officeDocument/2006/relationships" xmlns:p="http://schemas.openxmlformats.org/presentationml/2006/main">
-  <p:cSld>
-    <p:spTree>
-      <p:nvGrpSpPr>
-        <p:cNvPr id="1" name=""/>
-        <p:cNvGrpSpPr/>
-        <p:nvPr/>
-      </p:nvGrpSpPr>
-      <p:grpSpPr>
-        <a:xfrm>
-          <a:off x="0" y="0"/>
-          <a:ext cx="0" cy="0"/>
-          <a:chOff x="0" y="0"/>
-          <a:chExt cx="0" cy="0"/>
-        </a:xfrm>
-      </p:grpSpPr>
-      <p:sp>
-        <p:nvSpPr>
-          <p:cNvPr id="2" name="Title 1"/>
-          <p:cNvSpPr>
-            <a:spLocks noGrp="1"/>
-          </p:cNvSpPr>
-          <p:nvPr>
-            <p:ph type="title"/>
-          </p:nvPr>
-        </p:nvSpPr>
-        <p:spPr>
-          <a:xfrm>
-            <a:off x="457200" y="205979"/>
-            <a:ext cx="8229600" cy="857250"/>
-          </a:xfrm>
-        </p:spPr>
-        <p:txBody>
-          <a:bodyPr/>
-          <a:lstStyle/>
-          <a:p>
-            <a:pPr lvl="0" indent="0" marL="0">
-              <a:buNone/>
-            </a:pPr>
-            <a:r>
-              <a:rPr/>
-              <a:t>And the map is never computed</a:t>
-            </a:r>
-          </a:p>
-        </p:txBody>
-      </p:sp>
-      <p:sp>
-        <p:nvSpPr>
-          <p:cNvPr id="3" name="Content Placeholder 2"/>
-          <p:cNvSpPr>
-            <a:spLocks noGrp="1"/>
-          </p:cNvSpPr>
-          <p:nvPr>
-            <p:ph idx="1"/>
-          </p:nvPr>
-        </p:nvSpPr>
-        <p:spPr>
-          <a:xfrm>
-            <a:off x="457200" y="1200151"/>
-            <a:ext cx="8229600" cy="3394472"/>
-          </a:xfrm>
-        </p:spPr>
-        <p:txBody>
-          <a:bodyPr/>
-          <a:lstStyle/>
-          <a:p>
-            <a:pPr lvl="0"/>
-            <a:r>
-              <a:rPr/>
-              <a:t>The solution depends on the data </a:t>
-            </a:r>
-            <a:r>
-              <a:rPr b="1"/>
-              <a:t>only through inner products</a:t>
-            </a:r>
-            <a:r>
-              <a:rPr/>
-              <a:t> between pairs of points</a:t>
-            </a:r>
-          </a:p>
-          <a:p>
-            <a:pPr lvl="0"/>
-            <a:r>
-              <a:rPr/>
-              <a:t>So we need a function returning the inner product </a:t>
-            </a:r>
-            <a:r>
-              <a:rPr b="1"/>
-              <a:t>in the new space</a:t>
-            </a:r>
-            <a:r>
-              <a:rPr/>
-              <a:t>, while computing only with the original one</a:t>
-            </a:r>
-          </a:p>
-          <a:p>
-            <a:pPr lvl="0"/>
-            <a:r>
-              <a:rPr/>
-              <a:t>The radial basis function is scikit-learn’s default: one exponential per pair, for an </a:t>
-            </a:r>
-            <a:r>
-              <a:rPr b="1"/>
-              <a:t>infinite-dimensional</a:t>
-            </a:r>
-            <a:r>
-              <a:rPr/>
-              <a:t> space</a:t>
-            </a:r>
-          </a:p>
-        </p:txBody>
-      </p:sp>
-    </p:spTree>
-  </p:cSld>
-</p:sld>
-</file>
-
 <file path=ppt/slides/slide49.xml><?xml version="1.0" encoding="utf-8"?>
 <p:sld xmlns:a="http://schemas.openxmlformats.org/drawingml/2006/main" xmlns:r="http://schemas.openxmlformats.org/officeDocument/2006/relationships" xmlns:p="http://schemas.openxmlformats.org/presentationml/2006/main">
   <p:cSld>
@@ -16194,41 +16507,77 @@
             </a:pPr>
             <a:r>
               <a:rPr/>
-              <a:t>The radial basis function, written out</a:t>
-            </a:r>
-          </a:p>
-        </p:txBody>
-      </p:sp>
-      <p:pic>
-        <p:nvPicPr>
-          <p:cNvPr descr="eq_f6b1392351.png" id="0" name="Picture 1"/>
-          <p:cNvPicPr>
-            <a:picLocks noGrp="1" noChangeAspect="1"/>
-          </p:cNvPicPr>
-          <p:nvPr/>
-        </p:nvPicPr>
-        <p:blipFill>
-          <a:blip r:embed="rId3"/>
-          <a:stretch>
-            <a:fillRect/>
-          </a:stretch>
-        </p:blipFill>
-        <p:spPr bwMode="auto">
+              <a:t>And the map is never computed</a:t>
+            </a:r>
+          </a:p>
+        </p:txBody>
+      </p:sp>
+      <p:sp>
+        <p:nvSpPr>
+          <p:cNvPr id="3" name="Content Placeholder 2"/>
+          <p:cNvSpPr>
+            <a:spLocks noGrp="1"/>
+          </p:cNvSpPr>
+          <p:nvPr>
+            <p:ph idx="1"/>
+          </p:nvPr>
+        </p:nvSpPr>
+        <p:spPr>
           <a:xfrm>
-            <a:off x="457200" y="2433439"/>
-            <a:ext cx="8229600" cy="825500"/>
+            <a:off x="457200" y="1200151"/>
+            <a:ext cx="8229600" cy="3394472"/>
           </a:xfrm>
-          <a:prstGeom prst="rect">
-            <a:avLst/>
-          </a:prstGeom>
-          <a:noFill/>
-          <a:ln w="9525">
-            <a:noFill/>
-            <a:headEnd/>
-            <a:tailEnd/>
-          </a:ln>
         </p:spPr>
-      </p:pic>
+        <p:txBody>
+          <a:bodyPr/>
+          <a:lstStyle/>
+          <a:p>
+            <a:pPr lvl="0"/>
+            <a:r>
+              <a:rPr/>
+              <a:t>The solution depends on the data </a:t>
+            </a:r>
+            <a:r>
+              <a:rPr b="1"/>
+              <a:t>only through inner products</a:t>
+            </a:r>
+            <a:r>
+              <a:rPr/>
+              <a:t> between pairs of points</a:t>
+            </a:r>
+          </a:p>
+          <a:p>
+            <a:pPr lvl="0"/>
+            <a:r>
+              <a:rPr/>
+              <a:t>So we need a function returning the inner product </a:t>
+            </a:r>
+            <a:r>
+              <a:rPr b="1"/>
+              <a:t>in the new space</a:t>
+            </a:r>
+            <a:r>
+              <a:rPr/>
+              <a:t>, while computing only with the original one</a:t>
+            </a:r>
+          </a:p>
+          <a:p>
+            <a:pPr lvl="0"/>
+            <a:r>
+              <a:rPr/>
+              <a:t>The radial basis function is scikit-learn’s default: one exponential per pair, for an </a:t>
+            </a:r>
+            <a:r>
+              <a:rPr b="1"/>
+              <a:t>infinite-dimensional</a:t>
+            </a:r>
+            <a:r>
+              <a:rPr/>
+              <a:t> space</a:t>
+            </a:r>
+          </a:p>
+        </p:txBody>
+      </p:sp>
     </p:spTree>
   </p:cSld>
 </p:sld>
@@ -16317,6 +16666,88 @@
 </file>
 
 <file path=ppt/slides/slide50.xml><?xml version="1.0" encoding="utf-8"?>
+<p:sld xmlns:a="http://schemas.openxmlformats.org/drawingml/2006/main" xmlns:r="http://schemas.openxmlformats.org/officeDocument/2006/relationships" xmlns:p="http://schemas.openxmlformats.org/presentationml/2006/main">
+  <p:cSld>
+    <p:spTree>
+      <p:nvGrpSpPr>
+        <p:cNvPr id="1" name=""/>
+        <p:cNvGrpSpPr/>
+        <p:nvPr/>
+      </p:nvGrpSpPr>
+      <p:grpSpPr>
+        <a:xfrm>
+          <a:off x="0" y="0"/>
+          <a:ext cx="0" cy="0"/>
+          <a:chOff x="0" y="0"/>
+          <a:chExt cx="0" cy="0"/>
+        </a:xfrm>
+      </p:grpSpPr>
+      <p:sp>
+        <p:nvSpPr>
+          <p:cNvPr id="2" name="Title 1"/>
+          <p:cNvSpPr>
+            <a:spLocks noGrp="1"/>
+          </p:cNvSpPr>
+          <p:nvPr>
+            <p:ph type="title"/>
+          </p:nvPr>
+        </p:nvSpPr>
+        <p:spPr>
+          <a:xfrm>
+            <a:off x="457200" y="205979"/>
+            <a:ext cx="8229600" cy="857250"/>
+          </a:xfrm>
+        </p:spPr>
+        <p:txBody>
+          <a:bodyPr/>
+          <a:lstStyle/>
+          <a:p>
+            <a:pPr lvl="0" indent="0" marL="0">
+              <a:buNone/>
+            </a:pPr>
+            <a:r>
+              <a:rPr/>
+              <a:t>The radial basis function, written out</a:t>
+            </a:r>
+          </a:p>
+        </p:txBody>
+      </p:sp>
+      <p:pic>
+        <p:nvPicPr>
+          <p:cNvPr descr="eq_f6b1392351.png" id="0" name="Picture 1"/>
+          <p:cNvPicPr>
+            <a:picLocks noGrp="1" noChangeAspect="1"/>
+          </p:cNvPicPr>
+          <p:nvPr/>
+        </p:nvPicPr>
+        <p:blipFill>
+          <a:blip r:embed="rId3"/>
+          <a:stretch>
+            <a:fillRect/>
+          </a:stretch>
+        </p:blipFill>
+        <p:spPr bwMode="auto">
+          <a:xfrm>
+            <a:off x="457200" y="2433439"/>
+            <a:ext cx="8229600" cy="825500"/>
+          </a:xfrm>
+          <a:prstGeom prst="rect">
+            <a:avLst/>
+          </a:prstGeom>
+          <a:noFill/>
+          <a:ln w="9525">
+            <a:noFill/>
+            <a:headEnd/>
+            <a:tailEnd/>
+          </a:ln>
+        </p:spPr>
+      </p:pic>
+    </p:spTree>
+  </p:cSld>
+</p:sld>
+</file>
+
+<file path=ppt/slides/slide51.xml><?xml version="1.0" encoding="utf-8"?>
 <p:sld xmlns:a="http://schemas.openxmlformats.org/drawingml/2006/main" xmlns:r="http://schemas.openxmlformats.org/officeDocument/2006/relationships" xmlns:p="http://schemas.openxmlformats.org/presentationml/2006/main">
   <p:cSld>
     <p:spTree>
@@ -16588,7 +17019,7 @@
 </p:sld>
 </file>
 
-<file path=ppt/slides/slide51.xml><?xml version="1.0" encoding="utf-8"?>
+<file path=ppt/slides/slide52.xml><?xml version="1.0" encoding="utf-8"?>
 <p:sld xmlns:a="http://schemas.openxmlformats.org/drawingml/2006/main" xmlns:r="http://schemas.openxmlformats.org/officeDocument/2006/relationships" xmlns:p="http://schemas.openxmlformats.org/presentationml/2006/main">
   <p:cSld>
     <p:spTree>
@@ -16670,7 +17101,7 @@
 </p:sld>
 </file>
 
-<file path=ppt/slides/slide52.xml><?xml version="1.0" encoding="utf-8"?>
+<file path=ppt/slides/slide53.xml><?xml version="1.0" encoding="utf-8"?>
 <p:sld xmlns:a="http://schemas.openxmlformats.org/drawingml/2006/main" xmlns:r="http://schemas.openxmlformats.org/officeDocument/2006/relationships" xmlns:p="http://schemas.openxmlformats.org/presentationml/2006/main">
   <p:cSld>
     <p:spTree>
@@ -16750,7 +17181,7 @@
 </p:sld>
 </file>
 
-<file path=ppt/slides/slide53.xml><?xml version="1.0" encoding="utf-8"?>
+<file path=ppt/slides/slide54.xml><?xml version="1.0" encoding="utf-8"?>
 <p:sld xmlns:a="http://schemas.openxmlformats.org/drawingml/2006/main" xmlns:r="http://schemas.openxmlformats.org/officeDocument/2006/relationships" xmlns:p="http://schemas.openxmlformats.org/presentationml/2006/main">
   <p:cSld>
     <p:spTree>
@@ -17088,7 +17519,7 @@
 </p:sld>
 </file>
 
-<file path=ppt/slides/slide54.xml><?xml version="1.0" encoding="utf-8"?>
+<file path=ppt/slides/slide55.xml><?xml version="1.0" encoding="utf-8"?>
 <p:sld xmlns:a="http://schemas.openxmlformats.org/drawingml/2006/main" xmlns:r="http://schemas.openxmlformats.org/officeDocument/2006/relationships" xmlns:p="http://schemas.openxmlformats.org/presentationml/2006/main">
   <p:cSld>
     <p:spTree>
@@ -17366,7 +17797,7 @@
 </p:sld>
 </file>
 
-<file path=ppt/slides/slide55.xml><?xml version="1.0" encoding="utf-8"?>
+<file path=ppt/slides/slide56.xml><?xml version="1.0" encoding="utf-8"?>
 <p:sld xmlns:a="http://schemas.openxmlformats.org/drawingml/2006/main" xmlns:r="http://schemas.openxmlformats.org/officeDocument/2006/relationships" xmlns:p="http://schemas.openxmlformats.org/presentationml/2006/main">
   <p:cSld>
     <p:spTree>
@@ -17498,7 +17929,7 @@
 </p:sld>
 </file>
 
-<file path=ppt/slides/slide56.xml><?xml version="1.0" encoding="utf-8"?>
+<file path=ppt/slides/slide57.xml><?xml version="1.0" encoding="utf-8"?>
 <p:sld xmlns:a="http://schemas.openxmlformats.org/drawingml/2006/main" xmlns:r="http://schemas.openxmlformats.org/officeDocument/2006/relationships" xmlns:p="http://schemas.openxmlformats.org/presentationml/2006/main">
   <p:cSld>
     <p:spTree>

</xml_diff>

<commit_message>
Close the gaps a read-through found in lesson 6's Naive Bayes chapter
Section 4.5 still said the pump data had no correlated features, which
section 4.3 now contradicts; the overconfidence it describes needs features
that repeat the same evidence, and the text and slide say so. Section 4.3
asserted the log-ratio was a weighted sum of squared distances without the
algebra; it now shows the weights and why they are positive. Section 4.2
quoted 0.933 before 4.3 presents it, used x1 and x2 without naming them,
pointed at section 4.4's sensors before they exist, and restated training a
paragraph after the table had shown it.

Co-Authored-By: Claude Opus 5.5 <noreply@anthropic.com>
</commit_message>
<xml_diff>
--- a/Lessons/06_knn_naive_bayes_svm/Slides/knn_naive_bayes_svm_slides.pptx
+++ b/Lessons/06_knn_naive_bayes_svm/Slides/knn_naive_bayes_svm_slides.pptx
@@ -4238,7 +4238,7 @@
             </a:pPr>
             <a:r>
               <a:rPr/>
-              <a:t>The more common complaint runs in the opposite direction, so give it too: when features ARE correlated, multiplying their probabilities counts the same evidence repeatedly. Ten correlated words in a document are treated as ten independent pieces of evidence, and the posterior saturates. Naive Bayes is famous for reporting 0.999 on problems it gets wrong a fifth of the time.</a:t>
+              <a:t>The more common complaint runs in the opposite direction, so give it too: when features carry the SAME evidence about the class - near-copies of one another - multiplying their probabilities counts it repeatedly. Be precise here, because they have just seen two kinds of dependence that are not this: the pumps’ ring and the XOR sensors. Ten correlated words in a document are treated as ten independent pieces of evidence, and the posterior saturates. Naive Bayes is famous for reporting 0.999 on problems it gets wrong a fifth of the time.</a:t>
             </a:r>
           </a:p>
           <a:p>
@@ -15219,7 +15219,7 @@
             <a:pPr lvl="0"/>
             <a:r>
               <a:rPr/>
-              <a:t>With correlated features it fails the other way: 0.999 reported, with an accuracy nothing like that</a:t>
+              <a:t>With features that repeat each other it fails the other way: 0.999 reported, with an accuracy nothing like that</a:t>
             </a:r>
           </a:p>
           <a:p>

</xml_diff>

<commit_message>
Make lesson 6's interaction figure say what Naive Bayes sees
The per-sensor histograms were drawn as overlapping translucent fills, so the
two classes blended into an unlabelled brown and the figure never showed the
model itself. They are now outlines, with the one bell per class that Gaussian
Naive Bayes fits drawn dashed on top: two humps in the data, one bell in the
valley between them, and the two classes' bells nearly identical. Section 4.4
explains the colours, counts the four quadrants, tabulates the fitted bells,
and contrasts them with the pumps, where a shared centre came with different
widths.

Co-Authored-By: Claude Opus 5.5 <noreply@anthropic.com>
</commit_message>
<xml_diff>
--- a/Lessons/06_knn_naive_bayes_svm/Slides/knn_naive_bayes_svm_slides.pptx
+++ b/Lessons/06_knn_naive_bayes_svm/Slides/knn_naive_bayes_svm_slides.pptx
@@ -3966,7 +3966,35 @@
             </a:pPr>
             <a:r>
               <a:rPr/>
-              <a:t>Middle and right: each sensor on its own, which is ALL Naive Bayes ever gets. The two class distributions sit almost exactly on top of one another.</a:t>
+              <a:t>Colours first, because someone will ask: teal is healthy, rust is faulty, everywhere. In the left panel each class owns two opposite quadrants - healthy has both sensors high or both low, faulty one high and one low.</a:t>
+            </a:r>
+          </a:p>
+          <a:p>
+            <a:pPr lvl="0" indent="0" marL="0">
+              <a:buNone/>
+            </a:pPr>
+          </a:p>
+          <a:p>
+            <a:pPr lvl="0" indent="0" marL="0">
+              <a:buNone/>
+            </a:pPr>
+            <a:r>
+              <a:rPr/>
+              <a:t>Middle and right: each sensor on its own, which is ALL Naive Bayes ever gets. Solid outlines are the data. Each sensor is either low or high, so each outline has two humps - and healthy and faulty have the SAME two humps, because each class is about half low and half high on each sensor alone.</a:t>
+            </a:r>
+          </a:p>
+          <a:p>
+            <a:pPr lvl="0" indent="0" marL="0">
+              <a:buNone/>
+            </a:pPr>
+          </a:p>
+          <a:p>
+            <a:pPr lvl="0" indent="0" marL="0">
+              <a:buNone/>
+            </a:pPr>
+            <a:r>
+              <a:rPr/>
+              <a:t>The dashed curves are what the model fits: one bell per sensor per class. A single bell cannot follow two humps, so it sits in the valley between them, and the two classes’ bells almost coincide - centre near 0, sd about 1.1 for both. Contrast the pumps a few slides ago: bells with a shared centre but widths of 1.7 against 4.6 Hz, and the widths carried the class. Here nothing does.</a:t>
             </a:r>
           </a:p>
           <a:p>
@@ -14798,8 +14826,8 @@
         </p:blipFill>
         <p:spPr bwMode="auto">
           <a:xfrm>
-            <a:off x="457200" y="1607939"/>
-            <a:ext cx="8229600" cy="2476500"/>
+            <a:off x="457200" y="1588889"/>
+            <a:ext cx="8229600" cy="2514600"/>
           </a:xfrm>
           <a:prstGeom prst="rect">
             <a:avLst/>

</xml_diff>

<commit_message>
Draw why lesson 6's 48 Hz pump reads faulty
The worked pump was only a table of log-densities. A new figure from
notebook 02 draws the two fitted bells on each reading with the pump marked:
at 48 Hz the narrow healthy vibration bell has fallen to almost nothing
while the wide faulty one is 86 times higher, at 42 Hz the order reverses,
and on pressure 5.6 bar is central for both, with the narrow bell peaking
above 1. It is slide 31, sits beside the example in section 4.2, and the
lesson plan's slide ranges move by one.

Co-Authored-By: Claude Opus 5.5 <noreply@anthropic.com>
</commit_message>
<xml_diff>
--- a/Lessons/06_knn_naive_bayes_svm/Slides/knn_naive_bayes_svm_slides.pptx
+++ b/Lessons/06_knn_naive_bayes_svm/Slides/knn_naive_bayes_svm_slides.pptx
@@ -5,7 +5,7 @@
     <p:sldMasterId id="2147483648" r:id="rId1"/>
   </p:sldMasterIdLst>
   <p:notesMasterIdLst>
-    <p:notesMasterId r:id="rId62"/>
+    <p:notesMasterId r:id="rId63"/>
   </p:notesMasterIdLst>
   <p:sldIdLst>
     <p:sldId id="256" r:id="rId2"/>
@@ -68,6 +68,7 @@
     <p:sldId id="313" r:id="rId59"/>
     <p:sldId id="314" r:id="rId60"/>
     <p:sldId id="315" r:id="rId61"/>
+    <p:sldId id="316" r:id="rId62"/>
   </p:sldIdLst>
   <p:sldSz cx="9144000" cy="5143500" type="screen16x9"/>
   <p:notesSz cx="6858000" cy="9144000"/>
@@ -3135,7 +3136,7 @@
             </a:pPr>
             <a:r>
               <a:rPr/>
-              <a:t>One pump makes it concrete. At 48 Hz and 5.6 bar, 6 Hz off the design point, that is three and a half healthy standard deviations but barely more than one faulty one. The vibration term decides it: P(faulty) = 0.981. At the design point itself, 42 Hz and 5.6 bar, P(healthy) = 0.820.</a:t>
+              <a:t>One pump makes it concrete. At 48 Hz and 5.6 bar, 6 Hz off the design point, that is three and a half healthy standard deviations but barely more than one faulty one. The vibration term decides it: P(faulty) = 0.981. At the design point itself, 42 Hz and 5.6 bar, P(healthy) = 0.820. The next slide draws it.</a:t>
             </a:r>
           </a:p>
           <a:p>
@@ -3363,35 +3364,49 @@
             </a:pPr>
             <a:r>
               <a:rPr/>
-              <a:t>This is inference, and it is worth saying how little it is. For each class, take the log prior and add one number per reading: the log of that class’s bell, evaluated at the reading. Compare the totals. That is the prediction. No training row is consulted - only the ten stored numbers - which is the exact opposite of k-NN, where prediction is the whole cost.</a:t>
-            </a:r>
-          </a:p>
-          <a:p>
-            <a:pPr lvl="0" indent="0" marL="0">
-              <a:buNone/>
-            </a:pPr>
-          </a:p>
-          <a:p>
-            <a:pPr lvl="0" indent="0" marL="0">
-              <a:buNone/>
-            </a:pPr>
-            <a:r>
-              <a:rPr/>
-              <a:t>Walk the pump across. Vibration decides it: 48 Hz is 6 Hz from the centre, three and a half standard deviations for the narrow healthy bell, so its log density is −7.745; for the wide faulty bell it is barely more than one, −3.286. Pressure is at the centre, so it favours the narrow bell slightly - and its healthy log density is positive, +0.598, because a density is not a probability and a narrow bell peaks above 1.</a:t>
-            </a:r>
-          </a:p>
-          <a:p>
-            <a:pPr lvl="0" indent="0" marL="0">
-              <a:buNone/>
-            </a:pPr>
-          </a:p>
-          <a:p>
-            <a:pPr lvl="0" indent="0" marL="0">
-              <a:buNone/>
-            </a:pPr>
-            <a:r>
-              <a:rPr/>
-              <a:t>Faulty has the larger total, so faulty is the prediction. The probability in the title is the normalisation from slide 26 in log form: the gap between the totals, 3.951, through the logistic function, 1 / (1 + e^(−3.951)) = 0.981. Handout section 4.2 lists the four steps.</a:t>
+              <a:t>The previous slide’s numbers, drawn. Left, vibration: both bells are centred on 42 Hz, and the only difference is width. Follow the dashed line at 48 Hz up. The narrow healthy bell has fallen almost to nothing there - 6 Hz is three and a half of its standard deviations - while the wide faulty bell, for which 6 Hz is barely more than one, is still well up: 86 times higher.</a:t>
+            </a:r>
+          </a:p>
+          <a:p>
+            <a:pPr lvl="0" indent="0" marL="0">
+              <a:buNone/>
+            </a:pPr>
+          </a:p>
+          <a:p>
+            <a:pPr lvl="0" indent="0" marL="0">
+              <a:buNone/>
+            </a:pPr>
+            <a:r>
+              <a:rPr/>
+              <a:t>Then the other dashed line, at 42 Hz, the design point: there the narrow bell is on top, and that pump comes out healthy, 0.820.</a:t>
+            </a:r>
+          </a:p>
+          <a:p>
+            <a:pPr lvl="0" indent="0" marL="0">
+              <a:buNone/>
+            </a:pPr>
+          </a:p>
+          <a:p>
+            <a:pPr lvl="0" indent="0" marL="0">
+              <a:buNone/>
+            </a:pPr>
+            <a:r>
+              <a:rPr/>
+              <a:t>Right, pressure: 5.6 bar is central for both classes, so this reading barely discriminates - and the narrow healthy bell peaks at about 1.82, which is why its log-density comes out positive on the next slide. A density is not a probability.</a:t>
+            </a:r>
+          </a:p>
+          <a:p>
+            <a:pPr lvl="0" indent="0" marL="0">
+              <a:buNone/>
+            </a:pPr>
+          </a:p>
+          <a:p>
+            <a:pPr lvl="0" indent="0" marL="0">
+              <a:buNone/>
+            </a:pPr>
+            <a:r>
+              <a:rPr/>
+              <a:t>The next slide puts these heights, as logarithms, in a table.</a:t>
             </a:r>
           </a:p>
         </p:txBody>
@@ -3473,49 +3488,35 @@
             </a:pPr>
             <a:r>
               <a:rPr/>
-              <a:t>Both halves matter, and students tend to hear only one of them.</a:t>
-            </a:r>
-          </a:p>
-          <a:p>
-            <a:pPr lvl="0" indent="0" marL="0">
-              <a:buNone/>
-            </a:pPr>
-          </a:p>
-          <a:p>
-            <a:pPr lvl="0" indent="0" marL="0">
-              <a:buNone/>
-            </a:pPr>
-            <a:r>
-              <a:rPr/>
-              <a:t>The bargain is real. Nothing else in this course trains in one pass, and nothing else tolerates ten thousand features on a few thousand rows.</a:t>
-            </a:r>
-          </a:p>
-          <a:p>
-            <a:pPr lvl="0" indent="0" marL="0">
-              <a:buNone/>
-            </a:pPr>
-          </a:p>
-          <a:p>
-            <a:pPr lvl="0" indent="0" marL="0">
-              <a:buNone/>
-            </a:pPr>
-            <a:r>
-              <a:rPr/>
-              <a:t>The assumption is false almost everywhere, and give concrete cases rather than a general warning. Two sensors on the same machine are both driven by the operating point, so of course they move together. In text, “New” and “York” co-occur far more than independence would allow. In medicine, symptoms of the same disease arrive in clusters.</a:t>
-            </a:r>
-          </a:p>
-          <a:p>
-            <a:pPr lvl="0" indent="0" marL="0">
-              <a:buNone/>
-            </a:pPr>
-          </a:p>
-          <a:p>
-            <a:pPr lvl="0" indent="0" marL="0">
-              <a:buNone/>
-            </a:pPr>
-            <a:r>
-              <a:rPr/>
-              <a:t>Then the framing that makes the rest of this segment worth doing, and put it as a question to the room: given that the assumption is essentially always false, why does anybody use this? The answer is that the assumption being false and the CLASSIFIER being wrong are different things. Argmax only needs the ordering right, not the probabilities. Handout section 4.2 closes on exactly this.</a:t>
+              <a:t>This is inference, and it is worth saying how little it is. For each class, take the log prior and add one number per reading: the log of that class’s bell, evaluated at the reading. Compare the totals. That is the prediction. No training row is consulted - only the ten stored numbers - which is the exact opposite of k-NN, where prediction is the whole cost.</a:t>
+            </a:r>
+          </a:p>
+          <a:p>
+            <a:pPr lvl="0" indent="0" marL="0">
+              <a:buNone/>
+            </a:pPr>
+          </a:p>
+          <a:p>
+            <a:pPr lvl="0" indent="0" marL="0">
+              <a:buNone/>
+            </a:pPr>
+            <a:r>
+              <a:rPr/>
+              <a:t>Walk the pump across. Vibration decides it: 48 Hz is 6 Hz from the centre, three and a half standard deviations for the narrow healthy bell, so its log density is −7.745; for the wide faulty bell it is barely more than one, −3.286. Pressure is at the centre, so it favours the narrow bell slightly - and its healthy log density is positive, +0.598, because a density is not a probability and a narrow bell peaks above 1.</a:t>
+            </a:r>
+          </a:p>
+          <a:p>
+            <a:pPr lvl="0" indent="0" marL="0">
+              <a:buNone/>
+            </a:pPr>
+          </a:p>
+          <a:p>
+            <a:pPr lvl="0" indent="0" marL="0">
+              <a:buNone/>
+            </a:pPr>
+            <a:r>
+              <a:rPr/>
+              <a:t>Faulty has the larger total, so faulty is the prediction. The probability in the title is the normalisation from slide 26 in log form: the gap between the totals, 3.951, through the logistic function, 1 / (1 + e^(−3.951)) = 0.981. Handout section 4.2 lists the four steps.</a:t>
             </a:r>
           </a:p>
         </p:txBody>
@@ -3597,49 +3598,49 @@
             </a:pPr>
             <a:r>
               <a:rPr/>
-              <a:t>A point behind k-NN, and an enormous distance ahead of the linear model - from a method that assumes something false and trains in a single pass over the data.</a:t>
-            </a:r>
-          </a:p>
-          <a:p>
-            <a:pPr lvl="0" indent="0" marL="0">
-              <a:buNone/>
-            </a:pPr>
-          </a:p>
-          <a:p>
-            <a:pPr lvl="0" indent="0" marL="0">
-              <a:buNone/>
-            </a:pPr>
-            <a:r>
-              <a:rPr/>
-              <a:t>Resist the temptation to stop here, because a score alone tells you nothing about when it will hold. Ask the room the useful question instead: WHY did that work? If the assumption is false, what happened?</a:t>
-            </a:r>
-          </a:p>
-          <a:p>
-            <a:pPr lvl="0" indent="0" marL="0">
-              <a:buNone/>
-            </a:pPr>
-          </a:p>
-          <a:p>
-            <a:pPr lvl="0" indent="0" marL="0">
-              <a:buNone/>
-            </a:pPr>
-            <a:r>
-              <a:rPr/>
-              <a:t>Then be explicit that we are about to check, rather than speculate. This is the habit worth transferring: when a model does better than you expected, find out whether it worked because its assumption held or despite it failing. That tells you whether the result will survive on the next dataset.</a:t>
-            </a:r>
-          </a:p>
-          <a:p>
-            <a:pPr lvl="0" indent="0" marL="0">
-              <a:buNone/>
-            </a:pPr>
-          </a:p>
-          <a:p>
-            <a:pPr lvl="0" indent="0" marL="0">
-              <a:buNone/>
-            </a:pPr>
-            <a:r>
-              <a:rPr/>
-              <a:t>Handout section 4.3.</a:t>
+              <a:t>Both halves matter, and students tend to hear only one of them.</a:t>
+            </a:r>
+          </a:p>
+          <a:p>
+            <a:pPr lvl="0" indent="0" marL="0">
+              <a:buNone/>
+            </a:pPr>
+          </a:p>
+          <a:p>
+            <a:pPr lvl="0" indent="0" marL="0">
+              <a:buNone/>
+            </a:pPr>
+            <a:r>
+              <a:rPr/>
+              <a:t>The bargain is real. Nothing else in this course trains in one pass, and nothing else tolerates ten thousand features on a few thousand rows.</a:t>
+            </a:r>
+          </a:p>
+          <a:p>
+            <a:pPr lvl="0" indent="0" marL="0">
+              <a:buNone/>
+            </a:pPr>
+          </a:p>
+          <a:p>
+            <a:pPr lvl="0" indent="0" marL="0">
+              <a:buNone/>
+            </a:pPr>
+            <a:r>
+              <a:rPr/>
+              <a:t>The assumption is false almost everywhere, and give concrete cases rather than a general warning. Two sensors on the same machine are both driven by the operating point, so of course they move together. In text, “New” and “York” co-occur far more than independence would allow. In medicine, symptoms of the same disease arrive in clusters.</a:t>
+            </a:r>
+          </a:p>
+          <a:p>
+            <a:pPr lvl="0" indent="0" marL="0">
+              <a:buNone/>
+            </a:pPr>
+          </a:p>
+          <a:p>
+            <a:pPr lvl="0" indent="0" marL="0">
+              <a:buNone/>
+            </a:pPr>
+            <a:r>
+              <a:rPr/>
+              <a:t>Then the framing that makes the rest of this segment worth doing, and put it as a question to the room: given that the assumption is essentially always false, why does anybody use this? The answer is that the assumption being false and the CLASSIFIER being wrong are different things. Argmax only needs the ordering right, not the probabilities. Handout section 4.2 closes on exactly this.</a:t>
             </a:r>
           </a:p>
         </p:txBody>
@@ -3721,35 +3722,49 @@
             </a:pPr>
             <a:r>
               <a:rPr/>
-              <a:t>Show the middle column first and let the room draw the conclusion everyone draws: within each class the readings are uncorrelated, so the assumption holds. It is the natural check, and for bell-shaped data it would settle it.</a:t>
-            </a:r>
-          </a:p>
-          <a:p>
-            <a:pPr lvl="0" indent="0" marL="0">
-              <a:buNone/>
-            </a:pPr>
-          </a:p>
-          <a:p>
-            <a:pPr lvl="0" indent="0" marL="0">
-              <a:buNone/>
-            </a:pPr>
-            <a:r>
-              <a:rPr/>
-              <a:t>Then the trap. Correlation only sees straight-line dependence. Healthy pumps fill a disc and faulty ones a ring; on a ring, a pump far out in vibration must be central in pressure. That dependence is symmetric, so the straight-line summary averages it to zero. Square each reading’s distance from the design point and it appears: −0.420 among the faulty pumps. Or say it as a spread: the pressure of a faulty pump has a standard deviation of 0.784 when its vibration is extreme (the fifth furthest out, beyond 6.2 Hz from the centre) and 1.309 when it is not - 0.37 against 0.62 bar, same average, very different spread. Put the distinction on the board in two lines: uncorrelated, yes; independent, no. Naive Bayes assumes the second. The assumption is false.</a:t>
-            </a:r>
-          </a:p>
-          <a:p>
-            <a:pPr lvl="0" indent="0" marL="0">
-              <a:buNone/>
-            </a:pPr>
-          </a:p>
-          <a:p>
-            <a:pPr lvl="0" indent="0" marL="0">
-              <a:buNone/>
-            </a:pPr>
-            <a:r>
-              <a:rPr/>
-              <a:t>So why 0.933? Because the densities are wrong but the boundary they imply is right. With both classes centred on the same point, comparing a narrow bell with a wide one gives an axis-aligned ellipse, and the true envelope is an axis-aligned ellipse. The fitted model’s edge sits at about 3.17 Hz by 0.41 bar against a true 3.5 by 0.45 - the same shape, a tenth small. A false assumption is cheap when it leaves the boundary the right shape. The next slide is the case where it does not. Handout section 4.3.</a:t>
+              <a:t>A point behind k-NN, and an enormous distance ahead of the linear model - from a method that assumes something false and trains in a single pass over the data.</a:t>
+            </a:r>
+          </a:p>
+          <a:p>
+            <a:pPr lvl="0" indent="0" marL="0">
+              <a:buNone/>
+            </a:pPr>
+          </a:p>
+          <a:p>
+            <a:pPr lvl="0" indent="0" marL="0">
+              <a:buNone/>
+            </a:pPr>
+            <a:r>
+              <a:rPr/>
+              <a:t>Resist the temptation to stop here, because a score alone tells you nothing about when it will hold. Ask the room the useful question instead: WHY did that work? If the assumption is false, what happened?</a:t>
+            </a:r>
+          </a:p>
+          <a:p>
+            <a:pPr lvl="0" indent="0" marL="0">
+              <a:buNone/>
+            </a:pPr>
+          </a:p>
+          <a:p>
+            <a:pPr lvl="0" indent="0" marL="0">
+              <a:buNone/>
+            </a:pPr>
+            <a:r>
+              <a:rPr/>
+              <a:t>Then be explicit that we are about to check, rather than speculate. This is the habit worth transferring: when a model does better than you expected, find out whether it worked because its assumption held or despite it failing. That tells you whether the result will survive on the next dataset.</a:t>
+            </a:r>
+          </a:p>
+          <a:p>
+            <a:pPr lvl="0" indent="0" marL="0">
+              <a:buNone/>
+            </a:pPr>
+          </a:p>
+          <a:p>
+            <a:pPr lvl="0" indent="0" marL="0">
+              <a:buNone/>
+            </a:pPr>
+            <a:r>
+              <a:rPr/>
+              <a:t>Handout section 4.3.</a:t>
             </a:r>
           </a:p>
         </p:txBody>
@@ -3831,49 +3846,35 @@
             </a:pPr>
             <a:r>
               <a:rPr/>
-              <a:t>Change one thing about the problem and watch the method fall apart. Describe the physics before the geometry, because the rule is completely reasonable engineering.</a:t>
-            </a:r>
-          </a:p>
-          <a:p>
-            <a:pPr lvl="0" indent="0" marL="0">
-              <a:buNone/>
-            </a:pPr>
-          </a:p>
-          <a:p>
-            <a:pPr lvl="0" indent="0" marL="0">
-              <a:buNone/>
-            </a:pPr>
-            <a:r>
-              <a:rPr/>
-              <a:t>High demand and high delivery: fine, that is the machine working hard. Low and low: fine, that is idle. High demand with low delivery, or the reverse: something is wrong between them. Exactly one high means faulty.</a:t>
-            </a:r>
-          </a:p>
-          <a:p>
-            <a:pPr lvl="0" indent="0" marL="0">
-              <a:buNone/>
-            </a:pPr>
-          </a:p>
-          <a:p>
-            <a:pPr lvl="0" indent="0" marL="0">
-              <a:buNone/>
-            </a:pPr>
-            <a:r>
-              <a:rPr/>
-              <a:t>Ask them, before the picture, what each sensor tells you ON ITS OWN under that rule. Give it a moment. The answer is: nothing at all. Every value of sensor A appears in both classes about equally often, because whether it means “faulty” depends entirely on sensor B.</a:t>
-            </a:r>
-          </a:p>
-          <a:p>
-            <a:pPr lvl="0" indent="0" marL="0">
-              <a:buNone/>
-            </a:pPr>
-          </a:p>
-          <a:p>
-            <a:pPr lvl="0" indent="0" marL="0">
-              <a:buNone/>
-            </a:pPr>
-            <a:r>
-              <a:rPr/>
-              <a:t>That is what an interaction is, and it is precisely the structure the independence assumption is unable to represent. Handout section 4.4.</a:t>
+              <a:t>Show the middle column first and let the room draw the conclusion everyone draws: within each class the readings are uncorrelated, so the assumption holds. It is the natural check, and for bell-shaped data it would settle it.</a:t>
+            </a:r>
+          </a:p>
+          <a:p>
+            <a:pPr lvl="0" indent="0" marL="0">
+              <a:buNone/>
+            </a:pPr>
+          </a:p>
+          <a:p>
+            <a:pPr lvl="0" indent="0" marL="0">
+              <a:buNone/>
+            </a:pPr>
+            <a:r>
+              <a:rPr/>
+              <a:t>Then the trap. Correlation only sees straight-line dependence. Healthy pumps fill a disc and faulty ones a ring; on a ring, a pump far out in vibration must be central in pressure. That dependence is symmetric, so the straight-line summary averages it to zero. Square each reading’s distance from the design point and it appears: −0.420 among the faulty pumps. Or say it as a spread: the pressure of a faulty pump has a standard deviation of 0.784 when its vibration is extreme (the fifth furthest out, beyond 6.2 Hz from the centre) and 1.309 when it is not - 0.37 against 0.62 bar, same average, very different spread. Put the distinction on the board in two lines: uncorrelated, yes; independent, no. Naive Bayes assumes the second. The assumption is false.</a:t>
+            </a:r>
+          </a:p>
+          <a:p>
+            <a:pPr lvl="0" indent="0" marL="0">
+              <a:buNone/>
+            </a:pPr>
+          </a:p>
+          <a:p>
+            <a:pPr lvl="0" indent="0" marL="0">
+              <a:buNone/>
+            </a:pPr>
+            <a:r>
+              <a:rPr/>
+              <a:t>So why 0.933? Because the densities are wrong but the boundary they imply is right. With both classes centred on the same point, comparing a narrow bell with a wide one gives an axis-aligned ellipse, and the true envelope is an axis-aligned ellipse. The fitted model’s edge sits at about 3.17 Hz by 0.41 bar against a true 3.5 by 0.45 - the same shape, a tenth small. A false assumption is cheap when it leaves the boundary the right shape. The next slide is the case where it does not. Handout section 4.3.</a:t>
             </a:r>
           </a:p>
         </p:txBody>
@@ -3955,77 +3956,49 @@
             </a:pPr>
             <a:r>
               <a:rPr/>
-              <a:t>Left panel: the two sensors together. Four clean groups, and a perfectly learnable rule - any method that can draw a non-linear boundary will find it.</a:t>
-            </a:r>
-          </a:p>
-          <a:p>
-            <a:pPr lvl="0" indent="0" marL="0">
-              <a:buNone/>
-            </a:pPr>
-          </a:p>
-          <a:p>
-            <a:pPr lvl="0" indent="0" marL="0">
-              <a:buNone/>
-            </a:pPr>
-            <a:r>
-              <a:rPr/>
-              <a:t>Colours first, because someone will ask: teal is healthy, rust is faulty, everywhere. In the left panel each class owns two opposite quadrants - healthy has both sensors high or both low, faulty one high and one low.</a:t>
-            </a:r>
-          </a:p>
-          <a:p>
-            <a:pPr lvl="0" indent="0" marL="0">
-              <a:buNone/>
-            </a:pPr>
-          </a:p>
-          <a:p>
-            <a:pPr lvl="0" indent="0" marL="0">
-              <a:buNone/>
-            </a:pPr>
-            <a:r>
-              <a:rPr/>
-              <a:t>Middle and right: each sensor on its own, which is ALL Naive Bayes ever gets. Solid outlines are the data. Each sensor is either low or high, so each outline has two humps - and healthy and faulty have the SAME two humps, because each class is about half low and half high on each sensor alone.</a:t>
-            </a:r>
-          </a:p>
-          <a:p>
-            <a:pPr lvl="0" indent="0" marL="0">
-              <a:buNone/>
-            </a:pPr>
-          </a:p>
-          <a:p>
-            <a:pPr lvl="0" indent="0" marL="0">
-              <a:buNone/>
-            </a:pPr>
-            <a:r>
-              <a:rPr/>
-              <a:t>The dashed curves are what the model fits: one bell per sensor per class. A single bell cannot follow two humps, so it sits in the valley between them, and the two classes’ bells almost coincide - centre near 0, sd about 1.1 for both. Contrast the pumps a few slides ago: bells with a shared centre but widths of 1.7 against 4.6 Hz, and the widths carried the class. Here nothing does.</a:t>
-            </a:r>
-          </a:p>
-          <a:p>
-            <a:pPr lvl="0" indent="0" marL="0">
-              <a:buNone/>
-            </a:pPr>
-          </a:p>
-          <a:p>
-            <a:pPr lvl="0" indent="0" marL="0">
-              <a:buNone/>
-            </a:pPr>
-            <a:r>
-              <a:rPr/>
-              <a:t>That is the slide in one sentence: the information is real, it is entirely in the relationship between the columns, and factorising the density throws that relationship away before the model ever sees it.</a:t>
-            </a:r>
-          </a:p>
-          <a:p>
-            <a:pPr lvl="0" indent="0" marL="0">
-              <a:buNone/>
-            </a:pPr>
-          </a:p>
-          <a:p>
-            <a:pPr lvl="0" indent="0" marL="0">
-              <a:buNone/>
-            </a:pPr>
-            <a:r>
-              <a:rPr/>
-              <a:t>Worth saying that no amount of data repairs this. It is not an estimation problem - with a million rows the marginals still overlap. The model cannot represent what is being asked of it.</a:t>
+              <a:t>Change one thing about the problem and watch the method fall apart. Describe the physics before the geometry, because the rule is completely reasonable engineering.</a:t>
+            </a:r>
+          </a:p>
+          <a:p>
+            <a:pPr lvl="0" indent="0" marL="0">
+              <a:buNone/>
+            </a:pPr>
+          </a:p>
+          <a:p>
+            <a:pPr lvl="0" indent="0" marL="0">
+              <a:buNone/>
+            </a:pPr>
+            <a:r>
+              <a:rPr/>
+              <a:t>High demand and high delivery: fine, that is the machine working hard. Low and low: fine, that is idle. High demand with low delivery, or the reverse: something is wrong between them. Exactly one high means faulty.</a:t>
+            </a:r>
+          </a:p>
+          <a:p>
+            <a:pPr lvl="0" indent="0" marL="0">
+              <a:buNone/>
+            </a:pPr>
+          </a:p>
+          <a:p>
+            <a:pPr lvl="0" indent="0" marL="0">
+              <a:buNone/>
+            </a:pPr>
+            <a:r>
+              <a:rPr/>
+              <a:t>Ask them, before the picture, what each sensor tells you ON ITS OWN under that rule. Give it a moment. The answer is: nothing at all. Every value of sensor A appears in both classes about equally often, because whether it means “faulty” depends entirely on sensor B.</a:t>
+            </a:r>
+          </a:p>
+          <a:p>
+            <a:pPr lvl="0" indent="0" marL="0">
+              <a:buNone/>
+            </a:pPr>
+          </a:p>
+          <a:p>
+            <a:pPr lvl="0" indent="0" marL="0">
+              <a:buNone/>
+            </a:pPr>
+            <a:r>
+              <a:rPr/>
+              <a:t>That is what an interaction is, and it is precisely the structure the independence assumption is unable to represent. Handout section 4.4.</a:t>
             </a:r>
           </a:p>
         </p:txBody>
@@ -4107,63 +4080,77 @@
             </a:pPr>
             <a:r>
               <a:rPr/>
-              <a:t>Two things to draw out, and the second is the more interesting.</a:t>
-            </a:r>
-          </a:p>
-          <a:p>
-            <a:pPr lvl="0" indent="0" marL="0">
-              <a:buNone/>
-            </a:pPr>
-          </a:p>
-          <a:p>
-            <a:pPr lvl="0" indent="0" marL="0">
-              <a:buNone/>
-            </a:pPr>
-            <a:r>
-              <a:rPr/>
-              <a:t>First: k-NN and the RBF SVM are at 0.967 and 0.972 on this data. The problem is not hard. It is only hard for a model that looks at one feature at a time.</a:t>
-            </a:r>
-          </a:p>
-          <a:p>
-            <a:pPr lvl="0" indent="0" marL="0">
-              <a:buNone/>
-            </a:pPr>
-          </a:p>
-          <a:p>
-            <a:pPr lvl="0" indent="0" marL="0">
-              <a:buNone/>
-            </a:pPr>
-            <a:r>
-              <a:rPr/>
-              <a:t>Second, and take the time: 0.404 is BELOW CHANCE. Below the majority baseline of 0.523, and below what you would get by flipping a coin. Ask how that is even possible - a model with no information should surely sit at 50%.</a:t>
-            </a:r>
-          </a:p>
-          <a:p>
-            <a:pPr lvl="0" indent="0" marL="0">
-              <a:buNone/>
-            </a:pPr>
-          </a:p>
-          <a:p>
-            <a:pPr lvl="0" indent="0" marL="0">
-              <a:buNone/>
-            </a:pPr>
-            <a:r>
-              <a:rPr/>
-              <a:t>The explanation is worth having in full. The class means on each sensor differ by about 0.17, against a spread near 1, purely as an artefact of a finite sample. That accident is the ONLY per-feature evidence available. Naive Bayes has nothing else to multiply, so it follows it - and in this sample it points the wrong way.</a:t>
-            </a:r>
-          </a:p>
-          <a:p>
-            <a:pPr lvl="0" indent="0" marL="0">
-              <a:buNone/>
-            </a:pPr>
-          </a:p>
-          <a:p>
-            <a:pPr lvl="0" indent="0" marL="0">
-              <a:buNone/>
-            </a:pPr>
-            <a:r>
-              <a:rPr/>
-              <a:t>The sentence to land: a model with no signal does not sit politely at 50%. It follows whatever spurious structure it can find, with complete confidence.</a:t>
+              <a:t>Left panel: the two sensors together. Four clean groups, and a perfectly learnable rule - any method that can draw a non-linear boundary will find it.</a:t>
+            </a:r>
+          </a:p>
+          <a:p>
+            <a:pPr lvl="0" indent="0" marL="0">
+              <a:buNone/>
+            </a:pPr>
+          </a:p>
+          <a:p>
+            <a:pPr lvl="0" indent="0" marL="0">
+              <a:buNone/>
+            </a:pPr>
+            <a:r>
+              <a:rPr/>
+              <a:t>Colours first, because someone will ask: teal is healthy, rust is faulty, everywhere. In the left panel each class owns two opposite quadrants - healthy has both sensors high or both low, faulty one high and one low.</a:t>
+            </a:r>
+          </a:p>
+          <a:p>
+            <a:pPr lvl="0" indent="0" marL="0">
+              <a:buNone/>
+            </a:pPr>
+          </a:p>
+          <a:p>
+            <a:pPr lvl="0" indent="0" marL="0">
+              <a:buNone/>
+            </a:pPr>
+            <a:r>
+              <a:rPr/>
+              <a:t>Middle and right: each sensor on its own, which is ALL Naive Bayes ever gets. Solid outlines are the data. Each sensor is either low or high, so each outline has two humps - and healthy and faulty have the SAME two humps, because each class is about half low and half high on each sensor alone.</a:t>
+            </a:r>
+          </a:p>
+          <a:p>
+            <a:pPr lvl="0" indent="0" marL="0">
+              <a:buNone/>
+            </a:pPr>
+          </a:p>
+          <a:p>
+            <a:pPr lvl="0" indent="0" marL="0">
+              <a:buNone/>
+            </a:pPr>
+            <a:r>
+              <a:rPr/>
+              <a:t>The dashed curves are what the model fits: one bell per sensor per class. A single bell cannot follow two humps, so it sits in the valley between them, and the two classes’ bells almost coincide - centre near 0, sd about 1.1 for both. Contrast the pumps a few slides ago: bells with a shared centre but widths of 1.7 against 4.6 Hz, and the widths carried the class. Here nothing does.</a:t>
+            </a:r>
+          </a:p>
+          <a:p>
+            <a:pPr lvl="0" indent="0" marL="0">
+              <a:buNone/>
+            </a:pPr>
+          </a:p>
+          <a:p>
+            <a:pPr lvl="0" indent="0" marL="0">
+              <a:buNone/>
+            </a:pPr>
+            <a:r>
+              <a:rPr/>
+              <a:t>That is the slide in one sentence: the information is real, it is entirely in the relationship between the columns, and factorising the density throws that relationship away before the model ever sees it.</a:t>
+            </a:r>
+          </a:p>
+          <a:p>
+            <a:pPr lvl="0" indent="0" marL="0">
+              <a:buNone/>
+            </a:pPr>
+          </a:p>
+          <a:p>
+            <a:pPr lvl="0" indent="0" marL="0">
+              <a:buNone/>
+            </a:pPr>
+            <a:r>
+              <a:rPr/>
+              <a:t>Worth saying that no amount of data repairs this. It is not an estimation problem - with a million rows the marginals still overlap. The model cannot represent what is being asked of it.</a:t>
             </a:r>
           </a:p>
         </p:txBody>
@@ -4245,59 +4232,63 @@
             </a:pPr>
             <a:r>
               <a:rPr/>
-              <a:t>Two numbers, four thousandths apart. The model is exactly as confident when it is wrong as when it is right, which means </a:t>
-            </a:r>
-            <a:r>
-              <a:rPr>
-                <a:latin typeface="Courier"/>
-              </a:rPr>
-              <a:t>predict_proba</a:t>
-            </a:r>
-            <a:r>
-              <a:rPr/>
-              <a:t> carries no usable information about reliability here.</a:t>
-            </a:r>
-          </a:p>
-          <a:p>
-            <a:pPr lvl="0" indent="0" marL="0">
-              <a:buNone/>
-            </a:pPr>
-          </a:p>
-          <a:p>
-            <a:pPr lvl="0" indent="0" marL="0">
-              <a:buNone/>
-            </a:pPr>
-            <a:r>
-              <a:rPr/>
-              <a:t>The more common complaint runs in the opposite direction, so give it too: when features carry the SAME evidence about the class - near-copies of one another - multiplying their probabilities counts it repeatedly. Be precise here, because they have just seen two kinds of dependence that are not this: the pumps’ ring and the XOR sensors. Ten correlated words in a document are treated as ten independent pieces of evidence, and the posterior saturates. Naive Bayes is famous for reporting 0.999 on problems it gets wrong a fifth of the time.</a:t>
-            </a:r>
-          </a:p>
-          <a:p>
-            <a:pPr lvl="0" indent="0" marL="0">
-              <a:buNone/>
-            </a:pPr>
-          </a:p>
-          <a:p>
-            <a:pPr lvl="0" indent="0" marL="0">
-              <a:buNone/>
-            </a:pPr>
-            <a:r>
-              <a:rPr/>
-              <a:t>Then lesson 5’s distinction, which this is the textbook case of: ranking and calibration are different properties. A model can order examples usefully and still report numbers that mean nothing.</a:t>
-            </a:r>
-          </a:p>
-          <a:p>
-            <a:pPr lvl="0" indent="0" marL="0">
-              <a:buNone/>
-            </a:pPr>
-          </a:p>
-          <a:p>
-            <a:pPr lvl="0" indent="0" marL="0">
-              <a:buNone/>
-            </a:pPr>
-            <a:r>
-              <a:rPr/>
-              <a:t>The practical consequence, and it is concrete: do not use Naive Bayes anywhere a calibrated probability enters a decision - including lesson 4’s cost calculation in section 7.2, where the threshold depends on the probability being real.</a:t>
+              <a:t>Two things to draw out, and the second is the more interesting.</a:t>
+            </a:r>
+          </a:p>
+          <a:p>
+            <a:pPr lvl="0" indent="0" marL="0">
+              <a:buNone/>
+            </a:pPr>
+          </a:p>
+          <a:p>
+            <a:pPr lvl="0" indent="0" marL="0">
+              <a:buNone/>
+            </a:pPr>
+            <a:r>
+              <a:rPr/>
+              <a:t>First: k-NN and the RBF SVM are at 0.967 and 0.972 on this data. The problem is not hard. It is only hard for a model that looks at one feature at a time.</a:t>
+            </a:r>
+          </a:p>
+          <a:p>
+            <a:pPr lvl="0" indent="0" marL="0">
+              <a:buNone/>
+            </a:pPr>
+          </a:p>
+          <a:p>
+            <a:pPr lvl="0" indent="0" marL="0">
+              <a:buNone/>
+            </a:pPr>
+            <a:r>
+              <a:rPr/>
+              <a:t>Second, and take the time: 0.404 is BELOW CHANCE. Below the majority baseline of 0.523, and below what you would get by flipping a coin. Ask how that is even possible - a model with no information should surely sit at 50%.</a:t>
+            </a:r>
+          </a:p>
+          <a:p>
+            <a:pPr lvl="0" indent="0" marL="0">
+              <a:buNone/>
+            </a:pPr>
+          </a:p>
+          <a:p>
+            <a:pPr lvl="0" indent="0" marL="0">
+              <a:buNone/>
+            </a:pPr>
+            <a:r>
+              <a:rPr/>
+              <a:t>The explanation is worth having in full. The class means on each sensor differ by about 0.17, against a spread near 1, purely as an artefact of a finite sample. That accident is the ONLY per-feature evidence available. Naive Bayes has nothing else to multiply, so it follows it - and in this sample it points the wrong way.</a:t>
+            </a:r>
+          </a:p>
+          <a:p>
+            <a:pPr lvl="0" indent="0" marL="0">
+              <a:buNone/>
+            </a:pPr>
+          </a:p>
+          <a:p>
+            <a:pPr lvl="0" indent="0" marL="0">
+              <a:buNone/>
+            </a:pPr>
+            <a:r>
+              <a:rPr/>
+              <a:t>The sentence to land: a model with no signal does not sit politely at 50%. It follows whatever spurious structure it can find, with complete confidence.</a:t>
             </a:r>
           </a:p>
         </p:txBody>
@@ -4379,49 +4370,59 @@
             </a:pPr>
             <a:r>
               <a:rPr/>
-              <a:t>Run notebooks/02. Sixteen minutes.</a:t>
-            </a:r>
-          </a:p>
-          <a:p>
-            <a:pPr lvl="0" indent="0" marL="0">
-              <a:buNone/>
-            </a:pPr>
-          </a:p>
-          <a:p>
-            <a:pPr lvl="0" indent="0" marL="0">
-              <a:buNone/>
-            </a:pPr>
-            <a:r>
-              <a:rPr/>
-              <a:t>The cell to protect is the one that prints 0.404 next to the 0.523 baseline. Let them see a below-chance score appear from correct code on solvable data before any explanation arrives.</a:t>
-            </a:r>
-          </a:p>
-          <a:p>
-            <a:pPr lvl="0" indent="0" marL="0">
-              <a:buNone/>
-            </a:pPr>
-          </a:p>
-          <a:p>
-            <a:pPr lvl="0" indent="0" marL="0">
-              <a:buNone/>
-            </a:pPr>
-            <a:r>
-              <a:rPr/>
-              <a:t>The notebook prints the within-class correlations on both datasets. Before that cell runs, ask them to predict the signs for the interacting sensors: it is the diagnostic they should carry - measure the assumption, do not assume it.</a:t>
-            </a:r>
-          </a:p>
-          <a:p>
-            <a:pPr lvl="0" indent="0" marL="0">
-              <a:buNone/>
-            </a:pPr>
-          </a:p>
-          <a:p>
-            <a:pPr lvl="0" indent="0" marL="0">
-              <a:buNone/>
-            </a:pPr>
-            <a:r>
-              <a:rPr/>
-              <a:t>If time allows, the interesting exercise is to hand Naive Bayes the product of the two sensors as a third column and watch it recover. That is the whole story of feature engineering versus model choice in one cell.</a:t>
+              <a:t>Two numbers, four thousandths apart. The model is exactly as confident when it is wrong as when it is right, which means </a:t>
+            </a:r>
+            <a:r>
+              <a:rPr>
+                <a:latin typeface="Courier"/>
+              </a:rPr>
+              <a:t>predict_proba</a:t>
+            </a:r>
+            <a:r>
+              <a:rPr/>
+              <a:t> carries no usable information about reliability here.</a:t>
+            </a:r>
+          </a:p>
+          <a:p>
+            <a:pPr lvl="0" indent="0" marL="0">
+              <a:buNone/>
+            </a:pPr>
+          </a:p>
+          <a:p>
+            <a:pPr lvl="0" indent="0" marL="0">
+              <a:buNone/>
+            </a:pPr>
+            <a:r>
+              <a:rPr/>
+              <a:t>The more common complaint runs in the opposite direction, so give it too: when features carry the SAME evidence about the class - near-copies of one another - multiplying their probabilities counts it repeatedly. Be precise here, because they have just seen two kinds of dependence that are not this: the pumps’ ring and the XOR sensors. Ten correlated words in a document are treated as ten independent pieces of evidence, and the posterior saturates. Naive Bayes is famous for reporting 0.999 on problems it gets wrong a fifth of the time.</a:t>
+            </a:r>
+          </a:p>
+          <a:p>
+            <a:pPr lvl="0" indent="0" marL="0">
+              <a:buNone/>
+            </a:pPr>
+          </a:p>
+          <a:p>
+            <a:pPr lvl="0" indent="0" marL="0">
+              <a:buNone/>
+            </a:pPr>
+            <a:r>
+              <a:rPr/>
+              <a:t>Then lesson 5’s distinction, which this is the textbook case of: ranking and calibration are different properties. A model can order examples usefully and still report numbers that mean nothing.</a:t>
+            </a:r>
+          </a:p>
+          <a:p>
+            <a:pPr lvl="0" indent="0" marL="0">
+              <a:buNone/>
+            </a:pPr>
+          </a:p>
+          <a:p>
+            <a:pPr lvl="0" indent="0" marL="0">
+              <a:buNone/>
+            </a:pPr>
+            <a:r>
+              <a:rPr/>
+              <a:t>The practical consequence, and it is concrete: do not use Naive Bayes anywhere a calibrated probability enters a decision - including lesson 4’s cost calculation in section 7.2, where the threshold depends on the probability being real.</a:t>
             </a:r>
           </a:p>
         </p:txBody>
@@ -4503,49 +4504,49 @@
             </a:pPr>
             <a:r>
               <a:rPr/>
-              <a:t>Start with the problem rather than the solution. Draw two well-separated blobs on the board and ask for the boundary. Somebody will draw a line. Ask whether another line would have been equally good, and keep asking until the room sees that there are infinitely many, all with identical training error.</a:t>
-            </a:r>
-          </a:p>
-          <a:p>
-            <a:pPr lvl="0" indent="0" marL="0">
-              <a:buNone/>
-            </a:pPr>
-          </a:p>
-          <a:p>
-            <a:pPr lvl="0" indent="0" marL="0">
-              <a:buNone/>
-            </a:pPr>
-            <a:r>
-              <a:rPr/>
-              <a:t>So the error cannot decide. Something else has to. Logistic regression breaks the tie with log loss - a perfectly respectable answer, and one answer among several. The SVM breaks it differently: take the boundary with the most room around it.</a:t>
-            </a:r>
-          </a:p>
-          <a:p>
-            <a:pPr lvl="0" indent="0" marL="0">
-              <a:buNone/>
-            </a:pPr>
-          </a:p>
-          <a:p>
-            <a:pPr lvl="0" indent="0" marL="0">
-              <a:buNone/>
-            </a:pPr>
-            <a:r>
-              <a:rPr/>
-              <a:t>The intuition, and this is the sentence to say slowly: maximising the distance to the closest points chooses the boundary that tolerates the most movement in the data before it changes its mind. That is a statement about GENERALISATION, not about fit - which is unusual, because almost everything else in this course optimises fit and controls generalisation indirectly.</a:t>
-            </a:r>
-          </a:p>
-          <a:p>
-            <a:pPr lvl="0" indent="0" marL="0">
-              <a:buNone/>
-            </a:pPr>
-          </a:p>
-          <a:p>
-            <a:pPr lvl="0" indent="0" marL="0">
-              <a:buNone/>
-            </a:pPr>
-            <a:r>
-              <a:rPr/>
-              <a:t>Handout section 5.1.</a:t>
+              <a:t>Run notebooks/02. Sixteen minutes.</a:t>
+            </a:r>
+          </a:p>
+          <a:p>
+            <a:pPr lvl="0" indent="0" marL="0">
+              <a:buNone/>
+            </a:pPr>
+          </a:p>
+          <a:p>
+            <a:pPr lvl="0" indent="0" marL="0">
+              <a:buNone/>
+            </a:pPr>
+            <a:r>
+              <a:rPr/>
+              <a:t>The cell to protect is the one that prints 0.404 next to the 0.523 baseline. Let them see a below-chance score appear from correct code on solvable data before any explanation arrives.</a:t>
+            </a:r>
+          </a:p>
+          <a:p>
+            <a:pPr lvl="0" indent="0" marL="0">
+              <a:buNone/>
+            </a:pPr>
+          </a:p>
+          <a:p>
+            <a:pPr lvl="0" indent="0" marL="0">
+              <a:buNone/>
+            </a:pPr>
+            <a:r>
+              <a:rPr/>
+              <a:t>The notebook prints the within-class correlations on both datasets. Before that cell runs, ask them to predict the signs for the interacting sensors: it is the diagnostic they should carry - measure the assumption, do not assume it.</a:t>
+            </a:r>
+          </a:p>
+          <a:p>
+            <a:pPr lvl="0" indent="0" marL="0">
+              <a:buNone/>
+            </a:pPr>
+          </a:p>
+          <a:p>
+            <a:pPr lvl="0" indent="0" marL="0">
+              <a:buNone/>
+            </a:pPr>
+            <a:r>
+              <a:rPr/>
+              <a:t>If time allows, the interesting exercise is to hand Naive Bayes the product of the two sensors as a third column and watch it recover. That is the whole story of feature engineering versus model choice in one cell.</a:t>
             </a:r>
           </a:p>
         </p:txBody>
@@ -4751,49 +4752,49 @@
             </a:pPr>
             <a:r>
               <a:rPr/>
-              <a:t>The solid line is the boundary, the dashed lines are the edges of the slab, and the circled points are the support vectors touching it.</a:t>
-            </a:r>
-          </a:p>
-          <a:p>
-            <a:pPr lvl="0" indent="0" marL="0">
-              <a:buNone/>
-            </a:pPr>
-          </a:p>
-          <a:p>
-            <a:pPr lvl="0" indent="0" marL="0">
-              <a:buNone/>
-            </a:pPr>
-            <a:r>
-              <a:rPr/>
-              <a:t>The number to say out loud: of eighty points, THREE determine the answer. Move any of the other seventy-seven - anywhere, as far as you like, as long as they stay outside the slab - and the boundary does not shift by a millimetre.</a:t>
-            </a:r>
-          </a:p>
-          <a:p>
-            <a:pPr lvl="0" indent="0" marL="0">
-              <a:buNone/>
-            </a:pPr>
-          </a:p>
-          <a:p>
-            <a:pPr lvl="0" indent="0" marL="0">
-              <a:buNone/>
-            </a:pPr>
-            <a:r>
-              <a:rPr/>
-              <a:t>That is where the name comes from, and it is a genuinely different idea from anything so far. Every linear model in lessons 3 and 4 used every row: each one contributed to the gradient in proportion to its error. Here most of the data is irrelevant once the fit is done.</a:t>
-            </a:r>
-          </a:p>
-          <a:p>
-            <a:pPr lvl="0" indent="0" marL="0">
-              <a:buNone/>
-            </a:pPr>
-          </a:p>
-          <a:p>
-            <a:pPr lvl="0" indent="0" marL="0">
-              <a:buNone/>
-            </a:pPr>
-            <a:r>
-              <a:rPr/>
-              <a:t>Two consequences worth naming. The model is small - you store the support vectors, not the dataset, which is the contrast with k-NN. And it is sensitive in a specific way: an outlier near the boundary matters enormously, while an outlier far from it matters not at all.</a:t>
+              <a:t>Start with the problem rather than the solution. Draw two well-separated blobs on the board and ask for the boundary. Somebody will draw a line. Ask whether another line would have been equally good, and keep asking until the room sees that there are infinitely many, all with identical training error.</a:t>
+            </a:r>
+          </a:p>
+          <a:p>
+            <a:pPr lvl="0" indent="0" marL="0">
+              <a:buNone/>
+            </a:pPr>
+          </a:p>
+          <a:p>
+            <a:pPr lvl="0" indent="0" marL="0">
+              <a:buNone/>
+            </a:pPr>
+            <a:r>
+              <a:rPr/>
+              <a:t>So the error cannot decide. Something else has to. Logistic regression breaks the tie with log loss - a perfectly respectable answer, and one answer among several. The SVM breaks it differently: take the boundary with the most room around it.</a:t>
+            </a:r>
+          </a:p>
+          <a:p>
+            <a:pPr lvl="0" indent="0" marL="0">
+              <a:buNone/>
+            </a:pPr>
+          </a:p>
+          <a:p>
+            <a:pPr lvl="0" indent="0" marL="0">
+              <a:buNone/>
+            </a:pPr>
+            <a:r>
+              <a:rPr/>
+              <a:t>The intuition, and this is the sentence to say slowly: maximising the distance to the closest points chooses the boundary that tolerates the most movement in the data before it changes its mind. That is a statement about GENERALISATION, not about fit - which is unusual, because almost everything else in this course optimises fit and controls generalisation indirectly.</a:t>
+            </a:r>
+          </a:p>
+          <a:p>
+            <a:pPr lvl="0" indent="0" marL="0">
+              <a:buNone/>
+            </a:pPr>
+          </a:p>
+          <a:p>
+            <a:pPr lvl="0" indent="0" marL="0">
+              <a:buNone/>
+            </a:pPr>
+            <a:r>
+              <a:rPr/>
+              <a:t>Handout section 5.1.</a:t>
             </a:r>
           </a:p>
         </p:txBody>
@@ -4875,49 +4876,49 @@
             </a:pPr>
             <a:r>
               <a:rPr/>
-              <a:t>The point worth stressing is why the soft margin is not a patch or a convenience. With even one mislabelled point inside the other class, the strict problem is INFEASIBLE - there is no solution, not a bad one. Real data always contains such points. So the soft margin is the only version anyone ever runs; the hard-margin problem is a teaching device.</a:t>
-            </a:r>
-          </a:p>
-          <a:p>
-            <a:pPr lvl="0" indent="0" marL="0">
-              <a:buNone/>
-            </a:pPr>
-          </a:p>
-          <a:p>
-            <a:pPr lvl="0" indent="0" marL="0">
-              <a:buNone/>
-            </a:pPr>
-            <a:r>
-              <a:rPr/>
-              <a:t>Our own labels are flipped at 4%, deliberately, so this is not a hypothetical for this dataset: the hard-margin problem on these pumps has no answer.</a:t>
-            </a:r>
-          </a:p>
-          <a:p>
-            <a:pPr lvl="0" indent="0" marL="0">
-              <a:buNone/>
-            </a:pPr>
-          </a:p>
-          <a:p>
-            <a:pPr lvl="0" indent="0" marL="0">
-              <a:buNone/>
-            </a:pPr>
-            <a:r>
-              <a:rPr/>
-              <a:t>Then read the three cases of the slack aloud, because they come back twice: in the weights the training produces, and in who gets a vote at prediction. Put it next to lesson 4’s log loss: that one shrinks for a well-classified point but never reaches zero, so every row keeps pulling. The hinge reaches zero, and a point with zero loss drops out of the answer entirely.</a:t>
-            </a:r>
-          </a:p>
-          <a:p>
-            <a:pPr lvl="0" indent="0" marL="0">
-              <a:buNone/>
-            </a:pPr>
-          </a:p>
-          <a:p>
-            <a:pPr lvl="0" indent="0" marL="0">
-              <a:buNone/>
-            </a:pPr>
-            <a:r>
-              <a:rPr/>
-              <a:t>The next slide puts it in symbols. Handout section 5.2 has the derivation.</a:t>
+              <a:t>The solid line is the boundary, the dashed lines are the edges of the slab, and the circled points are the support vectors touching it.</a:t>
+            </a:r>
+          </a:p>
+          <a:p>
+            <a:pPr lvl="0" indent="0" marL="0">
+              <a:buNone/>
+            </a:pPr>
+          </a:p>
+          <a:p>
+            <a:pPr lvl="0" indent="0" marL="0">
+              <a:buNone/>
+            </a:pPr>
+            <a:r>
+              <a:rPr/>
+              <a:t>The number to say out loud: of eighty points, THREE determine the answer. Move any of the other seventy-seven - anywhere, as far as you like, as long as they stay outside the slab - and the boundary does not shift by a millimetre.</a:t>
+            </a:r>
+          </a:p>
+          <a:p>
+            <a:pPr lvl="0" indent="0" marL="0">
+              <a:buNone/>
+            </a:pPr>
+          </a:p>
+          <a:p>
+            <a:pPr lvl="0" indent="0" marL="0">
+              <a:buNone/>
+            </a:pPr>
+            <a:r>
+              <a:rPr/>
+              <a:t>That is where the name comes from, and it is a genuinely different idea from anything so far. Every linear model in lessons 3 and 4 used every row: each one contributed to the gradient in proportion to its error. Here most of the data is irrelevant once the fit is done.</a:t>
+            </a:r>
+          </a:p>
+          <a:p>
+            <a:pPr lvl="0" indent="0" marL="0">
+              <a:buNone/>
+            </a:pPr>
+          </a:p>
+          <a:p>
+            <a:pPr lvl="0" indent="0" marL="0">
+              <a:buNone/>
+            </a:pPr>
+            <a:r>
+              <a:rPr/>
+              <a:t>Two consequences worth naming. The model is small - you store the support vectors, not the dataset, which is the contrast with k-NN. And it is sensitive in a specific way: an outlier near the boundary matters enormously, while an outlier far from it matters not at all.</a:t>
             </a:r>
           </a:p>
         </p:txBody>
@@ -4999,49 +5000,49 @@
             </a:pPr>
             <a:r>
               <a:rPr/>
-              <a:t>The constraint is not on the slide any more - it made the line wide enough to land at 28pt - so state it: subject to y_i(w’x_i + b) &gt;= 1 - xi_i, every point on the right side of the slab by a margin, or paying xi_i for the shortfall. Handout section 5.2 writes it out.</a:t>
-            </a:r>
-          </a:p>
-          <a:p>
-            <a:pPr lvl="0" indent="0" marL="0">
-              <a:buNone/>
-            </a:pPr>
-          </a:p>
-          <a:p>
-            <a:pPr lvl="0" indent="0" marL="0">
-              <a:buNone/>
-            </a:pPr>
-            <a:r>
-              <a:rPr/>
-              <a:t>Do not derive this. State what each piece is doing and move on - handout section 5.2 has the derivation, including why maximising the margin is the same as minimising the norm of w.</a:t>
-            </a:r>
-          </a:p>
-          <a:p>
-            <a:pPr lvl="0" indent="0" marL="0">
-              <a:buNone/>
-            </a:pPr>
-          </a:p>
-          <a:p>
-            <a:pPr lvl="0" indent="0" marL="0">
-              <a:buNone/>
-            </a:pPr>
-            <a:r>
-              <a:rPr/>
-              <a:t>The first term wants a wide slab. The second term wants few violations. C sets the exchange rate between them, and that is the entire content of the expression. Read it out in those words rather than reading the symbols.</a:t>
-            </a:r>
-          </a:p>
-          <a:p>
-            <a:pPr lvl="0" indent="0" marL="0">
-              <a:buNone/>
-            </a:pPr>
-          </a:p>
-          <a:p>
-            <a:pPr lvl="0" indent="0" marL="0">
-              <a:buNone/>
-            </a:pPr>
-            <a:r>
-              <a:rPr/>
-              <a:t>If someone asks about the half in front of the norm: it is there to make the derivative tidy, exactly as in lesson 3’s cost function.</a:t>
+              <a:t>The point worth stressing is why the soft margin is not a patch or a convenience. With even one mislabelled point inside the other class, the strict problem is INFEASIBLE - there is no solution, not a bad one. Real data always contains such points. So the soft margin is the only version anyone ever runs; the hard-margin problem is a teaching device.</a:t>
+            </a:r>
+          </a:p>
+          <a:p>
+            <a:pPr lvl="0" indent="0" marL="0">
+              <a:buNone/>
+            </a:pPr>
+          </a:p>
+          <a:p>
+            <a:pPr lvl="0" indent="0" marL="0">
+              <a:buNone/>
+            </a:pPr>
+            <a:r>
+              <a:rPr/>
+              <a:t>Our own labels are flipped at 4%, deliberately, so this is not a hypothetical for this dataset: the hard-margin problem on these pumps has no answer.</a:t>
+            </a:r>
+          </a:p>
+          <a:p>
+            <a:pPr lvl="0" indent="0" marL="0">
+              <a:buNone/>
+            </a:pPr>
+          </a:p>
+          <a:p>
+            <a:pPr lvl="0" indent="0" marL="0">
+              <a:buNone/>
+            </a:pPr>
+            <a:r>
+              <a:rPr/>
+              <a:t>Then read the three cases of the slack aloud, because they come back twice: in the weights the training produces, and in who gets a vote at prediction. Put it next to lesson 4’s log loss: that one shrinks for a well-classified point but never reaches zero, so every row keeps pulling. The hinge reaches zero, and a point with zero loss drops out of the answer entirely.</a:t>
+            </a:r>
+          </a:p>
+          <a:p>
+            <a:pPr lvl="0" indent="0" marL="0">
+              <a:buNone/>
+            </a:pPr>
+          </a:p>
+          <a:p>
+            <a:pPr lvl="0" indent="0" marL="0">
+              <a:buNone/>
+            </a:pPr>
+            <a:r>
+              <a:rPr/>
+              <a:t>The next slide puts it in symbols. Handout section 5.2 has the derivation.</a:t>
             </a:r>
           </a:p>
         </p:txBody>
@@ -5123,55 +5124,49 @@
             </a:pPr>
             <a:r>
               <a:rPr/>
-              <a:t>Third appearance of the same idea, and say so - that repetition is the point. Lesson 3 had λ, this morning had k, now C. Every model has one knob that trades fitting this data against surviving the next, and recognising it in an unfamiliar model is worth more than memorising three names.</a:t>
-            </a:r>
-          </a:p>
-          <a:p>
-            <a:pPr lvl="0" indent="0" marL="0">
-              <a:buNone/>
-            </a:pPr>
-          </a:p>
-          <a:p>
-            <a:pPr lvl="0" indent="0" marL="0">
-              <a:buNone/>
-            </a:pPr>
-            <a:r>
-              <a:rPr/>
-              <a:t>Then the direction, which catches people out constantly and is worth writing on the board. Large λ means MORE regularisation. Large C means LESS. They run opposite ways, and scikit-learn’s </a:t>
-            </a:r>
-            <a:r>
-              <a:rPr>
-                <a:latin typeface="Courier"/>
-              </a:rPr>
-              <a:t>C</a:t>
-            </a:r>
-            <a:r>
-              <a:rPr/>
-              <a:t> parameter in </a:t>
-            </a:r>
-            <a:r>
-              <a:rPr>
-                <a:latin typeface="Courier"/>
-              </a:rPr>
-              <a:t>LogisticRegression</a:t>
-            </a:r>
-            <a:r>
-              <a:rPr/>
-              <a:t> has the same inverted convention - it is the reciprocal of the penalty there too.</a:t>
-            </a:r>
-          </a:p>
-          <a:p>
-            <a:pPr lvl="0" indent="0" marL="0">
-              <a:buNone/>
-            </a:pPr>
-          </a:p>
-          <a:p>
-            <a:pPr lvl="0" indent="0" marL="0">
-              <a:buNone/>
-            </a:pPr>
-            <a:r>
-              <a:rPr/>
-              <a:t>Ask them which way they would expect C to run before you tell them. Most guess wrong, and having guessed wrong once is what makes it stick.</a:t>
+              <a:t>The constraint is not on the slide any more - it made the line wide enough to land at 28pt - so state it: subject to y_i(w’x_i + b) &gt;= 1 - xi_i, every point on the right side of the slab by a margin, or paying xi_i for the shortfall. Handout section 5.2 writes it out.</a:t>
+            </a:r>
+          </a:p>
+          <a:p>
+            <a:pPr lvl="0" indent="0" marL="0">
+              <a:buNone/>
+            </a:pPr>
+          </a:p>
+          <a:p>
+            <a:pPr lvl="0" indent="0" marL="0">
+              <a:buNone/>
+            </a:pPr>
+            <a:r>
+              <a:rPr/>
+              <a:t>Do not derive this. State what each piece is doing and move on - handout section 5.2 has the derivation, including why maximising the margin is the same as minimising the norm of w.</a:t>
+            </a:r>
+          </a:p>
+          <a:p>
+            <a:pPr lvl="0" indent="0" marL="0">
+              <a:buNone/>
+            </a:pPr>
+          </a:p>
+          <a:p>
+            <a:pPr lvl="0" indent="0" marL="0">
+              <a:buNone/>
+            </a:pPr>
+            <a:r>
+              <a:rPr/>
+              <a:t>The first term wants a wide slab. The second term wants few violations. C sets the exchange rate between them, and that is the entire content of the expression. Read it out in those words rather than reading the symbols.</a:t>
+            </a:r>
+          </a:p>
+          <a:p>
+            <a:pPr lvl="0" indent="0" marL="0">
+              <a:buNone/>
+            </a:pPr>
+          </a:p>
+          <a:p>
+            <a:pPr lvl="0" indent="0" marL="0">
+              <a:buNone/>
+            </a:pPr>
+            <a:r>
+              <a:rPr/>
+              <a:t>If someone asks about the half in front of the norm: it is there to make the derivative tidy, exactly as in lesson 3’s cost function.</a:t>
             </a:r>
           </a:p>
         </p:txBody>
@@ -5253,49 +5248,55 @@
             </a:pPr>
             <a:r>
               <a:rPr/>
-              <a:t>The linear kernel scores 0.613 - the base rate, exactly as logistic regression did this morning, with the same zero variance across folds.</a:t>
-            </a:r>
-          </a:p>
-          <a:p>
-            <a:pPr lvl="0" indent="0" marL="0">
-              <a:buNone/>
-            </a:pPr>
-          </a:p>
-          <a:p>
-            <a:pPr lvl="0" indent="0" marL="0">
-              <a:buNone/>
-            </a:pPr>
-            <a:r>
-              <a:rPr/>
-              <a:t>Make the point explicitly, because it is the one students most often get backwards: the margin criterion is a better way of CHOOSING among straight lines. It does not give you anything other than a straight line. When no straight line works, choosing the best one optimally still gets you nothing. A better criterion cannot rescue an inadequate hypothesis class.</a:t>
-            </a:r>
-          </a:p>
-          <a:p>
-            <a:pPr lvl="0" indent="0" marL="0">
-              <a:buNone/>
-            </a:pPr>
-          </a:p>
-          <a:p>
-            <a:pPr lvl="0" indent="0" marL="0">
-              <a:buNone/>
-            </a:pPr>
-            <a:r>
-              <a:rPr/>
-              <a:t>Then the RBF row, which is the same algorithm with one argument changed, at 0.947 - the best number in the whole lesson, and within a hair of the 0.96 ceiling.</a:t>
-            </a:r>
-          </a:p>
-          <a:p>
-            <a:pPr lvl="0" indent="0" marL="0">
-              <a:buNone/>
-            </a:pPr>
-          </a:p>
-          <a:p>
-            <a:pPr lvl="0" indent="0" marL="0">
-              <a:buNone/>
-            </a:pPr>
-            <a:r>
-              <a:rPr/>
-              <a:t>The support-vector column says the same thing in a second language, and that is the next slide.</a:t>
+              <a:t>Third appearance of the same idea, and say so - that repetition is the point. Lesson 3 had λ, this morning had k, now C. Every model has one knob that trades fitting this data against surviving the next, and recognising it in an unfamiliar model is worth more than memorising three names.</a:t>
+            </a:r>
+          </a:p>
+          <a:p>
+            <a:pPr lvl="0" indent="0" marL="0">
+              <a:buNone/>
+            </a:pPr>
+          </a:p>
+          <a:p>
+            <a:pPr lvl="0" indent="0" marL="0">
+              <a:buNone/>
+            </a:pPr>
+            <a:r>
+              <a:rPr/>
+              <a:t>Then the direction, which catches people out constantly and is worth writing on the board. Large λ means MORE regularisation. Large C means LESS. They run opposite ways, and scikit-learn’s </a:t>
+            </a:r>
+            <a:r>
+              <a:rPr>
+                <a:latin typeface="Courier"/>
+              </a:rPr>
+              <a:t>C</a:t>
+            </a:r>
+            <a:r>
+              <a:rPr/>
+              <a:t> parameter in </a:t>
+            </a:r>
+            <a:r>
+              <a:rPr>
+                <a:latin typeface="Courier"/>
+              </a:rPr>
+              <a:t>LogisticRegression</a:t>
+            </a:r>
+            <a:r>
+              <a:rPr/>
+              <a:t> has the same inverted convention - it is the reciprocal of the penalty there too.</a:t>
+            </a:r>
+          </a:p>
+          <a:p>
+            <a:pPr lvl="0" indent="0" marL="0">
+              <a:buNone/>
+            </a:pPr>
+          </a:p>
+          <a:p>
+            <a:pPr lvl="0" indent="0" marL="0">
+              <a:buNone/>
+            </a:pPr>
+            <a:r>
+              <a:rPr/>
+              <a:t>Ask them which way they would expect C to run before you tell them. Most guess wrong, and having guessed wrong once is what makes it stick.</a:t>
             </a:r>
           </a:p>
         </p:txBody>
@@ -5377,59 +5378,49 @@
             </a:pPr>
             <a:r>
               <a:rPr/>
-              <a:t>Explain what 79% actually means geometrically. A support vector is a point on the margin or inside it. If 79% of your data is in that position, there is no region of empty space between the classes at all - the model has been forced to place a boundary through a crowd.</a:t>
-            </a:r>
-          </a:p>
-          <a:p>
-            <a:pPr lvl="0" indent="0" marL="0">
-              <a:buNone/>
-            </a:pPr>
-          </a:p>
-          <a:p>
-            <a:pPr lvl="0" indent="0" marL="0">
-              <a:buNone/>
-            </a:pPr>
-            <a:r>
-              <a:rPr/>
-              <a:t>Contrast with 23%, where the model found genuine room and only the points near the edge matter.</a:t>
-            </a:r>
-          </a:p>
-          <a:p>
-            <a:pPr lvl="0" indent="0" marL="0">
-              <a:buNone/>
-            </a:pPr>
-          </a:p>
-          <a:p>
-            <a:pPr lvl="0" indent="0" marL="0">
-              <a:buNone/>
-            </a:pPr>
-            <a:r>
-              <a:rPr/>
-              <a:t>Give them the diagnostic to keep, since it costs nothing: after fitting an SVM, look at </a:t>
-            </a:r>
-            <a:r>
-              <a:rPr>
-                <a:latin typeface="Courier"/>
-              </a:rPr>
-              <a:t>len(model.support_)</a:t>
-            </a:r>
-            <a:r>
-              <a:rPr/>
-              <a:t> over the number of training rows. High means the model is struggling to find room, which usually means the kernel is wrong for the geometry. It is a warning available BEFORE you cross-validate anything.</a:t>
-            </a:r>
-          </a:p>
-          <a:p>
-            <a:pPr lvl="0" indent="0" marL="0">
-              <a:buNone/>
-            </a:pPr>
-          </a:p>
-          <a:p>
-            <a:pPr lvl="0" indent="0" marL="0">
-              <a:buNone/>
-            </a:pPr>
-            <a:r>
-              <a:rPr/>
-              <a:t>Worth adding that it also predicts prediction cost - every support vector is one kernel evaluation per query, so a model needing 79% of the data has thrown away most of the speed advantage over k-NN.</a:t>
+              <a:t>The linear kernel scores 0.613 - the base rate, exactly as logistic regression did this morning, with the same zero variance across folds.</a:t>
+            </a:r>
+          </a:p>
+          <a:p>
+            <a:pPr lvl="0" indent="0" marL="0">
+              <a:buNone/>
+            </a:pPr>
+          </a:p>
+          <a:p>
+            <a:pPr lvl="0" indent="0" marL="0">
+              <a:buNone/>
+            </a:pPr>
+            <a:r>
+              <a:rPr/>
+              <a:t>Make the point explicitly, because it is the one students most often get backwards: the margin criterion is a better way of CHOOSING among straight lines. It does not give you anything other than a straight line. When no straight line works, choosing the best one optimally still gets you nothing. A better criterion cannot rescue an inadequate hypothesis class.</a:t>
+            </a:r>
+          </a:p>
+          <a:p>
+            <a:pPr lvl="0" indent="0" marL="0">
+              <a:buNone/>
+            </a:pPr>
+          </a:p>
+          <a:p>
+            <a:pPr lvl="0" indent="0" marL="0">
+              <a:buNone/>
+            </a:pPr>
+            <a:r>
+              <a:rPr/>
+              <a:t>Then the RBF row, which is the same algorithm with one argument changed, at 0.947 - the best number in the whole lesson, and within a hair of the 0.96 ceiling.</a:t>
+            </a:r>
+          </a:p>
+          <a:p>
+            <a:pPr lvl="0" indent="0" marL="0">
+              <a:buNone/>
+            </a:pPr>
+          </a:p>
+          <a:p>
+            <a:pPr lvl="0" indent="0" marL="0">
+              <a:buNone/>
+            </a:pPr>
+            <a:r>
+              <a:rPr/>
+              <a:t>The support-vector column says the same thing in a second language, and that is the next slide.</a:t>
             </a:r>
           </a:p>
         </p:txBody>
@@ -5511,49 +5502,59 @@
             </a:pPr>
             <a:r>
               <a:rPr/>
-              <a:t>Build the picture in words first and let them see it before the figure appears. Take the scatter plot from the start of the lesson, lift each point off the page by its distance from the centre, and look from the side.</a:t>
-            </a:r>
-          </a:p>
-          <a:p>
-            <a:pPr lvl="0" indent="0" marL="0">
-              <a:buNone/>
-            </a:pPr>
-          </a:p>
-          <a:p>
-            <a:pPr lvl="0" indent="0" marL="0">
-              <a:buNone/>
-            </a:pPr>
-            <a:r>
-              <a:rPr/>
-              <a:t>Then the sentence that reframes the whole afternoon: the classes were never inseparable. Separability is not a property of the data - it is a property of the data AND the coordinates you happen to have measured it in.</a:t>
-            </a:r>
-          </a:p>
-          <a:p>
-            <a:pPr lvl="0" indent="0" marL="0">
-              <a:buNone/>
-            </a:pPr>
-          </a:p>
-          <a:p>
-            <a:pPr lvl="0" indent="0" marL="0">
-              <a:buNone/>
-            </a:pPr>
-            <a:r>
-              <a:rPr/>
-              <a:t>Ask what is unsatisfying about what we just did, and wait for it. We chose that lift by already knowing the answer. We knew the fault mode was radial. In any real problem you do not, and inventing the right coordinate is the hard part - which is exactly the difficulty the kernel trick removes.</a:t>
-            </a:r>
-          </a:p>
-          <a:p>
-            <a:pPr lvl="0" indent="0" marL="0">
-              <a:buNone/>
-            </a:pPr>
-          </a:p>
-          <a:p>
-            <a:pPr lvl="0" indent="0" marL="0">
-              <a:buNone/>
-            </a:pPr>
-            <a:r>
-              <a:rPr/>
-              <a:t>Handout section 5.4.</a:t>
+              <a:t>Explain what 79% actually means geometrically. A support vector is a point on the margin or inside it. If 79% of your data is in that position, there is no region of empty space between the classes at all - the model has been forced to place a boundary through a crowd.</a:t>
+            </a:r>
+          </a:p>
+          <a:p>
+            <a:pPr lvl="0" indent="0" marL="0">
+              <a:buNone/>
+            </a:pPr>
+          </a:p>
+          <a:p>
+            <a:pPr lvl="0" indent="0" marL="0">
+              <a:buNone/>
+            </a:pPr>
+            <a:r>
+              <a:rPr/>
+              <a:t>Contrast with 23%, where the model found genuine room and only the points near the edge matter.</a:t>
+            </a:r>
+          </a:p>
+          <a:p>
+            <a:pPr lvl="0" indent="0" marL="0">
+              <a:buNone/>
+            </a:pPr>
+          </a:p>
+          <a:p>
+            <a:pPr lvl="0" indent="0" marL="0">
+              <a:buNone/>
+            </a:pPr>
+            <a:r>
+              <a:rPr/>
+              <a:t>Give them the diagnostic to keep, since it costs nothing: after fitting an SVM, look at </a:t>
+            </a:r>
+            <a:r>
+              <a:rPr>
+                <a:latin typeface="Courier"/>
+              </a:rPr>
+              <a:t>len(model.support_)</a:t>
+            </a:r>
+            <a:r>
+              <a:rPr/>
+              <a:t> over the number of training rows. High means the model is struggling to find room, which usually means the kernel is wrong for the geometry. It is a warning available BEFORE you cross-validate anything.</a:t>
+            </a:r>
+          </a:p>
+          <a:p>
+            <a:pPr lvl="0" indent="0" marL="0">
+              <a:buNone/>
+            </a:pPr>
+          </a:p>
+          <a:p>
+            <a:pPr lvl="0" indent="0" marL="0">
+              <a:buNone/>
+            </a:pPr>
+            <a:r>
+              <a:rPr/>
+              <a:t>Worth adding that it also predicts prediction cost - every support vector is one kernel evaluation per query, so a model needing 79% of the data has thrown away most of the speed advantage over k-NN.</a:t>
             </a:r>
           </a:p>
         </p:txBody>
@@ -5635,35 +5636,49 @@
             </a:pPr>
             <a:r>
               <a:rPr/>
-              <a:t>The same 1,200 pumps twice: on the left in the plane where they were measured, on the right lifted by their distance from the design point. The gold plane does what no line could.</a:t>
-            </a:r>
-          </a:p>
-          <a:p>
-            <a:pPr lvl="0" indent="0" marL="0">
-              <a:buNone/>
-            </a:pPr>
-          </a:p>
-          <a:p>
-            <a:pPr lvl="0" indent="0" marL="0">
-              <a:buNone/>
-            </a:pPr>
-            <a:r>
-              <a:rPr/>
-              <a:t>Have them look at the right panel and confirm for themselves that a flat horizontal cut separates the colours cleanly. Nothing was added - no new measurement, no extra sensor. The third coordinate is computed from the two they already had.</a:t>
-            </a:r>
-          </a:p>
-          <a:p>
-            <a:pPr lvl="0" indent="0" marL="0">
-              <a:buNone/>
-            </a:pPr>
-          </a:p>
-          <a:p>
-            <a:pPr lvl="0" indent="0" marL="0">
-              <a:buNone/>
-            </a:pPr>
-            <a:r>
-              <a:rPr/>
-              <a:t>Then set up the objection that the next slide answers. This worked because the lift was three-dimensional and we could guess it. The spaces that work in general are enormous - the useful ones are sometimes infinite-dimensional - and computing the coordinates of every point in such a space is impossible.</a:t>
+              <a:t>Build the picture in words first and let them see it before the figure appears. Take the scatter plot from the start of the lesson, lift each point off the page by its distance from the centre, and look from the side.</a:t>
+            </a:r>
+          </a:p>
+          <a:p>
+            <a:pPr lvl="0" indent="0" marL="0">
+              <a:buNone/>
+            </a:pPr>
+          </a:p>
+          <a:p>
+            <a:pPr lvl="0" indent="0" marL="0">
+              <a:buNone/>
+            </a:pPr>
+            <a:r>
+              <a:rPr/>
+              <a:t>Then the sentence that reframes the whole afternoon: the classes were never inseparable. Separability is not a property of the data - it is a property of the data AND the coordinates you happen to have measured it in.</a:t>
+            </a:r>
+          </a:p>
+          <a:p>
+            <a:pPr lvl="0" indent="0" marL="0">
+              <a:buNone/>
+            </a:pPr>
+          </a:p>
+          <a:p>
+            <a:pPr lvl="0" indent="0" marL="0">
+              <a:buNone/>
+            </a:pPr>
+            <a:r>
+              <a:rPr/>
+              <a:t>Ask what is unsatisfying about what we just did, and wait for it. We chose that lift by already knowing the answer. We knew the fault mode was radial. In any real problem you do not, and inventing the right coordinate is the hard part - which is exactly the difficulty the kernel trick removes.</a:t>
+            </a:r>
+          </a:p>
+          <a:p>
+            <a:pPr lvl="0" indent="0" marL="0">
+              <a:buNone/>
+            </a:pPr>
+          </a:p>
+          <a:p>
+            <a:pPr lvl="0" indent="0" marL="0">
+              <a:buNone/>
+            </a:pPr>
+            <a:r>
+              <a:rPr/>
+              <a:t>Handout section 5.4.</a:t>
             </a:r>
           </a:p>
         </p:txBody>
@@ -5745,35 +5760,35 @@
             </a:pPr>
             <a:r>
               <a:rPr/>
-              <a:t>The trick in one sentence: the SVM never needs the coordinates, only the angles and lengths between points, and those can be obtained without ever going there.</a:t>
-            </a:r>
-          </a:p>
-          <a:p>
-            <a:pPr lvl="0" indent="0" marL="0">
-              <a:buNone/>
-            </a:pPr>
-          </a:p>
-          <a:p>
-            <a:pPr lvl="0" indent="0" marL="0">
-              <a:buNone/>
-            </a:pPr>
-            <a:r>
-              <a:rPr/>
-              <a:t>Do not prove it - handout section 5.4 shows where the inner products come from in the dual formulation. The claim to state and let land is that a function of two ordinary two-dimensional vectors returns their inner product in a space of infinite dimension, at the cost of one exponential.</a:t>
-            </a:r>
-          </a:p>
-          <a:p>
-            <a:pPr lvl="0" indent="0" marL="0">
-              <a:buNone/>
-            </a:pPr>
-          </a:p>
-          <a:p>
-            <a:pPr lvl="0" indent="0" marL="0">
-              <a:buNone/>
-            </a:pPr>
-            <a:r>
-              <a:rPr/>
-              <a:t>And close the loop from the previous slide: we chose the lift in the picture by knowing the answer. The RBF kernel does something equivalent without being told, which is exactly why it works on problems where nobody could guess the right coordinates.</a:t>
+              <a:t>The same 1,200 pumps twice: on the left in the plane where they were measured, on the right lifted by their distance from the design point. The gold plane does what no line could.</a:t>
+            </a:r>
+          </a:p>
+          <a:p>
+            <a:pPr lvl="0" indent="0" marL="0">
+              <a:buNone/>
+            </a:pPr>
+          </a:p>
+          <a:p>
+            <a:pPr lvl="0" indent="0" marL="0">
+              <a:buNone/>
+            </a:pPr>
+            <a:r>
+              <a:rPr/>
+              <a:t>Have them look at the right panel and confirm for themselves that a flat horizontal cut separates the colours cleanly. Nothing was added - no new measurement, no extra sensor. The third coordinate is computed from the two they already had.</a:t>
+            </a:r>
+          </a:p>
+          <a:p>
+            <a:pPr lvl="0" indent="0" marL="0">
+              <a:buNone/>
+            </a:pPr>
+          </a:p>
+          <a:p>
+            <a:pPr lvl="0" indent="0" marL="0">
+              <a:buNone/>
+            </a:pPr>
+            <a:r>
+              <a:rPr/>
+              <a:t>Then set up the objection that the next slide answers. This worked because the lift was three-dimensional and we could guess it. The spaces that work in general are enormous - the useful ones are sometimes infinite-dimensional - and computing the coordinates of every point in such a space is impossible.</a:t>
             </a:r>
           </a:p>
         </p:txBody>
@@ -5855,35 +5870,35 @@
             </a:pPr>
             <a:r>
               <a:rPr/>
-              <a:t>Make the trick concrete before the famous formula. The lift here lists every product of two coordinates: phi(x) = (x1², √2·x1·x2, x2²). Two points, a = (1, 2) and b = (3, 1).</a:t>
-            </a:r>
-          </a:p>
-          <a:p>
-            <a:pPr lvl="0" indent="0" marL="0">
-              <a:buNone/>
-            </a:pPr>
-          </a:p>
-          <a:p>
-            <a:pPr lvl="0" indent="0" marL="0">
-              <a:buNone/>
-            </a:pPr>
-            <a:r>
-              <a:rPr/>
-              <a:t>First row: lift both into three dimensions and take the ordinary inner product - 9 + 12 + 4 = 25. Second row: never lift, take the inner product in the plane, 5, and square it - 25. Same number. The second route never left two dimensions, so the function (a · b)² IS the inner product in the lifted space. That is all a kernel is.</a:t>
-            </a:r>
-          </a:p>
-          <a:p>
-            <a:pPr lvl="0" indent="0" marL="0">
-              <a:buNone/>
-            </a:pPr>
-          </a:p>
-          <a:p>
-            <a:pPr lvl="0" indent="0" marL="0">
-              <a:buNone/>
-            </a:pPr>
-            <a:r>
-              <a:rPr/>
-              <a:t>Then connect it to the figure they just saw: the lifted space contains x1² and x2², and their sum is the squared distance from the centre - the coordinate we chose by hand. A flat plane there is a circle down here. The kernel found the lift we had to guess. Handout section 5.4.</a:t>
+              <a:t>The trick in one sentence: the SVM never needs the coordinates, only the angles and lengths between points, and those can be obtained without ever going there.</a:t>
+            </a:r>
+          </a:p>
+          <a:p>
+            <a:pPr lvl="0" indent="0" marL="0">
+              <a:buNone/>
+            </a:pPr>
+          </a:p>
+          <a:p>
+            <a:pPr lvl="0" indent="0" marL="0">
+              <a:buNone/>
+            </a:pPr>
+            <a:r>
+              <a:rPr/>
+              <a:t>Do not prove it - handout section 5.4 shows where the inner products come from in the dual formulation. The claim to state and let land is that a function of two ordinary two-dimensional vectors returns their inner product in a space of infinite dimension, at the cost of one exponential.</a:t>
+            </a:r>
+          </a:p>
+          <a:p>
+            <a:pPr lvl="0" indent="0" marL="0">
+              <a:buNone/>
+            </a:pPr>
+          </a:p>
+          <a:p>
+            <a:pPr lvl="0" indent="0" marL="0">
+              <a:buNone/>
+            </a:pPr>
+            <a:r>
+              <a:rPr/>
+              <a:t>And close the loop from the previous slide: we chose the lift in the picture by knowing the answer. The RBF kernel does something equivalent without being told, which is exactly why it works on problems where nobody could guess the right coordinates.</a:t>
             </a:r>
           </a:p>
         </p:txBody>
@@ -6097,73 +6112,35 @@
             </a:pPr>
             <a:r>
               <a:rPr/>
-              <a:t>One line, and it is the whole of what scikit-learn does when you leave </a:t>
-            </a:r>
-            <a:r>
-              <a:rPr>
-                <a:latin typeface="Courier"/>
-              </a:rPr>
-              <a:t>kernel</a:t>
-            </a:r>
-            <a:r>
-              <a:rPr/>
-              <a:t> at its default.</a:t>
-            </a:r>
-          </a:p>
-          <a:p>
-            <a:pPr lvl="0" indent="0" marL="0">
-              <a:buNone/>
-            </a:pPr>
-          </a:p>
-          <a:p>
-            <a:pPr lvl="0" indent="0" marL="0">
-              <a:buNone/>
-            </a:pPr>
-            <a:r>
-              <a:rPr/>
-              <a:t>Read it aloud as a similarity rather than as a formula: the closer two points are, the nearer the exponent is to zero and the nearer the kernel is to one; far apart, it falls away to nothing. That is all an RBF kernel says - how much does this point look like that one.</a:t>
-            </a:r>
-          </a:p>
-          <a:p>
-            <a:pPr lvl="0" indent="0" marL="0">
-              <a:buNone/>
-            </a:pPr>
-          </a:p>
-          <a:p>
-            <a:pPr lvl="0" indent="0" marL="0">
-              <a:buNone/>
-            </a:pPr>
-            <a:r>
-              <a:rPr/>
-              <a:t>Now say what γ means, because the next two slides turn on it: it sets how far a single training point’s influence reaches. Small γ, wide reach, smooth boundary. Large γ, each point influences only its immediate neighbourhood - and a boundary that can afford an island around every mislabelled pump.</a:t>
-            </a:r>
-          </a:p>
-          <a:p>
-            <a:pPr lvl="0" indent="0" marL="0">
-              <a:buNone/>
-            </a:pPr>
-          </a:p>
-          <a:p>
-            <a:pPr lvl="0" indent="0" marL="0">
-              <a:buNone/>
-            </a:pPr>
-            <a:r>
-              <a:rPr/>
-              <a:t>A number to anchor it: the similarity halves at a distance of sqrt(ln 2 / γ). For scikit-learn’s default on the standardised pumps, γ = 0.5, that is about 1.2 standard deviations.</a:t>
-            </a:r>
-          </a:p>
-          <a:p>
-            <a:pPr lvl="0" indent="0" marL="0">
-              <a:buNone/>
-            </a:pPr>
-          </a:p>
-          <a:p>
-            <a:pPr lvl="0" indent="0" marL="0">
-              <a:buNone/>
-            </a:pPr>
-            <a:r>
-              <a:rPr/>
-              <a:t>Worth naming the cost, since this is an engineering course: one exponential per pair of points, so the kernel matrix is m × m. That is why support vector machines are a poor fit above a hundred thousand rows, and it is a property of the method rather than of the implementation.</a:t>
+              <a:t>Make the trick concrete before the famous formula. The lift here lists every product of two coordinates: phi(x) = (x1², √2·x1·x2, x2²). Two points, a = (1, 2) and b = (3, 1).</a:t>
+            </a:r>
+          </a:p>
+          <a:p>
+            <a:pPr lvl="0" indent="0" marL="0">
+              <a:buNone/>
+            </a:pPr>
+          </a:p>
+          <a:p>
+            <a:pPr lvl="0" indent="0" marL="0">
+              <a:buNone/>
+            </a:pPr>
+            <a:r>
+              <a:rPr/>
+              <a:t>First row: lift both into three dimensions and take the ordinary inner product - 9 + 12 + 4 = 25. Second row: never lift, take the inner product in the plane, 5, and square it - 25. Same number. The second route never left two dimensions, so the function (a · b)² IS the inner product in the lifted space. That is all a kernel is.</a:t>
+            </a:r>
+          </a:p>
+          <a:p>
+            <a:pPr lvl="0" indent="0" marL="0">
+              <a:buNone/>
+            </a:pPr>
+          </a:p>
+          <a:p>
+            <a:pPr lvl="0" indent="0" marL="0">
+              <a:buNone/>
+            </a:pPr>
+            <a:r>
+              <a:rPr/>
+              <a:t>Then connect it to the figure they just saw: the lifted space contains x1² and x2², and their sum is the squared distance from the centre - the coordinate we chose by hand. A flat plane there is a circle down here. The kernel found the lift we had to guess. Handout section 5.4.</a:t>
             </a:r>
           </a:p>
         </p:txBody>
@@ -6245,35 +6222,73 @@
             </a:pPr>
             <a:r>
               <a:rPr/>
-              <a:t>Say what “fit” does, because after lesson 3 they will expect gradient descent. It is not. The SVM solves the dual: one weight per training point, found by a solver that picks two weights at a time - two, because the weights times the labels must sum to zero, so one cannot move alone - sets them to their best values with the rest fixed, and repeats until nothing improves. Convex, so there is one answer and it is found every time.</a:t>
-            </a:r>
-          </a:p>
-          <a:p>
-            <a:pPr lvl="0" indent="0" marL="0">
-              <a:buNone/>
-            </a:pPr>
-          </a:p>
-          <a:p>
-            <a:pPr lvl="0" indent="0" marL="0">
-              <a:buNone/>
-            </a:pPr>
-            <a:r>
-              <a:rPr/>
-              <a:t>Then the counts, which match the three cases of the slack from earlier. Weight zero: the 922 pumps safely on their own side, which the model now forgets. Weight at the ceiling C: the 268 inside the slab or on the wrong side - with C = 1 that weight is exactly 1, so each of them simply votes with its label. Between: the 10 sitting exactly on the edge.</a:t>
-            </a:r>
-          </a:p>
-          <a:p>
-            <a:pPr lvl="0" indent="0" marL="0">
-              <a:buNone/>
-            </a:pPr>
-          </a:p>
-          <a:p>
-            <a:pPr lvl="0" indent="0" marL="0">
-              <a:buNone/>
-            </a:pPr>
-            <a:r>
-              <a:rPr/>
-              <a:t>The model you ship is 278 points and their weights. Handout section 5.5.</a:t>
+              <a:t>One line, and it is the whole of what scikit-learn does when you leave </a:t>
+            </a:r>
+            <a:r>
+              <a:rPr>
+                <a:latin typeface="Courier"/>
+              </a:rPr>
+              <a:t>kernel</a:t>
+            </a:r>
+            <a:r>
+              <a:rPr/>
+              <a:t> at its default.</a:t>
+            </a:r>
+          </a:p>
+          <a:p>
+            <a:pPr lvl="0" indent="0" marL="0">
+              <a:buNone/>
+            </a:pPr>
+          </a:p>
+          <a:p>
+            <a:pPr lvl="0" indent="0" marL="0">
+              <a:buNone/>
+            </a:pPr>
+            <a:r>
+              <a:rPr/>
+              <a:t>Read it aloud as a similarity rather than as a formula: the closer two points are, the nearer the exponent is to zero and the nearer the kernel is to one; far apart, it falls away to nothing. That is all an RBF kernel says - how much does this point look like that one.</a:t>
+            </a:r>
+          </a:p>
+          <a:p>
+            <a:pPr lvl="0" indent="0" marL="0">
+              <a:buNone/>
+            </a:pPr>
+          </a:p>
+          <a:p>
+            <a:pPr lvl="0" indent="0" marL="0">
+              <a:buNone/>
+            </a:pPr>
+            <a:r>
+              <a:rPr/>
+              <a:t>Now say what γ means, because the next two slides turn on it: it sets how far a single training point’s influence reaches. Small γ, wide reach, smooth boundary. Large γ, each point influences only its immediate neighbourhood - and a boundary that can afford an island around every mislabelled pump.</a:t>
+            </a:r>
+          </a:p>
+          <a:p>
+            <a:pPr lvl="0" indent="0" marL="0">
+              <a:buNone/>
+            </a:pPr>
+          </a:p>
+          <a:p>
+            <a:pPr lvl="0" indent="0" marL="0">
+              <a:buNone/>
+            </a:pPr>
+            <a:r>
+              <a:rPr/>
+              <a:t>A number to anchor it: the similarity halves at a distance of sqrt(ln 2 / γ). For scikit-learn’s default on the standardised pumps, γ = 0.5, that is about 1.2 standard deviations.</a:t>
+            </a:r>
+          </a:p>
+          <a:p>
+            <a:pPr lvl="0" indent="0" marL="0">
+              <a:buNone/>
+            </a:pPr>
+          </a:p>
+          <a:p>
+            <a:pPr lvl="0" indent="0" marL="0">
+              <a:buNone/>
+            </a:pPr>
+            <a:r>
+              <a:rPr/>
+              <a:t>Worth naming the cost, since this is an engineering course: one exponential per pair of points, so the kernel matrix is m × m. That is why support vector machines are a poor fit above a hundred thousand rows, and it is a property of the method rather than of the implementation.</a:t>
             </a:r>
           </a:p>
         </p:txBody>
@@ -6355,35 +6370,35 @@
             </a:pPr>
             <a:r>
               <a:rPr/>
-              <a:t>Inference is a vote, in four steps. Standardise the pump with the training scaler. Compute its RBF similarity to each of the 278 support vectors. Add up weight times label times similarity - label +1 for faulty, -1 for healthy - and add b. Read the sign. Nothing else goes in: the total is exactly what decision_function returns.</a:t>
-            </a:r>
-          </a:p>
-          <a:p>
-            <a:pPr lvl="0" indent="0" marL="0">
-              <a:buNone/>
-            </a:pPr>
-          </a:p>
-          <a:p>
-            <a:pPr lvl="0" indent="0" marL="0">
-              <a:buNone/>
-            </a:pPr>
-            <a:r>
-              <a:rPr/>
-              <a:t>The same pump Naive Bayes called faulty at 0.981, reached by a completely different route.</a:t>
-            </a:r>
-          </a:p>
-          <a:p>
-            <a:pPr lvl="0" indent="0" marL="0">
-              <a:buNone/>
-            </a:pPr>
-          </a:p>
-          <a:p>
-            <a:pPr lvl="0" indent="0" marL="0">
-              <a:buNone/>
-            </a:pPr>
-            <a:r>
-              <a:rPr/>
-              <a:t>The point to make: the neighbourhood decides. The 56 support vectors within about 1.2 standard deviations contribute a net +1.141 towards faulty; the other 222 only -0.363. But not one neighbour - the five nearest disagree, because pumps just outside the envelope are faulty and some just inside carry flipped labels. So the SVM is k-NN again, with a smooth similarity instead of a hard k, only the support vectors voting, and learned weights. And the output is a score, not a probability. Handout section 5.5.</a:t>
+              <a:t>Say what “fit” does, because after lesson 3 they will expect gradient descent. It is not. The SVM solves the dual: one weight per training point, found by a solver that picks two weights at a time - two, because the weights times the labels must sum to zero, so one cannot move alone - sets them to their best values with the rest fixed, and repeats until nothing improves. Convex, so there is one answer and it is found every time.</a:t>
+            </a:r>
+          </a:p>
+          <a:p>
+            <a:pPr lvl="0" indent="0" marL="0">
+              <a:buNone/>
+            </a:pPr>
+          </a:p>
+          <a:p>
+            <a:pPr lvl="0" indent="0" marL="0">
+              <a:buNone/>
+            </a:pPr>
+            <a:r>
+              <a:rPr/>
+              <a:t>Then the counts, which match the three cases of the slack from earlier. Weight zero: the 922 pumps safely on their own side, which the model now forgets. Weight at the ceiling C: the 268 inside the slab or on the wrong side - with C = 1 that weight is exactly 1, so each of them simply votes with its label. Between: the 10 sitting exactly on the edge.</a:t>
+            </a:r>
+          </a:p>
+          <a:p>
+            <a:pPr lvl="0" indent="0" marL="0">
+              <a:buNone/>
+            </a:pPr>
+          </a:p>
+          <a:p>
+            <a:pPr lvl="0" indent="0" marL="0">
+              <a:buNone/>
+            </a:pPr>
+            <a:r>
+              <a:rPr/>
+              <a:t>The model you ship is 278 points and their weights. Handout section 5.5.</a:t>
             </a:r>
           </a:p>
         </p:txBody>
@@ -6465,53 +6480,35 @@
             </a:pPr>
             <a:r>
               <a:rPr/>
-              <a:t>Read the two columns against each other, exactly as lesson 5 taught, and let the last row do the work.</a:t>
-            </a:r>
-          </a:p>
-          <a:p>
-            <a:pPr lvl="0" indent="0" marL="0">
-              <a:buNone/>
-            </a:pPr>
-          </a:p>
-          <a:p>
-            <a:pPr lvl="0" indent="0" marL="0">
-              <a:buNone/>
-            </a:pPr>
-            <a:r>
-              <a:rPr/>
-              <a:t>The bottom row has the best training score on the slide - 0.995, nearly perfect - and the worst honest one. That is the signature of overfitting, and here it is not inferred from theory but measured on the same data by two different procedures.</a:t>
-            </a:r>
-          </a:p>
-          <a:p>
-            <a:pPr lvl="0" indent="0" marL="0">
-              <a:buNone/>
-            </a:pPr>
-          </a:p>
-          <a:p>
-            <a:pPr lvl="0" indent="0" marL="0">
-              <a:buNone/>
-            </a:pPr>
-            <a:r>
-              <a:rPr b="1"/>
-              <a:t>Now the second predictable mistake, and defend the instinct.</a:t>
-            </a:r>
-            <a:r>
-              <a:rPr/>
-              <a:t> Choosing between these three on the training score selects the WORST model, with complete confidence and a very impressive number to report. And the instinct behind it is not stupid: a higher score on the data you have is, in every other part of engineering, evidence of a better system. Fitting the data well is what we spent lessons 3 and 4 doing. What breaks the analogy is that a flexible model can fit data it has already been shown without learning anything transferable.</a:t>
-            </a:r>
-          </a:p>
-          <a:p>
-            <a:pPr lvl="0" indent="0" marL="0">
-              <a:buNone/>
-            </a:pPr>
-          </a:p>
-          <a:p>
-            <a:pPr lvl="0" indent="0" marL="0">
-              <a:buNone/>
-            </a:pPr>
-            <a:r>
-              <a:rPr/>
-              <a:t>The reason this table is on the slide rather than in the handout is that the next slide shows the same three settings as pictures - so the failure is visible as well as measurable, which is rare.</a:t>
+              <a:t>Inference is a vote, in four steps. Standardise the pump with the training scaler. Compute its RBF similarity to each of the 278 support vectors. Add up weight times label times similarity - label +1 for faulty, -1 for healthy - and add b. Read the sign. Nothing else goes in: the total is exactly what decision_function returns.</a:t>
+            </a:r>
+          </a:p>
+          <a:p>
+            <a:pPr lvl="0" indent="0" marL="0">
+              <a:buNone/>
+            </a:pPr>
+          </a:p>
+          <a:p>
+            <a:pPr lvl="0" indent="0" marL="0">
+              <a:buNone/>
+            </a:pPr>
+            <a:r>
+              <a:rPr/>
+              <a:t>The same pump Naive Bayes called faulty at 0.981, reached by a completely different route.</a:t>
+            </a:r>
+          </a:p>
+          <a:p>
+            <a:pPr lvl="0" indent="0" marL="0">
+              <a:buNone/>
+            </a:pPr>
+          </a:p>
+          <a:p>
+            <a:pPr lvl="0" indent="0" marL="0">
+              <a:buNone/>
+            </a:pPr>
+            <a:r>
+              <a:rPr/>
+              <a:t>The point to make: the neighbourhood decides. The 56 support vectors within about 1.2 standard deviations contribute a net +1.141 towards faulty; the other 222 only -0.363. But not one neighbour - the five nearest disagree, because pumps just outside the envelope are faulty and some just inside carry flipped labels. So the SVM is k-NN again, with a smooth similarity instead of a hard k, only the support vectors voting, and learned weights. And the output is a score, not a probability. Handout section 5.5.</a:t>
             </a:r>
           </a:p>
         </p:txBody>
@@ -6593,63 +6590,53 @@
             </a:pPr>
             <a:r>
               <a:rPr/>
-              <a:t>Three settings, with training and cross-validated scores in each title. Read them together.</a:t>
-            </a:r>
-          </a:p>
-          <a:p>
-            <a:pPr lvl="0" indent="0" marL="0">
-              <a:buNone/>
-            </a:pPr>
-          </a:p>
-          <a:p>
-            <a:pPr lvl="0" indent="0" marL="0">
-              <a:buNone/>
-            </a:pPr>
-            <a:r>
-              <a:rPr/>
-              <a:t>Left, γ = 0.1: a smooth boundary, slightly too smooth, and the two scores agree. Middle, γ = 1: close to the true envelope, and the best honest score.</a:t>
-            </a:r>
-          </a:p>
-          <a:p>
-            <a:pPr lvl="0" indent="0" marL="0">
-              <a:buNone/>
-            </a:pPr>
-          </a:p>
-          <a:p>
-            <a:pPr lvl="0" indent="0" marL="0">
-              <a:buNone/>
-            </a:pPr>
-            <a:r>
-              <a:rPr/>
-              <a:t>Right is the one to sit on. The boundary has broken into bubbles - small islands around individual points, including the mislabelled ones. That is what a 0.995 training score looks like from the outside: the model has drawn a private territory around each flipped label so that it can get it right.</a:t>
-            </a:r>
-          </a:p>
-          <a:p>
-            <a:pPr lvl="0" indent="0" marL="0">
-              <a:buNone/>
-            </a:pPr>
-          </a:p>
-          <a:p>
-            <a:pPr lvl="0" indent="0" marL="0">
-              <a:buNone/>
-            </a:pPr>
-            <a:r>
-              <a:rPr/>
-              <a:t>Ask them what happens to a new pump landing in the gap between two bubbles. That is the 0.902.</a:t>
-            </a:r>
-          </a:p>
-          <a:p>
-            <a:pPr lvl="0" indent="0" marL="0">
-              <a:buNone/>
-            </a:pPr>
-          </a:p>
-          <a:p>
-            <a:pPr lvl="0" indent="0" marL="0">
-              <a:buNone/>
-            </a:pPr>
-            <a:r>
-              <a:rPr/>
-              <a:t>The reason this slide matters more than the table: they have seen overfitting as a curve on a plot since lesson 5. Here it is a shape in the input space, and the shape is obviously wrong in a way no number is. When you can plot the boundary, plot it.</a:t>
+              <a:t>Read the two columns against each other, exactly as lesson 5 taught, and let the last row do the work.</a:t>
+            </a:r>
+          </a:p>
+          <a:p>
+            <a:pPr lvl="0" indent="0" marL="0">
+              <a:buNone/>
+            </a:pPr>
+          </a:p>
+          <a:p>
+            <a:pPr lvl="0" indent="0" marL="0">
+              <a:buNone/>
+            </a:pPr>
+            <a:r>
+              <a:rPr/>
+              <a:t>The bottom row has the best training score on the slide - 0.995, nearly perfect - and the worst honest one. That is the signature of overfitting, and here it is not inferred from theory but measured on the same data by two different procedures.</a:t>
+            </a:r>
+          </a:p>
+          <a:p>
+            <a:pPr lvl="0" indent="0" marL="0">
+              <a:buNone/>
+            </a:pPr>
+          </a:p>
+          <a:p>
+            <a:pPr lvl="0" indent="0" marL="0">
+              <a:buNone/>
+            </a:pPr>
+            <a:r>
+              <a:rPr b="1"/>
+              <a:t>Now the second predictable mistake, and defend the instinct.</a:t>
+            </a:r>
+            <a:r>
+              <a:rPr/>
+              <a:t> Choosing between these three on the training score selects the WORST model, with complete confidence and a very impressive number to report. And the instinct behind it is not stupid: a higher score on the data you have is, in every other part of engineering, evidence of a better system. Fitting the data well is what we spent lessons 3 and 4 doing. What breaks the analogy is that a flexible model can fit data it has already been shown without learning anything transferable.</a:t>
+            </a:r>
+          </a:p>
+          <a:p>
+            <a:pPr lvl="0" indent="0" marL="0">
+              <a:buNone/>
+            </a:pPr>
+          </a:p>
+          <a:p>
+            <a:pPr lvl="0" indent="0" marL="0">
+              <a:buNone/>
+            </a:pPr>
+            <a:r>
+              <a:rPr/>
+              <a:t>The reason this table is on the slide rather than in the handout is that the next slide shows the same three settings as pictures - so the failure is visible as well as measurable, which is rare.</a:t>
             </a:r>
           </a:p>
         </p:txBody>
@@ -6731,49 +6718,63 @@
             </a:pPr>
             <a:r>
               <a:rPr/>
-              <a:t>Run notebooks/03. Sixteen minutes.</a:t>
-            </a:r>
-          </a:p>
-          <a:p>
-            <a:pPr lvl="0" indent="0" marL="0">
-              <a:buNone/>
-            </a:pPr>
-          </a:p>
-          <a:p>
-            <a:pPr lvl="0" indent="0" marL="0">
-              <a:buNone/>
-            </a:pPr>
-            <a:r>
-              <a:rPr/>
-              <a:t>The cell to protect is the γ sweep with the boundary drawn at each setting. Let them turn γ up themselves and watch the bubbles form - it is the most direct experience of overfitting available in this course.</a:t>
-            </a:r>
-          </a:p>
-          <a:p>
-            <a:pPr lvl="0" indent="0" marL="0">
-              <a:buNone/>
-            </a:pPr>
-          </a:p>
-          <a:p>
-            <a:pPr lvl="0" indent="0" marL="0">
-              <a:buNone/>
-            </a:pPr>
-            <a:r>
-              <a:rPr/>
-              <a:t>Have them print the support-vector fraction for the linear and RBF kernels side by side. Two numbers, and it makes the diagnostic real rather than a claim on a slide.</a:t>
-            </a:r>
-          </a:p>
-          <a:p>
-            <a:pPr lvl="0" indent="0" marL="0">
-              <a:buNone/>
-            </a:pPr>
-          </a:p>
-          <a:p>
-            <a:pPr lvl="0" indent="0" marL="0">
-              <a:buNone/>
-            </a:pPr>
-            <a:r>
-              <a:rPr/>
-              <a:t>If time runs short, skip the C sweep and set it as reading: the table is in handout section 5.6.</a:t>
+              <a:t>Three settings, with training and cross-validated scores in each title. Read them together.</a:t>
+            </a:r>
+          </a:p>
+          <a:p>
+            <a:pPr lvl="0" indent="0" marL="0">
+              <a:buNone/>
+            </a:pPr>
+          </a:p>
+          <a:p>
+            <a:pPr lvl="0" indent="0" marL="0">
+              <a:buNone/>
+            </a:pPr>
+            <a:r>
+              <a:rPr/>
+              <a:t>Left, γ = 0.1: a smooth boundary, slightly too smooth, and the two scores agree. Middle, γ = 1: close to the true envelope, and the best honest score.</a:t>
+            </a:r>
+          </a:p>
+          <a:p>
+            <a:pPr lvl="0" indent="0" marL="0">
+              <a:buNone/>
+            </a:pPr>
+          </a:p>
+          <a:p>
+            <a:pPr lvl="0" indent="0" marL="0">
+              <a:buNone/>
+            </a:pPr>
+            <a:r>
+              <a:rPr/>
+              <a:t>Right is the one to sit on. The boundary has broken into bubbles - small islands around individual points, including the mislabelled ones. That is what a 0.995 training score looks like from the outside: the model has drawn a private territory around each flipped label so that it can get it right.</a:t>
+            </a:r>
+          </a:p>
+          <a:p>
+            <a:pPr lvl="0" indent="0" marL="0">
+              <a:buNone/>
+            </a:pPr>
+          </a:p>
+          <a:p>
+            <a:pPr lvl="0" indent="0" marL="0">
+              <a:buNone/>
+            </a:pPr>
+            <a:r>
+              <a:rPr/>
+              <a:t>Ask them what happens to a new pump landing in the gap between two bubbles. That is the 0.902.</a:t>
+            </a:r>
+          </a:p>
+          <a:p>
+            <a:pPr lvl="0" indent="0" marL="0">
+              <a:buNone/>
+            </a:pPr>
+          </a:p>
+          <a:p>
+            <a:pPr lvl="0" indent="0" marL="0">
+              <a:buNone/>
+            </a:pPr>
+            <a:r>
+              <a:rPr/>
+              <a:t>The reason this slide matters more than the table: they have seen overfitting as a curve on a plot since lesson 5. Here it is a shape in the input space, and the shape is obviously wrong in a way no number is. When you can plot the boundary, plot it.</a:t>
             </a:r>
           </a:p>
         </p:txBody>
@@ -6855,57 +6856,49 @@
             </a:pPr>
             <a:r>
               <a:rPr/>
-              <a:t>Everything in the lesson on the same 1,200 pumps, cross-validated the same way.</a:t>
-            </a:r>
-          </a:p>
-          <a:p>
-            <a:pPr lvl="0" indent="0" marL="0">
-              <a:buNone/>
-            </a:pPr>
-          </a:p>
-          <a:p>
-            <a:pPr lvl="0" indent="0" marL="0">
-              <a:buNone/>
-            </a:pPr>
-            <a:r>
-              <a:rPr/>
-              <a:t>Read the top three rows together: all exactly 0.613, and all three are linear. Then the bottom three, all near the ceiling, reached by three completely unrelated routes - remembering the neighbourhood, assuming independence, bending the space. There is no single idea shared between them.</a:t>
-            </a:r>
-          </a:p>
-          <a:p>
-            <a:pPr lvl="0" indent="0" marL="0">
-              <a:buNone/>
-            </a:pPr>
-          </a:p>
-          <a:p>
-            <a:pPr lvl="0" indent="0" marL="0">
-              <a:buNone/>
-            </a:pPr>
-            <a:r>
-              <a:rPr/>
-              <a:t>Then the number that is the lesson: the gap between best and worst is </a:t>
-            </a:r>
-            <a:r>
-              <a:rPr b="1"/>
-              <a:t>0.334</a:t>
-            </a:r>
-            <a:r>
-              <a:rPr/>
-              <a:t>. Larger than any difference this course has shown between a good model and a carefully tuned one - lesson 5’s entire hyperparameter search moved things by a few hundredths.</a:t>
-            </a:r>
-          </a:p>
-          <a:p>
-            <a:pPr lvl="0" indent="0" marL="0">
-              <a:buNone/>
-            </a:pPr>
-          </a:p>
-          <a:p>
-            <a:pPr lvl="0" indent="0" marL="0">
-              <a:buNone/>
-            </a:pPr>
-            <a:r>
-              <a:rPr/>
-              <a:t>Say the conclusion plainly, and it is the practical takeaway of the whole lesson: choosing the right family matters far more than tuning the wrong one. Nobody in the top three rows could have tuned their way out. And the way to tell which family you need is to look at the data first, which is what lesson 2 was for.</a:t>
+              <a:t>Run notebooks/03. Sixteen minutes.</a:t>
+            </a:r>
+          </a:p>
+          <a:p>
+            <a:pPr lvl="0" indent="0" marL="0">
+              <a:buNone/>
+            </a:pPr>
+          </a:p>
+          <a:p>
+            <a:pPr lvl="0" indent="0" marL="0">
+              <a:buNone/>
+            </a:pPr>
+            <a:r>
+              <a:rPr/>
+              <a:t>The cell to protect is the γ sweep with the boundary drawn at each setting. Let them turn γ up themselves and watch the bubbles form - it is the most direct experience of overfitting available in this course.</a:t>
+            </a:r>
+          </a:p>
+          <a:p>
+            <a:pPr lvl="0" indent="0" marL="0">
+              <a:buNone/>
+            </a:pPr>
+          </a:p>
+          <a:p>
+            <a:pPr lvl="0" indent="0" marL="0">
+              <a:buNone/>
+            </a:pPr>
+            <a:r>
+              <a:rPr/>
+              <a:t>Have them print the support-vector fraction for the linear and RBF kernels side by side. Two numbers, and it makes the diagnostic real rather than a claim on a slide.</a:t>
+            </a:r>
+          </a:p>
+          <a:p>
+            <a:pPr lvl="0" indent="0" marL="0">
+              <a:buNone/>
+            </a:pPr>
+          </a:p>
+          <a:p>
+            <a:pPr lvl="0" indent="0" marL="0">
+              <a:buNone/>
+            </a:pPr>
+            <a:r>
+              <a:rPr/>
+              <a:t>If time runs short, skip the C sweep and set it as reading: the table is in handout section 5.6.</a:t>
             </a:r>
           </a:p>
         </p:txBody>
@@ -6987,35 +6980,57 @@
             </a:pPr>
             <a:r>
               <a:rPr/>
-              <a:t>A table to photograph. Work down it and attach today’s evidence to each row, so it is remembered as a set of conclusions rather than as advice.</a:t>
-            </a:r>
-          </a:p>
-          <a:p>
-            <a:pPr lvl="0" indent="0" marL="0">
-              <a:buNone/>
-            </a:pPr>
-          </a:p>
-          <a:p>
-            <a:pPr lvl="0" indent="0" marL="0">
-              <a:buNone/>
-            </a:pPr>
-            <a:r>
-              <a:rPr/>
-              <a:t>Row two deserves a sentence on its own, because it is the one that sounds wrong after the last hour. Text classification is the canonical case: tens of thousands of word-count features, an assumption that is transparently false, and a method that works anyway - because being roughly right in ten thousand dimensions beats being unable to estimate anything at all. Also mention Naive Bayes as a baseline: it trains in one pass, so if your tuned model does not beat it you have learned something quickly and cheaply.</a:t>
-            </a:r>
-          </a:p>
-          <a:p>
-            <a:pPr lvl="0" indent="0" marL="0">
-              <a:buNone/>
-            </a:pPr>
-          </a:p>
-          <a:p>
-            <a:pPr lvl="0" indent="0" marL="0">
-              <a:buNone/>
-            </a:pPr>
-            <a:r>
-              <a:rPr/>
-              <a:t>One row that did not fit and should be said out loud: when you need to explain the decision to the person affected, none of today’s three will do it. A support vector machine in a lifted space has no explanation a customer would accept. Lesson 3’s Resources document covers why that is sometimes a legal requirement rather than a preference.</a:t>
+              <a:t>Everything in the lesson on the same 1,200 pumps, cross-validated the same way.</a:t>
+            </a:r>
+          </a:p>
+          <a:p>
+            <a:pPr lvl="0" indent="0" marL="0">
+              <a:buNone/>
+            </a:pPr>
+          </a:p>
+          <a:p>
+            <a:pPr lvl="0" indent="0" marL="0">
+              <a:buNone/>
+            </a:pPr>
+            <a:r>
+              <a:rPr/>
+              <a:t>Read the top three rows together: all exactly 0.613, and all three are linear. Then the bottom three, all near the ceiling, reached by three completely unrelated routes - remembering the neighbourhood, assuming independence, bending the space. There is no single idea shared between them.</a:t>
+            </a:r>
+          </a:p>
+          <a:p>
+            <a:pPr lvl="0" indent="0" marL="0">
+              <a:buNone/>
+            </a:pPr>
+          </a:p>
+          <a:p>
+            <a:pPr lvl="0" indent="0" marL="0">
+              <a:buNone/>
+            </a:pPr>
+            <a:r>
+              <a:rPr/>
+              <a:t>Then the number that is the lesson: the gap between best and worst is </a:t>
+            </a:r>
+            <a:r>
+              <a:rPr b="1"/>
+              <a:t>0.334</a:t>
+            </a:r>
+            <a:r>
+              <a:rPr/>
+              <a:t>. Larger than any difference this course has shown between a good model and a carefully tuned one - lesson 5’s entire hyperparameter search moved things by a few hundredths.</a:t>
+            </a:r>
+          </a:p>
+          <a:p>
+            <a:pPr lvl="0" indent="0" marL="0">
+              <a:buNone/>
+            </a:pPr>
+          </a:p>
+          <a:p>
+            <a:pPr lvl="0" indent="0" marL="0">
+              <a:buNone/>
+            </a:pPr>
+            <a:r>
+              <a:rPr/>
+              <a:t>Say the conclusion plainly, and it is the practical takeaway of the whole lesson: choosing the right family matters far more than tuning the wrong one. Nobody in the top three rows could have tuned their way out. And the way to tell which family you need is to look at the data first, which is what lesson 2 was for.</a:t>
             </a:r>
           </a:p>
         </p:txBody>
@@ -7097,49 +7112,35 @@
             </a:pPr>
             <a:r>
               <a:rPr/>
-              <a:t>Close on the number they opened the second segment with, and say it one more time: seventy per cent. In a hundred dimensions the nearest point in the entire dataset is seven tenths of the way to the farthest, and every method built on distance is operating on a quantity that has stopped varying.</a:t>
-            </a:r>
-          </a:p>
-          <a:p>
-            <a:pPr lvl="0" indent="0" marL="0">
-              <a:buNone/>
-            </a:pPr>
-          </a:p>
-          <a:p>
-            <a:pPr lvl="0" indent="0" marL="0">
-              <a:buNone/>
-            </a:pPr>
-            <a:r>
-              <a:rPr/>
-              <a:t>If they remember one habit from today, make it the diagnostic pair: before reaching for a model, look at the shape of the data; after fitting one, check whether the assumption it depends on is actually satisfied on your data - and check it properly. The −0.006 said yes; the squared distances said no; and the ellipse the model drew explained the 0.933.</a:t>
-            </a:r>
-          </a:p>
-          <a:p>
-            <a:pPr lvl="0" indent="0" marL="0">
-              <a:buNone/>
-            </a:pPr>
-          </a:p>
-          <a:p>
-            <a:pPr lvl="0" indent="0" marL="0">
-              <a:buNone/>
-            </a:pPr>
-            <a:r>
-              <a:rPr/>
-              <a:t>And the correction to the instinct that this lesson exists to install: more features is not free. It is nearly free for a linear model and it is expensive for anything built on a distance.</a:t>
-            </a:r>
-          </a:p>
-          <a:p>
-            <a:pPr lvl="0" indent="0" marL="0">
-              <a:buNone/>
-            </a:pPr>
-          </a:p>
-          <a:p>
-            <a:pPr lvl="0" indent="0" marL="0">
-              <a:buNone/>
-            </a:pPr>
-            <a:r>
-              <a:rPr/>
-              <a:t>Handout section 7 lists all of this with the section numbers.</a:t>
+              <a:t>A table to photograph. Work down it and attach today’s evidence to each row, so it is remembered as a set of conclusions rather than as advice.</a:t>
+            </a:r>
+          </a:p>
+          <a:p>
+            <a:pPr lvl="0" indent="0" marL="0">
+              <a:buNone/>
+            </a:pPr>
+          </a:p>
+          <a:p>
+            <a:pPr lvl="0" indent="0" marL="0">
+              <a:buNone/>
+            </a:pPr>
+            <a:r>
+              <a:rPr/>
+              <a:t>Row two deserves a sentence on its own, because it is the one that sounds wrong after the last hour. Text classification is the canonical case: tens of thousands of word-count features, an assumption that is transparently false, and a method that works anyway - because being roughly right in ten thousand dimensions beats being unable to estimate anything at all. Also mention Naive Bayes as a baseline: it trains in one pass, so if your tuned model does not beat it you have learned something quickly and cheaply.</a:t>
+            </a:r>
+          </a:p>
+          <a:p>
+            <a:pPr lvl="0" indent="0" marL="0">
+              <a:buNone/>
+            </a:pPr>
+          </a:p>
+          <a:p>
+            <a:pPr lvl="0" indent="0" marL="0">
+              <a:buNone/>
+            </a:pPr>
+            <a:r>
+              <a:rPr/>
+              <a:t>One row that did not fit and should be said out loud: when you need to explain the decision to the person affected, none of today’s three will do it. A support vector machine in a lifted space has no explanation a customer would accept. Lesson 3’s Resources document covers why that is sometimes a legal requirement rather than a preference.</a:t>
             </a:r>
           </a:p>
         </p:txBody>
@@ -7221,49 +7222,49 @@
             </a:pPr>
             <a:r>
               <a:rPr/>
-              <a:t>Set it explicitly and say out loud when it comes back: the first ten minutes of next Friday, 13 November.</a:t>
-            </a:r>
-          </a:p>
-          <a:p>
-            <a:pPr lvl="0" indent="0" marL="0">
-              <a:buNone/>
-            </a:pPr>
-          </a:p>
-          <a:p>
-            <a:pPr lvl="0" indent="0" marL="0">
-              <a:buNone/>
-            </a:pPr>
-            <a:r>
-              <a:rPr/>
-              <a:t>The marks are for the reasoning, not for the accuracy. A well-argued choice that scores slightly worse beats a lucky winner with no justification - and the argument has to reference the data, in the way that the squared distances and the fitted ellipse explained Naive Bayes on the pumps this afternoon.</a:t>
-            </a:r>
-          </a:p>
-          <a:p>
-            <a:pPr lvl="0" indent="0" marL="0">
-              <a:buNone/>
-            </a:pPr>
-          </a:p>
-          <a:p>
-            <a:pPr lvl="0" indent="0" marL="0">
-              <a:buNone/>
-            </a:pPr>
-            <a:r>
-              <a:rPr/>
-              <a:t>Remind them that everything must be cross-validated and reported with a spread, in the format lesson 5 set. Scaling goes inside the pipeline; that will be checked.</a:t>
-            </a:r>
-          </a:p>
-          <a:p>
-            <a:pPr lvl="0" indent="0" marL="0">
-              <a:buNone/>
-            </a:pPr>
-          </a:p>
-          <a:p>
-            <a:pPr lvl="0" indent="0" marL="0">
-              <a:buNone/>
-            </a:pPr>
-            <a:r>
-              <a:rPr/>
-              <a:t>Next week: decision trees and ensembles. A fourth family, with a different answer again to the same question - how do you draw a boundary that is not a line.</a:t>
+              <a:t>Close on the number they opened the second segment with, and say it one more time: seventy per cent. In a hundred dimensions the nearest point in the entire dataset is seven tenths of the way to the farthest, and every method built on distance is operating on a quantity that has stopped varying.</a:t>
+            </a:r>
+          </a:p>
+          <a:p>
+            <a:pPr lvl="0" indent="0" marL="0">
+              <a:buNone/>
+            </a:pPr>
+          </a:p>
+          <a:p>
+            <a:pPr lvl="0" indent="0" marL="0">
+              <a:buNone/>
+            </a:pPr>
+            <a:r>
+              <a:rPr/>
+              <a:t>If they remember one habit from today, make it the diagnostic pair: before reaching for a model, look at the shape of the data; after fitting one, check whether the assumption it depends on is actually satisfied on your data - and check it properly. The −0.006 said yes; the squared distances said no; and the ellipse the model drew explained the 0.933.</a:t>
+            </a:r>
+          </a:p>
+          <a:p>
+            <a:pPr lvl="0" indent="0" marL="0">
+              <a:buNone/>
+            </a:pPr>
+          </a:p>
+          <a:p>
+            <a:pPr lvl="0" indent="0" marL="0">
+              <a:buNone/>
+            </a:pPr>
+            <a:r>
+              <a:rPr/>
+              <a:t>And the correction to the instinct that this lesson exists to install: more features is not free. It is nearly free for a linear model and it is expensive for anything built on a distance.</a:t>
+            </a:r>
+          </a:p>
+          <a:p>
+            <a:pPr lvl="0" indent="0" marL="0">
+              <a:buNone/>
+            </a:pPr>
+          </a:p>
+          <a:p>
+            <a:pPr lvl="0" indent="0" marL="0">
+              <a:buNone/>
+            </a:pPr>
+            <a:r>
+              <a:rPr/>
+              <a:t>Handout section 7 lists all of this with the section numbers.</a:t>
             </a:r>
           </a:p>
         </p:txBody>
@@ -7410,6 +7411,130 @@
             <a:fld id="{18BDFEC3-8487-43E8-A154-7C12CBC1FFF2}" type="slidenum">
               <a:rPr lang="en-US"/>
               <a:t>7</a:t>
+            </a:fld>
+            <a:endParaRPr lang="en-US"/>
+          </a:p>
+        </p:txBody>
+      </p:sp>
+    </p:spTree>
+  </p:cSld>
+</p:notes>
+</file>
+
+<file path=ppt/notesSlides/notesSlide60.xml><?xml version="1.0" encoding="utf-8"?>
+<p:notes xmlns:a="http://schemas.openxmlformats.org/drawingml/2006/main" xmlns:r="http://schemas.openxmlformats.org/officeDocument/2006/relationships" xmlns:p="http://schemas.openxmlformats.org/presentationml/2006/main">
+  <p:cSld>
+    <p:spTree>
+      <p:nvGrpSpPr>
+        <p:cNvPr id="1" name=""/>
+        <p:cNvGrpSpPr/>
+        <p:nvPr/>
+      </p:nvGrpSpPr>
+      <p:grpSpPr>
+        <a:xfrm>
+          <a:off x="0" y="0"/>
+          <a:ext cx="0" cy="0"/>
+          <a:chOff x="0" y="0"/>
+          <a:chExt cx="0" cy="0"/>
+        </a:xfrm>
+      </p:grpSpPr>
+      <p:sp>
+        <p:nvSpPr>
+          <p:cNvPr id="2" name="Slide Image Placeholder 1"/>
+          <p:cNvSpPr>
+            <a:spLocks noGrp="1" noRot="1" noChangeAspect="1"/>
+          </p:cNvSpPr>
+          <p:nvPr>
+            <p:ph type="sldImg"/>
+          </p:nvPr>
+        </p:nvSpPr>
+        <p:spPr/>
+      </p:sp>
+      <p:sp>
+        <p:nvSpPr>
+          <p:cNvPr id="3" name="Notes Placeholder 2"/>
+          <p:cNvSpPr>
+            <a:spLocks noGrp="1"/>
+          </p:cNvSpPr>
+          <p:nvPr>
+            <p:ph type="body" idx="1"/>
+          </p:nvPr>
+        </p:nvSpPr>
+        <p:spPr/>
+        <p:txBody>
+          <a:bodyPr/>
+          <a:lstStyle/>
+          <a:p>
+            <a:pPr lvl="0" indent="0" marL="0">
+              <a:buNone/>
+            </a:pPr>
+            <a:r>
+              <a:rPr/>
+              <a:t>Set it explicitly and say out loud when it comes back: the first ten minutes of next Friday, 13 November.</a:t>
+            </a:r>
+          </a:p>
+          <a:p>
+            <a:pPr lvl="0" indent="0" marL="0">
+              <a:buNone/>
+            </a:pPr>
+          </a:p>
+          <a:p>
+            <a:pPr lvl="0" indent="0" marL="0">
+              <a:buNone/>
+            </a:pPr>
+            <a:r>
+              <a:rPr/>
+              <a:t>The marks are for the reasoning, not for the accuracy. A well-argued choice that scores slightly worse beats a lucky winner with no justification - and the argument has to reference the data, in the way that the squared distances and the fitted ellipse explained Naive Bayes on the pumps this afternoon.</a:t>
+            </a:r>
+          </a:p>
+          <a:p>
+            <a:pPr lvl="0" indent="0" marL="0">
+              <a:buNone/>
+            </a:pPr>
+          </a:p>
+          <a:p>
+            <a:pPr lvl="0" indent="0" marL="0">
+              <a:buNone/>
+            </a:pPr>
+            <a:r>
+              <a:rPr/>
+              <a:t>Remind them that everything must be cross-validated and reported with a spread, in the format lesson 5 set. Scaling goes inside the pipeline; that will be checked.</a:t>
+            </a:r>
+          </a:p>
+          <a:p>
+            <a:pPr lvl="0" indent="0" marL="0">
+              <a:buNone/>
+            </a:pPr>
+          </a:p>
+          <a:p>
+            <a:pPr lvl="0" indent="0" marL="0">
+              <a:buNone/>
+            </a:pPr>
+            <a:r>
+              <a:rPr/>
+              <a:t>Next week: decision trees and ensembles. A fourth family, with a different answer again to the same question - how do you draw a boundary that is not a line.</a:t>
+            </a:r>
+          </a:p>
+        </p:txBody>
+      </p:sp>
+      <p:sp>
+        <p:nvSpPr>
+          <p:cNvPr id="4" name="Slide Number Placeholder 3"/>
+          <p:cNvSpPr>
+            <a:spLocks noGrp="1"/>
+          </p:cNvSpPr>
+          <p:nvPr>
+            <p:ph type="sldNum" sz="quarter" idx="10"/>
+          </p:nvPr>
+        </p:nvSpPr>
+        <p:spPr/>
+        <p:txBody>
+          <a:bodyPr/>
+          <a:lstStyle/>
+          <a:p>
+            <a:fld id="{18BDFEC3-8487-43E8-A154-7C12CBC1FFF2}" type="slidenum">
+              <a:rPr lang="en-US"/>
+              <a:t>61</a:t>
             </a:fld>
             <a:endParaRPr lang="en-US"/>
           </a:p>
@@ -14165,6 +14290,88 @@
             </a:pPr>
             <a:r>
               <a:rPr/>
+              <a:t>48 Hz: one bell is 86 times the other</a:t>
+            </a:r>
+          </a:p>
+        </p:txBody>
+      </p:sp>
+      <p:pic>
+        <p:nvPicPr>
+          <p:cNvPr descr="nb_bells_one_pump.png" id="0" name="Picture 1"/>
+          <p:cNvPicPr>
+            <a:picLocks noGrp="1" noChangeAspect="1"/>
+          </p:cNvPicPr>
+          <p:nvPr/>
+        </p:nvPicPr>
+        <p:blipFill>
+          <a:blip r:embed="rId3"/>
+          <a:stretch>
+            <a:fillRect/>
+          </a:stretch>
+        </p:blipFill>
+        <p:spPr bwMode="auto">
+          <a:xfrm>
+            <a:off x="457200" y="1480939"/>
+            <a:ext cx="8229600" cy="2730500"/>
+          </a:xfrm>
+          <a:prstGeom prst="rect">
+            <a:avLst/>
+          </a:prstGeom>
+          <a:noFill/>
+          <a:ln w="9525">
+            <a:noFill/>
+            <a:headEnd/>
+            <a:tailEnd/>
+          </a:ln>
+        </p:spPr>
+      </p:pic>
+    </p:spTree>
+  </p:cSld>
+</p:sld>
+</file>
+
+<file path=ppt/slides/slide32.xml><?xml version="1.0" encoding="utf-8"?>
+<p:sld xmlns:a="http://schemas.openxmlformats.org/drawingml/2006/main" xmlns:r="http://schemas.openxmlformats.org/officeDocument/2006/relationships" xmlns:p="http://schemas.openxmlformats.org/presentationml/2006/main">
+  <p:cSld>
+    <p:spTree>
+      <p:nvGrpSpPr>
+        <p:cNvPr id="1" name=""/>
+        <p:cNvGrpSpPr/>
+        <p:nvPr/>
+      </p:nvGrpSpPr>
+      <p:grpSpPr>
+        <a:xfrm>
+          <a:off x="0" y="0"/>
+          <a:ext cx="0" cy="0"/>
+          <a:chOff x="0" y="0"/>
+          <a:chExt cx="0" cy="0"/>
+        </a:xfrm>
+      </p:grpSpPr>
+      <p:sp>
+        <p:nvSpPr>
+          <p:cNvPr id="2" name="Title 1"/>
+          <p:cNvSpPr>
+            <a:spLocks noGrp="1"/>
+          </p:cNvSpPr>
+          <p:nvPr>
+            <p:ph type="title"/>
+          </p:nvPr>
+        </p:nvSpPr>
+        <p:spPr>
+          <a:xfrm>
+            <a:off x="457200" y="205979"/>
+            <a:ext cx="8229600" cy="857250"/>
+          </a:xfrm>
+        </p:spPr>
+        <p:txBody>
+          <a:bodyPr/>
+          <a:lstStyle/>
+          <a:p>
+            <a:pPr lvl="0" indent="0" marL="0">
+              <a:buNone/>
+            </a:pPr>
+            <a:r>
+              <a:rPr/>
               <a:t>48 Hz, 5.6 bar: faulty, 0.981</a:t>
             </a:r>
           </a:p>
@@ -14442,7 +14649,7 @@
 </p:sld>
 </file>
 
-<file path=ppt/slides/slide32.xml><?xml version="1.0" encoding="utf-8"?>
+<file path=ppt/slides/slide33.xml><?xml version="1.0" encoding="utf-8"?>
 <p:sld xmlns:a="http://schemas.openxmlformats.org/drawingml/2006/main" xmlns:r="http://schemas.openxmlformats.org/officeDocument/2006/relationships" xmlns:p="http://schemas.openxmlformats.org/presentationml/2006/main">
   <p:cSld>
     <p:spTree>
@@ -14555,7 +14762,7 @@
 </p:sld>
 </file>
 
-<file path=ppt/slides/slide33.xml><?xml version="1.0" encoding="utf-8"?>
+<file path=ppt/slides/slide34.xml><?xml version="1.0" encoding="utf-8"?>
 <p:sld xmlns:a="http://schemas.openxmlformats.org/drawingml/2006/main" xmlns:r="http://schemas.openxmlformats.org/officeDocument/2006/relationships" xmlns:p="http://schemas.openxmlformats.org/presentationml/2006/main">
   <p:cSld>
     <p:spTree>
@@ -14797,7 +15004,7 @@
 </p:sld>
 </file>
 
-<file path=ppt/slides/slide34.xml><?xml version="1.0" encoding="utf-8"?>
+<file path=ppt/slides/slide35.xml><?xml version="1.0" encoding="utf-8"?>
 <p:sld xmlns:a="http://schemas.openxmlformats.org/drawingml/2006/main" xmlns:r="http://schemas.openxmlformats.org/officeDocument/2006/relationships" xmlns:p="http://schemas.openxmlformats.org/presentationml/2006/main">
   <p:cSld>
     <p:spTree>
@@ -15022,7 +15229,7 @@
 </p:sld>
 </file>
 
-<file path=ppt/slides/slide35.xml><?xml version="1.0" encoding="utf-8"?>
+<file path=ppt/slides/slide36.xml><?xml version="1.0" encoding="utf-8"?>
 <p:sld xmlns:a="http://schemas.openxmlformats.org/drawingml/2006/main" xmlns:r="http://schemas.openxmlformats.org/officeDocument/2006/relationships" xmlns:p="http://schemas.openxmlformats.org/presentationml/2006/main">
   <p:cSld>
     <p:spTree>
@@ -15124,7 +15331,7 @@
 </p:sld>
 </file>
 
-<file path=ppt/slides/slide36.xml><?xml version="1.0" encoding="utf-8"?>
+<file path=ppt/slides/slide37.xml><?xml version="1.0" encoding="utf-8"?>
 <p:sld xmlns:a="http://schemas.openxmlformats.org/drawingml/2006/main" xmlns:r="http://schemas.openxmlformats.org/officeDocument/2006/relationships" xmlns:p="http://schemas.openxmlformats.org/presentationml/2006/main">
   <p:cSld>
     <p:spTree>
@@ -15206,7 +15413,7 @@
 </p:sld>
 </file>
 
-<file path=ppt/slides/slide37.xml><?xml version="1.0" encoding="utf-8"?>
+<file path=ppt/slides/slide38.xml><?xml version="1.0" encoding="utf-8"?>
 <p:sld xmlns:a="http://schemas.openxmlformats.org/drawingml/2006/main" xmlns:r="http://schemas.openxmlformats.org/officeDocument/2006/relationships" xmlns:p="http://schemas.openxmlformats.org/presentationml/2006/main">
   <p:cSld>
     <p:spTree>
@@ -15512,119 +15719,6 @@
 </p:sld>
 </file>
 
-<file path=ppt/slides/slide38.xml><?xml version="1.0" encoding="utf-8"?>
-<p:sld xmlns:a="http://schemas.openxmlformats.org/drawingml/2006/main" xmlns:r="http://schemas.openxmlformats.org/officeDocument/2006/relationships" xmlns:p="http://schemas.openxmlformats.org/presentationml/2006/main">
-  <p:cSld>
-    <p:spTree>
-      <p:nvGrpSpPr>
-        <p:cNvPr id="1" name=""/>
-        <p:cNvGrpSpPr/>
-        <p:nvPr/>
-      </p:nvGrpSpPr>
-      <p:grpSpPr>
-        <a:xfrm>
-          <a:off x="0" y="0"/>
-          <a:ext cx="0" cy="0"/>
-          <a:chOff x="0" y="0"/>
-          <a:chExt cx="0" cy="0"/>
-        </a:xfrm>
-      </p:grpSpPr>
-      <p:sp>
-        <p:nvSpPr>
-          <p:cNvPr id="2" name="Title 1"/>
-          <p:cNvSpPr>
-            <a:spLocks noGrp="1"/>
-          </p:cNvSpPr>
-          <p:nvPr>
-            <p:ph type="title"/>
-          </p:nvPr>
-        </p:nvSpPr>
-        <p:spPr>
-          <a:xfrm>
-            <a:off x="457200" y="205979"/>
-            <a:ext cx="8229600" cy="857250"/>
-          </a:xfrm>
-        </p:spPr>
-        <p:txBody>
-          <a:bodyPr/>
-          <a:lstStyle/>
-          <a:p>
-            <a:pPr lvl="0" indent="0" marL="0">
-              <a:buNone/>
-            </a:pPr>
-            <a:r>
-              <a:rPr/>
-              <a:t>Its probabilities are not probabilities</a:t>
-            </a:r>
-          </a:p>
-        </p:txBody>
-      </p:sp>
-      <p:sp>
-        <p:nvSpPr>
-          <p:cNvPr id="3" name="Content Placeholder 2"/>
-          <p:cNvSpPr>
-            <a:spLocks noGrp="1"/>
-          </p:cNvSpPr>
-          <p:nvPr>
-            <p:ph idx="1"/>
-          </p:nvPr>
-        </p:nvSpPr>
-        <p:spPr>
-          <a:xfrm>
-            <a:off x="457200" y="1200151"/>
-            <a:ext cx="8229600" cy="3394472"/>
-          </a:xfrm>
-        </p:spPr>
-        <p:txBody>
-          <a:bodyPr/>
-          <a:lstStyle/>
-          <a:p>
-            <a:pPr lvl="0"/>
-            <a:r>
-              <a:rPr/>
-              <a:t>Mean confidence when </a:t>
-            </a:r>
-            <a:r>
-              <a:rPr b="1"/>
-              <a:t>correct: 0.567</a:t>
-            </a:r>
-            <a:r>
-              <a:rPr/>
-              <a:t>. When </a:t>
-            </a:r>
-            <a:r>
-              <a:rPr b="1"/>
-              <a:t>wrong: 0.555</a:t>
-            </a:r>
-          </a:p>
-          <a:p>
-            <a:pPr lvl="0"/>
-            <a:r>
-              <a:rPr/>
-              <a:t>It cannot tell the difference between the two situations</a:t>
-            </a:r>
-          </a:p>
-          <a:p>
-            <a:pPr lvl="0"/>
-            <a:r>
-              <a:rPr/>
-              <a:t>With features that repeat each other it fails the other way: 0.999 reported, with an accuracy nothing like that</a:t>
-            </a:r>
-          </a:p>
-          <a:p>
-            <a:pPr lvl="0"/>
-            <a:r>
-              <a:rPr b="1"/>
-              <a:t>The ranking may be useful while the probabilities are not</a:t>
-            </a:r>
-          </a:p>
-        </p:txBody>
-      </p:sp>
-    </p:spTree>
-  </p:cSld>
-</p:sld>
-</file>
-
 <file path=ppt/slides/slide39.xml><?xml version="1.0" encoding="utf-8"?>
 <p:sld xmlns:a="http://schemas.openxmlformats.org/drawingml/2006/main" xmlns:r="http://schemas.openxmlformats.org/officeDocument/2006/relationships" xmlns:p="http://schemas.openxmlformats.org/presentationml/2006/main">
   <p:cSld>
@@ -15667,7 +15761,7 @@
             </a:pPr>
             <a:r>
               <a:rPr/>
-              <a:t>Notebook 2, live</a:t>
+              <a:t>Its probabilities are not probabilities</a:t>
             </a:r>
           </a:p>
         </p:txBody>
@@ -15695,7 +15789,40 @@
             <a:pPr lvl="0"/>
             <a:r>
               <a:rPr/>
-              <a:t>Where breaking the assumption is cheap, and one step away where it is fatal</a:t>
+              <a:t>Mean confidence when </a:t>
+            </a:r>
+            <a:r>
+              <a:rPr b="1"/>
+              <a:t>correct: 0.567</a:t>
+            </a:r>
+            <a:r>
+              <a:rPr/>
+              <a:t>. When </a:t>
+            </a:r>
+            <a:r>
+              <a:rPr b="1"/>
+              <a:t>wrong: 0.555</a:t>
+            </a:r>
+          </a:p>
+          <a:p>
+            <a:pPr lvl="0"/>
+            <a:r>
+              <a:rPr/>
+              <a:t>It cannot tell the difference between the two situations</a:t>
+            </a:r>
+          </a:p>
+          <a:p>
+            <a:pPr lvl="0"/>
+            <a:r>
+              <a:rPr/>
+              <a:t>With features that repeat each other it fails the other way: 0.999 reported, with an accuracy nothing like that</a:t>
+            </a:r>
+          </a:p>
+          <a:p>
+            <a:pPr lvl="0"/>
+            <a:r>
+              <a:rPr b="1"/>
+              <a:t>The ranking may be useful while the probabilities are not</a:t>
             </a:r>
           </a:p>
         </p:txBody>
@@ -15853,7 +15980,7 @@
             </a:pPr>
             <a:r>
               <a:rPr/>
-              <a:t>The margin: a criterion that is not the error</a:t>
+              <a:t>Notebook 2, live</a:t>
             </a:r>
           </a:p>
         </p:txBody>
@@ -15881,48 +16008,7 @@
             <a:pPr lvl="0"/>
             <a:r>
               <a:rPr/>
-              <a:t>On separable data there are </a:t>
-            </a:r>
-            <a:r>
-              <a:rPr b="1"/>
-              <a:t>infinitely many</a:t>
-            </a:r>
-            <a:r>
-              <a:rPr/>
-              <a:t> separating lines, and every one has </a:t>
-            </a:r>
-            <a:r>
-              <a:rPr b="1"/>
-              <a:t>zero training error</a:t>
-            </a:r>
-          </a:p>
-          <a:p>
-            <a:pPr lvl="0"/>
-            <a:r>
-              <a:rPr/>
-              <a:t>Minimising the error therefore cannot choose between them</a:t>
-            </a:r>
-          </a:p>
-          <a:p>
-            <a:pPr lvl="0"/>
-            <a:r>
-              <a:rPr/>
-              <a:t>The SVM picks the widest </a:t>
-            </a:r>
-            <a:r>
-              <a:rPr b="1"/>
-              <a:t>slab</a:t>
-            </a:r>
-            <a:r>
-              <a:rPr/>
-              <a:t>: push it out until it touches the nearest point of each class</a:t>
-            </a:r>
-          </a:p>
-          <a:p>
-            <a:pPr lvl="0"/>
-            <a:r>
-              <a:rPr/>
-              <a:t>A boundary passing close to a point is one small perturbation from getting it wrong</a:t>
+              <a:t>Where breaking the assumption is cheap, and one step away where it is fatal</a:t>
             </a:r>
           </a:p>
         </p:txBody>
@@ -15933,6 +16019,127 @@
 </file>
 
 <file path=ppt/slides/slide41.xml><?xml version="1.0" encoding="utf-8"?>
+<p:sld xmlns:a="http://schemas.openxmlformats.org/drawingml/2006/main" xmlns:r="http://schemas.openxmlformats.org/officeDocument/2006/relationships" xmlns:p="http://schemas.openxmlformats.org/presentationml/2006/main">
+  <p:cSld>
+    <p:spTree>
+      <p:nvGrpSpPr>
+        <p:cNvPr id="1" name=""/>
+        <p:cNvGrpSpPr/>
+        <p:nvPr/>
+      </p:nvGrpSpPr>
+      <p:grpSpPr>
+        <a:xfrm>
+          <a:off x="0" y="0"/>
+          <a:ext cx="0" cy="0"/>
+          <a:chOff x="0" y="0"/>
+          <a:chExt cx="0" cy="0"/>
+        </a:xfrm>
+      </p:grpSpPr>
+      <p:sp>
+        <p:nvSpPr>
+          <p:cNvPr id="2" name="Title 1"/>
+          <p:cNvSpPr>
+            <a:spLocks noGrp="1"/>
+          </p:cNvSpPr>
+          <p:nvPr>
+            <p:ph type="title"/>
+          </p:nvPr>
+        </p:nvSpPr>
+        <p:spPr>
+          <a:xfrm>
+            <a:off x="457200" y="205979"/>
+            <a:ext cx="8229600" cy="857250"/>
+          </a:xfrm>
+        </p:spPr>
+        <p:txBody>
+          <a:bodyPr/>
+          <a:lstStyle/>
+          <a:p>
+            <a:pPr lvl="0" indent="0" marL="0">
+              <a:buNone/>
+            </a:pPr>
+            <a:r>
+              <a:rPr/>
+              <a:t>The margin: a criterion that is not the error</a:t>
+            </a:r>
+          </a:p>
+        </p:txBody>
+      </p:sp>
+      <p:sp>
+        <p:nvSpPr>
+          <p:cNvPr id="3" name="Content Placeholder 2"/>
+          <p:cNvSpPr>
+            <a:spLocks noGrp="1"/>
+          </p:cNvSpPr>
+          <p:nvPr>
+            <p:ph idx="1"/>
+          </p:nvPr>
+        </p:nvSpPr>
+        <p:spPr>
+          <a:xfrm>
+            <a:off x="457200" y="1200151"/>
+            <a:ext cx="8229600" cy="3394472"/>
+          </a:xfrm>
+        </p:spPr>
+        <p:txBody>
+          <a:bodyPr/>
+          <a:lstStyle/>
+          <a:p>
+            <a:pPr lvl="0"/>
+            <a:r>
+              <a:rPr/>
+              <a:t>On separable data there are </a:t>
+            </a:r>
+            <a:r>
+              <a:rPr b="1"/>
+              <a:t>infinitely many</a:t>
+            </a:r>
+            <a:r>
+              <a:rPr/>
+              <a:t> separating lines, and every one has </a:t>
+            </a:r>
+            <a:r>
+              <a:rPr b="1"/>
+              <a:t>zero training error</a:t>
+            </a:r>
+          </a:p>
+          <a:p>
+            <a:pPr lvl="0"/>
+            <a:r>
+              <a:rPr/>
+              <a:t>Minimising the error therefore cannot choose between them</a:t>
+            </a:r>
+          </a:p>
+          <a:p>
+            <a:pPr lvl="0"/>
+            <a:r>
+              <a:rPr/>
+              <a:t>The SVM picks the widest </a:t>
+            </a:r>
+            <a:r>
+              <a:rPr b="1"/>
+              <a:t>slab</a:t>
+            </a:r>
+            <a:r>
+              <a:rPr/>
+              <a:t>: push it out until it touches the nearest point of each class</a:t>
+            </a:r>
+          </a:p>
+          <a:p>
+            <a:pPr lvl="0"/>
+            <a:r>
+              <a:rPr/>
+              <a:t>A boundary passing close to a point is one small perturbation from getting it wrong</a:t>
+            </a:r>
+          </a:p>
+        </p:txBody>
+      </p:sp>
+    </p:spTree>
+  </p:cSld>
+</p:sld>
+</file>
+
+<file path=ppt/slides/slide42.xml><?xml version="1.0" encoding="utf-8"?>
 <p:sld xmlns:a="http://schemas.openxmlformats.org/drawingml/2006/main" xmlns:r="http://schemas.openxmlformats.org/officeDocument/2006/relationships" xmlns:p="http://schemas.openxmlformats.org/presentationml/2006/main">
   <p:cSld>
     <p:spTree>
@@ -16014,7 +16221,7 @@
 </p:sld>
 </file>
 
-<file path=ppt/slides/slide42.xml><?xml version="1.0" encoding="utf-8"?>
+<file path=ppt/slides/slide43.xml><?xml version="1.0" encoding="utf-8"?>
 <p:sld xmlns:a="http://schemas.openxmlformats.org/drawingml/2006/main" xmlns:r="http://schemas.openxmlformats.org/officeDocument/2006/relationships" xmlns:p="http://schemas.openxmlformats.org/presentationml/2006/main">
   <p:cSld>
     <p:spTree>
@@ -16127,7 +16334,7 @@
 </p:sld>
 </file>
 
-<file path=ppt/slides/slide43.xml><?xml version="1.0" encoding="utf-8"?>
+<file path=ppt/slides/slide44.xml><?xml version="1.0" encoding="utf-8"?>
 <p:sld xmlns:a="http://schemas.openxmlformats.org/drawingml/2006/main" xmlns:r="http://schemas.openxmlformats.org/officeDocument/2006/relationships" xmlns:p="http://schemas.openxmlformats.org/presentationml/2006/main">
   <p:cSld>
     <p:spTree>
@@ -16209,7 +16416,7 @@
 </p:sld>
 </file>
 
-<file path=ppt/slides/slide44.xml><?xml version="1.0" encoding="utf-8"?>
+<file path=ppt/slides/slide45.xml><?xml version="1.0" encoding="utf-8"?>
 <p:sld xmlns:a="http://schemas.openxmlformats.org/drawingml/2006/main" xmlns:r="http://schemas.openxmlformats.org/officeDocument/2006/relationships" xmlns:p="http://schemas.openxmlformats.org/presentationml/2006/main">
   <p:cSld>
     <p:spTree>
@@ -16322,7 +16529,7 @@
 </p:sld>
 </file>
 
-<file path=ppt/slides/slide45.xml><?xml version="1.0" encoding="utf-8"?>
+<file path=ppt/slides/slide46.xml><?xml version="1.0" encoding="utf-8"?>
 <p:sld xmlns:a="http://schemas.openxmlformats.org/drawingml/2006/main" xmlns:r="http://schemas.openxmlformats.org/officeDocument/2006/relationships" xmlns:p="http://schemas.openxmlformats.org/presentationml/2006/main">
   <p:cSld>
     <p:spTree>
@@ -16555,129 +16762,6 @@
 </p:sld>
 </file>
 
-<file path=ppt/slides/slide46.xml><?xml version="1.0" encoding="utf-8"?>
-<p:sld xmlns:a="http://schemas.openxmlformats.org/drawingml/2006/main" xmlns:r="http://schemas.openxmlformats.org/officeDocument/2006/relationships" xmlns:p="http://schemas.openxmlformats.org/presentationml/2006/main">
-  <p:cSld>
-    <p:spTree>
-      <p:nvGrpSpPr>
-        <p:cNvPr id="1" name=""/>
-        <p:cNvGrpSpPr/>
-        <p:nvPr/>
-      </p:nvGrpSpPr>
-      <p:grpSpPr>
-        <a:xfrm>
-          <a:off x="0" y="0"/>
-          <a:ext cx="0" cy="0"/>
-          <a:chOff x="0" y="0"/>
-          <a:chExt cx="0" cy="0"/>
-        </a:xfrm>
-      </p:grpSpPr>
-      <p:sp>
-        <p:nvSpPr>
-          <p:cNvPr id="2" name="Title 1"/>
-          <p:cNvSpPr>
-            <a:spLocks noGrp="1"/>
-          </p:cNvSpPr>
-          <p:nvPr>
-            <p:ph type="title"/>
-          </p:nvPr>
-        </p:nvSpPr>
-        <p:spPr>
-          <a:xfrm>
-            <a:off x="457200" y="205979"/>
-            <a:ext cx="8229600" cy="857250"/>
-          </a:xfrm>
-        </p:spPr>
-        <p:txBody>
-          <a:bodyPr/>
-          <a:lstStyle/>
-          <a:p>
-            <a:pPr lvl="0" indent="0" marL="0">
-              <a:buNone/>
-            </a:pPr>
-            <a:r>
-              <a:rPr/>
-              <a:t>A high support-vector fraction is a free warning</a:t>
-            </a:r>
-          </a:p>
-        </p:txBody>
-      </p:sp>
-      <p:sp>
-        <p:nvSpPr>
-          <p:cNvPr id="3" name="Content Placeholder 2"/>
-          <p:cNvSpPr>
-            <a:spLocks noGrp="1"/>
-          </p:cNvSpPr>
-          <p:nvPr>
-            <p:ph idx="1"/>
-          </p:nvPr>
-        </p:nvSpPr>
-        <p:spPr>
-          <a:xfrm>
-            <a:off x="457200" y="1200151"/>
-            <a:ext cx="8229600" cy="3394472"/>
-          </a:xfrm>
-        </p:spPr>
-        <p:txBody>
-          <a:bodyPr/>
-          <a:lstStyle/>
-          <a:p>
-            <a:pPr lvl="0"/>
-            <a:r>
-              <a:rPr/>
-              <a:t>The linear model needs </a:t>
-            </a:r>
-            <a:r>
-              <a:rPr b="1"/>
-              <a:t>79%</a:t>
-            </a:r>
-            <a:r>
-              <a:rPr/>
-              <a:t> of the training set to define its boundary</a:t>
-            </a:r>
-          </a:p>
-          <a:p>
-            <a:pPr lvl="0"/>
-            <a:r>
-              <a:rPr/>
-              <a:t>The RBF model needs </a:t>
-            </a:r>
-            <a:r>
-              <a:rPr b="1"/>
-              <a:t>23%</a:t>
-            </a:r>
-          </a:p>
-          <a:p>
-            <a:pPr lvl="0"/>
-            <a:r>
-              <a:rPr/>
-              <a:t>Almost every point sits on or inside the margin: there is no slab that separates anything</a:t>
-            </a:r>
-          </a:p>
-          <a:p>
-            <a:pPr lvl="0"/>
-            <a:r>
-              <a:rPr/>
-              <a:t>The count falls out of </a:t>
-            </a:r>
-            <a:r>
-              <a:rPr>
-                <a:latin typeface="Courier"/>
-              </a:rPr>
-              <a:t>fit</a:t>
-            </a:r>
-            <a:r>
-              <a:rPr/>
-              <a:t> at no cost, and you should look at it</a:t>
-            </a:r>
-          </a:p>
-        </p:txBody>
-      </p:sp>
-    </p:spTree>
-  </p:cSld>
-</p:sld>
-</file>
-
 <file path=ppt/slides/slide47.xml><?xml version="1.0" encoding="utf-8"?>
 <p:sld xmlns:a="http://schemas.openxmlformats.org/drawingml/2006/main" xmlns:r="http://schemas.openxmlformats.org/officeDocument/2006/relationships" xmlns:p="http://schemas.openxmlformats.org/presentationml/2006/main">
   <p:cSld>
@@ -16720,7 +16804,7 @@
             </a:pPr>
             <a:r>
               <a:rPr/>
-              <a:t>The kernel trick: they needed different coordinates</a:t>
+              <a:t>A high support-vector fraction is a free warning</a:t>
             </a:r>
           </a:p>
         </p:txBody>
@@ -16748,36 +16832,50 @@
             <a:pPr lvl="0"/>
             <a:r>
               <a:rPr/>
-              <a:t>Healthy pumps in a disc, faulty ones around it: no line works </a:t>
+              <a:t>The linear model needs </a:t>
             </a:r>
             <a:r>
               <a:rPr b="1"/>
-              <a:t>in the plane</a:t>
+              <a:t>79%</a:t>
+            </a:r>
+            <a:r>
+              <a:rPr/>
+              <a:t> of the training set to define its boundary</a:t>
             </a:r>
           </a:p>
           <a:p>
             <a:pPr lvl="0"/>
             <a:r>
               <a:rPr/>
-              <a:t>Add a third coordinate: the </a:t>
+              <a:t>The RBF model needs </a:t>
             </a:r>
             <a:r>
               <a:rPr b="1"/>
-              <a:t>distance from the design point</a:t>
+              <a:t>23%</a:t>
             </a:r>
           </a:p>
           <a:p>
             <a:pPr lvl="0"/>
             <a:r>
               <a:rPr/>
-              <a:t>Healthy pumps rise a little, faulty ones a lot, and a flat plane separates them perfectly</a:t>
+              <a:t>Almost every point sits on or inside the margin: there is no slab that separates anything</a:t>
             </a:r>
           </a:p>
           <a:p>
             <a:pPr lvl="0"/>
             <a:r>
               <a:rPr/>
-              <a:t>The classes were always separable. They were measured in the wrong coordinates</a:t>
+              <a:t>The count falls out of </a:t>
+            </a:r>
+            <a:r>
+              <a:rPr>
+                <a:latin typeface="Courier"/>
+              </a:rPr>
+              <a:t>fit</a:t>
+            </a:r>
+            <a:r>
+              <a:rPr/>
+              <a:t> at no cost, and you should look at it</a:t>
             </a:r>
           </a:p>
         </p:txBody>
@@ -16788,6 +16886,115 @@
 </file>
 
 <file path=ppt/slides/slide48.xml><?xml version="1.0" encoding="utf-8"?>
+<p:sld xmlns:a="http://schemas.openxmlformats.org/drawingml/2006/main" xmlns:r="http://schemas.openxmlformats.org/officeDocument/2006/relationships" xmlns:p="http://schemas.openxmlformats.org/presentationml/2006/main">
+  <p:cSld>
+    <p:spTree>
+      <p:nvGrpSpPr>
+        <p:cNvPr id="1" name=""/>
+        <p:cNvGrpSpPr/>
+        <p:nvPr/>
+      </p:nvGrpSpPr>
+      <p:grpSpPr>
+        <a:xfrm>
+          <a:off x="0" y="0"/>
+          <a:ext cx="0" cy="0"/>
+          <a:chOff x="0" y="0"/>
+          <a:chExt cx="0" cy="0"/>
+        </a:xfrm>
+      </p:grpSpPr>
+      <p:sp>
+        <p:nvSpPr>
+          <p:cNvPr id="2" name="Title 1"/>
+          <p:cNvSpPr>
+            <a:spLocks noGrp="1"/>
+          </p:cNvSpPr>
+          <p:nvPr>
+            <p:ph type="title"/>
+          </p:nvPr>
+        </p:nvSpPr>
+        <p:spPr>
+          <a:xfrm>
+            <a:off x="457200" y="205979"/>
+            <a:ext cx="8229600" cy="857250"/>
+          </a:xfrm>
+        </p:spPr>
+        <p:txBody>
+          <a:bodyPr/>
+          <a:lstStyle/>
+          <a:p>
+            <a:pPr lvl="0" indent="0" marL="0">
+              <a:buNone/>
+            </a:pPr>
+            <a:r>
+              <a:rPr/>
+              <a:t>The kernel trick: they needed different coordinates</a:t>
+            </a:r>
+          </a:p>
+        </p:txBody>
+      </p:sp>
+      <p:sp>
+        <p:nvSpPr>
+          <p:cNvPr id="3" name="Content Placeholder 2"/>
+          <p:cNvSpPr>
+            <a:spLocks noGrp="1"/>
+          </p:cNvSpPr>
+          <p:nvPr>
+            <p:ph idx="1"/>
+          </p:nvPr>
+        </p:nvSpPr>
+        <p:spPr>
+          <a:xfrm>
+            <a:off x="457200" y="1200151"/>
+            <a:ext cx="8229600" cy="3394472"/>
+          </a:xfrm>
+        </p:spPr>
+        <p:txBody>
+          <a:bodyPr/>
+          <a:lstStyle/>
+          <a:p>
+            <a:pPr lvl="0"/>
+            <a:r>
+              <a:rPr/>
+              <a:t>Healthy pumps in a disc, faulty ones around it: no line works </a:t>
+            </a:r>
+            <a:r>
+              <a:rPr b="1"/>
+              <a:t>in the plane</a:t>
+            </a:r>
+          </a:p>
+          <a:p>
+            <a:pPr lvl="0"/>
+            <a:r>
+              <a:rPr/>
+              <a:t>Add a third coordinate: the </a:t>
+            </a:r>
+            <a:r>
+              <a:rPr b="1"/>
+              <a:t>distance from the design point</a:t>
+            </a:r>
+          </a:p>
+          <a:p>
+            <a:pPr lvl="0"/>
+            <a:r>
+              <a:rPr/>
+              <a:t>Healthy pumps rise a little, faulty ones a lot, and a flat plane separates them perfectly</a:t>
+            </a:r>
+          </a:p>
+          <a:p>
+            <a:pPr lvl="0"/>
+            <a:r>
+              <a:rPr/>
+              <a:t>The classes were always separable. They were measured in the wrong coordinates</a:t>
+            </a:r>
+          </a:p>
+        </p:txBody>
+      </p:sp>
+    </p:spTree>
+  </p:cSld>
+</p:sld>
+</file>
+
+<file path=ppt/slides/slide49.xml><?xml version="1.0" encoding="utf-8"?>
 <p:sld xmlns:a="http://schemas.openxmlformats.org/drawingml/2006/main" xmlns:r="http://schemas.openxmlformats.org/officeDocument/2006/relationships" xmlns:p="http://schemas.openxmlformats.org/presentationml/2006/main">
   <p:cSld>
     <p:spTree>
@@ -16864,124 +17071,6 @@
           </a:ln>
         </p:spPr>
       </p:pic>
-    </p:spTree>
-  </p:cSld>
-</p:sld>
-</file>
-
-<file path=ppt/slides/slide49.xml><?xml version="1.0" encoding="utf-8"?>
-<p:sld xmlns:a="http://schemas.openxmlformats.org/drawingml/2006/main" xmlns:r="http://schemas.openxmlformats.org/officeDocument/2006/relationships" xmlns:p="http://schemas.openxmlformats.org/presentationml/2006/main">
-  <p:cSld>
-    <p:spTree>
-      <p:nvGrpSpPr>
-        <p:cNvPr id="1" name=""/>
-        <p:cNvGrpSpPr/>
-        <p:nvPr/>
-      </p:nvGrpSpPr>
-      <p:grpSpPr>
-        <a:xfrm>
-          <a:off x="0" y="0"/>
-          <a:ext cx="0" cy="0"/>
-          <a:chOff x="0" y="0"/>
-          <a:chExt cx="0" cy="0"/>
-        </a:xfrm>
-      </p:grpSpPr>
-      <p:sp>
-        <p:nvSpPr>
-          <p:cNvPr id="2" name="Title 1"/>
-          <p:cNvSpPr>
-            <a:spLocks noGrp="1"/>
-          </p:cNvSpPr>
-          <p:nvPr>
-            <p:ph type="title"/>
-          </p:nvPr>
-        </p:nvSpPr>
-        <p:spPr>
-          <a:xfrm>
-            <a:off x="457200" y="205979"/>
-            <a:ext cx="8229600" cy="857250"/>
-          </a:xfrm>
-        </p:spPr>
-        <p:txBody>
-          <a:bodyPr/>
-          <a:lstStyle/>
-          <a:p>
-            <a:pPr lvl="0" indent="0" marL="0">
-              <a:buNone/>
-            </a:pPr>
-            <a:r>
-              <a:rPr/>
-              <a:t>And the map is never computed</a:t>
-            </a:r>
-          </a:p>
-        </p:txBody>
-      </p:sp>
-      <p:sp>
-        <p:nvSpPr>
-          <p:cNvPr id="3" name="Content Placeholder 2"/>
-          <p:cNvSpPr>
-            <a:spLocks noGrp="1"/>
-          </p:cNvSpPr>
-          <p:nvPr>
-            <p:ph idx="1"/>
-          </p:nvPr>
-        </p:nvSpPr>
-        <p:spPr>
-          <a:xfrm>
-            <a:off x="457200" y="1200151"/>
-            <a:ext cx="8229600" cy="3394472"/>
-          </a:xfrm>
-        </p:spPr>
-        <p:txBody>
-          <a:bodyPr/>
-          <a:lstStyle/>
-          <a:p>
-            <a:pPr lvl="0"/>
-            <a:r>
-              <a:rPr/>
-              <a:t>The solution depends on the data </a:t>
-            </a:r>
-            <a:r>
-              <a:rPr b="1"/>
-              <a:t>only through inner products</a:t>
-            </a:r>
-            <a:r>
-              <a:rPr/>
-              <a:t> between pairs of points</a:t>
-            </a:r>
-          </a:p>
-          <a:p>
-            <a:pPr lvl="0"/>
-            <a:r>
-              <a:rPr/>
-              <a:t>So we need a function returning the inner product </a:t>
-            </a:r>
-            <a:r>
-              <a:rPr b="1"/>
-              <a:t>in the new space</a:t>
-            </a:r>
-            <a:r>
-              <a:rPr/>
-              <a:t>, while computing only with the original one</a:t>
-            </a:r>
-          </a:p>
-          <a:p>
-            <a:pPr lvl="0"/>
-            <a:r>
-              <a:rPr/>
-              <a:t>The radial basis function is scikit-learn’s default: one exponential per pair, for an </a:t>
-            </a:r>
-            <a:r>
-              <a:rPr b="1"/>
-              <a:t>infinite-dimensional</a:t>
-            </a:r>
-            <a:r>
-              <a:rPr/>
-              <a:t> space</a:t>
-            </a:r>
-          </a:p>
-        </p:txBody>
-      </p:sp>
     </p:spTree>
   </p:cSld>
 </p:sld>
@@ -17070,6 +17159,124 @@
 </file>
 
 <file path=ppt/slides/slide50.xml><?xml version="1.0" encoding="utf-8"?>
+<p:sld xmlns:a="http://schemas.openxmlformats.org/drawingml/2006/main" xmlns:r="http://schemas.openxmlformats.org/officeDocument/2006/relationships" xmlns:p="http://schemas.openxmlformats.org/presentationml/2006/main">
+  <p:cSld>
+    <p:spTree>
+      <p:nvGrpSpPr>
+        <p:cNvPr id="1" name=""/>
+        <p:cNvGrpSpPr/>
+        <p:nvPr/>
+      </p:nvGrpSpPr>
+      <p:grpSpPr>
+        <a:xfrm>
+          <a:off x="0" y="0"/>
+          <a:ext cx="0" cy="0"/>
+          <a:chOff x="0" y="0"/>
+          <a:chExt cx="0" cy="0"/>
+        </a:xfrm>
+      </p:grpSpPr>
+      <p:sp>
+        <p:nvSpPr>
+          <p:cNvPr id="2" name="Title 1"/>
+          <p:cNvSpPr>
+            <a:spLocks noGrp="1"/>
+          </p:cNvSpPr>
+          <p:nvPr>
+            <p:ph type="title"/>
+          </p:nvPr>
+        </p:nvSpPr>
+        <p:spPr>
+          <a:xfrm>
+            <a:off x="457200" y="205979"/>
+            <a:ext cx="8229600" cy="857250"/>
+          </a:xfrm>
+        </p:spPr>
+        <p:txBody>
+          <a:bodyPr/>
+          <a:lstStyle/>
+          <a:p>
+            <a:pPr lvl="0" indent="0" marL="0">
+              <a:buNone/>
+            </a:pPr>
+            <a:r>
+              <a:rPr/>
+              <a:t>And the map is never computed</a:t>
+            </a:r>
+          </a:p>
+        </p:txBody>
+      </p:sp>
+      <p:sp>
+        <p:nvSpPr>
+          <p:cNvPr id="3" name="Content Placeholder 2"/>
+          <p:cNvSpPr>
+            <a:spLocks noGrp="1"/>
+          </p:cNvSpPr>
+          <p:nvPr>
+            <p:ph idx="1"/>
+          </p:nvPr>
+        </p:nvSpPr>
+        <p:spPr>
+          <a:xfrm>
+            <a:off x="457200" y="1200151"/>
+            <a:ext cx="8229600" cy="3394472"/>
+          </a:xfrm>
+        </p:spPr>
+        <p:txBody>
+          <a:bodyPr/>
+          <a:lstStyle/>
+          <a:p>
+            <a:pPr lvl="0"/>
+            <a:r>
+              <a:rPr/>
+              <a:t>The solution depends on the data </a:t>
+            </a:r>
+            <a:r>
+              <a:rPr b="1"/>
+              <a:t>only through inner products</a:t>
+            </a:r>
+            <a:r>
+              <a:rPr/>
+              <a:t> between pairs of points</a:t>
+            </a:r>
+          </a:p>
+          <a:p>
+            <a:pPr lvl="0"/>
+            <a:r>
+              <a:rPr/>
+              <a:t>So we need a function returning the inner product </a:t>
+            </a:r>
+            <a:r>
+              <a:rPr b="1"/>
+              <a:t>in the new space</a:t>
+            </a:r>
+            <a:r>
+              <a:rPr/>
+              <a:t>, while computing only with the original one</a:t>
+            </a:r>
+          </a:p>
+          <a:p>
+            <a:pPr lvl="0"/>
+            <a:r>
+              <a:rPr/>
+              <a:t>The radial basis function is scikit-learn’s default: one exponential per pair, for an </a:t>
+            </a:r>
+            <a:r>
+              <a:rPr b="1"/>
+              <a:t>infinite-dimensional</a:t>
+            </a:r>
+            <a:r>
+              <a:rPr/>
+              <a:t> space</a:t>
+            </a:r>
+          </a:p>
+        </p:txBody>
+      </p:sp>
+    </p:spTree>
+  </p:cSld>
+</p:sld>
+</file>
+
+<file path=ppt/slides/slide51.xml><?xml version="1.0" encoding="utf-8"?>
 <p:sld xmlns:a="http://schemas.openxmlformats.org/drawingml/2006/main" xmlns:r="http://schemas.openxmlformats.org/officeDocument/2006/relationships" xmlns:p="http://schemas.openxmlformats.org/presentationml/2006/main">
   <p:cSld>
     <p:spTree>
@@ -17294,7 +17501,7 @@
 </p:sld>
 </file>
 
-<file path=ppt/slides/slide51.xml><?xml version="1.0" encoding="utf-8"?>
+<file path=ppt/slides/slide52.xml><?xml version="1.0" encoding="utf-8"?>
 <p:sld xmlns:a="http://schemas.openxmlformats.org/drawingml/2006/main" xmlns:r="http://schemas.openxmlformats.org/officeDocument/2006/relationships" xmlns:p="http://schemas.openxmlformats.org/presentationml/2006/main">
   <p:cSld>
     <p:spTree>
@@ -17376,7 +17583,7 @@
 </p:sld>
 </file>
 
-<file path=ppt/slides/slide52.xml><?xml version="1.0" encoding="utf-8"?>
+<file path=ppt/slides/slide53.xml><?xml version="1.0" encoding="utf-8"?>
 <p:sld xmlns:a="http://schemas.openxmlformats.org/drawingml/2006/main" xmlns:r="http://schemas.openxmlformats.org/officeDocument/2006/relationships" xmlns:p="http://schemas.openxmlformats.org/presentationml/2006/main">
   <p:cSld>
     <p:spTree>
@@ -17501,7 +17708,7 @@
 </p:sld>
 </file>
 
-<file path=ppt/slides/slide53.xml><?xml version="1.0" encoding="utf-8"?>
+<file path=ppt/slides/slide54.xml><?xml version="1.0" encoding="utf-8"?>
 <p:sld xmlns:a="http://schemas.openxmlformats.org/drawingml/2006/main" xmlns:r="http://schemas.openxmlformats.org/officeDocument/2006/relationships" xmlns:p="http://schemas.openxmlformats.org/presentationml/2006/main">
   <p:cSld>
     <p:spTree>
@@ -17743,7 +17950,7 @@
 </p:sld>
 </file>
 
-<file path=ppt/slides/slide54.xml><?xml version="1.0" encoding="utf-8"?>
+<file path=ppt/slides/slide55.xml><?xml version="1.0" encoding="utf-8"?>
 <p:sld xmlns:a="http://schemas.openxmlformats.org/drawingml/2006/main" xmlns:r="http://schemas.openxmlformats.org/officeDocument/2006/relationships" xmlns:p="http://schemas.openxmlformats.org/presentationml/2006/main">
   <p:cSld>
     <p:spTree>
@@ -18015,7 +18222,7 @@
 </p:sld>
 </file>
 
-<file path=ppt/slides/slide55.xml><?xml version="1.0" encoding="utf-8"?>
+<file path=ppt/slides/slide56.xml><?xml version="1.0" encoding="utf-8"?>
 <p:sld xmlns:a="http://schemas.openxmlformats.org/drawingml/2006/main" xmlns:r="http://schemas.openxmlformats.org/officeDocument/2006/relationships" xmlns:p="http://schemas.openxmlformats.org/presentationml/2006/main">
   <p:cSld>
     <p:spTree>
@@ -18097,7 +18304,7 @@
 </p:sld>
 </file>
 
-<file path=ppt/slides/slide56.xml><?xml version="1.0" encoding="utf-8"?>
+<file path=ppt/slides/slide57.xml><?xml version="1.0" encoding="utf-8"?>
 <p:sld xmlns:a="http://schemas.openxmlformats.org/drawingml/2006/main" xmlns:r="http://schemas.openxmlformats.org/officeDocument/2006/relationships" xmlns:p="http://schemas.openxmlformats.org/presentationml/2006/main">
   <p:cSld>
     <p:spTree>
@@ -18177,7 +18384,7 @@
 </p:sld>
 </file>
 
-<file path=ppt/slides/slide57.xml><?xml version="1.0" encoding="utf-8"?>
+<file path=ppt/slides/slide58.xml><?xml version="1.0" encoding="utf-8"?>
 <p:sld xmlns:a="http://schemas.openxmlformats.org/drawingml/2006/main" xmlns:r="http://schemas.openxmlformats.org/officeDocument/2006/relationships" xmlns:p="http://schemas.openxmlformats.org/presentationml/2006/main">
   <p:cSld>
     <p:spTree>
@@ -18515,7 +18722,7 @@
 </p:sld>
 </file>
 
-<file path=ppt/slides/slide58.xml><?xml version="1.0" encoding="utf-8"?>
+<file path=ppt/slides/slide59.xml><?xml version="1.0" encoding="utf-8"?>
 <p:sld xmlns:a="http://schemas.openxmlformats.org/drawingml/2006/main" xmlns:r="http://schemas.openxmlformats.org/officeDocument/2006/relationships" xmlns:p="http://schemas.openxmlformats.org/presentationml/2006/main">
   <p:cSld>
     <p:spTree>
@@ -18793,138 +19000,6 @@
 </p:sld>
 </file>
 
-<file path=ppt/slides/slide59.xml><?xml version="1.0" encoding="utf-8"?>
-<p:sld xmlns:a="http://schemas.openxmlformats.org/drawingml/2006/main" xmlns:r="http://schemas.openxmlformats.org/officeDocument/2006/relationships" xmlns:p="http://schemas.openxmlformats.org/presentationml/2006/main">
-  <p:cSld>
-    <p:spTree>
-      <p:nvGrpSpPr>
-        <p:cNvPr id="1" name=""/>
-        <p:cNvGrpSpPr/>
-        <p:nvPr/>
-      </p:nvGrpSpPr>
-      <p:grpSpPr>
-        <a:xfrm>
-          <a:off x="0" y="0"/>
-          <a:ext cx="0" cy="0"/>
-          <a:chOff x="0" y="0"/>
-          <a:chExt cx="0" cy="0"/>
-        </a:xfrm>
-      </p:grpSpPr>
-      <p:sp>
-        <p:nvSpPr>
-          <p:cNvPr id="2" name="Title 1"/>
-          <p:cNvSpPr>
-            <a:spLocks noGrp="1"/>
-          </p:cNvSpPr>
-          <p:nvPr>
-            <p:ph type="title"/>
-          </p:nvPr>
-        </p:nvSpPr>
-        <p:spPr>
-          <a:xfrm>
-            <a:off x="457200" y="205979"/>
-            <a:ext cx="8229600" cy="857250"/>
-          </a:xfrm>
-        </p:spPr>
-        <p:txBody>
-          <a:bodyPr/>
-          <a:lstStyle/>
-          <a:p>
-            <a:pPr lvl="0" indent="0" marL="0">
-              <a:buNone/>
-            </a:pPr>
-            <a:r>
-              <a:rPr/>
-              <a:t>What to take away</a:t>
-            </a:r>
-          </a:p>
-        </p:txBody>
-      </p:sp>
-      <p:sp>
-        <p:nvSpPr>
-          <p:cNvPr id="3" name="Content Placeholder 2"/>
-          <p:cNvSpPr>
-            <a:spLocks noGrp="1"/>
-          </p:cNvSpPr>
-          <p:nvPr>
-            <p:ph idx="1"/>
-          </p:nvPr>
-        </p:nvSpPr>
-        <p:spPr>
-          <a:xfrm>
-            <a:off x="457200" y="1200151"/>
-            <a:ext cx="8229600" cy="3394472"/>
-          </a:xfrm>
-        </p:spPr>
-        <p:txBody>
-          <a:bodyPr/>
-          <a:lstStyle/>
-          <a:p>
-            <a:pPr lvl="0"/>
-            <a:r>
-              <a:rPr b="1"/>
-              <a:t>No line separates the pumps</a:t>
-            </a:r>
-            <a:r>
-              <a:rPr/>
-              <a:t>: 0.613, the base rate</a:t>
-            </a:r>
-          </a:p>
-          <a:p>
-            <a:pPr lvl="0"/>
-            <a:r>
-              <a:rPr b="1"/>
-              <a:t>k is the bias-variance dial</a:t>
-            </a:r>
-            <a:r>
-              <a:rPr/>
-              <a:t>, made visible</a:t>
-            </a:r>
-          </a:p>
-          <a:p>
-            <a:pPr lvl="0"/>
-            <a:r>
-              <a:rPr b="1"/>
-              <a:t>In 100 dimensions the nearest point is 70% as far as the farthest</a:t>
-            </a:r>
-          </a:p>
-          <a:p>
-            <a:pPr lvl="0"/>
-            <a:r>
-              <a:rPr b="1"/>
-              <a:t>Naive Bayes</a:t>
-            </a:r>
-            <a:r>
-              <a:rPr/>
-              <a:t>: 0.933 where independence holds, </a:t>
-            </a:r>
-            <a:r>
-              <a:rPr b="1"/>
-              <a:t>0.404</a:t>
-            </a:r>
-            <a:r>
-              <a:rPr/>
-              <a:t> where it does not</a:t>
-            </a:r>
-          </a:p>
-          <a:p>
-            <a:pPr lvl="0"/>
-            <a:r>
-              <a:rPr b="1"/>
-              <a:t>Choosing the family beats tuning the wrong one</a:t>
-            </a:r>
-            <a:r>
-              <a:rPr/>
-              <a:t>: 0.613 to 0.947</a:t>
-            </a:r>
-          </a:p>
-        </p:txBody>
-      </p:sp>
-    </p:spTree>
-  </p:cSld>
-</p:sld>
-</file>
-
 <file path=ppt/slides/slide6.xml><?xml version="1.0" encoding="utf-8"?>
 <p:sld xmlns:a="http://schemas.openxmlformats.org/drawingml/2006/main" xmlns:r="http://schemas.openxmlformats.org/officeDocument/2006/relationships" xmlns:p="http://schemas.openxmlformats.org/presentationml/2006/main">
   <p:cSld>
@@ -19104,6 +19179,138 @@
 </file>
 
 <file path=ppt/slides/slide60.xml><?xml version="1.0" encoding="utf-8"?>
+<p:sld xmlns:a="http://schemas.openxmlformats.org/drawingml/2006/main" xmlns:r="http://schemas.openxmlformats.org/officeDocument/2006/relationships" xmlns:p="http://schemas.openxmlformats.org/presentationml/2006/main">
+  <p:cSld>
+    <p:spTree>
+      <p:nvGrpSpPr>
+        <p:cNvPr id="1" name=""/>
+        <p:cNvGrpSpPr/>
+        <p:nvPr/>
+      </p:nvGrpSpPr>
+      <p:grpSpPr>
+        <a:xfrm>
+          <a:off x="0" y="0"/>
+          <a:ext cx="0" cy="0"/>
+          <a:chOff x="0" y="0"/>
+          <a:chExt cx="0" cy="0"/>
+        </a:xfrm>
+      </p:grpSpPr>
+      <p:sp>
+        <p:nvSpPr>
+          <p:cNvPr id="2" name="Title 1"/>
+          <p:cNvSpPr>
+            <a:spLocks noGrp="1"/>
+          </p:cNvSpPr>
+          <p:nvPr>
+            <p:ph type="title"/>
+          </p:nvPr>
+        </p:nvSpPr>
+        <p:spPr>
+          <a:xfrm>
+            <a:off x="457200" y="205979"/>
+            <a:ext cx="8229600" cy="857250"/>
+          </a:xfrm>
+        </p:spPr>
+        <p:txBody>
+          <a:bodyPr/>
+          <a:lstStyle/>
+          <a:p>
+            <a:pPr lvl="0" indent="0" marL="0">
+              <a:buNone/>
+            </a:pPr>
+            <a:r>
+              <a:rPr/>
+              <a:t>What to take away</a:t>
+            </a:r>
+          </a:p>
+        </p:txBody>
+      </p:sp>
+      <p:sp>
+        <p:nvSpPr>
+          <p:cNvPr id="3" name="Content Placeholder 2"/>
+          <p:cNvSpPr>
+            <a:spLocks noGrp="1"/>
+          </p:cNvSpPr>
+          <p:nvPr>
+            <p:ph idx="1"/>
+          </p:nvPr>
+        </p:nvSpPr>
+        <p:spPr>
+          <a:xfrm>
+            <a:off x="457200" y="1200151"/>
+            <a:ext cx="8229600" cy="3394472"/>
+          </a:xfrm>
+        </p:spPr>
+        <p:txBody>
+          <a:bodyPr/>
+          <a:lstStyle/>
+          <a:p>
+            <a:pPr lvl="0"/>
+            <a:r>
+              <a:rPr b="1"/>
+              <a:t>No line separates the pumps</a:t>
+            </a:r>
+            <a:r>
+              <a:rPr/>
+              <a:t>: 0.613, the base rate</a:t>
+            </a:r>
+          </a:p>
+          <a:p>
+            <a:pPr lvl="0"/>
+            <a:r>
+              <a:rPr b="1"/>
+              <a:t>k is the bias-variance dial</a:t>
+            </a:r>
+            <a:r>
+              <a:rPr/>
+              <a:t>, made visible</a:t>
+            </a:r>
+          </a:p>
+          <a:p>
+            <a:pPr lvl="0"/>
+            <a:r>
+              <a:rPr b="1"/>
+              <a:t>In 100 dimensions the nearest point is 70% as far as the farthest</a:t>
+            </a:r>
+          </a:p>
+          <a:p>
+            <a:pPr lvl="0"/>
+            <a:r>
+              <a:rPr b="1"/>
+              <a:t>Naive Bayes</a:t>
+            </a:r>
+            <a:r>
+              <a:rPr/>
+              <a:t>: 0.933 where independence holds, </a:t>
+            </a:r>
+            <a:r>
+              <a:rPr b="1"/>
+              <a:t>0.404</a:t>
+            </a:r>
+            <a:r>
+              <a:rPr/>
+              <a:t> where it does not</a:t>
+            </a:r>
+          </a:p>
+          <a:p>
+            <a:pPr lvl="0"/>
+            <a:r>
+              <a:rPr b="1"/>
+              <a:t>Choosing the family beats tuning the wrong one</a:t>
+            </a:r>
+            <a:r>
+              <a:rPr/>
+              <a:t>: 0.613 to 0.947</a:t>
+            </a:r>
+          </a:p>
+        </p:txBody>
+      </p:sp>
+    </p:spTree>
+  </p:cSld>
+</p:sld>
+</file>
+
+<file path=ppt/slides/slide61.xml><?xml version="1.0" encoding="utf-8"?>
 <p:sld xmlns:a="http://schemas.openxmlformats.org/drawingml/2006/main" xmlns:r="http://schemas.openxmlformats.org/officeDocument/2006/relationships" xmlns:p="http://schemas.openxmlformats.org/presentationml/2006/main">
   <p:cSld>
     <p:spTree>

</xml_diff>

<commit_message>
Draw four of lesson 6's arguments that were only told
Four figures, each generated in a notebook and placed on its own slide and
beside the paragraph it illustrates: Naive Bayes' elliptical boundary
against the true envelope (section 4.3), the hinge loss against lesson 4's
log loss as functions of the margin (5.2), one pump's SVM vote with every
support vector sized by its similarity (5.5), and RBF similarity against
distance for each gamma, with the half-similarity reach marked (5.6). The
deck grows to 65 slides; the lesson plan's minutes are unchanged.

Co-Authored-By: Claude Opus 5.5 <noreply@anthropic.com>
</commit_message>
<xml_diff>
--- a/Lessons/06_knn_naive_bayes_svm/Slides/knn_naive_bayes_svm_slides.pptx
+++ b/Lessons/06_knn_naive_bayes_svm/Slides/knn_naive_bayes_svm_slides.pptx
@@ -5,7 +5,7 @@
     <p:sldMasterId id="2147483648" r:id="rId1"/>
   </p:sldMasterIdLst>
   <p:notesMasterIdLst>
-    <p:notesMasterId r:id="rId63"/>
+    <p:notesMasterId r:id="rId67"/>
   </p:notesMasterIdLst>
   <p:sldIdLst>
     <p:sldId id="256" r:id="rId2"/>
@@ -69,6 +69,10 @@
     <p:sldId id="314" r:id="rId60"/>
     <p:sldId id="315" r:id="rId61"/>
     <p:sldId id="316" r:id="rId62"/>
+    <p:sldId id="317" r:id="rId63"/>
+    <p:sldId id="318" r:id="rId64"/>
+    <p:sldId id="319" r:id="rId65"/>
+    <p:sldId id="320" r:id="rId66"/>
   </p:sldIdLst>
   <p:sldSz cx="9144000" cy="5143500" type="screen16x9"/>
   <p:notesSz cx="6858000" cy="9144000"/>
@@ -3956,49 +3960,21 @@
             </a:pPr>
             <a:r>
               <a:rPr/>
-              <a:t>Change one thing about the problem and watch the method fall apart. Describe the physics before the geometry, because the rule is completely reasonable engineering.</a:t>
-            </a:r>
-          </a:p>
-          <a:p>
-            <a:pPr lvl="0" indent="0" marL="0">
-              <a:buNone/>
-            </a:pPr>
-          </a:p>
-          <a:p>
-            <a:pPr lvl="0" indent="0" marL="0">
-              <a:buNone/>
-            </a:pPr>
-            <a:r>
-              <a:rPr/>
-              <a:t>High demand and high delivery: fine, that is the machine working hard. Low and low: fine, that is idle. High demand with low delivery, or the reverse: something is wrong between them. Exactly one high means faulty.</a:t>
-            </a:r>
-          </a:p>
-          <a:p>
-            <a:pPr lvl="0" indent="0" marL="0">
-              <a:buNone/>
-            </a:pPr>
-          </a:p>
-          <a:p>
-            <a:pPr lvl="0" indent="0" marL="0">
-              <a:buNone/>
-            </a:pPr>
-            <a:r>
-              <a:rPr/>
-              <a:t>Ask them, before the picture, what each sensor tells you ON ITS OWN under that rule. Give it a moment. The answer is: nothing at all. Every value of sensor A appears in both classes about equally often, because whether it means “faulty” depends entirely on sensor B.</a:t>
-            </a:r>
-          </a:p>
-          <a:p>
-            <a:pPr lvl="0" indent="0" marL="0">
-              <a:buNone/>
-            </a:pPr>
-          </a:p>
-          <a:p>
-            <a:pPr lvl="0" indent="0" marL="0">
-              <a:buNone/>
-            </a:pPr>
-            <a:r>
-              <a:rPr/>
-              <a:t>That is what an interaction is, and it is precisely the structure the independence assumption is unable to represent. Handout section 4.4.</a:t>
+              <a:t>The previous slide’s argument, drawn. Dots are the pumps; the solid black ellipse is where the fitted Naive Bayes model changes its mind; the dashed gold one is the envelope the data was generated from.</a:t>
+            </a:r>
+          </a:p>
+          <a:p>
+            <a:pPr lvl="0" indent="0" marL="0">
+              <a:buNone/>
+            </a:pPr>
+          </a:p>
+          <a:p>
+            <a:pPr lvl="0" indent="0" marL="0">
+              <a:buNone/>
+            </a:pPr>
+            <a:r>
+              <a:rPr/>
+              <a:t>Let them compare the two shapes before saying anything: same orientation, same proportions, the model’s about a tenth smaller - 3.17 Hz by 0.41 bar against 3.5 by 0.45. The assumption is false, the densities it multiplies are wrong, and the boundary they imply is nearly right. That is why 0.933 sits so close to k-NN’s 0.944. Handout section 4.3.</a:t>
             </a:r>
           </a:p>
         </p:txBody>
@@ -4080,77 +4056,49 @@
             </a:pPr>
             <a:r>
               <a:rPr/>
-              <a:t>Left panel: the two sensors together. Four clean groups, and a perfectly learnable rule - any method that can draw a non-linear boundary will find it.</a:t>
-            </a:r>
-          </a:p>
-          <a:p>
-            <a:pPr lvl="0" indent="0" marL="0">
-              <a:buNone/>
-            </a:pPr>
-          </a:p>
-          <a:p>
-            <a:pPr lvl="0" indent="0" marL="0">
-              <a:buNone/>
-            </a:pPr>
-            <a:r>
-              <a:rPr/>
-              <a:t>Colours first, because someone will ask: teal is healthy, rust is faulty, everywhere. In the left panel each class owns two opposite quadrants - healthy has both sensors high or both low, faulty one high and one low.</a:t>
-            </a:r>
-          </a:p>
-          <a:p>
-            <a:pPr lvl="0" indent="0" marL="0">
-              <a:buNone/>
-            </a:pPr>
-          </a:p>
-          <a:p>
-            <a:pPr lvl="0" indent="0" marL="0">
-              <a:buNone/>
-            </a:pPr>
-            <a:r>
-              <a:rPr/>
-              <a:t>Middle and right: each sensor on its own, which is ALL Naive Bayes ever gets. Solid outlines are the data. Each sensor is either low or high, so each outline has two humps - and healthy and faulty have the SAME two humps, because each class is about half low and half high on each sensor alone.</a:t>
-            </a:r>
-          </a:p>
-          <a:p>
-            <a:pPr lvl="0" indent="0" marL="0">
-              <a:buNone/>
-            </a:pPr>
-          </a:p>
-          <a:p>
-            <a:pPr lvl="0" indent="0" marL="0">
-              <a:buNone/>
-            </a:pPr>
-            <a:r>
-              <a:rPr/>
-              <a:t>The dashed curves are what the model fits: one bell per sensor per class. A single bell cannot follow two humps, so it sits in the valley between them, and the two classes’ bells almost coincide - centre near 0, sd about 1.1 for both. Contrast the pumps a few slides ago: bells with a shared centre but widths of 1.695 against 4.636 Hz, and the widths carried the class. Here nothing does.</a:t>
-            </a:r>
-          </a:p>
-          <a:p>
-            <a:pPr lvl="0" indent="0" marL="0">
-              <a:buNone/>
-            </a:pPr>
-          </a:p>
-          <a:p>
-            <a:pPr lvl="0" indent="0" marL="0">
-              <a:buNone/>
-            </a:pPr>
-            <a:r>
-              <a:rPr/>
-              <a:t>That is the slide in one sentence: the information is real, it is entirely in the relationship between the columns, and factorising the density throws that relationship away before the model ever sees it.</a:t>
-            </a:r>
-          </a:p>
-          <a:p>
-            <a:pPr lvl="0" indent="0" marL="0">
-              <a:buNone/>
-            </a:pPr>
-          </a:p>
-          <a:p>
-            <a:pPr lvl="0" indent="0" marL="0">
-              <a:buNone/>
-            </a:pPr>
-            <a:r>
-              <a:rPr/>
-              <a:t>Worth saying that no amount of data repairs this. It is not an estimation problem - with a million rows the marginals still overlap. The model cannot represent what is being asked of it.</a:t>
+              <a:t>Change one thing about the problem and watch the method fall apart. Describe the physics before the geometry, because the rule is completely reasonable engineering.</a:t>
+            </a:r>
+          </a:p>
+          <a:p>
+            <a:pPr lvl="0" indent="0" marL="0">
+              <a:buNone/>
+            </a:pPr>
+          </a:p>
+          <a:p>
+            <a:pPr lvl="0" indent="0" marL="0">
+              <a:buNone/>
+            </a:pPr>
+            <a:r>
+              <a:rPr/>
+              <a:t>High demand and high delivery: fine, that is the machine working hard. Low and low: fine, that is idle. High demand with low delivery, or the reverse: something is wrong between them. Exactly one high means faulty.</a:t>
+            </a:r>
+          </a:p>
+          <a:p>
+            <a:pPr lvl="0" indent="0" marL="0">
+              <a:buNone/>
+            </a:pPr>
+          </a:p>
+          <a:p>
+            <a:pPr lvl="0" indent="0" marL="0">
+              <a:buNone/>
+            </a:pPr>
+            <a:r>
+              <a:rPr/>
+              <a:t>Ask them, before the picture, what each sensor tells you ON ITS OWN under that rule. Give it a moment. The answer is: nothing at all. Every value of sensor A appears in both classes about equally often, because whether it means “faulty” depends entirely on sensor B.</a:t>
+            </a:r>
+          </a:p>
+          <a:p>
+            <a:pPr lvl="0" indent="0" marL="0">
+              <a:buNone/>
+            </a:pPr>
+          </a:p>
+          <a:p>
+            <a:pPr lvl="0" indent="0" marL="0">
+              <a:buNone/>
+            </a:pPr>
+            <a:r>
+              <a:rPr/>
+              <a:t>That is what an interaction is, and it is precisely the structure the independence assumption is unable to represent. Handout section 4.4.</a:t>
             </a:r>
           </a:p>
         </p:txBody>
@@ -4232,63 +4180,77 @@
             </a:pPr>
             <a:r>
               <a:rPr/>
-              <a:t>Two things to draw out, and the second is the more interesting.</a:t>
-            </a:r>
-          </a:p>
-          <a:p>
-            <a:pPr lvl="0" indent="0" marL="0">
-              <a:buNone/>
-            </a:pPr>
-          </a:p>
-          <a:p>
-            <a:pPr lvl="0" indent="0" marL="0">
-              <a:buNone/>
-            </a:pPr>
-            <a:r>
-              <a:rPr/>
-              <a:t>First: k-NN and the RBF SVM are at 0.967 and 0.972 on this data. The problem is not hard. It is only hard for a model that looks at one feature at a time.</a:t>
-            </a:r>
-          </a:p>
-          <a:p>
-            <a:pPr lvl="0" indent="0" marL="0">
-              <a:buNone/>
-            </a:pPr>
-          </a:p>
-          <a:p>
-            <a:pPr lvl="0" indent="0" marL="0">
-              <a:buNone/>
-            </a:pPr>
-            <a:r>
-              <a:rPr/>
-              <a:t>Second, and take the time: 0.404 is BELOW CHANCE. Below the majority baseline of 0.523, and below what you would get by flipping a coin. Ask how that is even possible - a model with no information should surely sit at 50%.</a:t>
-            </a:r>
-          </a:p>
-          <a:p>
-            <a:pPr lvl="0" indent="0" marL="0">
-              <a:buNone/>
-            </a:pPr>
-          </a:p>
-          <a:p>
-            <a:pPr lvl="0" indent="0" marL="0">
-              <a:buNone/>
-            </a:pPr>
-            <a:r>
-              <a:rPr/>
-              <a:t>The explanation is worth having in full. The class means on each sensor differ by about 0.17, against a spread near 1, purely as an artefact of a finite sample. That accident is the ONLY per-feature evidence available. Naive Bayes has nothing else to multiply, so it follows it - and in this sample it points the wrong way.</a:t>
-            </a:r>
-          </a:p>
-          <a:p>
-            <a:pPr lvl="0" indent="0" marL="0">
-              <a:buNone/>
-            </a:pPr>
-          </a:p>
-          <a:p>
-            <a:pPr lvl="0" indent="0" marL="0">
-              <a:buNone/>
-            </a:pPr>
-            <a:r>
-              <a:rPr/>
-              <a:t>The sentence to land: a model with no signal does not sit politely at 50%. It follows whatever spurious structure it can find, with complete confidence.</a:t>
+              <a:t>Left panel: the two sensors together. Four clean groups, and a perfectly learnable rule - any method that can draw a non-linear boundary will find it.</a:t>
+            </a:r>
+          </a:p>
+          <a:p>
+            <a:pPr lvl="0" indent="0" marL="0">
+              <a:buNone/>
+            </a:pPr>
+          </a:p>
+          <a:p>
+            <a:pPr lvl="0" indent="0" marL="0">
+              <a:buNone/>
+            </a:pPr>
+            <a:r>
+              <a:rPr/>
+              <a:t>Colours first, because someone will ask: teal is healthy, rust is faulty, everywhere. In the left panel each class owns two opposite quadrants - healthy has both sensors high or both low, faulty one high and one low.</a:t>
+            </a:r>
+          </a:p>
+          <a:p>
+            <a:pPr lvl="0" indent="0" marL="0">
+              <a:buNone/>
+            </a:pPr>
+          </a:p>
+          <a:p>
+            <a:pPr lvl="0" indent="0" marL="0">
+              <a:buNone/>
+            </a:pPr>
+            <a:r>
+              <a:rPr/>
+              <a:t>Middle and right: each sensor on its own, which is ALL Naive Bayes ever gets. Solid outlines are the data. Each sensor is either low or high, so each outline has two humps - and healthy and faulty have the SAME two humps, because each class is about half low and half high on each sensor alone.</a:t>
+            </a:r>
+          </a:p>
+          <a:p>
+            <a:pPr lvl="0" indent="0" marL="0">
+              <a:buNone/>
+            </a:pPr>
+          </a:p>
+          <a:p>
+            <a:pPr lvl="0" indent="0" marL="0">
+              <a:buNone/>
+            </a:pPr>
+            <a:r>
+              <a:rPr/>
+              <a:t>The dashed curves are what the model fits: one bell per sensor per class. A single bell cannot follow two humps, so it sits in the valley between them, and the two classes’ bells almost coincide - centre near 0, sd about 1.1 for both. Contrast the pumps a few slides ago: bells with a shared centre but widths of 1.695 against 4.636 Hz, and the widths carried the class. Here nothing does.</a:t>
+            </a:r>
+          </a:p>
+          <a:p>
+            <a:pPr lvl="0" indent="0" marL="0">
+              <a:buNone/>
+            </a:pPr>
+          </a:p>
+          <a:p>
+            <a:pPr lvl="0" indent="0" marL="0">
+              <a:buNone/>
+            </a:pPr>
+            <a:r>
+              <a:rPr/>
+              <a:t>That is the slide in one sentence: the information is real, it is entirely in the relationship between the columns, and factorising the density throws that relationship away before the model ever sees it.</a:t>
+            </a:r>
+          </a:p>
+          <a:p>
+            <a:pPr lvl="0" indent="0" marL="0">
+              <a:buNone/>
+            </a:pPr>
+          </a:p>
+          <a:p>
+            <a:pPr lvl="0" indent="0" marL="0">
+              <a:buNone/>
+            </a:pPr>
+            <a:r>
+              <a:rPr/>
+              <a:t>Worth saying that no amount of data repairs this. It is not an estimation problem - with a million rows the marginals still overlap. The model cannot represent what is being asked of it.</a:t>
             </a:r>
           </a:p>
         </p:txBody>
@@ -4370,59 +4332,63 @@
             </a:pPr>
             <a:r>
               <a:rPr/>
-              <a:t>Two numbers, four thousandths apart. The model is exactly as confident when it is wrong as when it is right, which means </a:t>
-            </a:r>
-            <a:r>
-              <a:rPr>
-                <a:latin typeface="Courier"/>
-              </a:rPr>
-              <a:t>predict_proba</a:t>
-            </a:r>
-            <a:r>
-              <a:rPr/>
-              <a:t> carries no usable information about reliability here.</a:t>
-            </a:r>
-          </a:p>
-          <a:p>
-            <a:pPr lvl="0" indent="0" marL="0">
-              <a:buNone/>
-            </a:pPr>
-          </a:p>
-          <a:p>
-            <a:pPr lvl="0" indent="0" marL="0">
-              <a:buNone/>
-            </a:pPr>
-            <a:r>
-              <a:rPr/>
-              <a:t>The more common complaint runs in the opposite direction, so give it too: when features carry the SAME evidence about the class - near-copies of one another - multiplying their probabilities counts it repeatedly. Be precise here, because they have just seen two kinds of dependence that are not this: the pumps’ ring and the XOR sensors. Ten correlated words in a document are treated as ten independent pieces of evidence, and the posterior saturates. Naive Bayes is famous for reporting 0.999 on problems it gets wrong a fifth of the time.</a:t>
-            </a:r>
-          </a:p>
-          <a:p>
-            <a:pPr lvl="0" indent="0" marL="0">
-              <a:buNone/>
-            </a:pPr>
-          </a:p>
-          <a:p>
-            <a:pPr lvl="0" indent="0" marL="0">
-              <a:buNone/>
-            </a:pPr>
-            <a:r>
-              <a:rPr/>
-              <a:t>Then lesson 5’s distinction, which this is the textbook case of: ranking and calibration are different properties. A model can order examples usefully and still report numbers that mean nothing.</a:t>
-            </a:r>
-          </a:p>
-          <a:p>
-            <a:pPr lvl="0" indent="0" marL="0">
-              <a:buNone/>
-            </a:pPr>
-          </a:p>
-          <a:p>
-            <a:pPr lvl="0" indent="0" marL="0">
-              <a:buNone/>
-            </a:pPr>
-            <a:r>
-              <a:rPr/>
-              <a:t>The practical consequence, and it is concrete: do not use Naive Bayes anywhere a calibrated probability enters a decision - including lesson 4’s cost calculation in section 7.2, where the threshold depends on the probability being real.</a:t>
+              <a:t>Two things to draw out, and the second is the more interesting.</a:t>
+            </a:r>
+          </a:p>
+          <a:p>
+            <a:pPr lvl="0" indent="0" marL="0">
+              <a:buNone/>
+            </a:pPr>
+          </a:p>
+          <a:p>
+            <a:pPr lvl="0" indent="0" marL="0">
+              <a:buNone/>
+            </a:pPr>
+            <a:r>
+              <a:rPr/>
+              <a:t>First: k-NN and the RBF SVM are at 0.967 and 0.972 on this data. The problem is not hard. It is only hard for a model that looks at one feature at a time.</a:t>
+            </a:r>
+          </a:p>
+          <a:p>
+            <a:pPr lvl="0" indent="0" marL="0">
+              <a:buNone/>
+            </a:pPr>
+          </a:p>
+          <a:p>
+            <a:pPr lvl="0" indent="0" marL="0">
+              <a:buNone/>
+            </a:pPr>
+            <a:r>
+              <a:rPr/>
+              <a:t>Second, and take the time: 0.404 is BELOW CHANCE. Below the majority baseline of 0.523, and below what you would get by flipping a coin. Ask how that is even possible - a model with no information should surely sit at 50%.</a:t>
+            </a:r>
+          </a:p>
+          <a:p>
+            <a:pPr lvl="0" indent="0" marL="0">
+              <a:buNone/>
+            </a:pPr>
+          </a:p>
+          <a:p>
+            <a:pPr lvl="0" indent="0" marL="0">
+              <a:buNone/>
+            </a:pPr>
+            <a:r>
+              <a:rPr/>
+              <a:t>The explanation is worth having in full. The class means on each sensor differ by about 0.17, against a spread near 1, purely as an artefact of a finite sample. That accident is the ONLY per-feature evidence available. Naive Bayes has nothing else to multiply, so it follows it - and in this sample it points the wrong way.</a:t>
+            </a:r>
+          </a:p>
+          <a:p>
+            <a:pPr lvl="0" indent="0" marL="0">
+              <a:buNone/>
+            </a:pPr>
+          </a:p>
+          <a:p>
+            <a:pPr lvl="0" indent="0" marL="0">
+              <a:buNone/>
+            </a:pPr>
+            <a:r>
+              <a:rPr/>
+              <a:t>The sentence to land: a model with no signal does not sit politely at 50%. It follows whatever spurious structure it can find, with complete confidence.</a:t>
             </a:r>
           </a:p>
         </p:txBody>
@@ -4504,49 +4470,59 @@
             </a:pPr>
             <a:r>
               <a:rPr/>
-              <a:t>Run notebooks/02. Sixteen minutes.</a:t>
-            </a:r>
-          </a:p>
-          <a:p>
-            <a:pPr lvl="0" indent="0" marL="0">
-              <a:buNone/>
-            </a:pPr>
-          </a:p>
-          <a:p>
-            <a:pPr lvl="0" indent="0" marL="0">
-              <a:buNone/>
-            </a:pPr>
-            <a:r>
-              <a:rPr/>
-              <a:t>The cell to protect is the one that prints 0.404 next to the 0.523 baseline. Let them see a below-chance score appear from correct code on solvable data before any explanation arrives.</a:t>
-            </a:r>
-          </a:p>
-          <a:p>
-            <a:pPr lvl="0" indent="0" marL="0">
-              <a:buNone/>
-            </a:pPr>
-          </a:p>
-          <a:p>
-            <a:pPr lvl="0" indent="0" marL="0">
-              <a:buNone/>
-            </a:pPr>
-            <a:r>
-              <a:rPr/>
-              <a:t>The notebook prints the within-class correlations on both datasets. Before that cell runs, ask them to predict the signs for the interacting sensors: it is the diagnostic they should carry - measure the assumption, do not assume it.</a:t>
-            </a:r>
-          </a:p>
-          <a:p>
-            <a:pPr lvl="0" indent="0" marL="0">
-              <a:buNone/>
-            </a:pPr>
-          </a:p>
-          <a:p>
-            <a:pPr lvl="0" indent="0" marL="0">
-              <a:buNone/>
-            </a:pPr>
-            <a:r>
-              <a:rPr/>
-              <a:t>If time allows, the interesting exercise is to hand Naive Bayes the product of the two sensors as a third column and watch it recover. That is the whole story of feature engineering versus model choice in one cell.</a:t>
+              <a:t>Two numbers, four thousandths apart. The model is exactly as confident when it is wrong as when it is right, which means </a:t>
+            </a:r>
+            <a:r>
+              <a:rPr>
+                <a:latin typeface="Courier"/>
+              </a:rPr>
+              <a:t>predict_proba</a:t>
+            </a:r>
+            <a:r>
+              <a:rPr/>
+              <a:t> carries no usable information about reliability here.</a:t>
+            </a:r>
+          </a:p>
+          <a:p>
+            <a:pPr lvl="0" indent="0" marL="0">
+              <a:buNone/>
+            </a:pPr>
+          </a:p>
+          <a:p>
+            <a:pPr lvl="0" indent="0" marL="0">
+              <a:buNone/>
+            </a:pPr>
+            <a:r>
+              <a:rPr/>
+              <a:t>The more common complaint runs in the opposite direction, so give it too: when features carry the SAME evidence about the class - near-copies of one another - multiplying their probabilities counts it repeatedly. Be precise here, because they have just seen two kinds of dependence that are not this: the pumps’ ring and the XOR sensors. Ten correlated words in a document are treated as ten independent pieces of evidence, and the posterior saturates. Naive Bayes is famous for reporting 0.999 on problems it gets wrong a fifth of the time.</a:t>
+            </a:r>
+          </a:p>
+          <a:p>
+            <a:pPr lvl="0" indent="0" marL="0">
+              <a:buNone/>
+            </a:pPr>
+          </a:p>
+          <a:p>
+            <a:pPr lvl="0" indent="0" marL="0">
+              <a:buNone/>
+            </a:pPr>
+            <a:r>
+              <a:rPr/>
+              <a:t>Then lesson 5’s distinction, which this is the textbook case of: ranking and calibration are different properties. A model can order examples usefully and still report numbers that mean nothing.</a:t>
+            </a:r>
+          </a:p>
+          <a:p>
+            <a:pPr lvl="0" indent="0" marL="0">
+              <a:buNone/>
+            </a:pPr>
+          </a:p>
+          <a:p>
+            <a:pPr lvl="0" indent="0" marL="0">
+              <a:buNone/>
+            </a:pPr>
+            <a:r>
+              <a:rPr/>
+              <a:t>The practical consequence, and it is concrete: do not use Naive Bayes anywhere a calibrated probability enters a decision - including lesson 4’s cost calculation in section 7.2, where the threshold depends on the probability being real.</a:t>
             </a:r>
           </a:p>
         </p:txBody>
@@ -4752,49 +4728,49 @@
             </a:pPr>
             <a:r>
               <a:rPr/>
-              <a:t>Start with the problem rather than the solution. Draw two well-separated blobs on the board and ask for the boundary. Somebody will draw a line. Ask whether another line would have been equally good, and keep asking until the room sees that there are infinitely many, all with identical training error.</a:t>
-            </a:r>
-          </a:p>
-          <a:p>
-            <a:pPr lvl="0" indent="0" marL="0">
-              <a:buNone/>
-            </a:pPr>
-          </a:p>
-          <a:p>
-            <a:pPr lvl="0" indent="0" marL="0">
-              <a:buNone/>
-            </a:pPr>
-            <a:r>
-              <a:rPr/>
-              <a:t>So the error cannot decide. Something else has to. Logistic regression breaks the tie with log loss - a perfectly respectable answer, and one answer among several. The SVM breaks it differently: take the boundary with the most room around it.</a:t>
-            </a:r>
-          </a:p>
-          <a:p>
-            <a:pPr lvl="0" indent="0" marL="0">
-              <a:buNone/>
-            </a:pPr>
-          </a:p>
-          <a:p>
-            <a:pPr lvl="0" indent="0" marL="0">
-              <a:buNone/>
-            </a:pPr>
-            <a:r>
-              <a:rPr/>
-              <a:t>The intuition, and this is the sentence to say slowly: maximising the distance to the closest points chooses the boundary that tolerates the most movement in the data before it changes its mind. That is a statement about GENERALISATION, not about fit - which is unusual, because almost everything else in this course optimises fit and controls generalisation indirectly.</a:t>
-            </a:r>
-          </a:p>
-          <a:p>
-            <a:pPr lvl="0" indent="0" marL="0">
-              <a:buNone/>
-            </a:pPr>
-          </a:p>
-          <a:p>
-            <a:pPr lvl="0" indent="0" marL="0">
-              <a:buNone/>
-            </a:pPr>
-            <a:r>
-              <a:rPr/>
-              <a:t>Handout section 5.1.</a:t>
+              <a:t>Run notebooks/02. Sixteen minutes.</a:t>
+            </a:r>
+          </a:p>
+          <a:p>
+            <a:pPr lvl="0" indent="0" marL="0">
+              <a:buNone/>
+            </a:pPr>
+          </a:p>
+          <a:p>
+            <a:pPr lvl="0" indent="0" marL="0">
+              <a:buNone/>
+            </a:pPr>
+            <a:r>
+              <a:rPr/>
+              <a:t>The cell to protect is the one that prints 0.404 next to the 0.523 baseline. Let them see a below-chance score appear from correct code on solvable data before any explanation arrives.</a:t>
+            </a:r>
+          </a:p>
+          <a:p>
+            <a:pPr lvl="0" indent="0" marL="0">
+              <a:buNone/>
+            </a:pPr>
+          </a:p>
+          <a:p>
+            <a:pPr lvl="0" indent="0" marL="0">
+              <a:buNone/>
+            </a:pPr>
+            <a:r>
+              <a:rPr/>
+              <a:t>The notebook prints the within-class correlations on both datasets. Before that cell runs, ask them to predict the signs for the interacting sensors: it is the diagnostic they should carry - measure the assumption, do not assume it.</a:t>
+            </a:r>
+          </a:p>
+          <a:p>
+            <a:pPr lvl="0" indent="0" marL="0">
+              <a:buNone/>
+            </a:pPr>
+          </a:p>
+          <a:p>
+            <a:pPr lvl="0" indent="0" marL="0">
+              <a:buNone/>
+            </a:pPr>
+            <a:r>
+              <a:rPr/>
+              <a:t>If time allows, the interesting exercise is to hand Naive Bayes the product of the two sensors as a third column and watch it recover. That is the whole story of feature engineering versus model choice in one cell.</a:t>
             </a:r>
           </a:p>
         </p:txBody>
@@ -4876,49 +4852,49 @@
             </a:pPr>
             <a:r>
               <a:rPr/>
-              <a:t>The solid line is the boundary, the dashed lines are the edges of the slab, and the circled points are the support vectors touching it.</a:t>
-            </a:r>
-          </a:p>
-          <a:p>
-            <a:pPr lvl="0" indent="0" marL="0">
-              <a:buNone/>
-            </a:pPr>
-          </a:p>
-          <a:p>
-            <a:pPr lvl="0" indent="0" marL="0">
-              <a:buNone/>
-            </a:pPr>
-            <a:r>
-              <a:rPr/>
-              <a:t>The number to say out loud: of eighty points, THREE determine the answer. Move any of the other seventy-seven - anywhere, as far as you like, as long as they stay outside the slab - and the boundary does not shift by a millimetre.</a:t>
-            </a:r>
-          </a:p>
-          <a:p>
-            <a:pPr lvl="0" indent="0" marL="0">
-              <a:buNone/>
-            </a:pPr>
-          </a:p>
-          <a:p>
-            <a:pPr lvl="0" indent="0" marL="0">
-              <a:buNone/>
-            </a:pPr>
-            <a:r>
-              <a:rPr/>
-              <a:t>That is where the name comes from, and it is a genuinely different idea from anything so far. Every linear model in lessons 3 and 4 used every row: each one contributed to the gradient in proportion to its error. Here most of the data is irrelevant once the fit is done.</a:t>
-            </a:r>
-          </a:p>
-          <a:p>
-            <a:pPr lvl="0" indent="0" marL="0">
-              <a:buNone/>
-            </a:pPr>
-          </a:p>
-          <a:p>
-            <a:pPr lvl="0" indent="0" marL="0">
-              <a:buNone/>
-            </a:pPr>
-            <a:r>
-              <a:rPr/>
-              <a:t>Two consequences worth naming. The model is small - you store the support vectors, not the dataset, which is the contrast with k-NN. And it is sensitive in a specific way: an outlier near the boundary matters enormously, while an outlier far from it matters not at all.</a:t>
+              <a:t>Start with the problem rather than the solution. Draw two well-separated blobs on the board and ask for the boundary. Somebody will draw a line. Ask whether another line would have been equally good, and keep asking until the room sees that there are infinitely many, all with identical training error.</a:t>
+            </a:r>
+          </a:p>
+          <a:p>
+            <a:pPr lvl="0" indent="0" marL="0">
+              <a:buNone/>
+            </a:pPr>
+          </a:p>
+          <a:p>
+            <a:pPr lvl="0" indent="0" marL="0">
+              <a:buNone/>
+            </a:pPr>
+            <a:r>
+              <a:rPr/>
+              <a:t>So the error cannot decide. Something else has to. Logistic regression breaks the tie with log loss - a perfectly respectable answer, and one answer among several. The SVM breaks it differently: take the boundary with the most room around it.</a:t>
+            </a:r>
+          </a:p>
+          <a:p>
+            <a:pPr lvl="0" indent="0" marL="0">
+              <a:buNone/>
+            </a:pPr>
+          </a:p>
+          <a:p>
+            <a:pPr lvl="0" indent="0" marL="0">
+              <a:buNone/>
+            </a:pPr>
+            <a:r>
+              <a:rPr/>
+              <a:t>The intuition, and this is the sentence to say slowly: maximising the distance to the closest points chooses the boundary that tolerates the most movement in the data before it changes its mind. That is a statement about GENERALISATION, not about fit - which is unusual, because almost everything else in this course optimises fit and controls generalisation indirectly.</a:t>
+            </a:r>
+          </a:p>
+          <a:p>
+            <a:pPr lvl="0" indent="0" marL="0">
+              <a:buNone/>
+            </a:pPr>
+          </a:p>
+          <a:p>
+            <a:pPr lvl="0" indent="0" marL="0">
+              <a:buNone/>
+            </a:pPr>
+            <a:r>
+              <a:rPr/>
+              <a:t>Handout section 5.1.</a:t>
             </a:r>
           </a:p>
         </p:txBody>
@@ -5000,49 +4976,49 @@
             </a:pPr>
             <a:r>
               <a:rPr/>
-              <a:t>The point worth stressing is why the soft margin is not a patch or a convenience. With even one mislabelled point inside the other class, the strict problem is INFEASIBLE - there is no solution, not a bad one. Real data always contains such points. So the soft margin is the only version anyone ever runs; the hard-margin problem is a teaching device.</a:t>
-            </a:r>
-          </a:p>
-          <a:p>
-            <a:pPr lvl="0" indent="0" marL="0">
-              <a:buNone/>
-            </a:pPr>
-          </a:p>
-          <a:p>
-            <a:pPr lvl="0" indent="0" marL="0">
-              <a:buNone/>
-            </a:pPr>
-            <a:r>
-              <a:rPr/>
-              <a:t>Our own labels are flipped at 4%, deliberately, so this is not a hypothetical for this dataset: the hard-margin problem on these pumps has no answer.</a:t>
-            </a:r>
-          </a:p>
-          <a:p>
-            <a:pPr lvl="0" indent="0" marL="0">
-              <a:buNone/>
-            </a:pPr>
-          </a:p>
-          <a:p>
-            <a:pPr lvl="0" indent="0" marL="0">
-              <a:buNone/>
-            </a:pPr>
-            <a:r>
-              <a:rPr/>
-              <a:t>Then read the three cases of the slack aloud, because they come back twice: in the weights the training produces, and in who gets a vote at prediction. Put it next to lesson 4’s log loss: that one shrinks for a well-classified point but never reaches zero, so every row keeps pulling. The hinge reaches zero, and a point with zero loss drops out of the answer entirely.</a:t>
-            </a:r>
-          </a:p>
-          <a:p>
-            <a:pPr lvl="0" indent="0" marL="0">
-              <a:buNone/>
-            </a:pPr>
-          </a:p>
-          <a:p>
-            <a:pPr lvl="0" indent="0" marL="0">
-              <a:buNone/>
-            </a:pPr>
-            <a:r>
-              <a:rPr/>
-              <a:t>The next slide puts it in symbols. Handout section 5.2 has the derivation.</a:t>
+              <a:t>The solid line is the boundary, the dashed lines are the edges of the slab, and the circled points are the support vectors touching it.</a:t>
+            </a:r>
+          </a:p>
+          <a:p>
+            <a:pPr lvl="0" indent="0" marL="0">
+              <a:buNone/>
+            </a:pPr>
+          </a:p>
+          <a:p>
+            <a:pPr lvl="0" indent="0" marL="0">
+              <a:buNone/>
+            </a:pPr>
+            <a:r>
+              <a:rPr/>
+              <a:t>The number to say out loud: of eighty points, THREE determine the answer. Move any of the other seventy-seven - anywhere, as far as you like, as long as they stay outside the slab - and the boundary does not shift by a millimetre.</a:t>
+            </a:r>
+          </a:p>
+          <a:p>
+            <a:pPr lvl="0" indent="0" marL="0">
+              <a:buNone/>
+            </a:pPr>
+          </a:p>
+          <a:p>
+            <a:pPr lvl="0" indent="0" marL="0">
+              <a:buNone/>
+            </a:pPr>
+            <a:r>
+              <a:rPr/>
+              <a:t>That is where the name comes from, and it is a genuinely different idea from anything so far. Every linear model in lessons 3 and 4 used every row: each one contributed to the gradient in proportion to its error. Here most of the data is irrelevant once the fit is done.</a:t>
+            </a:r>
+          </a:p>
+          <a:p>
+            <a:pPr lvl="0" indent="0" marL="0">
+              <a:buNone/>
+            </a:pPr>
+          </a:p>
+          <a:p>
+            <a:pPr lvl="0" indent="0" marL="0">
+              <a:buNone/>
+            </a:pPr>
+            <a:r>
+              <a:rPr/>
+              <a:t>Two consequences worth naming. The model is small - you store the support vectors, not the dataset, which is the contrast with k-NN. And it is sensitive in a specific way: an outlier near the boundary matters enormously, while an outlier far from it matters not at all.</a:t>
             </a:r>
           </a:p>
         </p:txBody>
@@ -5124,49 +5100,49 @@
             </a:pPr>
             <a:r>
               <a:rPr/>
-              <a:t>The constraint is not on the slide any more - it made the line wide enough to land at 28pt - so state it: subject to y_i(w’x_i + b) &gt;= 1 - xi_i, every point on the right side of the slab by a margin, or paying xi_i for the shortfall. Handout section 5.2 writes it out.</a:t>
-            </a:r>
-          </a:p>
-          <a:p>
-            <a:pPr lvl="0" indent="0" marL="0">
-              <a:buNone/>
-            </a:pPr>
-          </a:p>
-          <a:p>
-            <a:pPr lvl="0" indent="0" marL="0">
-              <a:buNone/>
-            </a:pPr>
-            <a:r>
-              <a:rPr/>
-              <a:t>Do not derive this. State what each piece is doing and move on - handout section 5.2 has the derivation, including why maximising the margin is the same as minimising the norm of w.</a:t>
-            </a:r>
-          </a:p>
-          <a:p>
-            <a:pPr lvl="0" indent="0" marL="0">
-              <a:buNone/>
-            </a:pPr>
-          </a:p>
-          <a:p>
-            <a:pPr lvl="0" indent="0" marL="0">
-              <a:buNone/>
-            </a:pPr>
-            <a:r>
-              <a:rPr/>
-              <a:t>The first term wants a wide slab. The second term wants few violations. C sets the exchange rate between them, and that is the entire content of the expression. Read it out in those words rather than reading the symbols.</a:t>
-            </a:r>
-          </a:p>
-          <a:p>
-            <a:pPr lvl="0" indent="0" marL="0">
-              <a:buNone/>
-            </a:pPr>
-          </a:p>
-          <a:p>
-            <a:pPr lvl="0" indent="0" marL="0">
-              <a:buNone/>
-            </a:pPr>
-            <a:r>
-              <a:rPr/>
-              <a:t>If someone asks about the half in front of the norm: it is there to make the derivative tidy, exactly as in lesson 3’s cost function.</a:t>
+              <a:t>The point worth stressing is why the soft margin is not a patch or a convenience. With even one mislabelled point inside the other class, the strict problem is INFEASIBLE - there is no solution, not a bad one. Real data always contains such points. So the soft margin is the only version anyone ever runs; the hard-margin problem is a teaching device.</a:t>
+            </a:r>
+          </a:p>
+          <a:p>
+            <a:pPr lvl="0" indent="0" marL="0">
+              <a:buNone/>
+            </a:pPr>
+          </a:p>
+          <a:p>
+            <a:pPr lvl="0" indent="0" marL="0">
+              <a:buNone/>
+            </a:pPr>
+            <a:r>
+              <a:rPr/>
+              <a:t>Our own labels are flipped at 4%, deliberately, so this is not a hypothetical for this dataset: the hard-margin problem on these pumps has no answer.</a:t>
+            </a:r>
+          </a:p>
+          <a:p>
+            <a:pPr lvl="0" indent="0" marL="0">
+              <a:buNone/>
+            </a:pPr>
+          </a:p>
+          <a:p>
+            <a:pPr lvl="0" indent="0" marL="0">
+              <a:buNone/>
+            </a:pPr>
+            <a:r>
+              <a:rPr/>
+              <a:t>Then read the three cases of the slack aloud, because they come back twice: in the weights the training produces, and in who gets a vote at prediction. Put it next to lesson 4’s log loss: that one shrinks for a well-classified point but never reaches zero, so every row keeps pulling. The hinge reaches zero, and a point with zero loss drops out of the answer entirely.</a:t>
+            </a:r>
+          </a:p>
+          <a:p>
+            <a:pPr lvl="0" indent="0" marL="0">
+              <a:buNone/>
+            </a:pPr>
+          </a:p>
+          <a:p>
+            <a:pPr lvl="0" indent="0" marL="0">
+              <a:buNone/>
+            </a:pPr>
+            <a:r>
+              <a:rPr/>
+              <a:t>The next slide puts it in symbols. Handout section 5.2 has the derivation.</a:t>
             </a:r>
           </a:p>
         </p:txBody>
@@ -5248,55 +5224,35 @@
             </a:pPr>
             <a:r>
               <a:rPr/>
-              <a:t>Third appearance of the same idea, and say so - that repetition is the point. Lesson 3 had λ, this morning had k, now C. Every model has one knob that trades fitting this data against surviving the next, and recognising it in an unfamiliar model is worth more than memorising three names.</a:t>
-            </a:r>
-          </a:p>
-          <a:p>
-            <a:pPr lvl="0" indent="0" marL="0">
-              <a:buNone/>
-            </a:pPr>
-          </a:p>
-          <a:p>
-            <a:pPr lvl="0" indent="0" marL="0">
-              <a:buNone/>
-            </a:pPr>
-            <a:r>
-              <a:rPr/>
-              <a:t>Then the direction, which catches people out constantly and is worth writing on the board. Large λ means MORE regularisation. Large C means LESS. They run opposite ways, and scikit-learn’s </a:t>
-            </a:r>
-            <a:r>
-              <a:rPr>
-                <a:latin typeface="Courier"/>
-              </a:rPr>
-              <a:t>C</a:t>
-            </a:r>
-            <a:r>
-              <a:rPr/>
-              <a:t> parameter in </a:t>
-            </a:r>
-            <a:r>
-              <a:rPr>
-                <a:latin typeface="Courier"/>
-              </a:rPr>
-              <a:t>LogisticRegression</a:t>
-            </a:r>
-            <a:r>
-              <a:rPr/>
-              <a:t> has the same inverted convention - it is the reciprocal of the penalty there too.</a:t>
-            </a:r>
-          </a:p>
-          <a:p>
-            <a:pPr lvl="0" indent="0" marL="0">
-              <a:buNone/>
-            </a:pPr>
-          </a:p>
-          <a:p>
-            <a:pPr lvl="0" indent="0" marL="0">
-              <a:buNone/>
-            </a:pPr>
-            <a:r>
-              <a:rPr/>
-              <a:t>Ask them which way they would expect C to run before you tell them. Most guess wrong, and having guessed wrong once is what makes it stick.</a:t>
+              <a:t>What each point pays, against its margin y times f(x): large and positive when it is safely on its own side, negative on the wrong side.</a:t>
+            </a:r>
+          </a:p>
+          <a:p>
+            <a:pPr lvl="0" indent="0" marL="0">
+              <a:buNone/>
+            </a:pPr>
+          </a:p>
+          <a:p>
+            <a:pPr lvl="0" indent="0" marL="0">
+              <a:buNone/>
+            </a:pPr>
+            <a:r>
+              <a:rPr/>
+              <a:t>Walk the three zones left to right. Wrong side: both losses are large. Inside the slab: the hinge still charges, falling in a straight line. Right of 1, outside the slab: the hinge is exactly zero, and the log loss from lesson 4 is still charging - 0.127 at a margin of 2, 0.049 at 3.</a:t>
+            </a:r>
+          </a:p>
+          <a:p>
+            <a:pPr lvl="0" indent="0" marL="0">
+              <a:buNone/>
+            </a:pPr>
+          </a:p>
+          <a:p>
+            <a:pPr lvl="0" indent="0" marL="0">
+              <a:buNone/>
+            </a:pPr>
+            <a:r>
+              <a:rPr/>
+              <a:t>The sentence to land: a point with zero loss stops pulling on the answer. That is where support vectors come from - and why logistic regression never has any. Handout section 5.2.</a:t>
             </a:r>
           </a:p>
         </p:txBody>
@@ -5378,49 +5334,49 @@
             </a:pPr>
             <a:r>
               <a:rPr/>
-              <a:t>The linear kernel scores 0.613 - the base rate, exactly as logistic regression did this morning, with the same zero variance across folds.</a:t>
-            </a:r>
-          </a:p>
-          <a:p>
-            <a:pPr lvl="0" indent="0" marL="0">
-              <a:buNone/>
-            </a:pPr>
-          </a:p>
-          <a:p>
-            <a:pPr lvl="0" indent="0" marL="0">
-              <a:buNone/>
-            </a:pPr>
-            <a:r>
-              <a:rPr/>
-              <a:t>Make the point explicitly, because it is the one students most often get backwards: the margin criterion is a better way of CHOOSING among straight lines. It does not give you anything other than a straight line. When no straight line works, choosing the best one optimally still gets you nothing. A better criterion cannot rescue an inadequate hypothesis class.</a:t>
-            </a:r>
-          </a:p>
-          <a:p>
-            <a:pPr lvl="0" indent="0" marL="0">
-              <a:buNone/>
-            </a:pPr>
-          </a:p>
-          <a:p>
-            <a:pPr lvl="0" indent="0" marL="0">
-              <a:buNone/>
-            </a:pPr>
-            <a:r>
-              <a:rPr/>
-              <a:t>Then the RBF row, which is the same algorithm with one argument changed, at 0.947 - the best number in the whole lesson, and within a hair of the 0.96 ceiling.</a:t>
-            </a:r>
-          </a:p>
-          <a:p>
-            <a:pPr lvl="0" indent="0" marL="0">
-              <a:buNone/>
-            </a:pPr>
-          </a:p>
-          <a:p>
-            <a:pPr lvl="0" indent="0" marL="0">
-              <a:buNone/>
-            </a:pPr>
-            <a:r>
-              <a:rPr/>
-              <a:t>The support-vector column says the same thing in a second language, and that is the next slide.</a:t>
+              <a:t>The constraint is not on the slide any more - it made the line wide enough to land at 28pt - so state it: subject to y_i(w’x_i + b) &gt;= 1 - xi_i, every point on the right side of the slab by a margin, or paying xi_i for the shortfall. Handout section 5.2 writes it out.</a:t>
+            </a:r>
+          </a:p>
+          <a:p>
+            <a:pPr lvl="0" indent="0" marL="0">
+              <a:buNone/>
+            </a:pPr>
+          </a:p>
+          <a:p>
+            <a:pPr lvl="0" indent="0" marL="0">
+              <a:buNone/>
+            </a:pPr>
+            <a:r>
+              <a:rPr/>
+              <a:t>Do not derive this. State what each piece is doing and move on - handout section 5.2 has the derivation, including why maximising the margin is the same as minimising the norm of w.</a:t>
+            </a:r>
+          </a:p>
+          <a:p>
+            <a:pPr lvl="0" indent="0" marL="0">
+              <a:buNone/>
+            </a:pPr>
+          </a:p>
+          <a:p>
+            <a:pPr lvl="0" indent="0" marL="0">
+              <a:buNone/>
+            </a:pPr>
+            <a:r>
+              <a:rPr/>
+              <a:t>The first term wants a wide slab. The second term wants few violations. C sets the exchange rate between them, and that is the entire content of the expression. Read it out in those words rather than reading the symbols.</a:t>
+            </a:r>
+          </a:p>
+          <a:p>
+            <a:pPr lvl="0" indent="0" marL="0">
+              <a:buNone/>
+            </a:pPr>
+          </a:p>
+          <a:p>
+            <a:pPr lvl="0" indent="0" marL="0">
+              <a:buNone/>
+            </a:pPr>
+            <a:r>
+              <a:rPr/>
+              <a:t>If someone asks about the half in front of the norm: it is there to make the derivative tidy, exactly as in lesson 3’s cost function.</a:t>
             </a:r>
           </a:p>
         </p:txBody>
@@ -5502,59 +5458,55 @@
             </a:pPr>
             <a:r>
               <a:rPr/>
-              <a:t>Explain what 79% actually means geometrically. A support vector is a point on the margin or inside it. If 79% of your data is in that position, there is no region of empty space between the classes at all - the model has been forced to place a boundary through a crowd.</a:t>
-            </a:r>
-          </a:p>
-          <a:p>
-            <a:pPr lvl="0" indent="0" marL="0">
-              <a:buNone/>
-            </a:pPr>
-          </a:p>
-          <a:p>
-            <a:pPr lvl="0" indent="0" marL="0">
-              <a:buNone/>
-            </a:pPr>
-            <a:r>
-              <a:rPr/>
-              <a:t>Contrast with 23%, where the model found genuine room and only the points near the edge matter.</a:t>
-            </a:r>
-          </a:p>
-          <a:p>
-            <a:pPr lvl="0" indent="0" marL="0">
-              <a:buNone/>
-            </a:pPr>
-          </a:p>
-          <a:p>
-            <a:pPr lvl="0" indent="0" marL="0">
-              <a:buNone/>
-            </a:pPr>
-            <a:r>
-              <a:rPr/>
-              <a:t>Give them the diagnostic to keep, since it costs nothing: after fitting an SVM, look at </a:t>
+              <a:t>Third appearance of the same idea, and say so - that repetition is the point. Lesson 3 had λ, this morning had k, now C. Every model has one knob that trades fitting this data against surviving the next, and recognising it in an unfamiliar model is worth more than memorising three names.</a:t>
+            </a:r>
+          </a:p>
+          <a:p>
+            <a:pPr lvl="0" indent="0" marL="0">
+              <a:buNone/>
+            </a:pPr>
+          </a:p>
+          <a:p>
+            <a:pPr lvl="0" indent="0" marL="0">
+              <a:buNone/>
+            </a:pPr>
+            <a:r>
+              <a:rPr/>
+              <a:t>Then the direction, which catches people out constantly and is worth writing on the board. Large λ means MORE regularisation. Large C means LESS. They run opposite ways, and scikit-learn’s </a:t>
             </a:r>
             <a:r>
               <a:rPr>
                 <a:latin typeface="Courier"/>
               </a:rPr>
-              <a:t>len(model.support_)</a:t>
-            </a:r>
-            <a:r>
-              <a:rPr/>
-              <a:t> over the number of training rows. High means the model is struggling to find room, which usually means the kernel is wrong for the geometry. It is a warning available BEFORE you cross-validate anything.</a:t>
-            </a:r>
-          </a:p>
-          <a:p>
-            <a:pPr lvl="0" indent="0" marL="0">
-              <a:buNone/>
-            </a:pPr>
-          </a:p>
-          <a:p>
-            <a:pPr lvl="0" indent="0" marL="0">
-              <a:buNone/>
-            </a:pPr>
-            <a:r>
-              <a:rPr/>
-              <a:t>Worth adding that it also predicts prediction cost - every support vector is one kernel evaluation per query, so a model needing 79% of the data has thrown away most of the speed advantage over k-NN.</a:t>
+              <a:t>C</a:t>
+            </a:r>
+            <a:r>
+              <a:rPr/>
+              <a:t> parameter in </a:t>
+            </a:r>
+            <a:r>
+              <a:rPr>
+                <a:latin typeface="Courier"/>
+              </a:rPr>
+              <a:t>LogisticRegression</a:t>
+            </a:r>
+            <a:r>
+              <a:rPr/>
+              <a:t> has the same inverted convention - it is the reciprocal of the penalty there too.</a:t>
+            </a:r>
+          </a:p>
+          <a:p>
+            <a:pPr lvl="0" indent="0" marL="0">
+              <a:buNone/>
+            </a:pPr>
+          </a:p>
+          <a:p>
+            <a:pPr lvl="0" indent="0" marL="0">
+              <a:buNone/>
+            </a:pPr>
+            <a:r>
+              <a:rPr/>
+              <a:t>Ask them which way they would expect C to run before you tell them. Most guess wrong, and having guessed wrong once is what makes it stick.</a:t>
             </a:r>
           </a:p>
         </p:txBody>
@@ -5636,49 +5588,49 @@
             </a:pPr>
             <a:r>
               <a:rPr/>
-              <a:t>Build the picture in words first and let them see it before the figure appears. Take the scatter plot from the start of the lesson, lift each point off the page by its distance from the centre, and look from the side.</a:t>
-            </a:r>
-          </a:p>
-          <a:p>
-            <a:pPr lvl="0" indent="0" marL="0">
-              <a:buNone/>
-            </a:pPr>
-          </a:p>
-          <a:p>
-            <a:pPr lvl="0" indent="0" marL="0">
-              <a:buNone/>
-            </a:pPr>
-            <a:r>
-              <a:rPr/>
-              <a:t>Then the sentence that reframes the whole afternoon: the classes were never inseparable. Separability is not a property of the data - it is a property of the data AND the coordinates you happen to have measured it in.</a:t>
-            </a:r>
-          </a:p>
-          <a:p>
-            <a:pPr lvl="0" indent="0" marL="0">
-              <a:buNone/>
-            </a:pPr>
-          </a:p>
-          <a:p>
-            <a:pPr lvl="0" indent="0" marL="0">
-              <a:buNone/>
-            </a:pPr>
-            <a:r>
-              <a:rPr/>
-              <a:t>Ask what is unsatisfying about what we just did, and wait for it. We chose that lift by already knowing the answer. We knew the fault mode was radial. In any real problem you do not, and inventing the right coordinate is the hard part - which is exactly the difficulty the kernel trick removes.</a:t>
-            </a:r>
-          </a:p>
-          <a:p>
-            <a:pPr lvl="0" indent="0" marL="0">
-              <a:buNone/>
-            </a:pPr>
-          </a:p>
-          <a:p>
-            <a:pPr lvl="0" indent="0" marL="0">
-              <a:buNone/>
-            </a:pPr>
-            <a:r>
-              <a:rPr/>
-              <a:t>Handout section 5.4.</a:t>
+              <a:t>The linear kernel scores 0.613 - the base rate, exactly as logistic regression did this morning, with the same zero variance across folds.</a:t>
+            </a:r>
+          </a:p>
+          <a:p>
+            <a:pPr lvl="0" indent="0" marL="0">
+              <a:buNone/>
+            </a:pPr>
+          </a:p>
+          <a:p>
+            <a:pPr lvl="0" indent="0" marL="0">
+              <a:buNone/>
+            </a:pPr>
+            <a:r>
+              <a:rPr/>
+              <a:t>Make the point explicitly, because it is the one students most often get backwards: the margin criterion is a better way of CHOOSING among straight lines. It does not give you anything other than a straight line. When no straight line works, choosing the best one optimally still gets you nothing. A better criterion cannot rescue an inadequate hypothesis class.</a:t>
+            </a:r>
+          </a:p>
+          <a:p>
+            <a:pPr lvl="0" indent="0" marL="0">
+              <a:buNone/>
+            </a:pPr>
+          </a:p>
+          <a:p>
+            <a:pPr lvl="0" indent="0" marL="0">
+              <a:buNone/>
+            </a:pPr>
+            <a:r>
+              <a:rPr/>
+              <a:t>Then the RBF row, which is the same algorithm with one argument changed, at 0.947 - the best number in the whole lesson, and within a hair of the 0.96 ceiling.</a:t>
+            </a:r>
+          </a:p>
+          <a:p>
+            <a:pPr lvl="0" indent="0" marL="0">
+              <a:buNone/>
+            </a:pPr>
+          </a:p>
+          <a:p>
+            <a:pPr lvl="0" indent="0" marL="0">
+              <a:buNone/>
+            </a:pPr>
+            <a:r>
+              <a:rPr/>
+              <a:t>The support-vector column says the same thing in a second language, and that is the next slide.</a:t>
             </a:r>
           </a:p>
         </p:txBody>
@@ -5760,35 +5712,59 @@
             </a:pPr>
             <a:r>
               <a:rPr/>
-              <a:t>The same 1,200 pumps twice: on the left in the plane where they were measured, on the right lifted by their distance from the design point. The gold plane does what no line could.</a:t>
-            </a:r>
-          </a:p>
-          <a:p>
-            <a:pPr lvl="0" indent="0" marL="0">
-              <a:buNone/>
-            </a:pPr>
-          </a:p>
-          <a:p>
-            <a:pPr lvl="0" indent="0" marL="0">
-              <a:buNone/>
-            </a:pPr>
-            <a:r>
-              <a:rPr/>
-              <a:t>Have them look at the right panel and confirm for themselves that a flat horizontal cut separates the colours cleanly. Nothing was added - no new measurement, no extra sensor. The third coordinate is computed from the two they already had.</a:t>
-            </a:r>
-          </a:p>
-          <a:p>
-            <a:pPr lvl="0" indent="0" marL="0">
-              <a:buNone/>
-            </a:pPr>
-          </a:p>
-          <a:p>
-            <a:pPr lvl="0" indent="0" marL="0">
-              <a:buNone/>
-            </a:pPr>
-            <a:r>
-              <a:rPr/>
-              <a:t>Then set up the objection that the next slide answers. This worked because the lift was three-dimensional and we could guess it. The spaces that work in general are enormous - the useful ones are sometimes infinite-dimensional - and computing the coordinates of every point in such a space is impossible.</a:t>
+              <a:t>Explain what 79% actually means geometrically. A support vector is a point on the margin or inside it. If 79% of your data is in that position, there is no region of empty space between the classes at all - the model has been forced to place a boundary through a crowd.</a:t>
+            </a:r>
+          </a:p>
+          <a:p>
+            <a:pPr lvl="0" indent="0" marL="0">
+              <a:buNone/>
+            </a:pPr>
+          </a:p>
+          <a:p>
+            <a:pPr lvl="0" indent="0" marL="0">
+              <a:buNone/>
+            </a:pPr>
+            <a:r>
+              <a:rPr/>
+              <a:t>Contrast with 23%, where the model found genuine room and only the points near the edge matter.</a:t>
+            </a:r>
+          </a:p>
+          <a:p>
+            <a:pPr lvl="0" indent="0" marL="0">
+              <a:buNone/>
+            </a:pPr>
+          </a:p>
+          <a:p>
+            <a:pPr lvl="0" indent="0" marL="0">
+              <a:buNone/>
+            </a:pPr>
+            <a:r>
+              <a:rPr/>
+              <a:t>Give them the diagnostic to keep, since it costs nothing: after fitting an SVM, look at </a:t>
+            </a:r>
+            <a:r>
+              <a:rPr>
+                <a:latin typeface="Courier"/>
+              </a:rPr>
+              <a:t>len(model.support_)</a:t>
+            </a:r>
+            <a:r>
+              <a:rPr/>
+              <a:t> over the number of training rows. High means the model is struggling to find room, which usually means the kernel is wrong for the geometry. It is a warning available BEFORE you cross-validate anything.</a:t>
+            </a:r>
+          </a:p>
+          <a:p>
+            <a:pPr lvl="0" indent="0" marL="0">
+              <a:buNone/>
+            </a:pPr>
+          </a:p>
+          <a:p>
+            <a:pPr lvl="0" indent="0" marL="0">
+              <a:buNone/>
+            </a:pPr>
+            <a:r>
+              <a:rPr/>
+              <a:t>Worth adding that it also predicts prediction cost - every support vector is one kernel evaluation per query, so a model needing 79% of the data has thrown away most of the speed advantage over k-NN.</a:t>
             </a:r>
           </a:p>
         </p:txBody>
@@ -5870,35 +5846,49 @@
             </a:pPr>
             <a:r>
               <a:rPr/>
-              <a:t>The trick in one sentence: the SVM never needs the coordinates, only the angles and lengths between points, and those can be obtained without ever going there.</a:t>
-            </a:r>
-          </a:p>
-          <a:p>
-            <a:pPr lvl="0" indent="0" marL="0">
-              <a:buNone/>
-            </a:pPr>
-          </a:p>
-          <a:p>
-            <a:pPr lvl="0" indent="0" marL="0">
-              <a:buNone/>
-            </a:pPr>
-            <a:r>
-              <a:rPr/>
-              <a:t>Do not prove it - handout section 5.4 shows where the inner products come from in the dual formulation. The claim to state and let land is that a function of two ordinary two-dimensional vectors returns their inner product in a space of infinite dimension, at the cost of one exponential.</a:t>
-            </a:r>
-          </a:p>
-          <a:p>
-            <a:pPr lvl="0" indent="0" marL="0">
-              <a:buNone/>
-            </a:pPr>
-          </a:p>
-          <a:p>
-            <a:pPr lvl="0" indent="0" marL="0">
-              <a:buNone/>
-            </a:pPr>
-            <a:r>
-              <a:rPr/>
-              <a:t>And close the loop from the previous slide: we chose the lift in the picture by knowing the answer. The RBF kernel does something equivalent without being told, which is exactly why it works on problems where nobody could guess the right coordinates.</a:t>
+              <a:t>Build the picture in words first and let them see it before the figure appears. Take the scatter plot from the start of the lesson, lift each point off the page by its distance from the centre, and look from the side.</a:t>
+            </a:r>
+          </a:p>
+          <a:p>
+            <a:pPr lvl="0" indent="0" marL="0">
+              <a:buNone/>
+            </a:pPr>
+          </a:p>
+          <a:p>
+            <a:pPr lvl="0" indent="0" marL="0">
+              <a:buNone/>
+            </a:pPr>
+            <a:r>
+              <a:rPr/>
+              <a:t>Then the sentence that reframes the whole afternoon: the classes were never inseparable. Separability is not a property of the data - it is a property of the data AND the coordinates you happen to have measured it in.</a:t>
+            </a:r>
+          </a:p>
+          <a:p>
+            <a:pPr lvl="0" indent="0" marL="0">
+              <a:buNone/>
+            </a:pPr>
+          </a:p>
+          <a:p>
+            <a:pPr lvl="0" indent="0" marL="0">
+              <a:buNone/>
+            </a:pPr>
+            <a:r>
+              <a:rPr/>
+              <a:t>Ask what is unsatisfying about what we just did, and wait for it. We chose that lift by already knowing the answer. We knew the fault mode was radial. In any real problem you do not, and inventing the right coordinate is the hard part - which is exactly the difficulty the kernel trick removes.</a:t>
+            </a:r>
+          </a:p>
+          <a:p>
+            <a:pPr lvl="0" indent="0" marL="0">
+              <a:buNone/>
+            </a:pPr>
+          </a:p>
+          <a:p>
+            <a:pPr lvl="0" indent="0" marL="0">
+              <a:buNone/>
+            </a:pPr>
+            <a:r>
+              <a:rPr/>
+              <a:t>Handout section 5.4.</a:t>
             </a:r>
           </a:p>
         </p:txBody>
@@ -6112,35 +6102,35 @@
             </a:pPr>
             <a:r>
               <a:rPr/>
-              <a:t>Make the trick concrete before the famous formula. The lift here lists every product of two coordinates: phi(x) = (x1², √2·x1·x2, x2²). Two points, a = (1, 2) and b = (3, 1).</a:t>
-            </a:r>
-          </a:p>
-          <a:p>
-            <a:pPr lvl="0" indent="0" marL="0">
-              <a:buNone/>
-            </a:pPr>
-          </a:p>
-          <a:p>
-            <a:pPr lvl="0" indent="0" marL="0">
-              <a:buNone/>
-            </a:pPr>
-            <a:r>
-              <a:rPr/>
-              <a:t>First row: lift both into three dimensions and take the ordinary inner product - 9 + 12 + 4 = 25. Second row: never lift, take the inner product in the plane, 5, and square it - 25. Same number. The second route never left two dimensions, so the function (a · b)² IS the inner product in the lifted space. That is all a kernel is.</a:t>
-            </a:r>
-          </a:p>
-          <a:p>
-            <a:pPr lvl="0" indent="0" marL="0">
-              <a:buNone/>
-            </a:pPr>
-          </a:p>
-          <a:p>
-            <a:pPr lvl="0" indent="0" marL="0">
-              <a:buNone/>
-            </a:pPr>
-            <a:r>
-              <a:rPr/>
-              <a:t>Then connect it to the figure they just saw: the lifted space contains x1² and x2², and their sum is the squared distance from the centre - the coordinate we chose by hand. A flat plane there is a circle down here. The kernel found the lift we had to guess. Handout section 5.4.</a:t>
+              <a:t>The same 1,200 pumps twice: on the left in the plane where they were measured, on the right lifted by their distance from the design point. The gold plane does what no line could.</a:t>
+            </a:r>
+          </a:p>
+          <a:p>
+            <a:pPr lvl="0" indent="0" marL="0">
+              <a:buNone/>
+            </a:pPr>
+          </a:p>
+          <a:p>
+            <a:pPr lvl="0" indent="0" marL="0">
+              <a:buNone/>
+            </a:pPr>
+            <a:r>
+              <a:rPr/>
+              <a:t>Have them look at the right panel and confirm for themselves that a flat horizontal cut separates the colours cleanly. Nothing was added - no new measurement, no extra sensor. The third coordinate is computed from the two they already had.</a:t>
+            </a:r>
+          </a:p>
+          <a:p>
+            <a:pPr lvl="0" indent="0" marL="0">
+              <a:buNone/>
+            </a:pPr>
+          </a:p>
+          <a:p>
+            <a:pPr lvl="0" indent="0" marL="0">
+              <a:buNone/>
+            </a:pPr>
+            <a:r>
+              <a:rPr/>
+              <a:t>Then set up the objection that the next slide answers. This worked because the lift was three-dimensional and we could guess it. The spaces that work in general are enormous - the useful ones are sometimes infinite-dimensional - and computing the coordinates of every point in such a space is impossible.</a:t>
             </a:r>
           </a:p>
         </p:txBody>
@@ -6222,73 +6212,35 @@
             </a:pPr>
             <a:r>
               <a:rPr/>
-              <a:t>One line, and it is the whole of what scikit-learn does when you leave </a:t>
-            </a:r>
-            <a:r>
-              <a:rPr>
-                <a:latin typeface="Courier"/>
-              </a:rPr>
-              <a:t>kernel</a:t>
-            </a:r>
-            <a:r>
-              <a:rPr/>
-              <a:t> at its default.</a:t>
-            </a:r>
-          </a:p>
-          <a:p>
-            <a:pPr lvl="0" indent="0" marL="0">
-              <a:buNone/>
-            </a:pPr>
-          </a:p>
-          <a:p>
-            <a:pPr lvl="0" indent="0" marL="0">
-              <a:buNone/>
-            </a:pPr>
-            <a:r>
-              <a:rPr/>
-              <a:t>Read it aloud as a similarity rather than as a formula: the closer two points are, the nearer the exponent is to zero and the nearer the kernel is to one; far apart, it falls away to nothing. That is all an RBF kernel says - how much does this point look like that one.</a:t>
-            </a:r>
-          </a:p>
-          <a:p>
-            <a:pPr lvl="0" indent="0" marL="0">
-              <a:buNone/>
-            </a:pPr>
-          </a:p>
-          <a:p>
-            <a:pPr lvl="0" indent="0" marL="0">
-              <a:buNone/>
-            </a:pPr>
-            <a:r>
-              <a:rPr/>
-              <a:t>Now say what γ means, because the next two slides turn on it: it sets how far a single training point’s influence reaches. Small γ, wide reach, smooth boundary. Large γ, each point influences only its immediate neighbourhood - and a boundary that can afford an island around every mislabelled pump.</a:t>
-            </a:r>
-          </a:p>
-          <a:p>
-            <a:pPr lvl="0" indent="0" marL="0">
-              <a:buNone/>
-            </a:pPr>
-          </a:p>
-          <a:p>
-            <a:pPr lvl="0" indent="0" marL="0">
-              <a:buNone/>
-            </a:pPr>
-            <a:r>
-              <a:rPr/>
-              <a:t>A number to anchor it: the similarity halves at a distance of sqrt(ln 2 / γ). For scikit-learn’s default on the standardised pumps, γ = 0.5, that is about 1.2 standard deviations.</a:t>
-            </a:r>
-          </a:p>
-          <a:p>
-            <a:pPr lvl="0" indent="0" marL="0">
-              <a:buNone/>
-            </a:pPr>
-          </a:p>
-          <a:p>
-            <a:pPr lvl="0" indent="0" marL="0">
-              <a:buNone/>
-            </a:pPr>
-            <a:r>
-              <a:rPr/>
-              <a:t>Worth naming the cost, since this is an engineering course: one exponential per pair of points, so the kernel matrix is m × m. That is why support vector machines are a poor fit above a hundred thousand rows, and it is a property of the method rather than of the implementation.</a:t>
+              <a:t>The trick in one sentence: the SVM never needs the coordinates, only the angles and lengths between points, and those can be obtained without ever going there.</a:t>
+            </a:r>
+          </a:p>
+          <a:p>
+            <a:pPr lvl="0" indent="0" marL="0">
+              <a:buNone/>
+            </a:pPr>
+          </a:p>
+          <a:p>
+            <a:pPr lvl="0" indent="0" marL="0">
+              <a:buNone/>
+            </a:pPr>
+            <a:r>
+              <a:rPr/>
+              <a:t>Do not prove it - handout section 5.4 shows where the inner products come from in the dual formulation. The claim to state and let land is that a function of two ordinary two-dimensional vectors returns their inner product in a space of infinite dimension, at the cost of one exponential.</a:t>
+            </a:r>
+          </a:p>
+          <a:p>
+            <a:pPr lvl="0" indent="0" marL="0">
+              <a:buNone/>
+            </a:pPr>
+          </a:p>
+          <a:p>
+            <a:pPr lvl="0" indent="0" marL="0">
+              <a:buNone/>
+            </a:pPr>
+            <a:r>
+              <a:rPr/>
+              <a:t>And close the loop from the previous slide: we chose the lift in the picture by knowing the answer. The RBF kernel does something equivalent without being told, which is exactly why it works on problems where nobody could guess the right coordinates.</a:t>
             </a:r>
           </a:p>
         </p:txBody>
@@ -6370,35 +6322,35 @@
             </a:pPr>
             <a:r>
               <a:rPr/>
-              <a:t>Say what “fit” does, because after lesson 3 they will expect gradient descent. It is not. The SVM solves the dual: one weight per training point, found by a solver that picks two weights at a time - two, because the weights times the labels must sum to zero, so one cannot move alone - sets them to their best values with the rest fixed, and repeats until nothing improves. Convex, so there is one answer and it is found every time.</a:t>
-            </a:r>
-          </a:p>
-          <a:p>
-            <a:pPr lvl="0" indent="0" marL="0">
-              <a:buNone/>
-            </a:pPr>
-          </a:p>
-          <a:p>
-            <a:pPr lvl="0" indent="0" marL="0">
-              <a:buNone/>
-            </a:pPr>
-            <a:r>
-              <a:rPr/>
-              <a:t>Then the counts, which match the three cases of the slack from earlier. Weight zero: the 922 pumps safely on their own side, which the model now forgets. Weight at the ceiling C: the 268 inside the slab or on the wrong side - with C = 1 that weight is exactly 1, so each of them simply votes with its label. Between: the 10 sitting exactly on the edge.</a:t>
-            </a:r>
-          </a:p>
-          <a:p>
-            <a:pPr lvl="0" indent="0" marL="0">
-              <a:buNone/>
-            </a:pPr>
-          </a:p>
-          <a:p>
-            <a:pPr lvl="0" indent="0" marL="0">
-              <a:buNone/>
-            </a:pPr>
-            <a:r>
-              <a:rPr/>
-              <a:t>The model you ship is 278 points and their weights. Handout section 5.5.</a:t>
+              <a:t>Make the trick concrete before the famous formula. The lift here lists every product of two coordinates: phi(x) = (x1², √2·x1·x2, x2²). Two points, a = (1, 2) and b = (3, 1).</a:t>
+            </a:r>
+          </a:p>
+          <a:p>
+            <a:pPr lvl="0" indent="0" marL="0">
+              <a:buNone/>
+            </a:pPr>
+          </a:p>
+          <a:p>
+            <a:pPr lvl="0" indent="0" marL="0">
+              <a:buNone/>
+            </a:pPr>
+            <a:r>
+              <a:rPr/>
+              <a:t>First row: lift both into three dimensions and take the ordinary inner product - 9 + 12 + 4 = 25. Second row: never lift, take the inner product in the plane, 5, and square it - 25. Same number. The second route never left two dimensions, so the function (a · b)² IS the inner product in the lifted space. That is all a kernel is.</a:t>
+            </a:r>
+          </a:p>
+          <a:p>
+            <a:pPr lvl="0" indent="0" marL="0">
+              <a:buNone/>
+            </a:pPr>
+          </a:p>
+          <a:p>
+            <a:pPr lvl="0" indent="0" marL="0">
+              <a:buNone/>
+            </a:pPr>
+            <a:r>
+              <a:rPr/>
+              <a:t>Then connect it to the figure they just saw: the lifted space contains x1² and x2², and their sum is the squared distance from the centre - the coordinate we chose by hand. A flat plane there is a circle down here. The kernel found the lift we had to guess. Handout section 5.4.</a:t>
             </a:r>
           </a:p>
         </p:txBody>
@@ -6480,35 +6432,73 @@
             </a:pPr>
             <a:r>
               <a:rPr/>
-              <a:t>Inference is a vote, in four steps. Standardise the pump with the training scaler. Compute its RBF similarity to each of the 278 support vectors. Add up weight times label times similarity - label +1 for faulty, -1 for healthy - and add b. Read the sign. Nothing else goes in: the total is exactly what decision_function returns.</a:t>
-            </a:r>
-          </a:p>
-          <a:p>
-            <a:pPr lvl="0" indent="0" marL="0">
-              <a:buNone/>
-            </a:pPr>
-          </a:p>
-          <a:p>
-            <a:pPr lvl="0" indent="0" marL="0">
-              <a:buNone/>
-            </a:pPr>
-            <a:r>
-              <a:rPr/>
-              <a:t>The same pump Naive Bayes called faulty at 0.981, reached by a completely different route.</a:t>
-            </a:r>
-          </a:p>
-          <a:p>
-            <a:pPr lvl="0" indent="0" marL="0">
-              <a:buNone/>
-            </a:pPr>
-          </a:p>
-          <a:p>
-            <a:pPr lvl="0" indent="0" marL="0">
-              <a:buNone/>
-            </a:pPr>
-            <a:r>
-              <a:rPr/>
-              <a:t>The point to make: the neighbourhood decides. The 56 support vectors within about 1.2 standard deviations contribute a net +1.141 towards faulty; the other 222 only -0.363. But not one neighbour - the five nearest disagree, because pumps just outside the envelope are faulty and some just inside carry flipped labels. So the SVM is k-NN again, with a smooth similarity instead of a hard k, only the support vectors voting, and learned weights. And the output is a score, not a probability. Handout section 5.5.</a:t>
+              <a:t>One line, and it is the whole of what scikit-learn does when you leave </a:t>
+            </a:r>
+            <a:r>
+              <a:rPr>
+                <a:latin typeface="Courier"/>
+              </a:rPr>
+              <a:t>kernel</a:t>
+            </a:r>
+            <a:r>
+              <a:rPr/>
+              <a:t> at its default.</a:t>
+            </a:r>
+          </a:p>
+          <a:p>
+            <a:pPr lvl="0" indent="0" marL="0">
+              <a:buNone/>
+            </a:pPr>
+          </a:p>
+          <a:p>
+            <a:pPr lvl="0" indent="0" marL="0">
+              <a:buNone/>
+            </a:pPr>
+            <a:r>
+              <a:rPr/>
+              <a:t>Read it aloud as a similarity rather than as a formula: the closer two points are, the nearer the exponent is to zero and the nearer the kernel is to one; far apart, it falls away to nothing. That is all an RBF kernel says - how much does this point look like that one.</a:t>
+            </a:r>
+          </a:p>
+          <a:p>
+            <a:pPr lvl="0" indent="0" marL="0">
+              <a:buNone/>
+            </a:pPr>
+          </a:p>
+          <a:p>
+            <a:pPr lvl="0" indent="0" marL="0">
+              <a:buNone/>
+            </a:pPr>
+            <a:r>
+              <a:rPr/>
+              <a:t>Now say what γ means, because the next two slides turn on it: it sets how far a single training point’s influence reaches. Small γ, wide reach, smooth boundary. Large γ, each point influences only its immediate neighbourhood - and a boundary that can afford an island around every mislabelled pump.</a:t>
+            </a:r>
+          </a:p>
+          <a:p>
+            <a:pPr lvl="0" indent="0" marL="0">
+              <a:buNone/>
+            </a:pPr>
+          </a:p>
+          <a:p>
+            <a:pPr lvl="0" indent="0" marL="0">
+              <a:buNone/>
+            </a:pPr>
+            <a:r>
+              <a:rPr/>
+              <a:t>A number to anchor it: the similarity halves at a distance of sqrt(ln 2 / γ). For scikit-learn’s default on the standardised pumps, γ = 0.5, that is about 1.2 standard deviations.</a:t>
+            </a:r>
+          </a:p>
+          <a:p>
+            <a:pPr lvl="0" indent="0" marL="0">
+              <a:buNone/>
+            </a:pPr>
+          </a:p>
+          <a:p>
+            <a:pPr lvl="0" indent="0" marL="0">
+              <a:buNone/>
+            </a:pPr>
+            <a:r>
+              <a:rPr/>
+              <a:t>Worth naming the cost, since this is an engineering course: one exponential per pair of points, so the kernel matrix is m × m. That is why support vector machines are a poor fit above a hundred thousand rows, and it is a property of the method rather than of the implementation.</a:t>
             </a:r>
           </a:p>
         </p:txBody>
@@ -6590,53 +6580,35 @@
             </a:pPr>
             <a:r>
               <a:rPr/>
-              <a:t>Read the two columns against each other, exactly as lesson 5 taught, and let the last row do the work.</a:t>
-            </a:r>
-          </a:p>
-          <a:p>
-            <a:pPr lvl="0" indent="0" marL="0">
-              <a:buNone/>
-            </a:pPr>
-          </a:p>
-          <a:p>
-            <a:pPr lvl="0" indent="0" marL="0">
-              <a:buNone/>
-            </a:pPr>
-            <a:r>
-              <a:rPr/>
-              <a:t>The bottom row has the best training score on the slide - 0.995, nearly perfect - and the worst honest one. That is the signature of overfitting, and here it is not inferred from theory but measured on the same data by two different procedures.</a:t>
-            </a:r>
-          </a:p>
-          <a:p>
-            <a:pPr lvl="0" indent="0" marL="0">
-              <a:buNone/>
-            </a:pPr>
-          </a:p>
-          <a:p>
-            <a:pPr lvl="0" indent="0" marL="0">
-              <a:buNone/>
-            </a:pPr>
-            <a:r>
-              <a:rPr b="1"/>
-              <a:t>Now the second predictable mistake, and defend the instinct.</a:t>
-            </a:r>
-            <a:r>
-              <a:rPr/>
-              <a:t> Choosing between these three on the training score selects the WORST model, with complete confidence and a very impressive number to report. And the instinct behind it is not stupid: a higher score on the data you have is, in every other part of engineering, evidence of a better system. Fitting the data well is what we spent lessons 3 and 4 doing. What breaks the analogy is that a flexible model can fit data it has already been shown without learning anything transferable.</a:t>
-            </a:r>
-          </a:p>
-          <a:p>
-            <a:pPr lvl="0" indent="0" marL="0">
-              <a:buNone/>
-            </a:pPr>
-          </a:p>
-          <a:p>
-            <a:pPr lvl="0" indent="0" marL="0">
-              <a:buNone/>
-            </a:pPr>
-            <a:r>
-              <a:rPr/>
-              <a:t>The reason this table is on the slide rather than in the handout is that the next slide shows the same three settings as pictures - so the failure is visible as well as measurable, which is rare.</a:t>
+              <a:t>Say what “fit” does, because after lesson 3 they will expect gradient descent. It is not. The SVM solves the dual: one weight per training point, found by a solver that picks two weights at a time - two, because the weights times the labels must sum to zero, so one cannot move alone - sets them to their best values with the rest fixed, and repeats until nothing improves. Convex, so there is one answer and it is found every time.</a:t>
+            </a:r>
+          </a:p>
+          <a:p>
+            <a:pPr lvl="0" indent="0" marL="0">
+              <a:buNone/>
+            </a:pPr>
+          </a:p>
+          <a:p>
+            <a:pPr lvl="0" indent="0" marL="0">
+              <a:buNone/>
+            </a:pPr>
+            <a:r>
+              <a:rPr/>
+              <a:t>Then the counts, which match the three cases of the slack from earlier. Weight zero: the 922 pumps safely on their own side, which the model now forgets. Weight at the ceiling C: the 268 inside the slab or on the wrong side - with C = 1 that weight is exactly 1, so each of them simply votes with its label. Between: the 10 sitting exactly on the edge.</a:t>
+            </a:r>
+          </a:p>
+          <a:p>
+            <a:pPr lvl="0" indent="0" marL="0">
+              <a:buNone/>
+            </a:pPr>
+          </a:p>
+          <a:p>
+            <a:pPr lvl="0" indent="0" marL="0">
+              <a:buNone/>
+            </a:pPr>
+            <a:r>
+              <a:rPr/>
+              <a:t>The model you ship is 278 points and their weights. Handout section 5.5.</a:t>
             </a:r>
           </a:p>
         </p:txBody>
@@ -6718,63 +6690,35 @@
             </a:pPr>
             <a:r>
               <a:rPr/>
-              <a:t>Three settings, with training and cross-validated scores in each title. Read them together.</a:t>
-            </a:r>
-          </a:p>
-          <a:p>
-            <a:pPr lvl="0" indent="0" marL="0">
-              <a:buNone/>
-            </a:pPr>
-          </a:p>
-          <a:p>
-            <a:pPr lvl="0" indent="0" marL="0">
-              <a:buNone/>
-            </a:pPr>
-            <a:r>
-              <a:rPr/>
-              <a:t>Left, γ = 0.1: a smooth boundary, slightly too smooth, and the two scores agree. Middle, γ = 1: close to the true envelope, and the best honest score.</a:t>
-            </a:r>
-          </a:p>
-          <a:p>
-            <a:pPr lvl="0" indent="0" marL="0">
-              <a:buNone/>
-            </a:pPr>
-          </a:p>
-          <a:p>
-            <a:pPr lvl="0" indent="0" marL="0">
-              <a:buNone/>
-            </a:pPr>
-            <a:r>
-              <a:rPr/>
-              <a:t>Right is the one to sit on. The boundary has broken into bubbles - small islands around individual points, including the mislabelled ones. That is what a 0.995 training score looks like from the outside: the model has drawn a private territory around each flipped label so that it can get it right.</a:t>
-            </a:r>
-          </a:p>
-          <a:p>
-            <a:pPr lvl="0" indent="0" marL="0">
-              <a:buNone/>
-            </a:pPr>
-          </a:p>
-          <a:p>
-            <a:pPr lvl="0" indent="0" marL="0">
-              <a:buNone/>
-            </a:pPr>
-            <a:r>
-              <a:rPr/>
-              <a:t>Ask them what happens to a new pump landing in the gap between two bubbles. That is the 0.902.</a:t>
-            </a:r>
-          </a:p>
-          <a:p>
-            <a:pPr lvl="0" indent="0" marL="0">
-              <a:buNone/>
-            </a:pPr>
-          </a:p>
-          <a:p>
-            <a:pPr lvl="0" indent="0" marL="0">
-              <a:buNone/>
-            </a:pPr>
-            <a:r>
-              <a:rPr/>
-              <a:t>The reason this slide matters more than the table: they have seen overfitting as a curve on a plot since lesson 5. Here it is a shape in the input space, and the shape is obviously wrong in a way no number is. When you can plot the boundary, plot it.</a:t>
+              <a:t>Inference is a vote, in four steps. Standardise the pump with the training scaler. Compute its RBF similarity to each of the 278 support vectors. Add up weight times label times similarity - label +1 for faulty, -1 for healthy - and add b. Read the sign. Nothing else goes in: the total is exactly what decision_function returns.</a:t>
+            </a:r>
+          </a:p>
+          <a:p>
+            <a:pPr lvl="0" indent="0" marL="0">
+              <a:buNone/>
+            </a:pPr>
+          </a:p>
+          <a:p>
+            <a:pPr lvl="0" indent="0" marL="0">
+              <a:buNone/>
+            </a:pPr>
+            <a:r>
+              <a:rPr/>
+              <a:t>The same pump Naive Bayes called faulty at 0.981, reached by a completely different route.</a:t>
+            </a:r>
+          </a:p>
+          <a:p>
+            <a:pPr lvl="0" indent="0" marL="0">
+              <a:buNone/>
+            </a:pPr>
+          </a:p>
+          <a:p>
+            <a:pPr lvl="0" indent="0" marL="0">
+              <a:buNone/>
+            </a:pPr>
+            <a:r>
+              <a:rPr/>
+              <a:t>The point to make: the neighbourhood decides. The 56 support vectors within about 1.2 standard deviations contribute a net +1.141 towards faulty; the other 222 only -0.363. But not one neighbour - the five nearest disagree, because pumps just outside the envelope are faulty and some just inside carry flipped labels. So the SVM is k-NN again, with a smooth similarity instead of a hard k, only the support vectors voting, and learned weights. And the output is a score, not a probability. Handout section 5.5.</a:t>
             </a:r>
           </a:p>
         </p:txBody>
@@ -6856,49 +6800,21 @@
             </a:pPr>
             <a:r>
               <a:rPr/>
-              <a:t>Run notebooks/03. Sixteen minutes.</a:t>
-            </a:r>
-          </a:p>
-          <a:p>
-            <a:pPr lvl="0" indent="0" marL="0">
-              <a:buNone/>
-            </a:pPr>
-          </a:p>
-          <a:p>
-            <a:pPr lvl="0" indent="0" marL="0">
-              <a:buNone/>
-            </a:pPr>
-            <a:r>
-              <a:rPr/>
-              <a:t>The cell to protect is the γ sweep with the boundary drawn at each setting. Let them turn γ up themselves and watch the bubbles form - it is the most direct experience of overfitting available in this course.</a:t>
-            </a:r>
-          </a:p>
-          <a:p>
-            <a:pPr lvl="0" indent="0" marL="0">
-              <a:buNone/>
-            </a:pPr>
-          </a:p>
-          <a:p>
-            <a:pPr lvl="0" indent="0" marL="0">
-              <a:buNone/>
-            </a:pPr>
-            <a:r>
-              <a:rPr/>
-              <a:t>Have them print the support-vector fraction for the linear and RBF kernels side by side. Two numbers, and it makes the diagnostic real rather than a claim on a slide.</a:t>
-            </a:r>
-          </a:p>
-          <a:p>
-            <a:pPr lvl="0" indent="0" marL="0">
-              <a:buNone/>
-            </a:pPr>
-          </a:p>
-          <a:p>
-            <a:pPr lvl="0" indent="0" marL="0">
-              <a:buNone/>
-            </a:pPr>
-            <a:r>
-              <a:rPr/>
-              <a:t>If time runs short, skip the C sweep and set it as reading: the table is in handout section 5.6.</a:t>
+              <a:t>The table on the previous slide, drawn. Every support vector is sized and shaded by its similarity to the pump, the gold star at 48 Hz and 5.6 bar; the dashed ellipse is where similarity falls to one half, about 1.2 standard deviations; the black line is the SVM’s boundary.</a:t>
+            </a:r>
+          </a:p>
+          <a:p>
+            <a:pPr lvl="0" indent="0" marL="0">
+              <a:buNone/>
+            </a:pPr>
+          </a:p>
+          <a:p>
+            <a:pPr lvl="0" indent="0" marL="0">
+              <a:buNone/>
+            </a:pPr>
+            <a:r>
+              <a:rPr/>
+              <a:t>Point out where the weight is: the 56 support vectors inside the dashed ellipse carry most of it, the ones across the disc have faded out. Then point at the star’s immediate neighbours - teal and rust together, boundary pumps and flipped labels. That is why the five nearest nearly cancel, and why it is the neighbourhood’s balance, not one neighbour, that makes it faulty. Handout section 5.5.</a:t>
             </a:r>
           </a:p>
         </p:txBody>
@@ -6980,57 +6896,53 @@
             </a:pPr>
             <a:r>
               <a:rPr/>
-              <a:t>Everything in the lesson on the same 1,200 pumps, cross-validated the same way.</a:t>
-            </a:r>
-          </a:p>
-          <a:p>
-            <a:pPr lvl="0" indent="0" marL="0">
-              <a:buNone/>
-            </a:pPr>
-          </a:p>
-          <a:p>
-            <a:pPr lvl="0" indent="0" marL="0">
-              <a:buNone/>
-            </a:pPr>
-            <a:r>
-              <a:rPr/>
-              <a:t>Read the top three rows together: all exactly 0.613, and all three are linear. Then the bottom three, all near the ceiling, reached by three completely unrelated routes - remembering the neighbourhood, assuming independence, bending the space. There is no single idea shared between them.</a:t>
-            </a:r>
-          </a:p>
-          <a:p>
-            <a:pPr lvl="0" indent="0" marL="0">
-              <a:buNone/>
-            </a:pPr>
-          </a:p>
-          <a:p>
-            <a:pPr lvl="0" indent="0" marL="0">
-              <a:buNone/>
-            </a:pPr>
-            <a:r>
-              <a:rPr/>
-              <a:t>Then the number that is the lesson: the gap between best and worst is </a:t>
-            </a:r>
+              <a:t>Read the two columns against each other, exactly as lesson 5 taught, and let the last row do the work.</a:t>
+            </a:r>
+          </a:p>
+          <a:p>
+            <a:pPr lvl="0" indent="0" marL="0">
+              <a:buNone/>
+            </a:pPr>
+          </a:p>
+          <a:p>
+            <a:pPr lvl="0" indent="0" marL="0">
+              <a:buNone/>
+            </a:pPr>
+            <a:r>
+              <a:rPr/>
+              <a:t>The bottom row has the best training score on the slide - 0.995, nearly perfect - and the worst honest one. That is the signature of overfitting, and here it is not inferred from theory but measured on the same data by two different procedures.</a:t>
+            </a:r>
+          </a:p>
+          <a:p>
+            <a:pPr lvl="0" indent="0" marL="0">
+              <a:buNone/>
+            </a:pPr>
+          </a:p>
+          <a:p>
+            <a:pPr lvl="0" indent="0" marL="0">
+              <a:buNone/>
+            </a:pPr>
             <a:r>
               <a:rPr b="1"/>
-              <a:t>0.334</a:t>
-            </a:r>
-            <a:r>
-              <a:rPr/>
-              <a:t>. Larger than any difference this course has shown between a good model and a carefully tuned one - lesson 5’s entire hyperparameter search moved things by a few hundredths.</a:t>
-            </a:r>
-          </a:p>
-          <a:p>
-            <a:pPr lvl="0" indent="0" marL="0">
-              <a:buNone/>
-            </a:pPr>
-          </a:p>
-          <a:p>
-            <a:pPr lvl="0" indent="0" marL="0">
-              <a:buNone/>
-            </a:pPr>
-            <a:r>
-              <a:rPr/>
-              <a:t>Say the conclusion plainly, and it is the practical takeaway of the whole lesson: choosing the right family matters far more than tuning the wrong one. Nobody in the top three rows could have tuned their way out. And the way to tell which family you need is to look at the data first, which is what lesson 2 was for.</a:t>
+              <a:t>Now the second predictable mistake, and defend the instinct.</a:t>
+            </a:r>
+            <a:r>
+              <a:rPr/>
+              <a:t> Choosing between these three on the training score selects the WORST model, with complete confidence and a very impressive number to report. And the instinct behind it is not stupid: a higher score on the data you have is, in every other part of engineering, evidence of a better system. Fitting the data well is what we spent lessons 3 and 4 doing. What breaks the analogy is that a flexible model can fit data it has already been shown without learning anything transferable.</a:t>
+            </a:r>
+          </a:p>
+          <a:p>
+            <a:pPr lvl="0" indent="0" marL="0">
+              <a:buNone/>
+            </a:pPr>
+          </a:p>
+          <a:p>
+            <a:pPr lvl="0" indent="0" marL="0">
+              <a:buNone/>
+            </a:pPr>
+            <a:r>
+              <a:rPr/>
+              <a:t>The reason this table is on the slide rather than in the handout is that the next slide shows the same three settings as pictures - so the failure is visible as well as measurable, which is rare.</a:t>
             </a:r>
           </a:p>
         </p:txBody>
@@ -7112,35 +7024,21 @@
             </a:pPr>
             <a:r>
               <a:rPr/>
-              <a:t>A table to photograph. Work down it and attach today’s evidence to each row, so it is remembered as a set of conclusions rather than as advice.</a:t>
-            </a:r>
-          </a:p>
-          <a:p>
-            <a:pPr lvl="0" indent="0" marL="0">
-              <a:buNone/>
-            </a:pPr>
-          </a:p>
-          <a:p>
-            <a:pPr lvl="0" indent="0" marL="0">
-              <a:buNone/>
-            </a:pPr>
-            <a:r>
-              <a:rPr/>
-              <a:t>Row two deserves a sentence on its own, because it is the one that sounds wrong after the last hour. Text classification is the canonical case: tens of thousands of word-count features, an assumption that is transparently false, and a method that works anyway - because being roughly right in ten thousand dimensions beats being unable to estimate anything at all. Also mention Naive Bayes as a baseline: it trains in one pass, so if your tuned model does not beat it you have learned something quickly and cheaply.</a:t>
-            </a:r>
-          </a:p>
-          <a:p>
-            <a:pPr lvl="0" indent="0" marL="0">
-              <a:buNone/>
-            </a:pPr>
-          </a:p>
-          <a:p>
-            <a:pPr lvl="0" indent="0" marL="0">
-              <a:buNone/>
-            </a:pPr>
-            <a:r>
-              <a:rPr/>
-              <a:t>One row that did not fit and should be said out loud: when you need to explain the decision to the person affected, none of today’s three will do it. A support vector machine in a lifted space has no explanation a customer would accept. Lesson 3’s Resources document covers why that is sometimes a legal requirement rather than a preference.</a:t>
+              <a:t>Gamma as a distance rather than a symbol. Each curve is the RBF similarity against the distance between two pumps; where it crosses the dotted line is the distance at which a support vector’s vote has halved: 2.63 standard deviations at gamma 0.1, 1.18 at the default 0.5, 0.83 at 1, and 0.12 at 50.</a:t>
+            </a:r>
+          </a:p>
+          <a:p>
+            <a:pPr lvl="0" indent="0" marL="0">
+              <a:buNone/>
+            </a:pPr>
+          </a:p>
+          <a:p>
+            <a:pPr lvl="0" indent="0" marL="0">
+              <a:buNone/>
+            </a:pPr>
+            <a:r>
+              <a:rPr/>
+              <a:t>Ask them to predict the next slide from this one: at gamma 50 a point speaks only for a neighbourhood a tenth of a standard deviation wide. What will the boundary look like? Islands. Handout section 5.6.</a:t>
             </a:r>
           </a:p>
         </p:txBody>
@@ -7222,49 +7120,63 @@
             </a:pPr>
             <a:r>
               <a:rPr/>
-              <a:t>Close on the number they opened the second segment with, and say it one more time: seventy per cent. In a hundred dimensions the nearest point in the entire dataset is seven tenths of the way to the farthest, and every method built on distance is operating on a quantity that has stopped varying.</a:t>
-            </a:r>
-          </a:p>
-          <a:p>
-            <a:pPr lvl="0" indent="0" marL="0">
-              <a:buNone/>
-            </a:pPr>
-          </a:p>
-          <a:p>
-            <a:pPr lvl="0" indent="0" marL="0">
-              <a:buNone/>
-            </a:pPr>
-            <a:r>
-              <a:rPr/>
-              <a:t>If they remember one habit from today, make it the diagnostic pair: before reaching for a model, look at the shape of the data; after fitting one, check whether the assumption it depends on is actually satisfied on your data - and check it properly. The −0.006 said yes; the squared distances said no; and the ellipse the model drew explained the 0.933.</a:t>
-            </a:r>
-          </a:p>
-          <a:p>
-            <a:pPr lvl="0" indent="0" marL="0">
-              <a:buNone/>
-            </a:pPr>
-          </a:p>
-          <a:p>
-            <a:pPr lvl="0" indent="0" marL="0">
-              <a:buNone/>
-            </a:pPr>
-            <a:r>
-              <a:rPr/>
-              <a:t>And the correction to the instinct that this lesson exists to install: more features is not free. It is nearly free for a linear model and it is expensive for anything built on a distance.</a:t>
-            </a:r>
-          </a:p>
-          <a:p>
-            <a:pPr lvl="0" indent="0" marL="0">
-              <a:buNone/>
-            </a:pPr>
-          </a:p>
-          <a:p>
-            <a:pPr lvl="0" indent="0" marL="0">
-              <a:buNone/>
-            </a:pPr>
-            <a:r>
-              <a:rPr/>
-              <a:t>Handout section 7 lists all of this with the section numbers.</a:t>
+              <a:t>Three settings, with training and cross-validated scores in each title. Read them together.</a:t>
+            </a:r>
+          </a:p>
+          <a:p>
+            <a:pPr lvl="0" indent="0" marL="0">
+              <a:buNone/>
+            </a:pPr>
+          </a:p>
+          <a:p>
+            <a:pPr lvl="0" indent="0" marL="0">
+              <a:buNone/>
+            </a:pPr>
+            <a:r>
+              <a:rPr/>
+              <a:t>Left, γ = 0.1: a smooth boundary, slightly too smooth, and the two scores agree. Middle, γ = 1: close to the true envelope, and the best honest score.</a:t>
+            </a:r>
+          </a:p>
+          <a:p>
+            <a:pPr lvl="0" indent="0" marL="0">
+              <a:buNone/>
+            </a:pPr>
+          </a:p>
+          <a:p>
+            <a:pPr lvl="0" indent="0" marL="0">
+              <a:buNone/>
+            </a:pPr>
+            <a:r>
+              <a:rPr/>
+              <a:t>Right is the one to sit on. The boundary has broken into bubbles - small islands around individual points, including the mislabelled ones. That is what a 0.995 training score looks like from the outside: the model has drawn a private territory around each flipped label so that it can get it right.</a:t>
+            </a:r>
+          </a:p>
+          <a:p>
+            <a:pPr lvl="0" indent="0" marL="0">
+              <a:buNone/>
+            </a:pPr>
+          </a:p>
+          <a:p>
+            <a:pPr lvl="0" indent="0" marL="0">
+              <a:buNone/>
+            </a:pPr>
+            <a:r>
+              <a:rPr/>
+              <a:t>Ask them what happens to a new pump landing in the gap between two bubbles. That is the 0.902.</a:t>
+            </a:r>
+          </a:p>
+          <a:p>
+            <a:pPr lvl="0" indent="0" marL="0">
+              <a:buNone/>
+            </a:pPr>
+          </a:p>
+          <a:p>
+            <a:pPr lvl="0" indent="0" marL="0">
+              <a:buNone/>
+            </a:pPr>
+            <a:r>
+              <a:rPr/>
+              <a:t>The reason this slide matters more than the table: they have seen overfitting as a curve on a plot since lesson 5. Here it is a shape in the input space, and the shape is obviously wrong in a way no number is. When you can plot the boundary, plot it.</a:t>
             </a:r>
           </a:p>
         </p:txBody>
@@ -7470,49 +7382,49 @@
             </a:pPr>
             <a:r>
               <a:rPr/>
-              <a:t>Set it explicitly and say out loud when it comes back: the first ten minutes of next Friday, 13 November.</a:t>
-            </a:r>
-          </a:p>
-          <a:p>
-            <a:pPr lvl="0" indent="0" marL="0">
-              <a:buNone/>
-            </a:pPr>
-          </a:p>
-          <a:p>
-            <a:pPr lvl="0" indent="0" marL="0">
-              <a:buNone/>
-            </a:pPr>
-            <a:r>
-              <a:rPr/>
-              <a:t>The marks are for the reasoning, not for the accuracy. A well-argued choice that scores slightly worse beats a lucky winner with no justification - and the argument has to reference the data, in the way that the squared distances and the fitted ellipse explained Naive Bayes on the pumps this afternoon.</a:t>
-            </a:r>
-          </a:p>
-          <a:p>
-            <a:pPr lvl="0" indent="0" marL="0">
-              <a:buNone/>
-            </a:pPr>
-          </a:p>
-          <a:p>
-            <a:pPr lvl="0" indent="0" marL="0">
-              <a:buNone/>
-            </a:pPr>
-            <a:r>
-              <a:rPr/>
-              <a:t>Remind them that everything must be cross-validated and reported with a spread, in the format lesson 5 set. Scaling goes inside the pipeline; that will be checked.</a:t>
-            </a:r>
-          </a:p>
-          <a:p>
-            <a:pPr lvl="0" indent="0" marL="0">
-              <a:buNone/>
-            </a:pPr>
-          </a:p>
-          <a:p>
-            <a:pPr lvl="0" indent="0" marL="0">
-              <a:buNone/>
-            </a:pPr>
-            <a:r>
-              <a:rPr/>
-              <a:t>Next week: decision trees and ensembles. A fourth family, with a different answer again to the same question - how do you draw a boundary that is not a line.</a:t>
+              <a:t>Run notebooks/03. Sixteen minutes.</a:t>
+            </a:r>
+          </a:p>
+          <a:p>
+            <a:pPr lvl="0" indent="0" marL="0">
+              <a:buNone/>
+            </a:pPr>
+          </a:p>
+          <a:p>
+            <a:pPr lvl="0" indent="0" marL="0">
+              <a:buNone/>
+            </a:pPr>
+            <a:r>
+              <a:rPr/>
+              <a:t>The cell to protect is the γ sweep with the boundary drawn at each setting. Let them turn γ up themselves and watch the bubbles form - it is the most direct experience of overfitting available in this course.</a:t>
+            </a:r>
+          </a:p>
+          <a:p>
+            <a:pPr lvl="0" indent="0" marL="0">
+              <a:buNone/>
+            </a:pPr>
+          </a:p>
+          <a:p>
+            <a:pPr lvl="0" indent="0" marL="0">
+              <a:buNone/>
+            </a:pPr>
+            <a:r>
+              <a:rPr/>
+              <a:t>Have them print the support-vector fraction for the linear and RBF kernels side by side. Two numbers, and it makes the diagnostic real rather than a claim on a slide.</a:t>
+            </a:r>
+          </a:p>
+          <a:p>
+            <a:pPr lvl="0" indent="0" marL="0">
+              <a:buNone/>
+            </a:pPr>
+          </a:p>
+          <a:p>
+            <a:pPr lvl="0" indent="0" marL="0">
+              <a:buNone/>
+            </a:pPr>
+            <a:r>
+              <a:rPr/>
+              <a:t>If time runs short, skip the C sweep and set it as reading: the table is in handout section 5.6.</a:t>
             </a:r>
           </a:p>
         </p:txBody>
@@ -7535,6 +7447,496 @@
             <a:fld id="{18BDFEC3-8487-43E8-A154-7C12CBC1FFF2}" type="slidenum">
               <a:rPr lang="en-US"/>
               <a:t>61</a:t>
+            </a:fld>
+            <a:endParaRPr lang="en-US"/>
+          </a:p>
+        </p:txBody>
+      </p:sp>
+    </p:spTree>
+  </p:cSld>
+</p:notes>
+</file>
+
+<file path=ppt/notesSlides/notesSlide61.xml><?xml version="1.0" encoding="utf-8"?>
+<p:notes xmlns:a="http://schemas.openxmlformats.org/drawingml/2006/main" xmlns:r="http://schemas.openxmlformats.org/officeDocument/2006/relationships" xmlns:p="http://schemas.openxmlformats.org/presentationml/2006/main">
+  <p:cSld>
+    <p:spTree>
+      <p:nvGrpSpPr>
+        <p:cNvPr id="1" name=""/>
+        <p:cNvGrpSpPr/>
+        <p:nvPr/>
+      </p:nvGrpSpPr>
+      <p:grpSpPr>
+        <a:xfrm>
+          <a:off x="0" y="0"/>
+          <a:ext cx="0" cy="0"/>
+          <a:chOff x="0" y="0"/>
+          <a:chExt cx="0" cy="0"/>
+        </a:xfrm>
+      </p:grpSpPr>
+      <p:sp>
+        <p:nvSpPr>
+          <p:cNvPr id="2" name="Slide Image Placeholder 1"/>
+          <p:cNvSpPr>
+            <a:spLocks noGrp="1" noRot="1" noChangeAspect="1"/>
+          </p:cNvSpPr>
+          <p:nvPr>
+            <p:ph type="sldImg"/>
+          </p:nvPr>
+        </p:nvSpPr>
+        <p:spPr/>
+      </p:sp>
+      <p:sp>
+        <p:nvSpPr>
+          <p:cNvPr id="3" name="Notes Placeholder 2"/>
+          <p:cNvSpPr>
+            <a:spLocks noGrp="1"/>
+          </p:cNvSpPr>
+          <p:nvPr>
+            <p:ph type="body" idx="1"/>
+          </p:nvPr>
+        </p:nvSpPr>
+        <p:spPr/>
+        <p:txBody>
+          <a:bodyPr/>
+          <a:lstStyle/>
+          <a:p>
+            <a:pPr lvl="0" indent="0" marL="0">
+              <a:buNone/>
+            </a:pPr>
+            <a:r>
+              <a:rPr/>
+              <a:t>Everything in the lesson on the same 1,200 pumps, cross-validated the same way.</a:t>
+            </a:r>
+          </a:p>
+          <a:p>
+            <a:pPr lvl="0" indent="0" marL="0">
+              <a:buNone/>
+            </a:pPr>
+          </a:p>
+          <a:p>
+            <a:pPr lvl="0" indent="0" marL="0">
+              <a:buNone/>
+            </a:pPr>
+            <a:r>
+              <a:rPr/>
+              <a:t>Read the top three rows together: all exactly 0.613, and all three are linear. Then the bottom three, all near the ceiling, reached by three completely unrelated routes - remembering the neighbourhood, assuming independence, bending the space. There is no single idea shared between them.</a:t>
+            </a:r>
+          </a:p>
+          <a:p>
+            <a:pPr lvl="0" indent="0" marL="0">
+              <a:buNone/>
+            </a:pPr>
+          </a:p>
+          <a:p>
+            <a:pPr lvl="0" indent="0" marL="0">
+              <a:buNone/>
+            </a:pPr>
+            <a:r>
+              <a:rPr/>
+              <a:t>Then the number that is the lesson: the gap between best and worst is </a:t>
+            </a:r>
+            <a:r>
+              <a:rPr b="1"/>
+              <a:t>0.334</a:t>
+            </a:r>
+            <a:r>
+              <a:rPr/>
+              <a:t>. Larger than any difference this course has shown between a good model and a carefully tuned one - lesson 5’s entire hyperparameter search moved things by a few hundredths.</a:t>
+            </a:r>
+          </a:p>
+          <a:p>
+            <a:pPr lvl="0" indent="0" marL="0">
+              <a:buNone/>
+            </a:pPr>
+          </a:p>
+          <a:p>
+            <a:pPr lvl="0" indent="0" marL="0">
+              <a:buNone/>
+            </a:pPr>
+            <a:r>
+              <a:rPr/>
+              <a:t>Say the conclusion plainly, and it is the practical takeaway of the whole lesson: choosing the right family matters far more than tuning the wrong one. Nobody in the top three rows could have tuned their way out. And the way to tell which family you need is to look at the data first, which is what lesson 2 was for.</a:t>
+            </a:r>
+          </a:p>
+        </p:txBody>
+      </p:sp>
+      <p:sp>
+        <p:nvSpPr>
+          <p:cNvPr id="4" name="Slide Number Placeholder 3"/>
+          <p:cNvSpPr>
+            <a:spLocks noGrp="1"/>
+          </p:cNvSpPr>
+          <p:nvPr>
+            <p:ph type="sldNum" sz="quarter" idx="10"/>
+          </p:nvPr>
+        </p:nvSpPr>
+        <p:spPr/>
+        <p:txBody>
+          <a:bodyPr/>
+          <a:lstStyle/>
+          <a:p>
+            <a:fld id="{18BDFEC3-8487-43E8-A154-7C12CBC1FFF2}" type="slidenum">
+              <a:rPr lang="en-US"/>
+              <a:t>62</a:t>
+            </a:fld>
+            <a:endParaRPr lang="en-US"/>
+          </a:p>
+        </p:txBody>
+      </p:sp>
+    </p:spTree>
+  </p:cSld>
+</p:notes>
+</file>
+
+<file path=ppt/notesSlides/notesSlide62.xml><?xml version="1.0" encoding="utf-8"?>
+<p:notes xmlns:a="http://schemas.openxmlformats.org/drawingml/2006/main" xmlns:r="http://schemas.openxmlformats.org/officeDocument/2006/relationships" xmlns:p="http://schemas.openxmlformats.org/presentationml/2006/main">
+  <p:cSld>
+    <p:spTree>
+      <p:nvGrpSpPr>
+        <p:cNvPr id="1" name=""/>
+        <p:cNvGrpSpPr/>
+        <p:nvPr/>
+      </p:nvGrpSpPr>
+      <p:grpSpPr>
+        <a:xfrm>
+          <a:off x="0" y="0"/>
+          <a:ext cx="0" cy="0"/>
+          <a:chOff x="0" y="0"/>
+          <a:chExt cx="0" cy="0"/>
+        </a:xfrm>
+      </p:grpSpPr>
+      <p:sp>
+        <p:nvSpPr>
+          <p:cNvPr id="2" name="Slide Image Placeholder 1"/>
+          <p:cNvSpPr>
+            <a:spLocks noGrp="1" noRot="1" noChangeAspect="1"/>
+          </p:cNvSpPr>
+          <p:nvPr>
+            <p:ph type="sldImg"/>
+          </p:nvPr>
+        </p:nvSpPr>
+        <p:spPr/>
+      </p:sp>
+      <p:sp>
+        <p:nvSpPr>
+          <p:cNvPr id="3" name="Notes Placeholder 2"/>
+          <p:cNvSpPr>
+            <a:spLocks noGrp="1"/>
+          </p:cNvSpPr>
+          <p:nvPr>
+            <p:ph type="body" idx="1"/>
+          </p:nvPr>
+        </p:nvSpPr>
+        <p:spPr/>
+        <p:txBody>
+          <a:bodyPr/>
+          <a:lstStyle/>
+          <a:p>
+            <a:pPr lvl="0" indent="0" marL="0">
+              <a:buNone/>
+            </a:pPr>
+            <a:r>
+              <a:rPr/>
+              <a:t>A table to photograph. Work down it and attach today’s evidence to each row, so it is remembered as a set of conclusions rather than as advice.</a:t>
+            </a:r>
+          </a:p>
+          <a:p>
+            <a:pPr lvl="0" indent="0" marL="0">
+              <a:buNone/>
+            </a:pPr>
+          </a:p>
+          <a:p>
+            <a:pPr lvl="0" indent="0" marL="0">
+              <a:buNone/>
+            </a:pPr>
+            <a:r>
+              <a:rPr/>
+              <a:t>Row two deserves a sentence on its own, because it is the one that sounds wrong after the last hour. Text classification is the canonical case: tens of thousands of word-count features, an assumption that is transparently false, and a method that works anyway - because being roughly right in ten thousand dimensions beats being unable to estimate anything at all. Also mention Naive Bayes as a baseline: it trains in one pass, so if your tuned model does not beat it you have learned something quickly and cheaply.</a:t>
+            </a:r>
+          </a:p>
+          <a:p>
+            <a:pPr lvl="0" indent="0" marL="0">
+              <a:buNone/>
+            </a:pPr>
+          </a:p>
+          <a:p>
+            <a:pPr lvl="0" indent="0" marL="0">
+              <a:buNone/>
+            </a:pPr>
+            <a:r>
+              <a:rPr/>
+              <a:t>One row that did not fit and should be said out loud: when you need to explain the decision to the person affected, none of today’s three will do it. A support vector machine in a lifted space has no explanation a customer would accept. Lesson 3’s Resources document covers why that is sometimes a legal requirement rather than a preference.</a:t>
+            </a:r>
+          </a:p>
+        </p:txBody>
+      </p:sp>
+      <p:sp>
+        <p:nvSpPr>
+          <p:cNvPr id="4" name="Slide Number Placeholder 3"/>
+          <p:cNvSpPr>
+            <a:spLocks noGrp="1"/>
+          </p:cNvSpPr>
+          <p:nvPr>
+            <p:ph type="sldNum" sz="quarter" idx="10"/>
+          </p:nvPr>
+        </p:nvSpPr>
+        <p:spPr/>
+        <p:txBody>
+          <a:bodyPr/>
+          <a:lstStyle/>
+          <a:p>
+            <a:fld id="{18BDFEC3-8487-43E8-A154-7C12CBC1FFF2}" type="slidenum">
+              <a:rPr lang="en-US"/>
+              <a:t>63</a:t>
+            </a:fld>
+            <a:endParaRPr lang="en-US"/>
+          </a:p>
+        </p:txBody>
+      </p:sp>
+    </p:spTree>
+  </p:cSld>
+</p:notes>
+</file>
+
+<file path=ppt/notesSlides/notesSlide63.xml><?xml version="1.0" encoding="utf-8"?>
+<p:notes xmlns:a="http://schemas.openxmlformats.org/drawingml/2006/main" xmlns:r="http://schemas.openxmlformats.org/officeDocument/2006/relationships" xmlns:p="http://schemas.openxmlformats.org/presentationml/2006/main">
+  <p:cSld>
+    <p:spTree>
+      <p:nvGrpSpPr>
+        <p:cNvPr id="1" name=""/>
+        <p:cNvGrpSpPr/>
+        <p:nvPr/>
+      </p:nvGrpSpPr>
+      <p:grpSpPr>
+        <a:xfrm>
+          <a:off x="0" y="0"/>
+          <a:ext cx="0" cy="0"/>
+          <a:chOff x="0" y="0"/>
+          <a:chExt cx="0" cy="0"/>
+        </a:xfrm>
+      </p:grpSpPr>
+      <p:sp>
+        <p:nvSpPr>
+          <p:cNvPr id="2" name="Slide Image Placeholder 1"/>
+          <p:cNvSpPr>
+            <a:spLocks noGrp="1" noRot="1" noChangeAspect="1"/>
+          </p:cNvSpPr>
+          <p:nvPr>
+            <p:ph type="sldImg"/>
+          </p:nvPr>
+        </p:nvSpPr>
+        <p:spPr/>
+      </p:sp>
+      <p:sp>
+        <p:nvSpPr>
+          <p:cNvPr id="3" name="Notes Placeholder 2"/>
+          <p:cNvSpPr>
+            <a:spLocks noGrp="1"/>
+          </p:cNvSpPr>
+          <p:nvPr>
+            <p:ph type="body" idx="1"/>
+          </p:nvPr>
+        </p:nvSpPr>
+        <p:spPr/>
+        <p:txBody>
+          <a:bodyPr/>
+          <a:lstStyle/>
+          <a:p>
+            <a:pPr lvl="0" indent="0" marL="0">
+              <a:buNone/>
+            </a:pPr>
+            <a:r>
+              <a:rPr/>
+              <a:t>Close on the number they opened the second segment with, and say it one more time: seventy per cent. In a hundred dimensions the nearest point in the entire dataset is seven tenths of the way to the farthest, and every method built on distance is operating on a quantity that has stopped varying.</a:t>
+            </a:r>
+          </a:p>
+          <a:p>
+            <a:pPr lvl="0" indent="0" marL="0">
+              <a:buNone/>
+            </a:pPr>
+          </a:p>
+          <a:p>
+            <a:pPr lvl="0" indent="0" marL="0">
+              <a:buNone/>
+            </a:pPr>
+            <a:r>
+              <a:rPr/>
+              <a:t>If they remember one habit from today, make it the diagnostic pair: before reaching for a model, look at the shape of the data; after fitting one, check whether the assumption it depends on is actually satisfied on your data - and check it properly. The −0.006 said yes; the squared distances said no; and the ellipse the model drew explained the 0.933.</a:t>
+            </a:r>
+          </a:p>
+          <a:p>
+            <a:pPr lvl="0" indent="0" marL="0">
+              <a:buNone/>
+            </a:pPr>
+          </a:p>
+          <a:p>
+            <a:pPr lvl="0" indent="0" marL="0">
+              <a:buNone/>
+            </a:pPr>
+            <a:r>
+              <a:rPr/>
+              <a:t>And the correction to the instinct that this lesson exists to install: more features is not free. It is nearly free for a linear model and it is expensive for anything built on a distance.</a:t>
+            </a:r>
+          </a:p>
+          <a:p>
+            <a:pPr lvl="0" indent="0" marL="0">
+              <a:buNone/>
+            </a:pPr>
+          </a:p>
+          <a:p>
+            <a:pPr lvl="0" indent="0" marL="0">
+              <a:buNone/>
+            </a:pPr>
+            <a:r>
+              <a:rPr/>
+              <a:t>Handout section 7 lists all of this with the section numbers.</a:t>
+            </a:r>
+          </a:p>
+        </p:txBody>
+      </p:sp>
+      <p:sp>
+        <p:nvSpPr>
+          <p:cNvPr id="4" name="Slide Number Placeholder 3"/>
+          <p:cNvSpPr>
+            <a:spLocks noGrp="1"/>
+          </p:cNvSpPr>
+          <p:nvPr>
+            <p:ph type="sldNum" sz="quarter" idx="10"/>
+          </p:nvPr>
+        </p:nvSpPr>
+        <p:spPr/>
+        <p:txBody>
+          <a:bodyPr/>
+          <a:lstStyle/>
+          <a:p>
+            <a:fld id="{18BDFEC3-8487-43E8-A154-7C12CBC1FFF2}" type="slidenum">
+              <a:rPr lang="en-US"/>
+              <a:t>64</a:t>
+            </a:fld>
+            <a:endParaRPr lang="en-US"/>
+          </a:p>
+        </p:txBody>
+      </p:sp>
+    </p:spTree>
+  </p:cSld>
+</p:notes>
+</file>
+
+<file path=ppt/notesSlides/notesSlide64.xml><?xml version="1.0" encoding="utf-8"?>
+<p:notes xmlns:a="http://schemas.openxmlformats.org/drawingml/2006/main" xmlns:r="http://schemas.openxmlformats.org/officeDocument/2006/relationships" xmlns:p="http://schemas.openxmlformats.org/presentationml/2006/main">
+  <p:cSld>
+    <p:spTree>
+      <p:nvGrpSpPr>
+        <p:cNvPr id="1" name=""/>
+        <p:cNvGrpSpPr/>
+        <p:nvPr/>
+      </p:nvGrpSpPr>
+      <p:grpSpPr>
+        <a:xfrm>
+          <a:off x="0" y="0"/>
+          <a:ext cx="0" cy="0"/>
+          <a:chOff x="0" y="0"/>
+          <a:chExt cx="0" cy="0"/>
+        </a:xfrm>
+      </p:grpSpPr>
+      <p:sp>
+        <p:nvSpPr>
+          <p:cNvPr id="2" name="Slide Image Placeholder 1"/>
+          <p:cNvSpPr>
+            <a:spLocks noGrp="1" noRot="1" noChangeAspect="1"/>
+          </p:cNvSpPr>
+          <p:nvPr>
+            <p:ph type="sldImg"/>
+          </p:nvPr>
+        </p:nvSpPr>
+        <p:spPr/>
+      </p:sp>
+      <p:sp>
+        <p:nvSpPr>
+          <p:cNvPr id="3" name="Notes Placeholder 2"/>
+          <p:cNvSpPr>
+            <a:spLocks noGrp="1"/>
+          </p:cNvSpPr>
+          <p:nvPr>
+            <p:ph type="body" idx="1"/>
+          </p:nvPr>
+        </p:nvSpPr>
+        <p:spPr/>
+        <p:txBody>
+          <a:bodyPr/>
+          <a:lstStyle/>
+          <a:p>
+            <a:pPr lvl="0" indent="0" marL="0">
+              <a:buNone/>
+            </a:pPr>
+            <a:r>
+              <a:rPr/>
+              <a:t>Set it explicitly and say out loud when it comes back: the first ten minutes of next Friday, 13 November.</a:t>
+            </a:r>
+          </a:p>
+          <a:p>
+            <a:pPr lvl="0" indent="0" marL="0">
+              <a:buNone/>
+            </a:pPr>
+          </a:p>
+          <a:p>
+            <a:pPr lvl="0" indent="0" marL="0">
+              <a:buNone/>
+            </a:pPr>
+            <a:r>
+              <a:rPr/>
+              <a:t>The marks are for the reasoning, not for the accuracy. A well-argued choice that scores slightly worse beats a lucky winner with no justification - and the argument has to reference the data, in the way that the squared distances and the fitted ellipse explained Naive Bayes on the pumps this afternoon.</a:t>
+            </a:r>
+          </a:p>
+          <a:p>
+            <a:pPr lvl="0" indent="0" marL="0">
+              <a:buNone/>
+            </a:pPr>
+          </a:p>
+          <a:p>
+            <a:pPr lvl="0" indent="0" marL="0">
+              <a:buNone/>
+            </a:pPr>
+            <a:r>
+              <a:rPr/>
+              <a:t>Remind them that everything must be cross-validated and reported with a spread, in the format lesson 5 set. Scaling goes inside the pipeline; that will be checked.</a:t>
+            </a:r>
+          </a:p>
+          <a:p>
+            <a:pPr lvl="0" indent="0" marL="0">
+              <a:buNone/>
+            </a:pPr>
+          </a:p>
+          <a:p>
+            <a:pPr lvl="0" indent="0" marL="0">
+              <a:buNone/>
+            </a:pPr>
+            <a:r>
+              <a:rPr/>
+              <a:t>Next week: decision trees and ensembles. A fourth family, with a different answer again to the same question - how do you draw a boundary that is not a line.</a:t>
+            </a:r>
+          </a:p>
+        </p:txBody>
+      </p:sp>
+      <p:sp>
+        <p:nvSpPr>
+          <p:cNvPr id="4" name="Slide Number Placeholder 3"/>
+          <p:cNvSpPr>
+            <a:spLocks noGrp="1"/>
+          </p:cNvSpPr>
+          <p:nvPr>
+            <p:ph type="sldNum" sz="quarter" idx="10"/>
+          </p:nvPr>
+        </p:nvSpPr>
+        <p:spPr/>
+        <p:txBody>
+          <a:bodyPr/>
+          <a:lstStyle/>
+          <a:p>
+            <a:fld id="{18BDFEC3-8487-43E8-A154-7C12CBC1FFF2}" type="slidenum">
+              <a:rPr lang="en-US"/>
+              <a:t>65</a:t>
             </a:fld>
             <a:endParaRPr lang="en-US"/>
           </a:p>
@@ -15271,6 +15673,88 @@
             </a:pPr>
             <a:r>
               <a:rPr/>
+              <a:t>Wrong densities, right boundary</a:t>
+            </a:r>
+          </a:p>
+        </p:txBody>
+      </p:sp>
+      <p:pic>
+        <p:nvPicPr>
+          <p:cNvPr descr="nb_boundary_vs_envelope.png" id="0" name="Picture 1"/>
+          <p:cNvPicPr>
+            <a:picLocks noGrp="1" noChangeAspect="1"/>
+          </p:cNvPicPr>
+          <p:nvPr/>
+        </p:nvPicPr>
+        <p:blipFill>
+          <a:blip r:embed="rId3"/>
+          <a:stretch>
+            <a:fillRect/>
+          </a:stretch>
+        </p:blipFill>
+        <p:spPr bwMode="auto">
+          <a:xfrm>
+            <a:off x="2161983" y="1166099"/>
+            <a:ext cx="4820034" cy="3360181"/>
+          </a:xfrm>
+          <a:prstGeom prst="rect">
+            <a:avLst/>
+          </a:prstGeom>
+          <a:noFill/>
+          <a:ln w="9525">
+            <a:noFill/>
+            <a:headEnd/>
+            <a:tailEnd/>
+          </a:ln>
+        </p:spPr>
+      </p:pic>
+    </p:spTree>
+  </p:cSld>
+</p:sld>
+</file>
+
+<file path=ppt/slides/slide37.xml><?xml version="1.0" encoding="utf-8"?>
+<p:sld xmlns:a="http://schemas.openxmlformats.org/drawingml/2006/main" xmlns:r="http://schemas.openxmlformats.org/officeDocument/2006/relationships" xmlns:p="http://schemas.openxmlformats.org/presentationml/2006/main">
+  <p:cSld>
+    <p:spTree>
+      <p:nvGrpSpPr>
+        <p:cNvPr id="1" name=""/>
+        <p:cNvGrpSpPr/>
+        <p:nvPr/>
+      </p:nvGrpSpPr>
+      <p:grpSpPr>
+        <a:xfrm>
+          <a:off x="0" y="0"/>
+          <a:ext cx="0" cy="0"/>
+          <a:chOff x="0" y="0"/>
+          <a:chExt cx="0" cy="0"/>
+        </a:xfrm>
+      </p:grpSpPr>
+      <p:sp>
+        <p:nvSpPr>
+          <p:cNvPr id="2" name="Title 1"/>
+          <p:cNvSpPr>
+            <a:spLocks noGrp="1"/>
+          </p:cNvSpPr>
+          <p:nvPr>
+            <p:ph type="title"/>
+          </p:nvPr>
+        </p:nvSpPr>
+        <p:spPr>
+          <a:xfrm>
+            <a:off x="457200" y="205979"/>
+            <a:ext cx="8229600" cy="857250"/>
+          </a:xfrm>
+        </p:spPr>
+        <p:txBody>
+          <a:bodyPr/>
+          <a:lstStyle/>
+          <a:p>
+            <a:pPr lvl="0" indent="0" marL="0">
+              <a:buNone/>
+            </a:pPr>
+            <a:r>
+              <a:rPr/>
               <a:t>One step away: when the signal is an interaction</a:t>
             </a:r>
           </a:p>
@@ -15331,7 +15815,7 @@
 </p:sld>
 </file>
 
-<file path=ppt/slides/slide37.xml><?xml version="1.0" encoding="utf-8"?>
+<file path=ppt/slides/slide38.xml><?xml version="1.0" encoding="utf-8"?>
 <p:sld xmlns:a="http://schemas.openxmlformats.org/drawingml/2006/main" xmlns:r="http://schemas.openxmlformats.org/officeDocument/2006/relationships" xmlns:p="http://schemas.openxmlformats.org/presentationml/2006/main">
   <p:cSld>
     <p:spTree>
@@ -15413,7 +15897,7 @@
 </p:sld>
 </file>
 
-<file path=ppt/slides/slide38.xml><?xml version="1.0" encoding="utf-8"?>
+<file path=ppt/slides/slide39.xml><?xml version="1.0" encoding="utf-8"?>
 <p:sld xmlns:a="http://schemas.openxmlformats.org/drawingml/2006/main" xmlns:r="http://schemas.openxmlformats.org/officeDocument/2006/relationships" xmlns:p="http://schemas.openxmlformats.org/presentationml/2006/main">
   <p:cSld>
     <p:spTree>
@@ -15719,119 +16203,6 @@
 </p:sld>
 </file>
 
-<file path=ppt/slides/slide39.xml><?xml version="1.0" encoding="utf-8"?>
-<p:sld xmlns:a="http://schemas.openxmlformats.org/drawingml/2006/main" xmlns:r="http://schemas.openxmlformats.org/officeDocument/2006/relationships" xmlns:p="http://schemas.openxmlformats.org/presentationml/2006/main">
-  <p:cSld>
-    <p:spTree>
-      <p:nvGrpSpPr>
-        <p:cNvPr id="1" name=""/>
-        <p:cNvGrpSpPr/>
-        <p:nvPr/>
-      </p:nvGrpSpPr>
-      <p:grpSpPr>
-        <a:xfrm>
-          <a:off x="0" y="0"/>
-          <a:ext cx="0" cy="0"/>
-          <a:chOff x="0" y="0"/>
-          <a:chExt cx="0" cy="0"/>
-        </a:xfrm>
-      </p:grpSpPr>
-      <p:sp>
-        <p:nvSpPr>
-          <p:cNvPr id="2" name="Title 1"/>
-          <p:cNvSpPr>
-            <a:spLocks noGrp="1"/>
-          </p:cNvSpPr>
-          <p:nvPr>
-            <p:ph type="title"/>
-          </p:nvPr>
-        </p:nvSpPr>
-        <p:spPr>
-          <a:xfrm>
-            <a:off x="457200" y="205979"/>
-            <a:ext cx="8229600" cy="857250"/>
-          </a:xfrm>
-        </p:spPr>
-        <p:txBody>
-          <a:bodyPr/>
-          <a:lstStyle/>
-          <a:p>
-            <a:pPr lvl="0" indent="0" marL="0">
-              <a:buNone/>
-            </a:pPr>
-            <a:r>
-              <a:rPr/>
-              <a:t>Its probabilities are not probabilities</a:t>
-            </a:r>
-          </a:p>
-        </p:txBody>
-      </p:sp>
-      <p:sp>
-        <p:nvSpPr>
-          <p:cNvPr id="3" name="Content Placeholder 2"/>
-          <p:cNvSpPr>
-            <a:spLocks noGrp="1"/>
-          </p:cNvSpPr>
-          <p:nvPr>
-            <p:ph idx="1"/>
-          </p:nvPr>
-        </p:nvSpPr>
-        <p:spPr>
-          <a:xfrm>
-            <a:off x="457200" y="1200151"/>
-            <a:ext cx="8229600" cy="3394472"/>
-          </a:xfrm>
-        </p:spPr>
-        <p:txBody>
-          <a:bodyPr/>
-          <a:lstStyle/>
-          <a:p>
-            <a:pPr lvl="0"/>
-            <a:r>
-              <a:rPr/>
-              <a:t>Mean confidence when </a:t>
-            </a:r>
-            <a:r>
-              <a:rPr b="1"/>
-              <a:t>correct: 0.567</a:t>
-            </a:r>
-            <a:r>
-              <a:rPr/>
-              <a:t>. When </a:t>
-            </a:r>
-            <a:r>
-              <a:rPr b="1"/>
-              <a:t>wrong: 0.555</a:t>
-            </a:r>
-          </a:p>
-          <a:p>
-            <a:pPr lvl="0"/>
-            <a:r>
-              <a:rPr/>
-              <a:t>It cannot tell the difference between the two situations</a:t>
-            </a:r>
-          </a:p>
-          <a:p>
-            <a:pPr lvl="0"/>
-            <a:r>
-              <a:rPr/>
-              <a:t>With features that repeat each other it fails the other way: 0.999 reported, with an accuracy nothing like that</a:t>
-            </a:r>
-          </a:p>
-          <a:p>
-            <a:pPr lvl="0"/>
-            <a:r>
-              <a:rPr b="1"/>
-              <a:t>The ranking may be useful while the probabilities are not</a:t>
-            </a:r>
-          </a:p>
-        </p:txBody>
-      </p:sp>
-    </p:spTree>
-  </p:cSld>
-</p:sld>
-</file>
-
 <file path=ppt/slides/slide4.xml><?xml version="1.0" encoding="utf-8"?>
 <p:sld xmlns:a="http://schemas.openxmlformats.org/drawingml/2006/main" xmlns:r="http://schemas.openxmlformats.org/officeDocument/2006/relationships" xmlns:p="http://schemas.openxmlformats.org/presentationml/2006/main">
   <p:cSld>
@@ -15980,7 +16351,7 @@
             </a:pPr>
             <a:r>
               <a:rPr/>
-              <a:t>Notebook 2, live</a:t>
+              <a:t>Its probabilities are not probabilities</a:t>
             </a:r>
           </a:p>
         </p:txBody>
@@ -16008,7 +16379,40 @@
             <a:pPr lvl="0"/>
             <a:r>
               <a:rPr/>
-              <a:t>Where breaking the assumption is cheap, and one step away where it is fatal</a:t>
+              <a:t>Mean confidence when </a:t>
+            </a:r>
+            <a:r>
+              <a:rPr b="1"/>
+              <a:t>correct: 0.567</a:t>
+            </a:r>
+            <a:r>
+              <a:rPr/>
+              <a:t>. When </a:t>
+            </a:r>
+            <a:r>
+              <a:rPr b="1"/>
+              <a:t>wrong: 0.555</a:t>
+            </a:r>
+          </a:p>
+          <a:p>
+            <a:pPr lvl="0"/>
+            <a:r>
+              <a:rPr/>
+              <a:t>It cannot tell the difference between the two situations</a:t>
+            </a:r>
+          </a:p>
+          <a:p>
+            <a:pPr lvl="0"/>
+            <a:r>
+              <a:rPr/>
+              <a:t>With features that repeat each other it fails the other way: 0.999 reported, with an accuracy nothing like that</a:t>
+            </a:r>
+          </a:p>
+          <a:p>
+            <a:pPr lvl="0"/>
+            <a:r>
+              <a:rPr b="1"/>
+              <a:t>The ranking may be useful while the probabilities are not</a:t>
             </a:r>
           </a:p>
         </p:txBody>
@@ -16060,7 +16464,7 @@
             </a:pPr>
             <a:r>
               <a:rPr/>
-              <a:t>The margin: a criterion that is not the error</a:t>
+              <a:t>Notebook 2, live</a:t>
             </a:r>
           </a:p>
         </p:txBody>
@@ -16088,48 +16492,7 @@
             <a:pPr lvl="0"/>
             <a:r>
               <a:rPr/>
-              <a:t>On separable data there are </a:t>
-            </a:r>
-            <a:r>
-              <a:rPr b="1"/>
-              <a:t>infinitely many</a:t>
-            </a:r>
-            <a:r>
-              <a:rPr/>
-              <a:t> separating lines, and every one has </a:t>
-            </a:r>
-            <a:r>
-              <a:rPr b="1"/>
-              <a:t>zero training error</a:t>
-            </a:r>
-          </a:p>
-          <a:p>
-            <a:pPr lvl="0"/>
-            <a:r>
-              <a:rPr/>
-              <a:t>Minimising the error therefore cannot choose between them</a:t>
-            </a:r>
-          </a:p>
-          <a:p>
-            <a:pPr lvl="0"/>
-            <a:r>
-              <a:rPr/>
-              <a:t>The SVM picks the widest </a:t>
-            </a:r>
-            <a:r>
-              <a:rPr b="1"/>
-              <a:t>slab</a:t>
-            </a:r>
-            <a:r>
-              <a:rPr/>
-              <a:t>: push it out until it touches the nearest point of each class</a:t>
-            </a:r>
-          </a:p>
-          <a:p>
-            <a:pPr lvl="0"/>
-            <a:r>
-              <a:rPr/>
-              <a:t>A boundary passing close to a point is one small perturbation from getting it wrong</a:t>
+              <a:t>Where breaking the assumption is cheap, and one step away where it is fatal</a:t>
             </a:r>
           </a:p>
         </p:txBody>
@@ -16140,6 +16503,127 @@
 </file>
 
 <file path=ppt/slides/slide42.xml><?xml version="1.0" encoding="utf-8"?>
+<p:sld xmlns:a="http://schemas.openxmlformats.org/drawingml/2006/main" xmlns:r="http://schemas.openxmlformats.org/officeDocument/2006/relationships" xmlns:p="http://schemas.openxmlformats.org/presentationml/2006/main">
+  <p:cSld>
+    <p:spTree>
+      <p:nvGrpSpPr>
+        <p:cNvPr id="1" name=""/>
+        <p:cNvGrpSpPr/>
+        <p:nvPr/>
+      </p:nvGrpSpPr>
+      <p:grpSpPr>
+        <a:xfrm>
+          <a:off x="0" y="0"/>
+          <a:ext cx="0" cy="0"/>
+          <a:chOff x="0" y="0"/>
+          <a:chExt cx="0" cy="0"/>
+        </a:xfrm>
+      </p:grpSpPr>
+      <p:sp>
+        <p:nvSpPr>
+          <p:cNvPr id="2" name="Title 1"/>
+          <p:cNvSpPr>
+            <a:spLocks noGrp="1"/>
+          </p:cNvSpPr>
+          <p:nvPr>
+            <p:ph type="title"/>
+          </p:nvPr>
+        </p:nvSpPr>
+        <p:spPr>
+          <a:xfrm>
+            <a:off x="457200" y="205979"/>
+            <a:ext cx="8229600" cy="857250"/>
+          </a:xfrm>
+        </p:spPr>
+        <p:txBody>
+          <a:bodyPr/>
+          <a:lstStyle/>
+          <a:p>
+            <a:pPr lvl="0" indent="0" marL="0">
+              <a:buNone/>
+            </a:pPr>
+            <a:r>
+              <a:rPr/>
+              <a:t>The margin: a criterion that is not the error</a:t>
+            </a:r>
+          </a:p>
+        </p:txBody>
+      </p:sp>
+      <p:sp>
+        <p:nvSpPr>
+          <p:cNvPr id="3" name="Content Placeholder 2"/>
+          <p:cNvSpPr>
+            <a:spLocks noGrp="1"/>
+          </p:cNvSpPr>
+          <p:nvPr>
+            <p:ph idx="1"/>
+          </p:nvPr>
+        </p:nvSpPr>
+        <p:spPr>
+          <a:xfrm>
+            <a:off x="457200" y="1200151"/>
+            <a:ext cx="8229600" cy="3394472"/>
+          </a:xfrm>
+        </p:spPr>
+        <p:txBody>
+          <a:bodyPr/>
+          <a:lstStyle/>
+          <a:p>
+            <a:pPr lvl="0"/>
+            <a:r>
+              <a:rPr/>
+              <a:t>On separable data there are </a:t>
+            </a:r>
+            <a:r>
+              <a:rPr b="1"/>
+              <a:t>infinitely many</a:t>
+            </a:r>
+            <a:r>
+              <a:rPr/>
+              <a:t> separating lines, and every one has </a:t>
+            </a:r>
+            <a:r>
+              <a:rPr b="1"/>
+              <a:t>zero training error</a:t>
+            </a:r>
+          </a:p>
+          <a:p>
+            <a:pPr lvl="0"/>
+            <a:r>
+              <a:rPr/>
+              <a:t>Minimising the error therefore cannot choose between them</a:t>
+            </a:r>
+          </a:p>
+          <a:p>
+            <a:pPr lvl="0"/>
+            <a:r>
+              <a:rPr/>
+              <a:t>The SVM picks the widest </a:t>
+            </a:r>
+            <a:r>
+              <a:rPr b="1"/>
+              <a:t>slab</a:t>
+            </a:r>
+            <a:r>
+              <a:rPr/>
+              <a:t>: push it out until it touches the nearest point of each class</a:t>
+            </a:r>
+          </a:p>
+          <a:p>
+            <a:pPr lvl="0"/>
+            <a:r>
+              <a:rPr/>
+              <a:t>A boundary passing close to a point is one small perturbation from getting it wrong</a:t>
+            </a:r>
+          </a:p>
+        </p:txBody>
+      </p:sp>
+    </p:spTree>
+  </p:cSld>
+</p:sld>
+</file>
+
+<file path=ppt/slides/slide43.xml><?xml version="1.0" encoding="utf-8"?>
 <p:sld xmlns:a="http://schemas.openxmlformats.org/drawingml/2006/main" xmlns:r="http://schemas.openxmlformats.org/officeDocument/2006/relationships" xmlns:p="http://schemas.openxmlformats.org/presentationml/2006/main">
   <p:cSld>
     <p:spTree>
@@ -16221,7 +16705,7 @@
 </p:sld>
 </file>
 
-<file path=ppt/slides/slide43.xml><?xml version="1.0" encoding="utf-8"?>
+<file path=ppt/slides/slide44.xml><?xml version="1.0" encoding="utf-8"?>
 <p:sld xmlns:a="http://schemas.openxmlformats.org/drawingml/2006/main" xmlns:r="http://schemas.openxmlformats.org/officeDocument/2006/relationships" xmlns:p="http://schemas.openxmlformats.org/presentationml/2006/main">
   <p:cSld>
     <p:spTree>
@@ -16334,7 +16818,89 @@
 </p:sld>
 </file>
 
-<file path=ppt/slides/slide44.xml><?xml version="1.0" encoding="utf-8"?>
+<file path=ppt/slides/slide45.xml><?xml version="1.0" encoding="utf-8"?>
+<p:sld xmlns:a="http://schemas.openxmlformats.org/drawingml/2006/main" xmlns:r="http://schemas.openxmlformats.org/officeDocument/2006/relationships" xmlns:p="http://schemas.openxmlformats.org/presentationml/2006/main">
+  <p:cSld>
+    <p:spTree>
+      <p:nvGrpSpPr>
+        <p:cNvPr id="1" name=""/>
+        <p:cNvGrpSpPr/>
+        <p:nvPr/>
+      </p:nvGrpSpPr>
+      <p:grpSpPr>
+        <a:xfrm>
+          <a:off x="0" y="0"/>
+          <a:ext cx="0" cy="0"/>
+          <a:chOff x="0" y="0"/>
+          <a:chExt cx="0" cy="0"/>
+        </a:xfrm>
+      </p:grpSpPr>
+      <p:sp>
+        <p:nvSpPr>
+          <p:cNvPr id="2" name="Title 1"/>
+          <p:cNvSpPr>
+            <a:spLocks noGrp="1"/>
+          </p:cNvSpPr>
+          <p:nvPr>
+            <p:ph type="title"/>
+          </p:nvPr>
+        </p:nvSpPr>
+        <p:spPr>
+          <a:xfrm>
+            <a:off x="457200" y="205979"/>
+            <a:ext cx="8229600" cy="857250"/>
+          </a:xfrm>
+        </p:spPr>
+        <p:txBody>
+          <a:bodyPr/>
+          <a:lstStyle/>
+          <a:p>
+            <a:pPr lvl="0" indent="0" marL="0">
+              <a:buNone/>
+            </a:pPr>
+            <a:r>
+              <a:rPr/>
+              <a:t>The hinge stops at zero</a:t>
+            </a:r>
+          </a:p>
+        </p:txBody>
+      </p:sp>
+      <p:pic>
+        <p:nvPicPr>
+          <p:cNvPr descr="hinge_vs_log_loss.png" id="0" name="Picture 1"/>
+          <p:cNvPicPr>
+            <a:picLocks noGrp="1" noChangeAspect="1"/>
+          </p:cNvPicPr>
+          <p:nvPr/>
+        </p:nvPicPr>
+        <p:blipFill>
+          <a:blip r:embed="rId3"/>
+          <a:stretch>
+            <a:fillRect/>
+          </a:stretch>
+        </p:blipFill>
+        <p:spPr bwMode="auto">
+          <a:xfrm>
+            <a:off x="1488688" y="1166099"/>
+            <a:ext cx="6166624" cy="3360181"/>
+          </a:xfrm>
+          <a:prstGeom prst="rect">
+            <a:avLst/>
+          </a:prstGeom>
+          <a:noFill/>
+          <a:ln w="9525">
+            <a:noFill/>
+            <a:headEnd/>
+            <a:tailEnd/>
+          </a:ln>
+        </p:spPr>
+      </p:pic>
+    </p:spTree>
+  </p:cSld>
+</p:sld>
+</file>
+
+<file path=ppt/slides/slide46.xml><?xml version="1.0" encoding="utf-8"?>
 <p:sld xmlns:a="http://schemas.openxmlformats.org/drawingml/2006/main" xmlns:r="http://schemas.openxmlformats.org/officeDocument/2006/relationships" xmlns:p="http://schemas.openxmlformats.org/presentationml/2006/main">
   <p:cSld>
     <p:spTree>
@@ -16416,7 +16982,7 @@
 </p:sld>
 </file>
 
-<file path=ppt/slides/slide45.xml><?xml version="1.0" encoding="utf-8"?>
+<file path=ppt/slides/slide47.xml><?xml version="1.0" encoding="utf-8"?>
 <p:sld xmlns:a="http://schemas.openxmlformats.org/drawingml/2006/main" xmlns:r="http://schemas.openxmlformats.org/officeDocument/2006/relationships" xmlns:p="http://schemas.openxmlformats.org/presentationml/2006/main">
   <p:cSld>
     <p:spTree>
@@ -16529,7 +17095,7 @@
 </p:sld>
 </file>
 
-<file path=ppt/slides/slide46.xml><?xml version="1.0" encoding="utf-8"?>
+<file path=ppt/slides/slide48.xml><?xml version="1.0" encoding="utf-8"?>
 <p:sld xmlns:a="http://schemas.openxmlformats.org/drawingml/2006/main" xmlns:r="http://schemas.openxmlformats.org/officeDocument/2006/relationships" xmlns:p="http://schemas.openxmlformats.org/presentationml/2006/main">
   <p:cSld>
     <p:spTree>
@@ -16762,238 +17328,6 @@
 </p:sld>
 </file>
 
-<file path=ppt/slides/slide47.xml><?xml version="1.0" encoding="utf-8"?>
-<p:sld xmlns:a="http://schemas.openxmlformats.org/drawingml/2006/main" xmlns:r="http://schemas.openxmlformats.org/officeDocument/2006/relationships" xmlns:p="http://schemas.openxmlformats.org/presentationml/2006/main">
-  <p:cSld>
-    <p:spTree>
-      <p:nvGrpSpPr>
-        <p:cNvPr id="1" name=""/>
-        <p:cNvGrpSpPr/>
-        <p:nvPr/>
-      </p:nvGrpSpPr>
-      <p:grpSpPr>
-        <a:xfrm>
-          <a:off x="0" y="0"/>
-          <a:ext cx="0" cy="0"/>
-          <a:chOff x="0" y="0"/>
-          <a:chExt cx="0" cy="0"/>
-        </a:xfrm>
-      </p:grpSpPr>
-      <p:sp>
-        <p:nvSpPr>
-          <p:cNvPr id="2" name="Title 1"/>
-          <p:cNvSpPr>
-            <a:spLocks noGrp="1"/>
-          </p:cNvSpPr>
-          <p:nvPr>
-            <p:ph type="title"/>
-          </p:nvPr>
-        </p:nvSpPr>
-        <p:spPr>
-          <a:xfrm>
-            <a:off x="457200" y="205979"/>
-            <a:ext cx="8229600" cy="857250"/>
-          </a:xfrm>
-        </p:spPr>
-        <p:txBody>
-          <a:bodyPr/>
-          <a:lstStyle/>
-          <a:p>
-            <a:pPr lvl="0" indent="0" marL="0">
-              <a:buNone/>
-            </a:pPr>
-            <a:r>
-              <a:rPr/>
-              <a:t>A high support-vector fraction is a free warning</a:t>
-            </a:r>
-          </a:p>
-        </p:txBody>
-      </p:sp>
-      <p:sp>
-        <p:nvSpPr>
-          <p:cNvPr id="3" name="Content Placeholder 2"/>
-          <p:cNvSpPr>
-            <a:spLocks noGrp="1"/>
-          </p:cNvSpPr>
-          <p:nvPr>
-            <p:ph idx="1"/>
-          </p:nvPr>
-        </p:nvSpPr>
-        <p:spPr>
-          <a:xfrm>
-            <a:off x="457200" y="1200151"/>
-            <a:ext cx="8229600" cy="3394472"/>
-          </a:xfrm>
-        </p:spPr>
-        <p:txBody>
-          <a:bodyPr/>
-          <a:lstStyle/>
-          <a:p>
-            <a:pPr lvl="0"/>
-            <a:r>
-              <a:rPr/>
-              <a:t>The linear model needs </a:t>
-            </a:r>
-            <a:r>
-              <a:rPr b="1"/>
-              <a:t>79%</a:t>
-            </a:r>
-            <a:r>
-              <a:rPr/>
-              <a:t> of the training set to define its boundary</a:t>
-            </a:r>
-          </a:p>
-          <a:p>
-            <a:pPr lvl="0"/>
-            <a:r>
-              <a:rPr/>
-              <a:t>The RBF model needs </a:t>
-            </a:r>
-            <a:r>
-              <a:rPr b="1"/>
-              <a:t>23%</a:t>
-            </a:r>
-          </a:p>
-          <a:p>
-            <a:pPr lvl="0"/>
-            <a:r>
-              <a:rPr/>
-              <a:t>Almost every point sits on or inside the margin: there is no slab that separates anything</a:t>
-            </a:r>
-          </a:p>
-          <a:p>
-            <a:pPr lvl="0"/>
-            <a:r>
-              <a:rPr/>
-              <a:t>The count falls out of </a:t>
-            </a:r>
-            <a:r>
-              <a:rPr>
-                <a:latin typeface="Courier"/>
-              </a:rPr>
-              <a:t>fit</a:t>
-            </a:r>
-            <a:r>
-              <a:rPr/>
-              <a:t> at no cost, and you should look at it</a:t>
-            </a:r>
-          </a:p>
-        </p:txBody>
-      </p:sp>
-    </p:spTree>
-  </p:cSld>
-</p:sld>
-</file>
-
-<file path=ppt/slides/slide48.xml><?xml version="1.0" encoding="utf-8"?>
-<p:sld xmlns:a="http://schemas.openxmlformats.org/drawingml/2006/main" xmlns:r="http://schemas.openxmlformats.org/officeDocument/2006/relationships" xmlns:p="http://schemas.openxmlformats.org/presentationml/2006/main">
-  <p:cSld>
-    <p:spTree>
-      <p:nvGrpSpPr>
-        <p:cNvPr id="1" name=""/>
-        <p:cNvGrpSpPr/>
-        <p:nvPr/>
-      </p:nvGrpSpPr>
-      <p:grpSpPr>
-        <a:xfrm>
-          <a:off x="0" y="0"/>
-          <a:ext cx="0" cy="0"/>
-          <a:chOff x="0" y="0"/>
-          <a:chExt cx="0" cy="0"/>
-        </a:xfrm>
-      </p:grpSpPr>
-      <p:sp>
-        <p:nvSpPr>
-          <p:cNvPr id="2" name="Title 1"/>
-          <p:cNvSpPr>
-            <a:spLocks noGrp="1"/>
-          </p:cNvSpPr>
-          <p:nvPr>
-            <p:ph type="title"/>
-          </p:nvPr>
-        </p:nvSpPr>
-        <p:spPr>
-          <a:xfrm>
-            <a:off x="457200" y="205979"/>
-            <a:ext cx="8229600" cy="857250"/>
-          </a:xfrm>
-        </p:spPr>
-        <p:txBody>
-          <a:bodyPr/>
-          <a:lstStyle/>
-          <a:p>
-            <a:pPr lvl="0" indent="0" marL="0">
-              <a:buNone/>
-            </a:pPr>
-            <a:r>
-              <a:rPr/>
-              <a:t>The kernel trick: they needed different coordinates</a:t>
-            </a:r>
-          </a:p>
-        </p:txBody>
-      </p:sp>
-      <p:sp>
-        <p:nvSpPr>
-          <p:cNvPr id="3" name="Content Placeholder 2"/>
-          <p:cNvSpPr>
-            <a:spLocks noGrp="1"/>
-          </p:cNvSpPr>
-          <p:nvPr>
-            <p:ph idx="1"/>
-          </p:nvPr>
-        </p:nvSpPr>
-        <p:spPr>
-          <a:xfrm>
-            <a:off x="457200" y="1200151"/>
-            <a:ext cx="8229600" cy="3394472"/>
-          </a:xfrm>
-        </p:spPr>
-        <p:txBody>
-          <a:bodyPr/>
-          <a:lstStyle/>
-          <a:p>
-            <a:pPr lvl="0"/>
-            <a:r>
-              <a:rPr/>
-              <a:t>Healthy pumps in a disc, faulty ones around it: no line works </a:t>
-            </a:r>
-            <a:r>
-              <a:rPr b="1"/>
-              <a:t>in the plane</a:t>
-            </a:r>
-          </a:p>
-          <a:p>
-            <a:pPr lvl="0"/>
-            <a:r>
-              <a:rPr/>
-              <a:t>Add a third coordinate: the </a:t>
-            </a:r>
-            <a:r>
-              <a:rPr b="1"/>
-              <a:t>distance from the design point</a:t>
-            </a:r>
-          </a:p>
-          <a:p>
-            <a:pPr lvl="0"/>
-            <a:r>
-              <a:rPr/>
-              <a:t>Healthy pumps rise a little, faulty ones a lot, and a flat plane separates them perfectly</a:t>
-            </a:r>
-          </a:p>
-          <a:p>
-            <a:pPr lvl="0"/>
-            <a:r>
-              <a:rPr/>
-              <a:t>The classes were always separable. They were measured in the wrong coordinates</a:t>
-            </a:r>
-          </a:p>
-        </p:txBody>
-      </p:sp>
-    </p:spTree>
-  </p:cSld>
-</p:sld>
-</file>
-
 <file path=ppt/slides/slide49.xml><?xml version="1.0" encoding="utf-8"?>
 <p:sld xmlns:a="http://schemas.openxmlformats.org/drawingml/2006/main" xmlns:r="http://schemas.openxmlformats.org/officeDocument/2006/relationships" xmlns:p="http://schemas.openxmlformats.org/presentationml/2006/main">
   <p:cSld>
@@ -17036,41 +17370,82 @@
             </a:pPr>
             <a:r>
               <a:rPr/>
-              <a:t>The same pumps, lifted</a:t>
-            </a:r>
-          </a:p>
-        </p:txBody>
-      </p:sp>
-      <p:pic>
-        <p:nvPicPr>
-          <p:cNvPr descr="kernel_lift.png" id="0" name="Picture 1"/>
-          <p:cNvPicPr>
-            <a:picLocks noGrp="1" noChangeAspect="1"/>
-          </p:cNvPicPr>
-          <p:nvPr/>
-        </p:nvPicPr>
-        <p:blipFill>
-          <a:blip r:embed="rId3"/>
-          <a:stretch>
-            <a:fillRect/>
-          </a:stretch>
-        </p:blipFill>
-        <p:spPr bwMode="auto">
+              <a:t>A high support-vector fraction is a free warning</a:t>
+            </a:r>
+          </a:p>
+        </p:txBody>
+      </p:sp>
+      <p:sp>
+        <p:nvSpPr>
+          <p:cNvPr id="3" name="Content Placeholder 2"/>
+          <p:cNvSpPr>
+            <a:spLocks noGrp="1"/>
+          </p:cNvSpPr>
+          <p:nvPr>
+            <p:ph idx="1"/>
+          </p:nvPr>
+        </p:nvSpPr>
+        <p:spPr>
           <a:xfrm>
-            <a:off x="1048215" y="1166099"/>
-            <a:ext cx="7047570" cy="3360181"/>
+            <a:off x="457200" y="1200151"/>
+            <a:ext cx="8229600" cy="3394472"/>
           </a:xfrm>
-          <a:prstGeom prst="rect">
-            <a:avLst/>
-          </a:prstGeom>
-          <a:noFill/>
-          <a:ln w="9525">
-            <a:noFill/>
-            <a:headEnd/>
-            <a:tailEnd/>
-          </a:ln>
         </p:spPr>
-      </p:pic>
+        <p:txBody>
+          <a:bodyPr/>
+          <a:lstStyle/>
+          <a:p>
+            <a:pPr lvl="0"/>
+            <a:r>
+              <a:rPr/>
+              <a:t>The linear model needs </a:t>
+            </a:r>
+            <a:r>
+              <a:rPr b="1"/>
+              <a:t>79%</a:t>
+            </a:r>
+            <a:r>
+              <a:rPr/>
+              <a:t> of the training set to define its boundary</a:t>
+            </a:r>
+          </a:p>
+          <a:p>
+            <a:pPr lvl="0"/>
+            <a:r>
+              <a:rPr/>
+              <a:t>The RBF model needs </a:t>
+            </a:r>
+            <a:r>
+              <a:rPr b="1"/>
+              <a:t>23%</a:t>
+            </a:r>
+          </a:p>
+          <a:p>
+            <a:pPr lvl="0"/>
+            <a:r>
+              <a:rPr/>
+              <a:t>Almost every point sits on or inside the margin: there is no slab that separates anything</a:t>
+            </a:r>
+          </a:p>
+          <a:p>
+            <a:pPr lvl="0"/>
+            <a:r>
+              <a:rPr/>
+              <a:t>The count falls out of </a:t>
+            </a:r>
+            <a:r>
+              <a:rPr>
+                <a:latin typeface="Courier"/>
+              </a:rPr>
+              <a:t>fit</a:t>
+            </a:r>
+            <a:r>
+              <a:rPr/>
+              <a:t> at no cost, and you should look at it</a:t>
+            </a:r>
+          </a:p>
+        </p:txBody>
+      </p:sp>
     </p:spTree>
   </p:cSld>
 </p:sld>
@@ -17200,7 +17575,7 @@
             </a:pPr>
             <a:r>
               <a:rPr/>
-              <a:t>And the map is never computed</a:t>
+              <a:t>The kernel trick: they needed different coordinates</a:t>
             </a:r>
           </a:p>
         </p:txBody>
@@ -17228,45 +17603,36 @@
             <a:pPr lvl="0"/>
             <a:r>
               <a:rPr/>
-              <a:t>The solution depends on the data </a:t>
+              <a:t>Healthy pumps in a disc, faulty ones around it: no line works </a:t>
             </a:r>
             <a:r>
               <a:rPr b="1"/>
-              <a:t>only through inner products</a:t>
-            </a:r>
-            <a:r>
-              <a:rPr/>
-              <a:t> between pairs of points</a:t>
+              <a:t>in the plane</a:t>
             </a:r>
           </a:p>
           <a:p>
             <a:pPr lvl="0"/>
             <a:r>
               <a:rPr/>
-              <a:t>So we need a function returning the inner product </a:t>
+              <a:t>Add a third coordinate: the </a:t>
             </a:r>
             <a:r>
               <a:rPr b="1"/>
-              <a:t>in the new space</a:t>
-            </a:r>
-            <a:r>
-              <a:rPr/>
-              <a:t>, while computing only with the original one</a:t>
+              <a:t>distance from the design point</a:t>
             </a:r>
           </a:p>
           <a:p>
             <a:pPr lvl="0"/>
             <a:r>
               <a:rPr/>
-              <a:t>The radial basis function is scikit-learn’s default: one exponential per pair, for an </a:t>
-            </a:r>
-            <a:r>
-              <a:rPr b="1"/>
-              <a:t>infinite-dimensional</a:t>
-            </a:r>
-            <a:r>
-              <a:rPr/>
-              <a:t> space</a:t>
+              <a:t>Healthy pumps rise a little, faulty ones a lot, and a flat plane separates them perfectly</a:t>
+            </a:r>
+          </a:p>
+          <a:p>
+            <a:pPr lvl="0"/>
+            <a:r>
+              <a:rPr/>
+              <a:t>The classes were always separable. They were measured in the wrong coordinates</a:t>
             </a:r>
           </a:p>
         </p:txBody>
@@ -17277,6 +17643,206 @@
 </file>
 
 <file path=ppt/slides/slide51.xml><?xml version="1.0" encoding="utf-8"?>
+<p:sld xmlns:a="http://schemas.openxmlformats.org/drawingml/2006/main" xmlns:r="http://schemas.openxmlformats.org/officeDocument/2006/relationships" xmlns:p="http://schemas.openxmlformats.org/presentationml/2006/main">
+  <p:cSld>
+    <p:spTree>
+      <p:nvGrpSpPr>
+        <p:cNvPr id="1" name=""/>
+        <p:cNvGrpSpPr/>
+        <p:nvPr/>
+      </p:nvGrpSpPr>
+      <p:grpSpPr>
+        <a:xfrm>
+          <a:off x="0" y="0"/>
+          <a:ext cx="0" cy="0"/>
+          <a:chOff x="0" y="0"/>
+          <a:chExt cx="0" cy="0"/>
+        </a:xfrm>
+      </p:grpSpPr>
+      <p:sp>
+        <p:nvSpPr>
+          <p:cNvPr id="2" name="Title 1"/>
+          <p:cNvSpPr>
+            <a:spLocks noGrp="1"/>
+          </p:cNvSpPr>
+          <p:nvPr>
+            <p:ph type="title"/>
+          </p:nvPr>
+        </p:nvSpPr>
+        <p:spPr>
+          <a:xfrm>
+            <a:off x="457200" y="205979"/>
+            <a:ext cx="8229600" cy="857250"/>
+          </a:xfrm>
+        </p:spPr>
+        <p:txBody>
+          <a:bodyPr/>
+          <a:lstStyle/>
+          <a:p>
+            <a:pPr lvl="0" indent="0" marL="0">
+              <a:buNone/>
+            </a:pPr>
+            <a:r>
+              <a:rPr/>
+              <a:t>The same pumps, lifted</a:t>
+            </a:r>
+          </a:p>
+        </p:txBody>
+      </p:sp>
+      <p:pic>
+        <p:nvPicPr>
+          <p:cNvPr descr="kernel_lift.png" id="0" name="Picture 1"/>
+          <p:cNvPicPr>
+            <a:picLocks noGrp="1" noChangeAspect="1"/>
+          </p:cNvPicPr>
+          <p:nvPr/>
+        </p:nvPicPr>
+        <p:blipFill>
+          <a:blip r:embed="rId3"/>
+          <a:stretch>
+            <a:fillRect/>
+          </a:stretch>
+        </p:blipFill>
+        <p:spPr bwMode="auto">
+          <a:xfrm>
+            <a:off x="1048215" y="1166099"/>
+            <a:ext cx="7047570" cy="3360181"/>
+          </a:xfrm>
+          <a:prstGeom prst="rect">
+            <a:avLst/>
+          </a:prstGeom>
+          <a:noFill/>
+          <a:ln w="9525">
+            <a:noFill/>
+            <a:headEnd/>
+            <a:tailEnd/>
+          </a:ln>
+        </p:spPr>
+      </p:pic>
+    </p:spTree>
+  </p:cSld>
+</p:sld>
+</file>
+
+<file path=ppt/slides/slide52.xml><?xml version="1.0" encoding="utf-8"?>
+<p:sld xmlns:a="http://schemas.openxmlformats.org/drawingml/2006/main" xmlns:r="http://schemas.openxmlformats.org/officeDocument/2006/relationships" xmlns:p="http://schemas.openxmlformats.org/presentationml/2006/main">
+  <p:cSld>
+    <p:spTree>
+      <p:nvGrpSpPr>
+        <p:cNvPr id="1" name=""/>
+        <p:cNvGrpSpPr/>
+        <p:nvPr/>
+      </p:nvGrpSpPr>
+      <p:grpSpPr>
+        <a:xfrm>
+          <a:off x="0" y="0"/>
+          <a:ext cx="0" cy="0"/>
+          <a:chOff x="0" y="0"/>
+          <a:chExt cx="0" cy="0"/>
+        </a:xfrm>
+      </p:grpSpPr>
+      <p:sp>
+        <p:nvSpPr>
+          <p:cNvPr id="2" name="Title 1"/>
+          <p:cNvSpPr>
+            <a:spLocks noGrp="1"/>
+          </p:cNvSpPr>
+          <p:nvPr>
+            <p:ph type="title"/>
+          </p:nvPr>
+        </p:nvSpPr>
+        <p:spPr>
+          <a:xfrm>
+            <a:off x="457200" y="205979"/>
+            <a:ext cx="8229600" cy="857250"/>
+          </a:xfrm>
+        </p:spPr>
+        <p:txBody>
+          <a:bodyPr/>
+          <a:lstStyle/>
+          <a:p>
+            <a:pPr lvl="0" indent="0" marL="0">
+              <a:buNone/>
+            </a:pPr>
+            <a:r>
+              <a:rPr/>
+              <a:t>And the map is never computed</a:t>
+            </a:r>
+          </a:p>
+        </p:txBody>
+      </p:sp>
+      <p:sp>
+        <p:nvSpPr>
+          <p:cNvPr id="3" name="Content Placeholder 2"/>
+          <p:cNvSpPr>
+            <a:spLocks noGrp="1"/>
+          </p:cNvSpPr>
+          <p:nvPr>
+            <p:ph idx="1"/>
+          </p:nvPr>
+        </p:nvSpPr>
+        <p:spPr>
+          <a:xfrm>
+            <a:off x="457200" y="1200151"/>
+            <a:ext cx="8229600" cy="3394472"/>
+          </a:xfrm>
+        </p:spPr>
+        <p:txBody>
+          <a:bodyPr/>
+          <a:lstStyle/>
+          <a:p>
+            <a:pPr lvl="0"/>
+            <a:r>
+              <a:rPr/>
+              <a:t>The solution depends on the data </a:t>
+            </a:r>
+            <a:r>
+              <a:rPr b="1"/>
+              <a:t>only through inner products</a:t>
+            </a:r>
+            <a:r>
+              <a:rPr/>
+              <a:t> between pairs of points</a:t>
+            </a:r>
+          </a:p>
+          <a:p>
+            <a:pPr lvl="0"/>
+            <a:r>
+              <a:rPr/>
+              <a:t>So we need a function returning the inner product </a:t>
+            </a:r>
+            <a:r>
+              <a:rPr b="1"/>
+              <a:t>in the new space</a:t>
+            </a:r>
+            <a:r>
+              <a:rPr/>
+              <a:t>, while computing only with the original one</a:t>
+            </a:r>
+          </a:p>
+          <a:p>
+            <a:pPr lvl="0"/>
+            <a:r>
+              <a:rPr/>
+              <a:t>The radial basis function is scikit-learn’s default: one exponential per pair, for an </a:t>
+            </a:r>
+            <a:r>
+              <a:rPr b="1"/>
+              <a:t>infinite-dimensional</a:t>
+            </a:r>
+            <a:r>
+              <a:rPr/>
+              <a:t> space</a:t>
+            </a:r>
+          </a:p>
+        </p:txBody>
+      </p:sp>
+    </p:spTree>
+  </p:cSld>
+</p:sld>
+</file>
+
+<file path=ppt/slides/slide53.xml><?xml version="1.0" encoding="utf-8"?>
 <p:sld xmlns:a="http://schemas.openxmlformats.org/drawingml/2006/main" xmlns:r="http://schemas.openxmlformats.org/officeDocument/2006/relationships" xmlns:p="http://schemas.openxmlformats.org/presentationml/2006/main">
   <p:cSld>
     <p:spTree>
@@ -17501,7 +18067,7 @@
 </p:sld>
 </file>
 
-<file path=ppt/slides/slide52.xml><?xml version="1.0" encoding="utf-8"?>
+<file path=ppt/slides/slide54.xml><?xml version="1.0" encoding="utf-8"?>
 <p:sld xmlns:a="http://schemas.openxmlformats.org/drawingml/2006/main" xmlns:r="http://schemas.openxmlformats.org/officeDocument/2006/relationships" xmlns:p="http://schemas.openxmlformats.org/presentationml/2006/main">
   <p:cSld>
     <p:spTree>
@@ -17583,7 +18149,7 @@
 </p:sld>
 </file>
 
-<file path=ppt/slides/slide53.xml><?xml version="1.0" encoding="utf-8"?>
+<file path=ppt/slides/slide55.xml><?xml version="1.0" encoding="utf-8"?>
 <p:sld xmlns:a="http://schemas.openxmlformats.org/drawingml/2006/main" xmlns:r="http://schemas.openxmlformats.org/officeDocument/2006/relationships" xmlns:p="http://schemas.openxmlformats.org/presentationml/2006/main">
   <p:cSld>
     <p:spTree>
@@ -17708,7 +18274,7 @@
 </p:sld>
 </file>
 
-<file path=ppt/slides/slide54.xml><?xml version="1.0" encoding="utf-8"?>
+<file path=ppt/slides/slide56.xml><?xml version="1.0" encoding="utf-8"?>
 <p:sld xmlns:a="http://schemas.openxmlformats.org/drawingml/2006/main" xmlns:r="http://schemas.openxmlformats.org/officeDocument/2006/relationships" xmlns:p="http://schemas.openxmlformats.org/presentationml/2006/main">
   <p:cSld>
     <p:spTree>
@@ -17950,7 +18516,89 @@
 </p:sld>
 </file>
 
-<file path=ppt/slides/slide55.xml><?xml version="1.0" encoding="utf-8"?>
+<file path=ppt/slides/slide57.xml><?xml version="1.0" encoding="utf-8"?>
+<p:sld xmlns:a="http://schemas.openxmlformats.org/drawingml/2006/main" xmlns:r="http://schemas.openxmlformats.org/officeDocument/2006/relationships" xmlns:p="http://schemas.openxmlformats.org/presentationml/2006/main">
+  <p:cSld>
+    <p:spTree>
+      <p:nvGrpSpPr>
+        <p:cNvPr id="1" name=""/>
+        <p:cNvGrpSpPr/>
+        <p:nvPr/>
+      </p:nvGrpSpPr>
+      <p:grpSpPr>
+        <a:xfrm>
+          <a:off x="0" y="0"/>
+          <a:ext cx="0" cy="0"/>
+          <a:chOff x="0" y="0"/>
+          <a:chExt cx="0" cy="0"/>
+        </a:xfrm>
+      </p:grpSpPr>
+      <p:sp>
+        <p:nvSpPr>
+          <p:cNvPr id="2" name="Title 1"/>
+          <p:cNvSpPr>
+            <a:spLocks noGrp="1"/>
+          </p:cNvSpPr>
+          <p:nvPr>
+            <p:ph type="title"/>
+          </p:nvPr>
+        </p:nvSpPr>
+        <p:spPr>
+          <a:xfrm>
+            <a:off x="457200" y="205979"/>
+            <a:ext cx="8229600" cy="857250"/>
+          </a:xfrm>
+        </p:spPr>
+        <p:txBody>
+          <a:bodyPr/>
+          <a:lstStyle/>
+          <a:p>
+            <a:pPr lvl="0" indent="0" marL="0">
+              <a:buNone/>
+            </a:pPr>
+            <a:r>
+              <a:rPr/>
+              <a:t>One pump’s vote, drawn</a:t>
+            </a:r>
+          </a:p>
+        </p:txBody>
+      </p:sp>
+      <p:pic>
+        <p:nvPicPr>
+          <p:cNvPr descr="svm_vote_one_pump.png" id="0" name="Picture 1"/>
+          <p:cNvPicPr>
+            <a:picLocks noGrp="1" noChangeAspect="1"/>
+          </p:cNvPicPr>
+          <p:nvPr/>
+        </p:nvPicPr>
+        <p:blipFill>
+          <a:blip r:embed="rId3"/>
+          <a:stretch>
+            <a:fillRect/>
+          </a:stretch>
+        </p:blipFill>
+        <p:spPr bwMode="auto">
+          <a:xfrm>
+            <a:off x="2193445" y="1166099"/>
+            <a:ext cx="4757110" cy="3360181"/>
+          </a:xfrm>
+          <a:prstGeom prst="rect">
+            <a:avLst/>
+          </a:prstGeom>
+          <a:noFill/>
+          <a:ln w="9525">
+            <a:noFill/>
+            <a:headEnd/>
+            <a:tailEnd/>
+          </a:ln>
+        </p:spPr>
+      </p:pic>
+    </p:spTree>
+  </p:cSld>
+</p:sld>
+</file>
+
+<file path=ppt/slides/slide58.xml><?xml version="1.0" encoding="utf-8"?>
 <p:sld xmlns:a="http://schemas.openxmlformats.org/drawingml/2006/main" xmlns:r="http://schemas.openxmlformats.org/officeDocument/2006/relationships" xmlns:p="http://schemas.openxmlformats.org/presentationml/2006/main">
   <p:cSld>
     <p:spTree>
@@ -18222,7 +18870,267 @@
 </p:sld>
 </file>
 
-<file path=ppt/slides/slide56.xml><?xml version="1.0" encoding="utf-8"?>
+<file path=ppt/slides/slide59.xml><?xml version="1.0" encoding="utf-8"?>
+<p:sld xmlns:a="http://schemas.openxmlformats.org/drawingml/2006/main" xmlns:r="http://schemas.openxmlformats.org/officeDocument/2006/relationships" xmlns:p="http://schemas.openxmlformats.org/presentationml/2006/main">
+  <p:cSld>
+    <p:spTree>
+      <p:nvGrpSpPr>
+        <p:cNvPr id="1" name=""/>
+        <p:cNvGrpSpPr/>
+        <p:nvPr/>
+      </p:nvGrpSpPr>
+      <p:grpSpPr>
+        <a:xfrm>
+          <a:off x="0" y="0"/>
+          <a:ext cx="0" cy="0"/>
+          <a:chOff x="0" y="0"/>
+          <a:chExt cx="0" cy="0"/>
+        </a:xfrm>
+      </p:grpSpPr>
+      <p:sp>
+        <p:nvSpPr>
+          <p:cNvPr id="2" name="Title 1"/>
+          <p:cNvSpPr>
+            <a:spLocks noGrp="1"/>
+          </p:cNvSpPr>
+          <p:nvPr>
+            <p:ph type="title"/>
+          </p:nvPr>
+        </p:nvSpPr>
+        <p:spPr>
+          <a:xfrm>
+            <a:off x="457200" y="205979"/>
+            <a:ext cx="8229600" cy="857250"/>
+          </a:xfrm>
+        </p:spPr>
+        <p:txBody>
+          <a:bodyPr/>
+          <a:lstStyle/>
+          <a:p>
+            <a:pPr lvl="0" indent="0" marL="0">
+              <a:buNone/>
+            </a:pPr>
+            <a:r>
+              <a:rPr/>
+              <a:t>How far one vote reaches</a:t>
+            </a:r>
+          </a:p>
+        </p:txBody>
+      </p:sp>
+      <p:pic>
+        <p:nvPicPr>
+          <p:cNvPr descr="rbf_reach.png" id="0" name="Picture 1"/>
+          <p:cNvPicPr>
+            <a:picLocks noGrp="1" noChangeAspect="1"/>
+          </p:cNvPicPr>
+          <p:nvPr/>
+        </p:nvPicPr>
+        <p:blipFill>
+          <a:blip r:embed="rId3"/>
+          <a:stretch>
+            <a:fillRect/>
+          </a:stretch>
+        </p:blipFill>
+        <p:spPr bwMode="auto">
+          <a:xfrm>
+            <a:off x="1419471" y="1166099"/>
+            <a:ext cx="6305058" cy="3360181"/>
+          </a:xfrm>
+          <a:prstGeom prst="rect">
+            <a:avLst/>
+          </a:prstGeom>
+          <a:noFill/>
+          <a:ln w="9525">
+            <a:noFill/>
+            <a:headEnd/>
+            <a:tailEnd/>
+          </a:ln>
+        </p:spPr>
+      </p:pic>
+    </p:spTree>
+  </p:cSld>
+</p:sld>
+</file>
+
+<file path=ppt/slides/slide6.xml><?xml version="1.0" encoding="utf-8"?>
+<p:sld xmlns:a="http://schemas.openxmlformats.org/drawingml/2006/main" xmlns:r="http://schemas.openxmlformats.org/officeDocument/2006/relationships" xmlns:p="http://schemas.openxmlformats.org/presentationml/2006/main">
+  <p:cSld>
+    <p:spTree>
+      <p:nvGrpSpPr>
+        <p:cNvPr id="1" name=""/>
+        <p:cNvGrpSpPr/>
+        <p:nvPr/>
+      </p:nvGrpSpPr>
+      <p:grpSpPr>
+        <a:xfrm>
+          <a:off x="0" y="0"/>
+          <a:ext cx="0" cy="0"/>
+          <a:chOff x="0" y="0"/>
+          <a:chExt cx="0" cy="0"/>
+        </a:xfrm>
+      </p:grpSpPr>
+      <p:sp>
+        <p:nvSpPr>
+          <p:cNvPr id="2" name="Title 1"/>
+          <p:cNvSpPr>
+            <a:spLocks noGrp="1"/>
+          </p:cNvSpPr>
+          <p:nvPr>
+            <p:ph type="title"/>
+          </p:nvPr>
+        </p:nvSpPr>
+        <p:spPr>
+          <a:xfrm>
+            <a:off x="457200" y="205979"/>
+            <a:ext cx="8229600" cy="857250"/>
+          </a:xfrm>
+        </p:spPr>
+        <p:txBody>
+          <a:bodyPr/>
+          <a:lstStyle/>
+          <a:p>
+            <a:pPr lvl="0" indent="0" marL="0">
+              <a:buNone/>
+            </a:pPr>
+            <a:r>
+              <a:rPr/>
+              <a:t>What a straight boundary costs</a:t>
+            </a:r>
+          </a:p>
+        </p:txBody>
+      </p:sp>
+      <p:graphicFrame>
+        <p:nvGraphicFramePr>
+          <p:cNvPr id="6" name="Content Placeholder 5"/>
+          <p:cNvGraphicFramePr>
+            <a:graphicFrameLocks noGrp="1"/>
+          </p:cNvGraphicFramePr>
+          <p:nvPr>
+            <p:ph idx="1"/>
+          </p:nvPr>
+        </p:nvGraphicFramePr>
+        <p:xfrm>
+          <a:off x="457200" y="1166099"/>
+          <a:ext cx="8229600" cy="3390900"/>
+        </p:xfrm>
+        <a:graphic>
+          <a:graphicData uri="http://schemas.openxmlformats.org/drawingml/2006/table">
+            <a:tbl>
+              <a:tblPr firstRow="1" bandRow="1">
+                <a:tableStyleId>{5C22544A-7EE6-4342-B048-85BDC9FD1C3A}</a:tableStyleId>
+              </a:tblPr>
+              <a:tblGrid>
+                <a:gridCol w="4114800"/>
+                <a:gridCol w="4114800"/>
+              </a:tblGrid>
+              <a:tr h="0">
+                <a:tc>
+                  <a:txBody>
+                    <a:bodyPr/>
+                    <a:lstStyle/>
+                    <a:p>
+                      <a:pPr lvl="0" indent="0" marL="0">
+                        <a:buNone/>
+                      </a:pPr>
+                      <a:r>
+                        <a:rPr/>
+                        <a:t>Model</a:t>
+                      </a:r>
+                    </a:p>
+                  </a:txBody>
+                  <a:tcPr/>
+                </a:tc>
+                <a:tc>
+                  <a:txBody>
+                    <a:bodyPr/>
+                    <a:lstStyle/>
+                    <a:p>
+                      <a:pPr lvl="0" indent="0" marL="0">
+                        <a:buNone/>
+                      </a:pPr>
+                      <a:r>
+                        <a:rPr/>
+                        <a:t>Cross-validated accuracy</a:t>
+                      </a:r>
+                    </a:p>
+                  </a:txBody>
+                  <a:tcPr/>
+                </a:tc>
+              </a:tr>
+              <a:tr h="0">
+                <a:tc>
+                  <a:txBody>
+                    <a:bodyPr/>
+                    <a:lstStyle/>
+                    <a:p>
+                      <a:pPr lvl="0" indent="0" marL="0">
+                        <a:buNone/>
+                      </a:pPr>
+                      <a:r>
+                        <a:rPr/>
+                        <a:t>Always predict the majority class</a:t>
+                      </a:r>
+                    </a:p>
+                  </a:txBody>
+                </a:tc>
+                <a:tc>
+                  <a:txBody>
+                    <a:bodyPr/>
+                    <a:lstStyle/>
+                    <a:p>
+                      <a:pPr lvl="0" indent="0" marL="0">
+                        <a:buNone/>
+                      </a:pPr>
+                      <a:r>
+                        <a:rPr/>
+                        <a:t>0.613</a:t>
+                      </a:r>
+                    </a:p>
+                  </a:txBody>
+                </a:tc>
+              </a:tr>
+              <a:tr h="0">
+                <a:tc>
+                  <a:txBody>
+                    <a:bodyPr/>
+                    <a:lstStyle/>
+                    <a:p>
+                      <a:pPr lvl="0" indent="0" marL="0">
+                        <a:buNone/>
+                      </a:pPr>
+                      <a:r>
+                        <a:rPr/>
+                        <a:t>Logistic regression (lesson 4)</a:t>
+                      </a:r>
+                    </a:p>
+                  </a:txBody>
+                </a:tc>
+                <a:tc>
+                  <a:txBody>
+                    <a:bodyPr/>
+                    <a:lstStyle/>
+                    <a:p>
+                      <a:pPr lvl="0" indent="0" marL="0">
+                        <a:buNone/>
+                      </a:pPr>
+                      <a:r>
+                        <a:rPr b="1"/>
+                        <a:t>0.613 ± 0.000</a:t>
+                      </a:r>
+                    </a:p>
+                  </a:txBody>
+                </a:tc>
+              </a:tr>
+            </a:tbl>
+          </a:graphicData>
+        </a:graphic>
+      </p:graphicFrame>
+    </p:spTree>
+  </p:cSld>
+</p:sld>
+</file>
+
+<file path=ppt/slides/slide60.xml><?xml version="1.0" encoding="utf-8"?>
 <p:sld xmlns:a="http://schemas.openxmlformats.org/drawingml/2006/main" xmlns:r="http://schemas.openxmlformats.org/officeDocument/2006/relationships" xmlns:p="http://schemas.openxmlformats.org/presentationml/2006/main">
   <p:cSld>
     <p:spTree>
@@ -18304,7 +19212,7 @@
 </p:sld>
 </file>
 
-<file path=ppt/slides/slide57.xml><?xml version="1.0" encoding="utf-8"?>
+<file path=ppt/slides/slide61.xml><?xml version="1.0" encoding="utf-8"?>
 <p:sld xmlns:a="http://schemas.openxmlformats.org/drawingml/2006/main" xmlns:r="http://schemas.openxmlformats.org/officeDocument/2006/relationships" xmlns:p="http://schemas.openxmlformats.org/presentationml/2006/main">
   <p:cSld>
     <p:spTree>
@@ -18384,7 +19292,7 @@
 </p:sld>
 </file>
 
-<file path=ppt/slides/slide58.xml><?xml version="1.0" encoding="utf-8"?>
+<file path=ppt/slides/slide62.xml><?xml version="1.0" encoding="utf-8"?>
 <p:sld xmlns:a="http://schemas.openxmlformats.org/drawingml/2006/main" xmlns:r="http://schemas.openxmlformats.org/officeDocument/2006/relationships" xmlns:p="http://schemas.openxmlformats.org/presentationml/2006/main">
   <p:cSld>
     <p:spTree>
@@ -18722,7 +19630,7 @@
 </p:sld>
 </file>
 
-<file path=ppt/slides/slide59.xml><?xml version="1.0" encoding="utf-8"?>
+<file path=ppt/slides/slide63.xml><?xml version="1.0" encoding="utf-8"?>
 <p:sld xmlns:a="http://schemas.openxmlformats.org/drawingml/2006/main" xmlns:r="http://schemas.openxmlformats.org/officeDocument/2006/relationships" xmlns:p="http://schemas.openxmlformats.org/presentationml/2006/main">
   <p:cSld>
     <p:spTree>
@@ -19000,7 +19908,7 @@
 </p:sld>
 </file>
 
-<file path=ppt/slides/slide6.xml><?xml version="1.0" encoding="utf-8"?>
+<file path=ppt/slides/slide64.xml><?xml version="1.0" encoding="utf-8"?>
 <p:sld xmlns:a="http://schemas.openxmlformats.org/drawingml/2006/main" xmlns:r="http://schemas.openxmlformats.org/officeDocument/2006/relationships" xmlns:p="http://schemas.openxmlformats.org/presentationml/2006/main">
   <p:cSld>
     <p:spTree>
@@ -19042,184 +19950,6 @@
             </a:pPr>
             <a:r>
               <a:rPr/>
-              <a:t>What a straight boundary costs</a:t>
-            </a:r>
-          </a:p>
-        </p:txBody>
-      </p:sp>
-      <p:graphicFrame>
-        <p:nvGraphicFramePr>
-          <p:cNvPr id="6" name="Content Placeholder 5"/>
-          <p:cNvGraphicFramePr>
-            <a:graphicFrameLocks noGrp="1"/>
-          </p:cNvGraphicFramePr>
-          <p:nvPr>
-            <p:ph idx="1"/>
-          </p:nvPr>
-        </p:nvGraphicFramePr>
-        <p:xfrm>
-          <a:off x="457200" y="1166099"/>
-          <a:ext cx="8229600" cy="3390900"/>
-        </p:xfrm>
-        <a:graphic>
-          <a:graphicData uri="http://schemas.openxmlformats.org/drawingml/2006/table">
-            <a:tbl>
-              <a:tblPr firstRow="1" bandRow="1">
-                <a:tableStyleId>{5C22544A-7EE6-4342-B048-85BDC9FD1C3A}</a:tableStyleId>
-              </a:tblPr>
-              <a:tblGrid>
-                <a:gridCol w="4114800"/>
-                <a:gridCol w="4114800"/>
-              </a:tblGrid>
-              <a:tr h="0">
-                <a:tc>
-                  <a:txBody>
-                    <a:bodyPr/>
-                    <a:lstStyle/>
-                    <a:p>
-                      <a:pPr lvl="0" indent="0" marL="0">
-                        <a:buNone/>
-                      </a:pPr>
-                      <a:r>
-                        <a:rPr/>
-                        <a:t>Model</a:t>
-                      </a:r>
-                    </a:p>
-                  </a:txBody>
-                  <a:tcPr/>
-                </a:tc>
-                <a:tc>
-                  <a:txBody>
-                    <a:bodyPr/>
-                    <a:lstStyle/>
-                    <a:p>
-                      <a:pPr lvl="0" indent="0" marL="0">
-                        <a:buNone/>
-                      </a:pPr>
-                      <a:r>
-                        <a:rPr/>
-                        <a:t>Cross-validated accuracy</a:t>
-                      </a:r>
-                    </a:p>
-                  </a:txBody>
-                  <a:tcPr/>
-                </a:tc>
-              </a:tr>
-              <a:tr h="0">
-                <a:tc>
-                  <a:txBody>
-                    <a:bodyPr/>
-                    <a:lstStyle/>
-                    <a:p>
-                      <a:pPr lvl="0" indent="0" marL="0">
-                        <a:buNone/>
-                      </a:pPr>
-                      <a:r>
-                        <a:rPr/>
-                        <a:t>Always predict the majority class</a:t>
-                      </a:r>
-                    </a:p>
-                  </a:txBody>
-                </a:tc>
-                <a:tc>
-                  <a:txBody>
-                    <a:bodyPr/>
-                    <a:lstStyle/>
-                    <a:p>
-                      <a:pPr lvl="0" indent="0" marL="0">
-                        <a:buNone/>
-                      </a:pPr>
-                      <a:r>
-                        <a:rPr/>
-                        <a:t>0.613</a:t>
-                      </a:r>
-                    </a:p>
-                  </a:txBody>
-                </a:tc>
-              </a:tr>
-              <a:tr h="0">
-                <a:tc>
-                  <a:txBody>
-                    <a:bodyPr/>
-                    <a:lstStyle/>
-                    <a:p>
-                      <a:pPr lvl="0" indent="0" marL="0">
-                        <a:buNone/>
-                      </a:pPr>
-                      <a:r>
-                        <a:rPr/>
-                        <a:t>Logistic regression (lesson 4)</a:t>
-                      </a:r>
-                    </a:p>
-                  </a:txBody>
-                </a:tc>
-                <a:tc>
-                  <a:txBody>
-                    <a:bodyPr/>
-                    <a:lstStyle/>
-                    <a:p>
-                      <a:pPr lvl="0" indent="0" marL="0">
-                        <a:buNone/>
-                      </a:pPr>
-                      <a:r>
-                        <a:rPr b="1"/>
-                        <a:t>0.613 ± 0.000</a:t>
-                      </a:r>
-                    </a:p>
-                  </a:txBody>
-                </a:tc>
-              </a:tr>
-            </a:tbl>
-          </a:graphicData>
-        </a:graphic>
-      </p:graphicFrame>
-    </p:spTree>
-  </p:cSld>
-</p:sld>
-</file>
-
-<file path=ppt/slides/slide60.xml><?xml version="1.0" encoding="utf-8"?>
-<p:sld xmlns:a="http://schemas.openxmlformats.org/drawingml/2006/main" xmlns:r="http://schemas.openxmlformats.org/officeDocument/2006/relationships" xmlns:p="http://schemas.openxmlformats.org/presentationml/2006/main">
-  <p:cSld>
-    <p:spTree>
-      <p:nvGrpSpPr>
-        <p:cNvPr id="1" name=""/>
-        <p:cNvGrpSpPr/>
-        <p:nvPr/>
-      </p:nvGrpSpPr>
-      <p:grpSpPr>
-        <a:xfrm>
-          <a:off x="0" y="0"/>
-          <a:ext cx="0" cy="0"/>
-          <a:chOff x="0" y="0"/>
-          <a:chExt cx="0" cy="0"/>
-        </a:xfrm>
-      </p:grpSpPr>
-      <p:sp>
-        <p:nvSpPr>
-          <p:cNvPr id="2" name="Title 1"/>
-          <p:cNvSpPr>
-            <a:spLocks noGrp="1"/>
-          </p:cNvSpPr>
-          <p:nvPr>
-            <p:ph type="title"/>
-          </p:nvPr>
-        </p:nvSpPr>
-        <p:spPr>
-          <a:xfrm>
-            <a:off x="457200" y="205979"/>
-            <a:ext cx="8229600" cy="857250"/>
-          </a:xfrm>
-        </p:spPr>
-        <p:txBody>
-          <a:bodyPr/>
-          <a:lstStyle/>
-          <a:p>
-            <a:pPr lvl="0" indent="0" marL="0">
-              <a:buNone/>
-            </a:pPr>
-            <a:r>
-              <a:rPr/>
               <a:t>What to take away</a:t>
             </a:r>
           </a:p>
@@ -19310,7 +20040,7 @@
 </p:sld>
 </file>
 
-<file path=ppt/slides/slide61.xml><?xml version="1.0" encoding="utf-8"?>
+<file path=ppt/slides/slide65.xml><?xml version="1.0" encoding="utf-8"?>
 <p:sld xmlns:a="http://schemas.openxmlformats.org/drawingml/2006/main" xmlns:r="http://schemas.openxmlformats.org/officeDocument/2006/relationships" xmlns:p="http://schemas.openxmlformats.org/presentationml/2006/main">
   <p:cSld>
     <p:spTree>

</xml_diff>

<commit_message>
Put lesson 6's step from log totals to 0.981 on a slide
Slide 32 showed the two log totals and a title of 0.981, and the step
between them lived only in the speaker notes. Slide 33 now carries it: the
gap between the totals, 3.951, through the sigmoid to 0.981, with the
direct normalisation of the two exponentiated scores as a check. The
lesson plan's slide ranges move by one; its minutes do not.

Co-Authored-By: Claude Opus 5.5 <noreply@anthropic.com>
</commit_message>
<xml_diff>
--- a/Lessons/06_knn_naive_bayes_svm/Slides/knn_naive_bayes_svm_slides.pptx
+++ b/Lessons/06_knn_naive_bayes_svm/Slides/knn_naive_bayes_svm_slides.pptx
@@ -5,7 +5,7 @@
     <p:sldMasterId id="2147483648" r:id="rId1"/>
   </p:sldMasterIdLst>
   <p:notesMasterIdLst>
-    <p:notesMasterId r:id="rId67"/>
+    <p:notesMasterId r:id="rId68"/>
   </p:notesMasterIdLst>
   <p:sldIdLst>
     <p:sldId id="256" r:id="rId2"/>
@@ -73,6 +73,7 @@
     <p:sldId id="318" r:id="rId64"/>
     <p:sldId id="319" r:id="rId65"/>
     <p:sldId id="320" r:id="rId66"/>
+    <p:sldId id="321" r:id="rId67"/>
   </p:sldIdLst>
   <p:sldSz cx="9144000" cy="5143500" type="screen16x9"/>
   <p:notesSz cx="6858000" cy="9144000"/>
@@ -3520,7 +3521,7 @@
             </a:pPr>
             <a:r>
               <a:rPr/>
-              <a:t>Faulty has the larger total, so faulty is the prediction. The probability in the title is the normalisation from slide 26 in log form: the gap between the totals, 3.951, through the logistic function, 1 / (1 + e^(−3.951)) = 0.981. Handout section 4.2 lists the four steps.</a:t>
+              <a:t>Faulty has the larger total, so faulty is the prediction. How the two totals become the 0.981 in the title is the next slide. Handout section 4.2 lists the four steps.</a:t>
             </a:r>
           </a:p>
         </p:txBody>
@@ -3602,49 +3603,35 @@
             </a:pPr>
             <a:r>
               <a:rPr/>
-              <a:t>Both halves matter, and students tend to hear only one of them.</a:t>
-            </a:r>
-          </a:p>
-          <a:p>
-            <a:pPr lvl="0" indent="0" marL="0">
-              <a:buNone/>
-            </a:pPr>
-          </a:p>
-          <a:p>
-            <a:pPr lvl="0" indent="0" marL="0">
-              <a:buNone/>
-            </a:pPr>
-            <a:r>
-              <a:rPr/>
-              <a:t>The bargain is real. Nothing else in this course trains in one pass, and nothing else tolerates ten thousand features on a few thousand rows.</a:t>
-            </a:r>
-          </a:p>
-          <a:p>
-            <a:pPr lvl="0" indent="0" marL="0">
-              <a:buNone/>
-            </a:pPr>
-          </a:p>
-          <a:p>
-            <a:pPr lvl="0" indent="0" marL="0">
-              <a:buNone/>
-            </a:pPr>
-            <a:r>
-              <a:rPr/>
-              <a:t>The assumption is false almost everywhere, and give concrete cases rather than a general warning. Two sensors on the same machine are both driven by the operating point, so of course they move together. In text, “New” and “York” co-occur far more than independence would allow. In medicine, symptoms of the same disease arrive in clusters.</a:t>
-            </a:r>
-          </a:p>
-          <a:p>
-            <a:pPr lvl="0" indent="0" marL="0">
-              <a:buNone/>
-            </a:pPr>
-          </a:p>
-          <a:p>
-            <a:pPr lvl="0" indent="0" marL="0">
-              <a:buNone/>
-            </a:pPr>
-            <a:r>
-              <a:rPr/>
-              <a:t>Then the framing that makes the rest of this segment worth doing, and put it as a question to the room: given that the assumption is essentially always false, why does anybody use this? The answer is that the assumption being false and the CLASSIFIER being wrong are different things. Argmax only needs the ordering right, not the probabilities. Handout section 4.2 closes on exactly this.</a:t>
+              <a:t>The step students do not see on their own. Each total is a logarithm: undo it and you get back the Bayes numerator, prior times likelihood - e^(−4.144) = 0.01585 for faulty, e^(−8.095) = 0.000305 for healthy. These are the two scores of slide 26, and the probability is one divided by their sum: the last bullet, 0.01585 over 0.01616, is 0.981.</a:t>
+            </a:r>
+          </a:p>
+          <a:p>
+            <a:pPr lvl="0" indent="0" marL="0">
+              <a:buNone/>
+            </a:pPr>
+          </a:p>
+          <a:p>
+            <a:pPr lvl="0" indent="0" marL="0">
+              <a:buNone/>
+            </a:pPr>
+            <a:r>
+              <a:rPr/>
+              <a:t>Now divide the top and the bottom of that fraction by the faulty score. What is left is 1 / (1 + e^(healthy total − faulty total)) - only the GAP between the totals survives. That gap, 3.951, is the log-odds: faulty is e^3.951, about 52 times, as likely as healthy.</a:t>
+            </a:r>
+          </a:p>
+          <a:p>
+            <a:pPr lvl="0" indent="0" marL="0">
+              <a:buNone/>
+            </a:pPr>
+          </a:p>
+          <a:p>
+            <a:pPr lvl="0" indent="0" marL="0">
+              <a:buNone/>
+            </a:pPr>
+            <a:r>
+              <a:rPr/>
+              <a:t>Point out whose function this is: 1 / (1 + e^(−z)) is lesson 4’s sigmoid, fed the difference between two Naive Bayes scores instead of a linear combination of features. And say why the gap form is the one to compute: with hundreds of features the totals reach −800, e^(−800) is zero in floating point, and the direct fraction becomes 0/0, while the gap stays an ordinary number. Handout section 4.2, “From log scores to a probability”.</a:t>
             </a:r>
           </a:p>
         </p:txBody>
@@ -3726,49 +3713,49 @@
             </a:pPr>
             <a:r>
               <a:rPr/>
-              <a:t>A point behind k-NN, and an enormous distance ahead of the linear model - from a method that assumes something false and trains in a single pass over the data.</a:t>
-            </a:r>
-          </a:p>
-          <a:p>
-            <a:pPr lvl="0" indent="0" marL="0">
-              <a:buNone/>
-            </a:pPr>
-          </a:p>
-          <a:p>
-            <a:pPr lvl="0" indent="0" marL="0">
-              <a:buNone/>
-            </a:pPr>
-            <a:r>
-              <a:rPr/>
-              <a:t>Resist the temptation to stop here, because a score alone tells you nothing about when it will hold. Ask the room the useful question instead: WHY did that work? If the assumption is false, what happened?</a:t>
-            </a:r>
-          </a:p>
-          <a:p>
-            <a:pPr lvl="0" indent="0" marL="0">
-              <a:buNone/>
-            </a:pPr>
-          </a:p>
-          <a:p>
-            <a:pPr lvl="0" indent="0" marL="0">
-              <a:buNone/>
-            </a:pPr>
-            <a:r>
-              <a:rPr/>
-              <a:t>Then be explicit that we are about to check, rather than speculate. This is the habit worth transferring: when a model does better than you expected, find out whether it worked because its assumption held or despite it failing. That tells you whether the result will survive on the next dataset.</a:t>
-            </a:r>
-          </a:p>
-          <a:p>
-            <a:pPr lvl="0" indent="0" marL="0">
-              <a:buNone/>
-            </a:pPr>
-          </a:p>
-          <a:p>
-            <a:pPr lvl="0" indent="0" marL="0">
-              <a:buNone/>
-            </a:pPr>
-            <a:r>
-              <a:rPr/>
-              <a:t>Handout section 4.3.</a:t>
+              <a:t>Both halves matter, and students tend to hear only one of them.</a:t>
+            </a:r>
+          </a:p>
+          <a:p>
+            <a:pPr lvl="0" indent="0" marL="0">
+              <a:buNone/>
+            </a:pPr>
+          </a:p>
+          <a:p>
+            <a:pPr lvl="0" indent="0" marL="0">
+              <a:buNone/>
+            </a:pPr>
+            <a:r>
+              <a:rPr/>
+              <a:t>The bargain is real. Nothing else in this course trains in one pass, and nothing else tolerates ten thousand features on a few thousand rows.</a:t>
+            </a:r>
+          </a:p>
+          <a:p>
+            <a:pPr lvl="0" indent="0" marL="0">
+              <a:buNone/>
+            </a:pPr>
+          </a:p>
+          <a:p>
+            <a:pPr lvl="0" indent="0" marL="0">
+              <a:buNone/>
+            </a:pPr>
+            <a:r>
+              <a:rPr/>
+              <a:t>The assumption is false almost everywhere, and give concrete cases rather than a general warning. Two sensors on the same machine are both driven by the operating point, so of course they move together. In text, “New” and “York” co-occur far more than independence would allow. In medicine, symptoms of the same disease arrive in clusters.</a:t>
+            </a:r>
+          </a:p>
+          <a:p>
+            <a:pPr lvl="0" indent="0" marL="0">
+              <a:buNone/>
+            </a:pPr>
+          </a:p>
+          <a:p>
+            <a:pPr lvl="0" indent="0" marL="0">
+              <a:buNone/>
+            </a:pPr>
+            <a:r>
+              <a:rPr/>
+              <a:t>Then the framing that makes the rest of this segment worth doing, and put it as a question to the room: given that the assumption is essentially always false, why does anybody use this? The answer is that the assumption being false and the CLASSIFIER being wrong are different things. Argmax only needs the ordering right, not the probabilities. Handout section 4.2 closes on exactly this.</a:t>
             </a:r>
           </a:p>
         </p:txBody>
@@ -3850,35 +3837,49 @@
             </a:pPr>
             <a:r>
               <a:rPr/>
-              <a:t>Show the middle column first and let the room draw the conclusion everyone draws: within each class the readings are uncorrelated, so the assumption holds. It is the natural check, and for bell-shaped data it would settle it.</a:t>
-            </a:r>
-          </a:p>
-          <a:p>
-            <a:pPr lvl="0" indent="0" marL="0">
-              <a:buNone/>
-            </a:pPr>
-          </a:p>
-          <a:p>
-            <a:pPr lvl="0" indent="0" marL="0">
-              <a:buNone/>
-            </a:pPr>
-            <a:r>
-              <a:rPr/>
-              <a:t>Then the trap. Correlation only sees straight-line dependence. Healthy pumps fill a disc and faulty ones a ring; on a ring, a pump far out in vibration must be central in pressure. That dependence is symmetric, so the straight-line summary averages it to zero. Square each reading’s distance from the design point and it appears: −0.420 among the faulty pumps. Or say it as a spread: the pressure of a faulty pump has a standard deviation of 0.784 when its vibration is extreme (the fifth furthest out, beyond 6.2 Hz from the centre) and 1.309 when it is not - 0.37 against 0.62 bar, same average, very different spread. Put the distinction on the board in two lines: uncorrelated, yes; independent, no. Naive Bayes assumes the second. The assumption is false.</a:t>
-            </a:r>
-          </a:p>
-          <a:p>
-            <a:pPr lvl="0" indent="0" marL="0">
-              <a:buNone/>
-            </a:pPr>
-          </a:p>
-          <a:p>
-            <a:pPr lvl="0" indent="0" marL="0">
-              <a:buNone/>
-            </a:pPr>
-            <a:r>
-              <a:rPr/>
-              <a:t>So why 0.933? Because the densities are wrong but the boundary they imply is right. With both classes centred on the same point, comparing a narrow bell with a wide one gives an axis-aligned ellipse, and the true envelope is an axis-aligned ellipse. The fitted model’s edge sits at about 3.17 Hz by 0.41 bar against a true 3.5 by 0.45 - the same shape, a tenth small. A false assumption is cheap when it leaves the boundary the right shape. The next slide is the case where it does not. Handout section 4.3.</a:t>
+              <a:t>A point behind k-NN, and an enormous distance ahead of the linear model - from a method that assumes something false and trains in a single pass over the data.</a:t>
+            </a:r>
+          </a:p>
+          <a:p>
+            <a:pPr lvl="0" indent="0" marL="0">
+              <a:buNone/>
+            </a:pPr>
+          </a:p>
+          <a:p>
+            <a:pPr lvl="0" indent="0" marL="0">
+              <a:buNone/>
+            </a:pPr>
+            <a:r>
+              <a:rPr/>
+              <a:t>Resist the temptation to stop here, because a score alone tells you nothing about when it will hold. Ask the room the useful question instead: WHY did that work? If the assumption is false, what happened?</a:t>
+            </a:r>
+          </a:p>
+          <a:p>
+            <a:pPr lvl="0" indent="0" marL="0">
+              <a:buNone/>
+            </a:pPr>
+          </a:p>
+          <a:p>
+            <a:pPr lvl="0" indent="0" marL="0">
+              <a:buNone/>
+            </a:pPr>
+            <a:r>
+              <a:rPr/>
+              <a:t>Then be explicit that we are about to check, rather than speculate. This is the habit worth transferring: when a model does better than you expected, find out whether it worked because its assumption held or despite it failing. That tells you whether the result will survive on the next dataset.</a:t>
+            </a:r>
+          </a:p>
+          <a:p>
+            <a:pPr lvl="0" indent="0" marL="0">
+              <a:buNone/>
+            </a:pPr>
+          </a:p>
+          <a:p>
+            <a:pPr lvl="0" indent="0" marL="0">
+              <a:buNone/>
+            </a:pPr>
+            <a:r>
+              <a:rPr/>
+              <a:t>Handout section 4.3.</a:t>
             </a:r>
           </a:p>
         </p:txBody>
@@ -3960,21 +3961,35 @@
             </a:pPr>
             <a:r>
               <a:rPr/>
-              <a:t>The previous slide’s argument, drawn. Dots are the pumps; the solid black ellipse is where the fitted Naive Bayes model changes its mind; the dashed gold one is the envelope the data was generated from.</a:t>
-            </a:r>
-          </a:p>
-          <a:p>
-            <a:pPr lvl="0" indent="0" marL="0">
-              <a:buNone/>
-            </a:pPr>
-          </a:p>
-          <a:p>
-            <a:pPr lvl="0" indent="0" marL="0">
-              <a:buNone/>
-            </a:pPr>
-            <a:r>
-              <a:rPr/>
-              <a:t>Let them compare the two shapes before saying anything: same orientation, same proportions, the model’s about a tenth smaller - 3.17 Hz by 0.41 bar against 3.5 by 0.45. The assumption is false, the densities it multiplies are wrong, and the boundary they imply is nearly right. That is why 0.933 sits so close to k-NN’s 0.944. Handout section 4.3.</a:t>
+              <a:t>Show the middle column first and let the room draw the conclusion everyone draws: within each class the readings are uncorrelated, so the assumption holds. It is the natural check, and for bell-shaped data it would settle it.</a:t>
+            </a:r>
+          </a:p>
+          <a:p>
+            <a:pPr lvl="0" indent="0" marL="0">
+              <a:buNone/>
+            </a:pPr>
+          </a:p>
+          <a:p>
+            <a:pPr lvl="0" indent="0" marL="0">
+              <a:buNone/>
+            </a:pPr>
+            <a:r>
+              <a:rPr/>
+              <a:t>Then the trap. Correlation only sees straight-line dependence. Healthy pumps fill a disc and faulty ones a ring; on a ring, a pump far out in vibration must be central in pressure. That dependence is symmetric, so the straight-line summary averages it to zero. Square each reading’s distance from the design point and it appears: −0.420 among the faulty pumps. Or say it as a spread: the pressure of a faulty pump has a standard deviation of 0.784 when its vibration is extreme (the fifth furthest out, beyond 6.2 Hz from the centre) and 1.309 when it is not - 0.37 against 0.62 bar, same average, very different spread. Put the distinction on the board in two lines: uncorrelated, yes; independent, no. Naive Bayes assumes the second. The assumption is false.</a:t>
+            </a:r>
+          </a:p>
+          <a:p>
+            <a:pPr lvl="0" indent="0" marL="0">
+              <a:buNone/>
+            </a:pPr>
+          </a:p>
+          <a:p>
+            <a:pPr lvl="0" indent="0" marL="0">
+              <a:buNone/>
+            </a:pPr>
+            <a:r>
+              <a:rPr/>
+              <a:t>So why 0.933? Because the densities are wrong but the boundary they imply is right. With both classes centred on the same point, comparing a narrow bell with a wide one gives an axis-aligned ellipse, and the true envelope is an axis-aligned ellipse. The fitted model’s edge sits at about 3.17 Hz by 0.41 bar against a true 3.5 by 0.45 - the same shape, a tenth small. A false assumption is cheap when it leaves the boundary the right shape. The next slide is the case where it does not. Handout section 4.3.</a:t>
             </a:r>
           </a:p>
         </p:txBody>
@@ -4056,49 +4071,21 @@
             </a:pPr>
             <a:r>
               <a:rPr/>
-              <a:t>Change one thing about the problem and watch the method fall apart. Describe the physics before the geometry, because the rule is completely reasonable engineering.</a:t>
-            </a:r>
-          </a:p>
-          <a:p>
-            <a:pPr lvl="0" indent="0" marL="0">
-              <a:buNone/>
-            </a:pPr>
-          </a:p>
-          <a:p>
-            <a:pPr lvl="0" indent="0" marL="0">
-              <a:buNone/>
-            </a:pPr>
-            <a:r>
-              <a:rPr/>
-              <a:t>High demand and high delivery: fine, that is the machine working hard. Low and low: fine, that is idle. High demand with low delivery, or the reverse: something is wrong between them. Exactly one high means faulty.</a:t>
-            </a:r>
-          </a:p>
-          <a:p>
-            <a:pPr lvl="0" indent="0" marL="0">
-              <a:buNone/>
-            </a:pPr>
-          </a:p>
-          <a:p>
-            <a:pPr lvl="0" indent="0" marL="0">
-              <a:buNone/>
-            </a:pPr>
-            <a:r>
-              <a:rPr/>
-              <a:t>Ask them, before the picture, what each sensor tells you ON ITS OWN under that rule. Give it a moment. The answer is: nothing at all. Every value of sensor A appears in both classes about equally often, because whether it means “faulty” depends entirely on sensor B.</a:t>
-            </a:r>
-          </a:p>
-          <a:p>
-            <a:pPr lvl="0" indent="0" marL="0">
-              <a:buNone/>
-            </a:pPr>
-          </a:p>
-          <a:p>
-            <a:pPr lvl="0" indent="0" marL="0">
-              <a:buNone/>
-            </a:pPr>
-            <a:r>
-              <a:rPr/>
-              <a:t>That is what an interaction is, and it is precisely the structure the independence assumption is unable to represent. Handout section 4.4.</a:t>
+              <a:t>The previous slide’s argument, drawn. Dots are the pumps; the solid black ellipse is where the fitted Naive Bayes model changes its mind; the dashed gold one is the envelope the data was generated from.</a:t>
+            </a:r>
+          </a:p>
+          <a:p>
+            <a:pPr lvl="0" indent="0" marL="0">
+              <a:buNone/>
+            </a:pPr>
+          </a:p>
+          <a:p>
+            <a:pPr lvl="0" indent="0" marL="0">
+              <a:buNone/>
+            </a:pPr>
+            <a:r>
+              <a:rPr/>
+              <a:t>Let them compare the two shapes before saying anything: same orientation, same proportions, the model’s about a tenth smaller - 3.17 Hz by 0.41 bar against 3.5 by 0.45. The assumption is false, the densities it multiplies are wrong, and the boundary they imply is nearly right. That is why 0.933 sits so close to k-NN’s 0.944. Handout section 4.3.</a:t>
             </a:r>
           </a:p>
         </p:txBody>
@@ -4180,77 +4167,49 @@
             </a:pPr>
             <a:r>
               <a:rPr/>
-              <a:t>Left panel: the two sensors together. Four clean groups, and a perfectly learnable rule - any method that can draw a non-linear boundary will find it.</a:t>
-            </a:r>
-          </a:p>
-          <a:p>
-            <a:pPr lvl="0" indent="0" marL="0">
-              <a:buNone/>
-            </a:pPr>
-          </a:p>
-          <a:p>
-            <a:pPr lvl="0" indent="0" marL="0">
-              <a:buNone/>
-            </a:pPr>
-            <a:r>
-              <a:rPr/>
-              <a:t>Colours first, because someone will ask: teal is healthy, rust is faulty, everywhere. In the left panel each class owns two opposite quadrants - healthy has both sensors high or both low, faulty one high and one low.</a:t>
-            </a:r>
-          </a:p>
-          <a:p>
-            <a:pPr lvl="0" indent="0" marL="0">
-              <a:buNone/>
-            </a:pPr>
-          </a:p>
-          <a:p>
-            <a:pPr lvl="0" indent="0" marL="0">
-              <a:buNone/>
-            </a:pPr>
-            <a:r>
-              <a:rPr/>
-              <a:t>Middle and right: each sensor on its own, which is ALL Naive Bayes ever gets. Solid outlines are the data. Each sensor is either low or high, so each outline has two humps - and healthy and faulty have the SAME two humps, because each class is about half low and half high on each sensor alone.</a:t>
-            </a:r>
-          </a:p>
-          <a:p>
-            <a:pPr lvl="0" indent="0" marL="0">
-              <a:buNone/>
-            </a:pPr>
-          </a:p>
-          <a:p>
-            <a:pPr lvl="0" indent="0" marL="0">
-              <a:buNone/>
-            </a:pPr>
-            <a:r>
-              <a:rPr/>
-              <a:t>The dashed curves are what the model fits: one bell per sensor per class. A single bell cannot follow two humps, so it sits in the valley between them, and the two classes’ bells almost coincide - centre near 0, sd about 1.1 for both. Contrast the pumps a few slides ago: bells with a shared centre but widths of 1.695 against 4.636 Hz, and the widths carried the class. Here nothing does.</a:t>
-            </a:r>
-          </a:p>
-          <a:p>
-            <a:pPr lvl="0" indent="0" marL="0">
-              <a:buNone/>
-            </a:pPr>
-          </a:p>
-          <a:p>
-            <a:pPr lvl="0" indent="0" marL="0">
-              <a:buNone/>
-            </a:pPr>
-            <a:r>
-              <a:rPr/>
-              <a:t>That is the slide in one sentence: the information is real, it is entirely in the relationship between the columns, and factorising the density throws that relationship away before the model ever sees it.</a:t>
-            </a:r>
-          </a:p>
-          <a:p>
-            <a:pPr lvl="0" indent="0" marL="0">
-              <a:buNone/>
-            </a:pPr>
-          </a:p>
-          <a:p>
-            <a:pPr lvl="0" indent="0" marL="0">
-              <a:buNone/>
-            </a:pPr>
-            <a:r>
-              <a:rPr/>
-              <a:t>Worth saying that no amount of data repairs this. It is not an estimation problem - with a million rows the marginals still overlap. The model cannot represent what is being asked of it.</a:t>
+              <a:t>Change one thing about the problem and watch the method fall apart. Describe the physics before the geometry, because the rule is completely reasonable engineering.</a:t>
+            </a:r>
+          </a:p>
+          <a:p>
+            <a:pPr lvl="0" indent="0" marL="0">
+              <a:buNone/>
+            </a:pPr>
+          </a:p>
+          <a:p>
+            <a:pPr lvl="0" indent="0" marL="0">
+              <a:buNone/>
+            </a:pPr>
+            <a:r>
+              <a:rPr/>
+              <a:t>High demand and high delivery: fine, that is the machine working hard. Low and low: fine, that is idle. High demand with low delivery, or the reverse: something is wrong between them. Exactly one high means faulty.</a:t>
+            </a:r>
+          </a:p>
+          <a:p>
+            <a:pPr lvl="0" indent="0" marL="0">
+              <a:buNone/>
+            </a:pPr>
+          </a:p>
+          <a:p>
+            <a:pPr lvl="0" indent="0" marL="0">
+              <a:buNone/>
+            </a:pPr>
+            <a:r>
+              <a:rPr/>
+              <a:t>Ask them, before the picture, what each sensor tells you ON ITS OWN under that rule. Give it a moment. The answer is: nothing at all. Every value of sensor A appears in both classes about equally often, because whether it means “faulty” depends entirely on sensor B.</a:t>
+            </a:r>
+          </a:p>
+          <a:p>
+            <a:pPr lvl="0" indent="0" marL="0">
+              <a:buNone/>
+            </a:pPr>
+          </a:p>
+          <a:p>
+            <a:pPr lvl="0" indent="0" marL="0">
+              <a:buNone/>
+            </a:pPr>
+            <a:r>
+              <a:rPr/>
+              <a:t>That is what an interaction is, and it is precisely the structure the independence assumption is unable to represent. Handout section 4.4.</a:t>
             </a:r>
           </a:p>
         </p:txBody>
@@ -4332,63 +4291,77 @@
             </a:pPr>
             <a:r>
               <a:rPr/>
-              <a:t>Two things to draw out, and the second is the more interesting.</a:t>
-            </a:r>
-          </a:p>
-          <a:p>
-            <a:pPr lvl="0" indent="0" marL="0">
-              <a:buNone/>
-            </a:pPr>
-          </a:p>
-          <a:p>
-            <a:pPr lvl="0" indent="0" marL="0">
-              <a:buNone/>
-            </a:pPr>
-            <a:r>
-              <a:rPr/>
-              <a:t>First: k-NN and the RBF SVM are at 0.967 and 0.972 on this data. The problem is not hard. It is only hard for a model that looks at one feature at a time.</a:t>
-            </a:r>
-          </a:p>
-          <a:p>
-            <a:pPr lvl="0" indent="0" marL="0">
-              <a:buNone/>
-            </a:pPr>
-          </a:p>
-          <a:p>
-            <a:pPr lvl="0" indent="0" marL="0">
-              <a:buNone/>
-            </a:pPr>
-            <a:r>
-              <a:rPr/>
-              <a:t>Second, and take the time: 0.404 is BELOW CHANCE. Below the majority baseline of 0.523, and below what you would get by flipping a coin. Ask how that is even possible - a model with no information should surely sit at 50%.</a:t>
-            </a:r>
-          </a:p>
-          <a:p>
-            <a:pPr lvl="0" indent="0" marL="0">
-              <a:buNone/>
-            </a:pPr>
-          </a:p>
-          <a:p>
-            <a:pPr lvl="0" indent="0" marL="0">
-              <a:buNone/>
-            </a:pPr>
-            <a:r>
-              <a:rPr/>
-              <a:t>The explanation is worth having in full. The class means on each sensor differ by about 0.17, against a spread near 1, purely as an artefact of a finite sample. That accident is the ONLY per-feature evidence available. Naive Bayes has nothing else to multiply, so it follows it - and in this sample it points the wrong way.</a:t>
-            </a:r>
-          </a:p>
-          <a:p>
-            <a:pPr lvl="0" indent="0" marL="0">
-              <a:buNone/>
-            </a:pPr>
-          </a:p>
-          <a:p>
-            <a:pPr lvl="0" indent="0" marL="0">
-              <a:buNone/>
-            </a:pPr>
-            <a:r>
-              <a:rPr/>
-              <a:t>The sentence to land: a model with no signal does not sit politely at 50%. It follows whatever spurious structure it can find, with complete confidence.</a:t>
+              <a:t>Left panel: the two sensors together. Four clean groups, and a perfectly learnable rule - any method that can draw a non-linear boundary will find it.</a:t>
+            </a:r>
+          </a:p>
+          <a:p>
+            <a:pPr lvl="0" indent="0" marL="0">
+              <a:buNone/>
+            </a:pPr>
+          </a:p>
+          <a:p>
+            <a:pPr lvl="0" indent="0" marL="0">
+              <a:buNone/>
+            </a:pPr>
+            <a:r>
+              <a:rPr/>
+              <a:t>Colours first, because someone will ask: teal is healthy, rust is faulty, everywhere. In the left panel each class owns two opposite quadrants - healthy has both sensors high or both low, faulty one high and one low.</a:t>
+            </a:r>
+          </a:p>
+          <a:p>
+            <a:pPr lvl="0" indent="0" marL="0">
+              <a:buNone/>
+            </a:pPr>
+          </a:p>
+          <a:p>
+            <a:pPr lvl="0" indent="0" marL="0">
+              <a:buNone/>
+            </a:pPr>
+            <a:r>
+              <a:rPr/>
+              <a:t>Middle and right: each sensor on its own, which is ALL Naive Bayes ever gets. Solid outlines are the data. Each sensor is either low or high, so each outline has two humps - and healthy and faulty have the SAME two humps, because each class is about half low and half high on each sensor alone.</a:t>
+            </a:r>
+          </a:p>
+          <a:p>
+            <a:pPr lvl="0" indent="0" marL="0">
+              <a:buNone/>
+            </a:pPr>
+          </a:p>
+          <a:p>
+            <a:pPr lvl="0" indent="0" marL="0">
+              <a:buNone/>
+            </a:pPr>
+            <a:r>
+              <a:rPr/>
+              <a:t>The dashed curves are what the model fits: one bell per sensor per class. A single bell cannot follow two humps, so it sits in the valley between them, and the two classes’ bells almost coincide - centre near 0, sd about 1.1 for both. Contrast the pumps a few slides ago: bells with a shared centre but widths of 1.695 against 4.636 Hz, and the widths carried the class. Here nothing does.</a:t>
+            </a:r>
+          </a:p>
+          <a:p>
+            <a:pPr lvl="0" indent="0" marL="0">
+              <a:buNone/>
+            </a:pPr>
+          </a:p>
+          <a:p>
+            <a:pPr lvl="0" indent="0" marL="0">
+              <a:buNone/>
+            </a:pPr>
+            <a:r>
+              <a:rPr/>
+              <a:t>That is the slide in one sentence: the information is real, it is entirely in the relationship between the columns, and factorising the density throws that relationship away before the model ever sees it.</a:t>
+            </a:r>
+          </a:p>
+          <a:p>
+            <a:pPr lvl="0" indent="0" marL="0">
+              <a:buNone/>
+            </a:pPr>
+          </a:p>
+          <a:p>
+            <a:pPr lvl="0" indent="0" marL="0">
+              <a:buNone/>
+            </a:pPr>
+            <a:r>
+              <a:rPr/>
+              <a:t>Worth saying that no amount of data repairs this. It is not an estimation problem - with a million rows the marginals still overlap. The model cannot represent what is being asked of it.</a:t>
             </a:r>
           </a:p>
         </p:txBody>
@@ -4470,59 +4443,63 @@
             </a:pPr>
             <a:r>
               <a:rPr/>
-              <a:t>Two numbers, four thousandths apart. The model is exactly as confident when it is wrong as when it is right, which means </a:t>
-            </a:r>
-            <a:r>
-              <a:rPr>
-                <a:latin typeface="Courier"/>
-              </a:rPr>
-              <a:t>predict_proba</a:t>
-            </a:r>
-            <a:r>
-              <a:rPr/>
-              <a:t> carries no usable information about reliability here.</a:t>
-            </a:r>
-          </a:p>
-          <a:p>
-            <a:pPr lvl="0" indent="0" marL="0">
-              <a:buNone/>
-            </a:pPr>
-          </a:p>
-          <a:p>
-            <a:pPr lvl="0" indent="0" marL="0">
-              <a:buNone/>
-            </a:pPr>
-            <a:r>
-              <a:rPr/>
-              <a:t>The more common complaint runs in the opposite direction, so give it too: when features carry the SAME evidence about the class - near-copies of one another - multiplying their probabilities counts it repeatedly. Be precise here, because they have just seen two kinds of dependence that are not this: the pumps’ ring and the XOR sensors. Ten correlated words in a document are treated as ten independent pieces of evidence, and the posterior saturates. Naive Bayes is famous for reporting 0.999 on problems it gets wrong a fifth of the time.</a:t>
-            </a:r>
-          </a:p>
-          <a:p>
-            <a:pPr lvl="0" indent="0" marL="0">
-              <a:buNone/>
-            </a:pPr>
-          </a:p>
-          <a:p>
-            <a:pPr lvl="0" indent="0" marL="0">
-              <a:buNone/>
-            </a:pPr>
-            <a:r>
-              <a:rPr/>
-              <a:t>Then lesson 5’s distinction, which this is the textbook case of: ranking and calibration are different properties. A model can order examples usefully and still report numbers that mean nothing.</a:t>
-            </a:r>
-          </a:p>
-          <a:p>
-            <a:pPr lvl="0" indent="0" marL="0">
-              <a:buNone/>
-            </a:pPr>
-          </a:p>
-          <a:p>
-            <a:pPr lvl="0" indent="0" marL="0">
-              <a:buNone/>
-            </a:pPr>
-            <a:r>
-              <a:rPr/>
-              <a:t>The practical consequence, and it is concrete: do not use Naive Bayes anywhere a calibrated probability enters a decision - including lesson 4’s cost calculation in section 7.2, where the threshold depends on the probability being real.</a:t>
+              <a:t>Two things to draw out, and the second is the more interesting.</a:t>
+            </a:r>
+          </a:p>
+          <a:p>
+            <a:pPr lvl="0" indent="0" marL="0">
+              <a:buNone/>
+            </a:pPr>
+          </a:p>
+          <a:p>
+            <a:pPr lvl="0" indent="0" marL="0">
+              <a:buNone/>
+            </a:pPr>
+            <a:r>
+              <a:rPr/>
+              <a:t>First: k-NN and the RBF SVM are at 0.967 and 0.972 on this data. The problem is not hard. It is only hard for a model that looks at one feature at a time.</a:t>
+            </a:r>
+          </a:p>
+          <a:p>
+            <a:pPr lvl="0" indent="0" marL="0">
+              <a:buNone/>
+            </a:pPr>
+          </a:p>
+          <a:p>
+            <a:pPr lvl="0" indent="0" marL="0">
+              <a:buNone/>
+            </a:pPr>
+            <a:r>
+              <a:rPr/>
+              <a:t>Second, and take the time: 0.404 is BELOW CHANCE. Below the majority baseline of 0.523, and below what you would get by flipping a coin. Ask how that is even possible - a model with no information should surely sit at 50%.</a:t>
+            </a:r>
+          </a:p>
+          <a:p>
+            <a:pPr lvl="0" indent="0" marL="0">
+              <a:buNone/>
+            </a:pPr>
+          </a:p>
+          <a:p>
+            <a:pPr lvl="0" indent="0" marL="0">
+              <a:buNone/>
+            </a:pPr>
+            <a:r>
+              <a:rPr/>
+              <a:t>The explanation is worth having in full. The class means on each sensor differ by about 0.17, against a spread near 1, purely as an artefact of a finite sample. That accident is the ONLY per-feature evidence available. Naive Bayes has nothing else to multiply, so it follows it - and in this sample it points the wrong way.</a:t>
+            </a:r>
+          </a:p>
+          <a:p>
+            <a:pPr lvl="0" indent="0" marL="0">
+              <a:buNone/>
+            </a:pPr>
+          </a:p>
+          <a:p>
+            <a:pPr lvl="0" indent="0" marL="0">
+              <a:buNone/>
+            </a:pPr>
+            <a:r>
+              <a:rPr/>
+              <a:t>The sentence to land: a model with no signal does not sit politely at 50%. It follows whatever spurious structure it can find, with complete confidence.</a:t>
             </a:r>
           </a:p>
         </p:txBody>
@@ -4728,49 +4705,59 @@
             </a:pPr>
             <a:r>
               <a:rPr/>
-              <a:t>Run notebooks/02. Sixteen minutes.</a:t>
-            </a:r>
-          </a:p>
-          <a:p>
-            <a:pPr lvl="0" indent="0" marL="0">
-              <a:buNone/>
-            </a:pPr>
-          </a:p>
-          <a:p>
-            <a:pPr lvl="0" indent="0" marL="0">
-              <a:buNone/>
-            </a:pPr>
-            <a:r>
-              <a:rPr/>
-              <a:t>The cell to protect is the one that prints 0.404 next to the 0.523 baseline. Let them see a below-chance score appear from correct code on solvable data before any explanation arrives.</a:t>
-            </a:r>
-          </a:p>
-          <a:p>
-            <a:pPr lvl="0" indent="0" marL="0">
-              <a:buNone/>
-            </a:pPr>
-          </a:p>
-          <a:p>
-            <a:pPr lvl="0" indent="0" marL="0">
-              <a:buNone/>
-            </a:pPr>
-            <a:r>
-              <a:rPr/>
-              <a:t>The notebook prints the within-class correlations on both datasets. Before that cell runs, ask them to predict the signs for the interacting sensors: it is the diagnostic they should carry - measure the assumption, do not assume it.</a:t>
-            </a:r>
-          </a:p>
-          <a:p>
-            <a:pPr lvl="0" indent="0" marL="0">
-              <a:buNone/>
-            </a:pPr>
-          </a:p>
-          <a:p>
-            <a:pPr lvl="0" indent="0" marL="0">
-              <a:buNone/>
-            </a:pPr>
-            <a:r>
-              <a:rPr/>
-              <a:t>If time allows, the interesting exercise is to hand Naive Bayes the product of the two sensors as a third column and watch it recover. That is the whole story of feature engineering versus model choice in one cell.</a:t>
+              <a:t>Two numbers, four thousandths apart. The model is exactly as confident when it is wrong as when it is right, which means </a:t>
+            </a:r>
+            <a:r>
+              <a:rPr>
+                <a:latin typeface="Courier"/>
+              </a:rPr>
+              <a:t>predict_proba</a:t>
+            </a:r>
+            <a:r>
+              <a:rPr/>
+              <a:t> carries no usable information about reliability here.</a:t>
+            </a:r>
+          </a:p>
+          <a:p>
+            <a:pPr lvl="0" indent="0" marL="0">
+              <a:buNone/>
+            </a:pPr>
+          </a:p>
+          <a:p>
+            <a:pPr lvl="0" indent="0" marL="0">
+              <a:buNone/>
+            </a:pPr>
+            <a:r>
+              <a:rPr/>
+              <a:t>The more common complaint runs in the opposite direction, so give it too: when features carry the SAME evidence about the class - near-copies of one another - multiplying their probabilities counts it repeatedly. Be precise here, because they have just seen two kinds of dependence that are not this: the pumps’ ring and the XOR sensors. Ten correlated words in a document are treated as ten independent pieces of evidence, and the posterior saturates. Naive Bayes is famous for reporting 0.999 on problems it gets wrong a fifth of the time.</a:t>
+            </a:r>
+          </a:p>
+          <a:p>
+            <a:pPr lvl="0" indent="0" marL="0">
+              <a:buNone/>
+            </a:pPr>
+          </a:p>
+          <a:p>
+            <a:pPr lvl="0" indent="0" marL="0">
+              <a:buNone/>
+            </a:pPr>
+            <a:r>
+              <a:rPr/>
+              <a:t>Then lesson 5’s distinction, which this is the textbook case of: ranking and calibration are different properties. A model can order examples usefully and still report numbers that mean nothing.</a:t>
+            </a:r>
+          </a:p>
+          <a:p>
+            <a:pPr lvl="0" indent="0" marL="0">
+              <a:buNone/>
+            </a:pPr>
+          </a:p>
+          <a:p>
+            <a:pPr lvl="0" indent="0" marL="0">
+              <a:buNone/>
+            </a:pPr>
+            <a:r>
+              <a:rPr/>
+              <a:t>The practical consequence, and it is concrete: do not use Naive Bayes anywhere a calibrated probability enters a decision - including lesson 4’s cost calculation in section 7.2, where the threshold depends on the probability being real.</a:t>
             </a:r>
           </a:p>
         </p:txBody>
@@ -4852,49 +4839,49 @@
             </a:pPr>
             <a:r>
               <a:rPr/>
-              <a:t>Start with the problem rather than the solution. Draw two well-separated blobs on the board and ask for the boundary. Somebody will draw a line. Ask whether another line would have been equally good, and keep asking until the room sees that there are infinitely many, all with identical training error.</a:t>
-            </a:r>
-          </a:p>
-          <a:p>
-            <a:pPr lvl="0" indent="0" marL="0">
-              <a:buNone/>
-            </a:pPr>
-          </a:p>
-          <a:p>
-            <a:pPr lvl="0" indent="0" marL="0">
-              <a:buNone/>
-            </a:pPr>
-            <a:r>
-              <a:rPr/>
-              <a:t>So the error cannot decide. Something else has to. Logistic regression breaks the tie with log loss - a perfectly respectable answer, and one answer among several. The SVM breaks it differently: take the boundary with the most room around it.</a:t>
-            </a:r>
-          </a:p>
-          <a:p>
-            <a:pPr lvl="0" indent="0" marL="0">
-              <a:buNone/>
-            </a:pPr>
-          </a:p>
-          <a:p>
-            <a:pPr lvl="0" indent="0" marL="0">
-              <a:buNone/>
-            </a:pPr>
-            <a:r>
-              <a:rPr/>
-              <a:t>The intuition, and this is the sentence to say slowly: maximising the distance to the closest points chooses the boundary that tolerates the most movement in the data before it changes its mind. That is a statement about GENERALISATION, not about fit - which is unusual, because almost everything else in this course optimises fit and controls generalisation indirectly.</a:t>
-            </a:r>
-          </a:p>
-          <a:p>
-            <a:pPr lvl="0" indent="0" marL="0">
-              <a:buNone/>
-            </a:pPr>
-          </a:p>
-          <a:p>
-            <a:pPr lvl="0" indent="0" marL="0">
-              <a:buNone/>
-            </a:pPr>
-            <a:r>
-              <a:rPr/>
-              <a:t>Handout section 5.1.</a:t>
+              <a:t>Run notebooks/02. Sixteen minutes.</a:t>
+            </a:r>
+          </a:p>
+          <a:p>
+            <a:pPr lvl="0" indent="0" marL="0">
+              <a:buNone/>
+            </a:pPr>
+          </a:p>
+          <a:p>
+            <a:pPr lvl="0" indent="0" marL="0">
+              <a:buNone/>
+            </a:pPr>
+            <a:r>
+              <a:rPr/>
+              <a:t>The cell to protect is the one that prints 0.404 next to the 0.523 baseline. Let them see a below-chance score appear from correct code on solvable data before any explanation arrives.</a:t>
+            </a:r>
+          </a:p>
+          <a:p>
+            <a:pPr lvl="0" indent="0" marL="0">
+              <a:buNone/>
+            </a:pPr>
+          </a:p>
+          <a:p>
+            <a:pPr lvl="0" indent="0" marL="0">
+              <a:buNone/>
+            </a:pPr>
+            <a:r>
+              <a:rPr/>
+              <a:t>The notebook prints the within-class correlations on both datasets. Before that cell runs, ask them to predict the signs for the interacting sensors: it is the diagnostic they should carry - measure the assumption, do not assume it.</a:t>
+            </a:r>
+          </a:p>
+          <a:p>
+            <a:pPr lvl="0" indent="0" marL="0">
+              <a:buNone/>
+            </a:pPr>
+          </a:p>
+          <a:p>
+            <a:pPr lvl="0" indent="0" marL="0">
+              <a:buNone/>
+            </a:pPr>
+            <a:r>
+              <a:rPr/>
+              <a:t>If time allows, the interesting exercise is to hand Naive Bayes the product of the two sensors as a third column and watch it recover. That is the whole story of feature engineering versus model choice in one cell.</a:t>
             </a:r>
           </a:p>
         </p:txBody>
@@ -4976,49 +4963,49 @@
             </a:pPr>
             <a:r>
               <a:rPr/>
-              <a:t>The solid line is the boundary, the dashed lines are the edges of the slab, and the circled points are the support vectors touching it.</a:t>
-            </a:r>
-          </a:p>
-          <a:p>
-            <a:pPr lvl="0" indent="0" marL="0">
-              <a:buNone/>
-            </a:pPr>
-          </a:p>
-          <a:p>
-            <a:pPr lvl="0" indent="0" marL="0">
-              <a:buNone/>
-            </a:pPr>
-            <a:r>
-              <a:rPr/>
-              <a:t>The number to say out loud: of eighty points, THREE determine the answer. Move any of the other seventy-seven - anywhere, as far as you like, as long as they stay outside the slab - and the boundary does not shift by a millimetre.</a:t>
-            </a:r>
-          </a:p>
-          <a:p>
-            <a:pPr lvl="0" indent="0" marL="0">
-              <a:buNone/>
-            </a:pPr>
-          </a:p>
-          <a:p>
-            <a:pPr lvl="0" indent="0" marL="0">
-              <a:buNone/>
-            </a:pPr>
-            <a:r>
-              <a:rPr/>
-              <a:t>That is where the name comes from, and it is a genuinely different idea from anything so far. Every linear model in lessons 3 and 4 used every row: each one contributed to the gradient in proportion to its error. Here most of the data is irrelevant once the fit is done.</a:t>
-            </a:r>
-          </a:p>
-          <a:p>
-            <a:pPr lvl="0" indent="0" marL="0">
-              <a:buNone/>
-            </a:pPr>
-          </a:p>
-          <a:p>
-            <a:pPr lvl="0" indent="0" marL="0">
-              <a:buNone/>
-            </a:pPr>
-            <a:r>
-              <a:rPr/>
-              <a:t>Two consequences worth naming. The model is small - you store the support vectors, not the dataset, which is the contrast with k-NN. And it is sensitive in a specific way: an outlier near the boundary matters enormously, while an outlier far from it matters not at all.</a:t>
+              <a:t>Start with the problem rather than the solution. Draw two well-separated blobs on the board and ask for the boundary. Somebody will draw a line. Ask whether another line would have been equally good, and keep asking until the room sees that there are infinitely many, all with identical training error.</a:t>
+            </a:r>
+          </a:p>
+          <a:p>
+            <a:pPr lvl="0" indent="0" marL="0">
+              <a:buNone/>
+            </a:pPr>
+          </a:p>
+          <a:p>
+            <a:pPr lvl="0" indent="0" marL="0">
+              <a:buNone/>
+            </a:pPr>
+            <a:r>
+              <a:rPr/>
+              <a:t>So the error cannot decide. Something else has to. Logistic regression breaks the tie with log loss - a perfectly respectable answer, and one answer among several. The SVM breaks it differently: take the boundary with the most room around it.</a:t>
+            </a:r>
+          </a:p>
+          <a:p>
+            <a:pPr lvl="0" indent="0" marL="0">
+              <a:buNone/>
+            </a:pPr>
+          </a:p>
+          <a:p>
+            <a:pPr lvl="0" indent="0" marL="0">
+              <a:buNone/>
+            </a:pPr>
+            <a:r>
+              <a:rPr/>
+              <a:t>The intuition, and this is the sentence to say slowly: maximising the distance to the closest points chooses the boundary that tolerates the most movement in the data before it changes its mind. That is a statement about GENERALISATION, not about fit - which is unusual, because almost everything else in this course optimises fit and controls generalisation indirectly.</a:t>
+            </a:r>
+          </a:p>
+          <a:p>
+            <a:pPr lvl="0" indent="0" marL="0">
+              <a:buNone/>
+            </a:pPr>
+          </a:p>
+          <a:p>
+            <a:pPr lvl="0" indent="0" marL="0">
+              <a:buNone/>
+            </a:pPr>
+            <a:r>
+              <a:rPr/>
+              <a:t>Handout section 5.1.</a:t>
             </a:r>
           </a:p>
         </p:txBody>
@@ -5100,49 +5087,49 @@
             </a:pPr>
             <a:r>
               <a:rPr/>
-              <a:t>The point worth stressing is why the soft margin is not a patch or a convenience. With even one mislabelled point inside the other class, the strict problem is INFEASIBLE - there is no solution, not a bad one. Real data always contains such points. So the soft margin is the only version anyone ever runs; the hard-margin problem is a teaching device.</a:t>
-            </a:r>
-          </a:p>
-          <a:p>
-            <a:pPr lvl="0" indent="0" marL="0">
-              <a:buNone/>
-            </a:pPr>
-          </a:p>
-          <a:p>
-            <a:pPr lvl="0" indent="0" marL="0">
-              <a:buNone/>
-            </a:pPr>
-            <a:r>
-              <a:rPr/>
-              <a:t>Our own labels are flipped at 4%, deliberately, so this is not a hypothetical for this dataset: the hard-margin problem on these pumps has no answer.</a:t>
-            </a:r>
-          </a:p>
-          <a:p>
-            <a:pPr lvl="0" indent="0" marL="0">
-              <a:buNone/>
-            </a:pPr>
-          </a:p>
-          <a:p>
-            <a:pPr lvl="0" indent="0" marL="0">
-              <a:buNone/>
-            </a:pPr>
-            <a:r>
-              <a:rPr/>
-              <a:t>Then read the three cases of the slack aloud, because they come back twice: in the weights the training produces, and in who gets a vote at prediction. Put it next to lesson 4’s log loss: that one shrinks for a well-classified point but never reaches zero, so every row keeps pulling. The hinge reaches zero, and a point with zero loss drops out of the answer entirely.</a:t>
-            </a:r>
-          </a:p>
-          <a:p>
-            <a:pPr lvl="0" indent="0" marL="0">
-              <a:buNone/>
-            </a:pPr>
-          </a:p>
-          <a:p>
-            <a:pPr lvl="0" indent="0" marL="0">
-              <a:buNone/>
-            </a:pPr>
-            <a:r>
-              <a:rPr/>
-              <a:t>The next slide puts it in symbols. Handout section 5.2 has the derivation.</a:t>
+              <a:t>The solid line is the boundary, the dashed lines are the edges of the slab, and the circled points are the support vectors touching it.</a:t>
+            </a:r>
+          </a:p>
+          <a:p>
+            <a:pPr lvl="0" indent="0" marL="0">
+              <a:buNone/>
+            </a:pPr>
+          </a:p>
+          <a:p>
+            <a:pPr lvl="0" indent="0" marL="0">
+              <a:buNone/>
+            </a:pPr>
+            <a:r>
+              <a:rPr/>
+              <a:t>The number to say out loud: of eighty points, THREE determine the answer. Move any of the other seventy-seven - anywhere, as far as you like, as long as they stay outside the slab - and the boundary does not shift by a millimetre.</a:t>
+            </a:r>
+          </a:p>
+          <a:p>
+            <a:pPr lvl="0" indent="0" marL="0">
+              <a:buNone/>
+            </a:pPr>
+          </a:p>
+          <a:p>
+            <a:pPr lvl="0" indent="0" marL="0">
+              <a:buNone/>
+            </a:pPr>
+            <a:r>
+              <a:rPr/>
+              <a:t>That is where the name comes from, and it is a genuinely different idea from anything so far. Every linear model in lessons 3 and 4 used every row: each one contributed to the gradient in proportion to its error. Here most of the data is irrelevant once the fit is done.</a:t>
+            </a:r>
+          </a:p>
+          <a:p>
+            <a:pPr lvl="0" indent="0" marL="0">
+              <a:buNone/>
+            </a:pPr>
+          </a:p>
+          <a:p>
+            <a:pPr lvl="0" indent="0" marL="0">
+              <a:buNone/>
+            </a:pPr>
+            <a:r>
+              <a:rPr/>
+              <a:t>Two consequences worth naming. The model is small - you store the support vectors, not the dataset, which is the contrast with k-NN. And it is sensitive in a specific way: an outlier near the boundary matters enormously, while an outlier far from it matters not at all.</a:t>
             </a:r>
           </a:p>
         </p:txBody>
@@ -5224,35 +5211,49 @@
             </a:pPr>
             <a:r>
               <a:rPr/>
-              <a:t>What each point pays, against its margin y times f(x): large and positive when it is safely on its own side, negative on the wrong side.</a:t>
-            </a:r>
-          </a:p>
-          <a:p>
-            <a:pPr lvl="0" indent="0" marL="0">
-              <a:buNone/>
-            </a:pPr>
-          </a:p>
-          <a:p>
-            <a:pPr lvl="0" indent="0" marL="0">
-              <a:buNone/>
-            </a:pPr>
-            <a:r>
-              <a:rPr/>
-              <a:t>Walk the three zones left to right. Wrong side: both losses are large. Inside the slab: the hinge still charges, falling in a straight line. Right of 1, outside the slab: the hinge is exactly zero, and the log loss from lesson 4 is still charging - 0.127 at a margin of 2, 0.049 at 3.</a:t>
-            </a:r>
-          </a:p>
-          <a:p>
-            <a:pPr lvl="0" indent="0" marL="0">
-              <a:buNone/>
-            </a:pPr>
-          </a:p>
-          <a:p>
-            <a:pPr lvl="0" indent="0" marL="0">
-              <a:buNone/>
-            </a:pPr>
-            <a:r>
-              <a:rPr/>
-              <a:t>The sentence to land: a point with zero loss stops pulling on the answer. That is where support vectors come from - and why logistic regression never has any. Handout section 5.2.</a:t>
+              <a:t>The point worth stressing is why the soft margin is not a patch or a convenience. With even one mislabelled point inside the other class, the strict problem is INFEASIBLE - there is no solution, not a bad one. Real data always contains such points. So the soft margin is the only version anyone ever runs; the hard-margin problem is a teaching device.</a:t>
+            </a:r>
+          </a:p>
+          <a:p>
+            <a:pPr lvl="0" indent="0" marL="0">
+              <a:buNone/>
+            </a:pPr>
+          </a:p>
+          <a:p>
+            <a:pPr lvl="0" indent="0" marL="0">
+              <a:buNone/>
+            </a:pPr>
+            <a:r>
+              <a:rPr/>
+              <a:t>Our own labels are flipped at 4%, deliberately, so this is not a hypothetical for this dataset: the hard-margin problem on these pumps has no answer.</a:t>
+            </a:r>
+          </a:p>
+          <a:p>
+            <a:pPr lvl="0" indent="0" marL="0">
+              <a:buNone/>
+            </a:pPr>
+          </a:p>
+          <a:p>
+            <a:pPr lvl="0" indent="0" marL="0">
+              <a:buNone/>
+            </a:pPr>
+            <a:r>
+              <a:rPr/>
+              <a:t>Then read the three cases of the slack aloud, because they come back twice: in the weights the training produces, and in who gets a vote at prediction. Put it next to lesson 4’s log loss: that one shrinks for a well-classified point but never reaches zero, so every row keeps pulling. The hinge reaches zero, and a point with zero loss drops out of the answer entirely.</a:t>
+            </a:r>
+          </a:p>
+          <a:p>
+            <a:pPr lvl="0" indent="0" marL="0">
+              <a:buNone/>
+            </a:pPr>
+          </a:p>
+          <a:p>
+            <a:pPr lvl="0" indent="0" marL="0">
+              <a:buNone/>
+            </a:pPr>
+            <a:r>
+              <a:rPr/>
+              <a:t>The next slide puts it in symbols. Handout section 5.2 has the derivation.</a:t>
             </a:r>
           </a:p>
         </p:txBody>
@@ -5334,49 +5335,35 @@
             </a:pPr>
             <a:r>
               <a:rPr/>
-              <a:t>The constraint is not on the slide any more - it made the line wide enough to land at 28pt - so state it: subject to y_i(w’x_i + b) &gt;= 1 - xi_i, every point on the right side of the slab by a margin, or paying xi_i for the shortfall. Handout section 5.2 writes it out.</a:t>
-            </a:r>
-          </a:p>
-          <a:p>
-            <a:pPr lvl="0" indent="0" marL="0">
-              <a:buNone/>
-            </a:pPr>
-          </a:p>
-          <a:p>
-            <a:pPr lvl="0" indent="0" marL="0">
-              <a:buNone/>
-            </a:pPr>
-            <a:r>
-              <a:rPr/>
-              <a:t>Do not derive this. State what each piece is doing and move on - handout section 5.2 has the derivation, including why maximising the margin is the same as minimising the norm of w.</a:t>
-            </a:r>
-          </a:p>
-          <a:p>
-            <a:pPr lvl="0" indent="0" marL="0">
-              <a:buNone/>
-            </a:pPr>
-          </a:p>
-          <a:p>
-            <a:pPr lvl="0" indent="0" marL="0">
-              <a:buNone/>
-            </a:pPr>
-            <a:r>
-              <a:rPr/>
-              <a:t>The first term wants a wide slab. The second term wants few violations. C sets the exchange rate between them, and that is the entire content of the expression. Read it out in those words rather than reading the symbols.</a:t>
-            </a:r>
-          </a:p>
-          <a:p>
-            <a:pPr lvl="0" indent="0" marL="0">
-              <a:buNone/>
-            </a:pPr>
-          </a:p>
-          <a:p>
-            <a:pPr lvl="0" indent="0" marL="0">
-              <a:buNone/>
-            </a:pPr>
-            <a:r>
-              <a:rPr/>
-              <a:t>If someone asks about the half in front of the norm: it is there to make the derivative tidy, exactly as in lesson 3’s cost function.</a:t>
+              <a:t>What each point pays, against its margin y times f(x): large and positive when it is safely on its own side, negative on the wrong side.</a:t>
+            </a:r>
+          </a:p>
+          <a:p>
+            <a:pPr lvl="0" indent="0" marL="0">
+              <a:buNone/>
+            </a:pPr>
+          </a:p>
+          <a:p>
+            <a:pPr lvl="0" indent="0" marL="0">
+              <a:buNone/>
+            </a:pPr>
+            <a:r>
+              <a:rPr/>
+              <a:t>Walk the three zones left to right. Wrong side: both losses are large. Inside the slab: the hinge still charges, falling in a straight line. Right of 1, outside the slab: the hinge is exactly zero, and the log loss from lesson 4 is still charging - 0.127 at a margin of 2, 0.049 at 3.</a:t>
+            </a:r>
+          </a:p>
+          <a:p>
+            <a:pPr lvl="0" indent="0" marL="0">
+              <a:buNone/>
+            </a:pPr>
+          </a:p>
+          <a:p>
+            <a:pPr lvl="0" indent="0" marL="0">
+              <a:buNone/>
+            </a:pPr>
+            <a:r>
+              <a:rPr/>
+              <a:t>The sentence to land: a point with zero loss stops pulling on the answer. That is where support vectors come from - and why logistic regression never has any. Handout section 5.2.</a:t>
             </a:r>
           </a:p>
         </p:txBody>
@@ -5458,55 +5445,49 @@
             </a:pPr>
             <a:r>
               <a:rPr/>
-              <a:t>Third appearance of the same idea, and say so - that repetition is the point. Lesson 3 had λ, this morning had k, now C. Every model has one knob that trades fitting this data against surviving the next, and recognising it in an unfamiliar model is worth more than memorising three names.</a:t>
-            </a:r>
-          </a:p>
-          <a:p>
-            <a:pPr lvl="0" indent="0" marL="0">
-              <a:buNone/>
-            </a:pPr>
-          </a:p>
-          <a:p>
-            <a:pPr lvl="0" indent="0" marL="0">
-              <a:buNone/>
-            </a:pPr>
-            <a:r>
-              <a:rPr/>
-              <a:t>Then the direction, which catches people out constantly and is worth writing on the board. Large λ means MORE regularisation. Large C means LESS. They run opposite ways, and scikit-learn’s </a:t>
-            </a:r>
-            <a:r>
-              <a:rPr>
-                <a:latin typeface="Courier"/>
-              </a:rPr>
-              <a:t>C</a:t>
-            </a:r>
-            <a:r>
-              <a:rPr/>
-              <a:t> parameter in </a:t>
-            </a:r>
-            <a:r>
-              <a:rPr>
-                <a:latin typeface="Courier"/>
-              </a:rPr>
-              <a:t>LogisticRegression</a:t>
-            </a:r>
-            <a:r>
-              <a:rPr/>
-              <a:t> has the same inverted convention - it is the reciprocal of the penalty there too.</a:t>
-            </a:r>
-          </a:p>
-          <a:p>
-            <a:pPr lvl="0" indent="0" marL="0">
-              <a:buNone/>
-            </a:pPr>
-          </a:p>
-          <a:p>
-            <a:pPr lvl="0" indent="0" marL="0">
-              <a:buNone/>
-            </a:pPr>
-            <a:r>
-              <a:rPr/>
-              <a:t>Ask them which way they would expect C to run before you tell them. Most guess wrong, and having guessed wrong once is what makes it stick.</a:t>
+              <a:t>The constraint is not on the slide any more - it made the line wide enough to land at 28pt - so state it: subject to y_i(w’x_i + b) &gt;= 1 - xi_i, every point on the right side of the slab by a margin, or paying xi_i for the shortfall. Handout section 5.2 writes it out.</a:t>
+            </a:r>
+          </a:p>
+          <a:p>
+            <a:pPr lvl="0" indent="0" marL="0">
+              <a:buNone/>
+            </a:pPr>
+          </a:p>
+          <a:p>
+            <a:pPr lvl="0" indent="0" marL="0">
+              <a:buNone/>
+            </a:pPr>
+            <a:r>
+              <a:rPr/>
+              <a:t>Do not derive this. State what each piece is doing and move on - handout section 5.2 has the derivation, including why maximising the margin is the same as minimising the norm of w.</a:t>
+            </a:r>
+          </a:p>
+          <a:p>
+            <a:pPr lvl="0" indent="0" marL="0">
+              <a:buNone/>
+            </a:pPr>
+          </a:p>
+          <a:p>
+            <a:pPr lvl="0" indent="0" marL="0">
+              <a:buNone/>
+            </a:pPr>
+            <a:r>
+              <a:rPr/>
+              <a:t>The first term wants a wide slab. The second term wants few violations. C sets the exchange rate between them, and that is the entire content of the expression. Read it out in those words rather than reading the symbols.</a:t>
+            </a:r>
+          </a:p>
+          <a:p>
+            <a:pPr lvl="0" indent="0" marL="0">
+              <a:buNone/>
+            </a:pPr>
+          </a:p>
+          <a:p>
+            <a:pPr lvl="0" indent="0" marL="0">
+              <a:buNone/>
+            </a:pPr>
+            <a:r>
+              <a:rPr/>
+              <a:t>If someone asks about the half in front of the norm: it is there to make the derivative tidy, exactly as in lesson 3’s cost function.</a:t>
             </a:r>
           </a:p>
         </p:txBody>
@@ -5588,49 +5569,55 @@
             </a:pPr>
             <a:r>
               <a:rPr/>
-              <a:t>The linear kernel scores 0.613 - the base rate, exactly as logistic regression did this morning, with the same zero variance across folds.</a:t>
-            </a:r>
-          </a:p>
-          <a:p>
-            <a:pPr lvl="0" indent="0" marL="0">
-              <a:buNone/>
-            </a:pPr>
-          </a:p>
-          <a:p>
-            <a:pPr lvl="0" indent="0" marL="0">
-              <a:buNone/>
-            </a:pPr>
-            <a:r>
-              <a:rPr/>
-              <a:t>Make the point explicitly, because it is the one students most often get backwards: the margin criterion is a better way of CHOOSING among straight lines. It does not give you anything other than a straight line. When no straight line works, choosing the best one optimally still gets you nothing. A better criterion cannot rescue an inadequate hypothesis class.</a:t>
-            </a:r>
-          </a:p>
-          <a:p>
-            <a:pPr lvl="0" indent="0" marL="0">
-              <a:buNone/>
-            </a:pPr>
-          </a:p>
-          <a:p>
-            <a:pPr lvl="0" indent="0" marL="0">
-              <a:buNone/>
-            </a:pPr>
-            <a:r>
-              <a:rPr/>
-              <a:t>Then the RBF row, which is the same algorithm with one argument changed, at 0.947 - the best number in the whole lesson, and within a hair of the 0.96 ceiling.</a:t>
-            </a:r>
-          </a:p>
-          <a:p>
-            <a:pPr lvl="0" indent="0" marL="0">
-              <a:buNone/>
-            </a:pPr>
-          </a:p>
-          <a:p>
-            <a:pPr lvl="0" indent="0" marL="0">
-              <a:buNone/>
-            </a:pPr>
-            <a:r>
-              <a:rPr/>
-              <a:t>The support-vector column says the same thing in a second language, and that is the next slide.</a:t>
+              <a:t>Third appearance of the same idea, and say so - that repetition is the point. Lesson 3 had λ, this morning had k, now C. Every model has one knob that trades fitting this data against surviving the next, and recognising it in an unfamiliar model is worth more than memorising three names.</a:t>
+            </a:r>
+          </a:p>
+          <a:p>
+            <a:pPr lvl="0" indent="0" marL="0">
+              <a:buNone/>
+            </a:pPr>
+          </a:p>
+          <a:p>
+            <a:pPr lvl="0" indent="0" marL="0">
+              <a:buNone/>
+            </a:pPr>
+            <a:r>
+              <a:rPr/>
+              <a:t>Then the direction, which catches people out constantly and is worth writing on the board. Large λ means MORE regularisation. Large C means LESS. They run opposite ways, and scikit-learn’s </a:t>
+            </a:r>
+            <a:r>
+              <a:rPr>
+                <a:latin typeface="Courier"/>
+              </a:rPr>
+              <a:t>C</a:t>
+            </a:r>
+            <a:r>
+              <a:rPr/>
+              <a:t> parameter in </a:t>
+            </a:r>
+            <a:r>
+              <a:rPr>
+                <a:latin typeface="Courier"/>
+              </a:rPr>
+              <a:t>LogisticRegression</a:t>
+            </a:r>
+            <a:r>
+              <a:rPr/>
+              <a:t> has the same inverted convention - it is the reciprocal of the penalty there too.</a:t>
+            </a:r>
+          </a:p>
+          <a:p>
+            <a:pPr lvl="0" indent="0" marL="0">
+              <a:buNone/>
+            </a:pPr>
+          </a:p>
+          <a:p>
+            <a:pPr lvl="0" indent="0" marL="0">
+              <a:buNone/>
+            </a:pPr>
+            <a:r>
+              <a:rPr/>
+              <a:t>Ask them which way they would expect C to run before you tell them. Most guess wrong, and having guessed wrong once is what makes it stick.</a:t>
             </a:r>
           </a:p>
         </p:txBody>
@@ -5712,59 +5699,49 @@
             </a:pPr>
             <a:r>
               <a:rPr/>
-              <a:t>Explain what 79% actually means geometrically. A support vector is a point on the margin or inside it. If 79% of your data is in that position, there is no region of empty space between the classes at all - the model has been forced to place a boundary through a crowd.</a:t>
-            </a:r>
-          </a:p>
-          <a:p>
-            <a:pPr lvl="0" indent="0" marL="0">
-              <a:buNone/>
-            </a:pPr>
-          </a:p>
-          <a:p>
-            <a:pPr lvl="0" indent="0" marL="0">
-              <a:buNone/>
-            </a:pPr>
-            <a:r>
-              <a:rPr/>
-              <a:t>Contrast with 23%, where the model found genuine room and only the points near the edge matter.</a:t>
-            </a:r>
-          </a:p>
-          <a:p>
-            <a:pPr lvl="0" indent="0" marL="0">
-              <a:buNone/>
-            </a:pPr>
-          </a:p>
-          <a:p>
-            <a:pPr lvl="0" indent="0" marL="0">
-              <a:buNone/>
-            </a:pPr>
-            <a:r>
-              <a:rPr/>
-              <a:t>Give them the diagnostic to keep, since it costs nothing: after fitting an SVM, look at </a:t>
-            </a:r>
-            <a:r>
-              <a:rPr>
-                <a:latin typeface="Courier"/>
-              </a:rPr>
-              <a:t>len(model.support_)</a:t>
-            </a:r>
-            <a:r>
-              <a:rPr/>
-              <a:t> over the number of training rows. High means the model is struggling to find room, which usually means the kernel is wrong for the geometry. It is a warning available BEFORE you cross-validate anything.</a:t>
-            </a:r>
-          </a:p>
-          <a:p>
-            <a:pPr lvl="0" indent="0" marL="0">
-              <a:buNone/>
-            </a:pPr>
-          </a:p>
-          <a:p>
-            <a:pPr lvl="0" indent="0" marL="0">
-              <a:buNone/>
-            </a:pPr>
-            <a:r>
-              <a:rPr/>
-              <a:t>Worth adding that it also predicts prediction cost - every support vector is one kernel evaluation per query, so a model needing 79% of the data has thrown away most of the speed advantage over k-NN.</a:t>
+              <a:t>The linear kernel scores 0.613 - the base rate, exactly as logistic regression did this morning, with the same zero variance across folds.</a:t>
+            </a:r>
+          </a:p>
+          <a:p>
+            <a:pPr lvl="0" indent="0" marL="0">
+              <a:buNone/>
+            </a:pPr>
+          </a:p>
+          <a:p>
+            <a:pPr lvl="0" indent="0" marL="0">
+              <a:buNone/>
+            </a:pPr>
+            <a:r>
+              <a:rPr/>
+              <a:t>Make the point explicitly, because it is the one students most often get backwards: the margin criterion is a better way of CHOOSING among straight lines. It does not give you anything other than a straight line. When no straight line works, choosing the best one optimally still gets you nothing. A better criterion cannot rescue an inadequate hypothesis class.</a:t>
+            </a:r>
+          </a:p>
+          <a:p>
+            <a:pPr lvl="0" indent="0" marL="0">
+              <a:buNone/>
+            </a:pPr>
+          </a:p>
+          <a:p>
+            <a:pPr lvl="0" indent="0" marL="0">
+              <a:buNone/>
+            </a:pPr>
+            <a:r>
+              <a:rPr/>
+              <a:t>Then the RBF row, which is the same algorithm with one argument changed, at 0.947 - the best number in the whole lesson, and within a hair of the 0.96 ceiling.</a:t>
+            </a:r>
+          </a:p>
+          <a:p>
+            <a:pPr lvl="0" indent="0" marL="0">
+              <a:buNone/>
+            </a:pPr>
+          </a:p>
+          <a:p>
+            <a:pPr lvl="0" indent="0" marL="0">
+              <a:buNone/>
+            </a:pPr>
+            <a:r>
+              <a:rPr/>
+              <a:t>The support-vector column says the same thing in a second language, and that is the next slide.</a:t>
             </a:r>
           </a:p>
         </p:txBody>
@@ -5846,49 +5823,59 @@
             </a:pPr>
             <a:r>
               <a:rPr/>
-              <a:t>Build the picture in words first and let them see it before the figure appears. Take the scatter plot from the start of the lesson, lift each point off the page by its distance from the centre, and look from the side.</a:t>
-            </a:r>
-          </a:p>
-          <a:p>
-            <a:pPr lvl="0" indent="0" marL="0">
-              <a:buNone/>
-            </a:pPr>
-          </a:p>
-          <a:p>
-            <a:pPr lvl="0" indent="0" marL="0">
-              <a:buNone/>
-            </a:pPr>
-            <a:r>
-              <a:rPr/>
-              <a:t>Then the sentence that reframes the whole afternoon: the classes were never inseparable. Separability is not a property of the data - it is a property of the data AND the coordinates you happen to have measured it in.</a:t>
-            </a:r>
-          </a:p>
-          <a:p>
-            <a:pPr lvl="0" indent="0" marL="0">
-              <a:buNone/>
-            </a:pPr>
-          </a:p>
-          <a:p>
-            <a:pPr lvl="0" indent="0" marL="0">
-              <a:buNone/>
-            </a:pPr>
-            <a:r>
-              <a:rPr/>
-              <a:t>Ask what is unsatisfying about what we just did, and wait for it. We chose that lift by already knowing the answer. We knew the fault mode was radial. In any real problem you do not, and inventing the right coordinate is the hard part - which is exactly the difficulty the kernel trick removes.</a:t>
-            </a:r>
-          </a:p>
-          <a:p>
-            <a:pPr lvl="0" indent="0" marL="0">
-              <a:buNone/>
-            </a:pPr>
-          </a:p>
-          <a:p>
-            <a:pPr lvl="0" indent="0" marL="0">
-              <a:buNone/>
-            </a:pPr>
-            <a:r>
-              <a:rPr/>
-              <a:t>Handout section 5.4.</a:t>
+              <a:t>Explain what 79% actually means geometrically. A support vector is a point on the margin or inside it. If 79% of your data is in that position, there is no region of empty space between the classes at all - the model has been forced to place a boundary through a crowd.</a:t>
+            </a:r>
+          </a:p>
+          <a:p>
+            <a:pPr lvl="0" indent="0" marL="0">
+              <a:buNone/>
+            </a:pPr>
+          </a:p>
+          <a:p>
+            <a:pPr lvl="0" indent="0" marL="0">
+              <a:buNone/>
+            </a:pPr>
+            <a:r>
+              <a:rPr/>
+              <a:t>Contrast with 23%, where the model found genuine room and only the points near the edge matter.</a:t>
+            </a:r>
+          </a:p>
+          <a:p>
+            <a:pPr lvl="0" indent="0" marL="0">
+              <a:buNone/>
+            </a:pPr>
+          </a:p>
+          <a:p>
+            <a:pPr lvl="0" indent="0" marL="0">
+              <a:buNone/>
+            </a:pPr>
+            <a:r>
+              <a:rPr/>
+              <a:t>Give them the diagnostic to keep, since it costs nothing: after fitting an SVM, look at </a:t>
+            </a:r>
+            <a:r>
+              <a:rPr>
+                <a:latin typeface="Courier"/>
+              </a:rPr>
+              <a:t>len(model.support_)</a:t>
+            </a:r>
+            <a:r>
+              <a:rPr/>
+              <a:t> over the number of training rows. High means the model is struggling to find room, which usually means the kernel is wrong for the geometry. It is a warning available BEFORE you cross-validate anything.</a:t>
+            </a:r>
+          </a:p>
+          <a:p>
+            <a:pPr lvl="0" indent="0" marL="0">
+              <a:buNone/>
+            </a:pPr>
+          </a:p>
+          <a:p>
+            <a:pPr lvl="0" indent="0" marL="0">
+              <a:buNone/>
+            </a:pPr>
+            <a:r>
+              <a:rPr/>
+              <a:t>Worth adding that it also predicts prediction cost - every support vector is one kernel evaluation per query, so a model needing 79% of the data has thrown away most of the speed advantage over k-NN.</a:t>
             </a:r>
           </a:p>
         </p:txBody>
@@ -6102,35 +6089,49 @@
             </a:pPr>
             <a:r>
               <a:rPr/>
-              <a:t>The same 1,200 pumps twice: on the left in the plane where they were measured, on the right lifted by their distance from the design point. The gold plane does what no line could.</a:t>
-            </a:r>
-          </a:p>
-          <a:p>
-            <a:pPr lvl="0" indent="0" marL="0">
-              <a:buNone/>
-            </a:pPr>
-          </a:p>
-          <a:p>
-            <a:pPr lvl="0" indent="0" marL="0">
-              <a:buNone/>
-            </a:pPr>
-            <a:r>
-              <a:rPr/>
-              <a:t>Have them look at the right panel and confirm for themselves that a flat horizontal cut separates the colours cleanly. Nothing was added - no new measurement, no extra sensor. The third coordinate is computed from the two they already had.</a:t>
-            </a:r>
-          </a:p>
-          <a:p>
-            <a:pPr lvl="0" indent="0" marL="0">
-              <a:buNone/>
-            </a:pPr>
-          </a:p>
-          <a:p>
-            <a:pPr lvl="0" indent="0" marL="0">
-              <a:buNone/>
-            </a:pPr>
-            <a:r>
-              <a:rPr/>
-              <a:t>Then set up the objection that the next slide answers. This worked because the lift was three-dimensional and we could guess it. The spaces that work in general are enormous - the useful ones are sometimes infinite-dimensional - and computing the coordinates of every point in such a space is impossible.</a:t>
+              <a:t>Build the picture in words first and let them see it before the figure appears. Take the scatter plot from the start of the lesson, lift each point off the page by its distance from the centre, and look from the side.</a:t>
+            </a:r>
+          </a:p>
+          <a:p>
+            <a:pPr lvl="0" indent="0" marL="0">
+              <a:buNone/>
+            </a:pPr>
+          </a:p>
+          <a:p>
+            <a:pPr lvl="0" indent="0" marL="0">
+              <a:buNone/>
+            </a:pPr>
+            <a:r>
+              <a:rPr/>
+              <a:t>Then the sentence that reframes the whole afternoon: the classes were never inseparable. Separability is not a property of the data - it is a property of the data AND the coordinates you happen to have measured it in.</a:t>
+            </a:r>
+          </a:p>
+          <a:p>
+            <a:pPr lvl="0" indent="0" marL="0">
+              <a:buNone/>
+            </a:pPr>
+          </a:p>
+          <a:p>
+            <a:pPr lvl="0" indent="0" marL="0">
+              <a:buNone/>
+            </a:pPr>
+            <a:r>
+              <a:rPr/>
+              <a:t>Ask what is unsatisfying about what we just did, and wait for it. We chose that lift by already knowing the answer. We knew the fault mode was radial. In any real problem you do not, and inventing the right coordinate is the hard part - which is exactly the difficulty the kernel trick removes.</a:t>
+            </a:r>
+          </a:p>
+          <a:p>
+            <a:pPr lvl="0" indent="0" marL="0">
+              <a:buNone/>
+            </a:pPr>
+          </a:p>
+          <a:p>
+            <a:pPr lvl="0" indent="0" marL="0">
+              <a:buNone/>
+            </a:pPr>
+            <a:r>
+              <a:rPr/>
+              <a:t>Handout section 5.4.</a:t>
             </a:r>
           </a:p>
         </p:txBody>
@@ -6212,35 +6213,35 @@
             </a:pPr>
             <a:r>
               <a:rPr/>
-              <a:t>The trick in one sentence: the SVM never needs the coordinates, only the angles and lengths between points, and those can be obtained without ever going there.</a:t>
-            </a:r>
-          </a:p>
-          <a:p>
-            <a:pPr lvl="0" indent="0" marL="0">
-              <a:buNone/>
-            </a:pPr>
-          </a:p>
-          <a:p>
-            <a:pPr lvl="0" indent="0" marL="0">
-              <a:buNone/>
-            </a:pPr>
-            <a:r>
-              <a:rPr/>
-              <a:t>Do not prove it - handout section 5.4 shows where the inner products come from in the dual formulation. The claim to state and let land is that a function of two ordinary two-dimensional vectors returns their inner product in a space of infinite dimension, at the cost of one exponential.</a:t>
-            </a:r>
-          </a:p>
-          <a:p>
-            <a:pPr lvl="0" indent="0" marL="0">
-              <a:buNone/>
-            </a:pPr>
-          </a:p>
-          <a:p>
-            <a:pPr lvl="0" indent="0" marL="0">
-              <a:buNone/>
-            </a:pPr>
-            <a:r>
-              <a:rPr/>
-              <a:t>And close the loop from the previous slide: we chose the lift in the picture by knowing the answer. The RBF kernel does something equivalent without being told, which is exactly why it works on problems where nobody could guess the right coordinates.</a:t>
+              <a:t>The same 1,200 pumps twice: on the left in the plane where they were measured, on the right lifted by their distance from the design point. The gold plane does what no line could.</a:t>
+            </a:r>
+          </a:p>
+          <a:p>
+            <a:pPr lvl="0" indent="0" marL="0">
+              <a:buNone/>
+            </a:pPr>
+          </a:p>
+          <a:p>
+            <a:pPr lvl="0" indent="0" marL="0">
+              <a:buNone/>
+            </a:pPr>
+            <a:r>
+              <a:rPr/>
+              <a:t>Have them look at the right panel and confirm for themselves that a flat horizontal cut separates the colours cleanly. Nothing was added - no new measurement, no extra sensor. The third coordinate is computed from the two they already had.</a:t>
+            </a:r>
+          </a:p>
+          <a:p>
+            <a:pPr lvl="0" indent="0" marL="0">
+              <a:buNone/>
+            </a:pPr>
+          </a:p>
+          <a:p>
+            <a:pPr lvl="0" indent="0" marL="0">
+              <a:buNone/>
+            </a:pPr>
+            <a:r>
+              <a:rPr/>
+              <a:t>Then set up the objection that the next slide answers. This worked because the lift was three-dimensional and we could guess it. The spaces that work in general are enormous - the useful ones are sometimes infinite-dimensional - and computing the coordinates of every point in such a space is impossible.</a:t>
             </a:r>
           </a:p>
         </p:txBody>
@@ -6322,35 +6323,35 @@
             </a:pPr>
             <a:r>
               <a:rPr/>
-              <a:t>Make the trick concrete before the famous formula. The lift here lists every product of two coordinates: phi(x) = (x1², √2·x1·x2, x2²). Two points, a = (1, 2) and b = (3, 1).</a:t>
-            </a:r>
-          </a:p>
-          <a:p>
-            <a:pPr lvl="0" indent="0" marL="0">
-              <a:buNone/>
-            </a:pPr>
-          </a:p>
-          <a:p>
-            <a:pPr lvl="0" indent="0" marL="0">
-              <a:buNone/>
-            </a:pPr>
-            <a:r>
-              <a:rPr/>
-              <a:t>First row: lift both into three dimensions and take the ordinary inner product - 9 + 12 + 4 = 25. Second row: never lift, take the inner product in the plane, 5, and square it - 25. Same number. The second route never left two dimensions, so the function (a · b)² IS the inner product in the lifted space. That is all a kernel is.</a:t>
-            </a:r>
-          </a:p>
-          <a:p>
-            <a:pPr lvl="0" indent="0" marL="0">
-              <a:buNone/>
-            </a:pPr>
-          </a:p>
-          <a:p>
-            <a:pPr lvl="0" indent="0" marL="0">
-              <a:buNone/>
-            </a:pPr>
-            <a:r>
-              <a:rPr/>
-              <a:t>Then connect it to the figure they just saw: the lifted space contains x1² and x2², and their sum is the squared distance from the centre - the coordinate we chose by hand. A flat plane there is a circle down here. The kernel found the lift we had to guess. Handout section 5.4.</a:t>
+              <a:t>The trick in one sentence: the SVM never needs the coordinates, only the angles and lengths between points, and those can be obtained without ever going there.</a:t>
+            </a:r>
+          </a:p>
+          <a:p>
+            <a:pPr lvl="0" indent="0" marL="0">
+              <a:buNone/>
+            </a:pPr>
+          </a:p>
+          <a:p>
+            <a:pPr lvl="0" indent="0" marL="0">
+              <a:buNone/>
+            </a:pPr>
+            <a:r>
+              <a:rPr/>
+              <a:t>Do not prove it - handout section 5.4 shows where the inner products come from in the dual formulation. The claim to state and let land is that a function of two ordinary two-dimensional vectors returns their inner product in a space of infinite dimension, at the cost of one exponential.</a:t>
+            </a:r>
+          </a:p>
+          <a:p>
+            <a:pPr lvl="0" indent="0" marL="0">
+              <a:buNone/>
+            </a:pPr>
+          </a:p>
+          <a:p>
+            <a:pPr lvl="0" indent="0" marL="0">
+              <a:buNone/>
+            </a:pPr>
+            <a:r>
+              <a:rPr/>
+              <a:t>And close the loop from the previous slide: we chose the lift in the picture by knowing the answer. The RBF kernel does something equivalent without being told, which is exactly why it works on problems where nobody could guess the right coordinates.</a:t>
             </a:r>
           </a:p>
         </p:txBody>
@@ -6432,73 +6433,35 @@
             </a:pPr>
             <a:r>
               <a:rPr/>
-              <a:t>One line, and it is the whole of what scikit-learn does when you leave </a:t>
-            </a:r>
-            <a:r>
-              <a:rPr>
-                <a:latin typeface="Courier"/>
-              </a:rPr>
-              <a:t>kernel</a:t>
-            </a:r>
-            <a:r>
-              <a:rPr/>
-              <a:t> at its default.</a:t>
-            </a:r>
-          </a:p>
-          <a:p>
-            <a:pPr lvl="0" indent="0" marL="0">
-              <a:buNone/>
-            </a:pPr>
-          </a:p>
-          <a:p>
-            <a:pPr lvl="0" indent="0" marL="0">
-              <a:buNone/>
-            </a:pPr>
-            <a:r>
-              <a:rPr/>
-              <a:t>Read it aloud as a similarity rather than as a formula: the closer two points are, the nearer the exponent is to zero and the nearer the kernel is to one; far apart, it falls away to nothing. That is all an RBF kernel says - how much does this point look like that one.</a:t>
-            </a:r>
-          </a:p>
-          <a:p>
-            <a:pPr lvl="0" indent="0" marL="0">
-              <a:buNone/>
-            </a:pPr>
-          </a:p>
-          <a:p>
-            <a:pPr lvl="0" indent="0" marL="0">
-              <a:buNone/>
-            </a:pPr>
-            <a:r>
-              <a:rPr/>
-              <a:t>Now say what γ means, because the next two slides turn on it: it sets how far a single training point’s influence reaches. Small γ, wide reach, smooth boundary. Large γ, each point influences only its immediate neighbourhood - and a boundary that can afford an island around every mislabelled pump.</a:t>
-            </a:r>
-          </a:p>
-          <a:p>
-            <a:pPr lvl="0" indent="0" marL="0">
-              <a:buNone/>
-            </a:pPr>
-          </a:p>
-          <a:p>
-            <a:pPr lvl="0" indent="0" marL="0">
-              <a:buNone/>
-            </a:pPr>
-            <a:r>
-              <a:rPr/>
-              <a:t>A number to anchor it: the similarity halves at a distance of sqrt(ln 2 / γ). For scikit-learn’s default on the standardised pumps, γ = 0.5, that is about 1.2 standard deviations.</a:t>
-            </a:r>
-          </a:p>
-          <a:p>
-            <a:pPr lvl="0" indent="0" marL="0">
-              <a:buNone/>
-            </a:pPr>
-          </a:p>
-          <a:p>
-            <a:pPr lvl="0" indent="0" marL="0">
-              <a:buNone/>
-            </a:pPr>
-            <a:r>
-              <a:rPr/>
-              <a:t>Worth naming the cost, since this is an engineering course: one exponential per pair of points, so the kernel matrix is m × m. That is why support vector machines are a poor fit above a hundred thousand rows, and it is a property of the method rather than of the implementation.</a:t>
+              <a:t>Make the trick concrete before the famous formula. The lift here lists every product of two coordinates: phi(x) = (x1², √2·x1·x2, x2²). Two points, a = (1, 2) and b = (3, 1).</a:t>
+            </a:r>
+          </a:p>
+          <a:p>
+            <a:pPr lvl="0" indent="0" marL="0">
+              <a:buNone/>
+            </a:pPr>
+          </a:p>
+          <a:p>
+            <a:pPr lvl="0" indent="0" marL="0">
+              <a:buNone/>
+            </a:pPr>
+            <a:r>
+              <a:rPr/>
+              <a:t>First row: lift both into three dimensions and take the ordinary inner product - 9 + 12 + 4 = 25. Second row: never lift, take the inner product in the plane, 5, and square it - 25. Same number. The second route never left two dimensions, so the function (a · b)² IS the inner product in the lifted space. That is all a kernel is.</a:t>
+            </a:r>
+          </a:p>
+          <a:p>
+            <a:pPr lvl="0" indent="0" marL="0">
+              <a:buNone/>
+            </a:pPr>
+          </a:p>
+          <a:p>
+            <a:pPr lvl="0" indent="0" marL="0">
+              <a:buNone/>
+            </a:pPr>
+            <a:r>
+              <a:rPr/>
+              <a:t>Then connect it to the figure they just saw: the lifted space contains x1² and x2², and their sum is the squared distance from the centre - the coordinate we chose by hand. A flat plane there is a circle down here. The kernel found the lift we had to guess. Handout section 5.4.</a:t>
             </a:r>
           </a:p>
         </p:txBody>
@@ -6580,35 +6543,73 @@
             </a:pPr>
             <a:r>
               <a:rPr/>
-              <a:t>Say what “fit” does, because after lesson 3 they will expect gradient descent. It is not. The SVM solves the dual: one weight per training point, found by a solver that picks two weights at a time - two, because the weights times the labels must sum to zero, so one cannot move alone - sets them to their best values with the rest fixed, and repeats until nothing improves. Convex, so there is one answer and it is found every time.</a:t>
-            </a:r>
-          </a:p>
-          <a:p>
-            <a:pPr lvl="0" indent="0" marL="0">
-              <a:buNone/>
-            </a:pPr>
-          </a:p>
-          <a:p>
-            <a:pPr lvl="0" indent="0" marL="0">
-              <a:buNone/>
-            </a:pPr>
-            <a:r>
-              <a:rPr/>
-              <a:t>Then the counts, which match the three cases of the slack from earlier. Weight zero: the 922 pumps safely on their own side, which the model now forgets. Weight at the ceiling C: the 268 inside the slab or on the wrong side - with C = 1 that weight is exactly 1, so each of them simply votes with its label. Between: the 10 sitting exactly on the edge.</a:t>
-            </a:r>
-          </a:p>
-          <a:p>
-            <a:pPr lvl="0" indent="0" marL="0">
-              <a:buNone/>
-            </a:pPr>
-          </a:p>
-          <a:p>
-            <a:pPr lvl="0" indent="0" marL="0">
-              <a:buNone/>
-            </a:pPr>
-            <a:r>
-              <a:rPr/>
-              <a:t>The model you ship is 278 points and their weights. Handout section 5.5.</a:t>
+              <a:t>One line, and it is the whole of what scikit-learn does when you leave </a:t>
+            </a:r>
+            <a:r>
+              <a:rPr>
+                <a:latin typeface="Courier"/>
+              </a:rPr>
+              <a:t>kernel</a:t>
+            </a:r>
+            <a:r>
+              <a:rPr/>
+              <a:t> at its default.</a:t>
+            </a:r>
+          </a:p>
+          <a:p>
+            <a:pPr lvl="0" indent="0" marL="0">
+              <a:buNone/>
+            </a:pPr>
+          </a:p>
+          <a:p>
+            <a:pPr lvl="0" indent="0" marL="0">
+              <a:buNone/>
+            </a:pPr>
+            <a:r>
+              <a:rPr/>
+              <a:t>Read it aloud as a similarity rather than as a formula: the closer two points are, the nearer the exponent is to zero and the nearer the kernel is to one; far apart, it falls away to nothing. That is all an RBF kernel says - how much does this point look like that one.</a:t>
+            </a:r>
+          </a:p>
+          <a:p>
+            <a:pPr lvl="0" indent="0" marL="0">
+              <a:buNone/>
+            </a:pPr>
+          </a:p>
+          <a:p>
+            <a:pPr lvl="0" indent="0" marL="0">
+              <a:buNone/>
+            </a:pPr>
+            <a:r>
+              <a:rPr/>
+              <a:t>Now say what γ means, because the next two slides turn on it: it sets how far a single training point’s influence reaches. Small γ, wide reach, smooth boundary. Large γ, each point influences only its immediate neighbourhood - and a boundary that can afford an island around every mislabelled pump.</a:t>
+            </a:r>
+          </a:p>
+          <a:p>
+            <a:pPr lvl="0" indent="0" marL="0">
+              <a:buNone/>
+            </a:pPr>
+          </a:p>
+          <a:p>
+            <a:pPr lvl="0" indent="0" marL="0">
+              <a:buNone/>
+            </a:pPr>
+            <a:r>
+              <a:rPr/>
+              <a:t>A number to anchor it: the similarity halves at a distance of sqrt(ln 2 / γ). For scikit-learn’s default on the standardised pumps, γ = 0.5, that is about 1.2 standard deviations.</a:t>
+            </a:r>
+          </a:p>
+          <a:p>
+            <a:pPr lvl="0" indent="0" marL="0">
+              <a:buNone/>
+            </a:pPr>
+          </a:p>
+          <a:p>
+            <a:pPr lvl="0" indent="0" marL="0">
+              <a:buNone/>
+            </a:pPr>
+            <a:r>
+              <a:rPr/>
+              <a:t>Worth naming the cost, since this is an engineering course: one exponential per pair of points, so the kernel matrix is m × m. That is why support vector machines are a poor fit above a hundred thousand rows, and it is a property of the method rather than of the implementation.</a:t>
             </a:r>
           </a:p>
         </p:txBody>
@@ -6690,35 +6691,35 @@
             </a:pPr>
             <a:r>
               <a:rPr/>
-              <a:t>Inference is a vote, in four steps. Standardise the pump with the training scaler. Compute its RBF similarity to each of the 278 support vectors. Add up weight times label times similarity - label +1 for faulty, -1 for healthy - and add b. Read the sign. Nothing else goes in: the total is exactly what decision_function returns.</a:t>
-            </a:r>
-          </a:p>
-          <a:p>
-            <a:pPr lvl="0" indent="0" marL="0">
-              <a:buNone/>
-            </a:pPr>
-          </a:p>
-          <a:p>
-            <a:pPr lvl="0" indent="0" marL="0">
-              <a:buNone/>
-            </a:pPr>
-            <a:r>
-              <a:rPr/>
-              <a:t>The same pump Naive Bayes called faulty at 0.981, reached by a completely different route.</a:t>
-            </a:r>
-          </a:p>
-          <a:p>
-            <a:pPr lvl="0" indent="0" marL="0">
-              <a:buNone/>
-            </a:pPr>
-          </a:p>
-          <a:p>
-            <a:pPr lvl="0" indent="0" marL="0">
-              <a:buNone/>
-            </a:pPr>
-            <a:r>
-              <a:rPr/>
-              <a:t>The point to make: the neighbourhood decides. The 56 support vectors within about 1.2 standard deviations contribute a net +1.141 towards faulty; the other 222 only -0.363. But not one neighbour - the five nearest disagree, because pumps just outside the envelope are faulty and some just inside carry flipped labels. So the SVM is k-NN again, with a smooth similarity instead of a hard k, only the support vectors voting, and learned weights. And the output is a score, not a probability. Handout section 5.5.</a:t>
+              <a:t>Say what “fit” does, because after lesson 3 they will expect gradient descent. It is not. The SVM solves the dual: one weight per training point, found by a solver that picks two weights at a time - two, because the weights times the labels must sum to zero, so one cannot move alone - sets them to their best values with the rest fixed, and repeats until nothing improves. Convex, so there is one answer and it is found every time.</a:t>
+            </a:r>
+          </a:p>
+          <a:p>
+            <a:pPr lvl="0" indent="0" marL="0">
+              <a:buNone/>
+            </a:pPr>
+          </a:p>
+          <a:p>
+            <a:pPr lvl="0" indent="0" marL="0">
+              <a:buNone/>
+            </a:pPr>
+            <a:r>
+              <a:rPr/>
+              <a:t>Then the counts, which match the three cases of the slack from earlier. Weight zero: the 922 pumps safely on their own side, which the model now forgets. Weight at the ceiling C: the 268 inside the slab or on the wrong side - with C = 1 that weight is exactly 1, so each of them simply votes with its label. Between: the 10 sitting exactly on the edge.</a:t>
+            </a:r>
+          </a:p>
+          <a:p>
+            <a:pPr lvl="0" indent="0" marL="0">
+              <a:buNone/>
+            </a:pPr>
+          </a:p>
+          <a:p>
+            <a:pPr lvl="0" indent="0" marL="0">
+              <a:buNone/>
+            </a:pPr>
+            <a:r>
+              <a:rPr/>
+              <a:t>The model you ship is 278 points and their weights. Handout section 5.5.</a:t>
             </a:r>
           </a:p>
         </p:txBody>
@@ -6800,21 +6801,35 @@
             </a:pPr>
             <a:r>
               <a:rPr/>
-              <a:t>The table on the previous slide, drawn. Every support vector is sized and shaded by its similarity to the pump, the gold star at 48 Hz and 5.6 bar; the dashed ellipse is where similarity falls to one half, about 1.2 standard deviations; the black line is the SVM’s boundary.</a:t>
-            </a:r>
-          </a:p>
-          <a:p>
-            <a:pPr lvl="0" indent="0" marL="0">
-              <a:buNone/>
-            </a:pPr>
-          </a:p>
-          <a:p>
-            <a:pPr lvl="0" indent="0" marL="0">
-              <a:buNone/>
-            </a:pPr>
-            <a:r>
-              <a:rPr/>
-              <a:t>Point out where the weight is: the 56 support vectors inside the dashed ellipse carry most of it, the ones across the disc have faded out. Then point at the star’s immediate neighbours - teal and rust together, boundary pumps and flipped labels. That is why the five nearest nearly cancel, and why it is the neighbourhood’s balance, not one neighbour, that makes it faulty. Handout section 5.5.</a:t>
+              <a:t>Inference is a vote, in four steps. Standardise the pump with the training scaler. Compute its RBF similarity to each of the 278 support vectors. Add up weight times label times similarity - label +1 for faulty, -1 for healthy - and add b. Read the sign. Nothing else goes in: the total is exactly what decision_function returns.</a:t>
+            </a:r>
+          </a:p>
+          <a:p>
+            <a:pPr lvl="0" indent="0" marL="0">
+              <a:buNone/>
+            </a:pPr>
+          </a:p>
+          <a:p>
+            <a:pPr lvl="0" indent="0" marL="0">
+              <a:buNone/>
+            </a:pPr>
+            <a:r>
+              <a:rPr/>
+              <a:t>The same pump Naive Bayes called faulty at 0.981, reached by a completely different route.</a:t>
+            </a:r>
+          </a:p>
+          <a:p>
+            <a:pPr lvl="0" indent="0" marL="0">
+              <a:buNone/>
+            </a:pPr>
+          </a:p>
+          <a:p>
+            <a:pPr lvl="0" indent="0" marL="0">
+              <a:buNone/>
+            </a:pPr>
+            <a:r>
+              <a:rPr/>
+              <a:t>The point to make: the neighbourhood decides. The 56 support vectors within about 1.2 standard deviations contribute a net +1.141 towards faulty; the other 222 only -0.363. But not one neighbour - the five nearest disagree, because pumps just outside the envelope are faulty and some just inside carry flipped labels. So the SVM is k-NN again, with a smooth similarity instead of a hard k, only the support vectors voting, and learned weights. And the output is a score, not a probability. Handout section 5.5.</a:t>
             </a:r>
           </a:p>
         </p:txBody>
@@ -6896,53 +6911,21 @@
             </a:pPr>
             <a:r>
               <a:rPr/>
-              <a:t>Read the two columns against each other, exactly as lesson 5 taught, and let the last row do the work.</a:t>
-            </a:r>
-          </a:p>
-          <a:p>
-            <a:pPr lvl="0" indent="0" marL="0">
-              <a:buNone/>
-            </a:pPr>
-          </a:p>
-          <a:p>
-            <a:pPr lvl="0" indent="0" marL="0">
-              <a:buNone/>
-            </a:pPr>
-            <a:r>
-              <a:rPr/>
-              <a:t>The bottom row has the best training score on the slide - 0.995, nearly perfect - and the worst honest one. That is the signature of overfitting, and here it is not inferred from theory but measured on the same data by two different procedures.</a:t>
-            </a:r>
-          </a:p>
-          <a:p>
-            <a:pPr lvl="0" indent="0" marL="0">
-              <a:buNone/>
-            </a:pPr>
-          </a:p>
-          <a:p>
-            <a:pPr lvl="0" indent="0" marL="0">
-              <a:buNone/>
-            </a:pPr>
-            <a:r>
-              <a:rPr b="1"/>
-              <a:t>Now the second predictable mistake, and defend the instinct.</a:t>
-            </a:r>
-            <a:r>
-              <a:rPr/>
-              <a:t> Choosing between these three on the training score selects the WORST model, with complete confidence and a very impressive number to report. And the instinct behind it is not stupid: a higher score on the data you have is, in every other part of engineering, evidence of a better system. Fitting the data well is what we spent lessons 3 and 4 doing. What breaks the analogy is that a flexible model can fit data it has already been shown without learning anything transferable.</a:t>
-            </a:r>
-          </a:p>
-          <a:p>
-            <a:pPr lvl="0" indent="0" marL="0">
-              <a:buNone/>
-            </a:pPr>
-          </a:p>
-          <a:p>
-            <a:pPr lvl="0" indent="0" marL="0">
-              <a:buNone/>
-            </a:pPr>
-            <a:r>
-              <a:rPr/>
-              <a:t>The reason this table is on the slide rather than in the handout is that the next slide shows the same three settings as pictures - so the failure is visible as well as measurable, which is rare.</a:t>
+              <a:t>The table on the previous slide, drawn. Every support vector is sized and shaded by its similarity to the pump, the gold star at 48 Hz and 5.6 bar; the dashed ellipse is where similarity falls to one half, about 1.2 standard deviations; the black line is the SVM’s boundary.</a:t>
+            </a:r>
+          </a:p>
+          <a:p>
+            <a:pPr lvl="0" indent="0" marL="0">
+              <a:buNone/>
+            </a:pPr>
+          </a:p>
+          <a:p>
+            <a:pPr lvl="0" indent="0" marL="0">
+              <a:buNone/>
+            </a:pPr>
+            <a:r>
+              <a:rPr/>
+              <a:t>Point out where the weight is: the 56 support vectors inside the dashed ellipse carry most of it, the ones across the disc have faded out. Then point at the star’s immediate neighbours - teal and rust together, boundary pumps and flipped labels. That is why the five nearest nearly cancel, and why it is the neighbourhood’s balance, not one neighbour, that makes it faulty. Handout section 5.5.</a:t>
             </a:r>
           </a:p>
         </p:txBody>
@@ -7024,21 +7007,53 @@
             </a:pPr>
             <a:r>
               <a:rPr/>
-              <a:t>Gamma as a distance rather than a symbol. Each curve is the RBF similarity against the distance between two pumps; where it crosses the dotted line is the distance at which a support vector’s vote has halved: 2.63 standard deviations at gamma 0.1, 1.18 at the default 0.5, 0.83 at 1, and 0.12 at 50.</a:t>
-            </a:r>
-          </a:p>
-          <a:p>
-            <a:pPr lvl="0" indent="0" marL="0">
-              <a:buNone/>
-            </a:pPr>
-          </a:p>
-          <a:p>
-            <a:pPr lvl="0" indent="0" marL="0">
-              <a:buNone/>
-            </a:pPr>
-            <a:r>
-              <a:rPr/>
-              <a:t>Ask them to predict the next slide from this one: at gamma 50 a point speaks only for a neighbourhood a tenth of a standard deviation wide. What will the boundary look like? Islands. Handout section 5.6.</a:t>
+              <a:t>Read the two columns against each other, exactly as lesson 5 taught, and let the last row do the work.</a:t>
+            </a:r>
+          </a:p>
+          <a:p>
+            <a:pPr lvl="0" indent="0" marL="0">
+              <a:buNone/>
+            </a:pPr>
+          </a:p>
+          <a:p>
+            <a:pPr lvl="0" indent="0" marL="0">
+              <a:buNone/>
+            </a:pPr>
+            <a:r>
+              <a:rPr/>
+              <a:t>The bottom row has the best training score on the slide - 0.995, nearly perfect - and the worst honest one. That is the signature of overfitting, and here it is not inferred from theory but measured on the same data by two different procedures.</a:t>
+            </a:r>
+          </a:p>
+          <a:p>
+            <a:pPr lvl="0" indent="0" marL="0">
+              <a:buNone/>
+            </a:pPr>
+          </a:p>
+          <a:p>
+            <a:pPr lvl="0" indent="0" marL="0">
+              <a:buNone/>
+            </a:pPr>
+            <a:r>
+              <a:rPr b="1"/>
+              <a:t>Now the second predictable mistake, and defend the instinct.</a:t>
+            </a:r>
+            <a:r>
+              <a:rPr/>
+              <a:t> Choosing between these three on the training score selects the WORST model, with complete confidence and a very impressive number to report. And the instinct behind it is not stupid: a higher score on the data you have is, in every other part of engineering, evidence of a better system. Fitting the data well is what we spent lessons 3 and 4 doing. What breaks the analogy is that a flexible model can fit data it has already been shown without learning anything transferable.</a:t>
+            </a:r>
+          </a:p>
+          <a:p>
+            <a:pPr lvl="0" indent="0" marL="0">
+              <a:buNone/>
+            </a:pPr>
+          </a:p>
+          <a:p>
+            <a:pPr lvl="0" indent="0" marL="0">
+              <a:buNone/>
+            </a:pPr>
+            <a:r>
+              <a:rPr/>
+              <a:t>The reason this table is on the slide rather than in the handout is that the next slide shows the same three settings as pictures - so the failure is visible as well as measurable, which is rare.</a:t>
             </a:r>
           </a:p>
         </p:txBody>
@@ -7120,63 +7135,21 @@
             </a:pPr>
             <a:r>
               <a:rPr/>
-              <a:t>Three settings, with training and cross-validated scores in each title. Read them together.</a:t>
-            </a:r>
-          </a:p>
-          <a:p>
-            <a:pPr lvl="0" indent="0" marL="0">
-              <a:buNone/>
-            </a:pPr>
-          </a:p>
-          <a:p>
-            <a:pPr lvl="0" indent="0" marL="0">
-              <a:buNone/>
-            </a:pPr>
-            <a:r>
-              <a:rPr/>
-              <a:t>Left, γ = 0.1: a smooth boundary, slightly too smooth, and the two scores agree. Middle, γ = 1: close to the true envelope, and the best honest score.</a:t>
-            </a:r>
-          </a:p>
-          <a:p>
-            <a:pPr lvl="0" indent="0" marL="0">
-              <a:buNone/>
-            </a:pPr>
-          </a:p>
-          <a:p>
-            <a:pPr lvl="0" indent="0" marL="0">
-              <a:buNone/>
-            </a:pPr>
-            <a:r>
-              <a:rPr/>
-              <a:t>Right is the one to sit on. The boundary has broken into bubbles - small islands around individual points, including the mislabelled ones. That is what a 0.995 training score looks like from the outside: the model has drawn a private territory around each flipped label so that it can get it right.</a:t>
-            </a:r>
-          </a:p>
-          <a:p>
-            <a:pPr lvl="0" indent="0" marL="0">
-              <a:buNone/>
-            </a:pPr>
-          </a:p>
-          <a:p>
-            <a:pPr lvl="0" indent="0" marL="0">
-              <a:buNone/>
-            </a:pPr>
-            <a:r>
-              <a:rPr/>
-              <a:t>Ask them what happens to a new pump landing in the gap between two bubbles. That is the 0.902.</a:t>
-            </a:r>
-          </a:p>
-          <a:p>
-            <a:pPr lvl="0" indent="0" marL="0">
-              <a:buNone/>
-            </a:pPr>
-          </a:p>
-          <a:p>
-            <a:pPr lvl="0" indent="0" marL="0">
-              <a:buNone/>
-            </a:pPr>
-            <a:r>
-              <a:rPr/>
-              <a:t>The reason this slide matters more than the table: they have seen overfitting as a curve on a plot since lesson 5. Here it is a shape in the input space, and the shape is obviously wrong in a way no number is. When you can plot the boundary, plot it.</a:t>
+              <a:t>Gamma as a distance rather than a symbol. Each curve is the RBF similarity against the distance between two pumps; where it crosses the dotted line is the distance at which a support vector’s vote has halved: 2.63 standard deviations at gamma 0.1, 1.18 at the default 0.5, 0.83 at 1, and 0.12 at 50.</a:t>
+            </a:r>
+          </a:p>
+          <a:p>
+            <a:pPr lvl="0" indent="0" marL="0">
+              <a:buNone/>
+            </a:pPr>
+          </a:p>
+          <a:p>
+            <a:pPr lvl="0" indent="0" marL="0">
+              <a:buNone/>
+            </a:pPr>
+            <a:r>
+              <a:rPr/>
+              <a:t>Ask them to predict the next slide from this one: at gamma 50 a point speaks only for a neighbourhood a tenth of a standard deviation wide. What will the boundary look like? Islands. Handout section 5.6.</a:t>
             </a:r>
           </a:p>
         </p:txBody>
@@ -7382,49 +7355,63 @@
             </a:pPr>
             <a:r>
               <a:rPr/>
-              <a:t>Run notebooks/03. Sixteen minutes.</a:t>
-            </a:r>
-          </a:p>
-          <a:p>
-            <a:pPr lvl="0" indent="0" marL="0">
-              <a:buNone/>
-            </a:pPr>
-          </a:p>
-          <a:p>
-            <a:pPr lvl="0" indent="0" marL="0">
-              <a:buNone/>
-            </a:pPr>
-            <a:r>
-              <a:rPr/>
-              <a:t>The cell to protect is the γ sweep with the boundary drawn at each setting. Let them turn γ up themselves and watch the bubbles form - it is the most direct experience of overfitting available in this course.</a:t>
-            </a:r>
-          </a:p>
-          <a:p>
-            <a:pPr lvl="0" indent="0" marL="0">
-              <a:buNone/>
-            </a:pPr>
-          </a:p>
-          <a:p>
-            <a:pPr lvl="0" indent="0" marL="0">
-              <a:buNone/>
-            </a:pPr>
-            <a:r>
-              <a:rPr/>
-              <a:t>Have them print the support-vector fraction for the linear and RBF kernels side by side. Two numbers, and it makes the diagnostic real rather than a claim on a slide.</a:t>
-            </a:r>
-          </a:p>
-          <a:p>
-            <a:pPr lvl="0" indent="0" marL="0">
-              <a:buNone/>
-            </a:pPr>
-          </a:p>
-          <a:p>
-            <a:pPr lvl="0" indent="0" marL="0">
-              <a:buNone/>
-            </a:pPr>
-            <a:r>
-              <a:rPr/>
-              <a:t>If time runs short, skip the C sweep and set it as reading: the table is in handout section 5.6.</a:t>
+              <a:t>Three settings, with training and cross-validated scores in each title. Read them together.</a:t>
+            </a:r>
+          </a:p>
+          <a:p>
+            <a:pPr lvl="0" indent="0" marL="0">
+              <a:buNone/>
+            </a:pPr>
+          </a:p>
+          <a:p>
+            <a:pPr lvl="0" indent="0" marL="0">
+              <a:buNone/>
+            </a:pPr>
+            <a:r>
+              <a:rPr/>
+              <a:t>Left, γ = 0.1: a smooth boundary, slightly too smooth, and the two scores agree. Middle, γ = 1: close to the true envelope, and the best honest score.</a:t>
+            </a:r>
+          </a:p>
+          <a:p>
+            <a:pPr lvl="0" indent="0" marL="0">
+              <a:buNone/>
+            </a:pPr>
+          </a:p>
+          <a:p>
+            <a:pPr lvl="0" indent="0" marL="0">
+              <a:buNone/>
+            </a:pPr>
+            <a:r>
+              <a:rPr/>
+              <a:t>Right is the one to sit on. The boundary has broken into bubbles - small islands around individual points, including the mislabelled ones. That is what a 0.995 training score looks like from the outside: the model has drawn a private territory around each flipped label so that it can get it right.</a:t>
+            </a:r>
+          </a:p>
+          <a:p>
+            <a:pPr lvl="0" indent="0" marL="0">
+              <a:buNone/>
+            </a:pPr>
+          </a:p>
+          <a:p>
+            <a:pPr lvl="0" indent="0" marL="0">
+              <a:buNone/>
+            </a:pPr>
+            <a:r>
+              <a:rPr/>
+              <a:t>Ask them what happens to a new pump landing in the gap between two bubbles. That is the 0.902.</a:t>
+            </a:r>
+          </a:p>
+          <a:p>
+            <a:pPr lvl="0" indent="0" marL="0">
+              <a:buNone/>
+            </a:pPr>
+          </a:p>
+          <a:p>
+            <a:pPr lvl="0" indent="0" marL="0">
+              <a:buNone/>
+            </a:pPr>
+            <a:r>
+              <a:rPr/>
+              <a:t>The reason this slide matters more than the table: they have seen overfitting as a curve on a plot since lesson 5. Here it is a shape in the input space, and the shape is obviously wrong in a way no number is. When you can plot the boundary, plot it.</a:t>
             </a:r>
           </a:p>
         </p:txBody>
@@ -7506,57 +7493,49 @@
             </a:pPr>
             <a:r>
               <a:rPr/>
-              <a:t>Everything in the lesson on the same 1,200 pumps, cross-validated the same way.</a:t>
-            </a:r>
-          </a:p>
-          <a:p>
-            <a:pPr lvl="0" indent="0" marL="0">
-              <a:buNone/>
-            </a:pPr>
-          </a:p>
-          <a:p>
-            <a:pPr lvl="0" indent="0" marL="0">
-              <a:buNone/>
-            </a:pPr>
-            <a:r>
-              <a:rPr/>
-              <a:t>Read the top three rows together: all exactly 0.613, and all three are linear. Then the bottom three, all near the ceiling, reached by three completely unrelated routes - remembering the neighbourhood, assuming independence, bending the space. There is no single idea shared between them.</a:t>
-            </a:r>
-          </a:p>
-          <a:p>
-            <a:pPr lvl="0" indent="0" marL="0">
-              <a:buNone/>
-            </a:pPr>
-          </a:p>
-          <a:p>
-            <a:pPr lvl="0" indent="0" marL="0">
-              <a:buNone/>
-            </a:pPr>
-            <a:r>
-              <a:rPr/>
-              <a:t>Then the number that is the lesson: the gap between best and worst is </a:t>
-            </a:r>
-            <a:r>
-              <a:rPr b="1"/>
-              <a:t>0.334</a:t>
-            </a:r>
-            <a:r>
-              <a:rPr/>
-              <a:t>. Larger than any difference this course has shown between a good model and a carefully tuned one - lesson 5’s entire hyperparameter search moved things by a few hundredths.</a:t>
-            </a:r>
-          </a:p>
-          <a:p>
-            <a:pPr lvl="0" indent="0" marL="0">
-              <a:buNone/>
-            </a:pPr>
-          </a:p>
-          <a:p>
-            <a:pPr lvl="0" indent="0" marL="0">
-              <a:buNone/>
-            </a:pPr>
-            <a:r>
-              <a:rPr/>
-              <a:t>Say the conclusion plainly, and it is the practical takeaway of the whole lesson: choosing the right family matters far more than tuning the wrong one. Nobody in the top three rows could have tuned their way out. And the way to tell which family you need is to look at the data first, which is what lesson 2 was for.</a:t>
+              <a:t>Run notebooks/03. Sixteen minutes.</a:t>
+            </a:r>
+          </a:p>
+          <a:p>
+            <a:pPr lvl="0" indent="0" marL="0">
+              <a:buNone/>
+            </a:pPr>
+          </a:p>
+          <a:p>
+            <a:pPr lvl="0" indent="0" marL="0">
+              <a:buNone/>
+            </a:pPr>
+            <a:r>
+              <a:rPr/>
+              <a:t>The cell to protect is the γ sweep with the boundary drawn at each setting. Let them turn γ up themselves and watch the bubbles form - it is the most direct experience of overfitting available in this course.</a:t>
+            </a:r>
+          </a:p>
+          <a:p>
+            <a:pPr lvl="0" indent="0" marL="0">
+              <a:buNone/>
+            </a:pPr>
+          </a:p>
+          <a:p>
+            <a:pPr lvl="0" indent="0" marL="0">
+              <a:buNone/>
+            </a:pPr>
+            <a:r>
+              <a:rPr/>
+              <a:t>Have them print the support-vector fraction for the linear and RBF kernels side by side. Two numbers, and it makes the diagnostic real rather than a claim on a slide.</a:t>
+            </a:r>
+          </a:p>
+          <a:p>
+            <a:pPr lvl="0" indent="0" marL="0">
+              <a:buNone/>
+            </a:pPr>
+          </a:p>
+          <a:p>
+            <a:pPr lvl="0" indent="0" marL="0">
+              <a:buNone/>
+            </a:pPr>
+            <a:r>
+              <a:rPr/>
+              <a:t>If time runs short, skip the C sweep and set it as reading: the table is in handout section 5.6.</a:t>
             </a:r>
           </a:p>
         </p:txBody>
@@ -7638,35 +7617,57 @@
             </a:pPr>
             <a:r>
               <a:rPr/>
-              <a:t>A table to photograph. Work down it and attach today’s evidence to each row, so it is remembered as a set of conclusions rather than as advice.</a:t>
-            </a:r>
-          </a:p>
-          <a:p>
-            <a:pPr lvl="0" indent="0" marL="0">
-              <a:buNone/>
-            </a:pPr>
-          </a:p>
-          <a:p>
-            <a:pPr lvl="0" indent="0" marL="0">
-              <a:buNone/>
-            </a:pPr>
-            <a:r>
-              <a:rPr/>
-              <a:t>Row two deserves a sentence on its own, because it is the one that sounds wrong after the last hour. Text classification is the canonical case: tens of thousands of word-count features, an assumption that is transparently false, and a method that works anyway - because being roughly right in ten thousand dimensions beats being unable to estimate anything at all. Also mention Naive Bayes as a baseline: it trains in one pass, so if your tuned model does not beat it you have learned something quickly and cheaply.</a:t>
-            </a:r>
-          </a:p>
-          <a:p>
-            <a:pPr lvl="0" indent="0" marL="0">
-              <a:buNone/>
-            </a:pPr>
-          </a:p>
-          <a:p>
-            <a:pPr lvl="0" indent="0" marL="0">
-              <a:buNone/>
-            </a:pPr>
-            <a:r>
-              <a:rPr/>
-              <a:t>One row that did not fit and should be said out loud: when you need to explain the decision to the person affected, none of today’s three will do it. A support vector machine in a lifted space has no explanation a customer would accept. Lesson 3’s Resources document covers why that is sometimes a legal requirement rather than a preference.</a:t>
+              <a:t>Everything in the lesson on the same 1,200 pumps, cross-validated the same way.</a:t>
+            </a:r>
+          </a:p>
+          <a:p>
+            <a:pPr lvl="0" indent="0" marL="0">
+              <a:buNone/>
+            </a:pPr>
+          </a:p>
+          <a:p>
+            <a:pPr lvl="0" indent="0" marL="0">
+              <a:buNone/>
+            </a:pPr>
+            <a:r>
+              <a:rPr/>
+              <a:t>Read the top three rows together: all exactly 0.613, and all three are linear. Then the bottom three, all near the ceiling, reached by three completely unrelated routes - remembering the neighbourhood, assuming independence, bending the space. There is no single idea shared between them.</a:t>
+            </a:r>
+          </a:p>
+          <a:p>
+            <a:pPr lvl="0" indent="0" marL="0">
+              <a:buNone/>
+            </a:pPr>
+          </a:p>
+          <a:p>
+            <a:pPr lvl="0" indent="0" marL="0">
+              <a:buNone/>
+            </a:pPr>
+            <a:r>
+              <a:rPr/>
+              <a:t>Then the number that is the lesson: the gap between best and worst is </a:t>
+            </a:r>
+            <a:r>
+              <a:rPr b="1"/>
+              <a:t>0.334</a:t>
+            </a:r>
+            <a:r>
+              <a:rPr/>
+              <a:t>. Larger than any difference this course has shown between a good model and a carefully tuned one - lesson 5’s entire hyperparameter search moved things by a few hundredths.</a:t>
+            </a:r>
+          </a:p>
+          <a:p>
+            <a:pPr lvl="0" indent="0" marL="0">
+              <a:buNone/>
+            </a:pPr>
+          </a:p>
+          <a:p>
+            <a:pPr lvl="0" indent="0" marL="0">
+              <a:buNone/>
+            </a:pPr>
+            <a:r>
+              <a:rPr/>
+              <a:t>Say the conclusion plainly, and it is the practical takeaway of the whole lesson: choosing the right family matters far more than tuning the wrong one. Nobody in the top three rows could have tuned their way out. And the way to tell which family you need is to look at the data first, which is what lesson 2 was for.</a:t>
             </a:r>
           </a:p>
         </p:txBody>
@@ -7748,49 +7749,35 @@
             </a:pPr>
             <a:r>
               <a:rPr/>
-              <a:t>Close on the number they opened the second segment with, and say it one more time: seventy per cent. In a hundred dimensions the nearest point in the entire dataset is seven tenths of the way to the farthest, and every method built on distance is operating on a quantity that has stopped varying.</a:t>
-            </a:r>
-          </a:p>
-          <a:p>
-            <a:pPr lvl="0" indent="0" marL="0">
-              <a:buNone/>
-            </a:pPr>
-          </a:p>
-          <a:p>
-            <a:pPr lvl="0" indent="0" marL="0">
-              <a:buNone/>
-            </a:pPr>
-            <a:r>
-              <a:rPr/>
-              <a:t>If they remember one habit from today, make it the diagnostic pair: before reaching for a model, look at the shape of the data; after fitting one, check whether the assumption it depends on is actually satisfied on your data - and check it properly. The −0.006 said yes; the squared distances said no; and the ellipse the model drew explained the 0.933.</a:t>
-            </a:r>
-          </a:p>
-          <a:p>
-            <a:pPr lvl="0" indent="0" marL="0">
-              <a:buNone/>
-            </a:pPr>
-          </a:p>
-          <a:p>
-            <a:pPr lvl="0" indent="0" marL="0">
-              <a:buNone/>
-            </a:pPr>
-            <a:r>
-              <a:rPr/>
-              <a:t>And the correction to the instinct that this lesson exists to install: more features is not free. It is nearly free for a linear model and it is expensive for anything built on a distance.</a:t>
-            </a:r>
-          </a:p>
-          <a:p>
-            <a:pPr lvl="0" indent="0" marL="0">
-              <a:buNone/>
-            </a:pPr>
-          </a:p>
-          <a:p>
-            <a:pPr lvl="0" indent="0" marL="0">
-              <a:buNone/>
-            </a:pPr>
-            <a:r>
-              <a:rPr/>
-              <a:t>Handout section 7 lists all of this with the section numbers.</a:t>
+              <a:t>A table to photograph. Work down it and attach today’s evidence to each row, so it is remembered as a set of conclusions rather than as advice.</a:t>
+            </a:r>
+          </a:p>
+          <a:p>
+            <a:pPr lvl="0" indent="0" marL="0">
+              <a:buNone/>
+            </a:pPr>
+          </a:p>
+          <a:p>
+            <a:pPr lvl="0" indent="0" marL="0">
+              <a:buNone/>
+            </a:pPr>
+            <a:r>
+              <a:rPr/>
+              <a:t>Row two deserves a sentence on its own, because it is the one that sounds wrong after the last hour. Text classification is the canonical case: tens of thousands of word-count features, an assumption that is transparently false, and a method that works anyway - because being roughly right in ten thousand dimensions beats being unable to estimate anything at all. Also mention Naive Bayes as a baseline: it trains in one pass, so if your tuned model does not beat it you have learned something quickly and cheaply.</a:t>
+            </a:r>
+          </a:p>
+          <a:p>
+            <a:pPr lvl="0" indent="0" marL="0">
+              <a:buNone/>
+            </a:pPr>
+          </a:p>
+          <a:p>
+            <a:pPr lvl="0" indent="0" marL="0">
+              <a:buNone/>
+            </a:pPr>
+            <a:r>
+              <a:rPr/>
+              <a:t>One row that did not fit and should be said out loud: when you need to explain the decision to the person affected, none of today’s three will do it. A support vector machine in a lifted space has no explanation a customer would accept. Lesson 3’s Resources document covers why that is sometimes a legal requirement rather than a preference.</a:t>
             </a:r>
           </a:p>
         </p:txBody>
@@ -7872,49 +7859,49 @@
             </a:pPr>
             <a:r>
               <a:rPr/>
-              <a:t>Set it explicitly and say out loud when it comes back: the first ten minutes of next Friday, 13 November.</a:t>
-            </a:r>
-          </a:p>
-          <a:p>
-            <a:pPr lvl="0" indent="0" marL="0">
-              <a:buNone/>
-            </a:pPr>
-          </a:p>
-          <a:p>
-            <a:pPr lvl="0" indent="0" marL="0">
-              <a:buNone/>
-            </a:pPr>
-            <a:r>
-              <a:rPr/>
-              <a:t>The marks are for the reasoning, not for the accuracy. A well-argued choice that scores slightly worse beats a lucky winner with no justification - and the argument has to reference the data, in the way that the squared distances and the fitted ellipse explained Naive Bayes on the pumps this afternoon.</a:t>
-            </a:r>
-          </a:p>
-          <a:p>
-            <a:pPr lvl="0" indent="0" marL="0">
-              <a:buNone/>
-            </a:pPr>
-          </a:p>
-          <a:p>
-            <a:pPr lvl="0" indent="0" marL="0">
-              <a:buNone/>
-            </a:pPr>
-            <a:r>
-              <a:rPr/>
-              <a:t>Remind them that everything must be cross-validated and reported with a spread, in the format lesson 5 set. Scaling goes inside the pipeline; that will be checked.</a:t>
-            </a:r>
-          </a:p>
-          <a:p>
-            <a:pPr lvl="0" indent="0" marL="0">
-              <a:buNone/>
-            </a:pPr>
-          </a:p>
-          <a:p>
-            <a:pPr lvl="0" indent="0" marL="0">
-              <a:buNone/>
-            </a:pPr>
-            <a:r>
-              <a:rPr/>
-              <a:t>Next week: decision trees and ensembles. A fourth family, with a different answer again to the same question - how do you draw a boundary that is not a line.</a:t>
+              <a:t>Close on the number they opened the second segment with, and say it one more time: seventy per cent. In a hundred dimensions the nearest point in the entire dataset is seven tenths of the way to the farthest, and every method built on distance is operating on a quantity that has stopped varying.</a:t>
+            </a:r>
+          </a:p>
+          <a:p>
+            <a:pPr lvl="0" indent="0" marL="0">
+              <a:buNone/>
+            </a:pPr>
+          </a:p>
+          <a:p>
+            <a:pPr lvl="0" indent="0" marL="0">
+              <a:buNone/>
+            </a:pPr>
+            <a:r>
+              <a:rPr/>
+              <a:t>If they remember one habit from today, make it the diagnostic pair: before reaching for a model, look at the shape of the data; after fitting one, check whether the assumption it depends on is actually satisfied on your data - and check it properly. The −0.006 said yes; the squared distances said no; and the ellipse the model drew explained the 0.933.</a:t>
+            </a:r>
+          </a:p>
+          <a:p>
+            <a:pPr lvl="0" indent="0" marL="0">
+              <a:buNone/>
+            </a:pPr>
+          </a:p>
+          <a:p>
+            <a:pPr lvl="0" indent="0" marL="0">
+              <a:buNone/>
+            </a:pPr>
+            <a:r>
+              <a:rPr/>
+              <a:t>And the correction to the instinct that this lesson exists to install: more features is not free. It is nearly free for a linear model and it is expensive for anything built on a distance.</a:t>
+            </a:r>
+          </a:p>
+          <a:p>
+            <a:pPr lvl="0" indent="0" marL="0">
+              <a:buNone/>
+            </a:pPr>
+          </a:p>
+          <a:p>
+            <a:pPr lvl="0" indent="0" marL="0">
+              <a:buNone/>
+            </a:pPr>
+            <a:r>
+              <a:rPr/>
+              <a:t>Handout section 7 lists all of this with the section numbers.</a:t>
             </a:r>
           </a:p>
         </p:txBody>
@@ -7937,6 +7924,130 @@
             <a:fld id="{18BDFEC3-8487-43E8-A154-7C12CBC1FFF2}" type="slidenum">
               <a:rPr lang="en-US"/>
               <a:t>65</a:t>
+            </a:fld>
+            <a:endParaRPr lang="en-US"/>
+          </a:p>
+        </p:txBody>
+      </p:sp>
+    </p:spTree>
+  </p:cSld>
+</p:notes>
+</file>
+
+<file path=ppt/notesSlides/notesSlide65.xml><?xml version="1.0" encoding="utf-8"?>
+<p:notes xmlns:a="http://schemas.openxmlformats.org/drawingml/2006/main" xmlns:r="http://schemas.openxmlformats.org/officeDocument/2006/relationships" xmlns:p="http://schemas.openxmlformats.org/presentationml/2006/main">
+  <p:cSld>
+    <p:spTree>
+      <p:nvGrpSpPr>
+        <p:cNvPr id="1" name=""/>
+        <p:cNvGrpSpPr/>
+        <p:nvPr/>
+      </p:nvGrpSpPr>
+      <p:grpSpPr>
+        <a:xfrm>
+          <a:off x="0" y="0"/>
+          <a:ext cx="0" cy="0"/>
+          <a:chOff x="0" y="0"/>
+          <a:chExt cx="0" cy="0"/>
+        </a:xfrm>
+      </p:grpSpPr>
+      <p:sp>
+        <p:nvSpPr>
+          <p:cNvPr id="2" name="Slide Image Placeholder 1"/>
+          <p:cNvSpPr>
+            <a:spLocks noGrp="1" noRot="1" noChangeAspect="1"/>
+          </p:cNvSpPr>
+          <p:nvPr>
+            <p:ph type="sldImg"/>
+          </p:nvPr>
+        </p:nvSpPr>
+        <p:spPr/>
+      </p:sp>
+      <p:sp>
+        <p:nvSpPr>
+          <p:cNvPr id="3" name="Notes Placeholder 2"/>
+          <p:cNvSpPr>
+            <a:spLocks noGrp="1"/>
+          </p:cNvSpPr>
+          <p:nvPr>
+            <p:ph type="body" idx="1"/>
+          </p:nvPr>
+        </p:nvSpPr>
+        <p:spPr/>
+        <p:txBody>
+          <a:bodyPr/>
+          <a:lstStyle/>
+          <a:p>
+            <a:pPr lvl="0" indent="0" marL="0">
+              <a:buNone/>
+            </a:pPr>
+            <a:r>
+              <a:rPr/>
+              <a:t>Set it explicitly and say out loud when it comes back: the first ten minutes of next Friday, 13 November.</a:t>
+            </a:r>
+          </a:p>
+          <a:p>
+            <a:pPr lvl="0" indent="0" marL="0">
+              <a:buNone/>
+            </a:pPr>
+          </a:p>
+          <a:p>
+            <a:pPr lvl="0" indent="0" marL="0">
+              <a:buNone/>
+            </a:pPr>
+            <a:r>
+              <a:rPr/>
+              <a:t>The marks are for the reasoning, not for the accuracy. A well-argued choice that scores slightly worse beats a lucky winner with no justification - and the argument has to reference the data, in the way that the squared distances and the fitted ellipse explained Naive Bayes on the pumps this afternoon.</a:t>
+            </a:r>
+          </a:p>
+          <a:p>
+            <a:pPr lvl="0" indent="0" marL="0">
+              <a:buNone/>
+            </a:pPr>
+          </a:p>
+          <a:p>
+            <a:pPr lvl="0" indent="0" marL="0">
+              <a:buNone/>
+            </a:pPr>
+            <a:r>
+              <a:rPr/>
+              <a:t>Remind them that everything must be cross-validated and reported with a spread, in the format lesson 5 set. Scaling goes inside the pipeline; that will be checked.</a:t>
+            </a:r>
+          </a:p>
+          <a:p>
+            <a:pPr lvl="0" indent="0" marL="0">
+              <a:buNone/>
+            </a:pPr>
+          </a:p>
+          <a:p>
+            <a:pPr lvl="0" indent="0" marL="0">
+              <a:buNone/>
+            </a:pPr>
+            <a:r>
+              <a:rPr/>
+              <a:t>Next week: decision trees and ensembles. A fourth family, with a different answer again to the same question - how do you draw a boundary that is not a line.</a:t>
+            </a:r>
+          </a:p>
+        </p:txBody>
+      </p:sp>
+      <p:sp>
+        <p:nvSpPr>
+          <p:cNvPr id="4" name="Slide Number Placeholder 3"/>
+          <p:cNvSpPr>
+            <a:spLocks noGrp="1"/>
+          </p:cNvSpPr>
+          <p:nvPr>
+            <p:ph type="sldNum" sz="quarter" idx="10"/>
+          </p:nvPr>
+        </p:nvSpPr>
+        <p:spPr/>
+        <p:txBody>
+          <a:bodyPr/>
+          <a:lstStyle/>
+          <a:p>
+            <a:fld id="{18BDFEC3-8487-43E8-A154-7C12CBC1FFF2}" type="slidenum">
+              <a:rPr lang="en-US"/>
+              <a:t>66</a:t>
             </a:fld>
             <a:endParaRPr lang="en-US"/>
           </a:p>
@@ -15093,7 +15204,7 @@
             </a:pPr>
             <a:r>
               <a:rPr/>
-              <a:t>A wonderful bargain, and almost never true</a:t>
+              <a:t>From the two totals to 0.981</a:t>
             </a:r>
           </a:p>
         </p:txBody>
@@ -15121,40 +15232,40 @@
             <a:pPr lvl="0"/>
             <a:r>
               <a:rPr/>
-              <a:t>Training is </a:t>
+              <a:t>Each total is a log score: log prior + log P(vibration) + log P(pressure)</a:t>
+            </a:r>
+          </a:p>
+          <a:p>
+            <a:pPr lvl="0"/>
+            <a:r>
+              <a:rPr/>
+              <a:t>The gap: −4.144 − (−8.095) = </a:t>
             </a:r>
             <a:r>
               <a:rPr b="1"/>
-              <a:t>a single pass</a:t>
-            </a:r>
-            <a:r>
-              <a:rPr/>
-              <a:t>; adding features costs almost nothing</a:t>
+              <a:t>3.951</a:t>
+            </a:r>
+            <a:r>
+              <a:rPr/>
+              <a:t>, in favour of faulty</a:t>
             </a:r>
           </a:p>
           <a:p>
             <a:pPr lvl="0"/>
             <a:r>
               <a:rPr/>
-              <a:t>But vibration and pressure are both driven by the operating point</a:t>
+              <a:t>P(faulty) = 1 / (1 + e^(−3.951)) = 1 / 1.0192 = </a:t>
+            </a:r>
+            <a:r>
+              <a:rPr b="1"/>
+              <a:t>0.981</a:t>
             </a:r>
           </a:p>
           <a:p>
             <a:pPr lvl="0"/>
             <a:r>
               <a:rPr/>
-              <a:t>“New” is not independent of “York” given the topic. Symptoms co-occur</a:t>
-            </a:r>
-          </a:p>
-          <a:p>
-            <a:pPr lvl="0"/>
-            <a:r>
-              <a:rPr/>
-              <a:t>So the question is not whether it holds: it is </a:t>
-            </a:r>
-            <a:r>
-              <a:rPr b="1"/>
-              <a:t>when being wrong about it costs you nothing</a:t>
+              <a:t>Check: e^(−4.144) / (e^(−4.144) + e^(−8.095)) = 0.01585 / 0.01616 = 0.981</a:t>
             </a:r>
           </a:p>
         </p:txBody>
@@ -15165,6 +15276,119 @@
 </file>
 
 <file path=ppt/slides/slide34.xml><?xml version="1.0" encoding="utf-8"?>
+<p:sld xmlns:a="http://schemas.openxmlformats.org/drawingml/2006/main" xmlns:r="http://schemas.openxmlformats.org/officeDocument/2006/relationships" xmlns:p="http://schemas.openxmlformats.org/presentationml/2006/main">
+  <p:cSld>
+    <p:spTree>
+      <p:nvGrpSpPr>
+        <p:cNvPr id="1" name=""/>
+        <p:cNvGrpSpPr/>
+        <p:nvPr/>
+      </p:nvGrpSpPr>
+      <p:grpSpPr>
+        <a:xfrm>
+          <a:off x="0" y="0"/>
+          <a:ext cx="0" cy="0"/>
+          <a:chOff x="0" y="0"/>
+          <a:chExt cx="0" cy="0"/>
+        </a:xfrm>
+      </p:grpSpPr>
+      <p:sp>
+        <p:nvSpPr>
+          <p:cNvPr id="2" name="Title 1"/>
+          <p:cNvSpPr>
+            <a:spLocks noGrp="1"/>
+          </p:cNvSpPr>
+          <p:nvPr>
+            <p:ph type="title"/>
+          </p:nvPr>
+        </p:nvSpPr>
+        <p:spPr>
+          <a:xfrm>
+            <a:off x="457200" y="205979"/>
+            <a:ext cx="8229600" cy="857250"/>
+          </a:xfrm>
+        </p:spPr>
+        <p:txBody>
+          <a:bodyPr/>
+          <a:lstStyle/>
+          <a:p>
+            <a:pPr lvl="0" indent="0" marL="0">
+              <a:buNone/>
+            </a:pPr>
+            <a:r>
+              <a:rPr/>
+              <a:t>A wonderful bargain, and almost never true</a:t>
+            </a:r>
+          </a:p>
+        </p:txBody>
+      </p:sp>
+      <p:sp>
+        <p:nvSpPr>
+          <p:cNvPr id="3" name="Content Placeholder 2"/>
+          <p:cNvSpPr>
+            <a:spLocks noGrp="1"/>
+          </p:cNvSpPr>
+          <p:nvPr>
+            <p:ph idx="1"/>
+          </p:nvPr>
+        </p:nvSpPr>
+        <p:spPr>
+          <a:xfrm>
+            <a:off x="457200" y="1200151"/>
+            <a:ext cx="8229600" cy="3394472"/>
+          </a:xfrm>
+        </p:spPr>
+        <p:txBody>
+          <a:bodyPr/>
+          <a:lstStyle/>
+          <a:p>
+            <a:pPr lvl="0"/>
+            <a:r>
+              <a:rPr/>
+              <a:t>Training is </a:t>
+            </a:r>
+            <a:r>
+              <a:rPr b="1"/>
+              <a:t>a single pass</a:t>
+            </a:r>
+            <a:r>
+              <a:rPr/>
+              <a:t>; adding features costs almost nothing</a:t>
+            </a:r>
+          </a:p>
+          <a:p>
+            <a:pPr lvl="0"/>
+            <a:r>
+              <a:rPr/>
+              <a:t>But vibration and pressure are both driven by the operating point</a:t>
+            </a:r>
+          </a:p>
+          <a:p>
+            <a:pPr lvl="0"/>
+            <a:r>
+              <a:rPr/>
+              <a:t>“New” is not independent of “York” given the topic. Symptoms co-occur</a:t>
+            </a:r>
+          </a:p>
+          <a:p>
+            <a:pPr lvl="0"/>
+            <a:r>
+              <a:rPr/>
+              <a:t>So the question is not whether it holds: it is </a:t>
+            </a:r>
+            <a:r>
+              <a:rPr b="1"/>
+              <a:t>when being wrong about it costs you nothing</a:t>
+            </a:r>
+          </a:p>
+        </p:txBody>
+      </p:sp>
+    </p:spTree>
+  </p:cSld>
+</p:sld>
+</file>
+
+<file path=ppt/slides/slide35.xml><?xml version="1.0" encoding="utf-8"?>
 <p:sld xmlns:a="http://schemas.openxmlformats.org/drawingml/2006/main" xmlns:r="http://schemas.openxmlformats.org/officeDocument/2006/relationships" xmlns:p="http://schemas.openxmlformats.org/presentationml/2006/main">
   <p:cSld>
     <p:spTree>
@@ -15406,7 +15630,7 @@
 </p:sld>
 </file>
 
-<file path=ppt/slides/slide35.xml><?xml version="1.0" encoding="utf-8"?>
+<file path=ppt/slides/slide36.xml><?xml version="1.0" encoding="utf-8"?>
 <p:sld xmlns:a="http://schemas.openxmlformats.org/drawingml/2006/main" xmlns:r="http://schemas.openxmlformats.org/officeDocument/2006/relationships" xmlns:p="http://schemas.openxmlformats.org/presentationml/2006/main">
   <p:cSld>
     <p:spTree>
@@ -15631,7 +15855,7 @@
 </p:sld>
 </file>
 
-<file path=ppt/slides/slide36.xml><?xml version="1.0" encoding="utf-8"?>
+<file path=ppt/slides/slide37.xml><?xml version="1.0" encoding="utf-8"?>
 <p:sld xmlns:a="http://schemas.openxmlformats.org/drawingml/2006/main" xmlns:r="http://schemas.openxmlformats.org/officeDocument/2006/relationships" xmlns:p="http://schemas.openxmlformats.org/presentationml/2006/main">
   <p:cSld>
     <p:spTree>
@@ -15713,7 +15937,7 @@
 </p:sld>
 </file>
 
-<file path=ppt/slides/slide37.xml><?xml version="1.0" encoding="utf-8"?>
+<file path=ppt/slides/slide38.xml><?xml version="1.0" encoding="utf-8"?>
 <p:sld xmlns:a="http://schemas.openxmlformats.org/drawingml/2006/main" xmlns:r="http://schemas.openxmlformats.org/officeDocument/2006/relationships" xmlns:p="http://schemas.openxmlformats.org/presentationml/2006/main">
   <p:cSld>
     <p:spTree>
@@ -15815,7 +16039,7 @@
 </p:sld>
 </file>
 
-<file path=ppt/slides/slide38.xml><?xml version="1.0" encoding="utf-8"?>
+<file path=ppt/slides/slide39.xml><?xml version="1.0" encoding="utf-8"?>
 <p:sld xmlns:a="http://schemas.openxmlformats.org/drawingml/2006/main" xmlns:r="http://schemas.openxmlformats.org/officeDocument/2006/relationships" xmlns:p="http://schemas.openxmlformats.org/presentationml/2006/main">
   <p:cSld>
     <p:spTree>
@@ -15897,7 +16121,113 @@
 </p:sld>
 </file>
 
-<file path=ppt/slides/slide39.xml><?xml version="1.0" encoding="utf-8"?>
+<file path=ppt/slides/slide4.xml><?xml version="1.0" encoding="utf-8"?>
+<p:sld xmlns:a="http://schemas.openxmlformats.org/drawingml/2006/main" xmlns:r="http://schemas.openxmlformats.org/officeDocument/2006/relationships" xmlns:p="http://schemas.openxmlformats.org/presentationml/2006/main">
+  <p:cSld>
+    <p:spTree>
+      <p:nvGrpSpPr>
+        <p:cNvPr id="1" name=""/>
+        <p:cNvGrpSpPr/>
+        <p:nvPr/>
+      </p:nvGrpSpPr>
+      <p:grpSpPr>
+        <a:xfrm>
+          <a:off x="0" y="0"/>
+          <a:ext cx="0" cy="0"/>
+          <a:chOff x="0" y="0"/>
+          <a:chExt cx="0" cy="0"/>
+        </a:xfrm>
+      </p:grpSpPr>
+      <p:sp>
+        <p:nvSpPr>
+          <p:cNvPr id="2" name="Title 1"/>
+          <p:cNvSpPr>
+            <a:spLocks noGrp="1"/>
+          </p:cNvSpPr>
+          <p:nvPr>
+            <p:ph type="title"/>
+          </p:nvPr>
+        </p:nvSpPr>
+        <p:spPr>
+          <a:xfrm>
+            <a:off x="457200" y="205979"/>
+            <a:ext cx="8229600" cy="857250"/>
+          </a:xfrm>
+        </p:spPr>
+        <p:txBody>
+          <a:bodyPr/>
+          <a:lstStyle/>
+          <a:p>
+            <a:pPr lvl="0" indent="0" marL="0">
+              <a:buNone/>
+            </a:pPr>
+            <a:r>
+              <a:rPr/>
+              <a:t>1,200 pumps, two readings each</a:t>
+            </a:r>
+          </a:p>
+        </p:txBody>
+      </p:sp>
+      <p:sp>
+        <p:nvSpPr>
+          <p:cNvPr id="3" name="Content Placeholder 2"/>
+          <p:cNvSpPr>
+            <a:spLocks noGrp="1"/>
+          </p:cNvSpPr>
+          <p:nvPr>
+            <p:ph idx="1"/>
+          </p:nvPr>
+        </p:nvSpPr>
+        <p:spPr>
+          <a:xfrm>
+            <a:off x="457200" y="1200151"/>
+            <a:ext cx="8229600" cy="3394472"/>
+          </a:xfrm>
+        </p:spPr>
+        <p:txBody>
+          <a:bodyPr/>
+          <a:lstStyle/>
+          <a:p>
+            <a:pPr lvl="0"/>
+            <a:r>
+              <a:rPr/>
+              <a:t>Vibration in Hz, pressure in bar</a:t>
+            </a:r>
+          </a:p>
+          <a:p>
+            <a:pPr lvl="0"/>
+            <a:r>
+              <a:rPr/>
+              <a:t>A pump is faulty when its readings fall </a:t>
+            </a:r>
+            <a:r>
+              <a:rPr b="1"/>
+              <a:t>outside the design envelope</a:t>
+            </a:r>
+            <a:r>
+              <a:rPr/>
+              <a:t>, too low as readily as too high</a:t>
+            </a:r>
+          </a:p>
+          <a:p>
+            <a:pPr lvl="0"/>
+            <a:r>
+              <a:rPr b="1"/>
+              <a:t>61.3%</a:t>
+            </a:r>
+            <a:r>
+              <a:rPr/>
+              <a:t> faulty; 4% of the labels are deliberately flipped</a:t>
+            </a:r>
+          </a:p>
+        </p:txBody>
+      </p:sp>
+    </p:spTree>
+  </p:cSld>
+</p:sld>
+</file>
+
+<file path=ppt/slides/slide40.xml><?xml version="1.0" encoding="utf-8"?>
 <p:sld xmlns:a="http://schemas.openxmlformats.org/drawingml/2006/main" xmlns:r="http://schemas.openxmlformats.org/officeDocument/2006/relationships" xmlns:p="http://schemas.openxmlformats.org/presentationml/2006/main">
   <p:cSld>
     <p:spTree>
@@ -16203,225 +16533,6 @@
 </p:sld>
 </file>
 
-<file path=ppt/slides/slide4.xml><?xml version="1.0" encoding="utf-8"?>
-<p:sld xmlns:a="http://schemas.openxmlformats.org/drawingml/2006/main" xmlns:r="http://schemas.openxmlformats.org/officeDocument/2006/relationships" xmlns:p="http://schemas.openxmlformats.org/presentationml/2006/main">
-  <p:cSld>
-    <p:spTree>
-      <p:nvGrpSpPr>
-        <p:cNvPr id="1" name=""/>
-        <p:cNvGrpSpPr/>
-        <p:nvPr/>
-      </p:nvGrpSpPr>
-      <p:grpSpPr>
-        <a:xfrm>
-          <a:off x="0" y="0"/>
-          <a:ext cx="0" cy="0"/>
-          <a:chOff x="0" y="0"/>
-          <a:chExt cx="0" cy="0"/>
-        </a:xfrm>
-      </p:grpSpPr>
-      <p:sp>
-        <p:nvSpPr>
-          <p:cNvPr id="2" name="Title 1"/>
-          <p:cNvSpPr>
-            <a:spLocks noGrp="1"/>
-          </p:cNvSpPr>
-          <p:nvPr>
-            <p:ph type="title"/>
-          </p:nvPr>
-        </p:nvSpPr>
-        <p:spPr>
-          <a:xfrm>
-            <a:off x="457200" y="205979"/>
-            <a:ext cx="8229600" cy="857250"/>
-          </a:xfrm>
-        </p:spPr>
-        <p:txBody>
-          <a:bodyPr/>
-          <a:lstStyle/>
-          <a:p>
-            <a:pPr lvl="0" indent="0" marL="0">
-              <a:buNone/>
-            </a:pPr>
-            <a:r>
-              <a:rPr/>
-              <a:t>1,200 pumps, two readings each</a:t>
-            </a:r>
-          </a:p>
-        </p:txBody>
-      </p:sp>
-      <p:sp>
-        <p:nvSpPr>
-          <p:cNvPr id="3" name="Content Placeholder 2"/>
-          <p:cNvSpPr>
-            <a:spLocks noGrp="1"/>
-          </p:cNvSpPr>
-          <p:nvPr>
-            <p:ph idx="1"/>
-          </p:nvPr>
-        </p:nvSpPr>
-        <p:spPr>
-          <a:xfrm>
-            <a:off x="457200" y="1200151"/>
-            <a:ext cx="8229600" cy="3394472"/>
-          </a:xfrm>
-        </p:spPr>
-        <p:txBody>
-          <a:bodyPr/>
-          <a:lstStyle/>
-          <a:p>
-            <a:pPr lvl="0"/>
-            <a:r>
-              <a:rPr/>
-              <a:t>Vibration in Hz, pressure in bar</a:t>
-            </a:r>
-          </a:p>
-          <a:p>
-            <a:pPr lvl="0"/>
-            <a:r>
-              <a:rPr/>
-              <a:t>A pump is faulty when its readings fall </a:t>
-            </a:r>
-            <a:r>
-              <a:rPr b="1"/>
-              <a:t>outside the design envelope</a:t>
-            </a:r>
-            <a:r>
-              <a:rPr/>
-              <a:t>, too low as readily as too high</a:t>
-            </a:r>
-          </a:p>
-          <a:p>
-            <a:pPr lvl="0"/>
-            <a:r>
-              <a:rPr b="1"/>
-              <a:t>61.3%</a:t>
-            </a:r>
-            <a:r>
-              <a:rPr/>
-              <a:t> faulty; 4% of the labels are deliberately flipped</a:t>
-            </a:r>
-          </a:p>
-        </p:txBody>
-      </p:sp>
-    </p:spTree>
-  </p:cSld>
-</p:sld>
-</file>
-
-<file path=ppt/slides/slide40.xml><?xml version="1.0" encoding="utf-8"?>
-<p:sld xmlns:a="http://schemas.openxmlformats.org/drawingml/2006/main" xmlns:r="http://schemas.openxmlformats.org/officeDocument/2006/relationships" xmlns:p="http://schemas.openxmlformats.org/presentationml/2006/main">
-  <p:cSld>
-    <p:spTree>
-      <p:nvGrpSpPr>
-        <p:cNvPr id="1" name=""/>
-        <p:cNvGrpSpPr/>
-        <p:nvPr/>
-      </p:nvGrpSpPr>
-      <p:grpSpPr>
-        <a:xfrm>
-          <a:off x="0" y="0"/>
-          <a:ext cx="0" cy="0"/>
-          <a:chOff x="0" y="0"/>
-          <a:chExt cx="0" cy="0"/>
-        </a:xfrm>
-      </p:grpSpPr>
-      <p:sp>
-        <p:nvSpPr>
-          <p:cNvPr id="2" name="Title 1"/>
-          <p:cNvSpPr>
-            <a:spLocks noGrp="1"/>
-          </p:cNvSpPr>
-          <p:nvPr>
-            <p:ph type="title"/>
-          </p:nvPr>
-        </p:nvSpPr>
-        <p:spPr>
-          <a:xfrm>
-            <a:off x="457200" y="205979"/>
-            <a:ext cx="8229600" cy="857250"/>
-          </a:xfrm>
-        </p:spPr>
-        <p:txBody>
-          <a:bodyPr/>
-          <a:lstStyle/>
-          <a:p>
-            <a:pPr lvl="0" indent="0" marL="0">
-              <a:buNone/>
-            </a:pPr>
-            <a:r>
-              <a:rPr/>
-              <a:t>Its probabilities are not probabilities</a:t>
-            </a:r>
-          </a:p>
-        </p:txBody>
-      </p:sp>
-      <p:sp>
-        <p:nvSpPr>
-          <p:cNvPr id="3" name="Content Placeholder 2"/>
-          <p:cNvSpPr>
-            <a:spLocks noGrp="1"/>
-          </p:cNvSpPr>
-          <p:nvPr>
-            <p:ph idx="1"/>
-          </p:nvPr>
-        </p:nvSpPr>
-        <p:spPr>
-          <a:xfrm>
-            <a:off x="457200" y="1200151"/>
-            <a:ext cx="8229600" cy="3394472"/>
-          </a:xfrm>
-        </p:spPr>
-        <p:txBody>
-          <a:bodyPr/>
-          <a:lstStyle/>
-          <a:p>
-            <a:pPr lvl="0"/>
-            <a:r>
-              <a:rPr/>
-              <a:t>Mean confidence when </a:t>
-            </a:r>
-            <a:r>
-              <a:rPr b="1"/>
-              <a:t>correct: 0.567</a:t>
-            </a:r>
-            <a:r>
-              <a:rPr/>
-              <a:t>. When </a:t>
-            </a:r>
-            <a:r>
-              <a:rPr b="1"/>
-              <a:t>wrong: 0.555</a:t>
-            </a:r>
-          </a:p>
-          <a:p>
-            <a:pPr lvl="0"/>
-            <a:r>
-              <a:rPr/>
-              <a:t>It cannot tell the difference between the two situations</a:t>
-            </a:r>
-          </a:p>
-          <a:p>
-            <a:pPr lvl="0"/>
-            <a:r>
-              <a:rPr/>
-              <a:t>With features that repeat each other it fails the other way: 0.999 reported, with an accuracy nothing like that</a:t>
-            </a:r>
-          </a:p>
-          <a:p>
-            <a:pPr lvl="0"/>
-            <a:r>
-              <a:rPr b="1"/>
-              <a:t>The ranking may be useful while the probabilities are not</a:t>
-            </a:r>
-          </a:p>
-        </p:txBody>
-      </p:sp>
-    </p:spTree>
-  </p:cSld>
-</p:sld>
-</file>
-
 <file path=ppt/slides/slide41.xml><?xml version="1.0" encoding="utf-8"?>
 <p:sld xmlns:a="http://schemas.openxmlformats.org/drawingml/2006/main" xmlns:r="http://schemas.openxmlformats.org/officeDocument/2006/relationships" xmlns:p="http://schemas.openxmlformats.org/presentationml/2006/main">
   <p:cSld>
@@ -16464,7 +16575,7 @@
             </a:pPr>
             <a:r>
               <a:rPr/>
-              <a:t>Notebook 2, live</a:t>
+              <a:t>Its probabilities are not probabilities</a:t>
             </a:r>
           </a:p>
         </p:txBody>
@@ -16492,7 +16603,40 @@
             <a:pPr lvl="0"/>
             <a:r>
               <a:rPr/>
-              <a:t>Where breaking the assumption is cheap, and one step away where it is fatal</a:t>
+              <a:t>Mean confidence when </a:t>
+            </a:r>
+            <a:r>
+              <a:rPr b="1"/>
+              <a:t>correct: 0.567</a:t>
+            </a:r>
+            <a:r>
+              <a:rPr/>
+              <a:t>. When </a:t>
+            </a:r>
+            <a:r>
+              <a:rPr b="1"/>
+              <a:t>wrong: 0.555</a:t>
+            </a:r>
+          </a:p>
+          <a:p>
+            <a:pPr lvl="0"/>
+            <a:r>
+              <a:rPr/>
+              <a:t>It cannot tell the difference between the two situations</a:t>
+            </a:r>
+          </a:p>
+          <a:p>
+            <a:pPr lvl="0"/>
+            <a:r>
+              <a:rPr/>
+              <a:t>With features that repeat each other it fails the other way: 0.999 reported, with an accuracy nothing like that</a:t>
+            </a:r>
+          </a:p>
+          <a:p>
+            <a:pPr lvl="0"/>
+            <a:r>
+              <a:rPr b="1"/>
+              <a:t>The ranking may be useful while the probabilities are not</a:t>
             </a:r>
           </a:p>
         </p:txBody>
@@ -16544,7 +16688,7 @@
             </a:pPr>
             <a:r>
               <a:rPr/>
-              <a:t>The margin: a criterion that is not the error</a:t>
+              <a:t>Notebook 2, live</a:t>
             </a:r>
           </a:p>
         </p:txBody>
@@ -16572,48 +16716,7 @@
             <a:pPr lvl="0"/>
             <a:r>
               <a:rPr/>
-              <a:t>On separable data there are </a:t>
-            </a:r>
-            <a:r>
-              <a:rPr b="1"/>
-              <a:t>infinitely many</a:t>
-            </a:r>
-            <a:r>
-              <a:rPr/>
-              <a:t> separating lines, and every one has </a:t>
-            </a:r>
-            <a:r>
-              <a:rPr b="1"/>
-              <a:t>zero training error</a:t>
-            </a:r>
-          </a:p>
-          <a:p>
-            <a:pPr lvl="0"/>
-            <a:r>
-              <a:rPr/>
-              <a:t>Minimising the error therefore cannot choose between them</a:t>
-            </a:r>
-          </a:p>
-          <a:p>
-            <a:pPr lvl="0"/>
-            <a:r>
-              <a:rPr/>
-              <a:t>The SVM picks the widest </a:t>
-            </a:r>
-            <a:r>
-              <a:rPr b="1"/>
-              <a:t>slab</a:t>
-            </a:r>
-            <a:r>
-              <a:rPr/>
-              <a:t>: push it out until it touches the nearest point of each class</a:t>
-            </a:r>
-          </a:p>
-          <a:p>
-            <a:pPr lvl="0"/>
-            <a:r>
-              <a:rPr/>
-              <a:t>A boundary passing close to a point is one small perturbation from getting it wrong</a:t>
+              <a:t>Where breaking the assumption is cheap, and one step away where it is fatal</a:t>
             </a:r>
           </a:p>
         </p:txBody>
@@ -16624,6 +16727,127 @@
 </file>
 
 <file path=ppt/slides/slide43.xml><?xml version="1.0" encoding="utf-8"?>
+<p:sld xmlns:a="http://schemas.openxmlformats.org/drawingml/2006/main" xmlns:r="http://schemas.openxmlformats.org/officeDocument/2006/relationships" xmlns:p="http://schemas.openxmlformats.org/presentationml/2006/main">
+  <p:cSld>
+    <p:spTree>
+      <p:nvGrpSpPr>
+        <p:cNvPr id="1" name=""/>
+        <p:cNvGrpSpPr/>
+        <p:nvPr/>
+      </p:nvGrpSpPr>
+      <p:grpSpPr>
+        <a:xfrm>
+          <a:off x="0" y="0"/>
+          <a:ext cx="0" cy="0"/>
+          <a:chOff x="0" y="0"/>
+          <a:chExt cx="0" cy="0"/>
+        </a:xfrm>
+      </p:grpSpPr>
+      <p:sp>
+        <p:nvSpPr>
+          <p:cNvPr id="2" name="Title 1"/>
+          <p:cNvSpPr>
+            <a:spLocks noGrp="1"/>
+          </p:cNvSpPr>
+          <p:nvPr>
+            <p:ph type="title"/>
+          </p:nvPr>
+        </p:nvSpPr>
+        <p:spPr>
+          <a:xfrm>
+            <a:off x="457200" y="205979"/>
+            <a:ext cx="8229600" cy="857250"/>
+          </a:xfrm>
+        </p:spPr>
+        <p:txBody>
+          <a:bodyPr/>
+          <a:lstStyle/>
+          <a:p>
+            <a:pPr lvl="0" indent="0" marL="0">
+              <a:buNone/>
+            </a:pPr>
+            <a:r>
+              <a:rPr/>
+              <a:t>The margin: a criterion that is not the error</a:t>
+            </a:r>
+          </a:p>
+        </p:txBody>
+      </p:sp>
+      <p:sp>
+        <p:nvSpPr>
+          <p:cNvPr id="3" name="Content Placeholder 2"/>
+          <p:cNvSpPr>
+            <a:spLocks noGrp="1"/>
+          </p:cNvSpPr>
+          <p:nvPr>
+            <p:ph idx="1"/>
+          </p:nvPr>
+        </p:nvSpPr>
+        <p:spPr>
+          <a:xfrm>
+            <a:off x="457200" y="1200151"/>
+            <a:ext cx="8229600" cy="3394472"/>
+          </a:xfrm>
+        </p:spPr>
+        <p:txBody>
+          <a:bodyPr/>
+          <a:lstStyle/>
+          <a:p>
+            <a:pPr lvl="0"/>
+            <a:r>
+              <a:rPr/>
+              <a:t>On separable data there are </a:t>
+            </a:r>
+            <a:r>
+              <a:rPr b="1"/>
+              <a:t>infinitely many</a:t>
+            </a:r>
+            <a:r>
+              <a:rPr/>
+              <a:t> separating lines, and every one has </a:t>
+            </a:r>
+            <a:r>
+              <a:rPr b="1"/>
+              <a:t>zero training error</a:t>
+            </a:r>
+          </a:p>
+          <a:p>
+            <a:pPr lvl="0"/>
+            <a:r>
+              <a:rPr/>
+              <a:t>Minimising the error therefore cannot choose between them</a:t>
+            </a:r>
+          </a:p>
+          <a:p>
+            <a:pPr lvl="0"/>
+            <a:r>
+              <a:rPr/>
+              <a:t>The SVM picks the widest </a:t>
+            </a:r>
+            <a:r>
+              <a:rPr b="1"/>
+              <a:t>slab</a:t>
+            </a:r>
+            <a:r>
+              <a:rPr/>
+              <a:t>: push it out until it touches the nearest point of each class</a:t>
+            </a:r>
+          </a:p>
+          <a:p>
+            <a:pPr lvl="0"/>
+            <a:r>
+              <a:rPr/>
+              <a:t>A boundary passing close to a point is one small perturbation from getting it wrong</a:t>
+            </a:r>
+          </a:p>
+        </p:txBody>
+      </p:sp>
+    </p:spTree>
+  </p:cSld>
+</p:sld>
+</file>
+
+<file path=ppt/slides/slide44.xml><?xml version="1.0" encoding="utf-8"?>
 <p:sld xmlns:a="http://schemas.openxmlformats.org/drawingml/2006/main" xmlns:r="http://schemas.openxmlformats.org/officeDocument/2006/relationships" xmlns:p="http://schemas.openxmlformats.org/presentationml/2006/main">
   <p:cSld>
     <p:spTree>
@@ -16705,7 +16929,7 @@
 </p:sld>
 </file>
 
-<file path=ppt/slides/slide44.xml><?xml version="1.0" encoding="utf-8"?>
+<file path=ppt/slides/slide45.xml><?xml version="1.0" encoding="utf-8"?>
 <p:sld xmlns:a="http://schemas.openxmlformats.org/drawingml/2006/main" xmlns:r="http://schemas.openxmlformats.org/officeDocument/2006/relationships" xmlns:p="http://schemas.openxmlformats.org/presentationml/2006/main">
   <p:cSld>
     <p:spTree>
@@ -16818,7 +17042,7 @@
 </p:sld>
 </file>
 
-<file path=ppt/slides/slide45.xml><?xml version="1.0" encoding="utf-8"?>
+<file path=ppt/slides/slide46.xml><?xml version="1.0" encoding="utf-8"?>
 <p:sld xmlns:a="http://schemas.openxmlformats.org/drawingml/2006/main" xmlns:r="http://schemas.openxmlformats.org/officeDocument/2006/relationships" xmlns:p="http://schemas.openxmlformats.org/presentationml/2006/main">
   <p:cSld>
     <p:spTree>
@@ -16900,7 +17124,7 @@
 </p:sld>
 </file>
 
-<file path=ppt/slides/slide46.xml><?xml version="1.0" encoding="utf-8"?>
+<file path=ppt/slides/slide47.xml><?xml version="1.0" encoding="utf-8"?>
 <p:sld xmlns:a="http://schemas.openxmlformats.org/drawingml/2006/main" xmlns:r="http://schemas.openxmlformats.org/officeDocument/2006/relationships" xmlns:p="http://schemas.openxmlformats.org/presentationml/2006/main">
   <p:cSld>
     <p:spTree>
@@ -16982,7 +17206,7 @@
 </p:sld>
 </file>
 
-<file path=ppt/slides/slide47.xml><?xml version="1.0" encoding="utf-8"?>
+<file path=ppt/slides/slide48.xml><?xml version="1.0" encoding="utf-8"?>
 <p:sld xmlns:a="http://schemas.openxmlformats.org/drawingml/2006/main" xmlns:r="http://schemas.openxmlformats.org/officeDocument/2006/relationships" xmlns:p="http://schemas.openxmlformats.org/presentationml/2006/main">
   <p:cSld>
     <p:spTree>
@@ -17095,7 +17319,7 @@
 </p:sld>
 </file>
 
-<file path=ppt/slides/slide48.xml><?xml version="1.0" encoding="utf-8"?>
+<file path=ppt/slides/slide49.xml><?xml version="1.0" encoding="utf-8"?>
 <p:sld xmlns:a="http://schemas.openxmlformats.org/drawingml/2006/main" xmlns:r="http://schemas.openxmlformats.org/officeDocument/2006/relationships" xmlns:p="http://schemas.openxmlformats.org/presentationml/2006/main">
   <p:cSld>
     <p:spTree>
@@ -17328,129 +17552,6 @@
 </p:sld>
 </file>
 
-<file path=ppt/slides/slide49.xml><?xml version="1.0" encoding="utf-8"?>
-<p:sld xmlns:a="http://schemas.openxmlformats.org/drawingml/2006/main" xmlns:r="http://schemas.openxmlformats.org/officeDocument/2006/relationships" xmlns:p="http://schemas.openxmlformats.org/presentationml/2006/main">
-  <p:cSld>
-    <p:spTree>
-      <p:nvGrpSpPr>
-        <p:cNvPr id="1" name=""/>
-        <p:cNvGrpSpPr/>
-        <p:nvPr/>
-      </p:nvGrpSpPr>
-      <p:grpSpPr>
-        <a:xfrm>
-          <a:off x="0" y="0"/>
-          <a:ext cx="0" cy="0"/>
-          <a:chOff x="0" y="0"/>
-          <a:chExt cx="0" cy="0"/>
-        </a:xfrm>
-      </p:grpSpPr>
-      <p:sp>
-        <p:nvSpPr>
-          <p:cNvPr id="2" name="Title 1"/>
-          <p:cNvSpPr>
-            <a:spLocks noGrp="1"/>
-          </p:cNvSpPr>
-          <p:nvPr>
-            <p:ph type="title"/>
-          </p:nvPr>
-        </p:nvSpPr>
-        <p:spPr>
-          <a:xfrm>
-            <a:off x="457200" y="205979"/>
-            <a:ext cx="8229600" cy="857250"/>
-          </a:xfrm>
-        </p:spPr>
-        <p:txBody>
-          <a:bodyPr/>
-          <a:lstStyle/>
-          <a:p>
-            <a:pPr lvl="0" indent="0" marL="0">
-              <a:buNone/>
-            </a:pPr>
-            <a:r>
-              <a:rPr/>
-              <a:t>A high support-vector fraction is a free warning</a:t>
-            </a:r>
-          </a:p>
-        </p:txBody>
-      </p:sp>
-      <p:sp>
-        <p:nvSpPr>
-          <p:cNvPr id="3" name="Content Placeholder 2"/>
-          <p:cNvSpPr>
-            <a:spLocks noGrp="1"/>
-          </p:cNvSpPr>
-          <p:nvPr>
-            <p:ph idx="1"/>
-          </p:nvPr>
-        </p:nvSpPr>
-        <p:spPr>
-          <a:xfrm>
-            <a:off x="457200" y="1200151"/>
-            <a:ext cx="8229600" cy="3394472"/>
-          </a:xfrm>
-        </p:spPr>
-        <p:txBody>
-          <a:bodyPr/>
-          <a:lstStyle/>
-          <a:p>
-            <a:pPr lvl="0"/>
-            <a:r>
-              <a:rPr/>
-              <a:t>The linear model needs </a:t>
-            </a:r>
-            <a:r>
-              <a:rPr b="1"/>
-              <a:t>79%</a:t>
-            </a:r>
-            <a:r>
-              <a:rPr/>
-              <a:t> of the training set to define its boundary</a:t>
-            </a:r>
-          </a:p>
-          <a:p>
-            <a:pPr lvl="0"/>
-            <a:r>
-              <a:rPr/>
-              <a:t>The RBF model needs </a:t>
-            </a:r>
-            <a:r>
-              <a:rPr b="1"/>
-              <a:t>23%</a:t>
-            </a:r>
-          </a:p>
-          <a:p>
-            <a:pPr lvl="0"/>
-            <a:r>
-              <a:rPr/>
-              <a:t>Almost every point sits on or inside the margin: there is no slab that separates anything</a:t>
-            </a:r>
-          </a:p>
-          <a:p>
-            <a:pPr lvl="0"/>
-            <a:r>
-              <a:rPr/>
-              <a:t>The count falls out of </a:t>
-            </a:r>
-            <a:r>
-              <a:rPr>
-                <a:latin typeface="Courier"/>
-              </a:rPr>
-              <a:t>fit</a:t>
-            </a:r>
-            <a:r>
-              <a:rPr/>
-              <a:t> at no cost, and you should look at it</a:t>
-            </a:r>
-          </a:p>
-        </p:txBody>
-      </p:sp>
-    </p:spTree>
-  </p:cSld>
-</p:sld>
-</file>
-
 <file path=ppt/slides/slide5.xml><?xml version="1.0" encoding="utf-8"?>
 <p:sld xmlns:a="http://schemas.openxmlformats.org/drawingml/2006/main" xmlns:r="http://schemas.openxmlformats.org/officeDocument/2006/relationships" xmlns:p="http://schemas.openxmlformats.org/presentationml/2006/main">
   <p:cSld>
@@ -17575,7 +17676,7 @@
             </a:pPr>
             <a:r>
               <a:rPr/>
-              <a:t>The kernel trick: they needed different coordinates</a:t>
+              <a:t>A high support-vector fraction is a free warning</a:t>
             </a:r>
           </a:p>
         </p:txBody>
@@ -17603,36 +17704,50 @@
             <a:pPr lvl="0"/>
             <a:r>
               <a:rPr/>
-              <a:t>Healthy pumps in a disc, faulty ones around it: no line works </a:t>
+              <a:t>The linear model needs </a:t>
             </a:r>
             <a:r>
               <a:rPr b="1"/>
-              <a:t>in the plane</a:t>
+              <a:t>79%</a:t>
+            </a:r>
+            <a:r>
+              <a:rPr/>
+              <a:t> of the training set to define its boundary</a:t>
             </a:r>
           </a:p>
           <a:p>
             <a:pPr lvl="0"/>
             <a:r>
               <a:rPr/>
-              <a:t>Add a third coordinate: the </a:t>
+              <a:t>The RBF model needs </a:t>
             </a:r>
             <a:r>
               <a:rPr b="1"/>
-              <a:t>distance from the design point</a:t>
+              <a:t>23%</a:t>
             </a:r>
           </a:p>
           <a:p>
             <a:pPr lvl="0"/>
             <a:r>
               <a:rPr/>
-              <a:t>Healthy pumps rise a little, faulty ones a lot, and a flat plane separates them perfectly</a:t>
+              <a:t>Almost every point sits on or inside the margin: there is no slab that separates anything</a:t>
             </a:r>
           </a:p>
           <a:p>
             <a:pPr lvl="0"/>
             <a:r>
               <a:rPr/>
-              <a:t>The classes were always separable. They were measured in the wrong coordinates</a:t>
+              <a:t>The count falls out of </a:t>
+            </a:r>
+            <a:r>
+              <a:rPr>
+                <a:latin typeface="Courier"/>
+              </a:rPr>
+              <a:t>fit</a:t>
+            </a:r>
+            <a:r>
+              <a:rPr/>
+              <a:t> at no cost, and you should look at it</a:t>
             </a:r>
           </a:p>
         </p:txBody>
@@ -17643,6 +17758,115 @@
 </file>
 
 <file path=ppt/slides/slide51.xml><?xml version="1.0" encoding="utf-8"?>
+<p:sld xmlns:a="http://schemas.openxmlformats.org/drawingml/2006/main" xmlns:r="http://schemas.openxmlformats.org/officeDocument/2006/relationships" xmlns:p="http://schemas.openxmlformats.org/presentationml/2006/main">
+  <p:cSld>
+    <p:spTree>
+      <p:nvGrpSpPr>
+        <p:cNvPr id="1" name=""/>
+        <p:cNvGrpSpPr/>
+        <p:nvPr/>
+      </p:nvGrpSpPr>
+      <p:grpSpPr>
+        <a:xfrm>
+          <a:off x="0" y="0"/>
+          <a:ext cx="0" cy="0"/>
+          <a:chOff x="0" y="0"/>
+          <a:chExt cx="0" cy="0"/>
+        </a:xfrm>
+      </p:grpSpPr>
+      <p:sp>
+        <p:nvSpPr>
+          <p:cNvPr id="2" name="Title 1"/>
+          <p:cNvSpPr>
+            <a:spLocks noGrp="1"/>
+          </p:cNvSpPr>
+          <p:nvPr>
+            <p:ph type="title"/>
+          </p:nvPr>
+        </p:nvSpPr>
+        <p:spPr>
+          <a:xfrm>
+            <a:off x="457200" y="205979"/>
+            <a:ext cx="8229600" cy="857250"/>
+          </a:xfrm>
+        </p:spPr>
+        <p:txBody>
+          <a:bodyPr/>
+          <a:lstStyle/>
+          <a:p>
+            <a:pPr lvl="0" indent="0" marL="0">
+              <a:buNone/>
+            </a:pPr>
+            <a:r>
+              <a:rPr/>
+              <a:t>The kernel trick: they needed different coordinates</a:t>
+            </a:r>
+          </a:p>
+        </p:txBody>
+      </p:sp>
+      <p:sp>
+        <p:nvSpPr>
+          <p:cNvPr id="3" name="Content Placeholder 2"/>
+          <p:cNvSpPr>
+            <a:spLocks noGrp="1"/>
+          </p:cNvSpPr>
+          <p:nvPr>
+            <p:ph idx="1"/>
+          </p:nvPr>
+        </p:nvSpPr>
+        <p:spPr>
+          <a:xfrm>
+            <a:off x="457200" y="1200151"/>
+            <a:ext cx="8229600" cy="3394472"/>
+          </a:xfrm>
+        </p:spPr>
+        <p:txBody>
+          <a:bodyPr/>
+          <a:lstStyle/>
+          <a:p>
+            <a:pPr lvl="0"/>
+            <a:r>
+              <a:rPr/>
+              <a:t>Healthy pumps in a disc, faulty ones around it: no line works </a:t>
+            </a:r>
+            <a:r>
+              <a:rPr b="1"/>
+              <a:t>in the plane</a:t>
+            </a:r>
+          </a:p>
+          <a:p>
+            <a:pPr lvl="0"/>
+            <a:r>
+              <a:rPr/>
+              <a:t>Add a third coordinate: the </a:t>
+            </a:r>
+            <a:r>
+              <a:rPr b="1"/>
+              <a:t>distance from the design point</a:t>
+            </a:r>
+          </a:p>
+          <a:p>
+            <a:pPr lvl="0"/>
+            <a:r>
+              <a:rPr/>
+              <a:t>Healthy pumps rise a little, faulty ones a lot, and a flat plane separates them perfectly</a:t>
+            </a:r>
+          </a:p>
+          <a:p>
+            <a:pPr lvl="0"/>
+            <a:r>
+              <a:rPr/>
+              <a:t>The classes were always separable. They were measured in the wrong coordinates</a:t>
+            </a:r>
+          </a:p>
+        </p:txBody>
+      </p:sp>
+    </p:spTree>
+  </p:cSld>
+</p:sld>
+</file>
+
+<file path=ppt/slides/slide52.xml><?xml version="1.0" encoding="utf-8"?>
 <p:sld xmlns:a="http://schemas.openxmlformats.org/drawingml/2006/main" xmlns:r="http://schemas.openxmlformats.org/officeDocument/2006/relationships" xmlns:p="http://schemas.openxmlformats.org/presentationml/2006/main">
   <p:cSld>
     <p:spTree>
@@ -17724,7 +17948,7 @@
 </p:sld>
 </file>
 
-<file path=ppt/slides/slide52.xml><?xml version="1.0" encoding="utf-8"?>
+<file path=ppt/slides/slide53.xml><?xml version="1.0" encoding="utf-8"?>
 <p:sld xmlns:a="http://schemas.openxmlformats.org/drawingml/2006/main" xmlns:r="http://schemas.openxmlformats.org/officeDocument/2006/relationships" xmlns:p="http://schemas.openxmlformats.org/presentationml/2006/main">
   <p:cSld>
     <p:spTree>
@@ -17842,7 +18066,7 @@
 </p:sld>
 </file>
 
-<file path=ppt/slides/slide53.xml><?xml version="1.0" encoding="utf-8"?>
+<file path=ppt/slides/slide54.xml><?xml version="1.0" encoding="utf-8"?>
 <p:sld xmlns:a="http://schemas.openxmlformats.org/drawingml/2006/main" xmlns:r="http://schemas.openxmlformats.org/officeDocument/2006/relationships" xmlns:p="http://schemas.openxmlformats.org/presentationml/2006/main">
   <p:cSld>
     <p:spTree>
@@ -18067,7 +18291,7 @@
 </p:sld>
 </file>
 
-<file path=ppt/slides/slide54.xml><?xml version="1.0" encoding="utf-8"?>
+<file path=ppt/slides/slide55.xml><?xml version="1.0" encoding="utf-8"?>
 <p:sld xmlns:a="http://schemas.openxmlformats.org/drawingml/2006/main" xmlns:r="http://schemas.openxmlformats.org/officeDocument/2006/relationships" xmlns:p="http://schemas.openxmlformats.org/presentationml/2006/main">
   <p:cSld>
     <p:spTree>
@@ -18149,7 +18373,7 @@
 </p:sld>
 </file>
 
-<file path=ppt/slides/slide55.xml><?xml version="1.0" encoding="utf-8"?>
+<file path=ppt/slides/slide56.xml><?xml version="1.0" encoding="utf-8"?>
 <p:sld xmlns:a="http://schemas.openxmlformats.org/drawingml/2006/main" xmlns:r="http://schemas.openxmlformats.org/officeDocument/2006/relationships" xmlns:p="http://schemas.openxmlformats.org/presentationml/2006/main">
   <p:cSld>
     <p:spTree>
@@ -18274,7 +18498,7 @@
 </p:sld>
 </file>
 
-<file path=ppt/slides/slide56.xml><?xml version="1.0" encoding="utf-8"?>
+<file path=ppt/slides/slide57.xml><?xml version="1.0" encoding="utf-8"?>
 <p:sld xmlns:a="http://schemas.openxmlformats.org/drawingml/2006/main" xmlns:r="http://schemas.openxmlformats.org/officeDocument/2006/relationships" xmlns:p="http://schemas.openxmlformats.org/presentationml/2006/main">
   <p:cSld>
     <p:spTree>
@@ -18516,7 +18740,7 @@
 </p:sld>
 </file>
 
-<file path=ppt/slides/slide57.xml><?xml version="1.0" encoding="utf-8"?>
+<file path=ppt/slides/slide58.xml><?xml version="1.0" encoding="utf-8"?>
 <p:sld xmlns:a="http://schemas.openxmlformats.org/drawingml/2006/main" xmlns:r="http://schemas.openxmlformats.org/officeDocument/2006/relationships" xmlns:p="http://schemas.openxmlformats.org/presentationml/2006/main">
   <p:cSld>
     <p:spTree>
@@ -18598,7 +18822,7 @@
 </p:sld>
 </file>
 
-<file path=ppt/slides/slide58.xml><?xml version="1.0" encoding="utf-8"?>
+<file path=ppt/slides/slide59.xml><?xml version="1.0" encoding="utf-8"?>
 <p:sld xmlns:a="http://schemas.openxmlformats.org/drawingml/2006/main" xmlns:r="http://schemas.openxmlformats.org/officeDocument/2006/relationships" xmlns:p="http://schemas.openxmlformats.org/presentationml/2006/main">
   <p:cSld>
     <p:spTree>
@@ -18870,88 +19094,6 @@
 </p:sld>
 </file>
 
-<file path=ppt/slides/slide59.xml><?xml version="1.0" encoding="utf-8"?>
-<p:sld xmlns:a="http://schemas.openxmlformats.org/drawingml/2006/main" xmlns:r="http://schemas.openxmlformats.org/officeDocument/2006/relationships" xmlns:p="http://schemas.openxmlformats.org/presentationml/2006/main">
-  <p:cSld>
-    <p:spTree>
-      <p:nvGrpSpPr>
-        <p:cNvPr id="1" name=""/>
-        <p:cNvGrpSpPr/>
-        <p:nvPr/>
-      </p:nvGrpSpPr>
-      <p:grpSpPr>
-        <a:xfrm>
-          <a:off x="0" y="0"/>
-          <a:ext cx="0" cy="0"/>
-          <a:chOff x="0" y="0"/>
-          <a:chExt cx="0" cy="0"/>
-        </a:xfrm>
-      </p:grpSpPr>
-      <p:sp>
-        <p:nvSpPr>
-          <p:cNvPr id="2" name="Title 1"/>
-          <p:cNvSpPr>
-            <a:spLocks noGrp="1"/>
-          </p:cNvSpPr>
-          <p:nvPr>
-            <p:ph type="title"/>
-          </p:nvPr>
-        </p:nvSpPr>
-        <p:spPr>
-          <a:xfrm>
-            <a:off x="457200" y="205979"/>
-            <a:ext cx="8229600" cy="857250"/>
-          </a:xfrm>
-        </p:spPr>
-        <p:txBody>
-          <a:bodyPr/>
-          <a:lstStyle/>
-          <a:p>
-            <a:pPr lvl="0" indent="0" marL="0">
-              <a:buNone/>
-            </a:pPr>
-            <a:r>
-              <a:rPr/>
-              <a:t>How far one vote reaches</a:t>
-            </a:r>
-          </a:p>
-        </p:txBody>
-      </p:sp>
-      <p:pic>
-        <p:nvPicPr>
-          <p:cNvPr descr="rbf_reach.png" id="0" name="Picture 1"/>
-          <p:cNvPicPr>
-            <a:picLocks noGrp="1" noChangeAspect="1"/>
-          </p:cNvPicPr>
-          <p:nvPr/>
-        </p:nvPicPr>
-        <p:blipFill>
-          <a:blip r:embed="rId3"/>
-          <a:stretch>
-            <a:fillRect/>
-          </a:stretch>
-        </p:blipFill>
-        <p:spPr bwMode="auto">
-          <a:xfrm>
-            <a:off x="1419471" y="1166099"/>
-            <a:ext cx="6305058" cy="3360181"/>
-          </a:xfrm>
-          <a:prstGeom prst="rect">
-            <a:avLst/>
-          </a:prstGeom>
-          <a:noFill/>
-          <a:ln w="9525">
-            <a:noFill/>
-            <a:headEnd/>
-            <a:tailEnd/>
-          </a:ln>
-        </p:spPr>
-      </p:pic>
-    </p:spTree>
-  </p:cSld>
-</p:sld>
-</file>
-
 <file path=ppt/slides/slide6.xml><?xml version="1.0" encoding="utf-8"?>
 <p:sld xmlns:a="http://schemas.openxmlformats.org/drawingml/2006/main" xmlns:r="http://schemas.openxmlformats.org/officeDocument/2006/relationships" xmlns:p="http://schemas.openxmlformats.org/presentationml/2006/main">
   <p:cSld>
@@ -19172,6 +19314,88 @@
             </a:pPr>
             <a:r>
               <a:rPr/>
+              <a:t>How far one vote reaches</a:t>
+            </a:r>
+          </a:p>
+        </p:txBody>
+      </p:sp>
+      <p:pic>
+        <p:nvPicPr>
+          <p:cNvPr descr="rbf_reach.png" id="0" name="Picture 1"/>
+          <p:cNvPicPr>
+            <a:picLocks noGrp="1" noChangeAspect="1"/>
+          </p:cNvPicPr>
+          <p:nvPr/>
+        </p:nvPicPr>
+        <p:blipFill>
+          <a:blip r:embed="rId3"/>
+          <a:stretch>
+            <a:fillRect/>
+          </a:stretch>
+        </p:blipFill>
+        <p:spPr bwMode="auto">
+          <a:xfrm>
+            <a:off x="1419471" y="1166099"/>
+            <a:ext cx="6305058" cy="3360181"/>
+          </a:xfrm>
+          <a:prstGeom prst="rect">
+            <a:avLst/>
+          </a:prstGeom>
+          <a:noFill/>
+          <a:ln w="9525">
+            <a:noFill/>
+            <a:headEnd/>
+            <a:tailEnd/>
+          </a:ln>
+        </p:spPr>
+      </p:pic>
+    </p:spTree>
+  </p:cSld>
+</p:sld>
+</file>
+
+<file path=ppt/slides/slide61.xml><?xml version="1.0" encoding="utf-8"?>
+<p:sld xmlns:a="http://schemas.openxmlformats.org/drawingml/2006/main" xmlns:r="http://schemas.openxmlformats.org/officeDocument/2006/relationships" xmlns:p="http://schemas.openxmlformats.org/presentationml/2006/main">
+  <p:cSld>
+    <p:spTree>
+      <p:nvGrpSpPr>
+        <p:cNvPr id="1" name=""/>
+        <p:cNvGrpSpPr/>
+        <p:nvPr/>
+      </p:nvGrpSpPr>
+      <p:grpSpPr>
+        <a:xfrm>
+          <a:off x="0" y="0"/>
+          <a:ext cx="0" cy="0"/>
+          <a:chOff x="0" y="0"/>
+          <a:chExt cx="0" cy="0"/>
+        </a:xfrm>
+      </p:grpSpPr>
+      <p:sp>
+        <p:nvSpPr>
+          <p:cNvPr id="2" name="Title 1"/>
+          <p:cNvSpPr>
+            <a:spLocks noGrp="1"/>
+          </p:cNvSpPr>
+          <p:nvPr>
+            <p:ph type="title"/>
+          </p:nvPr>
+        </p:nvSpPr>
+        <p:spPr>
+          <a:xfrm>
+            <a:off x="457200" y="205979"/>
+            <a:ext cx="8229600" cy="857250"/>
+          </a:xfrm>
+        </p:spPr>
+        <p:txBody>
+          <a:bodyPr/>
+          <a:lstStyle/>
+          <a:p>
+            <a:pPr lvl="0" indent="0" marL="0">
+              <a:buNone/>
+            </a:pPr>
+            <a:r>
+              <a:rPr/>
               <a:t>Overfitting you can see</a:t>
             </a:r>
           </a:p>
@@ -19212,7 +19436,7 @@
 </p:sld>
 </file>
 
-<file path=ppt/slides/slide61.xml><?xml version="1.0" encoding="utf-8"?>
+<file path=ppt/slides/slide62.xml><?xml version="1.0" encoding="utf-8"?>
 <p:sld xmlns:a="http://schemas.openxmlformats.org/drawingml/2006/main" xmlns:r="http://schemas.openxmlformats.org/officeDocument/2006/relationships" xmlns:p="http://schemas.openxmlformats.org/presentationml/2006/main">
   <p:cSld>
     <p:spTree>
@@ -19292,7 +19516,7 @@
 </p:sld>
 </file>
 
-<file path=ppt/slides/slide62.xml><?xml version="1.0" encoding="utf-8"?>
+<file path=ppt/slides/slide63.xml><?xml version="1.0" encoding="utf-8"?>
 <p:sld xmlns:a="http://schemas.openxmlformats.org/drawingml/2006/main" xmlns:r="http://schemas.openxmlformats.org/officeDocument/2006/relationships" xmlns:p="http://schemas.openxmlformats.org/presentationml/2006/main">
   <p:cSld>
     <p:spTree>
@@ -19630,7 +19854,7 @@
 </p:sld>
 </file>
 
-<file path=ppt/slides/slide63.xml><?xml version="1.0" encoding="utf-8"?>
+<file path=ppt/slides/slide64.xml><?xml version="1.0" encoding="utf-8"?>
 <p:sld xmlns:a="http://schemas.openxmlformats.org/drawingml/2006/main" xmlns:r="http://schemas.openxmlformats.org/officeDocument/2006/relationships" xmlns:p="http://schemas.openxmlformats.org/presentationml/2006/main">
   <p:cSld>
     <p:spTree>
@@ -19908,7 +20132,7 @@
 </p:sld>
 </file>
 
-<file path=ppt/slides/slide64.xml><?xml version="1.0" encoding="utf-8"?>
+<file path=ppt/slides/slide65.xml><?xml version="1.0" encoding="utf-8"?>
 <p:sld xmlns:a="http://schemas.openxmlformats.org/drawingml/2006/main" xmlns:r="http://schemas.openxmlformats.org/officeDocument/2006/relationships" xmlns:p="http://schemas.openxmlformats.org/presentationml/2006/main">
   <p:cSld>
     <p:spTree>
@@ -20040,7 +20264,7 @@
 </p:sld>
 </file>
 
-<file path=ppt/slides/slide65.xml><?xml version="1.0" encoding="utf-8"?>
+<file path=ppt/slides/slide66.xml><?xml version="1.0" encoding="utf-8"?>
 <p:sld xmlns:a="http://schemas.openxmlformats.org/drawingml/2006/main" xmlns:r="http://schemas.openxmlformats.org/officeDocument/2006/relationships" xmlns:p="http://schemas.openxmlformats.org/presentationml/2006/main">
   <p:cSld>
     <p:spTree>

</xml_diff>

<commit_message>
Read lesson 6's 1/(1 + e^-Delta) as odds
The step from two log totals to a probability was shown as algebra only.
Section 4.2 and slide 33 now add the reading that makes it obvious: e^3.951
is about 52, so faulty is 52 to 1 against healthy, and 52 to 1 is a
probability of 52/53 = 0.981 - 1/(1 + e^-Delta) is odds over odds plus one.
The division step also names the identity it uses, e^a/e^b = e^(a-b).

Co-Authored-By: Claude Opus 5.5 <noreply@anthropic.com>
</commit_message>
<xml_diff>
--- a/Lessons/06_knn_naive_bayes_svm/Slides/knn_naive_bayes_svm_slides.pptx
+++ b/Lessons/06_knn_naive_bayes_svm/Slides/knn_naive_bayes_svm_slides.pptx
@@ -3617,7 +3617,21 @@
             </a:pPr>
             <a:r>
               <a:rPr/>
-              <a:t>Now divide the top and the bottom of that fraction by the faulty score. What is left is 1 / (1 + e^(healthy total − faulty total)) - only the GAP between the totals survives. That gap, 3.951, is the log-odds: faulty is e^3.951, about 52 times, as likely as healthy.</a:t>
+              <a:t>Now divide the top and the bottom of that fraction by the faulty score - the fraction does not change. The ratio of the two scores is e^(healthy total) / e^(faulty total) = e^(healthy total − faulty total), so what is left is 1 / (1 + e^(−3.951)): only the GAP between the totals survives.</a:t>
+            </a:r>
+          </a:p>
+          <a:p>
+            <a:pPr lvl="0" indent="0" marL="0">
+              <a:buNone/>
+            </a:pPr>
+          </a:p>
+          <a:p>
+            <a:pPr lvl="0" indent="0" marL="0">
+              <a:buNone/>
+            </a:pPr>
+            <a:r>
+              <a:rPr/>
+              <a:t>Then give them the reading that makes it obvious: that gap is the log-odds, and e^3.951 is about 52. Faulty is 52 times as likely as healthy - odds of 52 to 1 - and 52 to 1 is a probability of 52/53 = 0.981, the way anyone would compute it for a bet. 1 / (1 + e^(−Δ)) is just odds over odds plus one, rewritten. The same 0.981 also comes out of normalising directly, 0.01585 / (0.01585 + 0.000305).</a:t>
             </a:r>
           </a:p>
           <a:p>
@@ -15265,7 +15279,15 @@
             <a:pPr lvl="0"/>
             <a:r>
               <a:rPr/>
-              <a:t>Check: e^(−4.144) / (e^(−4.144) + e^(−8.095)) = 0.01585 / 0.01616 = 0.981</a:t>
+              <a:t>As odds: e^3.951 ≈ 52, so </a:t>
+            </a:r>
+            <a:r>
+              <a:rPr b="1"/>
+              <a:t>52 to 1</a:t>
+            </a:r>
+            <a:r>
+              <a:rPr/>
+              <a:t>, and 52 / 53 = 0.981</a:t>
             </a:r>
           </a:p>
         </p:txBody>

</xml_diff>

<commit_message>
Make lesson 6's slides 32-35 say what they had left implicit
A student-eye reading found ten gaps. Slide 32 gave only the log form: it
now shows the log of the product equal to the sum of logs, names them as
natural logs, and states in its title why the winner does not change. Slide
33 listed log values unconnected to anything shown: each class now has a
value row (prior from slide 30, bell heights from slide 31, product 0.000305
or 0.01585) above its ln row, so the product and the sum sit side by side
and +0.598 reads as ln 1.818. Slide 34 names total probability as why the
sum of the scores is P(x). Slide 35 spells out the score ratio, the rule
e^a / e^b = e^(a - b), P(healthy) as 1 - 0.981, the odds as the ratio of the
two scores, and why the gap form is used at all.

Co-Authored-By: Claude Opus 5.5 <noreply@anthropic.com>
</commit_message>
<xml_diff>
--- a/Lessons/06_knn_naive_bayes_svm/Slides/knn_naive_bayes_svm_slides.pptx
+++ b/Lessons/06_knn_naive_bayes_svm/Slides/knn_naive_bayes_svm_slides.pptx
@@ -3495,7 +3495,7 @@
             </a:pPr>
             <a:r>
               <a:rPr/>
-              <a:t>Until now the classifier has been a product: prior times one density per reading. Say why nobody computes it that way. With hundreds of features the product is hundreds of small numbers multiplied together, and it underflows to exactly zero in floating point - 0.5 to the power 300 is already 5 times 10 to the minus 91, and real likelihoods are far smaller than 0.5. Every class then scores zero and nothing can be compared.</a:t>
+              <a:t>Inside the bracket on the left is the classifier as slides 26 and 28 built it: prior times one density per reading, the class with the largest product winning. The equation says its log is a sum, and the title says why that is allowed: ln is increasing, so the class with the largest product is also the class with the largest log. The logs are natural logs - base e - which matters two slides on, when we undo them with e. Say why nobody computes the left-hand side directly. With hundreds of features the product is hundreds of small numbers multiplied together, and it underflows to exactly zero in floating point - 0.5 to the power 300 is already 5 times 10 to the minus 91, and real likelihoods are far smaller than 0.5. Every class then scores zero and nothing can be compared.</a:t>
             </a:r>
           </a:p>
           <a:p>
@@ -3605,7 +3605,7 @@
             </a:pPr>
             <a:r>
               <a:rPr/>
-              <a:t>This is inference, and it is worth saying how little it is. For each class, take the log prior and add one number per reading: the log of that class’s bell, evaluated at the reading. Compare the totals. That is the prediction. No training row is consulted - only the ten stored numbers - which is the exact opposite of k-NN, where prediction is the whole cost.</a:t>
+              <a:t>This is inference, and it is worth saying how little it is. Read each class as two rows. The value row is the product form: the prior from slide 30, and the height of that class’s bell at each reading - the dots on slide 31 - each density conditional on the class. Multiply across and you get the score. The ln row is the same numbers logged, and the sum across is the log score. The last column is the point of the previous slide: e^(−8.095) is 0.000305, so the sum of logs and the product carry the same information. Compare the totals: that is the prediction. No training row is consulted - only the ten stored numbers - which is the exact opposite of k-NN, where prediction is the whole cost.</a:t>
             </a:r>
           </a:p>
           <a:p>
@@ -3743,7 +3743,7 @@
             </a:pPr>
             <a:r>
               <a:rPr/>
-              <a:t>Row 3 is slide 26’s normalisation, now with numbers. The sum of the two scores, 0.01616, is P(x), the denominator Bayes’ rule had and we dropped to choose the class. Dividing each score by it gives probabilities that add to one: 0.000305 / 0.01616 = 0.019 for healthy, 0.01585 / 0.01616 = 0.981 for faulty. Ask them to check the two add to one before moving on.</a:t>
+              <a:t>Row 3 is slide 26’s normalisation, now with numbers. Why the sum of the two scores is P(x): by the law of total probability a pump’s readings arise either from a healthy pump or from a faulty one, so P(x) = P(healthy) P(x | healthy) + P(faulty) P(x | faulty) - the two scores added. It is the denominator of slide 25’s Bayes’ rule, the one we dropped to choose the class. Dividing each score by it gives probabilities that add to one: 0.000305 / 0.01616 = 0.019 for healthy, 0.01585 / 0.01616 = 0.981 for faulty. Ask them to check the two add to one before moving on.</a:t>
             </a:r>
           </a:p>
           <a:p>
@@ -15135,14 +15135,14 @@
             </a:pPr>
             <a:r>
               <a:rPr/>
-              <a:t>Add the logs, do not multiply</a:t>
+              <a:t>Add the natural logs: same winner</a:t>
             </a:r>
           </a:p>
         </p:txBody>
       </p:sp>
       <p:pic>
         <p:nvPicPr>
-          <p:cNvPr descr="eq_97fca50ccb.png" id="0" name="Picture 1"/>
+          <p:cNvPr descr="eq_bcbcc80b6d.png" id="0" name="Picture 1"/>
           <p:cNvPicPr>
             <a:picLocks noGrp="1" noChangeAspect="1"/>
           </p:cNvPicPr>
@@ -15156,8 +15156,8 @@
         </p:blipFill>
         <p:spPr bwMode="auto">
           <a:xfrm>
-            <a:off x="457205" y="2408040"/>
-            <a:ext cx="8229590" cy="876299"/>
+            <a:off x="457200" y="2490589"/>
+            <a:ext cx="8229600" cy="711200"/>
           </a:xfrm>
           <a:prstGeom prst="rect">
             <a:avLst/>
@@ -15217,7 +15217,7 @@
             </a:pPr>
             <a:r>
               <a:rPr/>
-              <a:t>48 Hz, 5.6 bar: faulty, 0.981</a:t>
+              <a:t>48 Hz, 5.6 bar: scores and their logs</a:t>
             </a:r>
           </a:p>
         </p:txBody>
@@ -15243,11 +15243,12 @@
                 <a:tableStyleId>{5C22544A-7EE6-4342-B048-85BDC9FD1C3A}</a:tableStyleId>
               </a:tblPr>
               <a:tblGrid>
-                <a:gridCol w="1645920"/>
-                <a:gridCol w="1645920"/>
-                <a:gridCol w="1645920"/>
-                <a:gridCol w="1645920"/>
-                <a:gridCol w="1645920"/>
+                <a:gridCol w="1371600"/>
+                <a:gridCol w="1371600"/>
+                <a:gridCol w="1371600"/>
+                <a:gridCol w="1371600"/>
+                <a:gridCol w="1371600"/>
+                <a:gridCol w="1371600"/>
               </a:tblGrid>
               <a:tr h="0">
                 <a:tc>
@@ -15271,12 +15272,22 @@
                     <a:bodyPr/>
                     <a:lstStyle/>
                     <a:p>
+                      <a:endParaRPr/>
+                    </a:p>
+                  </a:txBody>
+                  <a:tcPr/>
+                </a:tc>
+                <a:tc>
+                  <a:txBody>
+                    <a:bodyPr/>
+                    <a:lstStyle/>
+                    <a:p>
                       <a:pPr lvl="0" indent="0" marL="0">
                         <a:buNone/>
                       </a:pPr>
                       <a:r>
                         <a:rPr/>
-                        <a:t>log prior</a:t>
+                        <a:t>Prior</a:t>
                       </a:r>
                     </a:p>
                   </a:txBody>
@@ -15292,7 +15303,7 @@
                       </a:pPr>
                       <a:r>
                         <a:rPr/>
-                        <a:t>log P(vibration)</a:t>
+                        <a:t>Vibration density</a:t>
                       </a:r>
                     </a:p>
                   </a:txBody>
@@ -15308,7 +15319,7 @@
                       </a:pPr>
                       <a:r>
                         <a:rPr/>
-                        <a:t>log P(pressure)</a:t>
+                        <a:t>Pressure density</a:t>
                       </a:r>
                     </a:p>
                   </a:txBody>
@@ -15324,7 +15335,7 @@
                       </a:pPr>
                       <a:r>
                         <a:rPr/>
-                        <a:t>Total</a:t>
+                        <a:t>Product, or sum of logs</a:t>
                       </a:r>
                     </a:p>
                   </a:txBody>
@@ -15343,6 +15354,113 @@
                       <a:r>
                         <a:rPr/>
                         <a:t>Healthy</a:t>
+                      </a:r>
+                    </a:p>
+                  </a:txBody>
+                </a:tc>
+                <a:tc>
+                  <a:txBody>
+                    <a:bodyPr/>
+                    <a:lstStyle/>
+                    <a:p>
+                      <a:pPr lvl="0" indent="0" marL="0">
+                        <a:buNone/>
+                      </a:pPr>
+                      <a:r>
+                        <a:rPr/>
+                        <a:t>value</a:t>
+                      </a:r>
+                    </a:p>
+                  </a:txBody>
+                </a:tc>
+                <a:tc>
+                  <a:txBody>
+                    <a:bodyPr/>
+                    <a:lstStyle/>
+                    <a:p>
+                      <a:pPr lvl="0" indent="0" marL="0">
+                        <a:buNone/>
+                      </a:pPr>
+                      <a:r>
+                        <a:rPr/>
+                        <a:t>0.3875</a:t>
+                      </a:r>
+                    </a:p>
+                  </a:txBody>
+                </a:tc>
+                <a:tc>
+                  <a:txBody>
+                    <a:bodyPr/>
+                    <a:lstStyle/>
+                    <a:p>
+                      <a:pPr lvl="0" indent="0" marL="0">
+                        <a:buNone/>
+                      </a:pPr>
+                      <a:r>
+                        <a:rPr/>
+                        <a:t>0.000433</a:t>
+                      </a:r>
+                    </a:p>
+                  </a:txBody>
+                </a:tc>
+                <a:tc>
+                  <a:txBody>
+                    <a:bodyPr/>
+                    <a:lstStyle/>
+                    <a:p>
+                      <a:pPr lvl="0" indent="0" marL="0">
+                        <a:buNone/>
+                      </a:pPr>
+                      <a:r>
+                        <a:rPr/>
+                        <a:t>1.818</a:t>
+                      </a:r>
+                    </a:p>
+                  </a:txBody>
+                </a:tc>
+                <a:tc>
+                  <a:txBody>
+                    <a:bodyPr/>
+                    <a:lstStyle/>
+                    <a:p>
+                      <a:pPr lvl="0" indent="0" marL="0">
+                        <a:buNone/>
+                      </a:pPr>
+                      <a:r>
+                        <a:rPr/>
+                        <a:t>0.000305</a:t>
+                      </a:r>
+                    </a:p>
+                  </a:txBody>
+                </a:tc>
+              </a:tr>
+              <a:tr h="0">
+                <a:tc>
+                  <a:txBody>
+                    <a:bodyPr/>
+                    <a:lstStyle/>
+                    <a:p>
+                      <a:pPr lvl="0" indent="0" marL="0">
+                        <a:buNone/>
+                      </a:pPr>
+                      <a:r>
+                        <a:rPr/>
+                        <a:t>Healthy</a:t>
+                      </a:r>
+                    </a:p>
+                  </a:txBody>
+                </a:tc>
+                <a:tc>
+                  <a:txBody>
+                    <a:bodyPr/>
+                    <a:lstStyle/>
+                    <a:p>
+                      <a:pPr lvl="0" indent="0" marL="0">
+                        <a:buNone/>
+                      </a:pPr>
+                      <a:r>
+                        <a:rPr/>
+                        <a:t>ln</a:t>
                       </a:r>
                     </a:p>
                   </a:txBody>
@@ -15420,6 +15538,113 @@
                       <a:r>
                         <a:rPr/>
                         <a:t>Faulty</a:t>
+                      </a:r>
+                    </a:p>
+                  </a:txBody>
+                </a:tc>
+                <a:tc>
+                  <a:txBody>
+                    <a:bodyPr/>
+                    <a:lstStyle/>
+                    <a:p>
+                      <a:pPr lvl="0" indent="0" marL="0">
+                        <a:buNone/>
+                      </a:pPr>
+                      <a:r>
+                        <a:rPr/>
+                        <a:t>value</a:t>
+                      </a:r>
+                    </a:p>
+                  </a:txBody>
+                </a:tc>
+                <a:tc>
+                  <a:txBody>
+                    <a:bodyPr/>
+                    <a:lstStyle/>
+                    <a:p>
+                      <a:pPr lvl="0" indent="0" marL="0">
+                        <a:buNone/>
+                      </a:pPr>
+                      <a:r>
+                        <a:rPr/>
+                        <a:t>0.6125</a:t>
+                      </a:r>
+                    </a:p>
+                  </a:txBody>
+                </a:tc>
+                <a:tc>
+                  <a:txBody>
+                    <a:bodyPr/>
+                    <a:lstStyle/>
+                    <a:p>
+                      <a:pPr lvl="0" indent="0" marL="0">
+                        <a:buNone/>
+                      </a:pPr>
+                      <a:r>
+                        <a:rPr/>
+                        <a:t>0.0374</a:t>
+                      </a:r>
+                    </a:p>
+                  </a:txBody>
+                </a:tc>
+                <a:tc>
+                  <a:txBody>
+                    <a:bodyPr/>
+                    <a:lstStyle/>
+                    <a:p>
+                      <a:pPr lvl="0" indent="0" marL="0">
+                        <a:buNone/>
+                      </a:pPr>
+                      <a:r>
+                        <a:rPr/>
+                        <a:t>0.692</a:t>
+                      </a:r>
+                    </a:p>
+                  </a:txBody>
+                </a:tc>
+                <a:tc>
+                  <a:txBody>
+                    <a:bodyPr/>
+                    <a:lstStyle/>
+                    <a:p>
+                      <a:pPr lvl="0" indent="0" marL="0">
+                        <a:buNone/>
+                      </a:pPr>
+                      <a:r>
+                        <a:rPr/>
+                        <a:t>0.01585</a:t>
+                      </a:r>
+                    </a:p>
+                  </a:txBody>
+                </a:tc>
+              </a:tr>
+              <a:tr h="0">
+                <a:tc>
+                  <a:txBody>
+                    <a:bodyPr/>
+                    <a:lstStyle/>
+                    <a:p>
+                      <a:pPr lvl="0" indent="0" marL="0">
+                        <a:buNone/>
+                      </a:pPr>
+                      <a:r>
+                        <a:rPr/>
+                        <a:t>Faulty</a:t>
+                      </a:r>
+                    </a:p>
+                  </a:txBody>
+                </a:tc>
+                <a:tc>
+                  <a:txBody>
+                    <a:bodyPr/>
+                    <a:lstStyle/>
+                    <a:p>
+                      <a:pPr lvl="0" indent="0" marL="0">
+                        <a:buNone/>
+                      </a:pPr>
+                      <a:r>
+                        <a:rPr/>
+                        <a:t>ln</a:t>
                       </a:r>
                     </a:p>
                   </a:txBody>
@@ -15721,7 +15946,7 @@
                       </a:pPr>
                       <a:r>
                         <a:rPr/>
-                        <a:t>3. Divide each by the sum, 0.01616 = P(x)</a:t>
+                        <a:t>3. Divide by their sum: 0.01616 = P(x), by total probability</a:t>
                       </a:r>
                     </a:p>
                   </a:txBody>
@@ -15836,18 +16061,14 @@
             <a:pPr lvl="0"/>
             <a:r>
               <a:rPr/>
-              <a:t>Divide by the faulty score: P(faulty) = 1 / (1 + healthy / faulty)</a:t>
+              <a:t>Divide by the faulty score: 1 / (1 + healthy score ÷ faulty score)</a:t>
             </a:r>
           </a:p>
           <a:p>
             <a:pPr lvl="0"/>
             <a:r>
               <a:rPr/>
-              <a:t>The ratio is e^(−8.095 + 4.144) = e^(−3.951) = 0.0192: </a:t>
-            </a:r>
-            <a:r>
-              <a:rPr b="1"/>
-              <a:t>only the gap counts</a:t>
+              <a:t>e^a ÷ e^b = e^(a − b), so the ratio is e^(−3.951) = 0.0192</a:t>
             </a:r>
           </a:p>
           <a:p>
@@ -15862,7 +16083,7 @@
             </a:r>
             <a:r>
               <a:rPr/>
-              <a:t>; P(healthy) = 1 / (1 + e^3.951) = </a:t>
+              <a:t>; P(healthy) = 1 − 0.981 = </a:t>
             </a:r>
             <a:r>
               <a:rPr b="1"/>
@@ -15873,15 +16094,18 @@
             <a:pPr lvl="0"/>
             <a:r>
               <a:rPr/>
-              <a:t>As odds, e^3.951 ≈ 52: </a:t>
+              <a:t>Odds: 0.01585 ÷ 0.000305 ≈ </a:t>
             </a:r>
             <a:r>
               <a:rPr b="1"/>
               <a:t>52 to 1</a:t>
             </a:r>
-            <a:r>
-              <a:rPr/>
-              <a:t>, so 52/53 and 1/53</a:t>
+          </a:p>
+          <a:p>
+            <a:pPr lvl="0"/>
+            <a:r>
+              <a:rPr/>
+              <a:t>With many features e^total = 0; the gap never underflows</a:t>
             </a:r>
           </a:p>
         </p:txBody>

</xml_diff>

<commit_message>
Say what lesson 6's uncorrelated-but-dependent table correlates
Slide 38's columns were headed Readings and Squared distances, with nothing
saying either was a correlation. They now read: correlation within the
class, of vibration and pressure, and of their squared distances from the
design point.

Co-Authored-By: Claude Opus 5.5 <noreply@anthropic.com>
</commit_message>
<xml_diff>
--- a/Lessons/06_knn_naive_bayes_svm/Slides/knn_naive_bayes_svm_slides.pptx
+++ b/Lessons/06_knn_naive_bayes_svm/Slides/knn_naive_bayes_svm_slides.pptx
@@ -16553,7 +16553,7 @@
                       </a:pPr>
                       <a:r>
                         <a:rPr/>
-                        <a:t>Within class</a:t>
+                        <a:t>Correlation, within the class</a:t>
                       </a:r>
                     </a:p>
                   </a:txBody>
@@ -16569,7 +16569,7 @@
                       </a:pPr>
                       <a:r>
                         <a:rPr/>
-                        <a:t>Readings</a:t>
+                        <a:t>vibration and pressure</a:t>
                       </a:r>
                     </a:p>
                   </a:txBody>
@@ -16585,7 +16585,7 @@
                       </a:pPr>
                       <a:r>
                         <a:rPr/>
-                        <a:t>Squared distances</a:t>
+                        <a:t>their squared distances from the design point</a:t>
                       </a:r>
                     </a:p>
                   </a:txBody>

</xml_diff>

<commit_message>
Explain why lesson 6 squares the distances rather than cubing them
Section 4.3 exposed the pumps' dependence by squaring each reading's
distance from the design point, and never said why the square. The
dependence is about distance, not side, so the transformation must be even:
the cube keeps the sign and is as blind as the raw correlation (-0.022 among
faulty pumps), while every even one sees it (square -0.420, absolute value
-0.454, fourth power -0.288). The square is chosen because the disc and ring
are defined by z1^2 + z2^2, the coordinate the kernel lift reuses - and the
section now says the check only worked because the dependence was known to
be radial. Notebook 02 prints the comparison; slide 38's notes carry it.

Co-Authored-By: Claude Opus 5.5 <noreply@anthropic.com>
</commit_message>
<xml_diff>
--- a/Lessons/06_knn_naive_bayes_svm/Slides/knn_naive_bayes_svm_slides.pptx
+++ b/Lessons/06_knn_naive_bayes_svm/Slides/knn_naive_bayes_svm_slides.pptx
@@ -4212,6 +4212,20 @@
             <a:r>
               <a:rPr/>
               <a:t>Show the middle column first and let the room draw the conclusion everyone draws: within each class the readings are uncorrelated, so the assumption holds. It is the natural check, and for bell-shaped data it would settle it.</a:t>
+            </a:r>
+          </a:p>
+          <a:p>
+            <a:pPr lvl="0" indent="0" marL="0">
+              <a:buNone/>
+            </a:pPr>
+          </a:p>
+          <a:p>
+            <a:pPr lvl="0" indent="0" marL="0">
+              <a:buNone/>
+            </a:pPr>
+            <a:r>
+              <a:rPr/>
+              <a:t>If someone asks why the square and not the cube - and someone should - the answer is symmetry. The dependence is about how far from the centre, not which side, so the transformation must map far-left and far-right alike: an even function. The square does (−2 and +2 both give 4); the cube is odd, keeps the sign, and its correlation among the faulty pumps is −0.022, as blind as the raw readings. The absolute value works too, −0.454. The square is the natural pick because the disc and the ring are defined by z1² + z2², and it is the coordinate the kernel lift will use later. Handout section 4.3.</a:t>
             </a:r>
           </a:p>
           <a:p>

</xml_diff>

<commit_message>
Say why lesson 6 uses Naive Bayes when its assumption is false
Section 4.3 showed the pumps violate independence given the class and
explained why the model scores 0.933 anyway, but never answered the prior
question a reader asks: why use it at all. It now opens by saying that the
assumption is a simplification judged by validation, not a precondition,
and that classifying needs only the right class ranked first (Domingos and
Pazzani, 1997). Slide 38's notes carry the same answer for the room.

Co-Authored-By: Claude Opus 5.5 <noreply@anthropic.com>
</commit_message>
<xml_diff>
--- a/Lessons/06_knn_naive_bayes_svm/Slides/knn_naive_bayes_svm_slides.pptx
+++ b/Lessons/06_knn_naive_bayes_svm/Slides/knn_naive_bayes_svm_slides.pptx
@@ -4240,6 +4240,20 @@
             <a:r>
               <a:rPr/>
               <a:t>Then the trap. Correlation only sees straight-line dependence. Healthy pumps fill a disc and faulty ones a ring; on a ring, a pump far out in vibration must be central in pressure. That dependence is symmetric, so the straight-line summary averages it to zero. Square each reading’s distance from the design point and it appears: −0.420 among the faulty pumps. Or say it as a spread: the pressure of a faulty pump has a standard deviation of 0.784 when its vibration is extreme (the fifth furthest out, beyond 6.2 Hz from the centre) and 1.309 when it is not - 0.37 against 0.62 bar, same average, very different spread. Put the distinction on the board in two lines: uncorrelated, yes; independent, no. Naive Bayes assumes the second. The assumption is false.</a:t>
+            </a:r>
+          </a:p>
+          <a:p>
+            <a:pPr lvl="0" indent="0" marL="0">
+              <a:buNone/>
+            </a:pPr>
+          </a:p>
+          <a:p>
+            <a:pPr lvl="0" indent="0" marL="0">
+              <a:buNone/>
+            </a:pPr>
+            <a:r>
+              <a:rPr/>
+              <a:t>Someone will then ask why we used it at all. Answer it directly: nobody checks the assumption before fitting. It is a simplification bought for ten numbers, and the model is judged, like any other, by its validation score. That score asks for less than the assumption does: to classify, the right class has only to come out on top - the sign of the log-score gap - not the densities to be right. Naive Bayes can be optimal in that sense with independence badly violated (Domingos and Pazzani, 1997).</a:t>
             </a:r>
           </a:p>
           <a:p>

</xml_diff>

<commit_message>
Bridge lesson 6's jump from the kernel picture to the inner-product claim
"And the map is never computed" asserted that the SVM depends on the data
only through inner products and named the dual formulation in its notes,
but nothing on any slide ever showed what that rewriting is, so the claim
had nothing to stand on.

Add a slide between it and the numeric kernel check: w as a weighted sum
of the training points, zero weight for pumps clear of the margin, and
the substitution that turns every computation into an inner product. The
lesson plan shifts by one slide from there to the end (69 slides).

Co-Authored-By: Claude Sonnet 5 <noreply@anthropic.com>
</commit_message>
<xml_diff>
--- a/Lessons/06_knn_naive_bayes_svm/Slides/knn_naive_bayes_svm_slides.pptx
+++ b/Lessons/06_knn_naive_bayes_svm/Slides/knn_naive_bayes_svm_slides.pptx
@@ -5,7 +5,7 @@
     <p:sldMasterId id="2147483648" r:id="rId1"/>
   </p:sldMasterIdLst>
   <p:notesMasterIdLst>
-    <p:notesMasterId r:id="rId70"/>
+    <p:notesMasterId r:id="rId71"/>
   </p:notesMasterIdLst>
   <p:sldIdLst>
     <p:sldId id="256" r:id="rId2"/>
@@ -76,6 +76,7 @@
     <p:sldId id="321" r:id="rId67"/>
     <p:sldId id="322" r:id="rId68"/>
     <p:sldId id="323" r:id="rId69"/>
+    <p:sldId id="324" r:id="rId70"/>
   </p:sldIdLst>
   <p:sldSz cx="9144000" cy="5143500" type="screen16x9"/>
   <p:notesSz cx="6858000" cy="9144000"/>
@@ -6615,7 +6616,7 @@
             </a:pPr>
             <a:r>
               <a:rPr/>
-              <a:t>Do not prove it - handout section 5.4 shows where the inner products come from in the dual formulation. The claim to state and let land is that a function of two ordinary two-dimensional vectors returns their inner product in a space of infinite dimension, at the cost of one exponential.</a:t>
+              <a:t>Do not prove it here - the next slide gives the one line that makes this claim true, and handout section 5.4 has the full three-fact argument behind that line. The claim to state and let land now is that a function of two ordinary two-dimensional vectors returns their inner product in a space of infinite dimension, at the cost of one exponential.</a:t>
             </a:r>
           </a:p>
           <a:p>
@@ -6711,35 +6712,57 @@
             </a:pPr>
             <a:r>
               <a:rPr/>
-              <a:t>Make the trick concrete before the famous formula. The lift here lists every product of two coordinates: phi(x) = (x1², √2·x1·x2, x2²). Two points, a = (1, 2) and b = (3, 1).</a:t>
-            </a:r>
-          </a:p>
-          <a:p>
-            <a:pPr lvl="0" indent="0" marL="0">
-              <a:buNone/>
-            </a:pPr>
-          </a:p>
-          <a:p>
-            <a:pPr lvl="0" indent="0" marL="0">
-              <a:buNone/>
-            </a:pPr>
-            <a:r>
-              <a:rPr/>
-              <a:t>First row: lift both into three dimensions and take the ordinary inner product - 9 + 12 + 4 = 25. Second row: never lift, take the inner product in the plane, 5, and square it - 25. Same number. The second route never left two dimensions, so the function (a · b)² IS the inner product in the lifted space. That is all a kernel is.</a:t>
-            </a:r>
-          </a:p>
-          <a:p>
-            <a:pPr lvl="0" indent="0" marL="0">
-              <a:buNone/>
-            </a:pPr>
-          </a:p>
-          <a:p>
-            <a:pPr lvl="0" indent="0" marL="0">
-              <a:buNone/>
-            </a:pPr>
-            <a:r>
-              <a:rPr/>
-              <a:t>Then connect it to the figure they just saw: the lifted space contains x1² and x2², and their sum is the squared distance from the centre - the coordinate we chose by hand. A flat plane there is a circle down here. The kernel found the lift we had to guess. Handout section 5.4.</a:t>
+              <a:t>This is the rewriting the previous slide’s claim depends on, and it is worth giving before the trick, not after - it is called the </a:t>
+            </a:r>
+            <a:r>
+              <a:rPr b="1"/>
+              <a:t>dual formulation</a:t>
+            </a:r>
+            <a:r>
+              <a:rPr/>
+              <a:t>, and that phrase from the handout is otherwise just a name with nothing behind it.</a:t>
+            </a:r>
+          </a:p>
+          <a:p>
+            <a:pPr lvl="0" indent="0" marL="0">
+              <a:buNone/>
+            </a:pPr>
+          </a:p>
+          <a:p>
+            <a:pPr lvl="0" indent="0" marL="0">
+              <a:buNone/>
+            </a:pPr>
+            <a:r>
+              <a:rPr/>
+              <a:t>Say it in one sentence first: instead of solving for w directly, the optimisation turns out to hand back w as a weighted sum of the training points themselves, one weight aᵢ per pump. The picture: the boundary is a tent held up by the points pressing against it, and aᵢ is how hard pump i presses. A pump comfortably on its own side of the slab presses on nothing, so its weight is exactly zero. Only the pumps on or inside the slab - the support vectors from Section 5.1 - get a positive weight, which is where that 79% against 23% came from.</a:t>
+            </a:r>
+          </a:p>
+          <a:p>
+            <a:pPr lvl="0" indent="0" marL="0">
+              <a:buNone/>
+            </a:pPr>
+          </a:p>
+          <a:p>
+            <a:pPr lvl="0" indent="0" marL="0">
+              <a:buNone/>
+            </a:pPr>
+            <a:r>
+              <a:rPr/>
+              <a:t>Now the payoff, and this is the sentence that makes the next slide make sense. Substitute this w back into the boundary, wᵀx + b, and every xᵢ is still there, but only ever multiplied against another point: xᵢ · xⱼ in training, xᵢ · x in prediction. Nowhere does a coordinate appear on its own. That is the whole reason a kernel is enough - a function that returns that one number, the inner product in the lifted space, is all either computation ever asks for.</a:t>
+            </a:r>
+          </a:p>
+          <a:p>
+            <a:pPr lvl="0" indent="0" marL="0">
+              <a:buNone/>
+            </a:pPr>
+          </a:p>
+          <a:p>
+            <a:pPr lvl="0" indent="0" marL="0">
+              <a:buNone/>
+            </a:pPr>
+            <a:r>
+              <a:rPr/>
+              <a:t>Do not derive aᵢ here - the three-fact argument, from the constrained optimisation to this formula, is handout section 5.4.</a:t>
             </a:r>
           </a:p>
         </p:txBody>
@@ -6821,73 +6844,35 @@
             </a:pPr>
             <a:r>
               <a:rPr/>
-              <a:t>One line, and it is the whole of what scikit-learn does when you leave </a:t>
-            </a:r>
-            <a:r>
-              <a:rPr>
-                <a:latin typeface="Courier"/>
-              </a:rPr>
-              <a:t>kernel</a:t>
-            </a:r>
-            <a:r>
-              <a:rPr/>
-              <a:t> at its default.</a:t>
-            </a:r>
-          </a:p>
-          <a:p>
-            <a:pPr lvl="0" indent="0" marL="0">
-              <a:buNone/>
-            </a:pPr>
-          </a:p>
-          <a:p>
-            <a:pPr lvl="0" indent="0" marL="0">
-              <a:buNone/>
-            </a:pPr>
-            <a:r>
-              <a:rPr/>
-              <a:t>Read it aloud as a similarity rather than as a formula: the closer two points are, the nearer the exponent is to zero and the nearer the kernel is to one; far apart, it falls away to nothing. That is all an RBF kernel says - how much does this point look like that one.</a:t>
-            </a:r>
-          </a:p>
-          <a:p>
-            <a:pPr lvl="0" indent="0" marL="0">
-              <a:buNone/>
-            </a:pPr>
-          </a:p>
-          <a:p>
-            <a:pPr lvl="0" indent="0" marL="0">
-              <a:buNone/>
-            </a:pPr>
-            <a:r>
-              <a:rPr/>
-              <a:t>Now say what γ means, because the next two slides turn on it: it sets how far a single training point’s influence reaches. Small γ, wide reach, smooth boundary. Large γ, each point influences only its immediate neighbourhood - and a boundary that can afford an island around every mislabelled pump.</a:t>
-            </a:r>
-          </a:p>
-          <a:p>
-            <a:pPr lvl="0" indent="0" marL="0">
-              <a:buNone/>
-            </a:pPr>
-          </a:p>
-          <a:p>
-            <a:pPr lvl="0" indent="0" marL="0">
-              <a:buNone/>
-            </a:pPr>
-            <a:r>
-              <a:rPr/>
-              <a:t>A number to anchor it: the similarity halves at a distance of sqrt(ln 2 / γ). For scikit-learn’s default on the standardised pumps, γ = 0.5, that is about 1.2 standard deviations.</a:t>
-            </a:r>
-          </a:p>
-          <a:p>
-            <a:pPr lvl="0" indent="0" marL="0">
-              <a:buNone/>
-            </a:pPr>
-          </a:p>
-          <a:p>
-            <a:pPr lvl="0" indent="0" marL="0">
-              <a:buNone/>
-            </a:pPr>
-            <a:r>
-              <a:rPr/>
-              <a:t>Worth naming the cost, since this is an engineering course: one exponential per pair of points, so the kernel matrix is m × m. That is why support vector machines are a poor fit above a hundred thousand rows, and it is a property of the method rather than of the implementation.</a:t>
+              <a:t>Make the trick concrete before the famous formula. The lift here lists every product of two coordinates: phi(x) = (x1², √2·x1·x2, x2²). Two points, a = (1, 2) and b = (3, 1).</a:t>
+            </a:r>
+          </a:p>
+          <a:p>
+            <a:pPr lvl="0" indent="0" marL="0">
+              <a:buNone/>
+            </a:pPr>
+          </a:p>
+          <a:p>
+            <a:pPr lvl="0" indent="0" marL="0">
+              <a:buNone/>
+            </a:pPr>
+            <a:r>
+              <a:rPr/>
+              <a:t>First row: lift both into three dimensions and take the ordinary inner product - 9 + 12 + 4 = 25. Second row: never lift, take the inner product in the plane, 5, and square it - 25. Same number. The second route never left two dimensions, so the function (a · b)² IS the inner product in the lifted space. That is all a kernel is.</a:t>
+            </a:r>
+          </a:p>
+          <a:p>
+            <a:pPr lvl="0" indent="0" marL="0">
+              <a:buNone/>
+            </a:pPr>
+          </a:p>
+          <a:p>
+            <a:pPr lvl="0" indent="0" marL="0">
+              <a:buNone/>
+            </a:pPr>
+            <a:r>
+              <a:rPr/>
+              <a:t>Then connect it to the figure they just saw: the lifted space contains x1² and x2², and their sum is the squared distance from the centre - the coordinate we chose by hand. A flat plane there is a circle down here. The kernel found the lift we had to guess. Handout section 5.4.</a:t>
             </a:r>
           </a:p>
         </p:txBody>
@@ -6969,35 +6954,73 @@
             </a:pPr>
             <a:r>
               <a:rPr/>
-              <a:t>Say what “fit” does, because after lesson 3 they will expect gradient descent. It is not. The SVM solves the dual: one weight per training point, found by a solver that picks two weights at a time - two, because the weights times the labels must sum to zero, so one cannot move alone - sets them to their best values with the rest fixed, and repeats until nothing improves. Convex, so there is one answer and it is found every time.</a:t>
-            </a:r>
-          </a:p>
-          <a:p>
-            <a:pPr lvl="0" indent="0" marL="0">
-              <a:buNone/>
-            </a:pPr>
-          </a:p>
-          <a:p>
-            <a:pPr lvl="0" indent="0" marL="0">
-              <a:buNone/>
-            </a:pPr>
-            <a:r>
-              <a:rPr/>
-              <a:t>Then the counts, which match the three cases of the slack from earlier. Weight zero: the 922 pumps safely on their own side, which the model now forgets. Weight at the ceiling C: the 268 inside the slab or on the wrong side - with C = 1 that weight is exactly 1, so each of them simply votes with its label. Between: the 10 sitting exactly on the edge.</a:t>
-            </a:r>
-          </a:p>
-          <a:p>
-            <a:pPr lvl="0" indent="0" marL="0">
-              <a:buNone/>
-            </a:pPr>
-          </a:p>
-          <a:p>
-            <a:pPr lvl="0" indent="0" marL="0">
-              <a:buNone/>
-            </a:pPr>
-            <a:r>
-              <a:rPr/>
-              <a:t>The model you ship is 278 points and their weights. Handout section 5.5.</a:t>
+              <a:t>One line, and it is the whole of what scikit-learn does when you leave </a:t>
+            </a:r>
+            <a:r>
+              <a:rPr>
+                <a:latin typeface="Courier"/>
+              </a:rPr>
+              <a:t>kernel</a:t>
+            </a:r>
+            <a:r>
+              <a:rPr/>
+              <a:t> at its default.</a:t>
+            </a:r>
+          </a:p>
+          <a:p>
+            <a:pPr lvl="0" indent="0" marL="0">
+              <a:buNone/>
+            </a:pPr>
+          </a:p>
+          <a:p>
+            <a:pPr lvl="0" indent="0" marL="0">
+              <a:buNone/>
+            </a:pPr>
+            <a:r>
+              <a:rPr/>
+              <a:t>Read it aloud as a similarity rather than as a formula: the closer two points are, the nearer the exponent is to zero and the nearer the kernel is to one; far apart, it falls away to nothing. That is all an RBF kernel says - how much does this point look like that one.</a:t>
+            </a:r>
+          </a:p>
+          <a:p>
+            <a:pPr lvl="0" indent="0" marL="0">
+              <a:buNone/>
+            </a:pPr>
+          </a:p>
+          <a:p>
+            <a:pPr lvl="0" indent="0" marL="0">
+              <a:buNone/>
+            </a:pPr>
+            <a:r>
+              <a:rPr/>
+              <a:t>Now say what γ means, because the next two slides turn on it: it sets how far a single training point’s influence reaches. Small γ, wide reach, smooth boundary. Large γ, each point influences only its immediate neighbourhood - and a boundary that can afford an island around every mislabelled pump.</a:t>
+            </a:r>
+          </a:p>
+          <a:p>
+            <a:pPr lvl="0" indent="0" marL="0">
+              <a:buNone/>
+            </a:pPr>
+          </a:p>
+          <a:p>
+            <a:pPr lvl="0" indent="0" marL="0">
+              <a:buNone/>
+            </a:pPr>
+            <a:r>
+              <a:rPr/>
+              <a:t>A number to anchor it: the similarity halves at a distance of sqrt(ln 2 / γ). For scikit-learn’s default on the standardised pumps, γ = 0.5, that is about 1.2 standard deviations.</a:t>
+            </a:r>
+          </a:p>
+          <a:p>
+            <a:pPr lvl="0" indent="0" marL="0">
+              <a:buNone/>
+            </a:pPr>
+          </a:p>
+          <a:p>
+            <a:pPr lvl="0" indent="0" marL="0">
+              <a:buNone/>
+            </a:pPr>
+            <a:r>
+              <a:rPr/>
+              <a:t>Worth naming the cost, since this is an engineering course: one exponential per pair of points, so the kernel matrix is m × m. That is why support vector machines are a poor fit above a hundred thousand rows, and it is a property of the method rather than of the implementation.</a:t>
             </a:r>
           </a:p>
         </p:txBody>
@@ -7079,35 +7102,35 @@
             </a:pPr>
             <a:r>
               <a:rPr/>
-              <a:t>Inference is a vote, in four steps. Standardise the pump with the training scaler. Compute its RBF similarity to each of the 278 support vectors. Add up weight times label times similarity - label +1 for faulty, -1 for healthy - and add b. Read the sign. Nothing else goes in: the total is exactly what decision_function returns.</a:t>
-            </a:r>
-          </a:p>
-          <a:p>
-            <a:pPr lvl="0" indent="0" marL="0">
-              <a:buNone/>
-            </a:pPr>
-          </a:p>
-          <a:p>
-            <a:pPr lvl="0" indent="0" marL="0">
-              <a:buNone/>
-            </a:pPr>
-            <a:r>
-              <a:rPr/>
-              <a:t>The same pump Naive Bayes called faulty at 0.981, reached by a completely different route.</a:t>
-            </a:r>
-          </a:p>
-          <a:p>
-            <a:pPr lvl="0" indent="0" marL="0">
-              <a:buNone/>
-            </a:pPr>
-          </a:p>
-          <a:p>
-            <a:pPr lvl="0" indent="0" marL="0">
-              <a:buNone/>
-            </a:pPr>
-            <a:r>
-              <a:rPr/>
-              <a:t>The point to make: the neighbourhood decides. The 56 support vectors within about 1.2 standard deviations contribute a net +1.141 towards faulty; the other 222 only -0.363. But not one neighbour - the five nearest disagree, because pumps just outside the envelope are faulty and some just inside carry flipped labels. So the SVM is k-NN again, with a smooth similarity instead of a hard k, only the support vectors voting, and learned weights. And the output is a score, not a probability. Handout section 5.5.</a:t>
+              <a:t>Say what “fit” does, because after lesson 3 they will expect gradient descent. It is not. The SVM solves the dual: one weight per training point, found by a solver that picks two weights at a time - two, because the weights times the labels must sum to zero, so one cannot move alone - sets them to their best values with the rest fixed, and repeats until nothing improves. Convex, so there is one answer and it is found every time.</a:t>
+            </a:r>
+          </a:p>
+          <a:p>
+            <a:pPr lvl="0" indent="0" marL="0">
+              <a:buNone/>
+            </a:pPr>
+          </a:p>
+          <a:p>
+            <a:pPr lvl="0" indent="0" marL="0">
+              <a:buNone/>
+            </a:pPr>
+            <a:r>
+              <a:rPr/>
+              <a:t>Then the counts, which match the three cases of the slack from earlier. Weight zero: the 922 pumps safely on their own side, which the model now forgets. Weight at the ceiling C: the 268 inside the slab or on the wrong side - with C = 1 that weight is exactly 1, so each of them simply votes with its label. Between: the 10 sitting exactly on the edge.</a:t>
+            </a:r>
+          </a:p>
+          <a:p>
+            <a:pPr lvl="0" indent="0" marL="0">
+              <a:buNone/>
+            </a:pPr>
+          </a:p>
+          <a:p>
+            <a:pPr lvl="0" indent="0" marL="0">
+              <a:buNone/>
+            </a:pPr>
+            <a:r>
+              <a:rPr/>
+              <a:t>The model you ship is 278 points and their weights. Handout section 5.5.</a:t>
             </a:r>
           </a:p>
         </p:txBody>
@@ -7189,21 +7212,35 @@
             </a:pPr>
             <a:r>
               <a:rPr/>
-              <a:t>The table on the previous slide, drawn. Every support vector is sized and shaded by its similarity to the pump, the gold star at 48 Hz and 5.6 bar; the dashed ellipse is where similarity falls to one half, about 1.2 standard deviations; the black line is the SVM’s boundary.</a:t>
-            </a:r>
-          </a:p>
-          <a:p>
-            <a:pPr lvl="0" indent="0" marL="0">
-              <a:buNone/>
-            </a:pPr>
-          </a:p>
-          <a:p>
-            <a:pPr lvl="0" indent="0" marL="0">
-              <a:buNone/>
-            </a:pPr>
-            <a:r>
-              <a:rPr/>
-              <a:t>Point out where the weight is: the 56 support vectors inside the dashed ellipse carry most of it, the ones across the disc have faded out. Then point at the star’s immediate neighbours - teal and rust together, boundary pumps and flipped labels. That is why the five nearest nearly cancel, and why it is the neighbourhood’s balance, not one neighbour, that makes it faulty. Handout section 5.5.</a:t>
+              <a:t>Inference is a vote, in four steps. Standardise the pump with the training scaler. Compute its RBF similarity to each of the 278 support vectors. Add up weight times label times similarity - label +1 for faulty, -1 for healthy - and add b. Read the sign. Nothing else goes in: the total is exactly what decision_function returns.</a:t>
+            </a:r>
+          </a:p>
+          <a:p>
+            <a:pPr lvl="0" indent="0" marL="0">
+              <a:buNone/>
+            </a:pPr>
+          </a:p>
+          <a:p>
+            <a:pPr lvl="0" indent="0" marL="0">
+              <a:buNone/>
+            </a:pPr>
+            <a:r>
+              <a:rPr/>
+              <a:t>The same pump Naive Bayes called faulty at 0.981, reached by a completely different route.</a:t>
+            </a:r>
+          </a:p>
+          <a:p>
+            <a:pPr lvl="0" indent="0" marL="0">
+              <a:buNone/>
+            </a:pPr>
+          </a:p>
+          <a:p>
+            <a:pPr lvl="0" indent="0" marL="0">
+              <a:buNone/>
+            </a:pPr>
+            <a:r>
+              <a:rPr/>
+              <a:t>The point to make: the neighbourhood decides. The 56 support vectors within about 1.2 standard deviations contribute a net +1.141 towards faulty; the other 222 only -0.363. But not one neighbour - the five nearest disagree, because pumps just outside the envelope are faulty and some just inside carry flipped labels. So the SVM is k-NN again, with a smooth similarity instead of a hard k, only the support vectors voting, and learned weights. And the output is a score, not a probability. Handout section 5.5.</a:t>
             </a:r>
           </a:p>
         </p:txBody>
@@ -7409,53 +7446,21 @@
             </a:pPr>
             <a:r>
               <a:rPr/>
-              <a:t>Read the two columns against each other, exactly as lesson 5 taught, and let the last row do the work.</a:t>
-            </a:r>
-          </a:p>
-          <a:p>
-            <a:pPr lvl="0" indent="0" marL="0">
-              <a:buNone/>
-            </a:pPr>
-          </a:p>
-          <a:p>
-            <a:pPr lvl="0" indent="0" marL="0">
-              <a:buNone/>
-            </a:pPr>
-            <a:r>
-              <a:rPr/>
-              <a:t>The bottom row has the best training score on the slide - 0.995, nearly perfect - and the worst honest one. That is the signature of overfitting, and here it is not inferred from theory but measured on the same data by two different procedures.</a:t>
-            </a:r>
-          </a:p>
-          <a:p>
-            <a:pPr lvl="0" indent="0" marL="0">
-              <a:buNone/>
-            </a:pPr>
-          </a:p>
-          <a:p>
-            <a:pPr lvl="0" indent="0" marL="0">
-              <a:buNone/>
-            </a:pPr>
-            <a:r>
-              <a:rPr b="1"/>
-              <a:t>Now the second predictable mistake, and defend the instinct.</a:t>
-            </a:r>
-            <a:r>
-              <a:rPr/>
-              <a:t> Choosing between these three on the training score selects the WORST model, with complete confidence and a very impressive number to report. And the instinct behind it is not stupid: a higher score on the data you have is, in every other part of engineering, evidence of a better system. Fitting the data well is what we spent lessons 3 and 4 doing. What breaks the analogy is that a flexible model can fit data it has already been shown without learning anything transferable.</a:t>
-            </a:r>
-          </a:p>
-          <a:p>
-            <a:pPr lvl="0" indent="0" marL="0">
-              <a:buNone/>
-            </a:pPr>
-          </a:p>
-          <a:p>
-            <a:pPr lvl="0" indent="0" marL="0">
-              <a:buNone/>
-            </a:pPr>
-            <a:r>
-              <a:rPr/>
-              <a:t>The reason this table is on the slide rather than in the handout is that the next slide shows the same three settings as pictures - so the failure is visible as well as measurable, which is rare.</a:t>
+              <a:t>The table on the previous slide, drawn. Every support vector is sized and shaded by its similarity to the pump, the gold star at 48 Hz and 5.6 bar; the dashed ellipse is where similarity falls to one half, about 1.2 standard deviations; the black line is the SVM’s boundary.</a:t>
+            </a:r>
+          </a:p>
+          <a:p>
+            <a:pPr lvl="0" indent="0" marL="0">
+              <a:buNone/>
+            </a:pPr>
+          </a:p>
+          <a:p>
+            <a:pPr lvl="0" indent="0" marL="0">
+              <a:buNone/>
+            </a:pPr>
+            <a:r>
+              <a:rPr/>
+              <a:t>Point out where the weight is: the 56 support vectors inside the dashed ellipse carry most of it, the ones across the disc have faded out. Then point at the star’s immediate neighbours - teal and rust together, boundary pumps and flipped labels. That is why the five nearest nearly cancel, and why it is the neighbourhood’s balance, not one neighbour, that makes it faulty. Handout section 5.5.</a:t>
             </a:r>
           </a:p>
         </p:txBody>
@@ -7537,21 +7542,53 @@
             </a:pPr>
             <a:r>
               <a:rPr/>
-              <a:t>Gamma as a distance rather than a symbol. Each curve is the RBF similarity against the distance between two pumps; where it crosses the dotted line is the distance at which a support vector’s vote has halved: 2.63 standard deviations at gamma 0.1, 1.18 at the default 0.5, 0.83 at 1, and 0.12 at 50.</a:t>
-            </a:r>
-          </a:p>
-          <a:p>
-            <a:pPr lvl="0" indent="0" marL="0">
-              <a:buNone/>
-            </a:pPr>
-          </a:p>
-          <a:p>
-            <a:pPr lvl="0" indent="0" marL="0">
-              <a:buNone/>
-            </a:pPr>
-            <a:r>
-              <a:rPr/>
-              <a:t>Ask them to predict the next slide from this one: at gamma 50 a point speaks only for a neighbourhood a tenth of a standard deviation wide. What will the boundary look like? Islands. Handout section 5.6.</a:t>
+              <a:t>Read the two columns against each other, exactly as lesson 5 taught, and let the last row do the work.</a:t>
+            </a:r>
+          </a:p>
+          <a:p>
+            <a:pPr lvl="0" indent="0" marL="0">
+              <a:buNone/>
+            </a:pPr>
+          </a:p>
+          <a:p>
+            <a:pPr lvl="0" indent="0" marL="0">
+              <a:buNone/>
+            </a:pPr>
+            <a:r>
+              <a:rPr/>
+              <a:t>The bottom row has the best training score on the slide - 0.995, nearly perfect - and the worst honest one. That is the signature of overfitting, and here it is not inferred from theory but measured on the same data by two different procedures.</a:t>
+            </a:r>
+          </a:p>
+          <a:p>
+            <a:pPr lvl="0" indent="0" marL="0">
+              <a:buNone/>
+            </a:pPr>
+          </a:p>
+          <a:p>
+            <a:pPr lvl="0" indent="0" marL="0">
+              <a:buNone/>
+            </a:pPr>
+            <a:r>
+              <a:rPr b="1"/>
+              <a:t>Now the second predictable mistake, and defend the instinct.</a:t>
+            </a:r>
+            <a:r>
+              <a:rPr/>
+              <a:t> Choosing between these three on the training score selects the WORST model, with complete confidence and a very impressive number to report. And the instinct behind it is not stupid: a higher score on the data you have is, in every other part of engineering, evidence of a better system. Fitting the data well is what we spent lessons 3 and 4 doing. What breaks the analogy is that a flexible model can fit data it has already been shown without learning anything transferable.</a:t>
+            </a:r>
+          </a:p>
+          <a:p>
+            <a:pPr lvl="0" indent="0" marL="0">
+              <a:buNone/>
+            </a:pPr>
+          </a:p>
+          <a:p>
+            <a:pPr lvl="0" indent="0" marL="0">
+              <a:buNone/>
+            </a:pPr>
+            <a:r>
+              <a:rPr/>
+              <a:t>The reason this table is on the slide rather than in the handout is that the next slide shows the same three settings as pictures - so the failure is visible as well as measurable, which is rare.</a:t>
             </a:r>
           </a:p>
         </p:txBody>
@@ -7633,63 +7670,21 @@
             </a:pPr>
             <a:r>
               <a:rPr/>
-              <a:t>Three settings, with training and cross-validated scores in each title. Read them together.</a:t>
-            </a:r>
-          </a:p>
-          <a:p>
-            <a:pPr lvl="0" indent="0" marL="0">
-              <a:buNone/>
-            </a:pPr>
-          </a:p>
-          <a:p>
-            <a:pPr lvl="0" indent="0" marL="0">
-              <a:buNone/>
-            </a:pPr>
-            <a:r>
-              <a:rPr/>
-              <a:t>Left, γ = 0.1: a smooth boundary, slightly too smooth, and the two scores agree. Middle, γ = 1: close to the true envelope, and the best honest score.</a:t>
-            </a:r>
-          </a:p>
-          <a:p>
-            <a:pPr lvl="0" indent="0" marL="0">
-              <a:buNone/>
-            </a:pPr>
-          </a:p>
-          <a:p>
-            <a:pPr lvl="0" indent="0" marL="0">
-              <a:buNone/>
-            </a:pPr>
-            <a:r>
-              <a:rPr/>
-              <a:t>Right is the one to sit on. The boundary has broken into bubbles - small islands around individual points, including the mislabelled ones. That is what a 0.995 training score looks like from the outside: the model has drawn a private territory around each flipped label so that it can get it right.</a:t>
-            </a:r>
-          </a:p>
-          <a:p>
-            <a:pPr lvl="0" indent="0" marL="0">
-              <a:buNone/>
-            </a:pPr>
-          </a:p>
-          <a:p>
-            <a:pPr lvl="0" indent="0" marL="0">
-              <a:buNone/>
-            </a:pPr>
-            <a:r>
-              <a:rPr/>
-              <a:t>Ask them what happens to a new pump landing in the gap between two bubbles. That is the 0.902.</a:t>
-            </a:r>
-          </a:p>
-          <a:p>
-            <a:pPr lvl="0" indent="0" marL="0">
-              <a:buNone/>
-            </a:pPr>
-          </a:p>
-          <a:p>
-            <a:pPr lvl="0" indent="0" marL="0">
-              <a:buNone/>
-            </a:pPr>
-            <a:r>
-              <a:rPr/>
-              <a:t>The reason this slide matters more than the table: they have seen overfitting as a curve on a plot since lesson 5. Here it is a shape in the input space, and the shape is obviously wrong in a way no number is. When you can plot the boundary, plot it.</a:t>
+              <a:t>Gamma as a distance rather than a symbol. Each curve is the RBF similarity against the distance between two pumps; where it crosses the dotted line is the distance at which a support vector’s vote has halved: 2.63 standard deviations at gamma 0.1, 1.18 at the default 0.5, 0.83 at 1, and 0.12 at 50.</a:t>
+            </a:r>
+          </a:p>
+          <a:p>
+            <a:pPr lvl="0" indent="0" marL="0">
+              <a:buNone/>
+            </a:pPr>
+          </a:p>
+          <a:p>
+            <a:pPr lvl="0" indent="0" marL="0">
+              <a:buNone/>
+            </a:pPr>
+            <a:r>
+              <a:rPr/>
+              <a:t>Ask them to predict the next slide from this one: at gamma 50 a point speaks only for a neighbourhood a tenth of a standard deviation wide. What will the boundary look like? Islands. Handout section 5.6.</a:t>
             </a:r>
           </a:p>
         </p:txBody>
@@ -7771,49 +7766,63 @@
             </a:pPr>
             <a:r>
               <a:rPr/>
-              <a:t>Run notebooks/03. Sixteen minutes.</a:t>
-            </a:r>
-          </a:p>
-          <a:p>
-            <a:pPr lvl="0" indent="0" marL="0">
-              <a:buNone/>
-            </a:pPr>
-          </a:p>
-          <a:p>
-            <a:pPr lvl="0" indent="0" marL="0">
-              <a:buNone/>
-            </a:pPr>
-            <a:r>
-              <a:rPr/>
-              <a:t>The cell to protect is the γ sweep with the boundary drawn at each setting. Let them turn γ up themselves and watch the bubbles form - it is the most direct experience of overfitting available in this course.</a:t>
-            </a:r>
-          </a:p>
-          <a:p>
-            <a:pPr lvl="0" indent="0" marL="0">
-              <a:buNone/>
-            </a:pPr>
-          </a:p>
-          <a:p>
-            <a:pPr lvl="0" indent="0" marL="0">
-              <a:buNone/>
-            </a:pPr>
-            <a:r>
-              <a:rPr/>
-              <a:t>Have them print the support-vector fraction for the linear and RBF kernels side by side. Two numbers, and it makes the diagnostic real rather than a claim on a slide.</a:t>
-            </a:r>
-          </a:p>
-          <a:p>
-            <a:pPr lvl="0" indent="0" marL="0">
-              <a:buNone/>
-            </a:pPr>
-          </a:p>
-          <a:p>
-            <a:pPr lvl="0" indent="0" marL="0">
-              <a:buNone/>
-            </a:pPr>
-            <a:r>
-              <a:rPr/>
-              <a:t>If time runs short, skip the C sweep and set it as reading: the table is in handout section 5.6.</a:t>
+              <a:t>Three settings, with training and cross-validated scores in each title. Read them together.</a:t>
+            </a:r>
+          </a:p>
+          <a:p>
+            <a:pPr lvl="0" indent="0" marL="0">
+              <a:buNone/>
+            </a:pPr>
+          </a:p>
+          <a:p>
+            <a:pPr lvl="0" indent="0" marL="0">
+              <a:buNone/>
+            </a:pPr>
+            <a:r>
+              <a:rPr/>
+              <a:t>Left, γ = 0.1: a smooth boundary, slightly too smooth, and the two scores agree. Middle, γ = 1: close to the true envelope, and the best honest score.</a:t>
+            </a:r>
+          </a:p>
+          <a:p>
+            <a:pPr lvl="0" indent="0" marL="0">
+              <a:buNone/>
+            </a:pPr>
+          </a:p>
+          <a:p>
+            <a:pPr lvl="0" indent="0" marL="0">
+              <a:buNone/>
+            </a:pPr>
+            <a:r>
+              <a:rPr/>
+              <a:t>Right is the one to sit on. The boundary has broken into bubbles - small islands around individual points, including the mislabelled ones. That is what a 0.995 training score looks like from the outside: the model has drawn a private territory around each flipped label so that it can get it right.</a:t>
+            </a:r>
+          </a:p>
+          <a:p>
+            <a:pPr lvl="0" indent="0" marL="0">
+              <a:buNone/>
+            </a:pPr>
+          </a:p>
+          <a:p>
+            <a:pPr lvl="0" indent="0" marL="0">
+              <a:buNone/>
+            </a:pPr>
+            <a:r>
+              <a:rPr/>
+              <a:t>Ask them what happens to a new pump landing in the gap between two bubbles. That is the 0.902.</a:t>
+            </a:r>
+          </a:p>
+          <a:p>
+            <a:pPr lvl="0" indent="0" marL="0">
+              <a:buNone/>
+            </a:pPr>
+          </a:p>
+          <a:p>
+            <a:pPr lvl="0" indent="0" marL="0">
+              <a:buNone/>
+            </a:pPr>
+            <a:r>
+              <a:rPr/>
+              <a:t>The reason this slide matters more than the table: they have seen overfitting as a curve on a plot since lesson 5. Here it is a shape in the input space, and the shape is obviously wrong in a way no number is. When you can plot the boundary, plot it.</a:t>
             </a:r>
           </a:p>
         </p:txBody>
@@ -7895,57 +7904,49 @@
             </a:pPr>
             <a:r>
               <a:rPr/>
-              <a:t>Everything in the lesson on the same 1,200 pumps, cross-validated the same way.</a:t>
-            </a:r>
-          </a:p>
-          <a:p>
-            <a:pPr lvl="0" indent="0" marL="0">
-              <a:buNone/>
-            </a:pPr>
-          </a:p>
-          <a:p>
-            <a:pPr lvl="0" indent="0" marL="0">
-              <a:buNone/>
-            </a:pPr>
-            <a:r>
-              <a:rPr/>
-              <a:t>Read the top three rows together: all exactly 0.613, and all three are linear. Then the bottom three, all near the ceiling, reached by three completely unrelated routes - remembering the neighbourhood, assuming independence, bending the space. There is no single idea shared between them.</a:t>
-            </a:r>
-          </a:p>
-          <a:p>
-            <a:pPr lvl="0" indent="0" marL="0">
-              <a:buNone/>
-            </a:pPr>
-          </a:p>
-          <a:p>
-            <a:pPr lvl="0" indent="0" marL="0">
-              <a:buNone/>
-            </a:pPr>
-            <a:r>
-              <a:rPr/>
-              <a:t>Then the number that is the lesson: the gap between best and worst is </a:t>
-            </a:r>
-            <a:r>
-              <a:rPr b="1"/>
-              <a:t>0.334</a:t>
-            </a:r>
-            <a:r>
-              <a:rPr/>
-              <a:t>. Larger than any difference this course has shown between a good model and a carefully tuned one - lesson 5’s entire hyperparameter search moved things by a few hundredths.</a:t>
-            </a:r>
-          </a:p>
-          <a:p>
-            <a:pPr lvl="0" indent="0" marL="0">
-              <a:buNone/>
-            </a:pPr>
-          </a:p>
-          <a:p>
-            <a:pPr lvl="0" indent="0" marL="0">
-              <a:buNone/>
-            </a:pPr>
-            <a:r>
-              <a:rPr/>
-              <a:t>Say the conclusion plainly, and it is the practical takeaway of the whole lesson: choosing the right family matters far more than tuning the wrong one. Nobody in the top three rows could have tuned their way out. And the way to tell which family you need is to look at the data first, which is what lesson 2 was for.</a:t>
+              <a:t>Run notebooks/03. Sixteen minutes.</a:t>
+            </a:r>
+          </a:p>
+          <a:p>
+            <a:pPr lvl="0" indent="0" marL="0">
+              <a:buNone/>
+            </a:pPr>
+          </a:p>
+          <a:p>
+            <a:pPr lvl="0" indent="0" marL="0">
+              <a:buNone/>
+            </a:pPr>
+            <a:r>
+              <a:rPr/>
+              <a:t>The cell to protect is the γ sweep with the boundary drawn at each setting. Let them turn γ up themselves and watch the bubbles form - it is the most direct experience of overfitting available in this course.</a:t>
+            </a:r>
+          </a:p>
+          <a:p>
+            <a:pPr lvl="0" indent="0" marL="0">
+              <a:buNone/>
+            </a:pPr>
+          </a:p>
+          <a:p>
+            <a:pPr lvl="0" indent="0" marL="0">
+              <a:buNone/>
+            </a:pPr>
+            <a:r>
+              <a:rPr/>
+              <a:t>Have them print the support-vector fraction for the linear and RBF kernels side by side. Two numbers, and it makes the diagnostic real rather than a claim on a slide.</a:t>
+            </a:r>
+          </a:p>
+          <a:p>
+            <a:pPr lvl="0" indent="0" marL="0">
+              <a:buNone/>
+            </a:pPr>
+          </a:p>
+          <a:p>
+            <a:pPr lvl="0" indent="0" marL="0">
+              <a:buNone/>
+            </a:pPr>
+            <a:r>
+              <a:rPr/>
+              <a:t>If time runs short, skip the C sweep and set it as reading: the table is in handout section 5.6.</a:t>
             </a:r>
           </a:p>
         </p:txBody>
@@ -8027,35 +8028,57 @@
             </a:pPr>
             <a:r>
               <a:rPr/>
-              <a:t>A table to photograph. Work down it and attach today’s evidence to each row, so it is remembered as a set of conclusions rather than as advice.</a:t>
-            </a:r>
-          </a:p>
-          <a:p>
-            <a:pPr lvl="0" indent="0" marL="0">
-              <a:buNone/>
-            </a:pPr>
-          </a:p>
-          <a:p>
-            <a:pPr lvl="0" indent="0" marL="0">
-              <a:buNone/>
-            </a:pPr>
-            <a:r>
-              <a:rPr/>
-              <a:t>Row two deserves a sentence on its own, because it is the one that sounds wrong after the last hour. Text classification is the canonical case: tens of thousands of word-count features, an assumption that is transparently false, and a method that works anyway - because being roughly right in ten thousand dimensions beats being unable to estimate anything at all. Also mention Naive Bayes as a baseline: it trains in one pass, so if your tuned model does not beat it you have learned something quickly and cheaply.</a:t>
-            </a:r>
-          </a:p>
-          <a:p>
-            <a:pPr lvl="0" indent="0" marL="0">
-              <a:buNone/>
-            </a:pPr>
-          </a:p>
-          <a:p>
-            <a:pPr lvl="0" indent="0" marL="0">
-              <a:buNone/>
-            </a:pPr>
-            <a:r>
-              <a:rPr/>
-              <a:t>One row that did not fit and should be said out loud: when you need to explain the decision to the person affected, none of today’s three will do it. A support vector machine in a lifted space has no explanation a customer would accept. Lesson 3’s Resources document covers why that is sometimes a legal requirement rather than a preference.</a:t>
+              <a:t>Everything in the lesson on the same 1,200 pumps, cross-validated the same way.</a:t>
+            </a:r>
+          </a:p>
+          <a:p>
+            <a:pPr lvl="0" indent="0" marL="0">
+              <a:buNone/>
+            </a:pPr>
+          </a:p>
+          <a:p>
+            <a:pPr lvl="0" indent="0" marL="0">
+              <a:buNone/>
+            </a:pPr>
+            <a:r>
+              <a:rPr/>
+              <a:t>Read the top three rows together: all exactly 0.613, and all three are linear. Then the bottom three, all near the ceiling, reached by three completely unrelated routes - remembering the neighbourhood, assuming independence, bending the space. There is no single idea shared between them.</a:t>
+            </a:r>
+          </a:p>
+          <a:p>
+            <a:pPr lvl="0" indent="0" marL="0">
+              <a:buNone/>
+            </a:pPr>
+          </a:p>
+          <a:p>
+            <a:pPr lvl="0" indent="0" marL="0">
+              <a:buNone/>
+            </a:pPr>
+            <a:r>
+              <a:rPr/>
+              <a:t>Then the number that is the lesson: the gap between best and worst is </a:t>
+            </a:r>
+            <a:r>
+              <a:rPr b="1"/>
+              <a:t>0.334</a:t>
+            </a:r>
+            <a:r>
+              <a:rPr/>
+              <a:t>. Larger than any difference this course has shown between a good model and a carefully tuned one - lesson 5’s entire hyperparameter search moved things by a few hundredths.</a:t>
+            </a:r>
+          </a:p>
+          <a:p>
+            <a:pPr lvl="0" indent="0" marL="0">
+              <a:buNone/>
+            </a:pPr>
+          </a:p>
+          <a:p>
+            <a:pPr lvl="0" indent="0" marL="0">
+              <a:buNone/>
+            </a:pPr>
+            <a:r>
+              <a:rPr/>
+              <a:t>Say the conclusion plainly, and it is the practical takeaway of the whole lesson: choosing the right family matters far more than tuning the wrong one. Nobody in the top three rows could have tuned their way out. And the way to tell which family you need is to look at the data first, which is what lesson 2 was for.</a:t>
             </a:r>
           </a:p>
         </p:txBody>
@@ -8137,49 +8160,35 @@
             </a:pPr>
             <a:r>
               <a:rPr/>
-              <a:t>Close on the number they opened the second segment with, and say it one more time: seventy per cent. In a hundred dimensions the nearest point in the entire dataset is seven tenths of the way to the farthest, and every method built on distance is operating on a quantity that has stopped varying.</a:t>
-            </a:r>
-          </a:p>
-          <a:p>
-            <a:pPr lvl="0" indent="0" marL="0">
-              <a:buNone/>
-            </a:pPr>
-          </a:p>
-          <a:p>
-            <a:pPr lvl="0" indent="0" marL="0">
-              <a:buNone/>
-            </a:pPr>
-            <a:r>
-              <a:rPr/>
-              <a:t>If they remember one habit from today, make it the diagnostic pair: before reaching for a model, look at the shape of the data; after fitting one, check whether the assumption it depends on is actually satisfied on your data - and check it properly. The −0.006 said yes; the squared distances said no; and the ellipse the model drew explained the 0.933.</a:t>
-            </a:r>
-          </a:p>
-          <a:p>
-            <a:pPr lvl="0" indent="0" marL="0">
-              <a:buNone/>
-            </a:pPr>
-          </a:p>
-          <a:p>
-            <a:pPr lvl="0" indent="0" marL="0">
-              <a:buNone/>
-            </a:pPr>
-            <a:r>
-              <a:rPr/>
-              <a:t>And the correction to the instinct that this lesson exists to install: more features is not free. It is nearly free for a linear model and it is expensive for anything built on a distance.</a:t>
-            </a:r>
-          </a:p>
-          <a:p>
-            <a:pPr lvl="0" indent="0" marL="0">
-              <a:buNone/>
-            </a:pPr>
-          </a:p>
-          <a:p>
-            <a:pPr lvl="0" indent="0" marL="0">
-              <a:buNone/>
-            </a:pPr>
-            <a:r>
-              <a:rPr/>
-              <a:t>Handout section 7 lists all of this with the section numbers.</a:t>
+              <a:t>A table to photograph. Work down it and attach today’s evidence to each row, so it is remembered as a set of conclusions rather than as advice.</a:t>
+            </a:r>
+          </a:p>
+          <a:p>
+            <a:pPr lvl="0" indent="0" marL="0">
+              <a:buNone/>
+            </a:pPr>
+          </a:p>
+          <a:p>
+            <a:pPr lvl="0" indent="0" marL="0">
+              <a:buNone/>
+            </a:pPr>
+            <a:r>
+              <a:rPr/>
+              <a:t>Row two deserves a sentence on its own, because it is the one that sounds wrong after the last hour. Text classification is the canonical case: tens of thousands of word-count features, an assumption that is transparently false, and a method that works anyway - because being roughly right in ten thousand dimensions beats being unable to estimate anything at all. Also mention Naive Bayes as a baseline: it trains in one pass, so if your tuned model does not beat it you have learned something quickly and cheaply.</a:t>
+            </a:r>
+          </a:p>
+          <a:p>
+            <a:pPr lvl="0" indent="0" marL="0">
+              <a:buNone/>
+            </a:pPr>
+          </a:p>
+          <a:p>
+            <a:pPr lvl="0" indent="0" marL="0">
+              <a:buNone/>
+            </a:pPr>
+            <a:r>
+              <a:rPr/>
+              <a:t>One row that did not fit and should be said out loud: when you need to explain the decision to the person affected, none of today’s three will do it. A support vector machine in a lifted space has no explanation a customer would accept. Lesson 3’s Resources document covers why that is sometimes a legal requirement rather than a preference.</a:t>
             </a:r>
           </a:p>
         </p:txBody>
@@ -8261,49 +8270,49 @@
             </a:pPr>
             <a:r>
               <a:rPr/>
-              <a:t>Set it explicitly and say out loud when it comes back: the first ten minutes of next Friday, 13 November.</a:t>
-            </a:r>
-          </a:p>
-          <a:p>
-            <a:pPr lvl="0" indent="0" marL="0">
-              <a:buNone/>
-            </a:pPr>
-          </a:p>
-          <a:p>
-            <a:pPr lvl="0" indent="0" marL="0">
-              <a:buNone/>
-            </a:pPr>
-            <a:r>
-              <a:rPr/>
-              <a:t>The marks are for the reasoning, not for the accuracy. A well-argued choice that scores slightly worse beats a lucky winner with no justification - and the argument has to reference the data, in the way that the squared distances and the fitted ellipse explained Naive Bayes on the pumps this afternoon.</a:t>
-            </a:r>
-          </a:p>
-          <a:p>
-            <a:pPr lvl="0" indent="0" marL="0">
-              <a:buNone/>
-            </a:pPr>
-          </a:p>
-          <a:p>
-            <a:pPr lvl="0" indent="0" marL="0">
-              <a:buNone/>
-            </a:pPr>
-            <a:r>
-              <a:rPr/>
-              <a:t>Remind them that everything must be cross-validated and reported with a spread, in the format lesson 5 set. Scaling goes inside the pipeline; that will be checked.</a:t>
-            </a:r>
-          </a:p>
-          <a:p>
-            <a:pPr lvl="0" indent="0" marL="0">
-              <a:buNone/>
-            </a:pPr>
-          </a:p>
-          <a:p>
-            <a:pPr lvl="0" indent="0" marL="0">
-              <a:buNone/>
-            </a:pPr>
-            <a:r>
-              <a:rPr/>
-              <a:t>Next week: decision trees and ensembles. A fourth family, with a different answer again to the same question - how do you draw a boundary that is not a line.</a:t>
+              <a:t>Close on the number they opened the second segment with, and say it one more time: seventy per cent. In a hundred dimensions the nearest point in the entire dataset is seven tenths of the way to the farthest, and every method built on distance is operating on a quantity that has stopped varying.</a:t>
+            </a:r>
+          </a:p>
+          <a:p>
+            <a:pPr lvl="0" indent="0" marL="0">
+              <a:buNone/>
+            </a:pPr>
+          </a:p>
+          <a:p>
+            <a:pPr lvl="0" indent="0" marL="0">
+              <a:buNone/>
+            </a:pPr>
+            <a:r>
+              <a:rPr/>
+              <a:t>If they remember one habit from today, make it the diagnostic pair: before reaching for a model, look at the shape of the data; after fitting one, check whether the assumption it depends on is actually satisfied on your data - and check it properly. The −0.006 said yes; the squared distances said no; and the ellipse the model drew explained the 0.933.</a:t>
+            </a:r>
+          </a:p>
+          <a:p>
+            <a:pPr lvl="0" indent="0" marL="0">
+              <a:buNone/>
+            </a:pPr>
+          </a:p>
+          <a:p>
+            <a:pPr lvl="0" indent="0" marL="0">
+              <a:buNone/>
+            </a:pPr>
+            <a:r>
+              <a:rPr/>
+              <a:t>And the correction to the instinct that this lesson exists to install: more features is not free. It is nearly free for a linear model and it is expensive for anything built on a distance.</a:t>
+            </a:r>
+          </a:p>
+          <a:p>
+            <a:pPr lvl="0" indent="0" marL="0">
+              <a:buNone/>
+            </a:pPr>
+          </a:p>
+          <a:p>
+            <a:pPr lvl="0" indent="0" marL="0">
+              <a:buNone/>
+            </a:pPr>
+            <a:r>
+              <a:rPr/>
+              <a:t>Handout section 7 lists all of this with the section numbers.</a:t>
             </a:r>
           </a:p>
         </p:txBody>
@@ -8326,6 +8335,130 @@
             <a:fld id="{18BDFEC3-8487-43E8-A154-7C12CBC1FFF2}" type="slidenum">
               <a:rPr lang="en-US"/>
               <a:t>68</a:t>
+            </a:fld>
+            <a:endParaRPr lang="en-US"/>
+          </a:p>
+        </p:txBody>
+      </p:sp>
+    </p:spTree>
+  </p:cSld>
+</p:notes>
+</file>
+
+<file path=ppt/notesSlides/notesSlide68.xml><?xml version="1.0" encoding="utf-8"?>
+<p:notes xmlns:a="http://schemas.openxmlformats.org/drawingml/2006/main" xmlns:r="http://schemas.openxmlformats.org/officeDocument/2006/relationships" xmlns:p="http://schemas.openxmlformats.org/presentationml/2006/main">
+  <p:cSld>
+    <p:spTree>
+      <p:nvGrpSpPr>
+        <p:cNvPr id="1" name=""/>
+        <p:cNvGrpSpPr/>
+        <p:nvPr/>
+      </p:nvGrpSpPr>
+      <p:grpSpPr>
+        <a:xfrm>
+          <a:off x="0" y="0"/>
+          <a:ext cx="0" cy="0"/>
+          <a:chOff x="0" y="0"/>
+          <a:chExt cx="0" cy="0"/>
+        </a:xfrm>
+      </p:grpSpPr>
+      <p:sp>
+        <p:nvSpPr>
+          <p:cNvPr id="2" name="Slide Image Placeholder 1"/>
+          <p:cNvSpPr>
+            <a:spLocks noGrp="1" noRot="1" noChangeAspect="1"/>
+          </p:cNvSpPr>
+          <p:nvPr>
+            <p:ph type="sldImg"/>
+          </p:nvPr>
+        </p:nvSpPr>
+        <p:spPr/>
+      </p:sp>
+      <p:sp>
+        <p:nvSpPr>
+          <p:cNvPr id="3" name="Notes Placeholder 2"/>
+          <p:cNvSpPr>
+            <a:spLocks noGrp="1"/>
+          </p:cNvSpPr>
+          <p:nvPr>
+            <p:ph type="body" idx="1"/>
+          </p:nvPr>
+        </p:nvSpPr>
+        <p:spPr/>
+        <p:txBody>
+          <a:bodyPr/>
+          <a:lstStyle/>
+          <a:p>
+            <a:pPr lvl="0" indent="0" marL="0">
+              <a:buNone/>
+            </a:pPr>
+            <a:r>
+              <a:rPr/>
+              <a:t>Set it explicitly and say out loud when it comes back: the first ten minutes of next Friday, 13 November.</a:t>
+            </a:r>
+          </a:p>
+          <a:p>
+            <a:pPr lvl="0" indent="0" marL="0">
+              <a:buNone/>
+            </a:pPr>
+          </a:p>
+          <a:p>
+            <a:pPr lvl="0" indent="0" marL="0">
+              <a:buNone/>
+            </a:pPr>
+            <a:r>
+              <a:rPr/>
+              <a:t>The marks are for the reasoning, not for the accuracy. A well-argued choice that scores slightly worse beats a lucky winner with no justification - and the argument has to reference the data, in the way that the squared distances and the fitted ellipse explained Naive Bayes on the pumps this afternoon.</a:t>
+            </a:r>
+          </a:p>
+          <a:p>
+            <a:pPr lvl="0" indent="0" marL="0">
+              <a:buNone/>
+            </a:pPr>
+          </a:p>
+          <a:p>
+            <a:pPr lvl="0" indent="0" marL="0">
+              <a:buNone/>
+            </a:pPr>
+            <a:r>
+              <a:rPr/>
+              <a:t>Remind them that everything must be cross-validated and reported with a spread, in the format lesson 5 set. Scaling goes inside the pipeline; that will be checked.</a:t>
+            </a:r>
+          </a:p>
+          <a:p>
+            <a:pPr lvl="0" indent="0" marL="0">
+              <a:buNone/>
+            </a:pPr>
+          </a:p>
+          <a:p>
+            <a:pPr lvl="0" indent="0" marL="0">
+              <a:buNone/>
+            </a:pPr>
+            <a:r>
+              <a:rPr/>
+              <a:t>Next week: decision trees and ensembles. A fourth family, with a different answer again to the same question - how do you draw a boundary that is not a line.</a:t>
+            </a:r>
+          </a:p>
+        </p:txBody>
+      </p:sp>
+      <p:sp>
+        <p:nvSpPr>
+          <p:cNvPr id="4" name="Slide Number Placeholder 3"/>
+          <p:cNvSpPr>
+            <a:spLocks noGrp="1"/>
+          </p:cNvSpPr>
+          <p:nvPr>
+            <p:ph type="sldNum" sz="quarter" idx="10"/>
+          </p:nvPr>
+        </p:nvSpPr>
+        <p:spPr/>
+        <p:txBody>
+          <a:bodyPr/>
+          <a:lstStyle/>
+          <a:p>
+            <a:fld id="{18BDFEC3-8487-43E8-A154-7C12CBC1FFF2}" type="slidenum">
+              <a:rPr lang="en-US"/>
+              <a:t>69</a:t>
             </a:fld>
             <a:endParaRPr lang="en-US"/>
           </a:p>
@@ -18976,6 +19109,88 @@
             </a:pPr>
             <a:r>
               <a:rPr/>
+              <a:t>The boundary is a weighted vote of the pumps</a:t>
+            </a:r>
+          </a:p>
+        </p:txBody>
+      </p:sp>
+      <p:pic>
+        <p:nvPicPr>
+          <p:cNvPr descr="eq_5ca15d7014.png" id="0" name="Picture 1"/>
+          <p:cNvPicPr>
+            <a:picLocks noGrp="1" noChangeAspect="1"/>
+          </p:cNvPicPr>
+          <p:nvPr/>
+        </p:nvPicPr>
+        <p:blipFill>
+          <a:blip r:embed="rId3"/>
+          <a:stretch>
+            <a:fillRect/>
+          </a:stretch>
+        </p:blipFill>
+        <p:spPr bwMode="auto">
+          <a:xfrm>
+            <a:off x="457200" y="1887339"/>
+            <a:ext cx="8229599" cy="1917700"/>
+          </a:xfrm>
+          <a:prstGeom prst="rect">
+            <a:avLst/>
+          </a:prstGeom>
+          <a:noFill/>
+          <a:ln w="9525">
+            <a:noFill/>
+            <a:headEnd/>
+            <a:tailEnd/>
+          </a:ln>
+        </p:spPr>
+      </p:pic>
+    </p:spTree>
+  </p:cSld>
+</p:sld>
+</file>
+
+<file path=ppt/slides/slide57.xml><?xml version="1.0" encoding="utf-8"?>
+<p:sld xmlns:a="http://schemas.openxmlformats.org/drawingml/2006/main" xmlns:r="http://schemas.openxmlformats.org/officeDocument/2006/relationships" xmlns:p="http://schemas.openxmlformats.org/presentationml/2006/main">
+  <p:cSld>
+    <p:spTree>
+      <p:nvGrpSpPr>
+        <p:cNvPr id="1" name=""/>
+        <p:cNvGrpSpPr/>
+        <p:nvPr/>
+      </p:nvGrpSpPr>
+      <p:grpSpPr>
+        <a:xfrm>
+          <a:off x="0" y="0"/>
+          <a:ext cx="0" cy="0"/>
+          <a:chOff x="0" y="0"/>
+          <a:chExt cx="0" cy="0"/>
+        </a:xfrm>
+      </p:grpSpPr>
+      <p:sp>
+        <p:nvSpPr>
+          <p:cNvPr id="2" name="Title 1"/>
+          <p:cNvSpPr>
+            <a:spLocks noGrp="1"/>
+          </p:cNvSpPr>
+          <p:nvPr>
+            <p:ph type="title"/>
+          </p:nvPr>
+        </p:nvSpPr>
+        <p:spPr>
+          <a:xfrm>
+            <a:off x="457200" y="205979"/>
+            <a:ext cx="8229600" cy="857250"/>
+          </a:xfrm>
+        </p:spPr>
+        <p:txBody>
+          <a:bodyPr/>
+          <a:lstStyle/>
+          <a:p>
+            <a:pPr lvl="0" indent="0" marL="0">
+              <a:buNone/>
+            </a:pPr>
+            <a:r>
+              <a:rPr/>
               <a:t>The kernel trick by hand: 25 = 25</a:t>
             </a:r>
           </a:p>
@@ -19159,7 +19374,7 @@
 </p:sld>
 </file>
 
-<file path=ppt/slides/slide57.xml><?xml version="1.0" encoding="utf-8"?>
+<file path=ppt/slides/slide58.xml><?xml version="1.0" encoding="utf-8"?>
 <p:sld xmlns:a="http://schemas.openxmlformats.org/drawingml/2006/main" xmlns:r="http://schemas.openxmlformats.org/officeDocument/2006/relationships" xmlns:p="http://schemas.openxmlformats.org/presentationml/2006/main">
   <p:cSld>
     <p:spTree>
@@ -19241,7 +19456,7 @@
 </p:sld>
 </file>
 
-<file path=ppt/slides/slide58.xml><?xml version="1.0" encoding="utf-8"?>
+<file path=ppt/slides/slide59.xml><?xml version="1.0" encoding="utf-8"?>
 <p:sld xmlns:a="http://schemas.openxmlformats.org/drawingml/2006/main" xmlns:r="http://schemas.openxmlformats.org/officeDocument/2006/relationships" xmlns:p="http://schemas.openxmlformats.org/presentationml/2006/main">
   <p:cSld>
     <p:spTree>
@@ -19366,7 +19581,185 @@
 </p:sld>
 </file>
 
-<file path=ppt/slides/slide59.xml><?xml version="1.0" encoding="utf-8"?>
+<file path=ppt/slides/slide6.xml><?xml version="1.0" encoding="utf-8"?>
+<p:sld xmlns:a="http://schemas.openxmlformats.org/drawingml/2006/main" xmlns:r="http://schemas.openxmlformats.org/officeDocument/2006/relationships" xmlns:p="http://schemas.openxmlformats.org/presentationml/2006/main">
+  <p:cSld>
+    <p:spTree>
+      <p:nvGrpSpPr>
+        <p:cNvPr id="1" name=""/>
+        <p:cNvGrpSpPr/>
+        <p:nvPr/>
+      </p:nvGrpSpPr>
+      <p:grpSpPr>
+        <a:xfrm>
+          <a:off x="0" y="0"/>
+          <a:ext cx="0" cy="0"/>
+          <a:chOff x="0" y="0"/>
+          <a:chExt cx="0" cy="0"/>
+        </a:xfrm>
+      </p:grpSpPr>
+      <p:sp>
+        <p:nvSpPr>
+          <p:cNvPr id="2" name="Title 1"/>
+          <p:cNvSpPr>
+            <a:spLocks noGrp="1"/>
+          </p:cNvSpPr>
+          <p:nvPr>
+            <p:ph type="title"/>
+          </p:nvPr>
+        </p:nvSpPr>
+        <p:spPr>
+          <a:xfrm>
+            <a:off x="457200" y="205979"/>
+            <a:ext cx="8229600" cy="857250"/>
+          </a:xfrm>
+        </p:spPr>
+        <p:txBody>
+          <a:bodyPr/>
+          <a:lstStyle/>
+          <a:p>
+            <a:pPr lvl="0" indent="0" marL="0">
+              <a:buNone/>
+            </a:pPr>
+            <a:r>
+              <a:rPr/>
+              <a:t>What a straight boundary costs</a:t>
+            </a:r>
+          </a:p>
+        </p:txBody>
+      </p:sp>
+      <p:graphicFrame>
+        <p:nvGraphicFramePr>
+          <p:cNvPr id="6" name="Content Placeholder 5"/>
+          <p:cNvGraphicFramePr>
+            <a:graphicFrameLocks noGrp="1"/>
+          </p:cNvGraphicFramePr>
+          <p:nvPr>
+            <p:ph idx="1"/>
+          </p:nvPr>
+        </p:nvGraphicFramePr>
+        <p:xfrm>
+          <a:off x="457200" y="1166099"/>
+          <a:ext cx="8229600" cy="3390900"/>
+        </p:xfrm>
+        <a:graphic>
+          <a:graphicData uri="http://schemas.openxmlformats.org/drawingml/2006/table">
+            <a:tbl>
+              <a:tblPr firstRow="1" bandRow="1">
+                <a:tableStyleId>{5C22544A-7EE6-4342-B048-85BDC9FD1C3A}</a:tableStyleId>
+              </a:tblPr>
+              <a:tblGrid>
+                <a:gridCol w="4114800"/>
+                <a:gridCol w="4114800"/>
+              </a:tblGrid>
+              <a:tr h="0">
+                <a:tc>
+                  <a:txBody>
+                    <a:bodyPr/>
+                    <a:lstStyle/>
+                    <a:p>
+                      <a:pPr lvl="0" indent="0" marL="0">
+                        <a:buNone/>
+                      </a:pPr>
+                      <a:r>
+                        <a:rPr/>
+                        <a:t>Model</a:t>
+                      </a:r>
+                    </a:p>
+                  </a:txBody>
+                  <a:tcPr/>
+                </a:tc>
+                <a:tc>
+                  <a:txBody>
+                    <a:bodyPr/>
+                    <a:lstStyle/>
+                    <a:p>
+                      <a:pPr lvl="0" indent="0" marL="0">
+                        <a:buNone/>
+                      </a:pPr>
+                      <a:r>
+                        <a:rPr/>
+                        <a:t>Cross-validated accuracy</a:t>
+                      </a:r>
+                    </a:p>
+                  </a:txBody>
+                  <a:tcPr/>
+                </a:tc>
+              </a:tr>
+              <a:tr h="0">
+                <a:tc>
+                  <a:txBody>
+                    <a:bodyPr/>
+                    <a:lstStyle/>
+                    <a:p>
+                      <a:pPr lvl="0" indent="0" marL="0">
+                        <a:buNone/>
+                      </a:pPr>
+                      <a:r>
+                        <a:rPr/>
+                        <a:t>Always predict the majority class</a:t>
+                      </a:r>
+                    </a:p>
+                  </a:txBody>
+                </a:tc>
+                <a:tc>
+                  <a:txBody>
+                    <a:bodyPr/>
+                    <a:lstStyle/>
+                    <a:p>
+                      <a:pPr lvl="0" indent="0" marL="0">
+                        <a:buNone/>
+                      </a:pPr>
+                      <a:r>
+                        <a:rPr/>
+                        <a:t>0.613</a:t>
+                      </a:r>
+                    </a:p>
+                  </a:txBody>
+                </a:tc>
+              </a:tr>
+              <a:tr h="0">
+                <a:tc>
+                  <a:txBody>
+                    <a:bodyPr/>
+                    <a:lstStyle/>
+                    <a:p>
+                      <a:pPr lvl="0" indent="0" marL="0">
+                        <a:buNone/>
+                      </a:pPr>
+                      <a:r>
+                        <a:rPr/>
+                        <a:t>Logistic regression (lesson 4)</a:t>
+                      </a:r>
+                    </a:p>
+                  </a:txBody>
+                </a:tc>
+                <a:tc>
+                  <a:txBody>
+                    <a:bodyPr/>
+                    <a:lstStyle/>
+                    <a:p>
+                      <a:pPr lvl="0" indent="0" marL="0">
+                        <a:buNone/>
+                      </a:pPr>
+                      <a:r>
+                        <a:rPr b="1"/>
+                        <a:t>0.613 ± 0.000</a:t>
+                      </a:r>
+                    </a:p>
+                  </a:txBody>
+                </a:tc>
+              </a:tr>
+            </a:tbl>
+          </a:graphicData>
+        </a:graphic>
+      </p:graphicFrame>
+    </p:spTree>
+  </p:cSld>
+</p:sld>
+</file>
+
+<file path=ppt/slides/slide60.xml><?xml version="1.0" encoding="utf-8"?>
 <p:sld xmlns:a="http://schemas.openxmlformats.org/drawingml/2006/main" xmlns:r="http://schemas.openxmlformats.org/officeDocument/2006/relationships" xmlns:p="http://schemas.openxmlformats.org/presentationml/2006/main">
   <p:cSld>
     <p:spTree>
@@ -19608,185 +20001,7 @@
 </p:sld>
 </file>
 
-<file path=ppt/slides/slide6.xml><?xml version="1.0" encoding="utf-8"?>
-<p:sld xmlns:a="http://schemas.openxmlformats.org/drawingml/2006/main" xmlns:r="http://schemas.openxmlformats.org/officeDocument/2006/relationships" xmlns:p="http://schemas.openxmlformats.org/presentationml/2006/main">
-  <p:cSld>
-    <p:spTree>
-      <p:nvGrpSpPr>
-        <p:cNvPr id="1" name=""/>
-        <p:cNvGrpSpPr/>
-        <p:nvPr/>
-      </p:nvGrpSpPr>
-      <p:grpSpPr>
-        <a:xfrm>
-          <a:off x="0" y="0"/>
-          <a:ext cx="0" cy="0"/>
-          <a:chOff x="0" y="0"/>
-          <a:chExt cx="0" cy="0"/>
-        </a:xfrm>
-      </p:grpSpPr>
-      <p:sp>
-        <p:nvSpPr>
-          <p:cNvPr id="2" name="Title 1"/>
-          <p:cNvSpPr>
-            <a:spLocks noGrp="1"/>
-          </p:cNvSpPr>
-          <p:nvPr>
-            <p:ph type="title"/>
-          </p:nvPr>
-        </p:nvSpPr>
-        <p:spPr>
-          <a:xfrm>
-            <a:off x="457200" y="205979"/>
-            <a:ext cx="8229600" cy="857250"/>
-          </a:xfrm>
-        </p:spPr>
-        <p:txBody>
-          <a:bodyPr/>
-          <a:lstStyle/>
-          <a:p>
-            <a:pPr lvl="0" indent="0" marL="0">
-              <a:buNone/>
-            </a:pPr>
-            <a:r>
-              <a:rPr/>
-              <a:t>What a straight boundary costs</a:t>
-            </a:r>
-          </a:p>
-        </p:txBody>
-      </p:sp>
-      <p:graphicFrame>
-        <p:nvGraphicFramePr>
-          <p:cNvPr id="6" name="Content Placeholder 5"/>
-          <p:cNvGraphicFramePr>
-            <a:graphicFrameLocks noGrp="1"/>
-          </p:cNvGraphicFramePr>
-          <p:nvPr>
-            <p:ph idx="1"/>
-          </p:nvPr>
-        </p:nvGraphicFramePr>
-        <p:xfrm>
-          <a:off x="457200" y="1166099"/>
-          <a:ext cx="8229600" cy="3390900"/>
-        </p:xfrm>
-        <a:graphic>
-          <a:graphicData uri="http://schemas.openxmlformats.org/drawingml/2006/table">
-            <a:tbl>
-              <a:tblPr firstRow="1" bandRow="1">
-                <a:tableStyleId>{5C22544A-7EE6-4342-B048-85BDC9FD1C3A}</a:tableStyleId>
-              </a:tblPr>
-              <a:tblGrid>
-                <a:gridCol w="4114800"/>
-                <a:gridCol w="4114800"/>
-              </a:tblGrid>
-              <a:tr h="0">
-                <a:tc>
-                  <a:txBody>
-                    <a:bodyPr/>
-                    <a:lstStyle/>
-                    <a:p>
-                      <a:pPr lvl="0" indent="0" marL="0">
-                        <a:buNone/>
-                      </a:pPr>
-                      <a:r>
-                        <a:rPr/>
-                        <a:t>Model</a:t>
-                      </a:r>
-                    </a:p>
-                  </a:txBody>
-                  <a:tcPr/>
-                </a:tc>
-                <a:tc>
-                  <a:txBody>
-                    <a:bodyPr/>
-                    <a:lstStyle/>
-                    <a:p>
-                      <a:pPr lvl="0" indent="0" marL="0">
-                        <a:buNone/>
-                      </a:pPr>
-                      <a:r>
-                        <a:rPr/>
-                        <a:t>Cross-validated accuracy</a:t>
-                      </a:r>
-                    </a:p>
-                  </a:txBody>
-                  <a:tcPr/>
-                </a:tc>
-              </a:tr>
-              <a:tr h="0">
-                <a:tc>
-                  <a:txBody>
-                    <a:bodyPr/>
-                    <a:lstStyle/>
-                    <a:p>
-                      <a:pPr lvl="0" indent="0" marL="0">
-                        <a:buNone/>
-                      </a:pPr>
-                      <a:r>
-                        <a:rPr/>
-                        <a:t>Always predict the majority class</a:t>
-                      </a:r>
-                    </a:p>
-                  </a:txBody>
-                </a:tc>
-                <a:tc>
-                  <a:txBody>
-                    <a:bodyPr/>
-                    <a:lstStyle/>
-                    <a:p>
-                      <a:pPr lvl="0" indent="0" marL="0">
-                        <a:buNone/>
-                      </a:pPr>
-                      <a:r>
-                        <a:rPr/>
-                        <a:t>0.613</a:t>
-                      </a:r>
-                    </a:p>
-                  </a:txBody>
-                </a:tc>
-              </a:tr>
-              <a:tr h="0">
-                <a:tc>
-                  <a:txBody>
-                    <a:bodyPr/>
-                    <a:lstStyle/>
-                    <a:p>
-                      <a:pPr lvl="0" indent="0" marL="0">
-                        <a:buNone/>
-                      </a:pPr>
-                      <a:r>
-                        <a:rPr/>
-                        <a:t>Logistic regression (lesson 4)</a:t>
-                      </a:r>
-                    </a:p>
-                  </a:txBody>
-                </a:tc>
-                <a:tc>
-                  <a:txBody>
-                    <a:bodyPr/>
-                    <a:lstStyle/>
-                    <a:p>
-                      <a:pPr lvl="0" indent="0" marL="0">
-                        <a:buNone/>
-                      </a:pPr>
-                      <a:r>
-                        <a:rPr b="1"/>
-                        <a:t>0.613 ± 0.000</a:t>
-                      </a:r>
-                    </a:p>
-                  </a:txBody>
-                </a:tc>
-              </a:tr>
-            </a:tbl>
-          </a:graphicData>
-        </a:graphic>
-      </p:graphicFrame>
-    </p:spTree>
-  </p:cSld>
-</p:sld>
-</file>
-
-<file path=ppt/slides/slide60.xml><?xml version="1.0" encoding="utf-8"?>
+<file path=ppt/slides/slide61.xml><?xml version="1.0" encoding="utf-8"?>
 <p:sld xmlns:a="http://schemas.openxmlformats.org/drawingml/2006/main" xmlns:r="http://schemas.openxmlformats.org/officeDocument/2006/relationships" xmlns:p="http://schemas.openxmlformats.org/presentationml/2006/main">
   <p:cSld>
     <p:spTree>
@@ -19868,7 +20083,7 @@
 </p:sld>
 </file>
 
-<file path=ppt/slides/slide61.xml><?xml version="1.0" encoding="utf-8"?>
+<file path=ppt/slides/slide62.xml><?xml version="1.0" encoding="utf-8"?>
 <p:sld xmlns:a="http://schemas.openxmlformats.org/drawingml/2006/main" xmlns:r="http://schemas.openxmlformats.org/officeDocument/2006/relationships" xmlns:p="http://schemas.openxmlformats.org/presentationml/2006/main">
   <p:cSld>
     <p:spTree>
@@ -20140,7 +20355,7 @@
 </p:sld>
 </file>
 
-<file path=ppt/slides/slide62.xml><?xml version="1.0" encoding="utf-8"?>
+<file path=ppt/slides/slide63.xml><?xml version="1.0" encoding="utf-8"?>
 <p:sld xmlns:a="http://schemas.openxmlformats.org/drawingml/2006/main" xmlns:r="http://schemas.openxmlformats.org/officeDocument/2006/relationships" xmlns:p="http://schemas.openxmlformats.org/presentationml/2006/main">
   <p:cSld>
     <p:spTree>
@@ -20222,7 +20437,7 @@
 </p:sld>
 </file>
 
-<file path=ppt/slides/slide63.xml><?xml version="1.0" encoding="utf-8"?>
+<file path=ppt/slides/slide64.xml><?xml version="1.0" encoding="utf-8"?>
 <p:sld xmlns:a="http://schemas.openxmlformats.org/drawingml/2006/main" xmlns:r="http://schemas.openxmlformats.org/officeDocument/2006/relationships" xmlns:p="http://schemas.openxmlformats.org/presentationml/2006/main">
   <p:cSld>
     <p:spTree>
@@ -20304,7 +20519,7 @@
 </p:sld>
 </file>
 
-<file path=ppt/slides/slide64.xml><?xml version="1.0" encoding="utf-8"?>
+<file path=ppt/slides/slide65.xml><?xml version="1.0" encoding="utf-8"?>
 <p:sld xmlns:a="http://schemas.openxmlformats.org/drawingml/2006/main" xmlns:r="http://schemas.openxmlformats.org/officeDocument/2006/relationships" xmlns:p="http://schemas.openxmlformats.org/presentationml/2006/main">
   <p:cSld>
     <p:spTree>
@@ -20384,7 +20599,7 @@
 </p:sld>
 </file>
 
-<file path=ppt/slides/slide65.xml><?xml version="1.0" encoding="utf-8"?>
+<file path=ppt/slides/slide66.xml><?xml version="1.0" encoding="utf-8"?>
 <p:sld xmlns:a="http://schemas.openxmlformats.org/drawingml/2006/main" xmlns:r="http://schemas.openxmlformats.org/officeDocument/2006/relationships" xmlns:p="http://schemas.openxmlformats.org/presentationml/2006/main">
   <p:cSld>
     <p:spTree>
@@ -20722,7 +20937,7 @@
 </p:sld>
 </file>
 
-<file path=ppt/slides/slide66.xml><?xml version="1.0" encoding="utf-8"?>
+<file path=ppt/slides/slide67.xml><?xml version="1.0" encoding="utf-8"?>
 <p:sld xmlns:a="http://schemas.openxmlformats.org/drawingml/2006/main" xmlns:r="http://schemas.openxmlformats.org/officeDocument/2006/relationships" xmlns:p="http://schemas.openxmlformats.org/presentationml/2006/main">
   <p:cSld>
     <p:spTree>
@@ -21000,7 +21215,7 @@
 </p:sld>
 </file>
 
-<file path=ppt/slides/slide67.xml><?xml version="1.0" encoding="utf-8"?>
+<file path=ppt/slides/slide68.xml><?xml version="1.0" encoding="utf-8"?>
 <p:sld xmlns:a="http://schemas.openxmlformats.org/drawingml/2006/main" xmlns:r="http://schemas.openxmlformats.org/officeDocument/2006/relationships" xmlns:p="http://schemas.openxmlformats.org/presentationml/2006/main">
   <p:cSld>
     <p:spTree>
@@ -21132,7 +21347,7 @@
 </p:sld>
 </file>
 
-<file path=ppt/slides/slide68.xml><?xml version="1.0" encoding="utf-8"?>
+<file path=ppt/slides/slide69.xml><?xml version="1.0" encoding="utf-8"?>
 <p:sld xmlns:a="http://schemas.openxmlformats.org/drawingml/2006/main" xmlns:r="http://schemas.openxmlformats.org/officeDocument/2006/relationships" xmlns:p="http://schemas.openxmlformats.org/presentationml/2006/main">
   <p:cSld>
     <p:spTree>

</xml_diff>

<commit_message>
Say how K(x_i, x_j) in training differs from K(x_i, x) in inference
Section 5.5 described training as "solving the dual" without ever writing
the dual with the kernel substituted in, so a reader had no way to see
that training only ever evaluates K between pairs of training points and
never touches the pump it will later classify.

Add the kernelized dual objective, with i and j both training indices,
and state the contrast explicitly against the inference formula that
follows, where x is the new point. Same addition in the Italian
translation and in the training slide's speaker notes.

Co-Authored-By: Claude Sonnet 5 <noreply@anthropic.com>
</commit_message>
<xml_diff>
--- a/Lessons/06_knn_naive_bayes_svm/Slides/knn_naive_bayes_svm_slides.pptx
+++ b/Lessons/06_knn_naive_bayes_svm/Slides/knn_naive_bayes_svm_slides.pptx
@@ -7102,7 +7102,21 @@
             </a:pPr>
             <a:r>
               <a:rPr/>
-              <a:t>Say what “fit” does, because after lesson 3 they will expect gradient descent. It is not. The SVM solves the dual: one weight per training point, found by a solver that picks two weights at a time - two, because the weights times the labels must sum to zero, so one cannot move alone - sets them to their best values with the rest fixed, and repeats until nothing improves. Convex, so there is one answer and it is found every time.</a:t>
+              <a:t>Say what “fit” does, because after lesson 3 they will expect gradient descent. It is not. The SVM solves the dual with the kernel substituted in: one weight per training point, found by a solver that picks two weights at a time - two, because the weights times the labels must sum to zero, so one cannot move alone - sets them to their best values with the rest fixed, and repeats until nothing improves. Convex, so there is one answer and it is found every time.</a:t>
+            </a:r>
+          </a:p>
+          <a:p>
+            <a:pPr lvl="0" indent="0" marL="0">
+              <a:buNone/>
+            </a:pPr>
+          </a:p>
+          <a:p>
+            <a:pPr lvl="0" indent="0" marL="0">
+              <a:buNone/>
+            </a:pPr>
+            <a:r>
+              <a:rPr/>
+              <a:t>Name the distinction the previous slide left open. The objective being solved here only ever evaluates K(x_i, x_j) between pairs of training pumps - the kernel matrix, m by m. The new pump, the one this model will eventually classify, appears nowhere in training. K(x_i, x), with a free x, is the prediction formula two slides on: same function, but its second argument is now the pump being classified rather than another training point.</a:t>
             </a:r>
           </a:p>
           <a:p>

</xml_diff>

<commit_message>
Anchor lesson 6's slides to its code and say its notes plainly
The three "Notebook N, live" slides now carry a table mapping each notebook
section to its slides and its scikit-learn calls, and the concept slides name
KNeighborsClassifier, the scaling pipeline, GaussianNB and SVC; lesson 6 joins
ANCHORED in verify_lesson.

Four inconsistencies are corrected. Naive Bayes is no longer said to work on
the pumps because independence holds (slide 68, notebook 2's takeaway): it is
false there and cheap. Slide 42's notes no longer call the below-chance model
confident, which slide 43 contradicts. Slide 69's notes speak of the exam, not
marks. A large C no longer "contorts" a linear SVM (slide, handout, concepts,
quiz): it narrows, shifts or rotates the slab. The handout and slide 21 also
stop citing an RBF result on the noise columns that no table shows.

The speaker notes are rewritten without ellipsis or jargon throughout.

Co-Authored-By: Claude Opus 5.5 <noreply@anthropic.com>
</commit_message>
<xml_diff>
--- a/Lessons/06_knn_naive_bayes_svm/Slides/knn_naive_bayes_svm_slides.pptx
+++ b/Lessons/06_knn_naive_bayes_svm/Slides/knn_naive_bayes_svm_slides.pptx
@@ -592,35 +592,35 @@
             </a:pPr>
             <a:r>
               <a:rPr/>
-              <a:t>Nothing to collect. What matters is the diagnosis, not the final figure, so ask the room what it found and listen for what it missed.</a:t>
-            </a:r>
-          </a:p>
-          <a:p>
-            <a:pPr lvl="0" indent="0" marL="0">
-              <a:buNone/>
-            </a:pPr>
-          </a:p>
-          <a:p>
-            <a:pPr lvl="0" indent="0" marL="0">
-              <a:buNone/>
-            </a:pPr>
-            <a:r>
-              <a:rPr/>
-              <a:t>There was more than one problem planted. Ask out loud how many people found the second one, and how many stopped after the first - stopping after the first is the realistic failure, because once a score drops from excellent to plausible the pressure to keep looking disappears.</a:t>
-            </a:r>
-          </a:p>
-          <a:p>
-            <a:pPr lvl="0" indent="0" marL="0">
-              <a:buNone/>
-            </a:pPr>
-          </a:p>
-          <a:p>
-            <a:pPr lvl="0" indent="0" marL="0">
-              <a:buNone/>
-            </a:pPr>
-            <a:r>
-              <a:rPr/>
-              <a:t>Then the sentence that links last week to today: everything from now on is evaluated with the apparatus you built in lesson 5. Today adds three model families, and each of them offers new ways to be wrong while looking right.</a:t>
+              <a:t>Nothing is collected. What matters is how each student found the problems, not the final score, so ask the room what they found and listen for what they missed.</a:t>
+            </a:r>
+          </a:p>
+          <a:p>
+            <a:pPr lvl="0" indent="0" marL="0">
+              <a:buNone/>
+            </a:pPr>
+          </a:p>
+          <a:p>
+            <a:pPr lvl="0" indent="0" marL="0">
+              <a:buNone/>
+            </a:pPr>
+            <a:r>
+              <a:rPr/>
+              <a:t>The exercise hid more than one problem on purpose. Ask out loud how many people found the second one, and how many stopped after the first - stopping after the first is the common failure, because once a score drops from excellent to plausible the pressure to keep looking disappears.</a:t>
+            </a:r>
+          </a:p>
+          <a:p>
+            <a:pPr lvl="0" indent="0" marL="0">
+              <a:buNone/>
+            </a:pPr>
+          </a:p>
+          <a:p>
+            <a:pPr lvl="0" indent="0" marL="0">
+              <a:buNone/>
+            </a:pPr>
+            <a:r>
+              <a:rPr/>
+              <a:t>Then the sentence that links last week to today: everything from now on is evaluated with the tools built in lesson 5: cross-validation, baselines, training scores read against validation scores. Today adds three families of models, and each of them can produce a result that looks right and is not, in a way of its own.</a:t>
             </a:r>
           </a:p>
         </p:txBody>
@@ -716,35 +716,35 @@
             </a:pPr>
             <a:r>
               <a:rPr/>
-              <a:t>Row one: training 1.000, honest 0.912. The gap is the whole of lesson 5 in two numbers on one line.</a:t>
-            </a:r>
-          </a:p>
-          <a:p>
-            <a:pPr lvl="0" indent="0" marL="0">
-              <a:buNone/>
-            </a:pPr>
-          </a:p>
-          <a:p>
-            <a:pPr lvl="0" indent="0" marL="0">
-              <a:buNone/>
-            </a:pPr>
-            <a:r>
-              <a:rPr/>
-              <a:t>The best value is k = 5, at 0.944 - wide enough to average out the flipped labels, narrow enough to still follow the boundary. Note that it is not dramatically better than 15 or 51: the choice of k is forgiving over a wide range, which is worth saying because they will otherwise grid-search it to death.</a:t>
-            </a:r>
-          </a:p>
-          <a:p>
-            <a:pPr lvl="0" indent="0" marL="0">
-              <a:buNone/>
-            </a:pPr>
-          </a:p>
-          <a:p>
-            <a:pPr lvl="0" indent="0" marL="0">
-              <a:buNone/>
-            </a:pPr>
-            <a:r>
-              <a:rPr/>
-              <a:t>The last row is the interesting failure. At k = 401 the training score has collapsed too, which distinguishes it from overfitting: this model is bad everywhere, not just on data it has not seen. That is what bias looks like.</a:t>
+              <a:t>Row one: training 1.000, honest 0.912. The difference between them is lesson 5’s warning about training scores, in a single row.</a:t>
+            </a:r>
+          </a:p>
+          <a:p>
+            <a:pPr lvl="0" indent="0" marL="0">
+              <a:buNone/>
+            </a:pPr>
+          </a:p>
+          <a:p>
+            <a:pPr lvl="0" indent="0" marL="0">
+              <a:buNone/>
+            </a:pPr>
+            <a:r>
+              <a:rPr/>
+              <a:t>The best value is k = 5, at 0.944 - wide enough to average out the flipped labels, narrow enough to still follow the boundary. Note that it is not dramatically better than 15 or 51: the choice of k is forgiving over a wide range, which is worth saying because otherwise they will spend a long search on a choice that hardly matters.</a:t>
+            </a:r>
+          </a:p>
+          <a:p>
+            <a:pPr lvl="0" indent="0" marL="0">
+              <a:buNone/>
+            </a:pPr>
+          </a:p>
+          <a:p>
+            <a:pPr lvl="0" indent="0" marL="0">
+              <a:buNone/>
+            </a:pPr>
+            <a:r>
+              <a:rPr/>
+              <a:t>The last row is the interesting failure. At k = 401 the training score has collapsed too, which distinguishes it from overfitting: this model is bad everywhere, not just on data it has not seen. That is what high bias looks like: a model too simple to follow the data.</a:t>
             </a:r>
           </a:p>
           <a:p>
@@ -868,21 +868,21 @@
             </a:pPr>
             <a:r>
               <a:rPr/>
-              <a:t>The gap between the two curves is variance, and watch it close as k grows. Where they meet and then both fall together, you have run out of variance and started buying bias. The minimum of the honest curve sits just before that.</a:t>
-            </a:r>
-          </a:p>
-          <a:p>
-            <a:pPr lvl="0" indent="0" marL="0">
-              <a:buNone/>
-            </a:pPr>
-          </a:p>
-          <a:p>
-            <a:pPr lvl="0" indent="0" marL="0">
-              <a:buNone/>
-            </a:pPr>
-            <a:r>
-              <a:rPr/>
-              <a:t>Ask them which end of this plot they would have picked by looking at the training curve alone. The answer is the far left, which is the worst honest model on the plot bar one.</a:t>
+              <a:t>A large gap between the two curves is a symptom of high variance; watch it close as k grows. Where the curves meet and then fall together, the variance is gone and bias has taken over: the model has become too smooth. The minimum of the honest curve sits just before that.</a:t>
+            </a:r>
+          </a:p>
+          <a:p>
+            <a:pPr lvl="0" indent="0" marL="0">
+              <a:buNone/>
+            </a:pPr>
+          </a:p>
+          <a:p>
+            <a:pPr lvl="0" indent="0" marL="0">
+              <a:buNone/>
+            </a:pPr>
+            <a:r>
+              <a:rPr/>
+              <a:t>Ask them which end of this plot they would have picked by looking at the training curve alone. The answer is the far left, k = 1, one of the worst models on the plot by its cross-validated score.</a:t>
             </a:r>
           </a:p>
         </p:txBody>
@@ -992,21 +992,21 @@
             </a:pPr>
             <a:r>
               <a:rPr/>
-              <a:t>k = 15: a clean disc, close to the envelope that actually generated the data. This is roughly the truth.</a:t>
-            </a:r>
-          </a:p>
-          <a:p>
-            <a:pPr lvl="0" indent="0" marL="0">
-              <a:buNone/>
-            </a:pPr>
-          </a:p>
-          <a:p>
-            <a:pPr lvl="0" indent="0" marL="0">
-              <a:buNone/>
-            </a:pPr>
-            <a:r>
-              <a:rPr/>
-              <a:t>k = 401 is the one worth the time, because it does not do what people expect. It has not collapsed to a single class. The boundary has INFLATED past the true envelope and now swallows faulty pumps. With 401 votes taken over a large neighbourhood, the majority class wins in regions where it should not. The model has stopped following the boundary and started averaging over it.</a:t>
+              <a:t>k = 15: a clean disc, close to the envelope that actually generated the data. This is close to the envelope the data was generated from.</a:t>
+            </a:r>
+          </a:p>
+          <a:p>
+            <a:pPr lvl="0" indent="0" marL="0">
+              <a:buNone/>
+            </a:pPr>
+          </a:p>
+          <a:p>
+            <a:pPr lvl="0" indent="0" marL="0">
+              <a:buNone/>
+            </a:pPr>
+            <a:r>
+              <a:rPr/>
+              <a:t>k = 401 is the one worth the time, because it does not do what people expect. It has not collapsed to a single class. The boundary has INFLATED past the true envelope and now swallows faulty pumps. With 401 votes taken over a large neighbourhood, the majority class wins in regions where it should not. The model no longer follows the boundary; it averages the votes across it.</a:t>
             </a:r>
           </a:p>
           <a:p>
@@ -1102,7 +1102,7 @@
             </a:pPr>
             <a:r>
               <a:rPr/>
-              <a:t>The first cost is engineering. For 1,200 pumps it is nothing. For ten million rows answering a thousand queries a second it is the entire problem, and it is why approximate nearest-neighbour indexes are a small industry. Mention that the scikit-learn default uses a k-d tree or ball tree, which helps in low dimensions and stops helping in high ones - for reasons that are the next segment.</a:t>
+              <a:t>The first cost is engineering. For 1,200 pumps it is nothing. For ten million rows answering a thousand queries a second it is the entire problem, and it is why there is a whole family of software for finding approximate nearest neighbours quickly. Mention that scikit-learn by default uses a k-d tree or a ball tree (data structures that avoid comparing the query with every row), which helps in low dimensions and stops helping in high ones - for reasons that are the next segment.</a:t>
             </a:r>
           </a:p>
           <a:p>
@@ -1392,7 +1392,7 @@
             </a:pPr>
             <a:r>
               <a:rPr/>
-              <a:t>The mechanism is on the next three slides, and it is geometry, not statistics.</a:t>
+              <a:t>The reason is on the next slides, and it is a property of distances in many dimensions, not of this dataset.</a:t>
             </a:r>
           </a:p>
         </p:txBody>
@@ -1502,7 +1502,7 @@
             </a:pPr>
             <a:r>
               <a:rPr/>
-              <a:t>Now add dimensions. Every new coordinate contributes its own squared difference to every pairwise distance. Those contributions are independent draws from the same distribution, so by the law of large numbers their average concentrates, and every distance converges on the same value.</a:t>
+              <a:t>Now add dimensions. Every new coordinate contributes its own squared difference to every pairwise distance. Those contributions are independent draws from the same distribution, so by the law of large numbers their sum grows while its spread, relative to its size, shrinks: every distance ends up close to the same value.</a:t>
             </a:r>
           </a:p>
           <a:p>
@@ -1530,7 +1530,7 @@
             </a:pPr>
             <a:r>
               <a:rPr/>
-              <a:t>Handout section 3.2 does it properly.</a:t>
+              <a:t>Handout section 3.2 has the derivation.</a:t>
             </a:r>
           </a:p>
         </p:txBody>
@@ -1626,7 +1626,7 @@
             </a:pPr>
             <a:r>
               <a:rPr/>
-              <a:t>The shape is the thing to notice: the damage is done early. Most of the rise happens in the first fifty dimensions, well below anything anyone would call high-dimensional. By the time you are worrying about a thousand features it is long over.</a:t>
+              <a:t>The shape is the thing to notice: the damage is done early. Most of the rise happens in the first fifty dimensions, well below anything anyone would call high-dimensional. By the time you are worrying about a thousand features, most of the damage has already happened.</a:t>
             </a:r>
           </a:p>
           <a:p>
@@ -1984,35 +1984,35 @@
             </a:pPr>
             <a:r>
               <a:rPr/>
-              <a:t>Agenda, and one framing sentence that is worth saying deliberately.</a:t>
-            </a:r>
-          </a:p>
-          <a:p>
-            <a:pPr lvl="0" indent="0" marL="0">
-              <a:buNone/>
-            </a:pPr>
-          </a:p>
-          <a:p>
-            <a:pPr lvl="0" indent="0" marL="0">
-              <a:buNone/>
-            </a:pPr>
-            <a:r>
-              <a:rPr/>
-              <a:t>Lessons 3 and 4 built linear models and spent most of their effort on fitting them honestly. Lesson 5 built the apparatus for telling whether a model works. None of that told them WHICH MODEL TO REACH FOR. This is the first lesson that offers a choice, and the choosing is the content.</a:t>
-            </a:r>
-          </a:p>
-          <a:p>
-            <a:pPr lvl="0" indent="0" marL="0">
-              <a:buNone/>
-            </a:pPr>
-          </a:p>
-          <a:p>
-            <a:pPr lvl="0" indent="0" marL="0">
-              <a:buNone/>
-            </a:pPr>
-            <a:r>
-              <a:rPr/>
-              <a:t>Stress that these are not three ways of doing the same thing. They attack classification from three unrelated directions: one makes no assumptions and does no fitting at all, one makes an assumption that is usually false and wins anyway, one changes the criterion and then changes the space. The differences between them are the point, not the accuracy figures.</a:t>
+              <a:t>The agenda, and one sentence about the whole lesson that is worth saying slowly.</a:t>
+            </a:r>
+          </a:p>
+          <a:p>
+            <a:pPr lvl="0" indent="0" marL="0">
+              <a:buNone/>
+            </a:pPr>
+          </a:p>
+          <a:p>
+            <a:pPr lvl="0" indent="0" marL="0">
+              <a:buNone/>
+            </a:pPr>
+            <a:r>
+              <a:rPr/>
+              <a:t>Lessons 3 and 4 built linear models and spent most of their effort on fitting them honestly. Lesson 5 built the apparatus for telling whether a model works. None of that told them WHICH KIND OF MODEL TO USE. This is the first lesson that offers a choice, and learning how to choose is what the lesson is about.</a:t>
+            </a:r>
+          </a:p>
+          <a:p>
+            <a:pPr lvl="0" indent="0" marL="0">
+              <a:buNone/>
+            </a:pPr>
+          </a:p>
+          <a:p>
+            <a:pPr lvl="0" indent="0" marL="0">
+              <a:buNone/>
+            </a:pPr>
+            <a:r>
+              <a:rPr/>
+              <a:t>Stress that these are not three ways of doing the same thing. They attack classification from three unrelated directions: k-NN makes no assumptions and does no fitting at all; Naive Bayes makes an assumption that is usually false and works well anyway; the SVM changes the criterion for choosing a boundary, and then changes the coordinates the data is described in. The differences between them are the point, not the accuracy figures.</a:t>
             </a:r>
           </a:p>
           <a:p>
@@ -2122,7 +2122,7 @@
             </a:pPr>
             <a:r>
               <a:rPr/>
-              <a:t>Neural networks work happily in thousands of dimensions. So do linear models with regularisation. What breaks is specifically the family of methods whose mechanism is a distance, because a quantity that no longer varies can no longer discriminate. Name the three that appear in this course: k-NN today, k-means in lesson 8, and the RBF kernel later this afternoon - which is why the RBF SVM also degraded in that table, though more slowly.</a:t>
+              <a:t>Neural networks work happily in thousands of dimensions. So do linear models with regularisation. What breaks is specifically the family of methods whose mechanism is a distance, because a quantity that no longer varies can no longer discriminate. Name the three that appear in this course: k-NN today, k-means in lesson 8, and the RBF kernel later this afternoon, which measures similarity through the same Euclidean distance.</a:t>
             </a:r>
           </a:p>
           <a:p>
@@ -2140,7 +2140,7 @@
             </a:r>
             <a:r>
               <a:rPr/>
-              <a:t> Adding features because they might help is good practice with a linear model: an irrelevant feature earns a coefficient near zero and costs you almost nothing. That reasoning is sound, and it is what they have been taught for three lessons. With k-NN the same feature costs you a dimension in the distance, and dimensions are what the method is made of. The habit is right; transferring it one lesson later does real damage. Say that the fix is to select features BEFORE the distance, inside the pipeline - which is last week’s rule again.</a:t>
+              <a:t> Adding features because they might help is good practice with a linear model: an irrelevant feature earns a coefficient near zero and costs you almost nothing. That reasoning is sound, and it is what they have been taught for three lessons. With k-NN the same feature costs you a dimension in the distance, and dimensions are what the method is made of. The habit is right; transferring it one lesson later does real damage. Say that the fix is to choose the features before any distance is computed, as a step inside the pipeline, so that the choice is made on the training part of each fold only - lesson 5’s rule again.</a:t>
             </a:r>
           </a:p>
         </p:txBody>
@@ -2222,35 +2222,35 @@
             </a:pPr>
             <a:r>
               <a:rPr/>
-              <a:t>Run notebooks/01. Twenty-two minutes.</a:t>
-            </a:r>
-          </a:p>
-          <a:p>
-            <a:pPr lvl="0" indent="0" marL="0">
-              <a:buNone/>
-            </a:pPr>
-          </a:p>
-          <a:p>
-            <a:pPr lvl="0" indent="0" marL="0">
-              <a:buNone/>
-            </a:pPr>
-            <a:r>
-              <a:rPr/>
-              <a:t>Have them run the unscaled version first, before the Pipeline appears, so they watch the score drop and can attribute it to the units rather than to the method.</a:t>
-            </a:r>
-          </a:p>
-          <a:p>
-            <a:pPr lvl="0" indent="0" marL="0">
-              <a:buNone/>
-            </a:pPr>
-          </a:p>
-          <a:p>
-            <a:pPr lvl="0" indent="0" marL="0">
-              <a:buNone/>
-            </a:pPr>
-            <a:r>
-              <a:rPr/>
-              <a:t>The cell to protect if time runs short is the noise-column sweep. Let them add the columns themselves and watch the score cross the baseline - it changes behaviour in a way that reading the table does not.</a:t>
+              <a:t>k-NN on the pumps, choosing k, and the curse of dimensionality measured. Run notebook 01. Twenty-two minutes.</a:t>
+            </a:r>
+          </a:p>
+          <a:p>
+            <a:pPr lvl="0" indent="0" marL="0">
+              <a:buNone/>
+            </a:pPr>
+          </a:p>
+          <a:p>
+            <a:pPr lvl="0" indent="0" marL="0">
+              <a:buNone/>
+            </a:pPr>
+            <a:r>
+              <a:rPr/>
+              <a:t>Have them run the unscaled version first, before the pipeline appears, so they watch the score drop and can attribute it to the units rather than to the method.</a:t>
+            </a:r>
+          </a:p>
+          <a:p>
+            <a:pPr lvl="0" indent="0" marL="0">
+              <a:buNone/>
+            </a:pPr>
+          </a:p>
+          <a:p>
+            <a:pPr lvl="0" indent="0" marL="0">
+              <a:buNone/>
+            </a:pPr>
+            <a:r>
+              <a:rPr/>
+              <a:t>If time runs short, do not skip the noise-column sweep. Let them add the columns themselves and watch the score cross the baseline - seeing it happen convinces more than reading the table.</a:t>
             </a:r>
           </a:p>
           <a:p>
@@ -2428,7 +2428,7 @@
             </a:pPr>
             <a:r>
               <a:rPr/>
-              <a:t>Say the strategy in words before the symbols appear. We want a quantity we cannot estimate directly. Bayes’ rule trades it for quantities we might be able to estimate. That is the whole move.</a:t>
+              <a:t>Say the strategy in words before the symbols appear. We want a quantity we cannot estimate directly. Bayes’ rule trades it for quantities we might be able to estimate. That exchange is the whole idea.</a:t>
             </a:r>
           </a:p>
           <a:p>
@@ -2470,7 +2470,7 @@
             </a:pPr>
             <a:r>
               <a:rPr/>
-              <a:t>Point out that this is the curse again, arriving from a completely different direction - density estimation rather than distance. Handout section 4.1.</a:t>
+              <a:t>Point out that this is the curse of dimensionality again, from a different direction: an hour ago it broke distances, here it breaks the estimation of a density. Handout section 4.1.</a:t>
             </a:r>
           </a:p>
         </p:txBody>
@@ -2676,7 +2676,7 @@
             </a:pPr>
             <a:r>
               <a:rPr/>
-              <a:t>Expect someone to object that the number is then no longer a probability. The instinct is sound - a term has been thrown away - and the answer is that it is recoverable. The denominator is the sum of the numerators over the classes, so dividing each score by the sum of the scores gives the probability back exactly. That is what predict_proba does, in logarithms. Dropping it costs nothing in calibration; where Naive Bayes does lose calibration is inside the numerator, and we will see that in a few slides.</a:t>
+              <a:t>Expect someone to object that the number is then no longer a probability. The instinct is sound - a term has been thrown away - and the answer is that it is recoverable. The denominator is the sum of the numerators over the classes, so dividing each score by the sum of the scores gives the probability back exactly. That is what predict_proba does, in logarithms. Dropping it does not make the probabilities less reliable. Where Naive Bayes’s probabilities do go wrong is inside the numerator, because of the assumption, and we will see that in a few slides.</a:t>
             </a:r>
           </a:p>
           <a:p>
@@ -2814,7 +2814,7 @@
             </a:pPr>
             <a:r>
               <a:rPr/>
-              <a:t>Mention that in practice this is computed as a sum of logarithms, for the same underflow reason as lesson 4’s log-likelihood: a product of several hundred small probabilities is exactly zero in floating point. Handout section 4.2 has the log form.</a:t>
+              <a:t>Mention that in practice this is computed as a sum of logarithms, for the same reason lesson 4 used the log-likelihood: a product of several hundred small probabilities is too small for the computer to store, and becomes exactly zero (this is called underflow). Handout section 4.2 has the log form.</a:t>
             </a:r>
           </a:p>
         </p:txBody>
@@ -2910,7 +2910,7 @@
             </a:pPr>
             <a:r>
               <a:rPr/>
-              <a:t>Why that matters is a counting argument, and it is worth making concrete. To estimate the left-hand side directly you would need enough pumps to fill an n-dimensional space - the curse of dimensionality from an hour ago, arriving in a new disguise. To estimate the right-hand side you need enough pumps to fit n separate histograms, which is a completely different demand.</a:t>
+              <a:t>Why that matters is a counting argument, and it is worth making concrete. To estimate the left-hand side directly you would need enough pumps to fill an n-dimensional space - the curse of dimensionality from an hour ago, in a new form. To estimate the right-hand side you need enough pumps to fit n separate histograms, which is a completely different demand.</a:t>
             </a:r>
           </a:p>
           <a:p>
@@ -3158,7 +3158,7 @@
             </a:pPr>
             <a:r>
               <a:rPr/>
-              <a:t>If someone spots in the handout that one log-density is positive, that is the moment to say a density is not a probability: a bell with a standard deviation of 0.219 bar peaks at about 1.82. Handout section 4.2 works the pump through term by term.</a:t>
+              <a:t>If someone spots in the handout that one log-density is positive, that is the moment to say a density is not a probability: it is a probability per unit of pressure, and a bell with a standard deviation of 0.219 bar has to peak at about 1.82 for its total area to be 1. Handout section 4.2 works the pump through term by term.</a:t>
             </a:r>
           </a:p>
         </p:txBody>
@@ -3268,7 +3268,7 @@
             </a:pPr>
             <a:r>
               <a:rPr/>
-              <a:t>The 4% flipped labels are lesson 5’s noise floor arriving in a classification problem. No model here can exceed roughly </a:t>
+              <a:t>The 4% flipped labels play the part of lesson 5’s irreducible noise: a model that learned the true rule perfectly would still get those pumps wrong. So no model here can exceed roughly </a:t>
             </a:r>
             <a:r>
               <a:rPr b="1"/>
@@ -3496,7 +3496,7 @@
             </a:pPr>
             <a:r>
               <a:rPr/>
-              <a:t>Inside the bracket on the left is the classifier as slides 26 and 28 built it: prior times one density per reading, the class with the largest product winning. The equation says its log is a sum, and the title says why that is allowed: ln is increasing, so the class with the largest product is also the class with the largest log. The logs are natural logs - base e - which matters two slides on, when we undo them with e. Say why nobody computes the left-hand side directly. With hundreds of features the product is hundreds of small numbers multiplied together, and it underflows to exactly zero in floating point - 0.5 to the power 300 is already 5 times 10 to the minus 91, and real likelihoods are far smaller than 0.5. Every class then scores zero and nothing can be compared.</a:t>
+              <a:t>Inside the bracket on the left is the classifier as slides 26 and 28 built it: prior times one density per reading, the class with the largest product winning. The equation says its log is a sum, and the title says why that is allowed: ln is increasing, so the class with the largest product is also the class with the largest log. The logs are natural logs - base e - which matters two slides later, when we undo them with e. Say why nobody computes the left-hand side directly. With hundreds of features the product is hundreds of small numbers multiplied together, and it becomes too small to store, exactly zero in floating point (underflow) - 0.5 to the power 300 is already 5 times 10 to the minus 91, and real likelihoods are far smaller than 0.5. Every class then scores zero and nothing can be compared.</a:t>
             </a:r>
           </a:p>
           <a:p>
@@ -3606,7 +3606,7 @@
             </a:pPr>
             <a:r>
               <a:rPr/>
-              <a:t>This is inference, and it is worth saying how little it is. Read each class as two rows. The value row is the product form: the prior from slide 30, and the height of that class’s bell at each reading - the dots on slide 31 - each density conditional on the class. Multiply across and you get the score. The ln row is the same numbers logged, and the sum across is the log score. The last column is the point of the previous slide: e^(−8.095) is 0.000305, so the sum of logs and the product carry the same information. Compare the totals: that is the prediction. No training row is consulted - only the ten stored numbers - which is the exact opposite of k-NN, where prediction is the whole cost.</a:t>
+              <a:t>This table is the whole of prediction (inference), and it is worth saying how little computation it needs. Read each class as two rows. The value row is the product form: the prior from slide 30, and the height of that class’s bell at each reading - the dots on slide 31 - each density conditional on the class. Multiply across and you get the score. The ln row is the same numbers logged, and the sum across is the log score. The last column is the point of the previous slide: e^(−8.095) is 0.000305, so the sum of logs and the product carry the same information. Compare the totals: that is the prediction. No training row is consulted - only the ten stored numbers - which is the exact opposite of k-NN, where prediction is the whole cost.</a:t>
             </a:r>
           </a:p>
           <a:p>
@@ -3882,7 +3882,7 @@
             </a:pPr>
             <a:r>
               <a:rPr/>
-              <a:t>Then the reading that makes it obvious. The gap is the log-odds: e^3.951 is about 52, so faulty is 52 times as likely as healthy. Odds of 52 to 1 split the probability 52/53 = 0.981 and 1/53 = 0.019, the way anyone would for a bet. 1 / (1 + e^(−Δ)) is lesson 4’s sigmoid - odds over odds plus one, rewritten. Handout section 4.2, “From log scores to a probability”.</a:t>
+              <a:t>Then the reading that makes it intuitive. The gap is the log-odds, the logarithm of how many times more likely faulty is than healthy: e^3.951 is about 52, so faulty is 52 times as likely as healthy. Odds of 52 to 1 split the probability 52/53 = 0.981 and 1/53 = 0.019, the way anyone would for a bet. 1 / (1 + e^(−Δ)) is lesson 4’s sigmoid - odds over odds plus one, rewritten. Handout section 4.2, “From log scores to a probability”.</a:t>
             </a:r>
           </a:p>
         </p:txBody>
@@ -4006,7 +4006,7 @@
             </a:pPr>
             <a:r>
               <a:rPr/>
-              <a:t>Then the framing that makes the rest of this segment worth doing, and put it as a question to the room: given that the assumption is essentially always false, why does anybody use this? The answer is that the assumption being false and the CLASSIFIER being wrong are different things. Argmax only needs the ordering right, not the probabilities. Handout section 4.2 closes on exactly this.</a:t>
+              <a:t>Then the framing that makes the rest of this segment worth doing, and put it as a question to the room: given that the assumption is essentially always false, why does anybody use this? The answer is that the assumption being false and the CLASSIFIER being wrong are different things. To choose a class, the model only needs the right class to get the highest score, not the probabilities to be right. Handout section 4.2 closes on exactly this.</a:t>
             </a:r>
           </a:p>
         </p:txBody>
@@ -4240,35 +4240,35 @@
             </a:pPr>
             <a:r>
               <a:rPr/>
-              <a:t>Then the trap. Correlation only sees straight-line dependence. Healthy pumps fill a disc and faulty ones a ring; on a ring, a pump far out in vibration must be central in pressure. That dependence is symmetric, so the straight-line summary averages it to zero. Square each reading’s distance from the design point and it appears: −0.420 among the faulty pumps. Or say it as a spread: the pressure of a faulty pump has a standard deviation of 0.784 when its vibration is extreme (the fifth furthest out, beyond 6.2 Hz from the centre) and 1.309 when it is not - 0.37 against 0.62 bar, same average, very different spread. Put the distinction on the board in two lines: uncorrelated, yes; independent, no. Naive Bayes assumes the second. The assumption is false.</a:t>
-            </a:r>
-          </a:p>
-          <a:p>
-            <a:pPr lvl="0" indent="0" marL="0">
-              <a:buNone/>
-            </a:pPr>
-          </a:p>
-          <a:p>
-            <a:pPr lvl="0" indent="0" marL="0">
-              <a:buNone/>
-            </a:pPr>
-            <a:r>
-              <a:rPr/>
-              <a:t>Someone will then ask why we used it at all. Answer it directly: nobody checks the assumption before fitting. It is a simplification bought for ten numbers, and the model is judged, like any other, by its validation score. That score asks for less than the assumption does: to classify, the right class has only to come out on top - the sign of the log-score gap - not the densities to be right. Naive Bayes can be optimal in that sense with independence badly violated (Domingos and Pazzani, 1997).</a:t>
-            </a:r>
-          </a:p>
-          <a:p>
-            <a:pPr lvl="0" indent="0" marL="0">
-              <a:buNone/>
-            </a:pPr>
-          </a:p>
-          <a:p>
-            <a:pPr lvl="0" indent="0" marL="0">
-              <a:buNone/>
-            </a:pPr>
-            <a:r>
-              <a:rPr/>
-              <a:t>So why 0.933? Because the densities are wrong but the boundary they imply is right. With both classes centred on the same point, comparing a narrow bell with a wide one gives an axis-aligned ellipse, and the true envelope is an axis-aligned ellipse. The fitted model’s edge sits at about 3.17 Hz by 0.41 bar against a true 3.5 by 0.45 - the same shape, a tenth small. A false assumption is cheap when it leaves the boundary the right shape. The next slide is the case where it does not. Handout section 4.3.</a:t>
+              <a:t>Then show why that conclusion is wrong. Correlation only sees straight-line dependence. Healthy pumps fill a disc and faulty ones a ring; on a ring, a pump far out in vibration must be central in pressure. That dependence is symmetric, so the straight-line summary averages it to zero. Square each reading’s distance from the design point and it appears: −0.420 among the faulty pumps. Or say it as a spread: the pressure of a faulty pump has a standard deviation of 0.784 when its vibration is extreme (the fifth furthest out, beyond 6.2 Hz from the centre) and 1.309 when it is not - 0.37 against 0.62 bar, same average, very different spread. Put the distinction on the board in two lines: uncorrelated, yes; independent, no. Naive Bayes assumes the second. The assumption is false.</a:t>
+            </a:r>
+          </a:p>
+          <a:p>
+            <a:pPr lvl="0" indent="0" marL="0">
+              <a:buNone/>
+            </a:pPr>
+          </a:p>
+          <a:p>
+            <a:pPr lvl="0" indent="0" marL="0">
+              <a:buNone/>
+            </a:pPr>
+            <a:r>
+              <a:rPr/>
+              <a:t>Someone will then ask why we used it at all. Answer it directly: nobody checks the assumption before fitting. It is a simplification accepted in exchange for a model of ten numbers, and the model is judged, like any other, by its validation score. That score asks for less than the assumption does. To classify correctly, the right class only has to get the higher score - the sign of the gap between the two log scores - and the densities do not have to be right. Naive Bayes can be optimal in that sense with independence badly violated (Domingos and Pazzani, 1997).</a:t>
+            </a:r>
+          </a:p>
+          <a:p>
+            <a:pPr lvl="0" indent="0" marL="0">
+              <a:buNone/>
+            </a:pPr>
+          </a:p>
+          <a:p>
+            <a:pPr lvl="0" indent="0" marL="0">
+              <a:buNone/>
+            </a:pPr>
+            <a:r>
+              <a:rPr/>
+              <a:t>So why 0.933? Because the densities are wrong but the boundary they imply is right. With both classes centred on the same point, comparing a narrow bell with a wide one gives an axis-aligned ellipse, and the true envelope is an axis-aligned ellipse. The fitted model’s edge sits at about 3.17 Hz by 0.41 bar against a true 3.5 by 0.45 - the same shape, about a tenth smaller. A false assumption is cheap when it leaves the boundary the right shape. The next slide is the case where it does not. Handout section 4.3.</a:t>
             </a:r>
           </a:p>
         </p:txBody>
@@ -4446,7 +4446,7 @@
             </a:pPr>
             <a:r>
               <a:rPr/>
-              <a:t>Change one thing about the problem and watch the method fall apart. Describe the physics before the geometry, because the rule is completely reasonable engineering.</a:t>
+              <a:t>Change one thing about the problem and watch the method fail. Describe the physics before the geometry, because the rule is completely reasonable engineering.</a:t>
             </a:r>
           </a:p>
           <a:p>
@@ -4584,35 +4584,35 @@
             </a:pPr>
             <a:r>
               <a:rPr/>
-              <a:t>The healthy pumps form a disc around the design point; the faulty ones form the annulus around them. There is no line. Not a badly chosen line - no line at all, because the class you want to isolate is completely surrounded.</a:t>
-            </a:r>
-          </a:p>
-          <a:p>
-            <a:pPr lvl="0" indent="0" marL="0">
-              <a:buNone/>
-            </a:pPr>
-          </a:p>
-          <a:p>
-            <a:pPr lvl="0" indent="0" marL="0">
-              <a:buNone/>
-            </a:pPr>
-            <a:r>
-              <a:rPr/>
-              <a:t>Worth naming what is unusual here, since most textbook pictures are blobs side by side: the geometry comes from the physics, not from an attempt to be awkward. Any “within tolerance versus out of tolerance” problem has this shape, and that covers a large fraction of industrial classification.</a:t>
-            </a:r>
-          </a:p>
-          <a:p>
-            <a:pPr lvl="0" indent="0" marL="0">
-              <a:buNone/>
-            </a:pPr>
-          </a:p>
-          <a:p>
-            <a:pPr lvl="0" indent="0" marL="0">
-              <a:buNone/>
-            </a:pPr>
-            <a:r>
-              <a:rPr/>
-              <a:t>The scattered wrong-coloured points inside each region are the 4% flipped labels. Point at two of them now - they come back at k = 1.</a:t>
+              <a:t>The healthy pumps form a disc around the design point; the faulty ones form a ring around them. There is no line. Not a badly chosen line - no line at all, because the class you want to isolate is completely surrounded.</a:t>
+            </a:r>
+          </a:p>
+          <a:p>
+            <a:pPr lvl="0" indent="0" marL="0">
+              <a:buNone/>
+            </a:pPr>
+          </a:p>
+          <a:p>
+            <a:pPr lvl="0" indent="0" marL="0">
+              <a:buNone/>
+            </a:pPr>
+            <a:r>
+              <a:rPr/>
+              <a:t>Worth naming what is unusual here, since most textbook pictures are blobs side by side: the shape comes from how pumps fail, not from a wish to make the problem hard. Any “within tolerance versus out of tolerance” problem has this shape, and that covers a large fraction of industrial classification.</a:t>
+            </a:r>
+          </a:p>
+          <a:p>
+            <a:pPr lvl="0" indent="0" marL="0">
+              <a:buNone/>
+            </a:pPr>
+          </a:p>
+          <a:p>
+            <a:pPr lvl="0" indent="0" marL="0">
+              <a:buNone/>
+            </a:pPr>
+            <a:r>
+              <a:rPr/>
+              <a:t>The scattered wrong-coloured points inside each region are the 4% flipped labels. Point at two of them now - they come back when k-NN uses a single neighbour, k = 1.</a:t>
             </a:r>
           </a:p>
         </p:txBody>
@@ -4888,21 +4888,21 @@
             </a:pPr>
             <a:r>
               <a:rPr/>
-              <a:t>The explanation is worth having in full. The class means on each sensor differ by about 0.17, against a spread near 1, purely as an artefact of a finite sample. That accident is the ONLY per-feature evidence available. Naive Bayes has nothing else to multiply, so it follows it - and in this sample it points the wrong way.</a:t>
-            </a:r>
-          </a:p>
-          <a:p>
-            <a:pPr lvl="0" indent="0" marL="0">
-              <a:buNone/>
-            </a:pPr>
-          </a:p>
-          <a:p>
-            <a:pPr lvl="0" indent="0" marL="0">
-              <a:buNone/>
-            </a:pPr>
-            <a:r>
-              <a:rPr/>
-              <a:t>The sentence to land: a model with no signal does not sit politely at 50%. It follows whatever spurious structure it can find, with complete confidence.</a:t>
+              <a:t>The explanation is worth having in full. The class means on each sensor differ by about 0.17, against a spread near 1, only by chance, because the sample is finite. That accident is the ONLY per-feature evidence available. Naive Bayes has nothing else to multiply, so it follows it - and in this sample it points the wrong way.</a:t>
+            </a:r>
+          </a:p>
+          <a:p>
+            <a:pPr lvl="0" indent="0" marL="0">
+              <a:buNone/>
+            </a:pPr>
+          </a:p>
+          <a:p>
+            <a:pPr lvl="0" indent="0" marL="0">
+              <a:buNone/>
+            </a:pPr>
+            <a:r>
+              <a:rPr/>
+              <a:t>The sentence to land: a model with no signal does not sit politely at 50%. It follows whatever accidental structure it can find in the sample. It is not even confident about it, which is the next slide.</a:t>
             </a:r>
           </a:p>
         </p:txBody>
@@ -5008,7 +5008,7 @@
             </a:pPr>
             <a:r>
               <a:rPr/>
-              <a:t>The more common complaint runs in the opposite direction, so give it too: when features carry the SAME evidence about the class - near-copies of one another - multiplying their probabilities counts it repeatedly. Be precise here, because they have just seen two kinds of dependence that are not this: the pumps’ ring and the XOR sensors. Ten correlated words in a document are treated as ten independent pieces of evidence, and the posterior saturates. Naive Bayes is famous for reporting 0.999 on problems it gets wrong a fifth of the time.</a:t>
+              <a:t>The more common complaint runs in the opposite direction, so give it too: when features carry the SAME evidence about the class - near-copies of one another - multiplying their probabilities counts it repeatedly. Be precise here, because they have just seen two kinds of dependence that are not this: the pumps’ ring and the XOR sensors. Ten correlated words in a document are treated as ten independent pieces of evidence, and the probability is pushed all the way to 0 or 1. Naive Bayes is famous for reporting 0.999 on problems it gets wrong a fifth of the time.</a:t>
             </a:r>
           </a:p>
           <a:p>
@@ -5118,21 +5118,21 @@
             </a:pPr>
             <a:r>
               <a:rPr/>
-              <a:t>Run notebooks/02. Sixteen minutes.</a:t>
-            </a:r>
-          </a:p>
-          <a:p>
-            <a:pPr lvl="0" indent="0" marL="0">
-              <a:buNone/>
-            </a:pPr>
-          </a:p>
-          <a:p>
-            <a:pPr lvl="0" indent="0" marL="0">
-              <a:buNone/>
-            </a:pPr>
-            <a:r>
-              <a:rPr/>
-              <a:t>The cell to protect is the one that prints 0.404 next to the 0.523 baseline. Let them see a below-chance score appear from correct code on solvable data before any explanation arrives.</a:t>
+              <a:t>Where breaking the assumption is cheap, and one step away where it is fatal. Run notebook 02. Sixteen minutes.</a:t>
+            </a:r>
+          </a:p>
+          <a:p>
+            <a:pPr lvl="0" indent="0" marL="0">
+              <a:buNone/>
+            </a:pPr>
+          </a:p>
+          <a:p>
+            <a:pPr lvl="0" indent="0" marL="0">
+              <a:buNone/>
+            </a:pPr>
+            <a:r>
+              <a:rPr/>
+              <a:t>If time runs short, keep the cell that prints 0.404 next to the 0.523 baseline. Let them see a below-chance score appear from correct code on solvable data before any explanation arrives.</a:t>
             </a:r>
           </a:p>
           <a:p>
@@ -5270,7 +5270,7 @@
             </a:pPr>
             <a:r>
               <a:rPr/>
-              <a:t>The intuition, and this is the sentence to say slowly: maximising the distance to the closest points chooses the boundary that tolerates the most movement in the data before it changes its mind. That is a statement about GENERALISATION, not about fit - which is unusual, because almost everything else in this course optimises fit and controls generalisation indirectly.</a:t>
+              <a:t>The intuition, and this is the sentence to say slowly: maximising the distance to the closest points chooses the boundary that tolerates the most movement in the data before it changes its mind. That is a statement about GENERALISATION, not about fit - which is unusual, because almost everything else in this course fits the training data as well as possible and protects generalisation only indirectly, through a penalty or a validation score.</a:t>
             </a:r>
           </a:p>
           <a:p>
@@ -5490,7 +5490,7 @@
             </a:pPr>
             <a:r>
               <a:rPr/>
-              <a:t>The point worth stressing is why the soft margin is not a patch or a convenience. With even one mislabelled point inside the other class, the strict problem is INFEASIBLE - there is no solution, not a bad one. Real data always contains such points. So the soft margin is the only version anyone ever runs; the hard-margin problem is a teaching device.</a:t>
+              <a:t>The point worth stressing is why the soft margin is not a patch or a convenience. With even one mislabelled point inside the other class, the strict problem is INFEASIBLE - there is no solution, not a bad one. Real data always contains such points. So the soft margin is the only version anyone ever runs; the strict (hard-margin) version is only a teaching device.</a:t>
             </a:r>
           </a:p>
           <a:p>
@@ -5724,7 +5724,7 @@
             </a:pPr>
             <a:r>
               <a:rPr/>
-              <a:t>The constraint is not on the slide any more - it made the line wide enough to land at 28pt - so state it: subject to y_i(w’x_i + b) &gt;= 1 - xi_i, every point on the right side of the slab by a margin, or paying xi_i for the shortfall. Handout section 5.2 writes it out.</a:t>
+              <a:t>The constraint is not on the slide - with it the line became too wide to read - so state it: subject to y_i(w’x_i + b) &gt;= 1 - xi_i, every point on the right side of the slab by a margin, or paying xi_i for the shortfall. Handout section 5.2 writes it out.</a:t>
             </a:r>
           </a:p>
           <a:p>
@@ -5899,6 +5899,20 @@
               <a:t>Ask them which way they would expect C to run before you tell them. Most guess wrong, and having guessed wrong once is what makes it stick.</a:t>
             </a:r>
           </a:p>
+          <a:p>
+            <a:pPr lvl="0" indent="0" marL="0">
+              <a:buNone/>
+            </a:pPr>
+          </a:p>
+          <a:p>
+            <a:pPr lvl="0" indent="0" marL="0">
+              <a:buNone/>
+            </a:pPr>
+            <a:r>
+              <a:rPr/>
+              <a:t>Be precise about what a large C does to the boundary. With a linear kernel the boundary and the two edges of the slab stay three parallel straight lines: a larger C can only make the slab narrower, or shift and rotate it, to classify more training points. It never bends it. With the RBF kernel the boundary can also bend around individual points, and slide 64 shows how far that goes when C and gamma are both large.</a:t>
+            </a:r>
+          </a:p>
         </p:txBody>
       </p:sp>
       <p:sp>
@@ -6006,7 +6020,7 @@
             </a:pPr>
             <a:r>
               <a:rPr/>
-              <a:t>Then point at the standard deviation, which is the real tell: </a:t>
+              <a:t>Then point at the standard deviation, which is the clearest sign: </a:t>
             </a:r>
             <a:r>
               <a:rPr b="1"/>
@@ -6028,7 +6042,7 @@
             </a:pPr>
             <a:r>
               <a:rPr/>
-              <a:t>Connect back to lesson 5’s habit: quote the baseline first, always. Without the 0.613 in the row above, 0.613 looks like a mediocre result rather than an absent one.</a:t>
+              <a:t>Connect back to lesson 5’s habit: quote the baseline first, always. Without the 0.613 in the row above, the model’s 0.613 would look like a mediocre result rather than what it is: no learning at all.</a:t>
             </a:r>
           </a:p>
         </p:txBody>
@@ -6138,21 +6152,21 @@
             </a:pPr>
             <a:r>
               <a:rPr/>
-              <a:t>Then the RBF row, which is the same algorithm with one argument changed, at 0.947 - the best number in the whole lesson, and within a hair of the 0.96 ceiling.</a:t>
-            </a:r>
-          </a:p>
-          <a:p>
-            <a:pPr lvl="0" indent="0" marL="0">
-              <a:buNone/>
-            </a:pPr>
-          </a:p>
-          <a:p>
-            <a:pPr lvl="0" indent="0" marL="0">
-              <a:buNone/>
-            </a:pPr>
-            <a:r>
-              <a:rPr/>
-              <a:t>The support-vector column says the same thing in a second language, and that is the next slide.</a:t>
+              <a:t>Then the RBF row, which is the same algorithm with one argument changed, at 0.947 - the best number in the whole lesson, and close to the 0.96 ceiling.</a:t>
+            </a:r>
+          </a:p>
+          <a:p>
+            <a:pPr lvl="0" indent="0" marL="0">
+              <a:buNone/>
+            </a:pPr>
+          </a:p>
+          <a:p>
+            <a:pPr lvl="0" indent="0" marL="0">
+              <a:buNone/>
+            </a:pPr>
+            <a:r>
+              <a:rPr/>
+              <a:t>The support-vector column says the same thing in a different way, and that is the next slide.</a:t>
             </a:r>
           </a:p>
         </p:txBody>
@@ -6272,7 +6286,7 @@
             </a:r>
             <a:r>
               <a:rPr/>
-              <a:t> over the number of training rows. High means the model is struggling to find room, which usually means the kernel is wrong for the geometry. It is a warning available BEFORE you cross-validate anything.</a:t>
+              <a:t> over the number of training rows. High means the model is struggling to find room, which usually means the kernel cannot draw the shape the classes need. It is a warning available BEFORE you cross-validate anything.</a:t>
             </a:r>
           </a:p>
           <a:p>
@@ -6602,7 +6616,7 @@
             </a:pPr>
             <a:r>
               <a:rPr/>
-              <a:t>The trick in one sentence: the SVM never needs the coordinates, only the angles and lengths between points, and those can be obtained without ever going there.</a:t>
+              <a:t>The trick in one sentence: the SVM never needs the coordinates, only the inner products between points, which carry their lengths and the angles between them, and those can be obtained without ever going there.</a:t>
             </a:r>
           </a:p>
           <a:p>
@@ -7116,7 +7130,7 @@
             </a:pPr>
             <a:r>
               <a:rPr/>
-              <a:t>Name the distinction the previous slide left open. The objective being solved here only ever evaluates K(x_i, x_j) between pairs of training pumps - the kernel matrix, m by m. The new pump, the one this model will eventually classify, appears nowhere in training. K(x_i, x), with a free x, is the prediction formula two slides on: same function, but its second argument is now the pump being classified rather than another training point.</a:t>
+              <a:t>Make explicit a distinction the earlier slides left open. The objective being solved here only ever evaluates K(x_i, x_j) between pairs of training pumps - the kernel matrix, m by m. The new pump, the one this model will eventually classify, appears nowhere in training. K(x_i, x), with x standing for any pump, is the prediction formula on the next slide: same function, but its second argument is now the pump being classified rather than another training point.</a:t>
             </a:r>
           </a:p>
           <a:p>
@@ -7350,21 +7364,21 @@
             </a:pPr>
             <a:r>
               <a:rPr/>
-              <a:t>Ask the room what could possibly go wrong with a method that makes no assumptions. The answer is the next fifteen minutes: making no assumptions means having no way to ignore anything, and that turns out to be expensive.</a:t>
-            </a:r>
-          </a:p>
-          <a:p>
-            <a:pPr lvl="0" indent="0" marL="0">
-              <a:buNone/>
-            </a:pPr>
-          </a:p>
-          <a:p>
-            <a:pPr lvl="0" indent="0" marL="0">
-              <a:buNone/>
-            </a:pPr>
-            <a:r>
-              <a:rPr/>
-              <a:t>Two decisions hide inside that sentence - what “closest” means, and what k is - and both are consequential. Take them in that order.</a:t>
+              <a:t>Ask the room what could possibly go wrong with a method that makes no assumptions. The next fifteen minutes answer it: a method with no assumptions has no way to ignore a useless column, and that turns out to be expensive.</a:t>
+            </a:r>
+          </a:p>
+          <a:p>
+            <a:pPr lvl="0" indent="0" marL="0">
+              <a:buNone/>
+            </a:pPr>
+          </a:p>
+          <a:p>
+            <a:pPr lvl="0" indent="0" marL="0">
+              <a:buNone/>
+            </a:pPr>
+            <a:r>
+              <a:rPr/>
+              <a:t>The sentence hides two decisions - what “closest” means, and how many neighbours k to use - and both change the result. Take them in that order.</a:t>
             </a:r>
           </a:p>
           <a:p>
@@ -7808,21 +7822,21 @@
             </a:pPr>
             <a:r>
               <a:rPr/>
-              <a:t>Right is the one to sit on. The boundary has broken into bubbles - small islands around individual points, including the mislabelled ones. That is what a 0.995 training score looks like from the outside: the model has drawn a private territory around each flipped label so that it can get it right.</a:t>
-            </a:r>
-          </a:p>
-          <a:p>
-            <a:pPr lvl="0" indent="0" marL="0">
-              <a:buNone/>
-            </a:pPr>
-          </a:p>
-          <a:p>
-            <a:pPr lvl="0" indent="0" marL="0">
-              <a:buNone/>
-            </a:pPr>
-            <a:r>
-              <a:rPr/>
-              <a:t>Ask them what happens to a new pump landing in the gap between two bubbles. That is the 0.902.</a:t>
+              <a:t>Spend time on the right panel. The boundary has broken into bubbles - small islands around individual points, including the mislabelled ones. That is what a 0.995 training score looks like from the outside: the model has drawn a private territory around each flipped label so that it can get it right.</a:t>
+            </a:r>
+          </a:p>
+          <a:p>
+            <a:pPr lvl="0" indent="0" marL="0">
+              <a:buNone/>
+            </a:pPr>
+          </a:p>
+          <a:p>
+            <a:pPr lvl="0" indent="0" marL="0">
+              <a:buNone/>
+            </a:pPr>
+            <a:r>
+              <a:rPr/>
+              <a:t>Ask them what happens to a new pump landing in the gap between two bubbles: it is judged by whichever stray point happens to be nearest, and that is where the 0.902 comes from.</a:t>
             </a:r>
           </a:p>
           <a:p>
@@ -7918,35 +7932,35 @@
             </a:pPr>
             <a:r>
               <a:rPr/>
-              <a:t>Run notebooks/03. Sixteen minutes.</a:t>
-            </a:r>
-          </a:p>
-          <a:p>
-            <a:pPr lvl="0" indent="0" marL="0">
-              <a:buNone/>
-            </a:pPr>
-          </a:p>
-          <a:p>
-            <a:pPr lvl="0" indent="0" marL="0">
-              <a:buNone/>
-            </a:pPr>
-            <a:r>
-              <a:rPr/>
-              <a:t>The cell to protect is the γ sweep with the boundary drawn at each setting. Let them turn γ up themselves and watch the bubbles form - it is the most direct experience of overfitting available in this course.</a:t>
-            </a:r>
-          </a:p>
-          <a:p>
-            <a:pPr lvl="0" indent="0" marL="0">
-              <a:buNone/>
-            </a:pPr>
-          </a:p>
-          <a:p>
-            <a:pPr lvl="0" indent="0" marL="0">
-              <a:buNone/>
-            </a:pPr>
-            <a:r>
-              <a:rPr/>
-              <a:t>Have them print the support-vector fraction for the linear and RBF kernels side by side. Two numbers, and it makes the diagnostic real rather than a claim on a slide.</a:t>
+              <a:t>Margins, support vectors, and what γ does to the boundary. Run notebook 03. Sixteen minutes.</a:t>
+            </a:r>
+          </a:p>
+          <a:p>
+            <a:pPr lvl="0" indent="0" marL="0">
+              <a:buNone/>
+            </a:pPr>
+          </a:p>
+          <a:p>
+            <a:pPr lvl="0" indent="0" marL="0">
+              <a:buNone/>
+            </a:pPr>
+            <a:r>
+              <a:rPr/>
+              <a:t>If time runs short, keep the γ sweep with the boundary drawn at each setting. Let them turn γ up themselves and watch the bubbles form - it is the most direct experience of overfitting available in this course.</a:t>
+            </a:r>
+          </a:p>
+          <a:p>
+            <a:pPr lvl="0" indent="0" marL="0">
+              <a:buNone/>
+            </a:pPr>
+          </a:p>
+          <a:p>
+            <a:pPr lvl="0" indent="0" marL="0">
+              <a:buNone/>
+            </a:pPr>
+            <a:r>
+              <a:rPr/>
+              <a:t>Have them print the fraction of support vectors for the linear and RBF kernels side by side. Two numbers, and it makes the diagnostic real rather than a claim on a slide.</a:t>
             </a:r>
           </a:p>
           <a:p>
@@ -8422,21 +8436,21 @@
             </a:pPr>
             <a:r>
               <a:rPr/>
-              <a:t>The marks are for the reasoning, not for the accuracy. A well-argued choice that scores slightly worse beats a lucky winner with no justification - and the argument has to reference the data, in the way that the squared distances and the fitted ellipse explained Naive Bayes on the pumps this afternoon.</a:t>
-            </a:r>
-          </a:p>
-          <a:p>
-            <a:pPr lvl="0" indent="0" marL="0">
-              <a:buNone/>
-            </a:pPr>
-          </a:p>
-          <a:p>
-            <a:pPr lvl="0" indent="0" marL="0">
-              <a:buNone/>
-            </a:pPr>
-            <a:r>
-              <a:rPr/>
-              <a:t>Remind them that everything must be cross-validated and reported with a spread, in the format lesson 5 set. Scaling goes inside the pipeline; that will be checked.</a:t>
+              <a:t>If this exercise is drawn at the exam, what counts is the reasoning, not the accuracy. A well-argued choice that scores slightly worse beats a lucky winner with no justification - and the argument has to reference the data, in the way that the squared distances and the fitted ellipse explained Naive Bayes on the pumps this afternoon.</a:t>
+            </a:r>
+          </a:p>
+          <a:p>
+            <a:pPr lvl="0" indent="0" marL="0">
+              <a:buNone/>
+            </a:pPr>
+          </a:p>
+          <a:p>
+            <a:pPr lvl="0" indent="0" marL="0">
+              <a:buNone/>
+            </a:pPr>
+            <a:r>
+              <a:rPr/>
+              <a:t>Remind them that everything must be cross-validated and reported with a spread, in the format lesson 5 set. Scaling goes inside the pipeline; at the exam that is one of the first things looked at.</a:t>
             </a:r>
           </a:p>
           <a:p>
@@ -8546,7 +8560,7 @@
             </a:pPr>
             <a:r>
               <a:rPr/>
-              <a:t>The observation that matters: every feature contributes to that sum through its own units. There is nothing in the expression that knows Hz from bar. The method has no other channel through which the data reaches it - no coefficients, no weights, no notion that one column might matter more than another.</a:t>
+              <a:t>The observation that matters: every feature contributes to that sum through its own units. There is nothing in the expression that knows Hz from bar. Distance is the only way the data reaches the method: there are no coefficients, no weights, nothing that could say one column matters more than another.</a:t>
             </a:r>
           </a:p>
           <a:p>
@@ -8656,7 +8670,7 @@
             </a:pPr>
             <a:r>
               <a:rPr/>
-              <a:t>This is where lesson 2 stops being hygiene and starts being the difference between a working model and a broken one.</a:t>
+              <a:t>In lesson 2 scaling looked like good housekeeping; here it is the difference between a working model and a broken one.</a:t>
             </a:r>
           </a:p>
           <a:p>
@@ -8684,21 +8698,21 @@
             </a:pPr>
             <a:r>
               <a:rPr/>
-              <a:t>The consequence: without standardisation, vibration picks every neighbour by itself and pressure is decorative. Change the pressure sensor to millibar and the model’s answers change. That should feel unacceptable, and it is.</a:t>
-            </a:r>
-          </a:p>
-          <a:p>
-            <a:pPr lvl="0" indent="0" marL="0">
-              <a:buNone/>
-            </a:pPr>
-          </a:p>
-          <a:p>
-            <a:pPr lvl="0" indent="0" marL="0">
-              <a:buNone/>
-            </a:pPr>
-            <a:r>
-              <a:rPr/>
-              <a:t>Practical instruction: k-NN goes in a Pipeline with StandardScaler, always, and the scaler is fitted inside the fold - which is last week’s lesson, not a new one.</a:t>
+              <a:t>The consequence: without standardisation, vibration alone decides which pumps are neighbours, and pressure has almost no effect. Change the pressure sensor to millibar and the model’s answers change. That should feel unacceptable, and it is.</a:t>
+            </a:r>
+          </a:p>
+          <a:p>
+            <a:pPr lvl="0" indent="0" marL="0">
+              <a:buNone/>
+            </a:pPr>
+          </a:p>
+          <a:p>
+            <a:pPr lvl="0" indent="0" marL="0">
+              <a:buNone/>
+            </a:pPr>
+            <a:r>
+              <a:rPr/>
+              <a:t>Practical instruction: k-NN goes in a Pipeline with StandardScaler, always, and the scaler is fitted on the training part of each fold only, as lesson 5 required.</a:t>
             </a:r>
           </a:p>
         </p:txBody>
@@ -8780,7 +8794,7 @@
             </a:pPr>
             <a:r>
               <a:rPr/>
-              <a:t>Lesson 5 decomposed error into bias and variance and had to build 300 parallel universes to show it. Here you watch the same trade-off by turning one integer, and that is why this slide is worth more time than its size suggests.</a:t>
+              <a:t>Lesson 5 split the error into bias and variance, and had to train the model on 300 different training sets to show it. Here you watch the same trade-off by turning one integer, and that is why this slide is worth more time than its size suggests.</a:t>
             </a:r>
           </a:p>
           <a:p>
@@ -8808,7 +8822,7 @@
             </a:pPr>
             <a:r>
               <a:rPr/>
-              <a:t>That is the purest illustration in the whole course of lesson 5’s point: a training score can be perfect and measure absolutely nothing. Not approximately nothing - nothing, by construction, independent of the data.</a:t>
+              <a:t>That is the purest illustration in the whole course of lesson 5’s point: a training score can be perfect and say nothing about how the model does on new data. Here the perfect score is guaranteed by how k = 1 works, whatever the data.</a:t>
             </a:r>
           </a:p>
           <a:p>
@@ -14047,34 +14061,272 @@
           </a:p>
         </p:txBody>
       </p:sp>
-      <p:sp>
-        <p:nvSpPr>
-          <p:cNvPr id="3" name="Content Placeholder 2"/>
-          <p:cNvSpPr>
-            <a:spLocks noGrp="1"/>
-          </p:cNvSpPr>
+      <p:graphicFrame>
+        <p:nvGraphicFramePr>
+          <p:cNvPr id="6" name="Content Placeholder 5"/>
+          <p:cNvGraphicFramePr>
+            <a:graphicFrameLocks noGrp="1"/>
+          </p:cNvGraphicFramePr>
           <p:nvPr>
             <p:ph idx="1"/>
           </p:nvPr>
-        </p:nvSpPr>
-        <p:spPr>
-          <a:xfrm>
-            <a:off x="457200" y="1200151"/>
-            <a:ext cx="8229600" cy="3394472"/>
-          </a:xfrm>
-        </p:spPr>
-        <p:txBody>
-          <a:bodyPr/>
-          <a:lstStyle/>
-          <a:p>
-            <a:pPr lvl="0"/>
-            <a:r>
-              <a:rPr/>
-              <a:t>k-NN on the pumps, choosing k, and the curse measured</a:t>
-            </a:r>
-          </a:p>
-        </p:txBody>
-      </p:sp>
+        </p:nvGraphicFramePr>
+        <p:xfrm>
+          <a:off x="457200" y="1166099"/>
+          <a:ext cx="8229600" cy="3390900"/>
+        </p:xfrm>
+        <a:graphic>
+          <a:graphicData uri="http://schemas.openxmlformats.org/drawingml/2006/table">
+            <a:tbl>
+              <a:tblPr firstRow="1" bandRow="1">
+                <a:tableStyleId>{5C22544A-7EE6-4342-B048-85BDC9FD1C3A}</a:tableStyleId>
+              </a:tblPr>
+              <a:tblGrid>
+                <a:gridCol w="4114800"/>
+                <a:gridCol w="4114800"/>
+              </a:tblGrid>
+              <a:tr h="0">
+                <a:tc>
+                  <a:txBody>
+                    <a:bodyPr/>
+                    <a:lstStyle/>
+                    <a:p>
+                      <a:pPr lvl="0" indent="0" marL="0">
+                        <a:buNone/>
+                      </a:pPr>
+                      <a:r>
+                        <a:rPr/>
+                        <a:t>section, and its slides</a:t>
+                      </a:r>
+                    </a:p>
+                  </a:txBody>
+                  <a:tcPr/>
+                </a:tc>
+                <a:tc>
+                  <a:txBody>
+                    <a:bodyPr/>
+                    <a:lstStyle/>
+                    <a:p>
+                      <a:pPr lvl="0" indent="0" marL="0">
+                        <a:buNone/>
+                      </a:pPr>
+                      <a:r>
+                        <a:rPr/>
+                        <a:t>you call (→ the number to come back with)</a:t>
+                      </a:r>
+                    </a:p>
+                  </a:txBody>
+                  <a:tcPr/>
+                </a:tc>
+              </a:tr>
+              <a:tr h="0">
+                <a:tc>
+                  <a:txBody>
+                    <a:bodyPr/>
+                    <a:lstStyle/>
+                    <a:p>
+                      <a:pPr lvl="0" indent="0" marL="0">
+                        <a:buNone/>
+                      </a:pPr>
+                      <a:r>
+                        <a:rPr/>
+                        <a:t>the straight line, 4-6</a:t>
+                      </a:r>
+                    </a:p>
+                  </a:txBody>
+                </a:tc>
+                <a:tc>
+                  <a:txBody>
+                    <a:bodyPr/>
+                    <a:lstStyle/>
+                    <a:p>
+                      <a:pPr lvl="0" indent="0" marL="0">
+                        <a:buNone/>
+                      </a:pPr>
+                      <a:r>
+                        <a:rPr>
+                          <a:latin typeface="Courier"/>
+                        </a:rPr>
+                        <a:t>LogisticRegression</a:t>
+                      </a:r>
+                      <a:r>
+                        <a:rPr/>
+                        <a:t> scored by </a:t>
+                      </a:r>
+                      <a:r>
+                        <a:rPr>
+                          <a:latin typeface="Courier"/>
+                        </a:rPr>
+                        <a:t>cross_val_score</a:t>
+                      </a:r>
+                      <a:r>
+                        <a:rPr/>
+                        <a:t> over </a:t>
+                      </a:r>
+                      <a:r>
+                        <a:rPr>
+                          <a:latin typeface="Courier"/>
+                        </a:rPr>
+                        <a:t>StratifiedKFold</a:t>
+                      </a:r>
+                      <a:r>
+                        <a:rPr/>
+                        <a:t> folds → 0.613</a:t>
+                      </a:r>
+                    </a:p>
+                  </a:txBody>
+                </a:tc>
+              </a:tr>
+              <a:tr h="0">
+                <a:tc>
+                  <a:txBody>
+                    <a:bodyPr/>
+                    <a:lstStyle/>
+                    <a:p>
+                      <a:pPr lvl="0" indent="0" marL="0">
+                        <a:buNone/>
+                      </a:pPr>
+                      <a:r>
+                        <a:rPr/>
+                        <a:t>k-NN, scaled first, 7-9</a:t>
+                      </a:r>
+                    </a:p>
+                  </a:txBody>
+                </a:tc>
+                <a:tc>
+                  <a:txBody>
+                    <a:bodyPr/>
+                    <a:lstStyle/>
+                    <a:p>
+                      <a:pPr lvl="0" indent="0" marL="0">
+                        <a:buNone/>
+                      </a:pPr>
+                      <a:r>
+                        <a:rPr>
+                          <a:latin typeface="Courier"/>
+                        </a:rPr>
+                        <a:t>make_pipeline(StandardScaler(), KNeighborsClassifier(k))</a:t>
+                      </a:r>
+                    </a:p>
+                  </a:txBody>
+                </a:tc>
+              </a:tr>
+              <a:tr h="0">
+                <a:tc>
+                  <a:txBody>
+                    <a:bodyPr/>
+                    <a:lstStyle/>
+                    <a:p>
+                      <a:pPr lvl="0" indent="0" marL="0">
+                        <a:buNone/>
+                      </a:pPr>
+                      <a:r>
+                        <a:rPr/>
+                        <a:t>choosing k, 10-13</a:t>
+                      </a:r>
+                    </a:p>
+                  </a:txBody>
+                </a:tc>
+                <a:tc>
+                  <a:txBody>
+                    <a:bodyPr/>
+                    <a:lstStyle/>
+                    <a:p>
+                      <a:pPr lvl="0" indent="0" marL="0">
+                        <a:buNone/>
+                      </a:pPr>
+                      <a:r>
+                        <a:rPr>
+                          <a:latin typeface="Courier"/>
+                        </a:rPr>
+                        <a:t>cross_val_score</a:t>
+                      </a:r>
+                      <a:r>
+                        <a:rPr/>
+                        <a:t> for each k → 0.944 at k = 5</a:t>
+                      </a:r>
+                    </a:p>
+                  </a:txBody>
+                </a:tc>
+              </a:tr>
+              <a:tr h="0">
+                <a:tc>
+                  <a:txBody>
+                    <a:bodyPr/>
+                    <a:lstStyle/>
+                    <a:p>
+                      <a:pPr lvl="0" indent="0" marL="0">
+                        <a:buNone/>
+                      </a:pPr>
+                      <a:r>
+                        <a:rPr/>
+                        <a:t>columns of noise, 15-16</a:t>
+                      </a:r>
+                    </a:p>
+                  </a:txBody>
+                </a:tc>
+                <a:tc>
+                  <a:txBody>
+                    <a:bodyPr/>
+                    <a:lstStyle/>
+                    <a:p>
+                      <a:pPr lvl="0" indent="0" marL="0">
+                        <a:buNone/>
+                      </a:pPr>
+                      <a:r>
+                        <a:rPr/>
+                        <a:t>the same pipeline on </a:t>
+                      </a:r>
+                      <a:r>
+                        <a:rPr>
+                          <a:latin typeface="Courier"/>
+                        </a:rPr>
+                        <a:t>load_with_noise(d)</a:t>
+                      </a:r>
+                      <a:r>
+                        <a:rPr/>
+                        <a:t> → 0.602 at 52 columns</a:t>
+                      </a:r>
+                    </a:p>
+                  </a:txBody>
+                </a:tc>
+              </a:tr>
+              <a:tr h="0">
+                <a:tc>
+                  <a:txBody>
+                    <a:bodyPr/>
+                    <a:lstStyle/>
+                    <a:p>
+                      <a:pPr lvl="0" indent="0" marL="0">
+                        <a:buNone/>
+                      </a:pPr>
+                      <a:r>
+                        <a:rPr/>
+                        <a:t>distances stop varying, 17-20</a:t>
+                      </a:r>
+                    </a:p>
+                  </a:txBody>
+                </a:tc>
+                <a:tc>
+                  <a:txBody>
+                    <a:bodyPr/>
+                    <a:lstStyle/>
+                    <a:p>
+                      <a:pPr lvl="0" indent="0" marL="0">
+                        <a:buNone/>
+                      </a:pPr>
+                      <a:r>
+                        <a:rPr/>
+                        <a:t>NumPy only: nearest ÷ farthest → 0.701 in 100 dimensions</a:t>
+                      </a:r>
+                    </a:p>
+                  </a:txBody>
+                </a:tc>
+              </a:tr>
+            </a:tbl>
+          </a:graphicData>
+        </a:graphic>
+      </p:graphicFrame>
     </p:spTree>
   </p:cSld>
 </p:sld>
@@ -14521,6 +14773,19 @@
               <a:t>Each factor is estimated from the rows of that class alone</a:t>
             </a:r>
           </a:p>
+          <a:p>
+            <a:pPr lvl="0"/>
+            <a:r>
+              <a:rPr/>
+              <a:t>In code: </a:t>
+            </a:r>
+            <a:r>
+              <a:rPr>
+                <a:latin typeface="Courier"/>
+              </a:rPr>
+              <a:t>GaussianNB()</a:t>
+            </a:r>
+          </a:p>
         </p:txBody>
       </p:sp>
     </p:spTree>
@@ -17708,34 +17973,322 @@
           </a:p>
         </p:txBody>
       </p:sp>
-      <p:sp>
-        <p:nvSpPr>
-          <p:cNvPr id="3" name="Content Placeholder 2"/>
-          <p:cNvSpPr>
-            <a:spLocks noGrp="1"/>
-          </p:cNvSpPr>
+      <p:graphicFrame>
+        <p:nvGraphicFramePr>
+          <p:cNvPr id="6" name="Content Placeholder 5"/>
+          <p:cNvGraphicFramePr>
+            <a:graphicFrameLocks noGrp="1"/>
+          </p:cNvGraphicFramePr>
           <p:nvPr>
             <p:ph idx="1"/>
           </p:nvPr>
-        </p:nvSpPr>
-        <p:spPr>
-          <a:xfrm>
-            <a:off x="457200" y="1200151"/>
-            <a:ext cx="8229600" cy="3394472"/>
-          </a:xfrm>
-        </p:spPr>
-        <p:txBody>
-          <a:bodyPr/>
-          <a:lstStyle/>
-          <a:p>
-            <a:pPr lvl="0"/>
-            <a:r>
-              <a:rPr/>
-              <a:t>Where breaking the assumption is cheap, and one step away where it is fatal</a:t>
-            </a:r>
-          </a:p>
-        </p:txBody>
-      </p:sp>
+        </p:nvGraphicFramePr>
+        <p:xfrm>
+          <a:off x="457200" y="1166099"/>
+          <a:ext cx="8229600" cy="3390900"/>
+        </p:xfrm>
+        <a:graphic>
+          <a:graphicData uri="http://schemas.openxmlformats.org/drawingml/2006/table">
+            <a:tbl>
+              <a:tblPr firstRow="1" bandRow="1">
+                <a:tableStyleId>{5C22544A-7EE6-4342-B048-85BDC9FD1C3A}</a:tableStyleId>
+              </a:tblPr>
+              <a:tblGrid>
+                <a:gridCol w="4114800"/>
+                <a:gridCol w="4114800"/>
+              </a:tblGrid>
+              <a:tr h="0">
+                <a:tc>
+                  <a:txBody>
+                    <a:bodyPr/>
+                    <a:lstStyle/>
+                    <a:p>
+                      <a:pPr lvl="0" indent="0" marL="0">
+                        <a:buNone/>
+                      </a:pPr>
+                      <a:r>
+                        <a:rPr/>
+                        <a:t>section, and its slides</a:t>
+                      </a:r>
+                    </a:p>
+                  </a:txBody>
+                  <a:tcPr/>
+                </a:tc>
+                <a:tc>
+                  <a:txBody>
+                    <a:bodyPr/>
+                    <a:lstStyle/>
+                    <a:p>
+                      <a:pPr lvl="0" indent="0" marL="0">
+                        <a:buNone/>
+                      </a:pPr>
+                      <a:r>
+                        <a:rPr/>
+                        <a:t>you call (→ the number to come back with)</a:t>
+                      </a:r>
+                    </a:p>
+                  </a:txBody>
+                  <a:tcPr/>
+                </a:tc>
+              </a:tr>
+              <a:tr h="0">
+                <a:tc>
+                  <a:txBody>
+                    <a:bodyPr/>
+                    <a:lstStyle/>
+                    <a:p>
+                      <a:pPr lvl="0" indent="0" marL="0">
+                        <a:buNone/>
+                      </a:pPr>
+                      <a:r>
+                        <a:rPr/>
+                        <a:t>on the pumps, 37</a:t>
+                      </a:r>
+                    </a:p>
+                  </a:txBody>
+                </a:tc>
+                <a:tc>
+                  <a:txBody>
+                    <a:bodyPr/>
+                    <a:lstStyle/>
+                    <a:p>
+                      <a:pPr lvl="0" indent="0" marL="0">
+                        <a:buNone/>
+                      </a:pPr>
+                      <a:r>
+                        <a:rPr>
+                          <a:latin typeface="Courier"/>
+                        </a:rPr>
+                        <a:t>GaussianNB</a:t>
+                      </a:r>
+                      <a:r>
+                        <a:rPr/>
+                        <a:t> beside </a:t>
+                      </a:r>
+                      <a:r>
+                        <a:rPr>
+                          <a:latin typeface="Courier"/>
+                        </a:rPr>
+                        <a:t>KNeighborsClassifier</a:t>
+                      </a:r>
+                      <a:r>
+                        <a:rPr/>
+                        <a:t> and </a:t>
+                      </a:r>
+                      <a:r>
+                        <a:rPr>
+                          <a:latin typeface="Courier"/>
+                        </a:rPr>
+                        <a:t>LogisticRegression</a:t>
+                      </a:r>
+                      <a:r>
+                        <a:rPr/>
+                        <a:t> → 0.933</a:t>
+                      </a:r>
+                    </a:p>
+                  </a:txBody>
+                </a:tc>
+              </a:tr>
+              <a:tr h="0">
+                <a:tc>
+                  <a:txBody>
+                    <a:bodyPr/>
+                    <a:lstStyle/>
+                    <a:p>
+                      <a:pPr lvl="0" indent="0" marL="0">
+                        <a:buNone/>
+                      </a:pPr>
+                      <a:r>
+                        <a:rPr/>
+                        <a:t>what training computed, 29-35</a:t>
+                      </a:r>
+                    </a:p>
+                  </a:txBody>
+                </a:tc>
+                <a:tc>
+                  <a:txBody>
+                    <a:bodyPr/>
+                    <a:lstStyle/>
+                    <a:p>
+                      <a:pPr lvl="0" indent="0" marL="0">
+                        <a:buNone/>
+                      </a:pPr>
+                      <a:r>
+                        <a:rPr>
+                          <a:latin typeface="Courier"/>
+                        </a:rPr>
+                        <a:t>.theta_</a:t>
+                      </a:r>
+                      <a:r>
+                        <a:rPr/>
+                        <a:t>, </a:t>
+                      </a:r>
+                      <a:r>
+                        <a:rPr>
+                          <a:latin typeface="Courier"/>
+                        </a:rPr>
+                        <a:t>.var_</a:t>
+                      </a:r>
+                      <a:r>
+                        <a:rPr/>
+                        <a:t>, </a:t>
+                      </a:r>
+                      <a:r>
+                        <a:rPr>
+                          <a:latin typeface="Courier"/>
+                        </a:rPr>
+                        <a:t>.class_prior_</a:t>
+                      </a:r>
+                      <a:r>
+                        <a:rPr/>
+                        <a:t>, </a:t>
+                      </a:r>
+                      <a:r>
+                        <a:rPr>
+                          <a:latin typeface="Courier"/>
+                        </a:rPr>
+                        <a:t>predict_proba</a:t>
+                      </a:r>
+                      <a:r>
+                        <a:rPr/>
+                        <a:t> → 0.981 at 48 Hz</a:t>
+                      </a:r>
+                    </a:p>
+                  </a:txBody>
+                </a:tc>
+              </a:tr>
+              <a:tr h="0">
+                <a:tc>
+                  <a:txBody>
+                    <a:bodyPr/>
+                    <a:lstStyle/>
+                    <a:p>
+                      <a:pPr lvl="0" indent="0" marL="0">
+                        <a:buNone/>
+                      </a:pPr>
+                      <a:r>
+                        <a:rPr/>
+                        <a:t>checking the assumption, 38-39</a:t>
+                      </a:r>
+                    </a:p>
+                  </a:txBody>
+                </a:tc>
+                <a:tc>
+                  <a:txBody>
+                    <a:bodyPr/>
+                    <a:lstStyle/>
+                    <a:p>
+                      <a:pPr lvl="0" indent="0" marL="0">
+                        <a:buNone/>
+                      </a:pPr>
+                      <a:r>
+                        <a:rPr>
+                          <a:latin typeface="Courier"/>
+                        </a:rPr>
+                        <a:t>X[y == c].corr()</a:t>
+                      </a:r>
+                      <a:r>
+                        <a:rPr/>
+                        <a:t>, within each class → −0.420</a:t>
+                      </a:r>
+                    </a:p>
+                  </a:txBody>
+                </a:tc>
+              </a:tr>
+              <a:tr h="0">
+                <a:tc>
+                  <a:txBody>
+                    <a:bodyPr/>
+                    <a:lstStyle/>
+                    <a:p>
+                      <a:pPr lvl="0" indent="0" marL="0">
+                        <a:buNone/>
+                      </a:pPr>
+                      <a:r>
+                        <a:rPr/>
+                        <a:t>the interacting sensors, 40-42</a:t>
+                      </a:r>
+                    </a:p>
+                  </a:txBody>
+                </a:tc>
+                <a:tc>
+                  <a:txBody>
+                    <a:bodyPr/>
+                    <a:lstStyle/>
+                    <a:p>
+                      <a:pPr lvl="0" indent="0" marL="0">
+                        <a:buNone/>
+                      </a:pPr>
+                      <a:r>
+                        <a:rPr/>
+                        <a:t>the same models, plus </a:t>
+                      </a:r>
+                      <a:r>
+                        <a:rPr>
+                          <a:latin typeface="Courier"/>
+                        </a:rPr>
+                        <a:t>SVC</a:t>
+                      </a:r>
+                      <a:r>
+                        <a:rPr/>
+                        <a:t> → 0.404</a:t>
+                      </a:r>
+                    </a:p>
+                  </a:txBody>
+                </a:tc>
+              </a:tr>
+              <a:tr h="0">
+                <a:tc>
+                  <a:txBody>
+                    <a:bodyPr/>
+                    <a:lstStyle/>
+                    <a:p>
+                      <a:pPr lvl="0" indent="0" marL="0">
+                        <a:buNone/>
+                      </a:pPr>
+                      <a:r>
+                        <a:rPr/>
+                        <a:t>confidence, right and wrong, 43</a:t>
+                      </a:r>
+                    </a:p>
+                  </a:txBody>
+                </a:tc>
+                <a:tc>
+                  <a:txBody>
+                    <a:bodyPr/>
+                    <a:lstStyle/>
+                    <a:p>
+                      <a:pPr lvl="0" indent="0" marL="0">
+                        <a:buNone/>
+                      </a:pPr>
+                      <a:r>
+                        <a:rPr>
+                          <a:latin typeface="Courier"/>
+                        </a:rPr>
+                        <a:t>train_test_split</a:t>
+                      </a:r>
+                      <a:r>
+                        <a:rPr/>
+                        <a:t>, then </a:t>
+                      </a:r>
+                      <a:r>
+                        <a:rPr>
+                          <a:latin typeface="Courier"/>
+                        </a:rPr>
+                        <a:t>predict_proba</a:t>
+                      </a:r>
+                      <a:r>
+                        <a:rPr/>
+                        <a:t> → 0.567 against 0.555</a:t>
+                      </a:r>
+                    </a:p>
+                  </a:txBody>
+                </a:tc>
+              </a:tr>
+            </a:tbl>
+          </a:graphicData>
+        </a:graphic>
+      </p:graphicFrame>
     </p:spTree>
   </p:cSld>
 </p:sld>
@@ -18377,7 +18930,7 @@
             </a:r>
             <a:r>
               <a:rPr/>
-              <a:t>: violations are expensive, so the model contorts to classify everything. Narrow margin, low bias, high variance</a:t>
+              <a:t>: violations are expensive, so the model accepts a narrower margin to classify more training points. Low bias, high variance</a:t>
             </a:r>
           </a:p>
           <a:p>
@@ -18395,7 +18948,7 @@
             <a:pPr lvl="0"/>
             <a:r>
               <a:rPr/>
-              <a:t>The same dial as k in k-NN and λ in lesson 3, in a third costume</a:t>
+              <a:t>C plays the role that k played in k-NN and λ in lesson 3</a:t>
             </a:r>
           </a:p>
           <a:p>
@@ -18719,7 +19272,17 @@
             <a:pPr lvl="0"/>
             <a:r>
               <a:rPr/>
-              <a:t>The linear model needs </a:t>
+              <a:t>The linear model, </a:t>
+            </a:r>
+            <a:r>
+              <a:rPr>
+                <a:latin typeface="Courier"/>
+              </a:rPr>
+              <a:t>SVC(kernel="linear")</a:t>
+            </a:r>
+            <a:r>
+              <a:rPr/>
+              <a:t>, needs </a:t>
             </a:r>
             <a:r>
               <a:rPr b="1"/>
@@ -18727,7 +19290,7 @@
             </a:r>
             <a:r>
               <a:rPr/>
-              <a:t> of the training set to define its boundary</a:t>
+              <a:t> of the training set</a:t>
             </a:r>
           </a:p>
           <a:p>
@@ -18752,7 +19315,7 @@
             <a:pPr lvl="0"/>
             <a:r>
               <a:rPr/>
-              <a:t>The count falls out of </a:t>
+              <a:t>The count comes free with </a:t>
             </a:r>
             <a:r>
               <a:rPr>
@@ -18762,7 +19325,17 @@
             </a:r>
             <a:r>
               <a:rPr/>
-              <a:t> at no cost, and you should look at it</a:t>
+              <a:t>, as </a:t>
+            </a:r>
+            <a:r>
+              <a:rPr>
+                <a:latin typeface="Courier"/>
+              </a:rPr>
+              <a:t>len(model.support_)</a:t>
+            </a:r>
+            <a:r>
+              <a:rPr/>
+              <a:t>: look at it</a:t>
             </a:r>
           </a:p>
         </p:txBody>
@@ -20580,34 +21153,292 @@
           </a:p>
         </p:txBody>
       </p:sp>
-      <p:sp>
-        <p:nvSpPr>
-          <p:cNvPr id="3" name="Content Placeholder 2"/>
-          <p:cNvSpPr>
-            <a:spLocks noGrp="1"/>
-          </p:cNvSpPr>
+      <p:graphicFrame>
+        <p:nvGraphicFramePr>
+          <p:cNvPr id="6" name="Content Placeholder 5"/>
+          <p:cNvGraphicFramePr>
+            <a:graphicFrameLocks noGrp="1"/>
+          </p:cNvGraphicFramePr>
           <p:nvPr>
             <p:ph idx="1"/>
           </p:nvPr>
-        </p:nvSpPr>
-        <p:spPr>
-          <a:xfrm>
-            <a:off x="457200" y="1200151"/>
-            <a:ext cx="8229600" cy="3394472"/>
-          </a:xfrm>
-        </p:spPr>
-        <p:txBody>
-          <a:bodyPr/>
-          <a:lstStyle/>
-          <a:p>
-            <a:pPr lvl="0"/>
-            <a:r>
-              <a:rPr/>
-              <a:t>Margins, support vectors, and what γ does to the boundary</a:t>
-            </a:r>
-          </a:p>
-        </p:txBody>
-      </p:sp>
+        </p:nvGraphicFramePr>
+        <p:xfrm>
+          <a:off x="457200" y="1166099"/>
+          <a:ext cx="8229600" cy="3390900"/>
+        </p:xfrm>
+        <a:graphic>
+          <a:graphicData uri="http://schemas.openxmlformats.org/drawingml/2006/table">
+            <a:tbl>
+              <a:tblPr firstRow="1" bandRow="1">
+                <a:tableStyleId>{5C22544A-7EE6-4342-B048-85BDC9FD1C3A}</a:tableStyleId>
+              </a:tblPr>
+              <a:tblGrid>
+                <a:gridCol w="4114800"/>
+                <a:gridCol w="4114800"/>
+              </a:tblGrid>
+              <a:tr h="0">
+                <a:tc>
+                  <a:txBody>
+                    <a:bodyPr/>
+                    <a:lstStyle/>
+                    <a:p>
+                      <a:pPr lvl="0" indent="0" marL="0">
+                        <a:buNone/>
+                      </a:pPr>
+                      <a:r>
+                        <a:rPr/>
+                        <a:t>section, and its slides</a:t>
+                      </a:r>
+                    </a:p>
+                  </a:txBody>
+                  <a:tcPr/>
+                </a:tc>
+                <a:tc>
+                  <a:txBody>
+                    <a:bodyPr/>
+                    <a:lstStyle/>
+                    <a:p>
+                      <a:pPr lvl="0" indent="0" marL="0">
+                        <a:buNone/>
+                      </a:pPr>
+                      <a:r>
+                        <a:rPr/>
+                        <a:t>you call (→ the number to come back with)</a:t>
+                      </a:r>
+                    </a:p>
+                  </a:txBody>
+                  <a:tcPr/>
+                </a:tc>
+              </a:tr>
+              <a:tr h="0">
+                <a:tc>
+                  <a:txBody>
+                    <a:bodyPr/>
+                    <a:lstStyle/>
+                    <a:p>
+                      <a:pPr lvl="0" indent="0" marL="0">
+                        <a:buNone/>
+                      </a:pPr>
+                      <a:r>
+                        <a:rPr/>
+                        <a:t>the widest slab, 45-48</a:t>
+                      </a:r>
+                    </a:p>
+                  </a:txBody>
+                </a:tc>
+                <a:tc>
+                  <a:txBody>
+                    <a:bodyPr/>
+                    <a:lstStyle/>
+                    <a:p>
+                      <a:pPr lvl="0" indent="0" marL="0">
+                        <a:buNone/>
+                      </a:pPr>
+                      <a:r>
+                        <a:rPr>
+                          <a:latin typeface="Courier"/>
+                        </a:rPr>
+                        <a:t>SVC(kernel="linear")</a:t>
+                      </a:r>
+                      <a:r>
+                        <a:rPr/>
+                        <a:t>, </a:t>
+                      </a:r>
+                      <a:r>
+                        <a:rPr>
+                          <a:latin typeface="Courier"/>
+                        </a:rPr>
+                        <a:t>.n_support_</a:t>
+                      </a:r>
+                      <a:r>
+                        <a:rPr/>
+                        <a:t>, </a:t>
+                      </a:r>
+                      <a:r>
+                        <a:rPr>
+                          <a:latin typeface="Courier"/>
+                        </a:rPr>
+                        <a:t>decision_function</a:t>
+                      </a:r>
+                      <a:r>
+                        <a:rPr/>
+                        <a:t> → 3 of 80 points</a:t>
+                      </a:r>
+                    </a:p>
+                  </a:txBody>
+                </a:tc>
+              </a:tr>
+              <a:tr h="0">
+                <a:tc>
+                  <a:txBody>
+                    <a:bodyPr/>
+                    <a:lstStyle/>
+                    <a:p>
+                      <a:pPr lvl="0" indent="0" marL="0">
+                        <a:buNone/>
+                      </a:pPr>
+                      <a:r>
+                        <a:rPr/>
+                        <a:t>a straight line still fails, 51-52</a:t>
+                      </a:r>
+                    </a:p>
+                  </a:txBody>
+                </a:tc>
+                <a:tc>
+                  <a:txBody>
+                    <a:bodyPr/>
+                    <a:lstStyle/>
+                    <a:p>
+                      <a:pPr lvl="0" indent="0" marL="0">
+                        <a:buNone/>
+                      </a:pPr>
+                      <a:r>
+                        <a:rPr>
+                          <a:latin typeface="Courier"/>
+                        </a:rPr>
+                        <a:t>cross_val_score</a:t>
+                      </a:r>
+                      <a:r>
+                        <a:rPr/>
+                        <a:t>, linear against RBF kernel → 947 against 278 support vectors</a:t>
+                      </a:r>
+                    </a:p>
+                  </a:txBody>
+                </a:tc>
+              </a:tr>
+              <a:tr h="0">
+                <a:tc>
+                  <a:txBody>
+                    <a:bodyPr/>
+                    <a:lstStyle/>
+                    <a:p>
+                      <a:pPr lvl="0" indent="0" marL="0">
+                        <a:buNone/>
+                      </a:pPr>
+                      <a:r>
+                        <a:rPr/>
+                        <a:t>the kernel trick, 53-58</a:t>
+                      </a:r>
+                    </a:p>
+                  </a:txBody>
+                </a:tc>
+                <a:tc>
+                  <a:txBody>
+                    <a:bodyPr/>
+                    <a:lstStyle/>
+                    <a:p>
+                      <a:pPr lvl="0" indent="0" marL="0">
+                        <a:buNone/>
+                      </a:pPr>
+                      <a:r>
+                        <a:rPr/>
+                        <a:t>NumPy only: (a · b)² against the lifted product → 25 = 25</a:t>
+                      </a:r>
+                    </a:p>
+                  </a:txBody>
+                </a:tc>
+              </a:tr>
+              <a:tr h="0">
+                <a:tc>
+                  <a:txBody>
+                    <a:bodyPr/>
+                    <a:lstStyle/>
+                    <a:p>
+                      <a:pPr lvl="0" indent="0" marL="0">
+                        <a:buNone/>
+                      </a:pPr>
+                      <a:r>
+                        <a:rPr/>
+                        <a:t>training and one prediction, 59-61</a:t>
+                      </a:r>
+                    </a:p>
+                  </a:txBody>
+                </a:tc>
+                <a:tc>
+                  <a:txBody>
+                    <a:bodyPr/>
+                    <a:lstStyle/>
+                    <a:p>
+                      <a:pPr lvl="0" indent="0" marL="0">
+                        <a:buNone/>
+                      </a:pPr>
+                      <a:r>
+                        <a:rPr>
+                          <a:latin typeface="Courier"/>
+                        </a:rPr>
+                        <a:t>.support_</a:t>
+                      </a:r>
+                      <a:r>
+                        <a:rPr/>
+                        <a:t>, </a:t>
+                      </a:r>
+                      <a:r>
+                        <a:rPr>
+                          <a:latin typeface="Courier"/>
+                        </a:rPr>
+                        <a:t>.dual_coef_</a:t>
+                      </a:r>
+                      <a:r>
+                        <a:rPr/>
+                        <a:t>, </a:t>
+                      </a:r>
+                      <a:r>
+                        <a:rPr>
+                          <a:latin typeface="Courier"/>
+                        </a:rPr>
+                        <a:t>.intercept_</a:t>
+                      </a:r>
+                      <a:r>
+                        <a:rPr/>
+                        <a:t> → +1.883</a:t>
+                      </a:r>
+                    </a:p>
+                  </a:txBody>
+                </a:tc>
+              </a:tr>
+              <a:tr h="0">
+                <a:tc>
+                  <a:txBody>
+                    <a:bodyPr/>
+                    <a:lstStyle/>
+                    <a:p>
+                      <a:pPr lvl="0" indent="0" marL="0">
+                        <a:buNone/>
+                      </a:pPr>
+                      <a:r>
+                        <a:rPr/>
+                        <a:t>gamma and C, 62-64</a:t>
+                      </a:r>
+                    </a:p>
+                  </a:txBody>
+                </a:tc>
+                <a:tc>
+                  <a:txBody>
+                    <a:bodyPr/>
+                    <a:lstStyle/>
+                    <a:p>
+                      <a:pPr lvl="0" indent="0" marL="0">
+                        <a:buNone/>
+                      </a:pPr>
+                      <a:r>
+                        <a:rPr>
+                          <a:latin typeface="Courier"/>
+                        </a:rPr>
+                        <a:t>SVC(gamma=..., C=...)</a:t>
+                      </a:r>
+                      <a:r>
+                        <a:rPr/>
+                        <a:t> in the pipeline → 0.944 at γ = 1</a:t>
+                      </a:r>
+                    </a:p>
+                  </a:txBody>
+                </a:tc>
+              </a:tr>
+            </a:tbl>
+          </a:graphicData>
+        </a:graphic>
+      </p:graphicFrame>
     </p:spTree>
   </p:cSld>
 </p:sld>
@@ -21332,7 +22163,7 @@
             </a:r>
             <a:r>
               <a:rPr/>
-              <a:t>: 0.933 where independence holds, </a:t>
+              <a:t>: 0.933 where its false assumption is cheap, </a:t>
             </a:r>
             <a:r>
               <a:rPr b="1"/>
@@ -21340,7 +22171,7 @@
             </a:r>
             <a:r>
               <a:rPr/>
-              <a:t> where it does not</a:t>
+              <a:t> where not</a:t>
             </a:r>
           </a:p>
           <a:p>
@@ -21561,6 +22392,19 @@
             <a:r>
               <a:rPr/>
               <a:t>: an unusually honest name for an algorithm</a:t>
+            </a:r>
+          </a:p>
+          <a:p>
+            <a:pPr lvl="0"/>
+            <a:r>
+              <a:rPr/>
+              <a:t>In code: </a:t>
+            </a:r>
+            <a:r>
+              <a:rPr>
+                <a:latin typeface="Courier"/>
+              </a:rPr>
+              <a:t>KNeighborsClassifier(n_neighbors=5)</a:t>
             </a:r>
           </a:p>
         </p:txBody>
@@ -21753,6 +22597,19 @@
             <a:r>
               <a:rPr b="1"/>
               <a:t>immediate consequences</a:t>
+            </a:r>
+          </a:p>
+          <a:p>
+            <a:pPr lvl="0"/>
+            <a:r>
+              <a:rPr/>
+              <a:t>In code: </a:t>
+            </a:r>
+            <a:r>
+              <a:rPr>
+                <a:latin typeface="Courier"/>
+              </a:rPr>
+              <a:t>make_pipeline(StandardScaler(), KNeighborsClassifier(5))</a:t>
             </a:r>
           </a:p>
         </p:txBody>

</xml_diff>

<commit_message>
Close the gaps a student with only lesson 6's deck would hit
A gap audit of the slide bodies, notes closed. The design envelope, the prior
and a prediction's confidence are now said where they first appear; the RBF
kernel, named on slide 21, is flagged as coming later today; the hinge loss is
written as max(0, 1 - y f(x)); and the claim that k = 1 always scores 1.000 in
training now carries its condition, no identical points with different
labels. "The bill for that", "bought cheap" and "the gap never underflows" are
written out. The figures needed no change.

Co-Authored-By: Claude Opus 5.5 <noreply@anthropic.com>
</commit_message>
<xml_diff>
--- a/Lessons/06_knn_naive_bayes_svm/Slides/knn_naive_bayes_svm_slides.pptx
+++ b/Lessons/06_knn_naive_bayes_svm/Slides/knn_naive_bayes_svm_slides.pptx
@@ -12085,7 +12085,7 @@
             </a:r>
             <a:r>
               <a:rPr/>
-              <a:t>. Always, on any dataset</a:t>
+              <a:t>, unless two identical points carry different labels</a:t>
             </a:r>
           </a:p>
         </p:txBody>
@@ -14004,7 +14004,7 @@
             <a:pPr lvl="0"/>
             <a:r>
               <a:rPr/>
-              <a:t>k-NN, k-means (lesson 8), and radial basis function (RBF) kernels, all of them</a:t>
+              <a:t>k-NN, k-means (lesson 8), and the radial basis function (RBF) kernel of support vector machines, later today</a:t>
             </a:r>
           </a:p>
         </p:txBody>
@@ -14497,7 +14497,7 @@
             <a:pPr lvl="0"/>
             <a:r>
               <a:rPr/>
-              <a:t>The prior is a count; the denominator is identical across classes and cancels</a:t>
+              <a:t>The prior P(y = c) is the class’s share of the data; the denominator is the same for every class and cancels</a:t>
             </a:r>
           </a:p>
           <a:p>
@@ -15031,14 +15031,7 @@
             </a:r>
             <a:r>
               <a:rPr/>
-              <a:t>: remember, and vote</a:t>
-            </a:r>
-          </a:p>
-          <a:p>
-            <a:pPr lvl="0"/>
-            <a:r>
-              <a:rPr/>
-              <a:t>The </a:t>
+              <a:t>, and the </a:t>
             </a:r>
             <a:r>
               <a:rPr b="1"/>
@@ -15046,7 +15039,7 @@
             </a:r>
             <a:r>
               <a:rPr/>
-              <a:t>: the bill for that</a:t>
+              <a:t> that limits it</a:t>
             </a:r>
           </a:p>
           <a:p>
@@ -15057,7 +15050,7 @@
             </a:r>
             <a:r>
               <a:rPr/>
-              <a:t>: one strong assumption, bought cheap</a:t>
+              <a:t>: one strong assumption, a cheap model</a:t>
             </a:r>
           </a:p>
           <a:p>
@@ -15068,14 +15061,14 @@
             </a:r>
             <a:r>
               <a:rPr/>
-              <a:t>: margins, and kernels</a:t>
+              <a:t>: margins and kernels</a:t>
             </a:r>
           </a:p>
           <a:p>
             <a:pPr lvl="0"/>
             <a:r>
               <a:rPr/>
-              <a:t>Which family to reach for, and why that beats tuning</a:t>
+              <a:t>Which family to choose, and why that beats tuning</a:t>
             </a:r>
           </a:p>
         </p:txBody>
@@ -16545,7 +16538,7 @@
             <a:pPr lvl="0"/>
             <a:r>
               <a:rPr/>
-              <a:t>With many features e^total = 0; the gap never underflows</a:t>
+              <a:t>With many features e^total rounds to 0 in the computer; the gap does not</a:t>
             </a:r>
           </a:p>
         </p:txBody>
@@ -17302,7 +17295,7 @@
             </a:r>
             <a:r>
               <a:rPr/>
-              <a:t>, too low as readily as too high</a:t>
+              <a:t> (the range it was built to run in), too low as readily as too high</a:t>
             </a:r>
           </a:p>
           <a:p>
@@ -17883,19 +17876,23 @@
             <a:pPr lvl="0"/>
             <a:r>
               <a:rPr/>
-              <a:t>Mean confidence when </a:t>
+              <a:t>Confidence, the probability given to the predicted class: </a:t>
             </a:r>
             <a:r>
               <a:rPr b="1"/>
-              <a:t>correct: 0.567</a:t>
-            </a:r>
-            <a:r>
-              <a:rPr/>
-              <a:t>. When </a:t>
+              <a:t>0.567</a:t>
+            </a:r>
+            <a:r>
+              <a:rPr/>
+              <a:t> when correct, </a:t>
             </a:r>
             <a:r>
               <a:rPr b="1"/>
-              <a:t>wrong: 0.555</a:t>
+              <a:t>0.555</a:t>
+            </a:r>
+            <a:r>
+              <a:rPr/>
+              <a:t> when wrong</a:t>
             </a:r>
           </a:p>
           <a:p>
@@ -18600,7 +18597,7 @@
             </a:r>
             <a:r>
               <a:rPr/>
-              <a:t>: exactly zero for a point with room to spare</a:t>
+              <a:t>, max(0, 1 − y·f(x)) with labels ±1: zero for a point with room to spare</a:t>
             </a:r>
           </a:p>
         </p:txBody>

</xml_diff>

<commit_message>
Rewrite lesson 6's speaker notes in full
Every note reread against its slide and every number checked. Fixes why
k = 401 inflates the healthy region (the compact healthy disc outvotes the
thin faulty ring, not the majority class), calibration attributed to lesson 5
instead of lesson 4, 0.947 called the best number when slide 42 has 0.972,
and the mixed 'this morning' and 'this afternoon' (now slide pointers or
'today', in the commentary too). The faulty pumps' pressure spread is given in
bar, and two duplicated passages are cut.

Co-Authored-By: Claude Opus 5.5 <noreply@anthropic.com>
</commit_message>
<xml_diff>
--- a/Lessons/06_knn_naive_bayes_svm/Slides/knn_naive_bayes_svm_slides.pptx
+++ b/Lessons/06_knn_naive_bayes_svm/Slides/knn_naive_bayes_svm_slides.pptx
@@ -992,21 +992,21 @@
             </a:pPr>
             <a:r>
               <a:rPr/>
-              <a:t>k = 15: a clean disc, close to the envelope that actually generated the data. This is close to the envelope the data was generated from.</a:t>
-            </a:r>
-          </a:p>
-          <a:p>
-            <a:pPr lvl="0" indent="0" marL="0">
-              <a:buNone/>
-            </a:pPr>
-          </a:p>
-          <a:p>
-            <a:pPr lvl="0" indent="0" marL="0">
-              <a:buNone/>
-            </a:pPr>
-            <a:r>
-              <a:rPr/>
-              <a:t>k = 401 is the one worth the time, because it does not do what people expect. It has not collapsed to a single class. The boundary has INFLATED past the true envelope and now swallows faulty pumps. With 401 votes taken over a large neighbourhood, the majority class wins in regions where it should not. The model no longer follows the boundary; it averages the votes across it.</a:t>
+              <a:t>k = 15: a clean disc, close to the envelope that actually generated the data.</a:t>
+            </a:r>
+          </a:p>
+          <a:p>
+            <a:pPr lvl="0" indent="0" marL="0">
+              <a:buNone/>
+            </a:pPr>
+          </a:p>
+          <a:p>
+            <a:pPr lvl="0" indent="0" marL="0">
+              <a:buNone/>
+            </a:pPr>
+            <a:r>
+              <a:rPr/>
+              <a:t>k = 401 is the one worth the time, because it does not do what people expect. It has not collapsed to a single class. The boundary has INFLATED past the true envelope and now swallows faulty pumps. Why it grows rather than shrinks: with 401 votes, a pump just outside the envelope counts nearly the whole healthy disc among its neighbours - the healthy pumps are packed tightly in the middle - while the faulty pumps are spread thinly round the ring. So the healthy votes win outside the envelope too. The model no longer follows the boundary; it averages the votes across it.</a:t>
             </a:r>
           </a:p>
           <a:p>
@@ -2122,7 +2122,7 @@
             </a:pPr>
             <a:r>
               <a:rPr/>
-              <a:t>Neural networks work happily in thousands of dimensions. So do linear models with regularisation. What breaks is specifically the family of methods whose mechanism is a distance, because a quantity that no longer varies can no longer discriminate. Name the three that appear in this course: k-NN today, k-means in lesson 8, and the RBF kernel later this afternoon, which measures similarity through the same Euclidean distance.</a:t>
+              <a:t>Neural networks work happily in thousands of dimensions. So do linear models with regularisation. What breaks is specifically the family of methods whose mechanism is a distance, because a quantity that no longer varies can no longer discriminate. Name the three that appear in this course: k-NN today, k-means in lesson 8, and the RBF kernel later today, which measures similarity through the same Euclidean distance.</a:t>
             </a:r>
           </a:p>
           <a:p>
@@ -2470,7 +2470,7 @@
             </a:pPr>
             <a:r>
               <a:rPr/>
-              <a:t>Point out that this is the curse of dimensionality again, from a different direction: an hour ago it broke distances, here it breaks the estimation of a density. Handout section 4.1.</a:t>
+              <a:t>Point out that this is the curse of dimensionality again, from a different direction: before the break it broke distances, here it breaks the estimation of a density. Handout section 4.1.</a:t>
             </a:r>
           </a:p>
         </p:txBody>
@@ -2676,7 +2676,7 @@
             </a:pPr>
             <a:r>
               <a:rPr/>
-              <a:t>Expect someone to object that the number is then no longer a probability. The instinct is sound - a term has been thrown away - and the answer is that it is recoverable. The denominator is the sum of the numerators over the classes, so dividing each score by the sum of the scores gives the probability back exactly. That is what predict_proba does, in logarithms. Dropping it does not make the probabilities less reliable. Where Naive Bayes’s probabilities do go wrong is inside the numerator, because of the assumption, and we will see that in a few slides.</a:t>
+              <a:t>Expect someone to object that the number is then no longer a probability. The instinct is sound - a term has been thrown away - and the answer is that it is recoverable. The denominator is the sum of the numerators over the classes, so dividing each score by the sum of the scores gives the probability back exactly. That is what predict_proba does, in logarithms. Dropping it does not make the probabilities less reliable. Where Naive Bayes’s probabilities do go wrong is inside the numerator, because of the assumption, and slide 43 shows it.</a:t>
             </a:r>
           </a:p>
           <a:p>
@@ -2786,7 +2786,7 @@
             </a:pPr>
             <a:r>
               <a:rPr/>
-              <a:t>Emphasise the words “given the class”. This is not a claim that the features are independent - it is a claim that whatever dependence they have is entirely explained by which class they belong to. Those are different claims and the distinction matters in about ten minutes, when we measure it.</a:t>
+              <a:t>Emphasise the words “given the class”. This is not a claim that the features are independent - it is a claim that whatever dependence they have is entirely explained by which class they belong to. Those are different claims and the distinction matters on slide 38, when we measure it.</a:t>
             </a:r>
           </a:p>
           <a:p>
@@ -2910,7 +2910,7 @@
             </a:pPr>
             <a:r>
               <a:rPr/>
-              <a:t>Why that matters is a counting argument, and it is worth making concrete. To estimate the left-hand side directly you would need enough pumps to fill an n-dimensional space - the curse of dimensionality from an hour ago, in a new form. To estimate the right-hand side you need enough pumps to fit n separate histograms, which is a completely different demand.</a:t>
+              <a:t>Why that matters is a counting argument, and it is worth making concrete. To estimate the left-hand side directly you would need enough pumps to fill an n-dimensional space - the curse of dimensionality from before the break, in a new form. To estimate the right-hand side you need enough pumps to fit n separate histograms, which is a completely different demand.</a:t>
             </a:r>
           </a:p>
           <a:p>
@@ -3496,7 +3496,7 @@
             </a:pPr>
             <a:r>
               <a:rPr/>
-              <a:t>Inside the bracket on the left is the classifier as slides 26 and 28 built it: prior times one density per reading, the class with the largest product winning. The equation says its log is a sum, and the title says why that is allowed: ln is increasing, so the class with the largest product is also the class with the largest log. The logs are natural logs - base e - which matters two slides later, when we undo them with e. Say why nobody computes the left-hand side directly. With hundreds of features the product is hundreds of small numbers multiplied together, and it becomes too small to store, exactly zero in floating point (underflow) - 0.5 to the power 300 is already 5 times 10 to the minus 91, and real likelihoods are far smaller than 0.5. Every class then scores zero and nothing can be compared.</a:t>
+              <a:t>Inside the bracket on the left is the classifier as slides 26 and 28 built it: prior times one density per reading, the class with the largest product winning. The equation says its log is a sum, and the title says why that is allowed: ln is increasing, so the class with the largest product is also the class with the largest log. The logs are natural logs - base e - which matters on slide 34, when we undo them with e. Say why nobody computes the left-hand side directly. With hundreds of features the product is hundreds of small numbers multiplied together, and it becomes too small to store, exactly zero in floating point (underflow) - 0.5 to the power 300 is already 5 times 10 to the minus 91, and real likelihoods are far smaller than 0.5. Every class then scores zero and nothing can be compared.</a:t>
             </a:r>
           </a:p>
           <a:p>
@@ -3634,7 +3634,7 @@
             </a:pPr>
             <a:r>
               <a:rPr/>
-              <a:t>Faulty has the larger total, so faulty is the prediction. How the two totals become the 0.981 in the title is the next slide. Handout section 4.2 lists the four steps.</a:t>
+              <a:t>Faulty has the larger total, so faulty is the prediction. How the two totals become the 0.981 of slide 30 is the next slide. Handout section 4.2 lists the four steps.</a:t>
             </a:r>
           </a:p>
         </p:txBody>
@@ -3978,7 +3978,7 @@
             </a:pPr>
             <a:r>
               <a:rPr/>
-              <a:t>The bargain is real. Nothing else in this course trains in one pass, and nothing else tolerates ten thousand features on a few thousand rows.</a:t>
+              <a:t>The bargain is real. Nothing else in this course trains in one pass, and few methods tolerate ten thousand features on a few thousand rows as cheaply.</a:t>
             </a:r>
           </a:p>
           <a:p>
@@ -4240,7 +4240,7 @@
             </a:pPr>
             <a:r>
               <a:rPr/>
-              <a:t>Then show why that conclusion is wrong. Correlation only sees straight-line dependence. Healthy pumps fill a disc and faulty ones a ring; on a ring, a pump far out in vibration must be central in pressure. That dependence is symmetric, so the straight-line summary averages it to zero. Square each reading’s distance from the design point and it appears: −0.420 among the faulty pumps. Or say it as a spread: the pressure of a faulty pump has a standard deviation of 0.784 when its vibration is extreme (the fifth furthest out, beyond 6.2 Hz from the centre) and 1.309 when it is not - 0.37 against 0.62 bar, same average, very different spread. Put the distinction on the board in two lines: uncorrelated, yes; independent, no. Naive Bayes assumes the second. The assumption is false.</a:t>
+              <a:t>Then show why that conclusion is wrong. Correlation only sees straight-line dependence. Healthy pumps fill a disc and faulty ones a ring; on a ring, a pump far out in vibration must be central in pressure. That dependence is symmetric, so the straight-line summary averages it to zero. Square each reading’s distance from the design point and it appears: −0.420 among the faulty pumps. Or say it as a spread. Take the faulty pumps whose vibration is most extreme - the fifth of them furthest from the centre, more than 6.2 Hz away - and their pressure has a standard deviation of 0.37 bar; for the other faulty pumps it is 0.62 bar. Same average pressure, very different spread, so knowing the vibration tells you something about the pressure. Put the distinction on the board in two lines: uncorrelated, yes; independent, no. Naive Bayes assumes the second. The assumption is false.</a:t>
             </a:r>
           </a:p>
           <a:p>
@@ -5022,21 +5022,21 @@
             </a:pPr>
             <a:r>
               <a:rPr/>
-              <a:t>Then lesson 5’s distinction, which this is the textbook case of: ranking and calibration are different properties. A model can order examples usefully and still report numbers that mean nothing.</a:t>
-            </a:r>
-          </a:p>
-          <a:p>
-            <a:pPr lvl="0" indent="0" marL="0">
-              <a:buNone/>
-            </a:pPr>
-          </a:p>
-          <a:p>
-            <a:pPr lvl="0" indent="0" marL="0">
-              <a:buNone/>
-            </a:pPr>
-            <a:r>
-              <a:rPr/>
-              <a:t>The practical consequence, and it is concrete: do not use Naive Bayes anywhere a calibrated probability enters a decision - including lesson 4’s cost calculation in section 7.2, where the threshold depends on the probability being real.</a:t>
+              <a:t>Then lesson 4’s distinction (its slide 37), which this is the textbook case of: ranking and calibration - whether a reported 0.7 comes true 70% of the time - are different properties. A model can order examples usefully and still report numbers that mean nothing.</a:t>
+            </a:r>
+          </a:p>
+          <a:p>
+            <a:pPr lvl="0" indent="0" marL="0">
+              <a:buNone/>
+            </a:pPr>
+          </a:p>
+          <a:p>
+            <a:pPr lvl="0" indent="0" marL="0">
+              <a:buNone/>
+            </a:pPr>
+            <a:r>
+              <a:rPr/>
+              <a:t>The practical consequence, and it is concrete: do not use Naive Bayes anywhere a calibrated probability enters a decision - including lesson 4’s cost calculation in its handout section 7.2, where the threshold depends on the probability being real.</a:t>
             </a:r>
           </a:p>
         </p:txBody>
@@ -5848,7 +5848,7 @@
             </a:pPr>
             <a:r>
               <a:rPr/>
-              <a:t>Third appearance of the same idea, and say so - that repetition is the point. Lesson 3 had λ, this morning had k, now C. Every model has one knob that trades fitting this data against surviving the next, and recognising it in an unfamiliar model is worth more than memorising three names.</a:t>
+              <a:t>Third appearance of the same idea, and say so - that repetition is the point. Lesson 3 had λ, the first half of today had k, now C. Every model has one knob that trades fitting this data against surviving the next, and recognising it in an unfamiliar model is worth more than memorising three names.</a:t>
             </a:r>
           </a:p>
           <a:p>
@@ -6124,7 +6124,7 @@
             </a:pPr>
             <a:r>
               <a:rPr/>
-              <a:t>The linear kernel scores 0.613 - the base rate, exactly as logistic regression did this morning, with the same zero variance across folds.</a:t>
+              <a:t>The linear kernel scores 0.613 - the base rate, exactly as logistic regression did on slide 6, with the same zero variance across folds.</a:t>
             </a:r>
           </a:p>
           <a:p>
@@ -6152,7 +6152,7 @@
             </a:pPr>
             <a:r>
               <a:rPr/>
-              <a:t>Then the RBF row, which is the same algorithm with one argument changed, at 0.947 - the best number in the whole lesson, and close to the 0.96 ceiling.</a:t>
+              <a:t>Then the RBF row, which is the same algorithm with one argument changed, at 0.947 - the best score on the pumps in the whole lesson, and close to the 0.96 ceiling.</a:t>
             </a:r>
           </a:p>
           <a:p>
@@ -6396,7 +6396,7 @@
             </a:pPr>
             <a:r>
               <a:rPr/>
-              <a:t>Then the sentence that reframes the whole afternoon: the classes were never inseparable. Separability is not a property of the data - it is a property of the data AND the coordinates you happen to have measured it in.</a:t>
+              <a:t>Then the sentence that reframes the whole lesson: the classes were never inseparable. Separability is not a property of the data - it is a property of the data AND the coordinates you happen to have measured it in.</a:t>
             </a:r>
           </a:p>
           <a:p>
@@ -6748,7 +6748,7 @@
             </a:pPr>
             <a:r>
               <a:rPr/>
-              <a:t>Say it in one sentence first: instead of solving for w directly, the optimisation turns out to hand back w as a weighted sum of the training points themselves, one weight aᵢ per pump. The picture: the boundary is a tent held up by the points pressing against it, and aᵢ is how hard pump i presses. A pump comfortably on its own side of the slab presses on nothing, so its weight is exactly zero. Only the pumps on or inside the slab - the support vectors from Section 5.1 - get a positive weight, which is where that 79% against 23% came from.</a:t>
+              <a:t>Say it in one sentence first: instead of solving for w directly, the optimisation turns out to hand back w as a weighted sum of the training points themselves, one weight aᵢ per pump. The picture: the boundary is a tent held up by the points pressing against it, and aᵢ is how hard pump i presses. A pump comfortably on its own side of the slab presses on nothing, so its weight is exactly zero. Only the pumps on or inside the slab - the support vectors of slide 46 and handout section 5.1 - get a positive weight, which is where that 79% against 23% came from.</a:t>
             </a:r>
           </a:p>
           <a:p>
@@ -7364,7 +7364,7 @@
             </a:pPr>
             <a:r>
               <a:rPr/>
-              <a:t>Ask the room what could possibly go wrong with a method that makes no assumptions. The next fifteen minutes answer it: a method with no assumptions has no way to ignore a useless column, and that turns out to be expensive.</a:t>
+              <a:t>Ask the room what could possibly go wrong with a method that makes no assumptions. Slides 15 to 21 answer it: a method with no assumptions has no way to ignore a useless column, and that turns out to be expensive.</a:t>
             </a:r>
           </a:p>
           <a:p>
@@ -7946,7 +7946,7 @@
             </a:pPr>
             <a:r>
               <a:rPr/>
-              <a:t>If time runs short, keep the γ sweep with the boundary drawn at each setting. Let them turn γ up themselves and watch the bubbles form - it is the most direct experience of overfitting available in this course.</a:t>
+              <a:t>If time runs short, keep the γ sweep with the boundary drawn at each setting, and skip the C sweep instead, setting it as reading (the table is in handout section 5.6). Let them turn γ up themselves and watch the bubbles form - it is the most direct experience of overfitting available in this course.</a:t>
             </a:r>
           </a:p>
           <a:p>
@@ -7961,20 +7961,6 @@
             <a:r>
               <a:rPr/>
               <a:t>Have them print the fraction of support vectors for the linear and RBF kernels side by side. Two numbers, and it makes the diagnostic real rather than a claim on a slide.</a:t>
-            </a:r>
-          </a:p>
-          <a:p>
-            <a:pPr lvl="0" indent="0" marL="0">
-              <a:buNone/>
-            </a:pPr>
-          </a:p>
-          <a:p>
-            <a:pPr lvl="0" indent="0" marL="0">
-              <a:buNone/>
-            </a:pPr>
-            <a:r>
-              <a:rPr/>
-              <a:t>If time runs short, skip the C sweep and set it as reading: the table is in handout section 5.6.</a:t>
             </a:r>
           </a:p>
         </p:txBody>
@@ -8092,7 +8078,7 @@
             </a:r>
             <a:r>
               <a:rPr/>
-              <a:t>. Larger than any difference this course has shown between a good model and a carefully tuned one - lesson 5’s entire hyperparameter search moved things by a few hundredths.</a:t>
+              <a:t>. That is larger than anything tuning has bought in this course - lesson 5’s whole hyperparameter search moved scores by a few hundredths.</a:t>
             </a:r>
           </a:p>
           <a:p>
@@ -8436,7 +8422,7 @@
             </a:pPr>
             <a:r>
               <a:rPr/>
-              <a:t>If this exercise is drawn at the exam, what counts is the reasoning, not the accuracy. A well-argued choice that scores slightly worse beats a lucky winner with no justification - and the argument has to reference the data, in the way that the squared distances and the fitted ellipse explained Naive Bayes on the pumps this afternoon.</a:t>
+              <a:t>If this exercise is drawn at the exam, what counts is the reasoning, not the accuracy. A well-argued choice that scores slightly worse beats a lucky winner with no justification - and the argument has to reference the data, in the way that the squared distances and the fitted ellipse explained Naive Bayes on the pumps today.</a:t>
             </a:r>
           </a:p>
           <a:p>

</xml_diff>